<commit_message>
Refactor code structure for improved readability and maintainability - Added sum of shap values for single predictions
</commit_message>
<xml_diff>
--- a/slides/AI_Agent_Explainability.pptx
+++ b/slides/AI_Agent_Explainability.pptx
@@ -8,6 +8,9 @@
   <p:sldIdLst>
     <p:sldId id="297" r:id="rId3"/>
     <p:sldId id="298" r:id="rId4"/>
+    <p:sldId id="299" r:id="rId5"/>
+    <p:sldId id="301" r:id="rId6"/>
+    <p:sldId id="300" r:id="rId7"/>
   </p:sldIdLst>
   <p:sldSz cx="9144000" cy="6858000" type="screen4x3"/>
   <p:notesSz cx="7559675" cy="10691813"/>
@@ -185,130 +188,6 @@
     </pc:docChg>
   </pc:docChgLst>
   <pc:docChgLst>
-    <pc:chgData name="Tiago Janela" userId="ee1a79fe-c79c-4f34-9602-7f6f2f0482b3" providerId="ADAL" clId="{771048AC-4F55-42D8-AA6A-766F659A7530}"/>
-    <pc:docChg chg="undo custSel addSld delSld modSld sldOrd">
-      <pc:chgData name="Tiago Janela" userId="ee1a79fe-c79c-4f34-9602-7f6f2f0482b3" providerId="ADAL" clId="{771048AC-4F55-42D8-AA6A-766F659A7530}" dt="2026-02-05T14:24:21.198" v="2967" actId="20577"/>
-      <pc:docMkLst>
-        <pc:docMk/>
-      </pc:docMkLst>
-      <pc:sldChg chg="delSp modSp add mod">
-        <pc:chgData name="Tiago Janela" userId="ee1a79fe-c79c-4f34-9602-7f6f2f0482b3" providerId="ADAL" clId="{771048AC-4F55-42D8-AA6A-766F659A7530}" dt="2026-02-05T14:24:21.198" v="2967" actId="20577"/>
-        <pc:sldMkLst>
-          <pc:docMk/>
-          <pc:sldMk cId="901468915" sldId="296"/>
-        </pc:sldMkLst>
-        <pc:spChg chg="mod">
-          <ac:chgData name="Tiago Janela" userId="ee1a79fe-c79c-4f34-9602-7f6f2f0482b3" providerId="ADAL" clId="{771048AC-4F55-42D8-AA6A-766F659A7530}" dt="2026-02-05T10:58:00.218" v="1144" actId="20577"/>
-          <ac:spMkLst>
-            <pc:docMk/>
-            <pc:sldMk cId="901468915" sldId="296"/>
-            <ac:spMk id="163" creationId="{CBF44E8C-8654-71A0-B86B-E9D342AC2D4D}"/>
-          </ac:spMkLst>
-        </pc:spChg>
-        <pc:spChg chg="mod">
-          <ac:chgData name="Tiago Janela" userId="ee1a79fe-c79c-4f34-9602-7f6f2f0482b3" providerId="ADAL" clId="{771048AC-4F55-42D8-AA6A-766F659A7530}" dt="2026-02-05T14:24:21.198" v="2967" actId="20577"/>
-          <ac:spMkLst>
-            <pc:docMk/>
-            <pc:sldMk cId="901468915" sldId="296"/>
-            <ac:spMk id="164" creationId="{B6FA4745-5BA4-2D80-2549-988AFFB4E146}"/>
-          </ac:spMkLst>
-        </pc:spChg>
-      </pc:sldChg>
-      <pc:sldChg chg="modSp add mod ord">
-        <pc:chgData name="Tiago Janela" userId="ee1a79fe-c79c-4f34-9602-7f6f2f0482b3" providerId="ADAL" clId="{771048AC-4F55-42D8-AA6A-766F659A7530}" dt="2026-02-05T12:59:57.611" v="1910" actId="20577"/>
-        <pc:sldMkLst>
-          <pc:docMk/>
-          <pc:sldMk cId="829672710" sldId="297"/>
-        </pc:sldMkLst>
-        <pc:spChg chg="mod">
-          <ac:chgData name="Tiago Janela" userId="ee1a79fe-c79c-4f34-9602-7f6f2f0482b3" providerId="ADAL" clId="{771048AC-4F55-42D8-AA6A-766F659A7530}" dt="2026-02-05T12:59:57.611" v="1910" actId="20577"/>
-          <ac:spMkLst>
-            <pc:docMk/>
-            <pc:sldMk cId="829672710" sldId="297"/>
-            <ac:spMk id="156" creationId="{00000000-0000-0000-0000-000000000000}"/>
-          </ac:spMkLst>
-        </pc:spChg>
-      </pc:sldChg>
-      <pc:sldChg chg="delSp modSp add mod ord">
-        <pc:chgData name="Tiago Janela" userId="ee1a79fe-c79c-4f34-9602-7f6f2f0482b3" providerId="ADAL" clId="{771048AC-4F55-42D8-AA6A-766F659A7530}" dt="2026-02-05T14:23:46.564" v="2966" actId="20577"/>
-        <pc:sldMkLst>
-          <pc:docMk/>
-          <pc:sldMk cId="721732568" sldId="298"/>
-        </pc:sldMkLst>
-        <pc:spChg chg="mod">
-          <ac:chgData name="Tiago Janela" userId="ee1a79fe-c79c-4f34-9602-7f6f2f0482b3" providerId="ADAL" clId="{771048AC-4F55-42D8-AA6A-766F659A7530}" dt="2026-02-05T14:23:46.564" v="2966" actId="20577"/>
-          <ac:spMkLst>
-            <pc:docMk/>
-            <pc:sldMk cId="721732568" sldId="298"/>
-            <ac:spMk id="2" creationId="{870990D0-7AC5-46BA-6FC4-274F8E0A3ABE}"/>
-          </ac:spMkLst>
-        </pc:spChg>
-        <pc:spChg chg="mod">
-          <ac:chgData name="Tiago Janela" userId="ee1a79fe-c79c-4f34-9602-7f6f2f0482b3" providerId="ADAL" clId="{771048AC-4F55-42D8-AA6A-766F659A7530}" dt="2026-02-05T13:01:46.094" v="1930" actId="20577"/>
-          <ac:spMkLst>
-            <pc:docMk/>
-            <pc:sldMk cId="721732568" sldId="298"/>
-            <ac:spMk id="163" creationId="{57944F4B-F502-E7CC-8790-8737702BC6AC}"/>
-          </ac:spMkLst>
-        </pc:spChg>
-      </pc:sldChg>
-    </pc:docChg>
-  </pc:docChgLst>
-  <pc:docChgLst>
-    <pc:chgData name="Tiago Janela" userId="ee1a79fe-c79c-4f34-9602-7f6f2f0482b3" providerId="ADAL" clId="{A1A622BE-A8AD-47B7-8802-BAC61BCE5126}"/>
-    <pc:docChg chg="undo custSel modSld">
-      <pc:chgData name="Tiago Janela" userId="ee1a79fe-c79c-4f34-9602-7f6f2f0482b3" providerId="ADAL" clId="{A1A622BE-A8AD-47B7-8802-BAC61BCE5126}" dt="2026-03-04T13:21:40.843" v="48" actId="403"/>
-      <pc:docMkLst>
-        <pc:docMk/>
-      </pc:docMkLst>
-      <pc:sldChg chg="modSp mod">
-        <pc:chgData name="Tiago Janela" userId="ee1a79fe-c79c-4f34-9602-7f6f2f0482b3" providerId="ADAL" clId="{A1A622BE-A8AD-47B7-8802-BAC61BCE5126}" dt="2026-03-04T13:20:02.161" v="40" actId="20577"/>
-        <pc:sldMkLst>
-          <pc:docMk/>
-          <pc:sldMk cId="114778141" sldId="303"/>
-        </pc:sldMkLst>
-        <pc:spChg chg="mod">
-          <ac:chgData name="Tiago Janela" userId="ee1a79fe-c79c-4f34-9602-7f6f2f0482b3" providerId="ADAL" clId="{A1A622BE-A8AD-47B7-8802-BAC61BCE5126}" dt="2026-03-04T13:20:02.161" v="40" actId="20577"/>
-          <ac:spMkLst>
-            <pc:docMk/>
-            <pc:sldMk cId="114778141" sldId="303"/>
-            <ac:spMk id="2" creationId="{3A594187-BB0C-FE87-8E79-972F5DD9EAE2}"/>
-          </ac:spMkLst>
-        </pc:spChg>
-      </pc:sldChg>
-      <pc:sldChg chg="modSp mod">
-        <pc:chgData name="Tiago Janela" userId="ee1a79fe-c79c-4f34-9602-7f6f2f0482b3" providerId="ADAL" clId="{A1A622BE-A8AD-47B7-8802-BAC61BCE5126}" dt="2026-03-04T13:21:32.291" v="47" actId="20577"/>
-        <pc:sldMkLst>
-          <pc:docMk/>
-          <pc:sldMk cId="1211845523" sldId="306"/>
-        </pc:sldMkLst>
-        <pc:spChg chg="mod">
-          <ac:chgData name="Tiago Janela" userId="ee1a79fe-c79c-4f34-9602-7f6f2f0482b3" providerId="ADAL" clId="{A1A622BE-A8AD-47B7-8802-BAC61BCE5126}" dt="2026-03-04T13:21:32.291" v="47" actId="20577"/>
-          <ac:spMkLst>
-            <pc:docMk/>
-            <pc:sldMk cId="1211845523" sldId="306"/>
-            <ac:spMk id="2" creationId="{3A594187-BB0C-FE87-8E79-972F5DD9EAE2}"/>
-          </ac:spMkLst>
-        </pc:spChg>
-      </pc:sldChg>
-      <pc:sldChg chg="modSp mod">
-        <pc:chgData name="Tiago Janela" userId="ee1a79fe-c79c-4f34-9602-7f6f2f0482b3" providerId="ADAL" clId="{A1A622BE-A8AD-47B7-8802-BAC61BCE5126}" dt="2026-03-04T13:21:40.843" v="48" actId="403"/>
-        <pc:sldMkLst>
-          <pc:docMk/>
-          <pc:sldMk cId="4258501269" sldId="307"/>
-        </pc:sldMkLst>
-        <pc:spChg chg="mod">
-          <ac:chgData name="Tiago Janela" userId="ee1a79fe-c79c-4f34-9602-7f6f2f0482b3" providerId="ADAL" clId="{A1A622BE-A8AD-47B7-8802-BAC61BCE5126}" dt="2026-03-04T13:21:40.843" v="48" actId="403"/>
-          <ac:spMkLst>
-            <pc:docMk/>
-            <pc:sldMk cId="4258501269" sldId="307"/>
-            <ac:spMk id="2" creationId="{3A594187-BB0C-FE87-8E79-972F5DD9EAE2}"/>
-          </ac:spMkLst>
-        </pc:spChg>
-      </pc:sldChg>
-    </pc:docChg>
-  </pc:docChgLst>
-  <pc:docChgLst>
     <pc:chgData name="Tiago Janela" userId="ee1a79fe-c79c-4f34-9602-7f6f2f0482b3" providerId="ADAL" clId="{67D2C233-DF3C-4C6D-9040-D7553E3BCB8A}"/>
     <pc:docChg chg="delSld modSld">
       <pc:chgData name="Tiago Janela" userId="ee1a79fe-c79c-4f34-9602-7f6f2f0482b3" providerId="ADAL" clId="{67D2C233-DF3C-4C6D-9040-D7553E3BCB8A}" dt="2026-03-16T14:03:02.466" v="54" actId="20577"/>
@@ -386,6 +265,201 @@
           <pc:docMk/>
           <pc:sldMk cId="1772121027" sldId="311"/>
         </pc:sldMkLst>
+      </pc:sldChg>
+    </pc:docChg>
+  </pc:docChgLst>
+  <pc:docChgLst>
+    <pc:chgData name="Tiago Janela" userId="ee1a79fe-c79c-4f34-9602-7f6f2f0482b3" providerId="ADAL" clId="{A1A622BE-A8AD-47B7-8802-BAC61BCE5126}"/>
+    <pc:docChg chg="undo custSel modSld">
+      <pc:chgData name="Tiago Janela" userId="ee1a79fe-c79c-4f34-9602-7f6f2f0482b3" providerId="ADAL" clId="{A1A622BE-A8AD-47B7-8802-BAC61BCE5126}" dt="2026-03-04T13:21:40.843" v="48" actId="403"/>
+      <pc:docMkLst>
+        <pc:docMk/>
+      </pc:docMkLst>
+      <pc:sldChg chg="modSp mod">
+        <pc:chgData name="Tiago Janela" userId="ee1a79fe-c79c-4f34-9602-7f6f2f0482b3" providerId="ADAL" clId="{A1A622BE-A8AD-47B7-8802-BAC61BCE5126}" dt="2026-03-04T13:20:02.161" v="40" actId="20577"/>
+        <pc:sldMkLst>
+          <pc:docMk/>
+          <pc:sldMk cId="114778141" sldId="303"/>
+        </pc:sldMkLst>
+        <pc:spChg chg="mod">
+          <ac:chgData name="Tiago Janela" userId="ee1a79fe-c79c-4f34-9602-7f6f2f0482b3" providerId="ADAL" clId="{A1A622BE-A8AD-47B7-8802-BAC61BCE5126}" dt="2026-03-04T13:20:02.161" v="40" actId="20577"/>
+          <ac:spMkLst>
+            <pc:docMk/>
+            <pc:sldMk cId="114778141" sldId="303"/>
+            <ac:spMk id="2" creationId="{3A594187-BB0C-FE87-8E79-972F5DD9EAE2}"/>
+          </ac:spMkLst>
+        </pc:spChg>
+      </pc:sldChg>
+      <pc:sldChg chg="modSp mod">
+        <pc:chgData name="Tiago Janela" userId="ee1a79fe-c79c-4f34-9602-7f6f2f0482b3" providerId="ADAL" clId="{A1A622BE-A8AD-47B7-8802-BAC61BCE5126}" dt="2026-03-04T13:21:32.291" v="47" actId="20577"/>
+        <pc:sldMkLst>
+          <pc:docMk/>
+          <pc:sldMk cId="1211845523" sldId="306"/>
+        </pc:sldMkLst>
+        <pc:spChg chg="mod">
+          <ac:chgData name="Tiago Janela" userId="ee1a79fe-c79c-4f34-9602-7f6f2f0482b3" providerId="ADAL" clId="{A1A622BE-A8AD-47B7-8802-BAC61BCE5126}" dt="2026-03-04T13:21:32.291" v="47" actId="20577"/>
+          <ac:spMkLst>
+            <pc:docMk/>
+            <pc:sldMk cId="1211845523" sldId="306"/>
+            <ac:spMk id="2" creationId="{3A594187-BB0C-FE87-8E79-972F5DD9EAE2}"/>
+          </ac:spMkLst>
+        </pc:spChg>
+      </pc:sldChg>
+      <pc:sldChg chg="modSp mod">
+        <pc:chgData name="Tiago Janela" userId="ee1a79fe-c79c-4f34-9602-7f6f2f0482b3" providerId="ADAL" clId="{A1A622BE-A8AD-47B7-8802-BAC61BCE5126}" dt="2026-03-04T13:21:40.843" v="48" actId="403"/>
+        <pc:sldMkLst>
+          <pc:docMk/>
+          <pc:sldMk cId="4258501269" sldId="307"/>
+        </pc:sldMkLst>
+        <pc:spChg chg="mod">
+          <ac:chgData name="Tiago Janela" userId="ee1a79fe-c79c-4f34-9602-7f6f2f0482b3" providerId="ADAL" clId="{A1A622BE-A8AD-47B7-8802-BAC61BCE5126}" dt="2026-03-04T13:21:40.843" v="48" actId="403"/>
+          <ac:spMkLst>
+            <pc:docMk/>
+            <pc:sldMk cId="4258501269" sldId="307"/>
+            <ac:spMk id="2" creationId="{3A594187-BB0C-FE87-8E79-972F5DD9EAE2}"/>
+          </ac:spMkLst>
+        </pc:spChg>
+      </pc:sldChg>
+    </pc:docChg>
+  </pc:docChgLst>
+  <pc:docChgLst>
+    <pc:chgData name="Tiago Janela" userId="ee1a79fe-c79c-4f34-9602-7f6f2f0482b3" providerId="ADAL" clId="{6BE67FA1-4A27-48B9-BA6A-E25A9786A9CC}"/>
+    <pc:docChg chg="undo custSel addSld modSld sldOrd">
+      <pc:chgData name="Tiago Janela" userId="ee1a79fe-c79c-4f34-9602-7f6f2f0482b3" providerId="ADAL" clId="{6BE67FA1-4A27-48B9-BA6A-E25A9786A9CC}" dt="2026-03-20T13:52:23.099" v="1063" actId="20577"/>
+      <pc:docMkLst>
+        <pc:docMk/>
+      </pc:docMkLst>
+      <pc:sldChg chg="addSp modSp mod">
+        <pc:chgData name="Tiago Janela" userId="ee1a79fe-c79c-4f34-9602-7f6f2f0482b3" providerId="ADAL" clId="{6BE67FA1-4A27-48B9-BA6A-E25A9786A9CC}" dt="2026-03-19T10:54:12.398" v="162" actId="1076"/>
+        <pc:sldMkLst>
+          <pc:docMk/>
+          <pc:sldMk cId="721732568" sldId="298"/>
+        </pc:sldMkLst>
+        <pc:spChg chg="mod">
+          <ac:chgData name="Tiago Janela" userId="ee1a79fe-c79c-4f34-9602-7f6f2f0482b3" providerId="ADAL" clId="{6BE67FA1-4A27-48B9-BA6A-E25A9786A9CC}" dt="2026-03-19T10:51:19.221" v="88" actId="20577"/>
+          <ac:spMkLst>
+            <pc:docMk/>
+            <pc:sldMk cId="721732568" sldId="298"/>
+            <ac:spMk id="2" creationId="{870990D0-7AC5-46BA-6FC4-274F8E0A3ABE}"/>
+          </ac:spMkLst>
+        </pc:spChg>
+        <pc:spChg chg="mod">
+          <ac:chgData name="Tiago Janela" userId="ee1a79fe-c79c-4f34-9602-7f6f2f0482b3" providerId="ADAL" clId="{6BE67FA1-4A27-48B9-BA6A-E25A9786A9CC}" dt="2026-03-19T10:37:44.329" v="9" actId="20577"/>
+          <ac:spMkLst>
+            <pc:docMk/>
+            <pc:sldMk cId="721732568" sldId="298"/>
+            <ac:spMk id="163" creationId="{57944F4B-F502-E7CC-8790-8737702BC6AC}"/>
+          </ac:spMkLst>
+        </pc:spChg>
+        <pc:picChg chg="add mod">
+          <ac:chgData name="Tiago Janela" userId="ee1a79fe-c79c-4f34-9602-7f6f2f0482b3" providerId="ADAL" clId="{6BE67FA1-4A27-48B9-BA6A-E25A9786A9CC}" dt="2026-03-19T10:54:12.398" v="162" actId="1076"/>
+          <ac:picMkLst>
+            <pc:docMk/>
+            <pc:sldMk cId="721732568" sldId="298"/>
+            <ac:picMk id="4" creationId="{A9172708-06AB-AE7A-4BC0-05B1328EE700}"/>
+          </ac:picMkLst>
+        </pc:picChg>
+      </pc:sldChg>
+      <pc:sldChg chg="delSp modSp add mod">
+        <pc:chgData name="Tiago Janela" userId="ee1a79fe-c79c-4f34-9602-7f6f2f0482b3" providerId="ADAL" clId="{6BE67FA1-4A27-48B9-BA6A-E25A9786A9CC}" dt="2026-03-19T10:59:23.180" v="500" actId="20577"/>
+        <pc:sldMkLst>
+          <pc:docMk/>
+          <pc:sldMk cId="1707478755" sldId="299"/>
+        </pc:sldMkLst>
+        <pc:spChg chg="mod">
+          <ac:chgData name="Tiago Janela" userId="ee1a79fe-c79c-4f34-9602-7f6f2f0482b3" providerId="ADAL" clId="{6BE67FA1-4A27-48B9-BA6A-E25A9786A9CC}" dt="2026-03-19T10:59:23.180" v="500" actId="20577"/>
+          <ac:spMkLst>
+            <pc:docMk/>
+            <pc:sldMk cId="1707478755" sldId="299"/>
+            <ac:spMk id="2" creationId="{870990D0-7AC5-46BA-6FC4-274F8E0A3ABE}"/>
+          </ac:spMkLst>
+        </pc:spChg>
+        <pc:picChg chg="del mod">
+          <ac:chgData name="Tiago Janela" userId="ee1a79fe-c79c-4f34-9602-7f6f2f0482b3" providerId="ADAL" clId="{6BE67FA1-4A27-48B9-BA6A-E25A9786A9CC}" dt="2026-03-19T10:51:55.896" v="93" actId="478"/>
+          <ac:picMkLst>
+            <pc:docMk/>
+            <pc:sldMk cId="1707478755" sldId="299"/>
+            <ac:picMk id="4" creationId="{A9172708-06AB-AE7A-4BC0-05B1328EE700}"/>
+          </ac:picMkLst>
+        </pc:picChg>
+      </pc:sldChg>
+      <pc:sldChg chg="addSp delSp modSp add mod">
+        <pc:chgData name="Tiago Janela" userId="ee1a79fe-c79c-4f34-9602-7f6f2f0482b3" providerId="ADAL" clId="{6BE67FA1-4A27-48B9-BA6A-E25A9786A9CC}" dt="2026-03-20T13:21:59.221" v="1059" actId="20577"/>
+        <pc:sldMkLst>
+          <pc:docMk/>
+          <pc:sldMk cId="457486825" sldId="300"/>
+        </pc:sldMkLst>
+        <pc:spChg chg="add del mod">
+          <ac:chgData name="Tiago Janela" userId="ee1a79fe-c79c-4f34-9602-7f6f2f0482b3" providerId="ADAL" clId="{6BE67FA1-4A27-48B9-BA6A-E25A9786A9CC}" dt="2026-03-20T13:19:05.879" v="819" actId="478"/>
+          <ac:spMkLst>
+            <pc:docMk/>
+            <pc:sldMk cId="457486825" sldId="300"/>
+            <ac:spMk id="2" creationId="{870990D0-7AC5-46BA-6FC4-274F8E0A3ABE}"/>
+          </ac:spMkLst>
+        </pc:spChg>
+        <pc:spChg chg="add mod">
+          <ac:chgData name="Tiago Janela" userId="ee1a79fe-c79c-4f34-9602-7f6f2f0482b3" providerId="ADAL" clId="{6BE67FA1-4A27-48B9-BA6A-E25A9786A9CC}" dt="2026-03-20T13:21:59.221" v="1059" actId="20577"/>
+          <ac:spMkLst>
+            <pc:docMk/>
+            <pc:sldMk cId="457486825" sldId="300"/>
+            <ac:spMk id="7" creationId="{66DE14D4-64D4-6D1F-DD92-BC16D674C58B}"/>
+          </ac:spMkLst>
+        </pc:spChg>
+        <pc:spChg chg="mod">
+          <ac:chgData name="Tiago Janela" userId="ee1a79fe-c79c-4f34-9602-7f6f2f0482b3" providerId="ADAL" clId="{6BE67FA1-4A27-48B9-BA6A-E25A9786A9CC}" dt="2026-03-20T13:08:59.412" v="584" actId="20577"/>
+          <ac:spMkLst>
+            <pc:docMk/>
+            <pc:sldMk cId="457486825" sldId="300"/>
+            <ac:spMk id="163" creationId="{57944F4B-F502-E7CC-8790-8737702BC6AC}"/>
+          </ac:spMkLst>
+        </pc:spChg>
+        <pc:picChg chg="add mod">
+          <ac:chgData name="Tiago Janela" userId="ee1a79fe-c79c-4f34-9602-7f6f2f0482b3" providerId="ADAL" clId="{6BE67FA1-4A27-48B9-BA6A-E25A9786A9CC}" dt="2026-03-20T13:19:08.305" v="821" actId="1076"/>
+          <ac:picMkLst>
+            <pc:docMk/>
+            <pc:sldMk cId="457486825" sldId="300"/>
+            <ac:picMk id="4" creationId="{0F3D5BC1-9264-881D-CF39-9525F816570A}"/>
+          </ac:picMkLst>
+        </pc:picChg>
+        <pc:picChg chg="add del">
+          <ac:chgData name="Tiago Janela" userId="ee1a79fe-c79c-4f34-9602-7f6f2f0482b3" providerId="ADAL" clId="{6BE67FA1-4A27-48B9-BA6A-E25A9786A9CC}" dt="2026-03-20T13:16:59.024" v="605" actId="478"/>
+          <ac:picMkLst>
+            <pc:docMk/>
+            <pc:sldMk cId="457486825" sldId="300"/>
+            <ac:picMk id="6" creationId="{D3BA145D-265C-C0B1-7C0E-2EE32552E491}"/>
+          </ac:picMkLst>
+        </pc:picChg>
+      </pc:sldChg>
+      <pc:sldChg chg="delSp modSp add mod ord">
+        <pc:chgData name="Tiago Janela" userId="ee1a79fe-c79c-4f34-9602-7f6f2f0482b3" providerId="ADAL" clId="{6BE67FA1-4A27-48B9-BA6A-E25A9786A9CC}" dt="2026-03-20T13:52:23.099" v="1063" actId="20577"/>
+        <pc:sldMkLst>
+          <pc:docMk/>
+          <pc:sldMk cId="2375808848" sldId="301"/>
+        </pc:sldMkLst>
+        <pc:spChg chg="mod">
+          <ac:chgData name="Tiago Janela" userId="ee1a79fe-c79c-4f34-9602-7f6f2f0482b3" providerId="ADAL" clId="{6BE67FA1-4A27-48B9-BA6A-E25A9786A9CC}" dt="2026-03-20T13:52:23.099" v="1063" actId="20577"/>
+          <ac:spMkLst>
+            <pc:docMk/>
+            <pc:sldMk cId="2375808848" sldId="301"/>
+            <ac:spMk id="2" creationId="{870990D0-7AC5-46BA-6FC4-274F8E0A3ABE}"/>
+          </ac:spMkLst>
+        </pc:spChg>
+        <pc:picChg chg="del">
+          <ac:chgData name="Tiago Janela" userId="ee1a79fe-c79c-4f34-9602-7f6f2f0482b3" providerId="ADAL" clId="{6BE67FA1-4A27-48B9-BA6A-E25A9786A9CC}" dt="2026-03-20T13:16:48.406" v="599" actId="478"/>
+          <ac:picMkLst>
+            <pc:docMk/>
+            <pc:sldMk cId="2375808848" sldId="301"/>
+            <ac:picMk id="4" creationId="{0F3D5BC1-9264-881D-CF39-9525F816570A}"/>
+          </ac:picMkLst>
+        </pc:picChg>
+        <pc:picChg chg="mod">
+          <ac:chgData name="Tiago Janela" userId="ee1a79fe-c79c-4f34-9602-7f6f2f0482b3" providerId="ADAL" clId="{6BE67FA1-4A27-48B9-BA6A-E25A9786A9CC}" dt="2026-03-20T13:17:16.190" v="611" actId="1076"/>
+          <ac:picMkLst>
+            <pc:docMk/>
+            <pc:sldMk cId="2375808848" sldId="301"/>
+            <ac:picMk id="6" creationId="{D3BA145D-265C-C0B1-7C0E-2EE32552E491}"/>
+          </ac:picMkLst>
+        </pc:picChg>
       </pc:sldChg>
     </pc:docChg>
   </pc:docChgLst>
@@ -843,6 +917,76 @@
       </pc:sldChg>
     </pc:docChg>
   </pc:docChgLst>
+  <pc:docChgLst>
+    <pc:chgData name="Tiago Janela" userId="ee1a79fe-c79c-4f34-9602-7f6f2f0482b3" providerId="ADAL" clId="{771048AC-4F55-42D8-AA6A-766F659A7530}"/>
+    <pc:docChg chg="undo custSel addSld delSld modSld sldOrd">
+      <pc:chgData name="Tiago Janela" userId="ee1a79fe-c79c-4f34-9602-7f6f2f0482b3" providerId="ADAL" clId="{771048AC-4F55-42D8-AA6A-766F659A7530}" dt="2026-02-05T14:24:21.198" v="2967" actId="20577"/>
+      <pc:docMkLst>
+        <pc:docMk/>
+      </pc:docMkLst>
+      <pc:sldChg chg="delSp modSp add mod">
+        <pc:chgData name="Tiago Janela" userId="ee1a79fe-c79c-4f34-9602-7f6f2f0482b3" providerId="ADAL" clId="{771048AC-4F55-42D8-AA6A-766F659A7530}" dt="2026-02-05T14:24:21.198" v="2967" actId="20577"/>
+        <pc:sldMkLst>
+          <pc:docMk/>
+          <pc:sldMk cId="901468915" sldId="296"/>
+        </pc:sldMkLst>
+        <pc:spChg chg="mod">
+          <ac:chgData name="Tiago Janela" userId="ee1a79fe-c79c-4f34-9602-7f6f2f0482b3" providerId="ADAL" clId="{771048AC-4F55-42D8-AA6A-766F659A7530}" dt="2026-02-05T10:58:00.218" v="1144" actId="20577"/>
+          <ac:spMkLst>
+            <pc:docMk/>
+            <pc:sldMk cId="901468915" sldId="296"/>
+            <ac:spMk id="163" creationId="{CBF44E8C-8654-71A0-B86B-E9D342AC2D4D}"/>
+          </ac:spMkLst>
+        </pc:spChg>
+        <pc:spChg chg="mod">
+          <ac:chgData name="Tiago Janela" userId="ee1a79fe-c79c-4f34-9602-7f6f2f0482b3" providerId="ADAL" clId="{771048AC-4F55-42D8-AA6A-766F659A7530}" dt="2026-02-05T14:24:21.198" v="2967" actId="20577"/>
+          <ac:spMkLst>
+            <pc:docMk/>
+            <pc:sldMk cId="901468915" sldId="296"/>
+            <ac:spMk id="164" creationId="{B6FA4745-5BA4-2D80-2549-988AFFB4E146}"/>
+          </ac:spMkLst>
+        </pc:spChg>
+      </pc:sldChg>
+      <pc:sldChg chg="modSp add mod ord">
+        <pc:chgData name="Tiago Janela" userId="ee1a79fe-c79c-4f34-9602-7f6f2f0482b3" providerId="ADAL" clId="{771048AC-4F55-42D8-AA6A-766F659A7530}" dt="2026-02-05T12:59:57.611" v="1910" actId="20577"/>
+        <pc:sldMkLst>
+          <pc:docMk/>
+          <pc:sldMk cId="829672710" sldId="297"/>
+        </pc:sldMkLst>
+        <pc:spChg chg="mod">
+          <ac:chgData name="Tiago Janela" userId="ee1a79fe-c79c-4f34-9602-7f6f2f0482b3" providerId="ADAL" clId="{771048AC-4F55-42D8-AA6A-766F659A7530}" dt="2026-02-05T12:59:57.611" v="1910" actId="20577"/>
+          <ac:spMkLst>
+            <pc:docMk/>
+            <pc:sldMk cId="829672710" sldId="297"/>
+            <ac:spMk id="156" creationId="{00000000-0000-0000-0000-000000000000}"/>
+          </ac:spMkLst>
+        </pc:spChg>
+      </pc:sldChg>
+      <pc:sldChg chg="delSp modSp add mod ord">
+        <pc:chgData name="Tiago Janela" userId="ee1a79fe-c79c-4f34-9602-7f6f2f0482b3" providerId="ADAL" clId="{771048AC-4F55-42D8-AA6A-766F659A7530}" dt="2026-02-05T14:23:46.564" v="2966" actId="20577"/>
+        <pc:sldMkLst>
+          <pc:docMk/>
+          <pc:sldMk cId="721732568" sldId="298"/>
+        </pc:sldMkLst>
+        <pc:spChg chg="mod">
+          <ac:chgData name="Tiago Janela" userId="ee1a79fe-c79c-4f34-9602-7f6f2f0482b3" providerId="ADAL" clId="{771048AC-4F55-42D8-AA6A-766F659A7530}" dt="2026-02-05T14:23:46.564" v="2966" actId="20577"/>
+          <ac:spMkLst>
+            <pc:docMk/>
+            <pc:sldMk cId="721732568" sldId="298"/>
+            <ac:spMk id="2" creationId="{870990D0-7AC5-46BA-6FC4-274F8E0A3ABE}"/>
+          </ac:spMkLst>
+        </pc:spChg>
+        <pc:spChg chg="mod">
+          <ac:chgData name="Tiago Janela" userId="ee1a79fe-c79c-4f34-9602-7f6f2f0482b3" providerId="ADAL" clId="{771048AC-4F55-42D8-AA6A-766F659A7530}" dt="2026-02-05T13:01:46.094" v="1930" actId="20577"/>
+          <ac:spMkLst>
+            <pc:docMk/>
+            <pc:sldMk cId="721732568" sldId="298"/>
+            <ac:spMk id="163" creationId="{57944F4B-F502-E7CC-8790-8737702BC6AC}"/>
+          </ac:spMkLst>
+        </pc:spChg>
+      </pc:sldChg>
+    </pc:docChg>
+  </pc:docChgLst>
 </pc:chgInfo>
 </file>
 
@@ -9955,7 +10099,7 @@
                 </a:solidFill>
                 <a:latin typeface="Century Gothic"/>
               </a:rPr>
-              <a:t>Analysis steps</a:t>
+              <a:t>Study idea</a:t>
             </a:r>
             <a:endParaRPr lang="en-US" sz="3200" b="0" strike="noStrike" spc="-1" dirty="0">
               <a:solidFill>
@@ -10038,8 +10182,8 @@
         </p:nvSpPr>
         <p:spPr>
           <a:xfrm>
-            <a:off x="382680" y="1371598"/>
-            <a:ext cx="8380080" cy="4685761"/>
+            <a:off x="380880" y="1371599"/>
+            <a:ext cx="8380080" cy="713065"/>
           </a:xfrm>
           <a:prstGeom prst="rect">
             <a:avLst/>
@@ -10241,7 +10385,7 @@
                 </a:solidFill>
                 <a:latin typeface="Century Gothic"/>
               </a:rPr>
-              <a:t>From</a:t>
+              <a:t>MCP-based Agent for ML compound explainability </a:t>
             </a:r>
             <a:endParaRPr lang="en-US" sz="2000" b="1" spc="-1" dirty="0">
               <a:solidFill>
@@ -10252,10 +10396,2004 @@
           </a:p>
         </p:txBody>
       </p:sp>
+      <p:pic>
+        <p:nvPicPr>
+          <p:cNvPr id="4" name="Picture 3" descr="A diagram of different types of chemistry&#10;&#10;AI-generated content may be incorrect.">
+            <a:extLst>
+              <a:ext uri="{FF2B5EF4-FFF2-40B4-BE49-F238E27FC236}">
+                <a16:creationId xmlns:a16="http://schemas.microsoft.com/office/drawing/2014/main" id="{A9172708-06AB-AE7A-4BC0-05B1328EE700}"/>
+              </a:ext>
+            </a:extLst>
+          </p:cNvPr>
+          <p:cNvPicPr>
+            <a:picLocks noChangeAspect="1"/>
+          </p:cNvPicPr>
+          <p:nvPr/>
+        </p:nvPicPr>
+        <p:blipFill>
+          <a:blip r:embed="rId2">
+            <a:extLst>
+              <a:ext uri="{28A0092B-C50C-407E-A947-70E740481C1C}">
+                <a14:useLocalDpi xmlns:a14="http://schemas.microsoft.com/office/drawing/2010/main" val="0"/>
+              </a:ext>
+            </a:extLst>
+          </a:blip>
+          <a:stretch>
+            <a:fillRect/>
+          </a:stretch>
+        </p:blipFill>
+        <p:spPr>
+          <a:xfrm>
+            <a:off x="665429" y="2123180"/>
+            <a:ext cx="7810981" cy="3363221"/>
+          </a:xfrm>
+          <a:prstGeom prst="rect">
+            <a:avLst/>
+          </a:prstGeom>
+        </p:spPr>
+      </p:pic>
     </p:spTree>
     <p:extLst>
       <p:ext uri="{BB962C8B-B14F-4D97-AF65-F5344CB8AC3E}">
         <p14:creationId xmlns:p14="http://schemas.microsoft.com/office/powerpoint/2010/main" val="721732568"/>
+      </p:ext>
+    </p:extLst>
+  </p:cSld>
+  <p:clrMapOvr>
+    <a:masterClrMapping/>
+  </p:clrMapOvr>
+  <mc:AlternateContent xmlns:mc="http://schemas.openxmlformats.org/markup-compatibility/2006" xmlns:p14="http://schemas.microsoft.com/office/powerpoint/2010/main">
+    <mc:Choice Requires="p14">
+      <p:transition spd="med" p14:dur="700">
+        <p:fade/>
+      </p:transition>
+    </mc:Choice>
+    <mc:Fallback xmlns:p15="http://schemas.microsoft.com/office/powerpoint/2012/main" xmlns="">
+      <p:transition spd="med">
+        <p:fade/>
+      </p:transition>
+    </mc:Fallback>
+  </mc:AlternateContent>
+</p:sld>
+</file>
+
+<file path=ppt/slides/slide3.xml><?xml version="1.0" encoding="utf-8"?>
+<p:sld xmlns:a="http://schemas.openxmlformats.org/drawingml/2006/main" xmlns:r="http://schemas.openxmlformats.org/officeDocument/2006/relationships" xmlns:p="http://schemas.openxmlformats.org/presentationml/2006/main">
+  <p:cSld>
+    <p:spTree>
+      <p:nvGrpSpPr>
+        <p:cNvPr id="1" name="">
+          <a:extLst>
+            <a:ext uri="{FF2B5EF4-FFF2-40B4-BE49-F238E27FC236}">
+              <a16:creationId xmlns:a16="http://schemas.microsoft.com/office/drawing/2014/main" id="{A6515F23-0912-A838-23CE-B8F00573A2DA}"/>
+            </a:ext>
+          </a:extLst>
+        </p:cNvPr>
+        <p:cNvGrpSpPr/>
+        <p:nvPr/>
+      </p:nvGrpSpPr>
+      <p:grpSpPr>
+        <a:xfrm>
+          <a:off x="0" y="0"/>
+          <a:ext cx="0" cy="0"/>
+          <a:chOff x="0" y="0"/>
+          <a:chExt cx="0" cy="0"/>
+        </a:xfrm>
+      </p:grpSpPr>
+      <p:sp>
+        <p:nvSpPr>
+          <p:cNvPr id="163" name="PlaceHolder 1">
+            <a:extLst>
+              <a:ext uri="{FF2B5EF4-FFF2-40B4-BE49-F238E27FC236}">
+                <a16:creationId xmlns:a16="http://schemas.microsoft.com/office/drawing/2014/main" id="{57944F4B-F502-E7CC-8790-8737702BC6AC}"/>
+              </a:ext>
+            </a:extLst>
+          </p:cNvPr>
+          <p:cNvSpPr>
+            <a:spLocks noGrp="1"/>
+          </p:cNvSpPr>
+          <p:nvPr>
+            <p:ph type="title"/>
+          </p:nvPr>
+        </p:nvSpPr>
+        <p:spPr>
+          <a:xfrm>
+            <a:off x="380880" y="228600"/>
+            <a:ext cx="8380080" cy="837720"/>
+          </a:xfrm>
+          <a:prstGeom prst="rect">
+            <a:avLst/>
+          </a:prstGeom>
+          <a:noFill/>
+          <a:ln w="0">
+            <a:noFill/>
+          </a:ln>
+        </p:spPr>
+        <p:txBody>
+          <a:bodyPr numCol="1" spcCol="0" anchor="ctr">
+            <a:noAutofit/>
+          </a:bodyPr>
+          <a:lstStyle/>
+          <a:p>
+            <a:pPr>
+              <a:lnSpc>
+                <a:spcPct val="100000"/>
+              </a:lnSpc>
+              <a:buNone/>
+            </a:pPr>
+            <a:r>
+              <a:rPr lang="en-US" sz="3200" b="0" strike="noStrike" spc="-1" dirty="0">
+                <a:solidFill>
+                  <a:srgbClr val="0064C8"/>
+                </a:solidFill>
+                <a:latin typeface="Century Gothic"/>
+              </a:rPr>
+              <a:t>Study idea</a:t>
+            </a:r>
+            <a:endParaRPr lang="en-US" sz="3200" b="0" strike="noStrike" spc="-1" dirty="0">
+              <a:solidFill>
+                <a:srgbClr val="000000"/>
+              </a:solidFill>
+              <a:latin typeface="Century Gothic"/>
+            </a:endParaRPr>
+          </a:p>
+        </p:txBody>
+      </p:sp>
+      <p:sp>
+        <p:nvSpPr>
+          <p:cNvPr id="165" name="PlaceHolder 3">
+            <a:extLst>
+              <a:ext uri="{FF2B5EF4-FFF2-40B4-BE49-F238E27FC236}">
+                <a16:creationId xmlns:a16="http://schemas.microsoft.com/office/drawing/2014/main" id="{2EFBEA53-7B78-D9A1-93EF-9608A3193D27}"/>
+              </a:ext>
+            </a:extLst>
+          </p:cNvPr>
+          <p:cNvSpPr>
+            <a:spLocks noGrp="1"/>
+          </p:cNvSpPr>
+          <p:nvPr>
+            <p:ph type="sldNum"/>
+          </p:nvPr>
+        </p:nvSpPr>
+        <p:spPr>
+          <a:xfrm>
+            <a:off x="8376840" y="5692680"/>
+            <a:ext cx="384120" cy="364680"/>
+          </a:xfrm>
+          <a:prstGeom prst="rect">
+            <a:avLst/>
+          </a:prstGeom>
+          <a:noFill/>
+          <a:ln w="0">
+            <a:noFill/>
+          </a:ln>
+        </p:spPr>
+        <p:txBody>
+          <a:bodyPr anchor="ctr">
+            <a:noAutofit/>
+          </a:bodyPr>
+          <a:lstStyle/>
+          <a:p>
+            <a:pPr algn="r">
+              <a:lnSpc>
+                <a:spcPct val="100000"/>
+              </a:lnSpc>
+              <a:buNone/>
+            </a:pPr>
+            <a:fld id="{8BD7C522-1E12-40C3-B25E-5F0462E20B22}" type="slidenum">
+              <a:rPr lang="en-US" sz="1200" b="0" strike="noStrike" spc="-1">
+                <a:solidFill>
+                  <a:srgbClr val="8B8B8B"/>
+                </a:solidFill>
+                <a:latin typeface="Century Gothic"/>
+              </a:rPr>
+              <a:t>3</a:t>
+            </a:fld>
+            <a:endParaRPr lang="en-GB" sz="1200" b="0" strike="noStrike" spc="-1" dirty="0">
+              <a:latin typeface="Times New Roman"/>
+            </a:endParaRPr>
+          </a:p>
+        </p:txBody>
+      </p:sp>
+      <p:sp>
+        <p:nvSpPr>
+          <p:cNvPr id="2" name="PlaceHolder 2">
+            <a:extLst>
+              <a:ext uri="{FF2B5EF4-FFF2-40B4-BE49-F238E27FC236}">
+                <a16:creationId xmlns:a16="http://schemas.microsoft.com/office/drawing/2014/main" id="{870990D0-7AC5-46BA-6FC4-274F8E0A3ABE}"/>
+              </a:ext>
+            </a:extLst>
+          </p:cNvPr>
+          <p:cNvSpPr txBox="1">
+            <a:spLocks/>
+          </p:cNvSpPr>
+          <p:nvPr/>
+        </p:nvSpPr>
+        <p:spPr>
+          <a:xfrm>
+            <a:off x="380880" y="1371599"/>
+            <a:ext cx="8380080" cy="4643307"/>
+          </a:xfrm>
+          <a:prstGeom prst="rect">
+            <a:avLst/>
+          </a:prstGeom>
+          <a:noFill/>
+          <a:ln w="0">
+            <a:noFill/>
+          </a:ln>
+        </p:spPr>
+        <p:txBody>
+          <a:bodyPr numCol="1" spcCol="0" anchor="t">
+            <a:noAutofit/>
+          </a:bodyPr>
+          <a:lstStyle>
+            <a:lvl1pPr marL="228600" indent="-228600" algn="l" defTabSz="914400" rtl="0" eaLnBrk="1" latinLnBrk="0" hangingPunct="1">
+              <a:lnSpc>
+                <a:spcPct val="90000"/>
+              </a:lnSpc>
+              <a:spcBef>
+                <a:spcPts val="1000"/>
+              </a:spcBef>
+              <a:buFont typeface="Arial" panose="020B0604020202020204" pitchFamily="34" charset="0"/>
+              <a:buChar char="•"/>
+              <a:defRPr sz="2800" kern="1200">
+                <a:solidFill>
+                  <a:schemeClr val="tx1"/>
+                </a:solidFill>
+                <a:latin typeface="+mn-lt"/>
+                <a:ea typeface="+mn-ea"/>
+                <a:cs typeface="+mn-cs"/>
+              </a:defRPr>
+            </a:lvl1pPr>
+            <a:lvl2pPr marL="685800" indent="-228600" algn="l" defTabSz="914400" rtl="0" eaLnBrk="1" latinLnBrk="0" hangingPunct="1">
+              <a:lnSpc>
+                <a:spcPct val="90000"/>
+              </a:lnSpc>
+              <a:spcBef>
+                <a:spcPts val="500"/>
+              </a:spcBef>
+              <a:buFont typeface="Arial" panose="020B0604020202020204" pitchFamily="34" charset="0"/>
+              <a:buChar char="•"/>
+              <a:defRPr sz="2400" kern="1200">
+                <a:solidFill>
+                  <a:schemeClr val="tx1"/>
+                </a:solidFill>
+                <a:latin typeface="+mn-lt"/>
+                <a:ea typeface="+mn-ea"/>
+                <a:cs typeface="+mn-cs"/>
+              </a:defRPr>
+            </a:lvl2pPr>
+            <a:lvl3pPr marL="1143000" indent="-228600" algn="l" defTabSz="914400" rtl="0" eaLnBrk="1" latinLnBrk="0" hangingPunct="1">
+              <a:lnSpc>
+                <a:spcPct val="90000"/>
+              </a:lnSpc>
+              <a:spcBef>
+                <a:spcPts val="500"/>
+              </a:spcBef>
+              <a:buFont typeface="Arial" panose="020B0604020202020204" pitchFamily="34" charset="0"/>
+              <a:buChar char="•"/>
+              <a:defRPr sz="2000" kern="1200">
+                <a:solidFill>
+                  <a:schemeClr val="tx1"/>
+                </a:solidFill>
+                <a:latin typeface="+mn-lt"/>
+                <a:ea typeface="+mn-ea"/>
+                <a:cs typeface="+mn-cs"/>
+              </a:defRPr>
+            </a:lvl3pPr>
+            <a:lvl4pPr marL="1600200" indent="-228600" algn="l" defTabSz="914400" rtl="0" eaLnBrk="1" latinLnBrk="0" hangingPunct="1">
+              <a:lnSpc>
+                <a:spcPct val="90000"/>
+              </a:lnSpc>
+              <a:spcBef>
+                <a:spcPts val="500"/>
+              </a:spcBef>
+              <a:buFont typeface="Arial" panose="020B0604020202020204" pitchFamily="34" charset="0"/>
+              <a:buChar char="•"/>
+              <a:defRPr sz="1800" kern="1200">
+                <a:solidFill>
+                  <a:schemeClr val="tx1"/>
+                </a:solidFill>
+                <a:latin typeface="+mn-lt"/>
+                <a:ea typeface="+mn-ea"/>
+                <a:cs typeface="+mn-cs"/>
+              </a:defRPr>
+            </a:lvl4pPr>
+            <a:lvl5pPr marL="2057400" indent="-228600" algn="l" defTabSz="914400" rtl="0" eaLnBrk="1" latinLnBrk="0" hangingPunct="1">
+              <a:lnSpc>
+                <a:spcPct val="90000"/>
+              </a:lnSpc>
+              <a:spcBef>
+                <a:spcPts val="500"/>
+              </a:spcBef>
+              <a:buFont typeface="Arial" panose="020B0604020202020204" pitchFamily="34" charset="0"/>
+              <a:buChar char="•"/>
+              <a:defRPr sz="1800" kern="1200">
+                <a:solidFill>
+                  <a:schemeClr val="tx1"/>
+                </a:solidFill>
+                <a:latin typeface="+mn-lt"/>
+                <a:ea typeface="+mn-ea"/>
+                <a:cs typeface="+mn-cs"/>
+              </a:defRPr>
+            </a:lvl5pPr>
+            <a:lvl6pPr marL="2514600" indent="-228600" algn="l" defTabSz="914400" rtl="0" eaLnBrk="1" latinLnBrk="0" hangingPunct="1">
+              <a:lnSpc>
+                <a:spcPct val="90000"/>
+              </a:lnSpc>
+              <a:spcBef>
+                <a:spcPts val="500"/>
+              </a:spcBef>
+              <a:buFont typeface="Arial" panose="020B0604020202020204" pitchFamily="34" charset="0"/>
+              <a:buChar char="•"/>
+              <a:defRPr sz="1800" kern="1200">
+                <a:solidFill>
+                  <a:schemeClr val="tx1"/>
+                </a:solidFill>
+                <a:latin typeface="+mn-lt"/>
+                <a:ea typeface="+mn-ea"/>
+                <a:cs typeface="+mn-cs"/>
+              </a:defRPr>
+            </a:lvl6pPr>
+            <a:lvl7pPr marL="2971800" indent="-228600" algn="l" defTabSz="914400" rtl="0" eaLnBrk="1" latinLnBrk="0" hangingPunct="1">
+              <a:lnSpc>
+                <a:spcPct val="90000"/>
+              </a:lnSpc>
+              <a:spcBef>
+                <a:spcPts val="500"/>
+              </a:spcBef>
+              <a:buFont typeface="Arial" panose="020B0604020202020204" pitchFamily="34" charset="0"/>
+              <a:buChar char="•"/>
+              <a:defRPr sz="1800" kern="1200">
+                <a:solidFill>
+                  <a:schemeClr val="tx1"/>
+                </a:solidFill>
+                <a:latin typeface="+mn-lt"/>
+                <a:ea typeface="+mn-ea"/>
+                <a:cs typeface="+mn-cs"/>
+              </a:defRPr>
+            </a:lvl7pPr>
+            <a:lvl8pPr marL="3429000" indent="-228600" algn="l" defTabSz="914400" rtl="0" eaLnBrk="1" latinLnBrk="0" hangingPunct="1">
+              <a:lnSpc>
+                <a:spcPct val="90000"/>
+              </a:lnSpc>
+              <a:spcBef>
+                <a:spcPts val="500"/>
+              </a:spcBef>
+              <a:buFont typeface="Arial" panose="020B0604020202020204" pitchFamily="34" charset="0"/>
+              <a:buChar char="•"/>
+              <a:defRPr sz="1800" kern="1200">
+                <a:solidFill>
+                  <a:schemeClr val="tx1"/>
+                </a:solidFill>
+                <a:latin typeface="+mn-lt"/>
+                <a:ea typeface="+mn-ea"/>
+                <a:cs typeface="+mn-cs"/>
+              </a:defRPr>
+            </a:lvl8pPr>
+            <a:lvl9pPr marL="3886200" indent="-228600" algn="l" defTabSz="914400" rtl="0" eaLnBrk="1" latinLnBrk="0" hangingPunct="1">
+              <a:lnSpc>
+                <a:spcPct val="90000"/>
+              </a:lnSpc>
+              <a:spcBef>
+                <a:spcPts val="500"/>
+              </a:spcBef>
+              <a:buFont typeface="Arial" panose="020B0604020202020204" pitchFamily="34" charset="0"/>
+              <a:buChar char="•"/>
+              <a:defRPr sz="1800" kern="1200">
+                <a:solidFill>
+                  <a:schemeClr val="tx1"/>
+                </a:solidFill>
+                <a:latin typeface="+mn-lt"/>
+                <a:ea typeface="+mn-ea"/>
+                <a:cs typeface="+mn-cs"/>
+              </a:defRPr>
+            </a:lvl9pPr>
+          </a:lstStyle>
+          <a:p>
+            <a:pPr marL="343080" indent="-343080">
+              <a:lnSpc>
+                <a:spcPct val="100000"/>
+              </a:lnSpc>
+              <a:spcBef>
+                <a:spcPts val="400"/>
+              </a:spcBef>
+              <a:buClr>
+                <a:srgbClr val="0064C8"/>
+              </a:buClr>
+              <a:buFont typeface="Wingdings 2" charset="2"/>
+              <a:buChar char=""/>
+            </a:pPr>
+            <a:r>
+              <a:rPr lang="en-US" sz="2000" spc="-1" dirty="0">
+                <a:solidFill>
+                  <a:srgbClr val="000000"/>
+                </a:solidFill>
+                <a:latin typeface="Century Gothic"/>
+              </a:rPr>
+              <a:t>Framework</a:t>
+            </a:r>
+          </a:p>
+          <a:p>
+            <a:pPr lvl="1">
+              <a:lnSpc>
+                <a:spcPct val="100000"/>
+              </a:lnSpc>
+              <a:spcBef>
+                <a:spcPts val="400"/>
+              </a:spcBef>
+              <a:buClr>
+                <a:srgbClr val="0064C8"/>
+              </a:buClr>
+              <a:buFont typeface="Symbol" panose="05050102010706020507" pitchFamily="18" charset="2"/>
+              <a:buChar char="-"/>
+            </a:pPr>
+            <a:r>
+              <a:rPr lang="en-US" sz="1600" spc="-1" dirty="0">
+                <a:solidFill>
+                  <a:srgbClr val="000000"/>
+                </a:solidFill>
+                <a:latin typeface="Century Gothic"/>
+              </a:rPr>
+              <a:t>LM Studio + Open Source LLM (GPT-OSS, </a:t>
+            </a:r>
+            <a:r>
+              <a:rPr lang="en-US" sz="1600" spc="-1" dirty="0" err="1">
+                <a:solidFill>
+                  <a:srgbClr val="000000"/>
+                </a:solidFill>
+                <a:latin typeface="Century Gothic"/>
+              </a:rPr>
+              <a:t>Qwen</a:t>
+            </a:r>
+            <a:r>
+              <a:rPr lang="en-US" sz="1600" spc="-1" dirty="0">
+                <a:solidFill>
+                  <a:srgbClr val="000000"/>
+                </a:solidFill>
+                <a:latin typeface="Century Gothic"/>
+              </a:rPr>
+              <a:t> 3.5, </a:t>
+            </a:r>
+            <a:r>
+              <a:rPr lang="en-US" sz="1600" spc="-1" dirty="0" err="1">
+                <a:solidFill>
+                  <a:srgbClr val="000000"/>
+                </a:solidFill>
+                <a:latin typeface="Century Gothic"/>
+              </a:rPr>
+              <a:t>etc</a:t>
+            </a:r>
+            <a:r>
+              <a:rPr lang="en-US" sz="1600" spc="-1" dirty="0">
+                <a:solidFill>
+                  <a:srgbClr val="000000"/>
+                </a:solidFill>
+                <a:latin typeface="Century Gothic"/>
+              </a:rPr>
+              <a:t>)</a:t>
+            </a:r>
+            <a:br>
+              <a:rPr lang="en-US" sz="1600" spc="-1" dirty="0">
+                <a:solidFill>
+                  <a:srgbClr val="000000"/>
+                </a:solidFill>
+                <a:latin typeface="Century Gothic"/>
+              </a:rPr>
+            </a:br>
+            <a:endParaRPr lang="en-US" sz="2000" spc="-1" dirty="0">
+              <a:solidFill>
+                <a:srgbClr val="000000"/>
+              </a:solidFill>
+              <a:latin typeface="Century Gothic"/>
+            </a:endParaRPr>
+          </a:p>
+          <a:p>
+            <a:pPr>
+              <a:lnSpc>
+                <a:spcPct val="100000"/>
+              </a:lnSpc>
+              <a:spcBef>
+                <a:spcPts val="400"/>
+              </a:spcBef>
+              <a:buClr>
+                <a:srgbClr val="0064C8"/>
+              </a:buClr>
+              <a:buFont typeface="Wingdings" panose="05000000000000000000" pitchFamily="2" charset="2"/>
+              <a:buChar char="§"/>
+            </a:pPr>
+            <a:r>
+              <a:rPr lang="en-US" sz="2000" spc="-1" dirty="0">
+                <a:solidFill>
+                  <a:srgbClr val="000000"/>
+                </a:solidFill>
+                <a:latin typeface="Century Gothic"/>
+              </a:rPr>
+              <a:t>Explainability methods</a:t>
+            </a:r>
+          </a:p>
+          <a:p>
+            <a:pPr lvl="1">
+              <a:lnSpc>
+                <a:spcPct val="100000"/>
+              </a:lnSpc>
+              <a:spcBef>
+                <a:spcPts val="400"/>
+              </a:spcBef>
+              <a:buClr>
+                <a:srgbClr val="0064C8"/>
+              </a:buClr>
+              <a:buFont typeface="Symbol" panose="05050102010706020507" pitchFamily="18" charset="2"/>
+              <a:buChar char="-"/>
+            </a:pPr>
+            <a:r>
+              <a:rPr lang="en-US" sz="1600" spc="-1" dirty="0">
+                <a:solidFill>
+                  <a:srgbClr val="000000"/>
+                </a:solidFill>
+                <a:latin typeface="Century Gothic"/>
+              </a:rPr>
+              <a:t>SHAP</a:t>
+            </a:r>
+          </a:p>
+          <a:p>
+            <a:pPr lvl="1">
+              <a:lnSpc>
+                <a:spcPct val="100000"/>
+              </a:lnSpc>
+              <a:spcBef>
+                <a:spcPts val="400"/>
+              </a:spcBef>
+              <a:buClr>
+                <a:srgbClr val="0064C8"/>
+              </a:buClr>
+              <a:buFont typeface="Symbol" panose="05050102010706020507" pitchFamily="18" charset="2"/>
+              <a:buChar char="-"/>
+            </a:pPr>
+            <a:r>
+              <a:rPr lang="en-US" sz="1600" spc="-1" dirty="0" err="1">
+                <a:solidFill>
+                  <a:srgbClr val="000000"/>
+                </a:solidFill>
+                <a:latin typeface="Century Gothic"/>
+              </a:rPr>
+              <a:t>MolAnchor</a:t>
+            </a:r>
+            <a:endParaRPr lang="en-US" sz="1600" spc="-1" dirty="0">
+              <a:solidFill>
+                <a:srgbClr val="000000"/>
+              </a:solidFill>
+              <a:latin typeface="Century Gothic"/>
+            </a:endParaRPr>
+          </a:p>
+          <a:p>
+            <a:pPr lvl="1">
+              <a:lnSpc>
+                <a:spcPct val="100000"/>
+              </a:lnSpc>
+              <a:spcBef>
+                <a:spcPts val="400"/>
+              </a:spcBef>
+              <a:buClr>
+                <a:srgbClr val="0064C8"/>
+              </a:buClr>
+              <a:buFont typeface="Symbol" panose="05050102010706020507" pitchFamily="18" charset="2"/>
+              <a:buChar char="-"/>
+            </a:pPr>
+            <a:r>
+              <a:rPr lang="en-US" sz="1600" spc="-1" dirty="0">
+                <a:solidFill>
+                  <a:srgbClr val="000000"/>
+                </a:solidFill>
+                <a:latin typeface="Century Gothic"/>
+              </a:rPr>
+              <a:t>Counterfactuals</a:t>
+            </a:r>
+          </a:p>
+          <a:p>
+            <a:pPr lvl="1">
+              <a:lnSpc>
+                <a:spcPct val="100000"/>
+              </a:lnSpc>
+              <a:spcBef>
+                <a:spcPts val="400"/>
+              </a:spcBef>
+              <a:buClr>
+                <a:srgbClr val="0064C8"/>
+              </a:buClr>
+              <a:buFont typeface="Symbol" panose="05050102010706020507" pitchFamily="18" charset="2"/>
+              <a:buChar char="-"/>
+            </a:pPr>
+            <a:r>
+              <a:rPr lang="en-US" sz="1600" spc="-1" dirty="0" err="1">
+                <a:solidFill>
+                  <a:srgbClr val="000000"/>
+                </a:solidFill>
+                <a:latin typeface="Century Gothic"/>
+              </a:rPr>
+              <a:t>ContrastiveExplain</a:t>
+            </a:r>
+            <a:r>
+              <a:rPr lang="en-US" sz="1600" spc="-1" dirty="0">
+                <a:solidFill>
+                  <a:srgbClr val="000000"/>
+                </a:solidFill>
+                <a:latin typeface="Century Gothic"/>
+              </a:rPr>
+              <a:t>. (?)</a:t>
+            </a:r>
+          </a:p>
+          <a:p>
+            <a:pPr lvl="1">
+              <a:lnSpc>
+                <a:spcPct val="100000"/>
+              </a:lnSpc>
+              <a:spcBef>
+                <a:spcPts val="400"/>
+              </a:spcBef>
+              <a:buClr>
+                <a:srgbClr val="0064C8"/>
+              </a:buClr>
+              <a:buFont typeface="Symbol" panose="05050102010706020507" pitchFamily="18" charset="2"/>
+              <a:buChar char="-"/>
+            </a:pPr>
+            <a:r>
+              <a:rPr lang="en-US" sz="1600" spc="-1" dirty="0" err="1">
+                <a:solidFill>
+                  <a:srgbClr val="000000"/>
+                </a:solidFill>
+                <a:latin typeface="Century Gothic"/>
+              </a:rPr>
+              <a:t>EdgeShaper</a:t>
+            </a:r>
+            <a:endParaRPr lang="en-US" sz="1600" spc="-1" dirty="0">
+              <a:solidFill>
+                <a:srgbClr val="000000"/>
+              </a:solidFill>
+              <a:latin typeface="Century Gothic"/>
+            </a:endParaRPr>
+          </a:p>
+          <a:p>
+            <a:pPr lvl="1">
+              <a:lnSpc>
+                <a:spcPct val="100000"/>
+              </a:lnSpc>
+              <a:spcBef>
+                <a:spcPts val="400"/>
+              </a:spcBef>
+              <a:buClr>
+                <a:srgbClr val="0064C8"/>
+              </a:buClr>
+              <a:buFont typeface="Symbol" panose="05050102010706020507" pitchFamily="18" charset="2"/>
+              <a:buChar char="-"/>
+            </a:pPr>
+            <a:endParaRPr lang="en-US" sz="1600" spc="-1" dirty="0">
+              <a:solidFill>
+                <a:srgbClr val="000000"/>
+              </a:solidFill>
+              <a:latin typeface="Century Gothic"/>
+            </a:endParaRPr>
+          </a:p>
+          <a:p>
+            <a:pPr>
+              <a:lnSpc>
+                <a:spcPct val="100000"/>
+              </a:lnSpc>
+              <a:spcBef>
+                <a:spcPts val="400"/>
+              </a:spcBef>
+              <a:buClr>
+                <a:srgbClr val="0064C8"/>
+              </a:buClr>
+              <a:buFont typeface="Wingdings" panose="05000000000000000000" pitchFamily="2" charset="2"/>
+              <a:buChar char="§"/>
+            </a:pPr>
+            <a:r>
+              <a:rPr lang="en-US" sz="2000" spc="-1" dirty="0">
+                <a:solidFill>
+                  <a:srgbClr val="000000"/>
+                </a:solidFill>
+                <a:latin typeface="Century Gothic"/>
+              </a:rPr>
+              <a:t>ML models</a:t>
+            </a:r>
+          </a:p>
+          <a:p>
+            <a:pPr lvl="1">
+              <a:lnSpc>
+                <a:spcPct val="100000"/>
+              </a:lnSpc>
+              <a:spcBef>
+                <a:spcPts val="400"/>
+              </a:spcBef>
+              <a:buClr>
+                <a:srgbClr val="0064C8"/>
+              </a:buClr>
+              <a:buFont typeface="Symbol" panose="05050102010706020507" pitchFamily="18" charset="2"/>
+              <a:buChar char="-"/>
+            </a:pPr>
+            <a:r>
+              <a:rPr lang="en-US" sz="1600" spc="-1" dirty="0">
+                <a:solidFill>
+                  <a:srgbClr val="000000"/>
+                </a:solidFill>
+                <a:latin typeface="Century Gothic"/>
+              </a:rPr>
+              <a:t>Traditional ML – RF, SVM</a:t>
+            </a:r>
+          </a:p>
+          <a:p>
+            <a:pPr lvl="1">
+              <a:lnSpc>
+                <a:spcPct val="100000"/>
+              </a:lnSpc>
+              <a:spcBef>
+                <a:spcPts val="400"/>
+              </a:spcBef>
+              <a:buClr>
+                <a:srgbClr val="0064C8"/>
+              </a:buClr>
+              <a:buFont typeface="Symbol" panose="05050102010706020507" pitchFamily="18" charset="2"/>
+              <a:buChar char="-"/>
+            </a:pPr>
+            <a:r>
+              <a:rPr lang="en-US" sz="1600" spc="-1" dirty="0">
+                <a:solidFill>
+                  <a:srgbClr val="000000"/>
+                </a:solidFill>
+                <a:latin typeface="Century Gothic"/>
+              </a:rPr>
+              <a:t>NNs – DNN, GNN</a:t>
+            </a:r>
+          </a:p>
+          <a:p>
+            <a:pPr lvl="1">
+              <a:lnSpc>
+                <a:spcPct val="100000"/>
+              </a:lnSpc>
+              <a:spcBef>
+                <a:spcPts val="400"/>
+              </a:spcBef>
+              <a:spcAft>
+                <a:spcPts val="601"/>
+              </a:spcAft>
+              <a:buClr>
+                <a:srgbClr val="0064C8"/>
+              </a:buClr>
+              <a:buFont typeface="Wingdings" panose="05000000000000000000" pitchFamily="2" charset="2"/>
+              <a:buChar char="§"/>
+            </a:pPr>
+            <a:endParaRPr lang="en-US" sz="1600" spc="-1" dirty="0">
+              <a:solidFill>
+                <a:srgbClr val="000000"/>
+              </a:solidFill>
+              <a:latin typeface="Century Gothic"/>
+            </a:endParaRPr>
+          </a:p>
+          <a:p>
+            <a:pPr marL="343080" indent="-343080">
+              <a:lnSpc>
+                <a:spcPct val="100000"/>
+              </a:lnSpc>
+              <a:spcBef>
+                <a:spcPts val="400"/>
+              </a:spcBef>
+              <a:spcAft>
+                <a:spcPts val="601"/>
+              </a:spcAft>
+              <a:buClr>
+                <a:srgbClr val="0064C8"/>
+              </a:buClr>
+              <a:buFont typeface="Wingdings 2" charset="2"/>
+              <a:buChar char=""/>
+            </a:pPr>
+            <a:endParaRPr lang="en-US" sz="2000" b="1" spc="-1" dirty="0">
+              <a:solidFill>
+                <a:srgbClr val="000000"/>
+              </a:solidFill>
+              <a:latin typeface="Century Gothic"/>
+            </a:endParaRPr>
+          </a:p>
+        </p:txBody>
+      </p:sp>
+    </p:spTree>
+    <p:extLst>
+      <p:ext uri="{BB962C8B-B14F-4D97-AF65-F5344CB8AC3E}">
+        <p14:creationId xmlns:p14="http://schemas.microsoft.com/office/powerpoint/2010/main" val="1707478755"/>
+      </p:ext>
+    </p:extLst>
+  </p:cSld>
+  <p:clrMapOvr>
+    <a:masterClrMapping/>
+  </p:clrMapOvr>
+  <mc:AlternateContent xmlns:mc="http://schemas.openxmlformats.org/markup-compatibility/2006" xmlns:p14="http://schemas.microsoft.com/office/powerpoint/2010/main">
+    <mc:Choice Requires="p14">
+      <p:transition spd="med" p14:dur="700">
+        <p:fade/>
+      </p:transition>
+    </mc:Choice>
+    <mc:Fallback xmlns:p15="http://schemas.microsoft.com/office/powerpoint/2012/main" xmlns="">
+      <p:transition spd="med">
+        <p:fade/>
+      </p:transition>
+    </mc:Fallback>
+  </mc:AlternateContent>
+</p:sld>
+</file>
+
+<file path=ppt/slides/slide4.xml><?xml version="1.0" encoding="utf-8"?>
+<p:sld xmlns:a="http://schemas.openxmlformats.org/drawingml/2006/main" xmlns:r="http://schemas.openxmlformats.org/officeDocument/2006/relationships" xmlns:p="http://schemas.openxmlformats.org/presentationml/2006/main">
+  <p:cSld>
+    <p:spTree>
+      <p:nvGrpSpPr>
+        <p:cNvPr id="1" name="">
+          <a:extLst>
+            <a:ext uri="{FF2B5EF4-FFF2-40B4-BE49-F238E27FC236}">
+              <a16:creationId xmlns:a16="http://schemas.microsoft.com/office/drawing/2014/main" id="{A6515F23-0912-A838-23CE-B8F00573A2DA}"/>
+            </a:ext>
+          </a:extLst>
+        </p:cNvPr>
+        <p:cNvGrpSpPr/>
+        <p:nvPr/>
+      </p:nvGrpSpPr>
+      <p:grpSpPr>
+        <a:xfrm>
+          <a:off x="0" y="0"/>
+          <a:ext cx="0" cy="0"/>
+          <a:chOff x="0" y="0"/>
+          <a:chExt cx="0" cy="0"/>
+        </a:xfrm>
+      </p:grpSpPr>
+      <p:sp>
+        <p:nvSpPr>
+          <p:cNvPr id="163" name="PlaceHolder 1">
+            <a:extLst>
+              <a:ext uri="{FF2B5EF4-FFF2-40B4-BE49-F238E27FC236}">
+                <a16:creationId xmlns:a16="http://schemas.microsoft.com/office/drawing/2014/main" id="{57944F4B-F502-E7CC-8790-8737702BC6AC}"/>
+              </a:ext>
+            </a:extLst>
+          </p:cNvPr>
+          <p:cNvSpPr>
+            <a:spLocks noGrp="1"/>
+          </p:cNvSpPr>
+          <p:nvPr>
+            <p:ph type="title"/>
+          </p:nvPr>
+        </p:nvSpPr>
+        <p:spPr>
+          <a:xfrm>
+            <a:off x="380880" y="228600"/>
+            <a:ext cx="8380080" cy="837720"/>
+          </a:xfrm>
+          <a:prstGeom prst="rect">
+            <a:avLst/>
+          </a:prstGeom>
+          <a:noFill/>
+          <a:ln w="0">
+            <a:noFill/>
+          </a:ln>
+        </p:spPr>
+        <p:txBody>
+          <a:bodyPr numCol="1" spcCol="0" anchor="ctr">
+            <a:noAutofit/>
+          </a:bodyPr>
+          <a:lstStyle/>
+          <a:p>
+            <a:pPr>
+              <a:lnSpc>
+                <a:spcPct val="100000"/>
+              </a:lnSpc>
+              <a:buNone/>
+            </a:pPr>
+            <a:r>
+              <a:rPr lang="en-US" sz="3200" b="0" strike="noStrike" spc="-1" dirty="0">
+                <a:solidFill>
+                  <a:srgbClr val="0064C8"/>
+                </a:solidFill>
+                <a:latin typeface="Century Gothic"/>
+              </a:rPr>
+              <a:t>Exemplary answer output</a:t>
+            </a:r>
+            <a:endParaRPr lang="en-US" sz="3200" b="0" strike="noStrike" spc="-1" dirty="0">
+              <a:solidFill>
+                <a:srgbClr val="000000"/>
+              </a:solidFill>
+              <a:latin typeface="Century Gothic"/>
+            </a:endParaRPr>
+          </a:p>
+        </p:txBody>
+      </p:sp>
+      <p:sp>
+        <p:nvSpPr>
+          <p:cNvPr id="165" name="PlaceHolder 3">
+            <a:extLst>
+              <a:ext uri="{FF2B5EF4-FFF2-40B4-BE49-F238E27FC236}">
+                <a16:creationId xmlns:a16="http://schemas.microsoft.com/office/drawing/2014/main" id="{2EFBEA53-7B78-D9A1-93EF-9608A3193D27}"/>
+              </a:ext>
+            </a:extLst>
+          </p:cNvPr>
+          <p:cNvSpPr>
+            <a:spLocks noGrp="1"/>
+          </p:cNvSpPr>
+          <p:nvPr>
+            <p:ph type="sldNum"/>
+          </p:nvPr>
+        </p:nvSpPr>
+        <p:spPr>
+          <a:xfrm>
+            <a:off x="8376840" y="5692680"/>
+            <a:ext cx="384120" cy="364680"/>
+          </a:xfrm>
+          <a:prstGeom prst="rect">
+            <a:avLst/>
+          </a:prstGeom>
+          <a:noFill/>
+          <a:ln w="0">
+            <a:noFill/>
+          </a:ln>
+        </p:spPr>
+        <p:txBody>
+          <a:bodyPr anchor="ctr">
+            <a:noAutofit/>
+          </a:bodyPr>
+          <a:lstStyle/>
+          <a:p>
+            <a:pPr algn="r">
+              <a:lnSpc>
+                <a:spcPct val="100000"/>
+              </a:lnSpc>
+              <a:buNone/>
+            </a:pPr>
+            <a:fld id="{8BD7C522-1E12-40C3-B25E-5F0462E20B22}" type="slidenum">
+              <a:rPr lang="en-US" sz="1200" b="0" strike="noStrike" spc="-1">
+                <a:solidFill>
+                  <a:srgbClr val="8B8B8B"/>
+                </a:solidFill>
+                <a:latin typeface="Century Gothic"/>
+              </a:rPr>
+              <a:t>4</a:t>
+            </a:fld>
+            <a:endParaRPr lang="en-GB" sz="1200" b="0" strike="noStrike" spc="-1" dirty="0">
+              <a:latin typeface="Times New Roman"/>
+            </a:endParaRPr>
+          </a:p>
+        </p:txBody>
+      </p:sp>
+      <p:sp>
+        <p:nvSpPr>
+          <p:cNvPr id="2" name="PlaceHolder 2">
+            <a:extLst>
+              <a:ext uri="{FF2B5EF4-FFF2-40B4-BE49-F238E27FC236}">
+                <a16:creationId xmlns:a16="http://schemas.microsoft.com/office/drawing/2014/main" id="{870990D0-7AC5-46BA-6FC4-274F8E0A3ABE}"/>
+              </a:ext>
+            </a:extLst>
+          </p:cNvPr>
+          <p:cNvSpPr txBox="1">
+            <a:spLocks/>
+          </p:cNvSpPr>
+          <p:nvPr/>
+        </p:nvSpPr>
+        <p:spPr>
+          <a:xfrm>
+            <a:off x="380880" y="1371598"/>
+            <a:ext cx="3306353" cy="4559301"/>
+          </a:xfrm>
+          <a:prstGeom prst="rect">
+            <a:avLst/>
+          </a:prstGeom>
+          <a:noFill/>
+          <a:ln w="0">
+            <a:noFill/>
+          </a:ln>
+        </p:spPr>
+        <p:txBody>
+          <a:bodyPr numCol="1" spcCol="0" anchor="t">
+            <a:noAutofit/>
+          </a:bodyPr>
+          <a:lstStyle>
+            <a:lvl1pPr marL="228600" indent="-228600" algn="l" defTabSz="914400" rtl="0" eaLnBrk="1" latinLnBrk="0" hangingPunct="1">
+              <a:lnSpc>
+                <a:spcPct val="90000"/>
+              </a:lnSpc>
+              <a:spcBef>
+                <a:spcPts val="1000"/>
+              </a:spcBef>
+              <a:buFont typeface="Arial" panose="020B0604020202020204" pitchFamily="34" charset="0"/>
+              <a:buChar char="•"/>
+              <a:defRPr sz="2800" kern="1200">
+                <a:solidFill>
+                  <a:schemeClr val="tx1"/>
+                </a:solidFill>
+                <a:latin typeface="+mn-lt"/>
+                <a:ea typeface="+mn-ea"/>
+                <a:cs typeface="+mn-cs"/>
+              </a:defRPr>
+            </a:lvl1pPr>
+            <a:lvl2pPr marL="685800" indent="-228600" algn="l" defTabSz="914400" rtl="0" eaLnBrk="1" latinLnBrk="0" hangingPunct="1">
+              <a:lnSpc>
+                <a:spcPct val="90000"/>
+              </a:lnSpc>
+              <a:spcBef>
+                <a:spcPts val="500"/>
+              </a:spcBef>
+              <a:buFont typeface="Arial" panose="020B0604020202020204" pitchFamily="34" charset="0"/>
+              <a:buChar char="•"/>
+              <a:defRPr sz="2400" kern="1200">
+                <a:solidFill>
+                  <a:schemeClr val="tx1"/>
+                </a:solidFill>
+                <a:latin typeface="+mn-lt"/>
+                <a:ea typeface="+mn-ea"/>
+                <a:cs typeface="+mn-cs"/>
+              </a:defRPr>
+            </a:lvl2pPr>
+            <a:lvl3pPr marL="1143000" indent="-228600" algn="l" defTabSz="914400" rtl="0" eaLnBrk="1" latinLnBrk="0" hangingPunct="1">
+              <a:lnSpc>
+                <a:spcPct val="90000"/>
+              </a:lnSpc>
+              <a:spcBef>
+                <a:spcPts val="500"/>
+              </a:spcBef>
+              <a:buFont typeface="Arial" panose="020B0604020202020204" pitchFamily="34" charset="0"/>
+              <a:buChar char="•"/>
+              <a:defRPr sz="2000" kern="1200">
+                <a:solidFill>
+                  <a:schemeClr val="tx1"/>
+                </a:solidFill>
+                <a:latin typeface="+mn-lt"/>
+                <a:ea typeface="+mn-ea"/>
+                <a:cs typeface="+mn-cs"/>
+              </a:defRPr>
+            </a:lvl3pPr>
+            <a:lvl4pPr marL="1600200" indent="-228600" algn="l" defTabSz="914400" rtl="0" eaLnBrk="1" latinLnBrk="0" hangingPunct="1">
+              <a:lnSpc>
+                <a:spcPct val="90000"/>
+              </a:lnSpc>
+              <a:spcBef>
+                <a:spcPts val="500"/>
+              </a:spcBef>
+              <a:buFont typeface="Arial" panose="020B0604020202020204" pitchFamily="34" charset="0"/>
+              <a:buChar char="•"/>
+              <a:defRPr sz="1800" kern="1200">
+                <a:solidFill>
+                  <a:schemeClr val="tx1"/>
+                </a:solidFill>
+                <a:latin typeface="+mn-lt"/>
+                <a:ea typeface="+mn-ea"/>
+                <a:cs typeface="+mn-cs"/>
+              </a:defRPr>
+            </a:lvl4pPr>
+            <a:lvl5pPr marL="2057400" indent="-228600" algn="l" defTabSz="914400" rtl="0" eaLnBrk="1" latinLnBrk="0" hangingPunct="1">
+              <a:lnSpc>
+                <a:spcPct val="90000"/>
+              </a:lnSpc>
+              <a:spcBef>
+                <a:spcPts val="500"/>
+              </a:spcBef>
+              <a:buFont typeface="Arial" panose="020B0604020202020204" pitchFamily="34" charset="0"/>
+              <a:buChar char="•"/>
+              <a:defRPr sz="1800" kern="1200">
+                <a:solidFill>
+                  <a:schemeClr val="tx1"/>
+                </a:solidFill>
+                <a:latin typeface="+mn-lt"/>
+                <a:ea typeface="+mn-ea"/>
+                <a:cs typeface="+mn-cs"/>
+              </a:defRPr>
+            </a:lvl5pPr>
+            <a:lvl6pPr marL="2514600" indent="-228600" algn="l" defTabSz="914400" rtl="0" eaLnBrk="1" latinLnBrk="0" hangingPunct="1">
+              <a:lnSpc>
+                <a:spcPct val="90000"/>
+              </a:lnSpc>
+              <a:spcBef>
+                <a:spcPts val="500"/>
+              </a:spcBef>
+              <a:buFont typeface="Arial" panose="020B0604020202020204" pitchFamily="34" charset="0"/>
+              <a:buChar char="•"/>
+              <a:defRPr sz="1800" kern="1200">
+                <a:solidFill>
+                  <a:schemeClr val="tx1"/>
+                </a:solidFill>
+                <a:latin typeface="+mn-lt"/>
+                <a:ea typeface="+mn-ea"/>
+                <a:cs typeface="+mn-cs"/>
+              </a:defRPr>
+            </a:lvl6pPr>
+            <a:lvl7pPr marL="2971800" indent="-228600" algn="l" defTabSz="914400" rtl="0" eaLnBrk="1" latinLnBrk="0" hangingPunct="1">
+              <a:lnSpc>
+                <a:spcPct val="90000"/>
+              </a:lnSpc>
+              <a:spcBef>
+                <a:spcPts val="500"/>
+              </a:spcBef>
+              <a:buFont typeface="Arial" panose="020B0604020202020204" pitchFamily="34" charset="0"/>
+              <a:buChar char="•"/>
+              <a:defRPr sz="1800" kern="1200">
+                <a:solidFill>
+                  <a:schemeClr val="tx1"/>
+                </a:solidFill>
+                <a:latin typeface="+mn-lt"/>
+                <a:ea typeface="+mn-ea"/>
+                <a:cs typeface="+mn-cs"/>
+              </a:defRPr>
+            </a:lvl7pPr>
+            <a:lvl8pPr marL="3429000" indent="-228600" algn="l" defTabSz="914400" rtl="0" eaLnBrk="1" latinLnBrk="0" hangingPunct="1">
+              <a:lnSpc>
+                <a:spcPct val="90000"/>
+              </a:lnSpc>
+              <a:spcBef>
+                <a:spcPts val="500"/>
+              </a:spcBef>
+              <a:buFont typeface="Arial" panose="020B0604020202020204" pitchFamily="34" charset="0"/>
+              <a:buChar char="•"/>
+              <a:defRPr sz="1800" kern="1200">
+                <a:solidFill>
+                  <a:schemeClr val="tx1"/>
+                </a:solidFill>
+                <a:latin typeface="+mn-lt"/>
+                <a:ea typeface="+mn-ea"/>
+                <a:cs typeface="+mn-cs"/>
+              </a:defRPr>
+            </a:lvl8pPr>
+            <a:lvl9pPr marL="3886200" indent="-228600" algn="l" defTabSz="914400" rtl="0" eaLnBrk="1" latinLnBrk="0" hangingPunct="1">
+              <a:lnSpc>
+                <a:spcPct val="90000"/>
+              </a:lnSpc>
+              <a:spcBef>
+                <a:spcPts val="500"/>
+              </a:spcBef>
+              <a:buFont typeface="Arial" panose="020B0604020202020204" pitchFamily="34" charset="0"/>
+              <a:buChar char="•"/>
+              <a:defRPr sz="1800" kern="1200">
+                <a:solidFill>
+                  <a:schemeClr val="tx1"/>
+                </a:solidFill>
+                <a:latin typeface="+mn-lt"/>
+                <a:ea typeface="+mn-ea"/>
+                <a:cs typeface="+mn-cs"/>
+              </a:defRPr>
+            </a:lvl9pPr>
+          </a:lstStyle>
+          <a:p>
+            <a:pPr>
+              <a:lnSpc>
+                <a:spcPct val="100000"/>
+              </a:lnSpc>
+              <a:spcBef>
+                <a:spcPts val="400"/>
+              </a:spcBef>
+              <a:buClr>
+                <a:srgbClr val="0064C8"/>
+              </a:buClr>
+              <a:buFont typeface="Wingdings" panose="05000000000000000000" pitchFamily="2" charset="2"/>
+              <a:buChar char="§"/>
+            </a:pPr>
+            <a:r>
+              <a:rPr lang="en-US" sz="2000" spc="-1" dirty="0">
+                <a:solidFill>
+                  <a:srgbClr val="000000"/>
+                </a:solidFill>
+                <a:latin typeface="Century Gothic"/>
+              </a:rPr>
+              <a:t>Build an ML model for a given dataset</a:t>
+            </a:r>
+          </a:p>
+          <a:p>
+            <a:pPr>
+              <a:lnSpc>
+                <a:spcPct val="100000"/>
+              </a:lnSpc>
+              <a:spcBef>
+                <a:spcPts val="400"/>
+              </a:spcBef>
+              <a:buClr>
+                <a:srgbClr val="0064C8"/>
+              </a:buClr>
+              <a:buFont typeface="Wingdings" panose="05000000000000000000" pitchFamily="2" charset="2"/>
+              <a:buChar char="§"/>
+            </a:pPr>
+            <a:endParaRPr lang="en-US" sz="2000" spc="-1" dirty="0">
+              <a:solidFill>
+                <a:srgbClr val="000000"/>
+              </a:solidFill>
+              <a:latin typeface="Century Gothic"/>
+            </a:endParaRPr>
+          </a:p>
+          <a:p>
+            <a:pPr>
+              <a:lnSpc>
+                <a:spcPct val="100000"/>
+              </a:lnSpc>
+              <a:spcBef>
+                <a:spcPts val="400"/>
+              </a:spcBef>
+              <a:buClr>
+                <a:srgbClr val="0064C8"/>
+              </a:buClr>
+              <a:buFont typeface="Wingdings" panose="05000000000000000000" pitchFamily="2" charset="2"/>
+              <a:buChar char="§"/>
+            </a:pPr>
+            <a:r>
+              <a:rPr lang="en-US" sz="2000" spc="-1" dirty="0">
+                <a:solidFill>
+                  <a:srgbClr val="000000"/>
+                </a:solidFill>
+                <a:latin typeface="Century Gothic"/>
+              </a:rPr>
+              <a:t>Get a complete report</a:t>
+            </a:r>
+          </a:p>
+          <a:p>
+            <a:pPr lvl="1">
+              <a:lnSpc>
+                <a:spcPct val="100000"/>
+              </a:lnSpc>
+              <a:spcBef>
+                <a:spcPts val="400"/>
+              </a:spcBef>
+              <a:buClr>
+                <a:srgbClr val="0064C8"/>
+              </a:buClr>
+              <a:buFont typeface="Symbol" panose="05050102010706020507" pitchFamily="18" charset="2"/>
+              <a:buChar char="-"/>
+            </a:pPr>
+            <a:r>
+              <a:rPr lang="en-US" sz="1800" spc="-1" dirty="0">
+                <a:solidFill>
+                  <a:srgbClr val="000000"/>
+                </a:solidFill>
+                <a:latin typeface="Century Gothic"/>
+              </a:rPr>
+              <a:t>Dataset summary</a:t>
+            </a:r>
+          </a:p>
+          <a:p>
+            <a:pPr lvl="1">
+              <a:lnSpc>
+                <a:spcPct val="100000"/>
+              </a:lnSpc>
+              <a:spcBef>
+                <a:spcPts val="400"/>
+              </a:spcBef>
+              <a:buClr>
+                <a:srgbClr val="0064C8"/>
+              </a:buClr>
+              <a:buFont typeface="Symbol" panose="05050102010706020507" pitchFamily="18" charset="2"/>
+              <a:buChar char="-"/>
+            </a:pPr>
+            <a:r>
+              <a:rPr lang="en-US" sz="1800" spc="-1" dirty="0">
+                <a:solidFill>
+                  <a:srgbClr val="000000"/>
+                </a:solidFill>
+                <a:latin typeface="Century Gothic"/>
+              </a:rPr>
+              <a:t>Data split statistics</a:t>
+            </a:r>
+          </a:p>
+          <a:p>
+            <a:pPr lvl="1">
+              <a:lnSpc>
+                <a:spcPct val="100000"/>
+              </a:lnSpc>
+              <a:spcBef>
+                <a:spcPts val="400"/>
+              </a:spcBef>
+              <a:buClr>
+                <a:srgbClr val="0064C8"/>
+              </a:buClr>
+              <a:buFont typeface="Symbol" panose="05050102010706020507" pitchFamily="18" charset="2"/>
+              <a:buChar char="-"/>
+            </a:pPr>
+            <a:r>
+              <a:rPr lang="en-US" sz="1800" spc="-1" dirty="0">
+                <a:solidFill>
+                  <a:srgbClr val="000000"/>
+                </a:solidFill>
+                <a:latin typeface="Century Gothic"/>
+              </a:rPr>
+              <a:t>Model training information</a:t>
+            </a:r>
+          </a:p>
+          <a:p>
+            <a:pPr lvl="1">
+              <a:lnSpc>
+                <a:spcPct val="100000"/>
+              </a:lnSpc>
+              <a:spcBef>
+                <a:spcPts val="400"/>
+              </a:spcBef>
+              <a:buClr>
+                <a:srgbClr val="0064C8"/>
+              </a:buClr>
+              <a:buFont typeface="Symbol" panose="05050102010706020507" pitchFamily="18" charset="2"/>
+              <a:buChar char="-"/>
+            </a:pPr>
+            <a:r>
+              <a:rPr lang="en-US" sz="1800" spc="-1" dirty="0">
+                <a:solidFill>
+                  <a:srgbClr val="000000"/>
+                </a:solidFill>
+                <a:latin typeface="Century Gothic"/>
+              </a:rPr>
+              <a:t>Test set performance </a:t>
+            </a:r>
+          </a:p>
+          <a:p>
+            <a:pPr marL="343080" indent="-343080">
+              <a:lnSpc>
+                <a:spcPct val="100000"/>
+              </a:lnSpc>
+              <a:spcBef>
+                <a:spcPts val="400"/>
+              </a:spcBef>
+              <a:spcAft>
+                <a:spcPts val="601"/>
+              </a:spcAft>
+              <a:buClr>
+                <a:srgbClr val="0064C8"/>
+              </a:buClr>
+              <a:buFont typeface="Wingdings 2" charset="2"/>
+              <a:buChar char=""/>
+            </a:pPr>
+            <a:endParaRPr lang="en-US" sz="2000" b="1" spc="-1" dirty="0">
+              <a:solidFill>
+                <a:srgbClr val="000000"/>
+              </a:solidFill>
+              <a:latin typeface="Century Gothic"/>
+            </a:endParaRPr>
+          </a:p>
+        </p:txBody>
+      </p:sp>
+      <p:pic>
+        <p:nvPicPr>
+          <p:cNvPr id="6" name="Picture 5">
+            <a:extLst>
+              <a:ext uri="{FF2B5EF4-FFF2-40B4-BE49-F238E27FC236}">
+                <a16:creationId xmlns:a16="http://schemas.microsoft.com/office/drawing/2014/main" id="{D3BA145D-265C-C0B1-7C0E-2EE32552E491}"/>
+              </a:ext>
+            </a:extLst>
+          </p:cNvPr>
+          <p:cNvPicPr>
+            <a:picLocks noChangeAspect="1"/>
+          </p:cNvPicPr>
+          <p:nvPr/>
+        </p:nvPicPr>
+        <p:blipFill>
+          <a:blip r:embed="rId2"/>
+          <a:stretch>
+            <a:fillRect/>
+          </a:stretch>
+        </p:blipFill>
+        <p:spPr>
+          <a:xfrm>
+            <a:off x="3817354" y="1196437"/>
+            <a:ext cx="4943606" cy="4598149"/>
+          </a:xfrm>
+          <a:prstGeom prst="rect">
+            <a:avLst/>
+          </a:prstGeom>
+        </p:spPr>
+      </p:pic>
+    </p:spTree>
+    <p:extLst>
+      <p:ext uri="{BB962C8B-B14F-4D97-AF65-F5344CB8AC3E}">
+        <p14:creationId xmlns:p14="http://schemas.microsoft.com/office/powerpoint/2010/main" val="2375808848"/>
+      </p:ext>
+    </p:extLst>
+  </p:cSld>
+  <p:clrMapOvr>
+    <a:masterClrMapping/>
+  </p:clrMapOvr>
+  <mc:AlternateContent xmlns:mc="http://schemas.openxmlformats.org/markup-compatibility/2006" xmlns:p14="http://schemas.microsoft.com/office/powerpoint/2010/main">
+    <mc:Choice Requires="p14">
+      <p:transition spd="med" p14:dur="700">
+        <p:fade/>
+      </p:transition>
+    </mc:Choice>
+    <mc:Fallback xmlns:p15="http://schemas.microsoft.com/office/powerpoint/2012/main" xmlns="">
+      <p:transition spd="med">
+        <p:fade/>
+      </p:transition>
+    </mc:Fallback>
+  </mc:AlternateContent>
+</p:sld>
+</file>
+
+<file path=ppt/slides/slide5.xml><?xml version="1.0" encoding="utf-8"?>
+<p:sld xmlns:a="http://schemas.openxmlformats.org/drawingml/2006/main" xmlns:r="http://schemas.openxmlformats.org/officeDocument/2006/relationships" xmlns:p="http://schemas.openxmlformats.org/presentationml/2006/main">
+  <p:cSld>
+    <p:spTree>
+      <p:nvGrpSpPr>
+        <p:cNvPr id="1" name="">
+          <a:extLst>
+            <a:ext uri="{FF2B5EF4-FFF2-40B4-BE49-F238E27FC236}">
+              <a16:creationId xmlns:a16="http://schemas.microsoft.com/office/drawing/2014/main" id="{A6515F23-0912-A838-23CE-B8F00573A2DA}"/>
+            </a:ext>
+          </a:extLst>
+        </p:cNvPr>
+        <p:cNvGrpSpPr/>
+        <p:nvPr/>
+      </p:nvGrpSpPr>
+      <p:grpSpPr>
+        <a:xfrm>
+          <a:off x="0" y="0"/>
+          <a:ext cx="0" cy="0"/>
+          <a:chOff x="0" y="0"/>
+          <a:chExt cx="0" cy="0"/>
+        </a:xfrm>
+      </p:grpSpPr>
+      <p:sp>
+        <p:nvSpPr>
+          <p:cNvPr id="163" name="PlaceHolder 1">
+            <a:extLst>
+              <a:ext uri="{FF2B5EF4-FFF2-40B4-BE49-F238E27FC236}">
+                <a16:creationId xmlns:a16="http://schemas.microsoft.com/office/drawing/2014/main" id="{57944F4B-F502-E7CC-8790-8737702BC6AC}"/>
+              </a:ext>
+            </a:extLst>
+          </p:cNvPr>
+          <p:cNvSpPr>
+            <a:spLocks noGrp="1"/>
+          </p:cNvSpPr>
+          <p:nvPr>
+            <p:ph type="title"/>
+          </p:nvPr>
+        </p:nvSpPr>
+        <p:spPr>
+          <a:xfrm>
+            <a:off x="380880" y="228600"/>
+            <a:ext cx="8380080" cy="837720"/>
+          </a:xfrm>
+          <a:prstGeom prst="rect">
+            <a:avLst/>
+          </a:prstGeom>
+          <a:noFill/>
+          <a:ln w="0">
+            <a:noFill/>
+          </a:ln>
+        </p:spPr>
+        <p:txBody>
+          <a:bodyPr numCol="1" spcCol="0" anchor="ctr">
+            <a:noAutofit/>
+          </a:bodyPr>
+          <a:lstStyle/>
+          <a:p>
+            <a:pPr>
+              <a:lnSpc>
+                <a:spcPct val="100000"/>
+              </a:lnSpc>
+              <a:buNone/>
+            </a:pPr>
+            <a:r>
+              <a:rPr lang="en-US" sz="3200" b="0" strike="noStrike" spc="-1" dirty="0">
+                <a:solidFill>
+                  <a:srgbClr val="0064C8"/>
+                </a:solidFill>
+                <a:latin typeface="Century Gothic"/>
+              </a:rPr>
+              <a:t>Exemplary answer output</a:t>
+            </a:r>
+            <a:endParaRPr lang="en-US" sz="3200" b="0" strike="noStrike" spc="-1" dirty="0">
+              <a:solidFill>
+                <a:srgbClr val="000000"/>
+              </a:solidFill>
+              <a:latin typeface="Century Gothic"/>
+            </a:endParaRPr>
+          </a:p>
+        </p:txBody>
+      </p:sp>
+      <p:sp>
+        <p:nvSpPr>
+          <p:cNvPr id="165" name="PlaceHolder 3">
+            <a:extLst>
+              <a:ext uri="{FF2B5EF4-FFF2-40B4-BE49-F238E27FC236}">
+                <a16:creationId xmlns:a16="http://schemas.microsoft.com/office/drawing/2014/main" id="{2EFBEA53-7B78-D9A1-93EF-9608A3193D27}"/>
+              </a:ext>
+            </a:extLst>
+          </p:cNvPr>
+          <p:cNvSpPr>
+            <a:spLocks noGrp="1"/>
+          </p:cNvSpPr>
+          <p:nvPr>
+            <p:ph type="sldNum"/>
+          </p:nvPr>
+        </p:nvSpPr>
+        <p:spPr>
+          <a:xfrm>
+            <a:off x="8376840" y="5692680"/>
+            <a:ext cx="384120" cy="364680"/>
+          </a:xfrm>
+          <a:prstGeom prst="rect">
+            <a:avLst/>
+          </a:prstGeom>
+          <a:noFill/>
+          <a:ln w="0">
+            <a:noFill/>
+          </a:ln>
+        </p:spPr>
+        <p:txBody>
+          <a:bodyPr anchor="ctr">
+            <a:noAutofit/>
+          </a:bodyPr>
+          <a:lstStyle/>
+          <a:p>
+            <a:pPr algn="r">
+              <a:lnSpc>
+                <a:spcPct val="100000"/>
+              </a:lnSpc>
+              <a:buNone/>
+            </a:pPr>
+            <a:fld id="{8BD7C522-1E12-40C3-B25E-5F0462E20B22}" type="slidenum">
+              <a:rPr lang="en-US" sz="1200" b="0" strike="noStrike" spc="-1">
+                <a:solidFill>
+                  <a:srgbClr val="8B8B8B"/>
+                </a:solidFill>
+                <a:latin typeface="Century Gothic"/>
+              </a:rPr>
+              <a:t>5</a:t>
+            </a:fld>
+            <a:endParaRPr lang="en-GB" sz="1200" b="0" strike="noStrike" spc="-1" dirty="0">
+              <a:latin typeface="Times New Roman"/>
+            </a:endParaRPr>
+          </a:p>
+        </p:txBody>
+      </p:sp>
+      <p:pic>
+        <p:nvPicPr>
+          <p:cNvPr id="4" name="Picture 3">
+            <a:extLst>
+              <a:ext uri="{FF2B5EF4-FFF2-40B4-BE49-F238E27FC236}">
+                <a16:creationId xmlns:a16="http://schemas.microsoft.com/office/drawing/2014/main" id="{0F3D5BC1-9264-881D-CF39-9525F816570A}"/>
+              </a:ext>
+            </a:extLst>
+          </p:cNvPr>
+          <p:cNvPicPr>
+            <a:picLocks noChangeAspect="1"/>
+          </p:cNvPicPr>
+          <p:nvPr/>
+        </p:nvPicPr>
+        <p:blipFill>
+          <a:blip r:embed="rId2"/>
+          <a:stretch>
+            <a:fillRect/>
+          </a:stretch>
+        </p:blipFill>
+        <p:spPr>
+          <a:xfrm>
+            <a:off x="4059608" y="970759"/>
+            <a:ext cx="4618726" cy="4817482"/>
+          </a:xfrm>
+          <a:prstGeom prst="rect">
+            <a:avLst/>
+          </a:prstGeom>
+        </p:spPr>
+      </p:pic>
+      <p:sp>
+        <p:nvSpPr>
+          <p:cNvPr id="7" name="PlaceHolder 2">
+            <a:extLst>
+              <a:ext uri="{FF2B5EF4-FFF2-40B4-BE49-F238E27FC236}">
+                <a16:creationId xmlns:a16="http://schemas.microsoft.com/office/drawing/2014/main" id="{66DE14D4-64D4-6D1F-DD92-BC16D674C58B}"/>
+              </a:ext>
+            </a:extLst>
+          </p:cNvPr>
+          <p:cNvSpPr txBox="1">
+            <a:spLocks/>
+          </p:cNvSpPr>
+          <p:nvPr/>
+        </p:nvSpPr>
+        <p:spPr>
+          <a:xfrm>
+            <a:off x="380880" y="1371598"/>
+            <a:ext cx="3556120" cy="4559301"/>
+          </a:xfrm>
+          <a:prstGeom prst="rect">
+            <a:avLst/>
+          </a:prstGeom>
+          <a:noFill/>
+          <a:ln w="0">
+            <a:noFill/>
+          </a:ln>
+        </p:spPr>
+        <p:txBody>
+          <a:bodyPr numCol="1" spcCol="0" anchor="t">
+            <a:noAutofit/>
+          </a:bodyPr>
+          <a:lstStyle>
+            <a:lvl1pPr marL="228600" indent="-228600" algn="l" defTabSz="914400" rtl="0" eaLnBrk="1" latinLnBrk="0" hangingPunct="1">
+              <a:lnSpc>
+                <a:spcPct val="90000"/>
+              </a:lnSpc>
+              <a:spcBef>
+                <a:spcPts val="1000"/>
+              </a:spcBef>
+              <a:buFont typeface="Arial" panose="020B0604020202020204" pitchFamily="34" charset="0"/>
+              <a:buChar char="•"/>
+              <a:defRPr sz="2800" kern="1200">
+                <a:solidFill>
+                  <a:schemeClr val="tx1"/>
+                </a:solidFill>
+                <a:latin typeface="+mn-lt"/>
+                <a:ea typeface="+mn-ea"/>
+                <a:cs typeface="+mn-cs"/>
+              </a:defRPr>
+            </a:lvl1pPr>
+            <a:lvl2pPr marL="685800" indent="-228600" algn="l" defTabSz="914400" rtl="0" eaLnBrk="1" latinLnBrk="0" hangingPunct="1">
+              <a:lnSpc>
+                <a:spcPct val="90000"/>
+              </a:lnSpc>
+              <a:spcBef>
+                <a:spcPts val="500"/>
+              </a:spcBef>
+              <a:buFont typeface="Arial" panose="020B0604020202020204" pitchFamily="34" charset="0"/>
+              <a:buChar char="•"/>
+              <a:defRPr sz="2400" kern="1200">
+                <a:solidFill>
+                  <a:schemeClr val="tx1"/>
+                </a:solidFill>
+                <a:latin typeface="+mn-lt"/>
+                <a:ea typeface="+mn-ea"/>
+                <a:cs typeface="+mn-cs"/>
+              </a:defRPr>
+            </a:lvl2pPr>
+            <a:lvl3pPr marL="1143000" indent="-228600" algn="l" defTabSz="914400" rtl="0" eaLnBrk="1" latinLnBrk="0" hangingPunct="1">
+              <a:lnSpc>
+                <a:spcPct val="90000"/>
+              </a:lnSpc>
+              <a:spcBef>
+                <a:spcPts val="500"/>
+              </a:spcBef>
+              <a:buFont typeface="Arial" panose="020B0604020202020204" pitchFamily="34" charset="0"/>
+              <a:buChar char="•"/>
+              <a:defRPr sz="2000" kern="1200">
+                <a:solidFill>
+                  <a:schemeClr val="tx1"/>
+                </a:solidFill>
+                <a:latin typeface="+mn-lt"/>
+                <a:ea typeface="+mn-ea"/>
+                <a:cs typeface="+mn-cs"/>
+              </a:defRPr>
+            </a:lvl3pPr>
+            <a:lvl4pPr marL="1600200" indent="-228600" algn="l" defTabSz="914400" rtl="0" eaLnBrk="1" latinLnBrk="0" hangingPunct="1">
+              <a:lnSpc>
+                <a:spcPct val="90000"/>
+              </a:lnSpc>
+              <a:spcBef>
+                <a:spcPts val="500"/>
+              </a:spcBef>
+              <a:buFont typeface="Arial" panose="020B0604020202020204" pitchFamily="34" charset="0"/>
+              <a:buChar char="•"/>
+              <a:defRPr sz="1800" kern="1200">
+                <a:solidFill>
+                  <a:schemeClr val="tx1"/>
+                </a:solidFill>
+                <a:latin typeface="+mn-lt"/>
+                <a:ea typeface="+mn-ea"/>
+                <a:cs typeface="+mn-cs"/>
+              </a:defRPr>
+            </a:lvl4pPr>
+            <a:lvl5pPr marL="2057400" indent="-228600" algn="l" defTabSz="914400" rtl="0" eaLnBrk="1" latinLnBrk="0" hangingPunct="1">
+              <a:lnSpc>
+                <a:spcPct val="90000"/>
+              </a:lnSpc>
+              <a:spcBef>
+                <a:spcPts val="500"/>
+              </a:spcBef>
+              <a:buFont typeface="Arial" panose="020B0604020202020204" pitchFamily="34" charset="0"/>
+              <a:buChar char="•"/>
+              <a:defRPr sz="1800" kern="1200">
+                <a:solidFill>
+                  <a:schemeClr val="tx1"/>
+                </a:solidFill>
+                <a:latin typeface="+mn-lt"/>
+                <a:ea typeface="+mn-ea"/>
+                <a:cs typeface="+mn-cs"/>
+              </a:defRPr>
+            </a:lvl5pPr>
+            <a:lvl6pPr marL="2514600" indent="-228600" algn="l" defTabSz="914400" rtl="0" eaLnBrk="1" latinLnBrk="0" hangingPunct="1">
+              <a:lnSpc>
+                <a:spcPct val="90000"/>
+              </a:lnSpc>
+              <a:spcBef>
+                <a:spcPts val="500"/>
+              </a:spcBef>
+              <a:buFont typeface="Arial" panose="020B0604020202020204" pitchFamily="34" charset="0"/>
+              <a:buChar char="•"/>
+              <a:defRPr sz="1800" kern="1200">
+                <a:solidFill>
+                  <a:schemeClr val="tx1"/>
+                </a:solidFill>
+                <a:latin typeface="+mn-lt"/>
+                <a:ea typeface="+mn-ea"/>
+                <a:cs typeface="+mn-cs"/>
+              </a:defRPr>
+            </a:lvl6pPr>
+            <a:lvl7pPr marL="2971800" indent="-228600" algn="l" defTabSz="914400" rtl="0" eaLnBrk="1" latinLnBrk="0" hangingPunct="1">
+              <a:lnSpc>
+                <a:spcPct val="90000"/>
+              </a:lnSpc>
+              <a:spcBef>
+                <a:spcPts val="500"/>
+              </a:spcBef>
+              <a:buFont typeface="Arial" panose="020B0604020202020204" pitchFamily="34" charset="0"/>
+              <a:buChar char="•"/>
+              <a:defRPr sz="1800" kern="1200">
+                <a:solidFill>
+                  <a:schemeClr val="tx1"/>
+                </a:solidFill>
+                <a:latin typeface="+mn-lt"/>
+                <a:ea typeface="+mn-ea"/>
+                <a:cs typeface="+mn-cs"/>
+              </a:defRPr>
+            </a:lvl7pPr>
+            <a:lvl8pPr marL="3429000" indent="-228600" algn="l" defTabSz="914400" rtl="0" eaLnBrk="1" latinLnBrk="0" hangingPunct="1">
+              <a:lnSpc>
+                <a:spcPct val="90000"/>
+              </a:lnSpc>
+              <a:spcBef>
+                <a:spcPts val="500"/>
+              </a:spcBef>
+              <a:buFont typeface="Arial" panose="020B0604020202020204" pitchFamily="34" charset="0"/>
+              <a:buChar char="•"/>
+              <a:defRPr sz="1800" kern="1200">
+                <a:solidFill>
+                  <a:schemeClr val="tx1"/>
+                </a:solidFill>
+                <a:latin typeface="+mn-lt"/>
+                <a:ea typeface="+mn-ea"/>
+                <a:cs typeface="+mn-cs"/>
+              </a:defRPr>
+            </a:lvl8pPr>
+            <a:lvl9pPr marL="3886200" indent="-228600" algn="l" defTabSz="914400" rtl="0" eaLnBrk="1" latinLnBrk="0" hangingPunct="1">
+              <a:lnSpc>
+                <a:spcPct val="90000"/>
+              </a:lnSpc>
+              <a:spcBef>
+                <a:spcPts val="500"/>
+              </a:spcBef>
+              <a:buFont typeface="Arial" panose="020B0604020202020204" pitchFamily="34" charset="0"/>
+              <a:buChar char="•"/>
+              <a:defRPr sz="1800" kern="1200">
+                <a:solidFill>
+                  <a:schemeClr val="tx1"/>
+                </a:solidFill>
+                <a:latin typeface="+mn-lt"/>
+                <a:ea typeface="+mn-ea"/>
+                <a:cs typeface="+mn-cs"/>
+              </a:defRPr>
+            </a:lvl9pPr>
+          </a:lstStyle>
+          <a:p>
+            <a:pPr>
+              <a:lnSpc>
+                <a:spcPct val="100000"/>
+              </a:lnSpc>
+              <a:spcBef>
+                <a:spcPts val="400"/>
+              </a:spcBef>
+              <a:buClr>
+                <a:srgbClr val="0064C8"/>
+              </a:buClr>
+              <a:buFont typeface="Wingdings" panose="05000000000000000000" pitchFamily="2" charset="2"/>
+              <a:buChar char="§"/>
+            </a:pPr>
+            <a:r>
+              <a:rPr lang="en-US" sz="2000" spc="-1" dirty="0">
+                <a:solidFill>
+                  <a:srgbClr val="000000"/>
+                </a:solidFill>
+                <a:latin typeface="Century Gothic"/>
+              </a:rPr>
+              <a:t>Ask the model to explain an ML prediction n for a given compound</a:t>
+            </a:r>
+          </a:p>
+          <a:p>
+            <a:pPr>
+              <a:lnSpc>
+                <a:spcPct val="100000"/>
+              </a:lnSpc>
+              <a:spcBef>
+                <a:spcPts val="400"/>
+              </a:spcBef>
+              <a:buClr>
+                <a:srgbClr val="0064C8"/>
+              </a:buClr>
+              <a:buFont typeface="Wingdings" panose="05000000000000000000" pitchFamily="2" charset="2"/>
+              <a:buChar char="§"/>
+            </a:pPr>
+            <a:endParaRPr lang="en-US" sz="2000" spc="-1" dirty="0">
+              <a:solidFill>
+                <a:srgbClr val="000000"/>
+              </a:solidFill>
+              <a:latin typeface="Century Gothic"/>
+            </a:endParaRPr>
+          </a:p>
+          <a:p>
+            <a:pPr>
+              <a:lnSpc>
+                <a:spcPct val="100000"/>
+              </a:lnSpc>
+              <a:spcBef>
+                <a:spcPts val="400"/>
+              </a:spcBef>
+              <a:buClr>
+                <a:srgbClr val="0064C8"/>
+              </a:buClr>
+              <a:buFont typeface="Wingdings" panose="05000000000000000000" pitchFamily="2" charset="2"/>
+              <a:buChar char="§"/>
+            </a:pPr>
+            <a:r>
+              <a:rPr lang="en-US" sz="2000" spc="-1" dirty="0">
+                <a:solidFill>
+                  <a:srgbClr val="000000"/>
+                </a:solidFill>
+                <a:latin typeface="Century Gothic"/>
+              </a:rPr>
+              <a:t>Get explanation statistics</a:t>
+            </a:r>
+          </a:p>
+          <a:p>
+            <a:pPr>
+              <a:lnSpc>
+                <a:spcPct val="100000"/>
+              </a:lnSpc>
+              <a:spcBef>
+                <a:spcPts val="400"/>
+              </a:spcBef>
+              <a:buClr>
+                <a:srgbClr val="0064C8"/>
+              </a:buClr>
+              <a:buFont typeface="Wingdings" panose="05000000000000000000" pitchFamily="2" charset="2"/>
+              <a:buChar char="§"/>
+            </a:pPr>
+            <a:endParaRPr lang="en-US" sz="2000" spc="-1" dirty="0">
+              <a:solidFill>
+                <a:srgbClr val="000000"/>
+              </a:solidFill>
+              <a:latin typeface="Century Gothic"/>
+            </a:endParaRPr>
+          </a:p>
+          <a:p>
+            <a:pPr>
+              <a:lnSpc>
+                <a:spcPct val="100000"/>
+              </a:lnSpc>
+              <a:spcBef>
+                <a:spcPts val="400"/>
+              </a:spcBef>
+              <a:buClr>
+                <a:srgbClr val="0064C8"/>
+              </a:buClr>
+              <a:buFont typeface="Wingdings" panose="05000000000000000000" pitchFamily="2" charset="2"/>
+              <a:buChar char="§"/>
+            </a:pPr>
+            <a:r>
+              <a:rPr lang="en-US" sz="2000" spc="-1" dirty="0">
+                <a:solidFill>
+                  <a:srgbClr val="000000"/>
+                </a:solidFill>
+                <a:latin typeface="Century Gothic"/>
+              </a:rPr>
+              <a:t>Display explanation mapping</a:t>
+            </a:r>
+          </a:p>
+          <a:p>
+            <a:pPr>
+              <a:lnSpc>
+                <a:spcPct val="100000"/>
+              </a:lnSpc>
+              <a:spcBef>
+                <a:spcPts val="400"/>
+              </a:spcBef>
+              <a:buClr>
+                <a:srgbClr val="0064C8"/>
+              </a:buClr>
+              <a:buFont typeface="Wingdings" panose="05000000000000000000" pitchFamily="2" charset="2"/>
+              <a:buChar char="§"/>
+            </a:pPr>
+            <a:endParaRPr lang="en-US" sz="2000" spc="-1" dirty="0">
+              <a:solidFill>
+                <a:srgbClr val="000000"/>
+              </a:solidFill>
+              <a:latin typeface="Century Gothic"/>
+            </a:endParaRPr>
+          </a:p>
+          <a:p>
+            <a:pPr>
+              <a:lnSpc>
+                <a:spcPct val="100000"/>
+              </a:lnSpc>
+              <a:spcBef>
+                <a:spcPts val="400"/>
+              </a:spcBef>
+              <a:buClr>
+                <a:srgbClr val="0064C8"/>
+              </a:buClr>
+              <a:buFont typeface="Wingdings" panose="05000000000000000000" pitchFamily="2" charset="2"/>
+              <a:buChar char="§"/>
+            </a:pPr>
+            <a:r>
+              <a:rPr lang="en-US" sz="2000" spc="-1" dirty="0">
+                <a:solidFill>
+                  <a:srgbClr val="000000"/>
+                </a:solidFill>
+                <a:latin typeface="Century Gothic"/>
+              </a:rPr>
+              <a:t>Rationalize explanations (LLM)</a:t>
+            </a:r>
+          </a:p>
+          <a:p>
+            <a:pPr>
+              <a:lnSpc>
+                <a:spcPct val="100000"/>
+              </a:lnSpc>
+              <a:spcBef>
+                <a:spcPts val="400"/>
+              </a:spcBef>
+              <a:buClr>
+                <a:srgbClr val="0064C8"/>
+              </a:buClr>
+              <a:buFont typeface="Wingdings" panose="05000000000000000000" pitchFamily="2" charset="2"/>
+              <a:buChar char="§"/>
+            </a:pPr>
+            <a:endParaRPr lang="en-US" sz="2000" spc="-1" dirty="0">
+              <a:solidFill>
+                <a:srgbClr val="000000"/>
+              </a:solidFill>
+              <a:latin typeface="Century Gothic"/>
+            </a:endParaRPr>
+          </a:p>
+          <a:p>
+            <a:pPr>
+              <a:lnSpc>
+                <a:spcPct val="100000"/>
+              </a:lnSpc>
+              <a:spcBef>
+                <a:spcPts val="400"/>
+              </a:spcBef>
+              <a:buClr>
+                <a:srgbClr val="0064C8"/>
+              </a:buClr>
+              <a:buFont typeface="Wingdings" panose="05000000000000000000" pitchFamily="2" charset="2"/>
+              <a:buChar char="§"/>
+            </a:pPr>
+            <a:endParaRPr lang="en-US" sz="1800" spc="-1" dirty="0">
+              <a:solidFill>
+                <a:srgbClr val="000000"/>
+              </a:solidFill>
+              <a:latin typeface="Century Gothic"/>
+            </a:endParaRPr>
+          </a:p>
+          <a:p>
+            <a:pPr marL="343080" indent="-343080">
+              <a:lnSpc>
+                <a:spcPct val="100000"/>
+              </a:lnSpc>
+              <a:spcBef>
+                <a:spcPts val="400"/>
+              </a:spcBef>
+              <a:spcAft>
+                <a:spcPts val="601"/>
+              </a:spcAft>
+              <a:buClr>
+                <a:srgbClr val="0064C8"/>
+              </a:buClr>
+              <a:buFont typeface="Wingdings 2" charset="2"/>
+              <a:buChar char=""/>
+            </a:pPr>
+            <a:endParaRPr lang="en-US" sz="2000" b="1" spc="-1" dirty="0">
+              <a:solidFill>
+                <a:srgbClr val="000000"/>
+              </a:solidFill>
+              <a:latin typeface="Century Gothic"/>
+            </a:endParaRPr>
+          </a:p>
+        </p:txBody>
+      </p:sp>
+    </p:spTree>
+    <p:extLst>
+      <p:ext uri="{BB962C8B-B14F-4D97-AF65-F5344CB8AC3E}">
+        <p14:creationId xmlns:p14="http://schemas.microsoft.com/office/powerpoint/2010/main" val="457486825"/>
       </p:ext>
     </p:extLst>
   </p:cSld>

</xml_diff>

<commit_message>
Update AI agent slides and add figures presentation
Co-Authored-By: Claude Sonnet 4.6 <noreply@anthropic.com>
</commit_message>
<xml_diff>
--- a/slides/AI_Agent_Explainability.pptx
+++ b/slides/AI_Agent_Explainability.pptx
@@ -11,6 +11,9 @@
     <p:sldId id="299" r:id="rId5"/>
     <p:sldId id="301" r:id="rId6"/>
     <p:sldId id="300" r:id="rId7"/>
+    <p:sldId id="302" r:id="rId8"/>
+    <p:sldId id="303" r:id="rId9"/>
+    <p:sldId id="304" r:id="rId10"/>
   </p:sldIdLst>
   <p:sldSz cx="9144000" cy="6858000" type="screen4x3"/>
   <p:notesSz cx="7559675" cy="10691813"/>
@@ -120,74 +123,6 @@
 <file path=ppt/changesInfos/changesInfo1.xml><?xml version="1.0" encoding="utf-8"?>
 <pc:chgInfo xmlns:a="http://schemas.openxmlformats.org/drawingml/2006/main" xmlns:r="http://schemas.openxmlformats.org/officeDocument/2006/relationships" xmlns:ac="http://schemas.microsoft.com/office/drawing/2013/main/command" xmlns:pc="http://schemas.microsoft.com/office/powerpoint/2013/main/command">
   <pc:docChgLst>
-    <pc:chgData name="Tiago Janela" userId="ee1a79fe-c79c-4f34-9602-7f6f2f0482b3" providerId="ADAL" clId="{143C78B0-29AB-41F6-944B-45926E54C361}"/>
-    <pc:docChg chg="undo custSel addSld delSld modSld">
-      <pc:chgData name="Tiago Janela" userId="ee1a79fe-c79c-4f34-9602-7f6f2f0482b3" providerId="ADAL" clId="{143C78B0-29AB-41F6-944B-45926E54C361}" dt="2026-02-06T15:56:52.044" v="1423" actId="20577"/>
-      <pc:docMkLst>
-        <pc:docMk/>
-      </pc:docMkLst>
-      <pc:sldChg chg="del">
-        <pc:chgData name="Tiago Janela" userId="ee1a79fe-c79c-4f34-9602-7f6f2f0482b3" providerId="ADAL" clId="{143C78B0-29AB-41F6-944B-45926E54C361}" dt="2026-02-06T11:02:26.764" v="8" actId="47"/>
-        <pc:sldMkLst>
-          <pc:docMk/>
-          <pc:sldMk cId="237093369" sldId="283"/>
-        </pc:sldMkLst>
-      </pc:sldChg>
-      <pc:sldChg chg="del">
-        <pc:chgData name="Tiago Janela" userId="ee1a79fe-c79c-4f34-9602-7f6f2f0482b3" providerId="ADAL" clId="{143C78B0-29AB-41F6-944B-45926E54C361}" dt="2026-02-06T11:02:27.633" v="9" actId="47"/>
-        <pc:sldMkLst>
-          <pc:docMk/>
-          <pc:sldMk cId="1512688275" sldId="289"/>
-        </pc:sldMkLst>
-      </pc:sldChg>
-      <pc:sldChg chg="modSp mod">
-        <pc:chgData name="Tiago Janela" userId="ee1a79fe-c79c-4f34-9602-7f6f2f0482b3" providerId="ADAL" clId="{143C78B0-29AB-41F6-944B-45926E54C361}" dt="2026-02-06T15:49:13.450" v="1174" actId="20577"/>
-        <pc:sldMkLst>
-          <pc:docMk/>
-          <pc:sldMk cId="901468915" sldId="296"/>
-        </pc:sldMkLst>
-        <pc:spChg chg="mod">
-          <ac:chgData name="Tiago Janela" userId="ee1a79fe-c79c-4f34-9602-7f6f2f0482b3" providerId="ADAL" clId="{143C78B0-29AB-41F6-944B-45926E54C361}" dt="2026-02-06T15:49:13.450" v="1174" actId="20577"/>
-          <ac:spMkLst>
-            <pc:docMk/>
-            <pc:sldMk cId="901468915" sldId="296"/>
-            <ac:spMk id="164" creationId="{B6FA4745-5BA4-2D80-2549-988AFFB4E146}"/>
-          </ac:spMkLst>
-        </pc:spChg>
-      </pc:sldChg>
-      <pc:sldChg chg="modSp mod">
-        <pc:chgData name="Tiago Janela" userId="ee1a79fe-c79c-4f34-9602-7f6f2f0482b3" providerId="ADAL" clId="{143C78B0-29AB-41F6-944B-45926E54C361}" dt="2026-02-06T13:27:15.929" v="215" actId="20577"/>
-        <pc:sldMkLst>
-          <pc:docMk/>
-          <pc:sldMk cId="829672710" sldId="297"/>
-        </pc:sldMkLst>
-        <pc:spChg chg="mod">
-          <ac:chgData name="Tiago Janela" userId="ee1a79fe-c79c-4f34-9602-7f6f2f0482b3" providerId="ADAL" clId="{143C78B0-29AB-41F6-944B-45926E54C361}" dt="2026-02-06T13:27:15.929" v="215" actId="20577"/>
-          <ac:spMkLst>
-            <pc:docMk/>
-            <pc:sldMk cId="829672710" sldId="297"/>
-            <ac:spMk id="156" creationId="{00000000-0000-0000-0000-000000000000}"/>
-          </ac:spMkLst>
-        </pc:spChg>
-      </pc:sldChg>
-      <pc:sldChg chg="modSp mod">
-        <pc:chgData name="Tiago Janela" userId="ee1a79fe-c79c-4f34-9602-7f6f2f0482b3" providerId="ADAL" clId="{143C78B0-29AB-41F6-944B-45926E54C361}" dt="2026-02-06T15:55:25.972" v="1391" actId="20577"/>
-        <pc:sldMkLst>
-          <pc:docMk/>
-          <pc:sldMk cId="721732568" sldId="298"/>
-        </pc:sldMkLst>
-        <pc:spChg chg="mod">
-          <ac:chgData name="Tiago Janela" userId="ee1a79fe-c79c-4f34-9602-7f6f2f0482b3" providerId="ADAL" clId="{143C78B0-29AB-41F6-944B-45926E54C361}" dt="2026-02-06T15:55:25.972" v="1391" actId="20577"/>
-          <ac:spMkLst>
-            <pc:docMk/>
-            <pc:sldMk cId="721732568" sldId="298"/>
-            <ac:spMk id="2" creationId="{870990D0-7AC5-46BA-6FC4-274F8E0A3ABE}"/>
-          </ac:spMkLst>
-        </pc:spChg>
-      </pc:sldChg>
-    </pc:docChg>
-  </pc:docChgLst>
-  <pc:docChgLst>
     <pc:chgData name="Tiago Janela" userId="ee1a79fe-c79c-4f34-9602-7f6f2f0482b3" providerId="ADAL" clId="{67D2C233-DF3C-4C6D-9040-D7553E3BCB8A}"/>
     <pc:docChg chg="delSld modSld">
       <pc:chgData name="Tiago Janela" userId="ee1a79fe-c79c-4f34-9602-7f6f2f0482b3" providerId="ADAL" clId="{67D2C233-DF3C-4C6D-9040-D7553E3BCB8A}" dt="2026-03-16T14:03:02.466" v="54" actId="20577"/>
@@ -265,60 +200,6 @@
           <pc:docMk/>
           <pc:sldMk cId="1772121027" sldId="311"/>
         </pc:sldMkLst>
-      </pc:sldChg>
-    </pc:docChg>
-  </pc:docChgLst>
-  <pc:docChgLst>
-    <pc:chgData name="Tiago Janela" userId="ee1a79fe-c79c-4f34-9602-7f6f2f0482b3" providerId="ADAL" clId="{A1A622BE-A8AD-47B7-8802-BAC61BCE5126}"/>
-    <pc:docChg chg="undo custSel modSld">
-      <pc:chgData name="Tiago Janela" userId="ee1a79fe-c79c-4f34-9602-7f6f2f0482b3" providerId="ADAL" clId="{A1A622BE-A8AD-47B7-8802-BAC61BCE5126}" dt="2026-03-04T13:21:40.843" v="48" actId="403"/>
-      <pc:docMkLst>
-        <pc:docMk/>
-      </pc:docMkLst>
-      <pc:sldChg chg="modSp mod">
-        <pc:chgData name="Tiago Janela" userId="ee1a79fe-c79c-4f34-9602-7f6f2f0482b3" providerId="ADAL" clId="{A1A622BE-A8AD-47B7-8802-BAC61BCE5126}" dt="2026-03-04T13:20:02.161" v="40" actId="20577"/>
-        <pc:sldMkLst>
-          <pc:docMk/>
-          <pc:sldMk cId="114778141" sldId="303"/>
-        </pc:sldMkLst>
-        <pc:spChg chg="mod">
-          <ac:chgData name="Tiago Janela" userId="ee1a79fe-c79c-4f34-9602-7f6f2f0482b3" providerId="ADAL" clId="{A1A622BE-A8AD-47B7-8802-BAC61BCE5126}" dt="2026-03-04T13:20:02.161" v="40" actId="20577"/>
-          <ac:spMkLst>
-            <pc:docMk/>
-            <pc:sldMk cId="114778141" sldId="303"/>
-            <ac:spMk id="2" creationId="{3A594187-BB0C-FE87-8E79-972F5DD9EAE2}"/>
-          </ac:spMkLst>
-        </pc:spChg>
-      </pc:sldChg>
-      <pc:sldChg chg="modSp mod">
-        <pc:chgData name="Tiago Janela" userId="ee1a79fe-c79c-4f34-9602-7f6f2f0482b3" providerId="ADAL" clId="{A1A622BE-A8AD-47B7-8802-BAC61BCE5126}" dt="2026-03-04T13:21:32.291" v="47" actId="20577"/>
-        <pc:sldMkLst>
-          <pc:docMk/>
-          <pc:sldMk cId="1211845523" sldId="306"/>
-        </pc:sldMkLst>
-        <pc:spChg chg="mod">
-          <ac:chgData name="Tiago Janela" userId="ee1a79fe-c79c-4f34-9602-7f6f2f0482b3" providerId="ADAL" clId="{A1A622BE-A8AD-47B7-8802-BAC61BCE5126}" dt="2026-03-04T13:21:32.291" v="47" actId="20577"/>
-          <ac:spMkLst>
-            <pc:docMk/>
-            <pc:sldMk cId="1211845523" sldId="306"/>
-            <ac:spMk id="2" creationId="{3A594187-BB0C-FE87-8E79-972F5DD9EAE2}"/>
-          </ac:spMkLst>
-        </pc:spChg>
-      </pc:sldChg>
-      <pc:sldChg chg="modSp mod">
-        <pc:chgData name="Tiago Janela" userId="ee1a79fe-c79c-4f34-9602-7f6f2f0482b3" providerId="ADAL" clId="{A1A622BE-A8AD-47B7-8802-BAC61BCE5126}" dt="2026-03-04T13:21:40.843" v="48" actId="403"/>
-        <pc:sldMkLst>
-          <pc:docMk/>
-          <pc:sldMk cId="4258501269" sldId="307"/>
-        </pc:sldMkLst>
-        <pc:spChg chg="mod">
-          <ac:chgData name="Tiago Janela" userId="ee1a79fe-c79c-4f34-9602-7f6f2f0482b3" providerId="ADAL" clId="{A1A622BE-A8AD-47B7-8802-BAC61BCE5126}" dt="2026-03-04T13:21:40.843" v="48" actId="403"/>
-          <ac:spMkLst>
-            <pc:docMk/>
-            <pc:sldMk cId="4258501269" sldId="307"/>
-            <ac:spMk id="2" creationId="{3A594187-BB0C-FE87-8E79-972F5DD9EAE2}"/>
-          </ac:spMkLst>
-        </pc:spChg>
       </pc:sldChg>
     </pc:docChg>
   </pc:docChgLst>
@@ -470,6 +351,198 @@
       <pc:docMkLst>
         <pc:docMk/>
       </pc:docMkLst>
+    </pc:docChg>
+  </pc:docChgLst>
+  <pc:docChgLst>
+    <pc:chgData name="Tiago Janela" userId="ee1a79fe-c79c-4f34-9602-7f6f2f0482b3" providerId="ADAL" clId="{771048AC-4F55-42D8-AA6A-766F659A7530}"/>
+    <pc:docChg chg="undo custSel addSld delSld modSld sldOrd">
+      <pc:chgData name="Tiago Janela" userId="ee1a79fe-c79c-4f34-9602-7f6f2f0482b3" providerId="ADAL" clId="{771048AC-4F55-42D8-AA6A-766F659A7530}" dt="2026-02-05T14:24:21.198" v="2967" actId="20577"/>
+      <pc:docMkLst>
+        <pc:docMk/>
+      </pc:docMkLst>
+      <pc:sldChg chg="delSp modSp add mod">
+        <pc:chgData name="Tiago Janela" userId="ee1a79fe-c79c-4f34-9602-7f6f2f0482b3" providerId="ADAL" clId="{771048AC-4F55-42D8-AA6A-766F659A7530}" dt="2026-02-05T14:24:21.198" v="2967" actId="20577"/>
+        <pc:sldMkLst>
+          <pc:docMk/>
+          <pc:sldMk cId="901468915" sldId="296"/>
+        </pc:sldMkLst>
+        <pc:spChg chg="mod">
+          <ac:chgData name="Tiago Janela" userId="ee1a79fe-c79c-4f34-9602-7f6f2f0482b3" providerId="ADAL" clId="{771048AC-4F55-42D8-AA6A-766F659A7530}" dt="2026-02-05T10:58:00.218" v="1144" actId="20577"/>
+          <ac:spMkLst>
+            <pc:docMk/>
+            <pc:sldMk cId="901468915" sldId="296"/>
+            <ac:spMk id="163" creationId="{CBF44E8C-8654-71A0-B86B-E9D342AC2D4D}"/>
+          </ac:spMkLst>
+        </pc:spChg>
+        <pc:spChg chg="mod">
+          <ac:chgData name="Tiago Janela" userId="ee1a79fe-c79c-4f34-9602-7f6f2f0482b3" providerId="ADAL" clId="{771048AC-4F55-42D8-AA6A-766F659A7530}" dt="2026-02-05T14:24:21.198" v="2967" actId="20577"/>
+          <ac:spMkLst>
+            <pc:docMk/>
+            <pc:sldMk cId="901468915" sldId="296"/>
+            <ac:spMk id="164" creationId="{B6FA4745-5BA4-2D80-2549-988AFFB4E146}"/>
+          </ac:spMkLst>
+        </pc:spChg>
+      </pc:sldChg>
+      <pc:sldChg chg="modSp add mod ord">
+        <pc:chgData name="Tiago Janela" userId="ee1a79fe-c79c-4f34-9602-7f6f2f0482b3" providerId="ADAL" clId="{771048AC-4F55-42D8-AA6A-766F659A7530}" dt="2026-02-05T12:59:57.611" v="1910" actId="20577"/>
+        <pc:sldMkLst>
+          <pc:docMk/>
+          <pc:sldMk cId="829672710" sldId="297"/>
+        </pc:sldMkLst>
+        <pc:spChg chg="mod">
+          <ac:chgData name="Tiago Janela" userId="ee1a79fe-c79c-4f34-9602-7f6f2f0482b3" providerId="ADAL" clId="{771048AC-4F55-42D8-AA6A-766F659A7530}" dt="2026-02-05T12:59:57.611" v="1910" actId="20577"/>
+          <ac:spMkLst>
+            <pc:docMk/>
+            <pc:sldMk cId="829672710" sldId="297"/>
+            <ac:spMk id="156" creationId="{00000000-0000-0000-0000-000000000000}"/>
+          </ac:spMkLst>
+        </pc:spChg>
+      </pc:sldChg>
+      <pc:sldChg chg="delSp modSp add mod ord">
+        <pc:chgData name="Tiago Janela" userId="ee1a79fe-c79c-4f34-9602-7f6f2f0482b3" providerId="ADAL" clId="{771048AC-4F55-42D8-AA6A-766F659A7530}" dt="2026-02-05T14:23:46.564" v="2966" actId="20577"/>
+        <pc:sldMkLst>
+          <pc:docMk/>
+          <pc:sldMk cId="721732568" sldId="298"/>
+        </pc:sldMkLst>
+        <pc:spChg chg="mod">
+          <ac:chgData name="Tiago Janela" userId="ee1a79fe-c79c-4f34-9602-7f6f2f0482b3" providerId="ADAL" clId="{771048AC-4F55-42D8-AA6A-766F659A7530}" dt="2026-02-05T14:23:46.564" v="2966" actId="20577"/>
+          <ac:spMkLst>
+            <pc:docMk/>
+            <pc:sldMk cId="721732568" sldId="298"/>
+            <ac:spMk id="2" creationId="{870990D0-7AC5-46BA-6FC4-274F8E0A3ABE}"/>
+          </ac:spMkLst>
+        </pc:spChg>
+        <pc:spChg chg="mod">
+          <ac:chgData name="Tiago Janela" userId="ee1a79fe-c79c-4f34-9602-7f6f2f0482b3" providerId="ADAL" clId="{771048AC-4F55-42D8-AA6A-766F659A7530}" dt="2026-02-05T13:01:46.094" v="1930" actId="20577"/>
+          <ac:spMkLst>
+            <pc:docMk/>
+            <pc:sldMk cId="721732568" sldId="298"/>
+            <ac:spMk id="163" creationId="{57944F4B-F502-E7CC-8790-8737702BC6AC}"/>
+          </ac:spMkLst>
+        </pc:spChg>
+      </pc:sldChg>
+    </pc:docChg>
+  </pc:docChgLst>
+  <pc:docChgLst>
+    <pc:chgData name="Tiago Janela" userId="ee1a79fe-c79c-4f34-9602-7f6f2f0482b3" providerId="ADAL" clId="{A1A622BE-A8AD-47B7-8802-BAC61BCE5126}"/>
+    <pc:docChg chg="undo custSel modSld">
+      <pc:chgData name="Tiago Janela" userId="ee1a79fe-c79c-4f34-9602-7f6f2f0482b3" providerId="ADAL" clId="{A1A622BE-A8AD-47B7-8802-BAC61BCE5126}" dt="2026-03-04T13:21:40.843" v="48" actId="403"/>
+      <pc:docMkLst>
+        <pc:docMk/>
+      </pc:docMkLst>
+      <pc:sldChg chg="modSp mod">
+        <pc:chgData name="Tiago Janela" userId="ee1a79fe-c79c-4f34-9602-7f6f2f0482b3" providerId="ADAL" clId="{A1A622BE-A8AD-47B7-8802-BAC61BCE5126}" dt="2026-03-04T13:20:02.161" v="40" actId="20577"/>
+        <pc:sldMkLst>
+          <pc:docMk/>
+          <pc:sldMk cId="114778141" sldId="303"/>
+        </pc:sldMkLst>
+        <pc:spChg chg="mod">
+          <ac:chgData name="Tiago Janela" userId="ee1a79fe-c79c-4f34-9602-7f6f2f0482b3" providerId="ADAL" clId="{A1A622BE-A8AD-47B7-8802-BAC61BCE5126}" dt="2026-03-04T13:20:02.161" v="40" actId="20577"/>
+          <ac:spMkLst>
+            <pc:docMk/>
+            <pc:sldMk cId="114778141" sldId="303"/>
+            <ac:spMk id="2" creationId="{3A594187-BB0C-FE87-8E79-972F5DD9EAE2}"/>
+          </ac:spMkLst>
+        </pc:spChg>
+      </pc:sldChg>
+      <pc:sldChg chg="modSp mod">
+        <pc:chgData name="Tiago Janela" userId="ee1a79fe-c79c-4f34-9602-7f6f2f0482b3" providerId="ADAL" clId="{A1A622BE-A8AD-47B7-8802-BAC61BCE5126}" dt="2026-03-04T13:21:32.291" v="47" actId="20577"/>
+        <pc:sldMkLst>
+          <pc:docMk/>
+          <pc:sldMk cId="1211845523" sldId="306"/>
+        </pc:sldMkLst>
+        <pc:spChg chg="mod">
+          <ac:chgData name="Tiago Janela" userId="ee1a79fe-c79c-4f34-9602-7f6f2f0482b3" providerId="ADAL" clId="{A1A622BE-A8AD-47B7-8802-BAC61BCE5126}" dt="2026-03-04T13:21:32.291" v="47" actId="20577"/>
+          <ac:spMkLst>
+            <pc:docMk/>
+            <pc:sldMk cId="1211845523" sldId="306"/>
+            <ac:spMk id="2" creationId="{3A594187-BB0C-FE87-8E79-972F5DD9EAE2}"/>
+          </ac:spMkLst>
+        </pc:spChg>
+      </pc:sldChg>
+      <pc:sldChg chg="modSp mod">
+        <pc:chgData name="Tiago Janela" userId="ee1a79fe-c79c-4f34-9602-7f6f2f0482b3" providerId="ADAL" clId="{A1A622BE-A8AD-47B7-8802-BAC61BCE5126}" dt="2026-03-04T13:21:40.843" v="48" actId="403"/>
+        <pc:sldMkLst>
+          <pc:docMk/>
+          <pc:sldMk cId="4258501269" sldId="307"/>
+        </pc:sldMkLst>
+        <pc:spChg chg="mod">
+          <ac:chgData name="Tiago Janela" userId="ee1a79fe-c79c-4f34-9602-7f6f2f0482b3" providerId="ADAL" clId="{A1A622BE-A8AD-47B7-8802-BAC61BCE5126}" dt="2026-03-04T13:21:40.843" v="48" actId="403"/>
+          <ac:spMkLst>
+            <pc:docMk/>
+            <pc:sldMk cId="4258501269" sldId="307"/>
+            <ac:spMk id="2" creationId="{3A594187-BB0C-FE87-8E79-972F5DD9EAE2}"/>
+          </ac:spMkLst>
+        </pc:spChg>
+      </pc:sldChg>
+    </pc:docChg>
+  </pc:docChgLst>
+  <pc:docChgLst>
+    <pc:chgData name="Tiago Janela" userId="ee1a79fe-c79c-4f34-9602-7f6f2f0482b3" providerId="ADAL" clId="{143C78B0-29AB-41F6-944B-45926E54C361}"/>
+    <pc:docChg chg="undo custSel addSld delSld modSld">
+      <pc:chgData name="Tiago Janela" userId="ee1a79fe-c79c-4f34-9602-7f6f2f0482b3" providerId="ADAL" clId="{143C78B0-29AB-41F6-944B-45926E54C361}" dt="2026-02-06T15:56:52.044" v="1423" actId="20577"/>
+      <pc:docMkLst>
+        <pc:docMk/>
+      </pc:docMkLst>
+      <pc:sldChg chg="del">
+        <pc:chgData name="Tiago Janela" userId="ee1a79fe-c79c-4f34-9602-7f6f2f0482b3" providerId="ADAL" clId="{143C78B0-29AB-41F6-944B-45926E54C361}" dt="2026-02-06T11:02:26.764" v="8" actId="47"/>
+        <pc:sldMkLst>
+          <pc:docMk/>
+          <pc:sldMk cId="237093369" sldId="283"/>
+        </pc:sldMkLst>
+      </pc:sldChg>
+      <pc:sldChg chg="del">
+        <pc:chgData name="Tiago Janela" userId="ee1a79fe-c79c-4f34-9602-7f6f2f0482b3" providerId="ADAL" clId="{143C78B0-29AB-41F6-944B-45926E54C361}" dt="2026-02-06T11:02:27.633" v="9" actId="47"/>
+        <pc:sldMkLst>
+          <pc:docMk/>
+          <pc:sldMk cId="1512688275" sldId="289"/>
+        </pc:sldMkLst>
+      </pc:sldChg>
+      <pc:sldChg chg="modSp mod">
+        <pc:chgData name="Tiago Janela" userId="ee1a79fe-c79c-4f34-9602-7f6f2f0482b3" providerId="ADAL" clId="{143C78B0-29AB-41F6-944B-45926E54C361}" dt="2026-02-06T15:49:13.450" v="1174" actId="20577"/>
+        <pc:sldMkLst>
+          <pc:docMk/>
+          <pc:sldMk cId="901468915" sldId="296"/>
+        </pc:sldMkLst>
+        <pc:spChg chg="mod">
+          <ac:chgData name="Tiago Janela" userId="ee1a79fe-c79c-4f34-9602-7f6f2f0482b3" providerId="ADAL" clId="{143C78B0-29AB-41F6-944B-45926E54C361}" dt="2026-02-06T15:49:13.450" v="1174" actId="20577"/>
+          <ac:spMkLst>
+            <pc:docMk/>
+            <pc:sldMk cId="901468915" sldId="296"/>
+            <ac:spMk id="164" creationId="{B6FA4745-5BA4-2D80-2549-988AFFB4E146}"/>
+          </ac:spMkLst>
+        </pc:spChg>
+      </pc:sldChg>
+      <pc:sldChg chg="modSp mod">
+        <pc:chgData name="Tiago Janela" userId="ee1a79fe-c79c-4f34-9602-7f6f2f0482b3" providerId="ADAL" clId="{143C78B0-29AB-41F6-944B-45926E54C361}" dt="2026-02-06T13:27:15.929" v="215" actId="20577"/>
+        <pc:sldMkLst>
+          <pc:docMk/>
+          <pc:sldMk cId="829672710" sldId="297"/>
+        </pc:sldMkLst>
+        <pc:spChg chg="mod">
+          <ac:chgData name="Tiago Janela" userId="ee1a79fe-c79c-4f34-9602-7f6f2f0482b3" providerId="ADAL" clId="{143C78B0-29AB-41F6-944B-45926E54C361}" dt="2026-02-06T13:27:15.929" v="215" actId="20577"/>
+          <ac:spMkLst>
+            <pc:docMk/>
+            <pc:sldMk cId="829672710" sldId="297"/>
+            <ac:spMk id="156" creationId="{00000000-0000-0000-0000-000000000000}"/>
+          </ac:spMkLst>
+        </pc:spChg>
+      </pc:sldChg>
+      <pc:sldChg chg="modSp mod">
+        <pc:chgData name="Tiago Janela" userId="ee1a79fe-c79c-4f34-9602-7f6f2f0482b3" providerId="ADAL" clId="{143C78B0-29AB-41F6-944B-45926E54C361}" dt="2026-02-06T15:55:25.972" v="1391" actId="20577"/>
+        <pc:sldMkLst>
+          <pc:docMk/>
+          <pc:sldMk cId="721732568" sldId="298"/>
+        </pc:sldMkLst>
+        <pc:spChg chg="mod">
+          <ac:chgData name="Tiago Janela" userId="ee1a79fe-c79c-4f34-9602-7f6f2f0482b3" providerId="ADAL" clId="{143C78B0-29AB-41F6-944B-45926E54C361}" dt="2026-02-06T15:55:25.972" v="1391" actId="20577"/>
+          <ac:spMkLst>
+            <pc:docMk/>
+            <pc:sldMk cId="721732568" sldId="298"/>
+            <ac:spMk id="2" creationId="{870990D0-7AC5-46BA-6FC4-274F8E0A3ABE}"/>
+          </ac:spMkLst>
+        </pc:spChg>
+      </pc:sldChg>
     </pc:docChg>
   </pc:docChgLst>
   <pc:docChgLst>
@@ -917,76 +990,6 @@
       </pc:sldChg>
     </pc:docChg>
   </pc:docChgLst>
-  <pc:docChgLst>
-    <pc:chgData name="Tiago Janela" userId="ee1a79fe-c79c-4f34-9602-7f6f2f0482b3" providerId="ADAL" clId="{771048AC-4F55-42D8-AA6A-766F659A7530}"/>
-    <pc:docChg chg="undo custSel addSld delSld modSld sldOrd">
-      <pc:chgData name="Tiago Janela" userId="ee1a79fe-c79c-4f34-9602-7f6f2f0482b3" providerId="ADAL" clId="{771048AC-4F55-42D8-AA6A-766F659A7530}" dt="2026-02-05T14:24:21.198" v="2967" actId="20577"/>
-      <pc:docMkLst>
-        <pc:docMk/>
-      </pc:docMkLst>
-      <pc:sldChg chg="delSp modSp add mod">
-        <pc:chgData name="Tiago Janela" userId="ee1a79fe-c79c-4f34-9602-7f6f2f0482b3" providerId="ADAL" clId="{771048AC-4F55-42D8-AA6A-766F659A7530}" dt="2026-02-05T14:24:21.198" v="2967" actId="20577"/>
-        <pc:sldMkLst>
-          <pc:docMk/>
-          <pc:sldMk cId="901468915" sldId="296"/>
-        </pc:sldMkLst>
-        <pc:spChg chg="mod">
-          <ac:chgData name="Tiago Janela" userId="ee1a79fe-c79c-4f34-9602-7f6f2f0482b3" providerId="ADAL" clId="{771048AC-4F55-42D8-AA6A-766F659A7530}" dt="2026-02-05T10:58:00.218" v="1144" actId="20577"/>
-          <ac:spMkLst>
-            <pc:docMk/>
-            <pc:sldMk cId="901468915" sldId="296"/>
-            <ac:spMk id="163" creationId="{CBF44E8C-8654-71A0-B86B-E9D342AC2D4D}"/>
-          </ac:spMkLst>
-        </pc:spChg>
-        <pc:spChg chg="mod">
-          <ac:chgData name="Tiago Janela" userId="ee1a79fe-c79c-4f34-9602-7f6f2f0482b3" providerId="ADAL" clId="{771048AC-4F55-42D8-AA6A-766F659A7530}" dt="2026-02-05T14:24:21.198" v="2967" actId="20577"/>
-          <ac:spMkLst>
-            <pc:docMk/>
-            <pc:sldMk cId="901468915" sldId="296"/>
-            <ac:spMk id="164" creationId="{B6FA4745-5BA4-2D80-2549-988AFFB4E146}"/>
-          </ac:spMkLst>
-        </pc:spChg>
-      </pc:sldChg>
-      <pc:sldChg chg="modSp add mod ord">
-        <pc:chgData name="Tiago Janela" userId="ee1a79fe-c79c-4f34-9602-7f6f2f0482b3" providerId="ADAL" clId="{771048AC-4F55-42D8-AA6A-766F659A7530}" dt="2026-02-05T12:59:57.611" v="1910" actId="20577"/>
-        <pc:sldMkLst>
-          <pc:docMk/>
-          <pc:sldMk cId="829672710" sldId="297"/>
-        </pc:sldMkLst>
-        <pc:spChg chg="mod">
-          <ac:chgData name="Tiago Janela" userId="ee1a79fe-c79c-4f34-9602-7f6f2f0482b3" providerId="ADAL" clId="{771048AC-4F55-42D8-AA6A-766F659A7530}" dt="2026-02-05T12:59:57.611" v="1910" actId="20577"/>
-          <ac:spMkLst>
-            <pc:docMk/>
-            <pc:sldMk cId="829672710" sldId="297"/>
-            <ac:spMk id="156" creationId="{00000000-0000-0000-0000-000000000000}"/>
-          </ac:spMkLst>
-        </pc:spChg>
-      </pc:sldChg>
-      <pc:sldChg chg="delSp modSp add mod ord">
-        <pc:chgData name="Tiago Janela" userId="ee1a79fe-c79c-4f34-9602-7f6f2f0482b3" providerId="ADAL" clId="{771048AC-4F55-42D8-AA6A-766F659A7530}" dt="2026-02-05T14:23:46.564" v="2966" actId="20577"/>
-        <pc:sldMkLst>
-          <pc:docMk/>
-          <pc:sldMk cId="721732568" sldId="298"/>
-        </pc:sldMkLst>
-        <pc:spChg chg="mod">
-          <ac:chgData name="Tiago Janela" userId="ee1a79fe-c79c-4f34-9602-7f6f2f0482b3" providerId="ADAL" clId="{771048AC-4F55-42D8-AA6A-766F659A7530}" dt="2026-02-05T14:23:46.564" v="2966" actId="20577"/>
-          <ac:spMkLst>
-            <pc:docMk/>
-            <pc:sldMk cId="721732568" sldId="298"/>
-            <ac:spMk id="2" creationId="{870990D0-7AC5-46BA-6FC4-274F8E0A3ABE}"/>
-          </ac:spMkLst>
-        </pc:spChg>
-        <pc:spChg chg="mod">
-          <ac:chgData name="Tiago Janela" userId="ee1a79fe-c79c-4f34-9602-7f6f2f0482b3" providerId="ADAL" clId="{771048AC-4F55-42D8-AA6A-766F659A7530}" dt="2026-02-05T13:01:46.094" v="1930" actId="20577"/>
-          <ac:spMkLst>
-            <pc:docMk/>
-            <pc:sldMk cId="721732568" sldId="298"/>
-            <ac:spMk id="163" creationId="{57944F4B-F502-E7CC-8790-8737702BC6AC}"/>
-          </ac:spMkLst>
-        </pc:spChg>
-      </pc:sldChg>
-    </pc:docChg>
-  </pc:docChgLst>
 </pc:chgInfo>
 </file>
 
@@ -10019,7 +10022,7 @@
         <p:fade/>
       </p:transition>
     </mc:Choice>
-    <mc:Fallback xmlns:p15="http://schemas.microsoft.com/office/powerpoint/2012/main" xmlns="">
+    <mc:Fallback xmlns="" xmlns:p15="http://schemas.microsoft.com/office/powerpoint/2012/main">
       <p:transition spd="med">
         <p:fade/>
       </p:transition>
@@ -10411,7 +10414,7 @@
           <p:nvPr/>
         </p:nvPicPr>
         <p:blipFill>
-          <a:blip r:embed="rId2">
+          <a:blip r:embed="rId2" cstate="print">
             <a:extLst>
               <a:ext uri="{28A0092B-C50C-407E-A947-70E740481C1C}">
                 <a14:useLocalDpi xmlns:a14="http://schemas.microsoft.com/office/drawing/2010/main" val="0"/>
@@ -10448,7 +10451,7 @@
         <p:fade/>
       </p:transition>
     </mc:Choice>
-    <mc:Fallback xmlns:p15="http://schemas.microsoft.com/office/powerpoint/2012/main" xmlns="">
+    <mc:Fallback xmlns="" xmlns:p15="http://schemas.microsoft.com/office/powerpoint/2012/main">
       <p:transition spd="med">
         <p:fade/>
       </p:transition>
@@ -11011,17 +11014,14 @@
                 </a:solidFill>
                 <a:latin typeface="Century Gothic"/>
               </a:rPr>
-              <a:t>ContrastiveExplain</a:t>
+              <a:t>MolCE</a:t>
             </a:r>
-            <a:r>
-              <a:rPr lang="en-US" sz="1600" spc="-1" dirty="0">
-                <a:solidFill>
-                  <a:srgbClr val="000000"/>
-                </a:solidFill>
-                <a:latin typeface="Century Gothic"/>
-              </a:rPr>
-              <a:t>. (?)</a:t>
-            </a:r>
+            <a:endParaRPr lang="en-US" sz="1600" spc="-1" dirty="0">
+              <a:solidFill>
+                <a:srgbClr val="000000"/>
+              </a:solidFill>
+              <a:latin typeface="Century Gothic"/>
+            </a:endParaRPr>
           </a:p>
           <a:p>
             <a:pPr lvl="1">
@@ -11212,7 +11212,7 @@
         <p:fade/>
       </p:transition>
     </mc:Choice>
-    <mc:Fallback xmlns:p15="http://schemas.microsoft.com/office/powerpoint/2012/main" xmlns="">
+    <mc:Fallback xmlns="" xmlns:p15="http://schemas.microsoft.com/office/powerpoint/2012/main">
       <p:transition spd="med">
         <p:fade/>
       </p:transition>
@@ -11791,7 +11791,7 @@
         <p:fade/>
       </p:transition>
     </mc:Choice>
-    <mc:Fallback xmlns:p15="http://schemas.microsoft.com/office/powerpoint/2012/main" xmlns="">
+    <mc:Fallback xmlns="" xmlns:p15="http://schemas.microsoft.com/office/powerpoint/2012/main">
       <p:transition spd="med">
         <p:fade/>
       </p:transition>
@@ -12184,7 +12184,7 @@
                 </a:solidFill>
                 <a:latin typeface="Century Gothic"/>
               </a:rPr>
-              <a:t>Ask the model to explain an ML prediction n for a given compound</a:t>
+              <a:t>Ask the model to explain an ML prediction for a given compound with SHAP</a:t>
             </a:r>
           </a:p>
           <a:p>
@@ -12406,7 +12406,1829 @@
         <p:fade/>
       </p:transition>
     </mc:Choice>
-    <mc:Fallback xmlns:p15="http://schemas.microsoft.com/office/powerpoint/2012/main" xmlns="">
+    <mc:Fallback xmlns="" xmlns:p15="http://schemas.microsoft.com/office/powerpoint/2012/main">
+      <p:transition spd="med">
+        <p:fade/>
+      </p:transition>
+    </mc:Fallback>
+  </mc:AlternateContent>
+</p:sld>
+</file>
+
+<file path=ppt/slides/slide6.xml><?xml version="1.0" encoding="utf-8"?>
+<p:sld xmlns:a="http://schemas.openxmlformats.org/drawingml/2006/main" xmlns:r="http://schemas.openxmlformats.org/officeDocument/2006/relationships" xmlns:p="http://schemas.openxmlformats.org/presentationml/2006/main">
+  <p:cSld>
+    <p:spTree>
+      <p:nvGrpSpPr>
+        <p:cNvPr id="1" name="">
+          <a:extLst>
+            <a:ext uri="{FF2B5EF4-FFF2-40B4-BE49-F238E27FC236}">
+              <a16:creationId xmlns:a16="http://schemas.microsoft.com/office/drawing/2014/main" id="{A6515F23-0912-A838-23CE-B8F00573A2DA}"/>
+            </a:ext>
+          </a:extLst>
+        </p:cNvPr>
+        <p:cNvGrpSpPr/>
+        <p:nvPr/>
+      </p:nvGrpSpPr>
+      <p:grpSpPr>
+        <a:xfrm>
+          <a:off x="0" y="0"/>
+          <a:ext cx="0" cy="0"/>
+          <a:chOff x="0" y="0"/>
+          <a:chExt cx="0" cy="0"/>
+        </a:xfrm>
+      </p:grpSpPr>
+      <p:sp>
+        <p:nvSpPr>
+          <p:cNvPr id="163" name="PlaceHolder 1">
+            <a:extLst>
+              <a:ext uri="{FF2B5EF4-FFF2-40B4-BE49-F238E27FC236}">
+                <a16:creationId xmlns:a16="http://schemas.microsoft.com/office/drawing/2014/main" id="{57944F4B-F502-E7CC-8790-8737702BC6AC}"/>
+              </a:ext>
+            </a:extLst>
+          </p:cNvPr>
+          <p:cNvSpPr>
+            <a:spLocks noGrp="1"/>
+          </p:cNvSpPr>
+          <p:nvPr>
+            <p:ph type="title"/>
+          </p:nvPr>
+        </p:nvSpPr>
+        <p:spPr>
+          <a:xfrm>
+            <a:off x="380880" y="228600"/>
+            <a:ext cx="8380080" cy="837720"/>
+          </a:xfrm>
+          <a:prstGeom prst="rect">
+            <a:avLst/>
+          </a:prstGeom>
+          <a:noFill/>
+          <a:ln w="0">
+            <a:noFill/>
+          </a:ln>
+        </p:spPr>
+        <p:txBody>
+          <a:bodyPr numCol="1" spcCol="0" anchor="ctr">
+            <a:noAutofit/>
+          </a:bodyPr>
+          <a:lstStyle/>
+          <a:p>
+            <a:pPr>
+              <a:lnSpc>
+                <a:spcPct val="100000"/>
+              </a:lnSpc>
+              <a:buNone/>
+            </a:pPr>
+            <a:r>
+              <a:rPr lang="en-US" sz="3200" b="0" strike="noStrike" spc="-1" dirty="0">
+                <a:solidFill>
+                  <a:srgbClr val="0064C8"/>
+                </a:solidFill>
+                <a:latin typeface="Century Gothic"/>
+              </a:rPr>
+              <a:t>Exemplary answer output</a:t>
+            </a:r>
+            <a:endParaRPr lang="en-US" sz="3200" b="0" strike="noStrike" spc="-1" dirty="0">
+              <a:solidFill>
+                <a:srgbClr val="000000"/>
+              </a:solidFill>
+              <a:latin typeface="Century Gothic"/>
+            </a:endParaRPr>
+          </a:p>
+        </p:txBody>
+      </p:sp>
+      <p:sp>
+        <p:nvSpPr>
+          <p:cNvPr id="165" name="PlaceHolder 3">
+            <a:extLst>
+              <a:ext uri="{FF2B5EF4-FFF2-40B4-BE49-F238E27FC236}">
+                <a16:creationId xmlns:a16="http://schemas.microsoft.com/office/drawing/2014/main" id="{2EFBEA53-7B78-D9A1-93EF-9608A3193D27}"/>
+              </a:ext>
+            </a:extLst>
+          </p:cNvPr>
+          <p:cNvSpPr>
+            <a:spLocks noGrp="1"/>
+          </p:cNvSpPr>
+          <p:nvPr>
+            <p:ph type="sldNum"/>
+          </p:nvPr>
+        </p:nvSpPr>
+        <p:spPr>
+          <a:xfrm>
+            <a:off x="8376840" y="5692680"/>
+            <a:ext cx="384120" cy="364680"/>
+          </a:xfrm>
+          <a:prstGeom prst="rect">
+            <a:avLst/>
+          </a:prstGeom>
+          <a:noFill/>
+          <a:ln w="0">
+            <a:noFill/>
+          </a:ln>
+        </p:spPr>
+        <p:txBody>
+          <a:bodyPr anchor="ctr">
+            <a:noAutofit/>
+          </a:bodyPr>
+          <a:lstStyle/>
+          <a:p>
+            <a:pPr algn="r">
+              <a:lnSpc>
+                <a:spcPct val="100000"/>
+              </a:lnSpc>
+              <a:buNone/>
+            </a:pPr>
+            <a:fld id="{8BD7C522-1E12-40C3-B25E-5F0462E20B22}" type="slidenum">
+              <a:rPr lang="en-US" sz="1200" b="0" strike="noStrike" spc="-1">
+                <a:solidFill>
+                  <a:srgbClr val="8B8B8B"/>
+                </a:solidFill>
+                <a:latin typeface="Century Gothic"/>
+              </a:rPr>
+              <a:t>6</a:t>
+            </a:fld>
+            <a:endParaRPr lang="en-GB" sz="1200" b="0" strike="noStrike" spc="-1" dirty="0">
+              <a:latin typeface="Times New Roman"/>
+            </a:endParaRPr>
+          </a:p>
+        </p:txBody>
+      </p:sp>
+      <p:sp>
+        <p:nvSpPr>
+          <p:cNvPr id="7" name="PlaceHolder 2">
+            <a:extLst>
+              <a:ext uri="{FF2B5EF4-FFF2-40B4-BE49-F238E27FC236}">
+                <a16:creationId xmlns:a16="http://schemas.microsoft.com/office/drawing/2014/main" id="{66DE14D4-64D4-6D1F-DD92-BC16D674C58B}"/>
+              </a:ext>
+            </a:extLst>
+          </p:cNvPr>
+          <p:cNvSpPr txBox="1">
+            <a:spLocks/>
+          </p:cNvSpPr>
+          <p:nvPr/>
+        </p:nvSpPr>
+        <p:spPr>
+          <a:xfrm>
+            <a:off x="380880" y="1371598"/>
+            <a:ext cx="3556120" cy="4559301"/>
+          </a:xfrm>
+          <a:prstGeom prst="rect">
+            <a:avLst/>
+          </a:prstGeom>
+          <a:noFill/>
+          <a:ln w="0">
+            <a:noFill/>
+          </a:ln>
+        </p:spPr>
+        <p:txBody>
+          <a:bodyPr numCol="1" spcCol="0" anchor="t">
+            <a:noAutofit/>
+          </a:bodyPr>
+          <a:lstStyle>
+            <a:lvl1pPr marL="228600" indent="-228600" algn="l" defTabSz="914400" rtl="0" eaLnBrk="1" latinLnBrk="0" hangingPunct="1">
+              <a:lnSpc>
+                <a:spcPct val="90000"/>
+              </a:lnSpc>
+              <a:spcBef>
+                <a:spcPts val="1000"/>
+              </a:spcBef>
+              <a:buFont typeface="Arial" panose="020B0604020202020204" pitchFamily="34" charset="0"/>
+              <a:buChar char="•"/>
+              <a:defRPr sz="2800" kern="1200">
+                <a:solidFill>
+                  <a:schemeClr val="tx1"/>
+                </a:solidFill>
+                <a:latin typeface="+mn-lt"/>
+                <a:ea typeface="+mn-ea"/>
+                <a:cs typeface="+mn-cs"/>
+              </a:defRPr>
+            </a:lvl1pPr>
+            <a:lvl2pPr marL="685800" indent="-228600" algn="l" defTabSz="914400" rtl="0" eaLnBrk="1" latinLnBrk="0" hangingPunct="1">
+              <a:lnSpc>
+                <a:spcPct val="90000"/>
+              </a:lnSpc>
+              <a:spcBef>
+                <a:spcPts val="500"/>
+              </a:spcBef>
+              <a:buFont typeface="Arial" panose="020B0604020202020204" pitchFamily="34" charset="0"/>
+              <a:buChar char="•"/>
+              <a:defRPr sz="2400" kern="1200">
+                <a:solidFill>
+                  <a:schemeClr val="tx1"/>
+                </a:solidFill>
+                <a:latin typeface="+mn-lt"/>
+                <a:ea typeface="+mn-ea"/>
+                <a:cs typeface="+mn-cs"/>
+              </a:defRPr>
+            </a:lvl2pPr>
+            <a:lvl3pPr marL="1143000" indent="-228600" algn="l" defTabSz="914400" rtl="0" eaLnBrk="1" latinLnBrk="0" hangingPunct="1">
+              <a:lnSpc>
+                <a:spcPct val="90000"/>
+              </a:lnSpc>
+              <a:spcBef>
+                <a:spcPts val="500"/>
+              </a:spcBef>
+              <a:buFont typeface="Arial" panose="020B0604020202020204" pitchFamily="34" charset="0"/>
+              <a:buChar char="•"/>
+              <a:defRPr sz="2000" kern="1200">
+                <a:solidFill>
+                  <a:schemeClr val="tx1"/>
+                </a:solidFill>
+                <a:latin typeface="+mn-lt"/>
+                <a:ea typeface="+mn-ea"/>
+                <a:cs typeface="+mn-cs"/>
+              </a:defRPr>
+            </a:lvl3pPr>
+            <a:lvl4pPr marL="1600200" indent="-228600" algn="l" defTabSz="914400" rtl="0" eaLnBrk="1" latinLnBrk="0" hangingPunct="1">
+              <a:lnSpc>
+                <a:spcPct val="90000"/>
+              </a:lnSpc>
+              <a:spcBef>
+                <a:spcPts val="500"/>
+              </a:spcBef>
+              <a:buFont typeface="Arial" panose="020B0604020202020204" pitchFamily="34" charset="0"/>
+              <a:buChar char="•"/>
+              <a:defRPr sz="1800" kern="1200">
+                <a:solidFill>
+                  <a:schemeClr val="tx1"/>
+                </a:solidFill>
+                <a:latin typeface="+mn-lt"/>
+                <a:ea typeface="+mn-ea"/>
+                <a:cs typeface="+mn-cs"/>
+              </a:defRPr>
+            </a:lvl4pPr>
+            <a:lvl5pPr marL="2057400" indent="-228600" algn="l" defTabSz="914400" rtl="0" eaLnBrk="1" latinLnBrk="0" hangingPunct="1">
+              <a:lnSpc>
+                <a:spcPct val="90000"/>
+              </a:lnSpc>
+              <a:spcBef>
+                <a:spcPts val="500"/>
+              </a:spcBef>
+              <a:buFont typeface="Arial" panose="020B0604020202020204" pitchFamily="34" charset="0"/>
+              <a:buChar char="•"/>
+              <a:defRPr sz="1800" kern="1200">
+                <a:solidFill>
+                  <a:schemeClr val="tx1"/>
+                </a:solidFill>
+                <a:latin typeface="+mn-lt"/>
+                <a:ea typeface="+mn-ea"/>
+                <a:cs typeface="+mn-cs"/>
+              </a:defRPr>
+            </a:lvl5pPr>
+            <a:lvl6pPr marL="2514600" indent="-228600" algn="l" defTabSz="914400" rtl="0" eaLnBrk="1" latinLnBrk="0" hangingPunct="1">
+              <a:lnSpc>
+                <a:spcPct val="90000"/>
+              </a:lnSpc>
+              <a:spcBef>
+                <a:spcPts val="500"/>
+              </a:spcBef>
+              <a:buFont typeface="Arial" panose="020B0604020202020204" pitchFamily="34" charset="0"/>
+              <a:buChar char="•"/>
+              <a:defRPr sz="1800" kern="1200">
+                <a:solidFill>
+                  <a:schemeClr val="tx1"/>
+                </a:solidFill>
+                <a:latin typeface="+mn-lt"/>
+                <a:ea typeface="+mn-ea"/>
+                <a:cs typeface="+mn-cs"/>
+              </a:defRPr>
+            </a:lvl6pPr>
+            <a:lvl7pPr marL="2971800" indent="-228600" algn="l" defTabSz="914400" rtl="0" eaLnBrk="1" latinLnBrk="0" hangingPunct="1">
+              <a:lnSpc>
+                <a:spcPct val="90000"/>
+              </a:lnSpc>
+              <a:spcBef>
+                <a:spcPts val="500"/>
+              </a:spcBef>
+              <a:buFont typeface="Arial" panose="020B0604020202020204" pitchFamily="34" charset="0"/>
+              <a:buChar char="•"/>
+              <a:defRPr sz="1800" kern="1200">
+                <a:solidFill>
+                  <a:schemeClr val="tx1"/>
+                </a:solidFill>
+                <a:latin typeface="+mn-lt"/>
+                <a:ea typeface="+mn-ea"/>
+                <a:cs typeface="+mn-cs"/>
+              </a:defRPr>
+            </a:lvl7pPr>
+            <a:lvl8pPr marL="3429000" indent="-228600" algn="l" defTabSz="914400" rtl="0" eaLnBrk="1" latinLnBrk="0" hangingPunct="1">
+              <a:lnSpc>
+                <a:spcPct val="90000"/>
+              </a:lnSpc>
+              <a:spcBef>
+                <a:spcPts val="500"/>
+              </a:spcBef>
+              <a:buFont typeface="Arial" panose="020B0604020202020204" pitchFamily="34" charset="0"/>
+              <a:buChar char="•"/>
+              <a:defRPr sz="1800" kern="1200">
+                <a:solidFill>
+                  <a:schemeClr val="tx1"/>
+                </a:solidFill>
+                <a:latin typeface="+mn-lt"/>
+                <a:ea typeface="+mn-ea"/>
+                <a:cs typeface="+mn-cs"/>
+              </a:defRPr>
+            </a:lvl8pPr>
+            <a:lvl9pPr marL="3886200" indent="-228600" algn="l" defTabSz="914400" rtl="0" eaLnBrk="1" latinLnBrk="0" hangingPunct="1">
+              <a:lnSpc>
+                <a:spcPct val="90000"/>
+              </a:lnSpc>
+              <a:spcBef>
+                <a:spcPts val="500"/>
+              </a:spcBef>
+              <a:buFont typeface="Arial" panose="020B0604020202020204" pitchFamily="34" charset="0"/>
+              <a:buChar char="•"/>
+              <a:defRPr sz="1800" kern="1200">
+                <a:solidFill>
+                  <a:schemeClr val="tx1"/>
+                </a:solidFill>
+                <a:latin typeface="+mn-lt"/>
+                <a:ea typeface="+mn-ea"/>
+                <a:cs typeface="+mn-cs"/>
+              </a:defRPr>
+            </a:lvl9pPr>
+          </a:lstStyle>
+          <a:p>
+            <a:pPr>
+              <a:lnSpc>
+                <a:spcPct val="100000"/>
+              </a:lnSpc>
+              <a:spcBef>
+                <a:spcPts val="400"/>
+              </a:spcBef>
+              <a:buClr>
+                <a:srgbClr val="0064C8"/>
+              </a:buClr>
+              <a:buFont typeface="Wingdings" panose="05000000000000000000" pitchFamily="2" charset="2"/>
+              <a:buChar char="§"/>
+            </a:pPr>
+            <a:r>
+              <a:rPr lang="en-US" sz="2000" spc="-1" dirty="0">
+                <a:solidFill>
+                  <a:srgbClr val="000000"/>
+                </a:solidFill>
+                <a:latin typeface="Century Gothic"/>
+              </a:rPr>
+              <a:t>Ask the model to explain an ML prediction n for a given compound with </a:t>
+            </a:r>
+            <a:r>
+              <a:rPr lang="en-US" sz="2000" spc="-1" dirty="0" err="1">
+                <a:solidFill>
+                  <a:srgbClr val="000000"/>
+                </a:solidFill>
+                <a:latin typeface="Century Gothic"/>
+              </a:rPr>
+              <a:t>MolAnchor</a:t>
+            </a:r>
+            <a:endParaRPr lang="en-US" sz="2000" spc="-1" dirty="0">
+              <a:solidFill>
+                <a:srgbClr val="000000"/>
+              </a:solidFill>
+              <a:latin typeface="Century Gothic"/>
+            </a:endParaRPr>
+          </a:p>
+          <a:p>
+            <a:pPr>
+              <a:lnSpc>
+                <a:spcPct val="100000"/>
+              </a:lnSpc>
+              <a:spcBef>
+                <a:spcPts val="400"/>
+              </a:spcBef>
+              <a:buClr>
+                <a:srgbClr val="0064C8"/>
+              </a:buClr>
+              <a:buFont typeface="Wingdings" panose="05000000000000000000" pitchFamily="2" charset="2"/>
+              <a:buChar char="§"/>
+            </a:pPr>
+            <a:endParaRPr lang="en-US" sz="2000" spc="-1" dirty="0">
+              <a:solidFill>
+                <a:srgbClr val="000000"/>
+              </a:solidFill>
+              <a:latin typeface="Century Gothic"/>
+            </a:endParaRPr>
+          </a:p>
+          <a:p>
+            <a:pPr>
+              <a:lnSpc>
+                <a:spcPct val="100000"/>
+              </a:lnSpc>
+              <a:spcBef>
+                <a:spcPts val="400"/>
+              </a:spcBef>
+              <a:buClr>
+                <a:srgbClr val="0064C8"/>
+              </a:buClr>
+              <a:buFont typeface="Wingdings" panose="05000000000000000000" pitchFamily="2" charset="2"/>
+              <a:buChar char="§"/>
+            </a:pPr>
+            <a:r>
+              <a:rPr lang="en-US" sz="2000" spc="-1" dirty="0">
+                <a:solidFill>
+                  <a:srgbClr val="000000"/>
+                </a:solidFill>
+                <a:latin typeface="Century Gothic"/>
+              </a:rPr>
+              <a:t>Get explanation statistics</a:t>
+            </a:r>
+          </a:p>
+          <a:p>
+            <a:pPr>
+              <a:lnSpc>
+                <a:spcPct val="100000"/>
+              </a:lnSpc>
+              <a:spcBef>
+                <a:spcPts val="400"/>
+              </a:spcBef>
+              <a:buClr>
+                <a:srgbClr val="0064C8"/>
+              </a:buClr>
+              <a:buFont typeface="Wingdings" panose="05000000000000000000" pitchFamily="2" charset="2"/>
+              <a:buChar char="§"/>
+            </a:pPr>
+            <a:endParaRPr lang="en-US" sz="2000" spc="-1" dirty="0">
+              <a:solidFill>
+                <a:srgbClr val="000000"/>
+              </a:solidFill>
+              <a:latin typeface="Century Gothic"/>
+            </a:endParaRPr>
+          </a:p>
+          <a:p>
+            <a:pPr>
+              <a:lnSpc>
+                <a:spcPct val="100000"/>
+              </a:lnSpc>
+              <a:spcBef>
+                <a:spcPts val="400"/>
+              </a:spcBef>
+              <a:buClr>
+                <a:srgbClr val="0064C8"/>
+              </a:buClr>
+              <a:buFont typeface="Wingdings" panose="05000000000000000000" pitchFamily="2" charset="2"/>
+              <a:buChar char="§"/>
+            </a:pPr>
+            <a:r>
+              <a:rPr lang="en-US" sz="2000" spc="-1" dirty="0">
+                <a:solidFill>
+                  <a:srgbClr val="000000"/>
+                </a:solidFill>
+                <a:latin typeface="Century Gothic"/>
+              </a:rPr>
+              <a:t>Display explanation mapping</a:t>
+            </a:r>
+          </a:p>
+          <a:p>
+            <a:pPr>
+              <a:lnSpc>
+                <a:spcPct val="100000"/>
+              </a:lnSpc>
+              <a:spcBef>
+                <a:spcPts val="400"/>
+              </a:spcBef>
+              <a:buClr>
+                <a:srgbClr val="0064C8"/>
+              </a:buClr>
+              <a:buFont typeface="Wingdings" panose="05000000000000000000" pitchFamily="2" charset="2"/>
+              <a:buChar char="§"/>
+            </a:pPr>
+            <a:endParaRPr lang="en-US" sz="2000" spc="-1" dirty="0">
+              <a:solidFill>
+                <a:srgbClr val="000000"/>
+              </a:solidFill>
+              <a:latin typeface="Century Gothic"/>
+            </a:endParaRPr>
+          </a:p>
+          <a:p>
+            <a:pPr>
+              <a:lnSpc>
+                <a:spcPct val="100000"/>
+              </a:lnSpc>
+              <a:spcBef>
+                <a:spcPts val="400"/>
+              </a:spcBef>
+              <a:buClr>
+                <a:srgbClr val="0064C8"/>
+              </a:buClr>
+              <a:buFont typeface="Wingdings" panose="05000000000000000000" pitchFamily="2" charset="2"/>
+              <a:buChar char="§"/>
+            </a:pPr>
+            <a:r>
+              <a:rPr lang="en-US" sz="2000" spc="-1" dirty="0">
+                <a:solidFill>
+                  <a:srgbClr val="000000"/>
+                </a:solidFill>
+                <a:latin typeface="Century Gothic"/>
+              </a:rPr>
+              <a:t>Rationalize explanations (LLM)</a:t>
+            </a:r>
+          </a:p>
+          <a:p>
+            <a:pPr>
+              <a:lnSpc>
+                <a:spcPct val="100000"/>
+              </a:lnSpc>
+              <a:spcBef>
+                <a:spcPts val="400"/>
+              </a:spcBef>
+              <a:buClr>
+                <a:srgbClr val="0064C8"/>
+              </a:buClr>
+              <a:buFont typeface="Wingdings" panose="05000000000000000000" pitchFamily="2" charset="2"/>
+              <a:buChar char="§"/>
+            </a:pPr>
+            <a:endParaRPr lang="en-US" sz="2000" spc="-1" dirty="0">
+              <a:solidFill>
+                <a:srgbClr val="000000"/>
+              </a:solidFill>
+              <a:latin typeface="Century Gothic"/>
+            </a:endParaRPr>
+          </a:p>
+          <a:p>
+            <a:pPr>
+              <a:lnSpc>
+                <a:spcPct val="100000"/>
+              </a:lnSpc>
+              <a:spcBef>
+                <a:spcPts val="400"/>
+              </a:spcBef>
+              <a:buClr>
+                <a:srgbClr val="0064C8"/>
+              </a:buClr>
+              <a:buFont typeface="Wingdings" panose="05000000000000000000" pitchFamily="2" charset="2"/>
+              <a:buChar char="§"/>
+            </a:pPr>
+            <a:endParaRPr lang="en-US" sz="1800" spc="-1" dirty="0">
+              <a:solidFill>
+                <a:srgbClr val="000000"/>
+              </a:solidFill>
+              <a:latin typeface="Century Gothic"/>
+            </a:endParaRPr>
+          </a:p>
+          <a:p>
+            <a:pPr marL="343080" indent="-343080">
+              <a:lnSpc>
+                <a:spcPct val="100000"/>
+              </a:lnSpc>
+              <a:spcBef>
+                <a:spcPts val="400"/>
+              </a:spcBef>
+              <a:spcAft>
+                <a:spcPts val="601"/>
+              </a:spcAft>
+              <a:buClr>
+                <a:srgbClr val="0064C8"/>
+              </a:buClr>
+              <a:buFont typeface="Wingdings 2" charset="2"/>
+              <a:buChar char=""/>
+            </a:pPr>
+            <a:endParaRPr lang="en-US" sz="2000" b="1" spc="-1" dirty="0">
+              <a:solidFill>
+                <a:srgbClr val="000000"/>
+              </a:solidFill>
+              <a:latin typeface="Century Gothic"/>
+            </a:endParaRPr>
+          </a:p>
+        </p:txBody>
+      </p:sp>
+      <p:pic>
+        <p:nvPicPr>
+          <p:cNvPr id="3" name="Picture 2">
+            <a:extLst>
+              <a:ext uri="{FF2B5EF4-FFF2-40B4-BE49-F238E27FC236}">
+                <a16:creationId xmlns:a16="http://schemas.microsoft.com/office/drawing/2014/main" id="{CABC6A26-9CF7-7B03-D767-F8B5CB557E1B}"/>
+              </a:ext>
+            </a:extLst>
+          </p:cNvPr>
+          <p:cNvPicPr>
+            <a:picLocks noChangeAspect="1"/>
+          </p:cNvPicPr>
+          <p:nvPr/>
+        </p:nvPicPr>
+        <p:blipFill>
+          <a:blip r:embed="rId2"/>
+          <a:srcRect l="-3811" t="-1266" r="-2705" b="-5248"/>
+          <a:stretch/>
+        </p:blipFill>
+        <p:spPr>
+          <a:xfrm>
+            <a:off x="4313911" y="1075604"/>
+            <a:ext cx="4307305" cy="4025986"/>
+          </a:xfrm>
+          <a:prstGeom prst="rect">
+            <a:avLst/>
+          </a:prstGeom>
+        </p:spPr>
+      </p:pic>
+      <p:pic>
+        <p:nvPicPr>
+          <p:cNvPr id="6" name="Picture 5">
+            <a:extLst>
+              <a:ext uri="{FF2B5EF4-FFF2-40B4-BE49-F238E27FC236}">
+                <a16:creationId xmlns:a16="http://schemas.microsoft.com/office/drawing/2014/main" id="{C0F84ACB-0B25-83EE-C843-9841A30F787F}"/>
+              </a:ext>
+            </a:extLst>
+          </p:cNvPr>
+          <p:cNvPicPr>
+            <a:picLocks noChangeAspect="1"/>
+          </p:cNvPicPr>
+          <p:nvPr/>
+        </p:nvPicPr>
+        <p:blipFill>
+          <a:blip r:embed="rId3"/>
+          <a:stretch>
+            <a:fillRect/>
+          </a:stretch>
+        </p:blipFill>
+        <p:spPr>
+          <a:xfrm>
+            <a:off x="4464050" y="4862478"/>
+            <a:ext cx="4051300" cy="1083662"/>
+          </a:xfrm>
+          <a:prstGeom prst="rect">
+            <a:avLst/>
+          </a:prstGeom>
+        </p:spPr>
+      </p:pic>
+    </p:spTree>
+    <p:extLst>
+      <p:ext uri="{BB962C8B-B14F-4D97-AF65-F5344CB8AC3E}">
+        <p14:creationId xmlns:p14="http://schemas.microsoft.com/office/powerpoint/2010/main" val="4267688927"/>
+      </p:ext>
+    </p:extLst>
+  </p:cSld>
+  <p:clrMapOvr>
+    <a:masterClrMapping/>
+  </p:clrMapOvr>
+  <mc:AlternateContent xmlns:mc="http://schemas.openxmlformats.org/markup-compatibility/2006">
+    <mc:Choice xmlns:p14="http://schemas.microsoft.com/office/powerpoint/2010/main" Requires="p14">
+      <p:transition spd="med" p14:dur="700">
+        <p:fade/>
+      </p:transition>
+    </mc:Choice>
+    <mc:Fallback>
+      <p:transition spd="med">
+        <p:fade/>
+      </p:transition>
+    </mc:Fallback>
+  </mc:AlternateContent>
+</p:sld>
+</file>
+
+<file path=ppt/slides/slide7.xml><?xml version="1.0" encoding="utf-8"?>
+<p:sld xmlns:a="http://schemas.openxmlformats.org/drawingml/2006/main" xmlns:r="http://schemas.openxmlformats.org/officeDocument/2006/relationships" xmlns:p="http://schemas.openxmlformats.org/presentationml/2006/main">
+  <p:cSld>
+    <p:spTree>
+      <p:nvGrpSpPr>
+        <p:cNvPr id="1" name="">
+          <a:extLst>
+            <a:ext uri="{FF2B5EF4-FFF2-40B4-BE49-F238E27FC236}">
+              <a16:creationId xmlns:a16="http://schemas.microsoft.com/office/drawing/2014/main" id="{A6515F23-0912-A838-23CE-B8F00573A2DA}"/>
+            </a:ext>
+          </a:extLst>
+        </p:cNvPr>
+        <p:cNvGrpSpPr/>
+        <p:nvPr/>
+      </p:nvGrpSpPr>
+      <p:grpSpPr>
+        <a:xfrm>
+          <a:off x="0" y="0"/>
+          <a:ext cx="0" cy="0"/>
+          <a:chOff x="0" y="0"/>
+          <a:chExt cx="0" cy="0"/>
+        </a:xfrm>
+      </p:grpSpPr>
+      <p:sp>
+        <p:nvSpPr>
+          <p:cNvPr id="163" name="PlaceHolder 1">
+            <a:extLst>
+              <a:ext uri="{FF2B5EF4-FFF2-40B4-BE49-F238E27FC236}">
+                <a16:creationId xmlns:a16="http://schemas.microsoft.com/office/drawing/2014/main" id="{57944F4B-F502-E7CC-8790-8737702BC6AC}"/>
+              </a:ext>
+            </a:extLst>
+          </p:cNvPr>
+          <p:cNvSpPr>
+            <a:spLocks noGrp="1"/>
+          </p:cNvSpPr>
+          <p:nvPr>
+            <p:ph type="title"/>
+          </p:nvPr>
+        </p:nvSpPr>
+        <p:spPr>
+          <a:xfrm>
+            <a:off x="380880" y="228600"/>
+            <a:ext cx="8380080" cy="837720"/>
+          </a:xfrm>
+          <a:prstGeom prst="rect">
+            <a:avLst/>
+          </a:prstGeom>
+          <a:noFill/>
+          <a:ln w="0">
+            <a:noFill/>
+          </a:ln>
+        </p:spPr>
+        <p:txBody>
+          <a:bodyPr numCol="1" spcCol="0" anchor="ctr">
+            <a:noAutofit/>
+          </a:bodyPr>
+          <a:lstStyle/>
+          <a:p>
+            <a:pPr>
+              <a:lnSpc>
+                <a:spcPct val="100000"/>
+              </a:lnSpc>
+              <a:buNone/>
+            </a:pPr>
+            <a:r>
+              <a:rPr lang="en-US" sz="3200" b="0" strike="noStrike" spc="-1" dirty="0">
+                <a:solidFill>
+                  <a:srgbClr val="0064C8"/>
+                </a:solidFill>
+                <a:latin typeface="Century Gothic"/>
+              </a:rPr>
+              <a:t>To do list</a:t>
+            </a:r>
+            <a:endParaRPr lang="en-US" sz="3200" b="0" strike="noStrike" spc="-1" dirty="0">
+              <a:solidFill>
+                <a:srgbClr val="000000"/>
+              </a:solidFill>
+              <a:latin typeface="Century Gothic"/>
+            </a:endParaRPr>
+          </a:p>
+        </p:txBody>
+      </p:sp>
+      <p:sp>
+        <p:nvSpPr>
+          <p:cNvPr id="165" name="PlaceHolder 3">
+            <a:extLst>
+              <a:ext uri="{FF2B5EF4-FFF2-40B4-BE49-F238E27FC236}">
+                <a16:creationId xmlns:a16="http://schemas.microsoft.com/office/drawing/2014/main" id="{2EFBEA53-7B78-D9A1-93EF-9608A3193D27}"/>
+              </a:ext>
+            </a:extLst>
+          </p:cNvPr>
+          <p:cNvSpPr>
+            <a:spLocks noGrp="1"/>
+          </p:cNvSpPr>
+          <p:nvPr>
+            <p:ph type="sldNum"/>
+          </p:nvPr>
+        </p:nvSpPr>
+        <p:spPr>
+          <a:xfrm>
+            <a:off x="8376840" y="5692680"/>
+            <a:ext cx="384120" cy="364680"/>
+          </a:xfrm>
+          <a:prstGeom prst="rect">
+            <a:avLst/>
+          </a:prstGeom>
+          <a:noFill/>
+          <a:ln w="0">
+            <a:noFill/>
+          </a:ln>
+        </p:spPr>
+        <p:txBody>
+          <a:bodyPr anchor="ctr">
+            <a:noAutofit/>
+          </a:bodyPr>
+          <a:lstStyle/>
+          <a:p>
+            <a:pPr algn="r">
+              <a:lnSpc>
+                <a:spcPct val="100000"/>
+              </a:lnSpc>
+              <a:buNone/>
+            </a:pPr>
+            <a:fld id="{8BD7C522-1E12-40C3-B25E-5F0462E20B22}" type="slidenum">
+              <a:rPr lang="en-US" sz="1200" b="0" strike="noStrike" spc="-1">
+                <a:solidFill>
+                  <a:srgbClr val="8B8B8B"/>
+                </a:solidFill>
+                <a:latin typeface="Century Gothic"/>
+              </a:rPr>
+              <a:t>7</a:t>
+            </a:fld>
+            <a:endParaRPr lang="en-GB" sz="1200" b="0" strike="noStrike" spc="-1" dirty="0">
+              <a:latin typeface="Times New Roman"/>
+            </a:endParaRPr>
+          </a:p>
+        </p:txBody>
+      </p:sp>
+      <p:sp>
+        <p:nvSpPr>
+          <p:cNvPr id="7" name="PlaceHolder 2">
+            <a:extLst>
+              <a:ext uri="{FF2B5EF4-FFF2-40B4-BE49-F238E27FC236}">
+                <a16:creationId xmlns:a16="http://schemas.microsoft.com/office/drawing/2014/main" id="{66DE14D4-64D4-6D1F-DD92-BC16D674C58B}"/>
+              </a:ext>
+            </a:extLst>
+          </p:cNvPr>
+          <p:cNvSpPr txBox="1">
+            <a:spLocks/>
+          </p:cNvSpPr>
+          <p:nvPr/>
+        </p:nvSpPr>
+        <p:spPr>
+          <a:xfrm>
+            <a:off x="380880" y="1371598"/>
+            <a:ext cx="8109070" cy="4559301"/>
+          </a:xfrm>
+          <a:prstGeom prst="rect">
+            <a:avLst/>
+          </a:prstGeom>
+          <a:noFill/>
+          <a:ln w="0">
+            <a:noFill/>
+          </a:ln>
+        </p:spPr>
+        <p:txBody>
+          <a:bodyPr numCol="1" spcCol="0" anchor="t">
+            <a:noAutofit/>
+          </a:bodyPr>
+          <a:lstStyle>
+            <a:lvl1pPr marL="228600" indent="-228600" algn="l" defTabSz="914400" rtl="0" eaLnBrk="1" latinLnBrk="0" hangingPunct="1">
+              <a:lnSpc>
+                <a:spcPct val="90000"/>
+              </a:lnSpc>
+              <a:spcBef>
+                <a:spcPts val="1000"/>
+              </a:spcBef>
+              <a:buFont typeface="Arial" panose="020B0604020202020204" pitchFamily="34" charset="0"/>
+              <a:buChar char="•"/>
+              <a:defRPr sz="2800" kern="1200">
+                <a:solidFill>
+                  <a:schemeClr val="tx1"/>
+                </a:solidFill>
+                <a:latin typeface="+mn-lt"/>
+                <a:ea typeface="+mn-ea"/>
+                <a:cs typeface="+mn-cs"/>
+              </a:defRPr>
+            </a:lvl1pPr>
+            <a:lvl2pPr marL="685800" indent="-228600" algn="l" defTabSz="914400" rtl="0" eaLnBrk="1" latinLnBrk="0" hangingPunct="1">
+              <a:lnSpc>
+                <a:spcPct val="90000"/>
+              </a:lnSpc>
+              <a:spcBef>
+                <a:spcPts val="500"/>
+              </a:spcBef>
+              <a:buFont typeface="Arial" panose="020B0604020202020204" pitchFamily="34" charset="0"/>
+              <a:buChar char="•"/>
+              <a:defRPr sz="2400" kern="1200">
+                <a:solidFill>
+                  <a:schemeClr val="tx1"/>
+                </a:solidFill>
+                <a:latin typeface="+mn-lt"/>
+                <a:ea typeface="+mn-ea"/>
+                <a:cs typeface="+mn-cs"/>
+              </a:defRPr>
+            </a:lvl2pPr>
+            <a:lvl3pPr marL="1143000" indent="-228600" algn="l" defTabSz="914400" rtl="0" eaLnBrk="1" latinLnBrk="0" hangingPunct="1">
+              <a:lnSpc>
+                <a:spcPct val="90000"/>
+              </a:lnSpc>
+              <a:spcBef>
+                <a:spcPts val="500"/>
+              </a:spcBef>
+              <a:buFont typeface="Arial" panose="020B0604020202020204" pitchFamily="34" charset="0"/>
+              <a:buChar char="•"/>
+              <a:defRPr sz="2000" kern="1200">
+                <a:solidFill>
+                  <a:schemeClr val="tx1"/>
+                </a:solidFill>
+                <a:latin typeface="+mn-lt"/>
+                <a:ea typeface="+mn-ea"/>
+                <a:cs typeface="+mn-cs"/>
+              </a:defRPr>
+            </a:lvl3pPr>
+            <a:lvl4pPr marL="1600200" indent="-228600" algn="l" defTabSz="914400" rtl="0" eaLnBrk="1" latinLnBrk="0" hangingPunct="1">
+              <a:lnSpc>
+                <a:spcPct val="90000"/>
+              </a:lnSpc>
+              <a:spcBef>
+                <a:spcPts val="500"/>
+              </a:spcBef>
+              <a:buFont typeface="Arial" panose="020B0604020202020204" pitchFamily="34" charset="0"/>
+              <a:buChar char="•"/>
+              <a:defRPr sz="1800" kern="1200">
+                <a:solidFill>
+                  <a:schemeClr val="tx1"/>
+                </a:solidFill>
+                <a:latin typeface="+mn-lt"/>
+                <a:ea typeface="+mn-ea"/>
+                <a:cs typeface="+mn-cs"/>
+              </a:defRPr>
+            </a:lvl4pPr>
+            <a:lvl5pPr marL="2057400" indent="-228600" algn="l" defTabSz="914400" rtl="0" eaLnBrk="1" latinLnBrk="0" hangingPunct="1">
+              <a:lnSpc>
+                <a:spcPct val="90000"/>
+              </a:lnSpc>
+              <a:spcBef>
+                <a:spcPts val="500"/>
+              </a:spcBef>
+              <a:buFont typeface="Arial" panose="020B0604020202020204" pitchFamily="34" charset="0"/>
+              <a:buChar char="•"/>
+              <a:defRPr sz="1800" kern="1200">
+                <a:solidFill>
+                  <a:schemeClr val="tx1"/>
+                </a:solidFill>
+                <a:latin typeface="+mn-lt"/>
+                <a:ea typeface="+mn-ea"/>
+                <a:cs typeface="+mn-cs"/>
+              </a:defRPr>
+            </a:lvl5pPr>
+            <a:lvl6pPr marL="2514600" indent="-228600" algn="l" defTabSz="914400" rtl="0" eaLnBrk="1" latinLnBrk="0" hangingPunct="1">
+              <a:lnSpc>
+                <a:spcPct val="90000"/>
+              </a:lnSpc>
+              <a:spcBef>
+                <a:spcPts val="500"/>
+              </a:spcBef>
+              <a:buFont typeface="Arial" panose="020B0604020202020204" pitchFamily="34" charset="0"/>
+              <a:buChar char="•"/>
+              <a:defRPr sz="1800" kern="1200">
+                <a:solidFill>
+                  <a:schemeClr val="tx1"/>
+                </a:solidFill>
+                <a:latin typeface="+mn-lt"/>
+                <a:ea typeface="+mn-ea"/>
+                <a:cs typeface="+mn-cs"/>
+              </a:defRPr>
+            </a:lvl6pPr>
+            <a:lvl7pPr marL="2971800" indent="-228600" algn="l" defTabSz="914400" rtl="0" eaLnBrk="1" latinLnBrk="0" hangingPunct="1">
+              <a:lnSpc>
+                <a:spcPct val="90000"/>
+              </a:lnSpc>
+              <a:spcBef>
+                <a:spcPts val="500"/>
+              </a:spcBef>
+              <a:buFont typeface="Arial" panose="020B0604020202020204" pitchFamily="34" charset="0"/>
+              <a:buChar char="•"/>
+              <a:defRPr sz="1800" kern="1200">
+                <a:solidFill>
+                  <a:schemeClr val="tx1"/>
+                </a:solidFill>
+                <a:latin typeface="+mn-lt"/>
+                <a:ea typeface="+mn-ea"/>
+                <a:cs typeface="+mn-cs"/>
+              </a:defRPr>
+            </a:lvl7pPr>
+            <a:lvl8pPr marL="3429000" indent="-228600" algn="l" defTabSz="914400" rtl="0" eaLnBrk="1" latinLnBrk="0" hangingPunct="1">
+              <a:lnSpc>
+                <a:spcPct val="90000"/>
+              </a:lnSpc>
+              <a:spcBef>
+                <a:spcPts val="500"/>
+              </a:spcBef>
+              <a:buFont typeface="Arial" panose="020B0604020202020204" pitchFamily="34" charset="0"/>
+              <a:buChar char="•"/>
+              <a:defRPr sz="1800" kern="1200">
+                <a:solidFill>
+                  <a:schemeClr val="tx1"/>
+                </a:solidFill>
+                <a:latin typeface="+mn-lt"/>
+                <a:ea typeface="+mn-ea"/>
+                <a:cs typeface="+mn-cs"/>
+              </a:defRPr>
+            </a:lvl8pPr>
+            <a:lvl9pPr marL="3886200" indent="-228600" algn="l" defTabSz="914400" rtl="0" eaLnBrk="1" latinLnBrk="0" hangingPunct="1">
+              <a:lnSpc>
+                <a:spcPct val="90000"/>
+              </a:lnSpc>
+              <a:spcBef>
+                <a:spcPts val="500"/>
+              </a:spcBef>
+              <a:buFont typeface="Arial" panose="020B0604020202020204" pitchFamily="34" charset="0"/>
+              <a:buChar char="•"/>
+              <a:defRPr sz="1800" kern="1200">
+                <a:solidFill>
+                  <a:schemeClr val="tx1"/>
+                </a:solidFill>
+                <a:latin typeface="+mn-lt"/>
+                <a:ea typeface="+mn-ea"/>
+                <a:cs typeface="+mn-cs"/>
+              </a:defRPr>
+            </a:lvl9pPr>
+          </a:lstStyle>
+          <a:p>
+            <a:pPr>
+              <a:lnSpc>
+                <a:spcPct val="100000"/>
+              </a:lnSpc>
+              <a:spcBef>
+                <a:spcPts val="400"/>
+              </a:spcBef>
+              <a:buClr>
+                <a:srgbClr val="0064C8"/>
+              </a:buClr>
+              <a:buFont typeface="Wingdings" panose="05000000000000000000" pitchFamily="2" charset="2"/>
+              <a:buChar char="§"/>
+            </a:pPr>
+            <a:r>
+              <a:rPr lang="en-US" sz="2000" spc="-1" dirty="0">
+                <a:solidFill>
+                  <a:srgbClr val="000000"/>
+                </a:solidFill>
+                <a:latin typeface="Century Gothic"/>
+              </a:rPr>
+              <a:t>Add and properly implement missing XAI methods (</a:t>
+            </a:r>
+            <a:r>
+              <a:rPr lang="en-US" sz="2000" spc="-1" dirty="0" err="1">
+                <a:solidFill>
+                  <a:srgbClr val="000000"/>
+                </a:solidFill>
+                <a:latin typeface="Century Gothic"/>
+              </a:rPr>
+              <a:t>MolCE</a:t>
+            </a:r>
+            <a:r>
+              <a:rPr lang="en-US" sz="2000" spc="-1" dirty="0">
+                <a:solidFill>
+                  <a:srgbClr val="000000"/>
+                </a:solidFill>
+                <a:latin typeface="Century Gothic"/>
+              </a:rPr>
+              <a:t>, </a:t>
+            </a:r>
+            <a:r>
+              <a:rPr lang="en-US" sz="2000" spc="-1" dirty="0" err="1">
+                <a:solidFill>
+                  <a:srgbClr val="000000"/>
+                </a:solidFill>
+                <a:latin typeface="Century Gothic"/>
+              </a:rPr>
+              <a:t>EdgeSHaper</a:t>
+            </a:r>
+            <a:r>
+              <a:rPr lang="en-US" sz="2000" spc="-1" dirty="0">
+                <a:solidFill>
+                  <a:srgbClr val="000000"/>
+                </a:solidFill>
+                <a:latin typeface="Century Gothic"/>
+              </a:rPr>
+              <a:t>, Counterfactuals)</a:t>
+            </a:r>
+          </a:p>
+          <a:p>
+            <a:pPr>
+              <a:lnSpc>
+                <a:spcPct val="100000"/>
+              </a:lnSpc>
+              <a:spcBef>
+                <a:spcPts val="400"/>
+              </a:spcBef>
+              <a:buClr>
+                <a:srgbClr val="0064C8"/>
+              </a:buClr>
+              <a:buFont typeface="Wingdings" panose="05000000000000000000" pitchFamily="2" charset="2"/>
+              <a:buChar char="§"/>
+            </a:pPr>
+            <a:endParaRPr lang="en-US" sz="2000" spc="-1" dirty="0">
+              <a:solidFill>
+                <a:srgbClr val="000000"/>
+              </a:solidFill>
+              <a:latin typeface="Century Gothic"/>
+            </a:endParaRPr>
+          </a:p>
+          <a:p>
+            <a:pPr>
+              <a:lnSpc>
+                <a:spcPct val="100000"/>
+              </a:lnSpc>
+              <a:spcBef>
+                <a:spcPts val="400"/>
+              </a:spcBef>
+              <a:buClr>
+                <a:srgbClr val="0064C8"/>
+              </a:buClr>
+              <a:buFont typeface="Wingdings" panose="05000000000000000000" pitchFamily="2" charset="2"/>
+              <a:buChar char="§"/>
+            </a:pPr>
+            <a:r>
+              <a:rPr lang="en-US" sz="2000" spc="-1" dirty="0">
+                <a:solidFill>
+                  <a:srgbClr val="000000"/>
+                </a:solidFill>
+                <a:latin typeface="Century Gothic"/>
+              </a:rPr>
+              <a:t>Integrate with cluster for faster inference and explore larger LLM’s</a:t>
+            </a:r>
+          </a:p>
+          <a:p>
+            <a:pPr marL="0" indent="0">
+              <a:lnSpc>
+                <a:spcPct val="100000"/>
+              </a:lnSpc>
+              <a:spcBef>
+                <a:spcPts val="400"/>
+              </a:spcBef>
+              <a:buClr>
+                <a:srgbClr val="0064C8"/>
+              </a:buClr>
+              <a:buNone/>
+            </a:pPr>
+            <a:endParaRPr lang="en-US" sz="2000" spc="-1" dirty="0">
+              <a:solidFill>
+                <a:srgbClr val="000000"/>
+              </a:solidFill>
+              <a:latin typeface="Century Gothic"/>
+            </a:endParaRPr>
+          </a:p>
+          <a:p>
+            <a:pPr>
+              <a:lnSpc>
+                <a:spcPct val="100000"/>
+              </a:lnSpc>
+              <a:spcBef>
+                <a:spcPts val="400"/>
+              </a:spcBef>
+              <a:buClr>
+                <a:srgbClr val="0064C8"/>
+              </a:buClr>
+              <a:buFont typeface="Wingdings" panose="05000000000000000000" pitchFamily="2" charset="2"/>
+              <a:buChar char="§"/>
+            </a:pPr>
+            <a:r>
+              <a:rPr lang="en-US" sz="2000" spc="-1" dirty="0">
+                <a:solidFill>
+                  <a:srgbClr val="000000"/>
+                </a:solidFill>
+                <a:latin typeface="Century Gothic"/>
+              </a:rPr>
+              <a:t>Clean up the repository and make it available</a:t>
+            </a:r>
+          </a:p>
+          <a:p>
+            <a:pPr>
+              <a:lnSpc>
+                <a:spcPct val="100000"/>
+              </a:lnSpc>
+              <a:spcBef>
+                <a:spcPts val="400"/>
+              </a:spcBef>
+              <a:buClr>
+                <a:srgbClr val="0064C8"/>
+              </a:buClr>
+              <a:buFont typeface="Wingdings" panose="05000000000000000000" pitchFamily="2" charset="2"/>
+              <a:buChar char="§"/>
+            </a:pPr>
+            <a:endParaRPr lang="en-US" sz="2000" spc="-1" dirty="0">
+              <a:solidFill>
+                <a:srgbClr val="000000"/>
+              </a:solidFill>
+              <a:latin typeface="Century Gothic"/>
+            </a:endParaRPr>
+          </a:p>
+          <a:p>
+            <a:pPr>
+              <a:lnSpc>
+                <a:spcPct val="100000"/>
+              </a:lnSpc>
+              <a:spcBef>
+                <a:spcPts val="400"/>
+              </a:spcBef>
+              <a:buClr>
+                <a:srgbClr val="0064C8"/>
+              </a:buClr>
+              <a:buFont typeface="Wingdings" panose="05000000000000000000" pitchFamily="2" charset="2"/>
+              <a:buChar char="§"/>
+            </a:pPr>
+            <a:r>
+              <a:rPr lang="en-US" sz="2000" spc="-1" dirty="0">
+                <a:solidFill>
+                  <a:srgbClr val="000000"/>
+                </a:solidFill>
+                <a:latin typeface="Century Gothic"/>
+              </a:rPr>
+              <a:t>Make a guide for lab members for the implementation of AI agents</a:t>
+            </a:r>
+          </a:p>
+          <a:p>
+            <a:pPr>
+              <a:lnSpc>
+                <a:spcPct val="100000"/>
+              </a:lnSpc>
+              <a:spcBef>
+                <a:spcPts val="400"/>
+              </a:spcBef>
+              <a:buClr>
+                <a:srgbClr val="0064C8"/>
+              </a:buClr>
+              <a:buFont typeface="Wingdings" panose="05000000000000000000" pitchFamily="2" charset="2"/>
+              <a:buChar char="§"/>
+            </a:pPr>
+            <a:endParaRPr lang="en-US" sz="2000" spc="-1" dirty="0">
+              <a:solidFill>
+                <a:srgbClr val="000000"/>
+              </a:solidFill>
+              <a:latin typeface="Century Gothic"/>
+            </a:endParaRPr>
+          </a:p>
+          <a:p>
+            <a:pPr>
+              <a:lnSpc>
+                <a:spcPct val="100000"/>
+              </a:lnSpc>
+              <a:spcBef>
+                <a:spcPts val="400"/>
+              </a:spcBef>
+              <a:buClr>
+                <a:srgbClr val="0064C8"/>
+              </a:buClr>
+              <a:buFont typeface="Wingdings" panose="05000000000000000000" pitchFamily="2" charset="2"/>
+              <a:buChar char="§"/>
+            </a:pPr>
+            <a:endParaRPr lang="en-US" sz="1800" spc="-1" dirty="0">
+              <a:solidFill>
+                <a:srgbClr val="000000"/>
+              </a:solidFill>
+              <a:latin typeface="Century Gothic"/>
+            </a:endParaRPr>
+          </a:p>
+          <a:p>
+            <a:pPr marL="343080" indent="-343080">
+              <a:lnSpc>
+                <a:spcPct val="100000"/>
+              </a:lnSpc>
+              <a:spcBef>
+                <a:spcPts val="400"/>
+              </a:spcBef>
+              <a:spcAft>
+                <a:spcPts val="601"/>
+              </a:spcAft>
+              <a:buClr>
+                <a:srgbClr val="0064C8"/>
+              </a:buClr>
+              <a:buFont typeface="Wingdings 2" charset="2"/>
+              <a:buChar char=""/>
+            </a:pPr>
+            <a:endParaRPr lang="en-US" sz="2000" b="1" spc="-1" dirty="0">
+              <a:solidFill>
+                <a:srgbClr val="000000"/>
+              </a:solidFill>
+              <a:latin typeface="Century Gothic"/>
+            </a:endParaRPr>
+          </a:p>
+        </p:txBody>
+      </p:sp>
+    </p:spTree>
+    <p:extLst>
+      <p:ext uri="{BB962C8B-B14F-4D97-AF65-F5344CB8AC3E}">
+        <p14:creationId xmlns:p14="http://schemas.microsoft.com/office/powerpoint/2010/main" val="3727029337"/>
+      </p:ext>
+    </p:extLst>
+  </p:cSld>
+  <p:clrMapOvr>
+    <a:masterClrMapping/>
+  </p:clrMapOvr>
+  <mc:AlternateContent xmlns:mc="http://schemas.openxmlformats.org/markup-compatibility/2006">
+    <mc:Choice xmlns:p14="http://schemas.microsoft.com/office/powerpoint/2010/main" Requires="p14">
+      <p:transition spd="med" p14:dur="700">
+        <p:fade/>
+      </p:transition>
+    </mc:Choice>
+    <mc:Fallback>
+      <p:transition spd="med">
+        <p:fade/>
+      </p:transition>
+    </mc:Fallback>
+  </mc:AlternateContent>
+</p:sld>
+</file>
+
+<file path=ppt/slides/slide8.xml><?xml version="1.0" encoding="utf-8"?>
+<p:sld xmlns:a="http://schemas.openxmlformats.org/drawingml/2006/main" xmlns:r="http://schemas.openxmlformats.org/officeDocument/2006/relationships" xmlns:p="http://schemas.openxmlformats.org/presentationml/2006/main">
+  <p:cSld>
+    <p:spTree>
+      <p:nvGrpSpPr>
+        <p:cNvPr id="1" name="">
+          <a:extLst>
+            <a:ext uri="{FF2B5EF4-FFF2-40B4-BE49-F238E27FC236}">
+              <a16:creationId xmlns:a16="http://schemas.microsoft.com/office/drawing/2014/main" id="{A6515F23-0912-A838-23CE-B8F00573A2DA}"/>
+            </a:ext>
+          </a:extLst>
+        </p:cNvPr>
+        <p:cNvGrpSpPr/>
+        <p:nvPr/>
+      </p:nvGrpSpPr>
+      <p:grpSpPr>
+        <a:xfrm>
+          <a:off x="0" y="0"/>
+          <a:ext cx="0" cy="0"/>
+          <a:chOff x="0" y="0"/>
+          <a:chExt cx="0" cy="0"/>
+        </a:xfrm>
+      </p:grpSpPr>
+      <p:sp>
+        <p:nvSpPr>
+          <p:cNvPr id="163" name="PlaceHolder 1">
+            <a:extLst>
+              <a:ext uri="{FF2B5EF4-FFF2-40B4-BE49-F238E27FC236}">
+                <a16:creationId xmlns:a16="http://schemas.microsoft.com/office/drawing/2014/main" id="{57944F4B-F502-E7CC-8790-8737702BC6AC}"/>
+              </a:ext>
+            </a:extLst>
+          </p:cNvPr>
+          <p:cNvSpPr>
+            <a:spLocks noGrp="1"/>
+          </p:cNvSpPr>
+          <p:nvPr>
+            <p:ph type="title"/>
+          </p:nvPr>
+        </p:nvSpPr>
+        <p:spPr>
+          <a:xfrm>
+            <a:off x="380880" y="228600"/>
+            <a:ext cx="8380080" cy="837720"/>
+          </a:xfrm>
+          <a:prstGeom prst="rect">
+            <a:avLst/>
+          </a:prstGeom>
+          <a:noFill/>
+          <a:ln w="0">
+            <a:noFill/>
+          </a:ln>
+        </p:spPr>
+        <p:txBody>
+          <a:bodyPr numCol="1" spcCol="0" anchor="ctr">
+            <a:noAutofit/>
+          </a:bodyPr>
+          <a:lstStyle/>
+          <a:p>
+            <a:pPr>
+              <a:lnSpc>
+                <a:spcPct val="100000"/>
+              </a:lnSpc>
+              <a:buNone/>
+            </a:pPr>
+            <a:r>
+              <a:rPr lang="en-US" sz="3200" b="0" strike="noStrike" spc="-1" dirty="0">
+                <a:solidFill>
+                  <a:srgbClr val="0064C8"/>
+                </a:solidFill>
+                <a:latin typeface="Century Gothic"/>
+              </a:rPr>
+              <a:t>Framing</a:t>
+            </a:r>
+            <a:endParaRPr lang="en-US" sz="3200" b="0" strike="noStrike" spc="-1" dirty="0">
+              <a:solidFill>
+                <a:srgbClr val="000000"/>
+              </a:solidFill>
+              <a:latin typeface="Century Gothic"/>
+            </a:endParaRPr>
+          </a:p>
+        </p:txBody>
+      </p:sp>
+      <p:sp>
+        <p:nvSpPr>
+          <p:cNvPr id="165" name="PlaceHolder 3">
+            <a:extLst>
+              <a:ext uri="{FF2B5EF4-FFF2-40B4-BE49-F238E27FC236}">
+                <a16:creationId xmlns:a16="http://schemas.microsoft.com/office/drawing/2014/main" id="{2EFBEA53-7B78-D9A1-93EF-9608A3193D27}"/>
+              </a:ext>
+            </a:extLst>
+          </p:cNvPr>
+          <p:cNvSpPr>
+            <a:spLocks noGrp="1"/>
+          </p:cNvSpPr>
+          <p:nvPr>
+            <p:ph type="sldNum"/>
+          </p:nvPr>
+        </p:nvSpPr>
+        <p:spPr>
+          <a:xfrm>
+            <a:off x="8376840" y="5692680"/>
+            <a:ext cx="384120" cy="364680"/>
+          </a:xfrm>
+          <a:prstGeom prst="rect">
+            <a:avLst/>
+          </a:prstGeom>
+          <a:noFill/>
+          <a:ln w="0">
+            <a:noFill/>
+          </a:ln>
+        </p:spPr>
+        <p:txBody>
+          <a:bodyPr anchor="ctr">
+            <a:noAutofit/>
+          </a:bodyPr>
+          <a:lstStyle/>
+          <a:p>
+            <a:pPr algn="r">
+              <a:lnSpc>
+                <a:spcPct val="100000"/>
+              </a:lnSpc>
+              <a:buNone/>
+            </a:pPr>
+            <a:fld id="{8BD7C522-1E12-40C3-B25E-5F0462E20B22}" type="slidenum">
+              <a:rPr lang="en-US" sz="1200" b="0" strike="noStrike" spc="-1">
+                <a:solidFill>
+                  <a:srgbClr val="8B8B8B"/>
+                </a:solidFill>
+                <a:latin typeface="Century Gothic"/>
+              </a:rPr>
+              <a:t>8</a:t>
+            </a:fld>
+            <a:endParaRPr lang="en-GB" sz="1200" b="0" strike="noStrike" spc="-1" dirty="0">
+              <a:latin typeface="Times New Roman"/>
+            </a:endParaRPr>
+          </a:p>
+        </p:txBody>
+      </p:sp>
+      <p:sp>
+        <p:nvSpPr>
+          <p:cNvPr id="7" name="PlaceHolder 2">
+            <a:extLst>
+              <a:ext uri="{FF2B5EF4-FFF2-40B4-BE49-F238E27FC236}">
+                <a16:creationId xmlns:a16="http://schemas.microsoft.com/office/drawing/2014/main" id="{66DE14D4-64D4-6D1F-DD92-BC16D674C58B}"/>
+              </a:ext>
+            </a:extLst>
+          </p:cNvPr>
+          <p:cNvSpPr txBox="1">
+            <a:spLocks/>
+          </p:cNvSpPr>
+          <p:nvPr/>
+        </p:nvSpPr>
+        <p:spPr>
+          <a:xfrm>
+            <a:off x="380880" y="1371598"/>
+            <a:ext cx="8109070" cy="4559301"/>
+          </a:xfrm>
+          <a:prstGeom prst="rect">
+            <a:avLst/>
+          </a:prstGeom>
+          <a:noFill/>
+          <a:ln w="0">
+            <a:noFill/>
+          </a:ln>
+        </p:spPr>
+        <p:txBody>
+          <a:bodyPr numCol="1" spcCol="0" anchor="t">
+            <a:noAutofit/>
+          </a:bodyPr>
+          <a:lstStyle>
+            <a:lvl1pPr marL="228600" indent="-228600" algn="l" defTabSz="914400" rtl="0" eaLnBrk="1" latinLnBrk="0" hangingPunct="1">
+              <a:lnSpc>
+                <a:spcPct val="90000"/>
+              </a:lnSpc>
+              <a:spcBef>
+                <a:spcPts val="1000"/>
+              </a:spcBef>
+              <a:buFont typeface="Arial" panose="020B0604020202020204" pitchFamily="34" charset="0"/>
+              <a:buChar char="•"/>
+              <a:defRPr sz="2800" kern="1200">
+                <a:solidFill>
+                  <a:schemeClr val="tx1"/>
+                </a:solidFill>
+                <a:latin typeface="+mn-lt"/>
+                <a:ea typeface="+mn-ea"/>
+                <a:cs typeface="+mn-cs"/>
+              </a:defRPr>
+            </a:lvl1pPr>
+            <a:lvl2pPr marL="685800" indent="-228600" algn="l" defTabSz="914400" rtl="0" eaLnBrk="1" latinLnBrk="0" hangingPunct="1">
+              <a:lnSpc>
+                <a:spcPct val="90000"/>
+              </a:lnSpc>
+              <a:spcBef>
+                <a:spcPts val="500"/>
+              </a:spcBef>
+              <a:buFont typeface="Arial" panose="020B0604020202020204" pitchFamily="34" charset="0"/>
+              <a:buChar char="•"/>
+              <a:defRPr sz="2400" kern="1200">
+                <a:solidFill>
+                  <a:schemeClr val="tx1"/>
+                </a:solidFill>
+                <a:latin typeface="+mn-lt"/>
+                <a:ea typeface="+mn-ea"/>
+                <a:cs typeface="+mn-cs"/>
+              </a:defRPr>
+            </a:lvl2pPr>
+            <a:lvl3pPr marL="1143000" indent="-228600" algn="l" defTabSz="914400" rtl="0" eaLnBrk="1" latinLnBrk="0" hangingPunct="1">
+              <a:lnSpc>
+                <a:spcPct val="90000"/>
+              </a:lnSpc>
+              <a:spcBef>
+                <a:spcPts val="500"/>
+              </a:spcBef>
+              <a:buFont typeface="Arial" panose="020B0604020202020204" pitchFamily="34" charset="0"/>
+              <a:buChar char="•"/>
+              <a:defRPr sz="2000" kern="1200">
+                <a:solidFill>
+                  <a:schemeClr val="tx1"/>
+                </a:solidFill>
+                <a:latin typeface="+mn-lt"/>
+                <a:ea typeface="+mn-ea"/>
+                <a:cs typeface="+mn-cs"/>
+              </a:defRPr>
+            </a:lvl3pPr>
+            <a:lvl4pPr marL="1600200" indent="-228600" algn="l" defTabSz="914400" rtl="0" eaLnBrk="1" latinLnBrk="0" hangingPunct="1">
+              <a:lnSpc>
+                <a:spcPct val="90000"/>
+              </a:lnSpc>
+              <a:spcBef>
+                <a:spcPts val="500"/>
+              </a:spcBef>
+              <a:buFont typeface="Arial" panose="020B0604020202020204" pitchFamily="34" charset="0"/>
+              <a:buChar char="•"/>
+              <a:defRPr sz="1800" kern="1200">
+                <a:solidFill>
+                  <a:schemeClr val="tx1"/>
+                </a:solidFill>
+                <a:latin typeface="+mn-lt"/>
+                <a:ea typeface="+mn-ea"/>
+                <a:cs typeface="+mn-cs"/>
+              </a:defRPr>
+            </a:lvl4pPr>
+            <a:lvl5pPr marL="2057400" indent="-228600" algn="l" defTabSz="914400" rtl="0" eaLnBrk="1" latinLnBrk="0" hangingPunct="1">
+              <a:lnSpc>
+                <a:spcPct val="90000"/>
+              </a:lnSpc>
+              <a:spcBef>
+                <a:spcPts val="500"/>
+              </a:spcBef>
+              <a:buFont typeface="Arial" panose="020B0604020202020204" pitchFamily="34" charset="0"/>
+              <a:buChar char="•"/>
+              <a:defRPr sz="1800" kern="1200">
+                <a:solidFill>
+                  <a:schemeClr val="tx1"/>
+                </a:solidFill>
+                <a:latin typeface="+mn-lt"/>
+                <a:ea typeface="+mn-ea"/>
+                <a:cs typeface="+mn-cs"/>
+              </a:defRPr>
+            </a:lvl5pPr>
+            <a:lvl6pPr marL="2514600" indent="-228600" algn="l" defTabSz="914400" rtl="0" eaLnBrk="1" latinLnBrk="0" hangingPunct="1">
+              <a:lnSpc>
+                <a:spcPct val="90000"/>
+              </a:lnSpc>
+              <a:spcBef>
+                <a:spcPts val="500"/>
+              </a:spcBef>
+              <a:buFont typeface="Arial" panose="020B0604020202020204" pitchFamily="34" charset="0"/>
+              <a:buChar char="•"/>
+              <a:defRPr sz="1800" kern="1200">
+                <a:solidFill>
+                  <a:schemeClr val="tx1"/>
+                </a:solidFill>
+                <a:latin typeface="+mn-lt"/>
+                <a:ea typeface="+mn-ea"/>
+                <a:cs typeface="+mn-cs"/>
+              </a:defRPr>
+            </a:lvl6pPr>
+            <a:lvl7pPr marL="2971800" indent="-228600" algn="l" defTabSz="914400" rtl="0" eaLnBrk="1" latinLnBrk="0" hangingPunct="1">
+              <a:lnSpc>
+                <a:spcPct val="90000"/>
+              </a:lnSpc>
+              <a:spcBef>
+                <a:spcPts val="500"/>
+              </a:spcBef>
+              <a:buFont typeface="Arial" panose="020B0604020202020204" pitchFamily="34" charset="0"/>
+              <a:buChar char="•"/>
+              <a:defRPr sz="1800" kern="1200">
+                <a:solidFill>
+                  <a:schemeClr val="tx1"/>
+                </a:solidFill>
+                <a:latin typeface="+mn-lt"/>
+                <a:ea typeface="+mn-ea"/>
+                <a:cs typeface="+mn-cs"/>
+              </a:defRPr>
+            </a:lvl7pPr>
+            <a:lvl8pPr marL="3429000" indent="-228600" algn="l" defTabSz="914400" rtl="0" eaLnBrk="1" latinLnBrk="0" hangingPunct="1">
+              <a:lnSpc>
+                <a:spcPct val="90000"/>
+              </a:lnSpc>
+              <a:spcBef>
+                <a:spcPts val="500"/>
+              </a:spcBef>
+              <a:buFont typeface="Arial" panose="020B0604020202020204" pitchFamily="34" charset="0"/>
+              <a:buChar char="•"/>
+              <a:defRPr sz="1800" kern="1200">
+                <a:solidFill>
+                  <a:schemeClr val="tx1"/>
+                </a:solidFill>
+                <a:latin typeface="+mn-lt"/>
+                <a:ea typeface="+mn-ea"/>
+                <a:cs typeface="+mn-cs"/>
+              </a:defRPr>
+            </a:lvl8pPr>
+            <a:lvl9pPr marL="3886200" indent="-228600" algn="l" defTabSz="914400" rtl="0" eaLnBrk="1" latinLnBrk="0" hangingPunct="1">
+              <a:lnSpc>
+                <a:spcPct val="90000"/>
+              </a:lnSpc>
+              <a:spcBef>
+                <a:spcPts val="500"/>
+              </a:spcBef>
+              <a:buFont typeface="Arial" panose="020B0604020202020204" pitchFamily="34" charset="0"/>
+              <a:buChar char="•"/>
+              <a:defRPr sz="1800" kern="1200">
+                <a:solidFill>
+                  <a:schemeClr val="tx1"/>
+                </a:solidFill>
+                <a:latin typeface="+mn-lt"/>
+                <a:ea typeface="+mn-ea"/>
+                <a:cs typeface="+mn-cs"/>
+              </a:defRPr>
+            </a:lvl9pPr>
+          </a:lstStyle>
+          <a:p>
+            <a:pPr>
+              <a:lnSpc>
+                <a:spcPct val="100000"/>
+              </a:lnSpc>
+              <a:spcBef>
+                <a:spcPts val="400"/>
+              </a:spcBef>
+              <a:buClr>
+                <a:srgbClr val="0064C8"/>
+              </a:buClr>
+              <a:buFont typeface="Wingdings" panose="05000000000000000000" pitchFamily="2" charset="2"/>
+              <a:buChar char="§"/>
+            </a:pPr>
+            <a:r>
+              <a:rPr lang="en-US" sz="2000" spc="-1" dirty="0">
+                <a:solidFill>
+                  <a:srgbClr val="000000"/>
+                </a:solidFill>
+                <a:latin typeface="Century Gothic"/>
+              </a:rPr>
+              <a:t>How to frame the project:</a:t>
+            </a:r>
+          </a:p>
+          <a:p>
+            <a:pPr lvl="1">
+              <a:lnSpc>
+                <a:spcPct val="100000"/>
+              </a:lnSpc>
+              <a:spcBef>
+                <a:spcPts val="400"/>
+              </a:spcBef>
+              <a:buClr>
+                <a:srgbClr val="0064C8"/>
+              </a:buClr>
+              <a:buFont typeface="Wingdings" panose="05000000000000000000" pitchFamily="2" charset="2"/>
+              <a:buChar char="§"/>
+            </a:pPr>
+            <a:r>
+              <a:rPr lang="en-US" sz="1600" spc="-1" dirty="0">
+                <a:solidFill>
+                  <a:srgbClr val="000000"/>
+                </a:solidFill>
+                <a:latin typeface="Century Gothic"/>
+              </a:rPr>
+              <a:t>A proof-of-concept study?</a:t>
+            </a:r>
+          </a:p>
+          <a:p>
+            <a:pPr lvl="1">
+              <a:lnSpc>
+                <a:spcPct val="100000"/>
+              </a:lnSpc>
+              <a:spcBef>
+                <a:spcPts val="400"/>
+              </a:spcBef>
+              <a:buClr>
+                <a:srgbClr val="0064C8"/>
+              </a:buClr>
+              <a:buFont typeface="Wingdings" panose="05000000000000000000" pitchFamily="2" charset="2"/>
+              <a:buChar char="§"/>
+            </a:pPr>
+            <a:r>
+              <a:rPr lang="en-US" sz="1600" spc="-1" dirty="0">
+                <a:solidFill>
+                  <a:srgbClr val="000000"/>
+                </a:solidFill>
+                <a:latin typeface="Century Gothic"/>
+              </a:rPr>
+              <a:t>A explainability platform for XAI applied to molecular design?</a:t>
+            </a:r>
+          </a:p>
+          <a:p>
+            <a:pPr lvl="1">
+              <a:lnSpc>
+                <a:spcPct val="100000"/>
+              </a:lnSpc>
+              <a:spcBef>
+                <a:spcPts val="400"/>
+              </a:spcBef>
+              <a:buClr>
+                <a:srgbClr val="0064C8"/>
+              </a:buClr>
+              <a:buFont typeface="Wingdings" panose="05000000000000000000" pitchFamily="2" charset="2"/>
+              <a:buChar char="§"/>
+            </a:pPr>
+            <a:r>
+              <a:rPr lang="en-US" sz="1600" spc="-1" dirty="0">
+                <a:solidFill>
+                  <a:srgbClr val="000000"/>
+                </a:solidFill>
+                <a:latin typeface="Century Gothic"/>
+              </a:rPr>
+              <a:t> A explainability platform for XAI specific to molecular selectivity?</a:t>
+            </a:r>
+          </a:p>
+          <a:p>
+            <a:pPr lvl="1">
+              <a:lnSpc>
+                <a:spcPct val="100000"/>
+              </a:lnSpc>
+              <a:spcBef>
+                <a:spcPts val="400"/>
+              </a:spcBef>
+              <a:buClr>
+                <a:srgbClr val="0064C8"/>
+              </a:buClr>
+              <a:buFont typeface="Wingdings" panose="05000000000000000000" pitchFamily="2" charset="2"/>
+              <a:buChar char="§"/>
+            </a:pPr>
+            <a:endParaRPr lang="en-US" sz="1600" spc="-1" dirty="0">
+              <a:solidFill>
+                <a:srgbClr val="000000"/>
+              </a:solidFill>
+              <a:latin typeface="Century Gothic"/>
+            </a:endParaRPr>
+          </a:p>
+          <a:p>
+            <a:pPr>
+              <a:lnSpc>
+                <a:spcPct val="100000"/>
+              </a:lnSpc>
+              <a:spcBef>
+                <a:spcPts val="400"/>
+              </a:spcBef>
+              <a:buClr>
+                <a:srgbClr val="0064C8"/>
+              </a:buClr>
+              <a:buFont typeface="Wingdings" panose="05000000000000000000" pitchFamily="2" charset="2"/>
+              <a:buChar char="§"/>
+            </a:pPr>
+            <a:endParaRPr lang="en-US" sz="2000" spc="-1" dirty="0">
+              <a:solidFill>
+                <a:srgbClr val="000000"/>
+              </a:solidFill>
+              <a:latin typeface="Century Gothic"/>
+            </a:endParaRPr>
+          </a:p>
+          <a:p>
+            <a:pPr>
+              <a:lnSpc>
+                <a:spcPct val="100000"/>
+              </a:lnSpc>
+              <a:spcBef>
+                <a:spcPts val="400"/>
+              </a:spcBef>
+              <a:buClr>
+                <a:srgbClr val="0064C8"/>
+              </a:buClr>
+              <a:buFont typeface="Wingdings" panose="05000000000000000000" pitchFamily="2" charset="2"/>
+              <a:buChar char="§"/>
+            </a:pPr>
+            <a:endParaRPr lang="en-US" sz="1800" spc="-1" dirty="0">
+              <a:solidFill>
+                <a:srgbClr val="000000"/>
+              </a:solidFill>
+              <a:latin typeface="Century Gothic"/>
+            </a:endParaRPr>
+          </a:p>
+          <a:p>
+            <a:pPr marL="343080" indent="-343080">
+              <a:lnSpc>
+                <a:spcPct val="100000"/>
+              </a:lnSpc>
+              <a:spcBef>
+                <a:spcPts val="400"/>
+              </a:spcBef>
+              <a:spcAft>
+                <a:spcPts val="601"/>
+              </a:spcAft>
+              <a:buClr>
+                <a:srgbClr val="0064C8"/>
+              </a:buClr>
+              <a:buFont typeface="Wingdings 2" charset="2"/>
+              <a:buChar char=""/>
+            </a:pPr>
+            <a:endParaRPr lang="en-US" sz="2000" b="1" spc="-1" dirty="0">
+              <a:solidFill>
+                <a:srgbClr val="000000"/>
+              </a:solidFill>
+              <a:latin typeface="Century Gothic"/>
+            </a:endParaRPr>
+          </a:p>
+        </p:txBody>
+      </p:sp>
+    </p:spTree>
+    <p:extLst>
+      <p:ext uri="{BB962C8B-B14F-4D97-AF65-F5344CB8AC3E}">
+        <p14:creationId xmlns:p14="http://schemas.microsoft.com/office/powerpoint/2010/main" val="1594879052"/>
+      </p:ext>
+    </p:extLst>
+  </p:cSld>
+  <p:clrMapOvr>
+    <a:masterClrMapping/>
+  </p:clrMapOvr>
+  <mc:AlternateContent xmlns:mc="http://schemas.openxmlformats.org/markup-compatibility/2006">
+    <mc:Choice xmlns:p14="http://schemas.microsoft.com/office/powerpoint/2010/main" Requires="p14">
+      <p:transition spd="med" p14:dur="700">
+        <p:fade/>
+      </p:transition>
+    </mc:Choice>
+    <mc:Fallback>
       <p:transition spd="med">
         <p:fade/>
       </p:transition>

</xml_diff>

<commit_message>
Update AI Agent Explainability slides
Co-Authored-By: Claude Sonnet 4.6 <noreply@anthropic.com>
</commit_message>
<xml_diff>
--- a/slides/AI_Agent_Explainability.pptx
+++ b/slides/AI_Agent_Explainability.pptx
@@ -12,8 +12,9 @@
     <p:sldId id="301" r:id="rId6"/>
     <p:sldId id="300" r:id="rId7"/>
     <p:sldId id="302" r:id="rId8"/>
-    <p:sldId id="303" r:id="rId9"/>
-    <p:sldId id="304" r:id="rId10"/>
+    <p:sldId id="305" r:id="rId9"/>
+    <p:sldId id="303" r:id="rId10"/>
+    <p:sldId id="304" r:id="rId11"/>
   </p:sldIdLst>
   <p:sldSz cx="9144000" cy="6858000" type="screen4x3"/>
   <p:notesSz cx="7559675" cy="10691813"/>
@@ -10022,7 +10023,7 @@
         <p:fade/>
       </p:transition>
     </mc:Choice>
-    <mc:Fallback xmlns:p15="http://schemas.microsoft.com/office/powerpoint/2012/main" xmlns="">
+    <mc:Fallback xmlns="" xmlns:p15="http://schemas.microsoft.com/office/powerpoint/2012/main">
       <p:transition spd="med">
         <p:fade/>
       </p:transition>
@@ -10451,7 +10452,7 @@
         <p:fade/>
       </p:transition>
     </mc:Choice>
-    <mc:Fallback xmlns:p15="http://schemas.microsoft.com/office/powerpoint/2012/main" xmlns="">
+    <mc:Fallback xmlns="" xmlns:p15="http://schemas.microsoft.com/office/powerpoint/2012/main">
       <p:transition spd="med">
         <p:fade/>
       </p:transition>
@@ -11212,7 +11213,7 @@
         <p:fade/>
       </p:transition>
     </mc:Choice>
-    <mc:Fallback xmlns:p15="http://schemas.microsoft.com/office/powerpoint/2012/main" xmlns="">
+    <mc:Fallback xmlns="" xmlns:p15="http://schemas.microsoft.com/office/powerpoint/2012/main">
       <p:transition spd="med">
         <p:fade/>
       </p:transition>
@@ -11791,7 +11792,7 @@
         <p:fade/>
       </p:transition>
     </mc:Choice>
-    <mc:Fallback xmlns:p15="http://schemas.microsoft.com/office/powerpoint/2012/main" xmlns="">
+    <mc:Fallback xmlns="" xmlns:p15="http://schemas.microsoft.com/office/powerpoint/2012/main">
       <p:transition spd="med">
         <p:fade/>
       </p:transition>
@@ -11871,7 +11872,7 @@
                 </a:solidFill>
                 <a:latin typeface="Century Gothic"/>
               </a:rPr>
-              <a:t>Exemplary answer output</a:t>
+              <a:t>Exemplary answer output SHAP</a:t>
             </a:r>
             <a:endParaRPr lang="en-US" sz="3200" b="0" strike="noStrike" spc="-1" dirty="0">
               <a:solidFill>
@@ -12406,7 +12407,7 @@
         <p:fade/>
       </p:transition>
     </mc:Choice>
-    <mc:Fallback xmlns:p15="http://schemas.microsoft.com/office/powerpoint/2012/main" xmlns="">
+    <mc:Fallback xmlns="" xmlns:p15="http://schemas.microsoft.com/office/powerpoint/2012/main">
       <p:transition spd="med">
         <p:fade/>
       </p:transition>
@@ -12486,7 +12487,16 @@
                 </a:solidFill>
                 <a:latin typeface="Century Gothic"/>
               </a:rPr>
-              <a:t>Exemplary answer output</a:t>
+              <a:t>Exemplary answer output </a:t>
+            </a:r>
+            <a:r>
+              <a:rPr lang="en-US" sz="3200" b="0" strike="noStrike" spc="-1" dirty="0" err="1">
+                <a:solidFill>
+                  <a:srgbClr val="0064C8"/>
+                </a:solidFill>
+                <a:latin typeface="Century Gothic"/>
+              </a:rPr>
+              <a:t>MolAnchor</a:t>
             </a:r>
             <a:endParaRPr lang="en-US" sz="3200" b="0" strike="noStrike" spc="-1" dirty="0">
               <a:solidFill>
@@ -12829,7 +12839,7 @@
                 </a:solidFill>
                 <a:latin typeface="Century Gothic"/>
               </a:rPr>
-              <a:t>Get explanation statistics</a:t>
+              <a:t>Get explanation statistics (Anchor and substructure occurrence)</a:t>
             </a:r>
           </a:p>
           <a:p>
@@ -12874,7 +12884,7 @@
                 </a:solidFill>
                 <a:latin typeface="Century Gothic"/>
               </a:rPr>
-              <a:t>Display explanation mapping</a:t>
+              <a:t>Global explanations also available</a:t>
             </a:r>
           </a:p>
           <a:p>
@@ -13145,7 +13155,16 @@
                 </a:solidFill>
                 <a:latin typeface="Century Gothic"/>
               </a:rPr>
-              <a:t>To do list</a:t>
+              <a:t>Exemplary answer output </a:t>
+            </a:r>
+            <a:r>
+              <a:rPr lang="en-US" sz="3200" b="0" strike="noStrike" spc="-1" dirty="0" err="1">
+                <a:solidFill>
+                  <a:srgbClr val="0064C8"/>
+                </a:solidFill>
+                <a:latin typeface="Century Gothic"/>
+              </a:rPr>
+              <a:t>MolCE</a:t>
             </a:r>
             <a:endParaRPr lang="en-US" sz="3200" b="0" strike="noStrike" spc="-1" dirty="0">
               <a:solidFill>
@@ -13228,8 +13247,8 @@
         </p:nvSpPr>
         <p:spPr>
           <a:xfrm>
-            <a:off x="380880" y="1371598"/>
-            <a:ext cx="8109070" cy="4559301"/>
+            <a:off x="374530" y="1371598"/>
+            <a:ext cx="3556120" cy="4559301"/>
           </a:xfrm>
           <a:prstGeom prst="rect">
             <a:avLst/>
@@ -13428,43 +13447,7 @@
                 </a:solidFill>
                 <a:latin typeface="Century Gothic"/>
               </a:rPr>
-              <a:t>Add and properly implement missing XAI methods (</a:t>
-            </a:r>
-            <a:r>
-              <a:rPr lang="en-US" sz="2000" spc="-1" dirty="0" err="1">
-                <a:solidFill>
-                  <a:srgbClr val="000000"/>
-                </a:solidFill>
-                <a:latin typeface="Century Gothic"/>
-              </a:rPr>
-              <a:t>MolCE</a:t>
-            </a:r>
-            <a:r>
-              <a:rPr lang="en-US" sz="2000" spc="-1" dirty="0">
-                <a:solidFill>
-                  <a:srgbClr val="000000"/>
-                </a:solidFill>
-                <a:latin typeface="Century Gothic"/>
-              </a:rPr>
-              <a:t>, </a:t>
-            </a:r>
-            <a:r>
-              <a:rPr lang="en-US" sz="2000" spc="-1" dirty="0" err="1">
-                <a:solidFill>
-                  <a:srgbClr val="000000"/>
-                </a:solidFill>
-                <a:latin typeface="Century Gothic"/>
-              </a:rPr>
-              <a:t>EdgeSHAPer</a:t>
-            </a:r>
-            <a:r>
-              <a:rPr lang="en-US" sz="2000" spc="-1" dirty="0">
-                <a:solidFill>
-                  <a:srgbClr val="000000"/>
-                </a:solidFill>
-                <a:latin typeface="Century Gothic"/>
-              </a:rPr>
-              <a:t>, Counterfactuals)</a:t>
+              <a:t>For instances: See both substituent and scaffold foils</a:t>
             </a:r>
           </a:p>
           <a:p>
@@ -13509,51 +13492,7 @@
                 </a:solidFill>
                 <a:latin typeface="Century Gothic"/>
               </a:rPr>
-              <a:t>Integrate with cluster for faster inference and explore larger LLMs</a:t>
-            </a:r>
-          </a:p>
-          <a:p>
-            <a:pPr marL="0" indent="0">
-              <a:lnSpc>
-                <a:spcPct val="100000"/>
-              </a:lnSpc>
-              <a:spcBef>
-                <a:spcPts val="400"/>
-              </a:spcBef>
-              <a:buClr>
-                <a:srgbClr val="0064C8"/>
-              </a:buClr>
-              <a:buNone/>
-            </a:pPr>
-            <a:endParaRPr lang="en-US" sz="2000" spc="-1" dirty="0">
-              <a:solidFill>
-                <a:srgbClr val="000000"/>
-              </a:solidFill>
-              <a:latin typeface="Century Gothic"/>
-            </a:endParaRPr>
-          </a:p>
-          <a:p>
-            <a:pPr>
-              <a:lnSpc>
-                <a:spcPct val="100000"/>
-              </a:lnSpc>
-              <a:spcBef>
-                <a:spcPts val="400"/>
-              </a:spcBef>
-              <a:buClr>
-                <a:srgbClr val="0064C8"/>
-              </a:buClr>
-              <a:buFont typeface="Wingdings" panose="05000000000000000000" pitchFamily="2" charset="2"/>
-              <a:buChar char="§"/>
-            </a:pPr>
-            <a:r>
-              <a:rPr lang="en-US" sz="2000" spc="-1" dirty="0">
-                <a:solidFill>
-                  <a:srgbClr val="000000"/>
-                </a:solidFill>
-                <a:latin typeface="Century Gothic"/>
-              </a:rPr>
-              <a:t>Clean up the repository and make it available </a:t>
+              <a:t>Get explanation statistics (occurrence, contrastive score)</a:t>
             </a:r>
           </a:p>
           <a:p>
@@ -13578,7 +13517,7 @@
             </a:endParaRPr>
           </a:p>
           <a:p>
-            <a:pPr lvl="1">
+            <a:pPr>
               <a:lnSpc>
                 <a:spcPct val="100000"/>
               </a:lnSpc>
@@ -13592,13 +13531,13 @@
               <a:buChar char="§"/>
             </a:pPr>
             <a:r>
-              <a:rPr lang="en-US" sz="1600" spc="-1" dirty="0">
+              <a:rPr lang="en-US" sz="2000" spc="-1" dirty="0">
                 <a:solidFill>
                   <a:srgbClr val="000000"/>
                 </a:solidFill>
                 <a:latin typeface="Century Gothic"/>
               </a:rPr>
-              <a:t>An “organization repository” is available for the whole lab to ease the integration of new components</a:t>
+              <a:t>Global explanations also available</a:t>
             </a:r>
           </a:p>
           <a:p>
@@ -13643,7 +13582,7 @@
                 </a:solidFill>
                 <a:latin typeface="Century Gothic"/>
               </a:rPr>
-              <a:t>Make a guide for lab members for the implementation of AI agents</a:t>
+              <a:t>Rationalize explanations (LLM)</a:t>
             </a:r>
           </a:p>
           <a:p>
@@ -13714,23 +13653,83 @@
           </a:p>
         </p:txBody>
       </p:sp>
+      <p:pic>
+        <p:nvPicPr>
+          <p:cNvPr id="4" name="Picture 3">
+            <a:extLst>
+              <a:ext uri="{FF2B5EF4-FFF2-40B4-BE49-F238E27FC236}">
+                <a16:creationId xmlns:a16="http://schemas.microsoft.com/office/drawing/2014/main" id="{A6448BF6-C81C-6C8D-8F4B-2F0B75A53E81}"/>
+              </a:ext>
+            </a:extLst>
+          </p:cNvPr>
+          <p:cNvPicPr>
+            <a:picLocks noChangeAspect="1"/>
+          </p:cNvPicPr>
+          <p:nvPr/>
+        </p:nvPicPr>
+        <p:blipFill>
+          <a:blip r:embed="rId2"/>
+          <a:stretch>
+            <a:fillRect/>
+          </a:stretch>
+        </p:blipFill>
+        <p:spPr>
+          <a:xfrm>
+            <a:off x="4343622" y="990120"/>
+            <a:ext cx="4557038" cy="3008146"/>
+          </a:xfrm>
+          <a:prstGeom prst="rect">
+            <a:avLst/>
+          </a:prstGeom>
+        </p:spPr>
+      </p:pic>
+      <p:pic>
+        <p:nvPicPr>
+          <p:cNvPr id="8" name="Picture 7">
+            <a:extLst>
+              <a:ext uri="{FF2B5EF4-FFF2-40B4-BE49-F238E27FC236}">
+                <a16:creationId xmlns:a16="http://schemas.microsoft.com/office/drawing/2014/main" id="{F267D0B5-80AA-A015-D6E0-17D1621B9965}"/>
+              </a:ext>
+            </a:extLst>
+          </p:cNvPr>
+          <p:cNvPicPr>
+            <a:picLocks noChangeAspect="1"/>
+          </p:cNvPicPr>
+          <p:nvPr/>
+        </p:nvPicPr>
+        <p:blipFill>
+          <a:blip r:embed="rId3"/>
+          <a:stretch>
+            <a:fillRect/>
+          </a:stretch>
+        </p:blipFill>
+        <p:spPr>
+          <a:xfrm>
+            <a:off x="4343622" y="3998266"/>
+            <a:ext cx="4557038" cy="2149192"/>
+          </a:xfrm>
+          <a:prstGeom prst="rect">
+            <a:avLst/>
+          </a:prstGeom>
+        </p:spPr>
+      </p:pic>
     </p:spTree>
     <p:extLst>
       <p:ext uri="{BB962C8B-B14F-4D97-AF65-F5344CB8AC3E}">
-        <p14:creationId xmlns:p14="http://schemas.microsoft.com/office/powerpoint/2010/main" val="3727029337"/>
+        <p14:creationId xmlns:p14="http://schemas.microsoft.com/office/powerpoint/2010/main" val="755729670"/>
       </p:ext>
     </p:extLst>
   </p:cSld>
   <p:clrMapOvr>
     <a:masterClrMapping/>
   </p:clrMapOvr>
-  <mc:AlternateContent xmlns:mc="http://schemas.openxmlformats.org/markup-compatibility/2006" xmlns:p14="http://schemas.microsoft.com/office/powerpoint/2010/main">
-    <mc:Choice Requires="p14">
+  <mc:AlternateContent xmlns:mc="http://schemas.openxmlformats.org/markup-compatibility/2006">
+    <mc:Choice xmlns:p14="http://schemas.microsoft.com/office/powerpoint/2010/main" Requires="p14">
       <p:transition spd="med" p14:dur="700">
         <p:fade/>
       </p:transition>
     </mc:Choice>
-    <mc:Fallback xmlns="">
+    <mc:Fallback>
       <p:transition spd="med">
         <p:fade/>
       </p:transition>
@@ -13810,7 +13809,7 @@
                 </a:solidFill>
                 <a:latin typeface="Century Gothic"/>
               </a:rPr>
-              <a:t>Framing</a:t>
+              <a:t>To do list</a:t>
             </a:r>
             <a:endParaRPr lang="en-US" sz="3200" b="0" strike="noStrike" spc="-1" dirty="0">
               <a:solidFill>
@@ -13870,6 +13869,653 @@
                 <a:latin typeface="Century Gothic"/>
               </a:rPr>
               <a:t>8</a:t>
+            </a:fld>
+            <a:endParaRPr lang="en-GB" sz="1200" b="0" strike="noStrike" spc="-1" dirty="0">
+              <a:latin typeface="Times New Roman"/>
+            </a:endParaRPr>
+          </a:p>
+        </p:txBody>
+      </p:sp>
+      <p:sp>
+        <p:nvSpPr>
+          <p:cNvPr id="7" name="PlaceHolder 2">
+            <a:extLst>
+              <a:ext uri="{FF2B5EF4-FFF2-40B4-BE49-F238E27FC236}">
+                <a16:creationId xmlns:a16="http://schemas.microsoft.com/office/drawing/2014/main" id="{66DE14D4-64D4-6D1F-DD92-BC16D674C58B}"/>
+              </a:ext>
+            </a:extLst>
+          </p:cNvPr>
+          <p:cNvSpPr txBox="1">
+            <a:spLocks/>
+          </p:cNvSpPr>
+          <p:nvPr/>
+        </p:nvSpPr>
+        <p:spPr>
+          <a:xfrm>
+            <a:off x="380880" y="1371598"/>
+            <a:ext cx="8109070" cy="4559301"/>
+          </a:xfrm>
+          <a:prstGeom prst="rect">
+            <a:avLst/>
+          </a:prstGeom>
+          <a:noFill/>
+          <a:ln w="0">
+            <a:noFill/>
+          </a:ln>
+        </p:spPr>
+        <p:txBody>
+          <a:bodyPr numCol="1" spcCol="0" anchor="t">
+            <a:noAutofit/>
+          </a:bodyPr>
+          <a:lstStyle>
+            <a:lvl1pPr marL="228600" indent="-228600" algn="l" defTabSz="914400" rtl="0" eaLnBrk="1" latinLnBrk="0" hangingPunct="1">
+              <a:lnSpc>
+                <a:spcPct val="90000"/>
+              </a:lnSpc>
+              <a:spcBef>
+                <a:spcPts val="1000"/>
+              </a:spcBef>
+              <a:buFont typeface="Arial" panose="020B0604020202020204" pitchFamily="34" charset="0"/>
+              <a:buChar char="•"/>
+              <a:defRPr sz="2800" kern="1200">
+                <a:solidFill>
+                  <a:schemeClr val="tx1"/>
+                </a:solidFill>
+                <a:latin typeface="+mn-lt"/>
+                <a:ea typeface="+mn-ea"/>
+                <a:cs typeface="+mn-cs"/>
+              </a:defRPr>
+            </a:lvl1pPr>
+            <a:lvl2pPr marL="685800" indent="-228600" algn="l" defTabSz="914400" rtl="0" eaLnBrk="1" latinLnBrk="0" hangingPunct="1">
+              <a:lnSpc>
+                <a:spcPct val="90000"/>
+              </a:lnSpc>
+              <a:spcBef>
+                <a:spcPts val="500"/>
+              </a:spcBef>
+              <a:buFont typeface="Arial" panose="020B0604020202020204" pitchFamily="34" charset="0"/>
+              <a:buChar char="•"/>
+              <a:defRPr sz="2400" kern="1200">
+                <a:solidFill>
+                  <a:schemeClr val="tx1"/>
+                </a:solidFill>
+                <a:latin typeface="+mn-lt"/>
+                <a:ea typeface="+mn-ea"/>
+                <a:cs typeface="+mn-cs"/>
+              </a:defRPr>
+            </a:lvl2pPr>
+            <a:lvl3pPr marL="1143000" indent="-228600" algn="l" defTabSz="914400" rtl="0" eaLnBrk="1" latinLnBrk="0" hangingPunct="1">
+              <a:lnSpc>
+                <a:spcPct val="90000"/>
+              </a:lnSpc>
+              <a:spcBef>
+                <a:spcPts val="500"/>
+              </a:spcBef>
+              <a:buFont typeface="Arial" panose="020B0604020202020204" pitchFamily="34" charset="0"/>
+              <a:buChar char="•"/>
+              <a:defRPr sz="2000" kern="1200">
+                <a:solidFill>
+                  <a:schemeClr val="tx1"/>
+                </a:solidFill>
+                <a:latin typeface="+mn-lt"/>
+                <a:ea typeface="+mn-ea"/>
+                <a:cs typeface="+mn-cs"/>
+              </a:defRPr>
+            </a:lvl3pPr>
+            <a:lvl4pPr marL="1600200" indent="-228600" algn="l" defTabSz="914400" rtl="0" eaLnBrk="1" latinLnBrk="0" hangingPunct="1">
+              <a:lnSpc>
+                <a:spcPct val="90000"/>
+              </a:lnSpc>
+              <a:spcBef>
+                <a:spcPts val="500"/>
+              </a:spcBef>
+              <a:buFont typeface="Arial" panose="020B0604020202020204" pitchFamily="34" charset="0"/>
+              <a:buChar char="•"/>
+              <a:defRPr sz="1800" kern="1200">
+                <a:solidFill>
+                  <a:schemeClr val="tx1"/>
+                </a:solidFill>
+                <a:latin typeface="+mn-lt"/>
+                <a:ea typeface="+mn-ea"/>
+                <a:cs typeface="+mn-cs"/>
+              </a:defRPr>
+            </a:lvl4pPr>
+            <a:lvl5pPr marL="2057400" indent="-228600" algn="l" defTabSz="914400" rtl="0" eaLnBrk="1" latinLnBrk="0" hangingPunct="1">
+              <a:lnSpc>
+                <a:spcPct val="90000"/>
+              </a:lnSpc>
+              <a:spcBef>
+                <a:spcPts val="500"/>
+              </a:spcBef>
+              <a:buFont typeface="Arial" panose="020B0604020202020204" pitchFamily="34" charset="0"/>
+              <a:buChar char="•"/>
+              <a:defRPr sz="1800" kern="1200">
+                <a:solidFill>
+                  <a:schemeClr val="tx1"/>
+                </a:solidFill>
+                <a:latin typeface="+mn-lt"/>
+                <a:ea typeface="+mn-ea"/>
+                <a:cs typeface="+mn-cs"/>
+              </a:defRPr>
+            </a:lvl5pPr>
+            <a:lvl6pPr marL="2514600" indent="-228600" algn="l" defTabSz="914400" rtl="0" eaLnBrk="1" latinLnBrk="0" hangingPunct="1">
+              <a:lnSpc>
+                <a:spcPct val="90000"/>
+              </a:lnSpc>
+              <a:spcBef>
+                <a:spcPts val="500"/>
+              </a:spcBef>
+              <a:buFont typeface="Arial" panose="020B0604020202020204" pitchFamily="34" charset="0"/>
+              <a:buChar char="•"/>
+              <a:defRPr sz="1800" kern="1200">
+                <a:solidFill>
+                  <a:schemeClr val="tx1"/>
+                </a:solidFill>
+                <a:latin typeface="+mn-lt"/>
+                <a:ea typeface="+mn-ea"/>
+                <a:cs typeface="+mn-cs"/>
+              </a:defRPr>
+            </a:lvl6pPr>
+            <a:lvl7pPr marL="2971800" indent="-228600" algn="l" defTabSz="914400" rtl="0" eaLnBrk="1" latinLnBrk="0" hangingPunct="1">
+              <a:lnSpc>
+                <a:spcPct val="90000"/>
+              </a:lnSpc>
+              <a:spcBef>
+                <a:spcPts val="500"/>
+              </a:spcBef>
+              <a:buFont typeface="Arial" panose="020B0604020202020204" pitchFamily="34" charset="0"/>
+              <a:buChar char="•"/>
+              <a:defRPr sz="1800" kern="1200">
+                <a:solidFill>
+                  <a:schemeClr val="tx1"/>
+                </a:solidFill>
+                <a:latin typeface="+mn-lt"/>
+                <a:ea typeface="+mn-ea"/>
+                <a:cs typeface="+mn-cs"/>
+              </a:defRPr>
+            </a:lvl7pPr>
+            <a:lvl8pPr marL="3429000" indent="-228600" algn="l" defTabSz="914400" rtl="0" eaLnBrk="1" latinLnBrk="0" hangingPunct="1">
+              <a:lnSpc>
+                <a:spcPct val="90000"/>
+              </a:lnSpc>
+              <a:spcBef>
+                <a:spcPts val="500"/>
+              </a:spcBef>
+              <a:buFont typeface="Arial" panose="020B0604020202020204" pitchFamily="34" charset="0"/>
+              <a:buChar char="•"/>
+              <a:defRPr sz="1800" kern="1200">
+                <a:solidFill>
+                  <a:schemeClr val="tx1"/>
+                </a:solidFill>
+                <a:latin typeface="+mn-lt"/>
+                <a:ea typeface="+mn-ea"/>
+                <a:cs typeface="+mn-cs"/>
+              </a:defRPr>
+            </a:lvl8pPr>
+            <a:lvl9pPr marL="3886200" indent="-228600" algn="l" defTabSz="914400" rtl="0" eaLnBrk="1" latinLnBrk="0" hangingPunct="1">
+              <a:lnSpc>
+                <a:spcPct val="90000"/>
+              </a:lnSpc>
+              <a:spcBef>
+                <a:spcPts val="500"/>
+              </a:spcBef>
+              <a:buFont typeface="Arial" panose="020B0604020202020204" pitchFamily="34" charset="0"/>
+              <a:buChar char="•"/>
+              <a:defRPr sz="1800" kern="1200">
+                <a:solidFill>
+                  <a:schemeClr val="tx1"/>
+                </a:solidFill>
+                <a:latin typeface="+mn-lt"/>
+                <a:ea typeface="+mn-ea"/>
+                <a:cs typeface="+mn-cs"/>
+              </a:defRPr>
+            </a:lvl9pPr>
+          </a:lstStyle>
+          <a:p>
+            <a:pPr>
+              <a:lnSpc>
+                <a:spcPct val="100000"/>
+              </a:lnSpc>
+              <a:spcBef>
+                <a:spcPts val="400"/>
+              </a:spcBef>
+              <a:buClr>
+                <a:srgbClr val="0064C8"/>
+              </a:buClr>
+              <a:buFont typeface="Wingdings" panose="05000000000000000000" pitchFamily="2" charset="2"/>
+              <a:buChar char="§"/>
+            </a:pPr>
+            <a:r>
+              <a:rPr lang="en-US" sz="2000" spc="-1" dirty="0">
+                <a:solidFill>
+                  <a:srgbClr val="000000"/>
+                </a:solidFill>
+                <a:latin typeface="Century Gothic"/>
+              </a:rPr>
+              <a:t>Add and properly implement missing XAI methods (</a:t>
+            </a:r>
+            <a:r>
+              <a:rPr lang="en-US" sz="2000" spc="-1" dirty="0" err="1">
+                <a:solidFill>
+                  <a:srgbClr val="000000"/>
+                </a:solidFill>
+                <a:latin typeface="Century Gothic"/>
+              </a:rPr>
+              <a:t>EdgeSHAPer</a:t>
+            </a:r>
+            <a:r>
+              <a:rPr lang="en-US" sz="2000" spc="-1" dirty="0">
+                <a:solidFill>
+                  <a:srgbClr val="000000"/>
+                </a:solidFill>
+                <a:latin typeface="Century Gothic"/>
+              </a:rPr>
+              <a:t> and Counterfactuals)</a:t>
+            </a:r>
+          </a:p>
+          <a:p>
+            <a:pPr>
+              <a:lnSpc>
+                <a:spcPct val="100000"/>
+              </a:lnSpc>
+              <a:spcBef>
+                <a:spcPts val="400"/>
+              </a:spcBef>
+              <a:buClr>
+                <a:srgbClr val="0064C8"/>
+              </a:buClr>
+              <a:buFont typeface="Wingdings" panose="05000000000000000000" pitchFamily="2" charset="2"/>
+              <a:buChar char="§"/>
+            </a:pPr>
+            <a:endParaRPr lang="en-US" sz="2000" spc="-1" dirty="0">
+              <a:solidFill>
+                <a:srgbClr val="000000"/>
+              </a:solidFill>
+              <a:latin typeface="Century Gothic"/>
+            </a:endParaRPr>
+          </a:p>
+          <a:p>
+            <a:pPr>
+              <a:lnSpc>
+                <a:spcPct val="100000"/>
+              </a:lnSpc>
+              <a:spcBef>
+                <a:spcPts val="400"/>
+              </a:spcBef>
+              <a:buClr>
+                <a:srgbClr val="0064C8"/>
+              </a:buClr>
+              <a:buFont typeface="Wingdings" panose="05000000000000000000" pitchFamily="2" charset="2"/>
+              <a:buChar char="§"/>
+            </a:pPr>
+            <a:r>
+              <a:rPr lang="en-US" sz="2000" spc="-1" dirty="0">
+                <a:solidFill>
+                  <a:srgbClr val="000000"/>
+                </a:solidFill>
+                <a:latin typeface="Century Gothic"/>
+              </a:rPr>
+              <a:t>Integrate with cluster for faster inference and explore larger LLMs</a:t>
+            </a:r>
+          </a:p>
+          <a:p>
+            <a:pPr marL="0" indent="0">
+              <a:lnSpc>
+                <a:spcPct val="100000"/>
+              </a:lnSpc>
+              <a:spcBef>
+                <a:spcPts val="400"/>
+              </a:spcBef>
+              <a:buClr>
+                <a:srgbClr val="0064C8"/>
+              </a:buClr>
+              <a:buNone/>
+            </a:pPr>
+            <a:endParaRPr lang="en-US" sz="2000" spc="-1" dirty="0">
+              <a:solidFill>
+                <a:srgbClr val="000000"/>
+              </a:solidFill>
+              <a:latin typeface="Century Gothic"/>
+            </a:endParaRPr>
+          </a:p>
+          <a:p>
+            <a:pPr>
+              <a:lnSpc>
+                <a:spcPct val="100000"/>
+              </a:lnSpc>
+              <a:spcBef>
+                <a:spcPts val="400"/>
+              </a:spcBef>
+              <a:buClr>
+                <a:srgbClr val="0064C8"/>
+              </a:buClr>
+              <a:buFont typeface="Wingdings" panose="05000000000000000000" pitchFamily="2" charset="2"/>
+              <a:buChar char="§"/>
+            </a:pPr>
+            <a:r>
+              <a:rPr lang="en-US" sz="2000" spc="-1" dirty="0">
+                <a:solidFill>
+                  <a:srgbClr val="000000"/>
+                </a:solidFill>
+                <a:latin typeface="Century Gothic"/>
+              </a:rPr>
+              <a:t>Clean up the repository and make it available </a:t>
+            </a:r>
+          </a:p>
+          <a:p>
+            <a:pPr>
+              <a:lnSpc>
+                <a:spcPct val="100000"/>
+              </a:lnSpc>
+              <a:spcBef>
+                <a:spcPts val="400"/>
+              </a:spcBef>
+              <a:buClr>
+                <a:srgbClr val="0064C8"/>
+              </a:buClr>
+              <a:buFont typeface="Wingdings" panose="05000000000000000000" pitchFamily="2" charset="2"/>
+              <a:buChar char="§"/>
+            </a:pPr>
+            <a:endParaRPr lang="en-US" sz="2000" spc="-1" dirty="0">
+              <a:solidFill>
+                <a:srgbClr val="000000"/>
+              </a:solidFill>
+              <a:latin typeface="Century Gothic"/>
+            </a:endParaRPr>
+          </a:p>
+          <a:p>
+            <a:pPr lvl="1">
+              <a:lnSpc>
+                <a:spcPct val="100000"/>
+              </a:lnSpc>
+              <a:spcBef>
+                <a:spcPts val="400"/>
+              </a:spcBef>
+              <a:buClr>
+                <a:srgbClr val="0064C8"/>
+              </a:buClr>
+              <a:buFont typeface="Wingdings" panose="05000000000000000000" pitchFamily="2" charset="2"/>
+              <a:buChar char="§"/>
+            </a:pPr>
+            <a:r>
+              <a:rPr lang="en-US" sz="1600" spc="-1" dirty="0">
+                <a:solidFill>
+                  <a:srgbClr val="000000"/>
+                </a:solidFill>
+                <a:latin typeface="Century Gothic"/>
+              </a:rPr>
+              <a:t>An “organization repository” is available for the whole lab to ease the integration of new components</a:t>
+            </a:r>
+          </a:p>
+          <a:p>
+            <a:pPr>
+              <a:lnSpc>
+                <a:spcPct val="100000"/>
+              </a:lnSpc>
+              <a:spcBef>
+                <a:spcPts val="400"/>
+              </a:spcBef>
+              <a:buClr>
+                <a:srgbClr val="0064C8"/>
+              </a:buClr>
+              <a:buFont typeface="Wingdings" panose="05000000000000000000" pitchFamily="2" charset="2"/>
+              <a:buChar char="§"/>
+            </a:pPr>
+            <a:endParaRPr lang="en-US" sz="2000" spc="-1" dirty="0">
+              <a:solidFill>
+                <a:srgbClr val="000000"/>
+              </a:solidFill>
+              <a:latin typeface="Century Gothic"/>
+            </a:endParaRPr>
+          </a:p>
+          <a:p>
+            <a:pPr>
+              <a:lnSpc>
+                <a:spcPct val="100000"/>
+              </a:lnSpc>
+              <a:spcBef>
+                <a:spcPts val="400"/>
+              </a:spcBef>
+              <a:buClr>
+                <a:srgbClr val="0064C8"/>
+              </a:buClr>
+              <a:buFont typeface="Wingdings" panose="05000000000000000000" pitchFamily="2" charset="2"/>
+              <a:buChar char="§"/>
+            </a:pPr>
+            <a:r>
+              <a:rPr lang="en-US" sz="2000" spc="-1" dirty="0">
+                <a:solidFill>
+                  <a:srgbClr val="000000"/>
+                </a:solidFill>
+                <a:latin typeface="Century Gothic"/>
+              </a:rPr>
+              <a:t>Make a guide for lab members for the implementation of AI agents</a:t>
+            </a:r>
+          </a:p>
+          <a:p>
+            <a:pPr>
+              <a:lnSpc>
+                <a:spcPct val="100000"/>
+              </a:lnSpc>
+              <a:spcBef>
+                <a:spcPts val="400"/>
+              </a:spcBef>
+              <a:buClr>
+                <a:srgbClr val="0064C8"/>
+              </a:buClr>
+              <a:buFont typeface="Wingdings" panose="05000000000000000000" pitchFamily="2" charset="2"/>
+              <a:buChar char="§"/>
+            </a:pPr>
+            <a:endParaRPr lang="en-US" sz="2000" spc="-1" dirty="0">
+              <a:solidFill>
+                <a:srgbClr val="000000"/>
+              </a:solidFill>
+              <a:latin typeface="Century Gothic"/>
+            </a:endParaRPr>
+          </a:p>
+          <a:p>
+            <a:pPr>
+              <a:lnSpc>
+                <a:spcPct val="100000"/>
+              </a:lnSpc>
+              <a:spcBef>
+                <a:spcPts val="400"/>
+              </a:spcBef>
+              <a:buClr>
+                <a:srgbClr val="0064C8"/>
+              </a:buClr>
+              <a:buFont typeface="Wingdings" panose="05000000000000000000" pitchFamily="2" charset="2"/>
+              <a:buChar char="§"/>
+            </a:pPr>
+            <a:endParaRPr lang="en-US" sz="1800" spc="-1" dirty="0">
+              <a:solidFill>
+                <a:srgbClr val="000000"/>
+              </a:solidFill>
+              <a:latin typeface="Century Gothic"/>
+            </a:endParaRPr>
+          </a:p>
+          <a:p>
+            <a:pPr marL="343080" indent="-343080">
+              <a:lnSpc>
+                <a:spcPct val="100000"/>
+              </a:lnSpc>
+              <a:spcBef>
+                <a:spcPts val="400"/>
+              </a:spcBef>
+              <a:spcAft>
+                <a:spcPts val="601"/>
+              </a:spcAft>
+              <a:buClr>
+                <a:srgbClr val="0064C8"/>
+              </a:buClr>
+              <a:buFont typeface="Wingdings 2" charset="2"/>
+              <a:buChar char=""/>
+            </a:pPr>
+            <a:endParaRPr lang="en-US" sz="2000" b="1" spc="-1" dirty="0">
+              <a:solidFill>
+                <a:srgbClr val="000000"/>
+              </a:solidFill>
+              <a:latin typeface="Century Gothic"/>
+            </a:endParaRPr>
+          </a:p>
+        </p:txBody>
+      </p:sp>
+    </p:spTree>
+    <p:extLst>
+      <p:ext uri="{BB962C8B-B14F-4D97-AF65-F5344CB8AC3E}">
+        <p14:creationId xmlns:p14="http://schemas.microsoft.com/office/powerpoint/2010/main" val="3727029337"/>
+      </p:ext>
+    </p:extLst>
+  </p:cSld>
+  <p:clrMapOvr>
+    <a:masterClrMapping/>
+  </p:clrMapOvr>
+  <mc:AlternateContent xmlns:mc="http://schemas.openxmlformats.org/markup-compatibility/2006" xmlns:p14="http://schemas.microsoft.com/office/powerpoint/2010/main">
+    <mc:Choice Requires="p14">
+      <p:transition spd="med" p14:dur="700">
+        <p:fade/>
+      </p:transition>
+    </mc:Choice>
+    <mc:Fallback xmlns="">
+      <p:transition spd="med">
+        <p:fade/>
+      </p:transition>
+    </mc:Fallback>
+  </mc:AlternateContent>
+</p:sld>
+</file>
+
+<file path=ppt/slides/slide9.xml><?xml version="1.0" encoding="utf-8"?>
+<p:sld xmlns:a="http://schemas.openxmlformats.org/drawingml/2006/main" xmlns:r="http://schemas.openxmlformats.org/officeDocument/2006/relationships" xmlns:p="http://schemas.openxmlformats.org/presentationml/2006/main">
+  <p:cSld>
+    <p:spTree>
+      <p:nvGrpSpPr>
+        <p:cNvPr id="1" name="">
+          <a:extLst>
+            <a:ext uri="{FF2B5EF4-FFF2-40B4-BE49-F238E27FC236}">
+              <a16:creationId xmlns:a16="http://schemas.microsoft.com/office/drawing/2014/main" id="{A6515F23-0912-A838-23CE-B8F00573A2DA}"/>
+            </a:ext>
+          </a:extLst>
+        </p:cNvPr>
+        <p:cNvGrpSpPr/>
+        <p:nvPr/>
+      </p:nvGrpSpPr>
+      <p:grpSpPr>
+        <a:xfrm>
+          <a:off x="0" y="0"/>
+          <a:ext cx="0" cy="0"/>
+          <a:chOff x="0" y="0"/>
+          <a:chExt cx="0" cy="0"/>
+        </a:xfrm>
+      </p:grpSpPr>
+      <p:sp>
+        <p:nvSpPr>
+          <p:cNvPr id="163" name="PlaceHolder 1">
+            <a:extLst>
+              <a:ext uri="{FF2B5EF4-FFF2-40B4-BE49-F238E27FC236}">
+                <a16:creationId xmlns:a16="http://schemas.microsoft.com/office/drawing/2014/main" id="{57944F4B-F502-E7CC-8790-8737702BC6AC}"/>
+              </a:ext>
+            </a:extLst>
+          </p:cNvPr>
+          <p:cNvSpPr>
+            <a:spLocks noGrp="1"/>
+          </p:cNvSpPr>
+          <p:nvPr>
+            <p:ph type="title"/>
+          </p:nvPr>
+        </p:nvSpPr>
+        <p:spPr>
+          <a:xfrm>
+            <a:off x="380880" y="228600"/>
+            <a:ext cx="8380080" cy="837720"/>
+          </a:xfrm>
+          <a:prstGeom prst="rect">
+            <a:avLst/>
+          </a:prstGeom>
+          <a:noFill/>
+          <a:ln w="0">
+            <a:noFill/>
+          </a:ln>
+        </p:spPr>
+        <p:txBody>
+          <a:bodyPr numCol="1" spcCol="0" anchor="ctr">
+            <a:noAutofit/>
+          </a:bodyPr>
+          <a:lstStyle/>
+          <a:p>
+            <a:pPr>
+              <a:lnSpc>
+                <a:spcPct val="100000"/>
+              </a:lnSpc>
+              <a:buNone/>
+            </a:pPr>
+            <a:r>
+              <a:rPr lang="en-US" sz="3200" b="0" strike="noStrike" spc="-1" dirty="0">
+                <a:solidFill>
+                  <a:srgbClr val="0064C8"/>
+                </a:solidFill>
+                <a:latin typeface="Century Gothic"/>
+              </a:rPr>
+              <a:t>Framing</a:t>
+            </a:r>
+            <a:endParaRPr lang="en-US" sz="3200" b="0" strike="noStrike" spc="-1" dirty="0">
+              <a:solidFill>
+                <a:srgbClr val="000000"/>
+              </a:solidFill>
+              <a:latin typeface="Century Gothic"/>
+            </a:endParaRPr>
+          </a:p>
+        </p:txBody>
+      </p:sp>
+      <p:sp>
+        <p:nvSpPr>
+          <p:cNvPr id="165" name="PlaceHolder 3">
+            <a:extLst>
+              <a:ext uri="{FF2B5EF4-FFF2-40B4-BE49-F238E27FC236}">
+                <a16:creationId xmlns:a16="http://schemas.microsoft.com/office/drawing/2014/main" id="{2EFBEA53-7B78-D9A1-93EF-9608A3193D27}"/>
+              </a:ext>
+            </a:extLst>
+          </p:cNvPr>
+          <p:cNvSpPr>
+            <a:spLocks noGrp="1"/>
+          </p:cNvSpPr>
+          <p:nvPr>
+            <p:ph type="sldNum"/>
+          </p:nvPr>
+        </p:nvSpPr>
+        <p:spPr>
+          <a:xfrm>
+            <a:off x="8376840" y="5692680"/>
+            <a:ext cx="384120" cy="364680"/>
+          </a:xfrm>
+          <a:prstGeom prst="rect">
+            <a:avLst/>
+          </a:prstGeom>
+          <a:noFill/>
+          <a:ln w="0">
+            <a:noFill/>
+          </a:ln>
+        </p:spPr>
+        <p:txBody>
+          <a:bodyPr anchor="ctr">
+            <a:noAutofit/>
+          </a:bodyPr>
+          <a:lstStyle/>
+          <a:p>
+            <a:pPr algn="r">
+              <a:lnSpc>
+                <a:spcPct val="100000"/>
+              </a:lnSpc>
+              <a:buNone/>
+            </a:pPr>
+            <a:fld id="{8BD7C522-1E12-40C3-B25E-5F0462E20B22}" type="slidenum">
+              <a:rPr lang="en-US" sz="1200" b="0" strike="noStrike" spc="-1">
+                <a:solidFill>
+                  <a:srgbClr val="8B8B8B"/>
+                </a:solidFill>
+                <a:latin typeface="Century Gothic"/>
+              </a:rPr>
+              <a:t>9</a:t>
             </a:fld>
             <a:endParaRPr lang="en-GB" sz="1200" b="0" strike="noStrike" spc="-1" dirty="0">
               <a:latin typeface="Times New Roman"/>

</xml_diff>

<commit_message>
Update presentation slides for AI Agent Explainability and related figures
</commit_message>
<xml_diff>
--- a/slides/AI_Agent_Explainability.pptx
+++ b/slides/AI_Agent_Explainability.pptx
@@ -130,13 +130,6 @@
       <pc:docMkLst>
         <pc:docMk/>
       </pc:docMkLst>
-      <pc:sldChg chg="del">
-        <pc:chgData name="Tiago Janela" userId="ee1a79fe-c79c-4f34-9602-7f6f2f0482b3" providerId="ADAL" clId="{67D2C233-DF3C-4C6D-9040-D7553E3BCB8A}" dt="2026-03-16T14:02:41.446" v="6" actId="47"/>
-        <pc:sldMkLst>
-          <pc:docMk/>
-          <pc:sldMk cId="901468915" sldId="296"/>
-        </pc:sldMkLst>
-      </pc:sldChg>
       <pc:sldChg chg="modSp mod">
         <pc:chgData name="Tiago Janela" userId="ee1a79fe-c79c-4f34-9602-7f6f2f0482b3" providerId="ADAL" clId="{67D2C233-DF3C-4C6D-9040-D7553E3BCB8A}" dt="2026-03-16T14:03:02.466" v="54" actId="20577"/>
         <pc:sldMkLst>
@@ -167,40 +160,29 @@
           </ac:spMkLst>
         </pc:spChg>
       </pc:sldChg>
-      <pc:sldChg chg="del">
-        <pc:chgData name="Tiago Janela" userId="ee1a79fe-c79c-4f34-9602-7f6f2f0482b3" providerId="ADAL" clId="{67D2C233-DF3C-4C6D-9040-D7553E3BCB8A}" dt="2026-03-16T14:02:36.535" v="1" actId="47"/>
+    </pc:docChg>
+  </pc:docChgLst>
+  <pc:docChgLst>
+    <pc:chgData name="Tiago Janela" userId="ee1a79fe-c79c-4f34-9602-7f6f2f0482b3" providerId="ADAL" clId="{A1A622BE-A8AD-47B7-8802-BAC61BCE5126}"/>
+    <pc:docChg chg="undo custSel modSld">
+      <pc:chgData name="Tiago Janela" userId="ee1a79fe-c79c-4f34-9602-7f6f2f0482b3" providerId="ADAL" clId="{A1A622BE-A8AD-47B7-8802-BAC61BCE5126}" dt="2026-04-02T12:40:40.607" v="50" actId="478"/>
+      <pc:docMkLst>
+        <pc:docMk/>
+      </pc:docMkLst>
+      <pc:sldChg chg="addSp delSp modSp mod">
+        <pc:chgData name="Tiago Janela" userId="ee1a79fe-c79c-4f34-9602-7f6f2f0482b3" providerId="ADAL" clId="{A1A622BE-A8AD-47B7-8802-BAC61BCE5126}" dt="2026-04-02T12:40:40.607" v="50" actId="478"/>
         <pc:sldMkLst>
           <pc:docMk/>
-          <pc:sldMk cId="114778141" sldId="303"/>
+          <pc:sldMk cId="1707478755" sldId="299"/>
         </pc:sldMkLst>
-      </pc:sldChg>
-      <pc:sldChg chg="del">
-        <pc:chgData name="Tiago Janela" userId="ee1a79fe-c79c-4f34-9602-7f6f2f0482b3" providerId="ADAL" clId="{67D2C233-DF3C-4C6D-9040-D7553E3BCB8A}" dt="2026-03-16T14:02:37.693" v="2" actId="47"/>
-        <pc:sldMkLst>
-          <pc:docMk/>
-          <pc:sldMk cId="1211845523" sldId="306"/>
-        </pc:sldMkLst>
-      </pc:sldChg>
-      <pc:sldChg chg="del">
-        <pc:chgData name="Tiago Janela" userId="ee1a79fe-c79c-4f34-9602-7f6f2f0482b3" providerId="ADAL" clId="{67D2C233-DF3C-4C6D-9040-D7553E3BCB8A}" dt="2026-03-16T14:02:37.999" v="3" actId="47"/>
-        <pc:sldMkLst>
-          <pc:docMk/>
-          <pc:sldMk cId="4258501269" sldId="307"/>
-        </pc:sldMkLst>
-      </pc:sldChg>
-      <pc:sldChg chg="del">
-        <pc:chgData name="Tiago Janela" userId="ee1a79fe-c79c-4f34-9602-7f6f2f0482b3" providerId="ADAL" clId="{67D2C233-DF3C-4C6D-9040-D7553E3BCB8A}" dt="2026-03-16T14:02:38.398" v="4" actId="47"/>
-        <pc:sldMkLst>
-          <pc:docMk/>
-          <pc:sldMk cId="467547607" sldId="308"/>
-        </pc:sldMkLst>
-      </pc:sldChg>
-      <pc:sldChg chg="del">
-        <pc:chgData name="Tiago Janela" userId="ee1a79fe-c79c-4f34-9602-7f6f2f0482b3" providerId="ADAL" clId="{67D2C233-DF3C-4C6D-9040-D7553E3BCB8A}" dt="2026-03-16T14:02:38.965" v="5" actId="47"/>
-        <pc:sldMkLst>
-          <pc:docMk/>
-          <pc:sldMk cId="1772121027" sldId="311"/>
-        </pc:sldMkLst>
+        <pc:graphicFrameChg chg="add del modGraphic">
+          <ac:chgData name="Tiago Janela" userId="ee1a79fe-c79c-4f34-9602-7f6f2f0482b3" providerId="ADAL" clId="{A1A622BE-A8AD-47B7-8802-BAC61BCE5126}" dt="2026-04-02T12:40:40.607" v="50" actId="478"/>
+          <ac:graphicFrameMkLst>
+            <pc:docMk/>
+            <pc:sldMk cId="1707478755" sldId="299"/>
+            <ac:graphicFrameMk id="4" creationId="{689F2044-8E26-DCF5-DE2D-9AD979C8C1EE}"/>
+          </ac:graphicFrameMkLst>
+        </pc:graphicFrameChg>
       </pc:sldChg>
     </pc:docChg>
   </pc:docChgLst>
@@ -256,14 +238,6 @@
             <ac:spMk id="2" creationId="{870990D0-7AC5-46BA-6FC4-274F8E0A3ABE}"/>
           </ac:spMkLst>
         </pc:spChg>
-        <pc:picChg chg="del mod">
-          <ac:chgData name="Tiago Janela" userId="ee1a79fe-c79c-4f34-9602-7f6f2f0482b3" providerId="ADAL" clId="{6BE67FA1-4A27-48B9-BA6A-E25A9786A9CC}" dt="2026-03-19T10:51:55.896" v="93" actId="478"/>
-          <ac:picMkLst>
-            <pc:docMk/>
-            <pc:sldMk cId="1707478755" sldId="299"/>
-            <ac:picMk id="4" creationId="{A9172708-06AB-AE7A-4BC0-05B1328EE700}"/>
-          </ac:picMkLst>
-        </pc:picChg>
       </pc:sldChg>
       <pc:sldChg chg="addSp delSp modSp add mod">
         <pc:chgData name="Tiago Janela" userId="ee1a79fe-c79c-4f34-9602-7f6f2f0482b3" providerId="ADAL" clId="{6BE67FA1-4A27-48B9-BA6A-E25A9786A9CC}" dt="2026-03-20T13:21:59.221" v="1059" actId="20577"/>
@@ -271,14 +245,6 @@
           <pc:docMk/>
           <pc:sldMk cId="457486825" sldId="300"/>
         </pc:sldMkLst>
-        <pc:spChg chg="add del mod">
-          <ac:chgData name="Tiago Janela" userId="ee1a79fe-c79c-4f34-9602-7f6f2f0482b3" providerId="ADAL" clId="{6BE67FA1-4A27-48B9-BA6A-E25A9786A9CC}" dt="2026-03-20T13:19:05.879" v="819" actId="478"/>
-          <ac:spMkLst>
-            <pc:docMk/>
-            <pc:sldMk cId="457486825" sldId="300"/>
-            <ac:spMk id="2" creationId="{870990D0-7AC5-46BA-6FC4-274F8E0A3ABE}"/>
-          </ac:spMkLst>
-        </pc:spChg>
         <pc:spChg chg="add mod">
           <ac:chgData name="Tiago Janela" userId="ee1a79fe-c79c-4f34-9602-7f6f2f0482b3" providerId="ADAL" clId="{6BE67FA1-4A27-48B9-BA6A-E25A9786A9CC}" dt="2026-03-20T13:21:59.221" v="1059" actId="20577"/>
           <ac:spMkLst>
@@ -303,14 +269,6 @@
             <ac:picMk id="4" creationId="{0F3D5BC1-9264-881D-CF39-9525F816570A}"/>
           </ac:picMkLst>
         </pc:picChg>
-        <pc:picChg chg="add del">
-          <ac:chgData name="Tiago Janela" userId="ee1a79fe-c79c-4f34-9602-7f6f2f0482b3" providerId="ADAL" clId="{6BE67FA1-4A27-48B9-BA6A-E25A9786A9CC}" dt="2026-03-20T13:16:59.024" v="605" actId="478"/>
-          <ac:picMkLst>
-            <pc:docMk/>
-            <pc:sldMk cId="457486825" sldId="300"/>
-            <ac:picMk id="6" creationId="{D3BA145D-265C-C0B1-7C0E-2EE32552E491}"/>
-          </ac:picMkLst>
-        </pc:picChg>
       </pc:sldChg>
       <pc:sldChg chg="delSp modSp add mod ord">
         <pc:chgData name="Tiago Janela" userId="ee1a79fe-c79c-4f34-9602-7f6f2f0482b3" providerId="ADAL" clId="{6BE67FA1-4A27-48B9-BA6A-E25A9786A9CC}" dt="2026-03-20T13:52:23.099" v="1063" actId="20577"/>
@@ -326,14 +284,6 @@
             <ac:spMk id="2" creationId="{870990D0-7AC5-46BA-6FC4-274F8E0A3ABE}"/>
           </ac:spMkLst>
         </pc:spChg>
-        <pc:picChg chg="del">
-          <ac:chgData name="Tiago Janela" userId="ee1a79fe-c79c-4f34-9602-7f6f2f0482b3" providerId="ADAL" clId="{6BE67FA1-4A27-48B9-BA6A-E25A9786A9CC}" dt="2026-03-20T13:16:48.406" v="599" actId="478"/>
-          <ac:picMkLst>
-            <pc:docMk/>
-            <pc:sldMk cId="2375808848" sldId="301"/>
-            <ac:picMk id="4" creationId="{0F3D5BC1-9264-881D-CF39-9525F816570A}"/>
-          </ac:picMkLst>
-        </pc:picChg>
         <pc:picChg chg="mod">
           <ac:chgData name="Tiago Janela" userId="ee1a79fe-c79c-4f34-9602-7f6f2f0482b3" providerId="ADAL" clId="{6BE67FA1-4A27-48B9-BA6A-E25A9786A9CC}" dt="2026-03-20T13:17:16.190" v="611" actId="1076"/>
           <ac:picMkLst>
@@ -346,312 +296,12 @@
     </pc:docChg>
   </pc:docChgLst>
   <pc:docChgLst>
-    <pc:chgData name="Tiago Janela" userId="ee1a79fe-c79c-4f34-9602-7f6f2f0482b3" providerId="ADAL" clId="{0E7D8533-49DC-4BED-8D2D-C8EE6F23A854}"/>
-    <pc:docChg chg="undo custSel addSld delSld modSld sldOrd modMainMaster">
-      <pc:chgData name="Tiago Janela" userId="ee1a79fe-c79c-4f34-9602-7f6f2f0482b3" providerId="ADAL" clId="{0E7D8533-49DC-4BED-8D2D-C8EE6F23A854}" dt="2026-02-03T14:21:45.404" v="3954" actId="478"/>
-      <pc:docMkLst>
-        <pc:docMk/>
-      </pc:docMkLst>
-    </pc:docChg>
-  </pc:docChgLst>
-  <pc:docChgLst>
-    <pc:chgData name="Tiago Janela" userId="ee1a79fe-c79c-4f34-9602-7f6f2f0482b3" providerId="ADAL" clId="{771048AC-4F55-42D8-AA6A-766F659A7530}"/>
-    <pc:docChg chg="undo custSel addSld delSld modSld sldOrd">
-      <pc:chgData name="Tiago Janela" userId="ee1a79fe-c79c-4f34-9602-7f6f2f0482b3" providerId="ADAL" clId="{771048AC-4F55-42D8-AA6A-766F659A7530}" dt="2026-02-05T14:24:21.198" v="2967" actId="20577"/>
-      <pc:docMkLst>
-        <pc:docMk/>
-      </pc:docMkLst>
-      <pc:sldChg chg="delSp modSp add mod">
-        <pc:chgData name="Tiago Janela" userId="ee1a79fe-c79c-4f34-9602-7f6f2f0482b3" providerId="ADAL" clId="{771048AC-4F55-42D8-AA6A-766F659A7530}" dt="2026-02-05T14:24:21.198" v="2967" actId="20577"/>
-        <pc:sldMkLst>
-          <pc:docMk/>
-          <pc:sldMk cId="901468915" sldId="296"/>
-        </pc:sldMkLst>
-        <pc:spChg chg="mod">
-          <ac:chgData name="Tiago Janela" userId="ee1a79fe-c79c-4f34-9602-7f6f2f0482b3" providerId="ADAL" clId="{771048AC-4F55-42D8-AA6A-766F659A7530}" dt="2026-02-05T10:58:00.218" v="1144" actId="20577"/>
-          <ac:spMkLst>
-            <pc:docMk/>
-            <pc:sldMk cId="901468915" sldId="296"/>
-            <ac:spMk id="163" creationId="{CBF44E8C-8654-71A0-B86B-E9D342AC2D4D}"/>
-          </ac:spMkLst>
-        </pc:spChg>
-        <pc:spChg chg="mod">
-          <ac:chgData name="Tiago Janela" userId="ee1a79fe-c79c-4f34-9602-7f6f2f0482b3" providerId="ADAL" clId="{771048AC-4F55-42D8-AA6A-766F659A7530}" dt="2026-02-05T14:24:21.198" v="2967" actId="20577"/>
-          <ac:spMkLst>
-            <pc:docMk/>
-            <pc:sldMk cId="901468915" sldId="296"/>
-            <ac:spMk id="164" creationId="{B6FA4745-5BA4-2D80-2549-988AFFB4E146}"/>
-          </ac:spMkLst>
-        </pc:spChg>
-      </pc:sldChg>
-      <pc:sldChg chg="modSp add mod ord">
-        <pc:chgData name="Tiago Janela" userId="ee1a79fe-c79c-4f34-9602-7f6f2f0482b3" providerId="ADAL" clId="{771048AC-4F55-42D8-AA6A-766F659A7530}" dt="2026-02-05T12:59:57.611" v="1910" actId="20577"/>
-        <pc:sldMkLst>
-          <pc:docMk/>
-          <pc:sldMk cId="829672710" sldId="297"/>
-        </pc:sldMkLst>
-        <pc:spChg chg="mod">
-          <ac:chgData name="Tiago Janela" userId="ee1a79fe-c79c-4f34-9602-7f6f2f0482b3" providerId="ADAL" clId="{771048AC-4F55-42D8-AA6A-766F659A7530}" dt="2026-02-05T12:59:57.611" v="1910" actId="20577"/>
-          <ac:spMkLst>
-            <pc:docMk/>
-            <pc:sldMk cId="829672710" sldId="297"/>
-            <ac:spMk id="156" creationId="{00000000-0000-0000-0000-000000000000}"/>
-          </ac:spMkLst>
-        </pc:spChg>
-      </pc:sldChg>
-      <pc:sldChg chg="delSp modSp add mod ord">
-        <pc:chgData name="Tiago Janela" userId="ee1a79fe-c79c-4f34-9602-7f6f2f0482b3" providerId="ADAL" clId="{771048AC-4F55-42D8-AA6A-766F659A7530}" dt="2026-02-05T14:23:46.564" v="2966" actId="20577"/>
-        <pc:sldMkLst>
-          <pc:docMk/>
-          <pc:sldMk cId="721732568" sldId="298"/>
-        </pc:sldMkLst>
-        <pc:spChg chg="mod">
-          <ac:chgData name="Tiago Janela" userId="ee1a79fe-c79c-4f34-9602-7f6f2f0482b3" providerId="ADAL" clId="{771048AC-4F55-42D8-AA6A-766F659A7530}" dt="2026-02-05T14:23:46.564" v="2966" actId="20577"/>
-          <ac:spMkLst>
-            <pc:docMk/>
-            <pc:sldMk cId="721732568" sldId="298"/>
-            <ac:spMk id="2" creationId="{870990D0-7AC5-46BA-6FC4-274F8E0A3ABE}"/>
-          </ac:spMkLst>
-        </pc:spChg>
-        <pc:spChg chg="mod">
-          <ac:chgData name="Tiago Janela" userId="ee1a79fe-c79c-4f34-9602-7f6f2f0482b3" providerId="ADAL" clId="{771048AC-4F55-42D8-AA6A-766F659A7530}" dt="2026-02-05T13:01:46.094" v="1930" actId="20577"/>
-          <ac:spMkLst>
-            <pc:docMk/>
-            <pc:sldMk cId="721732568" sldId="298"/>
-            <ac:spMk id="163" creationId="{57944F4B-F502-E7CC-8790-8737702BC6AC}"/>
-          </ac:spMkLst>
-        </pc:spChg>
-      </pc:sldChg>
-    </pc:docChg>
-  </pc:docChgLst>
-  <pc:docChgLst>
-    <pc:chgData name="Tiago Janela" userId="ee1a79fe-c79c-4f34-9602-7f6f2f0482b3" providerId="ADAL" clId="{A1A622BE-A8AD-47B7-8802-BAC61BCE5126}"/>
-    <pc:docChg chg="undo custSel modSld">
-      <pc:chgData name="Tiago Janela" userId="ee1a79fe-c79c-4f34-9602-7f6f2f0482b3" providerId="ADAL" clId="{A1A622BE-A8AD-47B7-8802-BAC61BCE5126}" dt="2026-03-04T13:21:40.843" v="48" actId="403"/>
-      <pc:docMkLst>
-        <pc:docMk/>
-      </pc:docMkLst>
-      <pc:sldChg chg="modSp mod">
-        <pc:chgData name="Tiago Janela" userId="ee1a79fe-c79c-4f34-9602-7f6f2f0482b3" providerId="ADAL" clId="{A1A622BE-A8AD-47B7-8802-BAC61BCE5126}" dt="2026-03-04T13:20:02.161" v="40" actId="20577"/>
-        <pc:sldMkLst>
-          <pc:docMk/>
-          <pc:sldMk cId="114778141" sldId="303"/>
-        </pc:sldMkLst>
-        <pc:spChg chg="mod">
-          <ac:chgData name="Tiago Janela" userId="ee1a79fe-c79c-4f34-9602-7f6f2f0482b3" providerId="ADAL" clId="{A1A622BE-A8AD-47B7-8802-BAC61BCE5126}" dt="2026-03-04T13:20:02.161" v="40" actId="20577"/>
-          <ac:spMkLst>
-            <pc:docMk/>
-            <pc:sldMk cId="114778141" sldId="303"/>
-            <ac:spMk id="2" creationId="{3A594187-BB0C-FE87-8E79-972F5DD9EAE2}"/>
-          </ac:spMkLst>
-        </pc:spChg>
-      </pc:sldChg>
-      <pc:sldChg chg="modSp mod">
-        <pc:chgData name="Tiago Janela" userId="ee1a79fe-c79c-4f34-9602-7f6f2f0482b3" providerId="ADAL" clId="{A1A622BE-A8AD-47B7-8802-BAC61BCE5126}" dt="2026-03-04T13:21:32.291" v="47" actId="20577"/>
-        <pc:sldMkLst>
-          <pc:docMk/>
-          <pc:sldMk cId="1211845523" sldId="306"/>
-        </pc:sldMkLst>
-        <pc:spChg chg="mod">
-          <ac:chgData name="Tiago Janela" userId="ee1a79fe-c79c-4f34-9602-7f6f2f0482b3" providerId="ADAL" clId="{A1A622BE-A8AD-47B7-8802-BAC61BCE5126}" dt="2026-03-04T13:21:32.291" v="47" actId="20577"/>
-          <ac:spMkLst>
-            <pc:docMk/>
-            <pc:sldMk cId="1211845523" sldId="306"/>
-            <ac:spMk id="2" creationId="{3A594187-BB0C-FE87-8E79-972F5DD9EAE2}"/>
-          </ac:spMkLst>
-        </pc:spChg>
-      </pc:sldChg>
-      <pc:sldChg chg="modSp mod">
-        <pc:chgData name="Tiago Janela" userId="ee1a79fe-c79c-4f34-9602-7f6f2f0482b3" providerId="ADAL" clId="{A1A622BE-A8AD-47B7-8802-BAC61BCE5126}" dt="2026-03-04T13:21:40.843" v="48" actId="403"/>
-        <pc:sldMkLst>
-          <pc:docMk/>
-          <pc:sldMk cId="4258501269" sldId="307"/>
-        </pc:sldMkLst>
-        <pc:spChg chg="mod">
-          <ac:chgData name="Tiago Janela" userId="ee1a79fe-c79c-4f34-9602-7f6f2f0482b3" providerId="ADAL" clId="{A1A622BE-A8AD-47B7-8802-BAC61BCE5126}" dt="2026-03-04T13:21:40.843" v="48" actId="403"/>
-          <ac:spMkLst>
-            <pc:docMk/>
-            <pc:sldMk cId="4258501269" sldId="307"/>
-            <ac:spMk id="2" creationId="{3A594187-BB0C-FE87-8E79-972F5DD9EAE2}"/>
-          </ac:spMkLst>
-        </pc:spChg>
-      </pc:sldChg>
-    </pc:docChg>
-  </pc:docChgLst>
-  <pc:docChgLst>
-    <pc:chgData name="Tiago Janela" userId="ee1a79fe-c79c-4f34-9602-7f6f2f0482b3" providerId="ADAL" clId="{143C78B0-29AB-41F6-944B-45926E54C361}"/>
-    <pc:docChg chg="undo custSel addSld delSld modSld">
-      <pc:chgData name="Tiago Janela" userId="ee1a79fe-c79c-4f34-9602-7f6f2f0482b3" providerId="ADAL" clId="{143C78B0-29AB-41F6-944B-45926E54C361}" dt="2026-02-06T15:56:52.044" v="1423" actId="20577"/>
-      <pc:docMkLst>
-        <pc:docMk/>
-      </pc:docMkLst>
-      <pc:sldChg chg="del">
-        <pc:chgData name="Tiago Janela" userId="ee1a79fe-c79c-4f34-9602-7f6f2f0482b3" providerId="ADAL" clId="{143C78B0-29AB-41F6-944B-45926E54C361}" dt="2026-02-06T11:02:26.764" v="8" actId="47"/>
-        <pc:sldMkLst>
-          <pc:docMk/>
-          <pc:sldMk cId="237093369" sldId="283"/>
-        </pc:sldMkLst>
-      </pc:sldChg>
-      <pc:sldChg chg="del">
-        <pc:chgData name="Tiago Janela" userId="ee1a79fe-c79c-4f34-9602-7f6f2f0482b3" providerId="ADAL" clId="{143C78B0-29AB-41F6-944B-45926E54C361}" dt="2026-02-06T11:02:27.633" v="9" actId="47"/>
-        <pc:sldMkLst>
-          <pc:docMk/>
-          <pc:sldMk cId="1512688275" sldId="289"/>
-        </pc:sldMkLst>
-      </pc:sldChg>
-      <pc:sldChg chg="modSp mod">
-        <pc:chgData name="Tiago Janela" userId="ee1a79fe-c79c-4f34-9602-7f6f2f0482b3" providerId="ADAL" clId="{143C78B0-29AB-41F6-944B-45926E54C361}" dt="2026-02-06T15:49:13.450" v="1174" actId="20577"/>
-        <pc:sldMkLst>
-          <pc:docMk/>
-          <pc:sldMk cId="901468915" sldId="296"/>
-        </pc:sldMkLst>
-        <pc:spChg chg="mod">
-          <ac:chgData name="Tiago Janela" userId="ee1a79fe-c79c-4f34-9602-7f6f2f0482b3" providerId="ADAL" clId="{143C78B0-29AB-41F6-944B-45926E54C361}" dt="2026-02-06T15:49:13.450" v="1174" actId="20577"/>
-          <ac:spMkLst>
-            <pc:docMk/>
-            <pc:sldMk cId="901468915" sldId="296"/>
-            <ac:spMk id="164" creationId="{B6FA4745-5BA4-2D80-2549-988AFFB4E146}"/>
-          </ac:spMkLst>
-        </pc:spChg>
-      </pc:sldChg>
-      <pc:sldChg chg="modSp mod">
-        <pc:chgData name="Tiago Janela" userId="ee1a79fe-c79c-4f34-9602-7f6f2f0482b3" providerId="ADAL" clId="{143C78B0-29AB-41F6-944B-45926E54C361}" dt="2026-02-06T13:27:15.929" v="215" actId="20577"/>
-        <pc:sldMkLst>
-          <pc:docMk/>
-          <pc:sldMk cId="829672710" sldId="297"/>
-        </pc:sldMkLst>
-        <pc:spChg chg="mod">
-          <ac:chgData name="Tiago Janela" userId="ee1a79fe-c79c-4f34-9602-7f6f2f0482b3" providerId="ADAL" clId="{143C78B0-29AB-41F6-944B-45926E54C361}" dt="2026-02-06T13:27:15.929" v="215" actId="20577"/>
-          <ac:spMkLst>
-            <pc:docMk/>
-            <pc:sldMk cId="829672710" sldId="297"/>
-            <ac:spMk id="156" creationId="{00000000-0000-0000-0000-000000000000}"/>
-          </ac:spMkLst>
-        </pc:spChg>
-      </pc:sldChg>
-      <pc:sldChg chg="modSp mod">
-        <pc:chgData name="Tiago Janela" userId="ee1a79fe-c79c-4f34-9602-7f6f2f0482b3" providerId="ADAL" clId="{143C78B0-29AB-41F6-944B-45926E54C361}" dt="2026-02-06T15:55:25.972" v="1391" actId="20577"/>
-        <pc:sldMkLst>
-          <pc:docMk/>
-          <pc:sldMk cId="721732568" sldId="298"/>
-        </pc:sldMkLst>
-        <pc:spChg chg="mod">
-          <ac:chgData name="Tiago Janela" userId="ee1a79fe-c79c-4f34-9602-7f6f2f0482b3" providerId="ADAL" clId="{143C78B0-29AB-41F6-944B-45926E54C361}" dt="2026-02-06T15:55:25.972" v="1391" actId="20577"/>
-          <ac:spMkLst>
-            <pc:docMk/>
-            <pc:sldMk cId="721732568" sldId="298"/>
-            <ac:spMk id="2" creationId="{870990D0-7AC5-46BA-6FC4-274F8E0A3ABE}"/>
-          </ac:spMkLst>
-        </pc:spChg>
-      </pc:sldChg>
-    </pc:docChg>
-  </pc:docChgLst>
-  <pc:docChgLst>
     <pc:chgData name="Tiago Janela" userId="ee1a79fe-c79c-4f34-9602-7f6f2f0482b3" providerId="ADAL" clId="{97693404-9C1B-400A-95DF-A7B72570E7A0}"/>
     <pc:docChg chg="undo custSel addSld delSld modSld sldOrd">
       <pc:chgData name="Tiago Janela" userId="ee1a79fe-c79c-4f34-9602-7f6f2f0482b3" providerId="ADAL" clId="{97693404-9C1B-400A-95DF-A7B72570E7A0}" dt="2026-03-09T10:33:25.226" v="5259" actId="20577"/>
       <pc:docMkLst>
         <pc:docMk/>
       </pc:docMkLst>
-      <pc:sldChg chg="addSp delSp modSp add del mod ord modShow">
-        <pc:chgData name="Tiago Janela" userId="ee1a79fe-c79c-4f34-9602-7f6f2f0482b3" providerId="ADAL" clId="{97693404-9C1B-400A-95DF-A7B72570E7A0}" dt="2026-03-04T15:49:46.058" v="3107" actId="47"/>
-        <pc:sldMkLst>
-          <pc:docMk/>
-          <pc:sldMk cId="237093369" sldId="283"/>
-        </pc:sldMkLst>
-        <pc:spChg chg="mod">
-          <ac:chgData name="Tiago Janela" userId="ee1a79fe-c79c-4f34-9602-7f6f2f0482b3" providerId="ADAL" clId="{97693404-9C1B-400A-95DF-A7B72570E7A0}" dt="2026-02-18T10:48:32.233" v="764" actId="20577"/>
-          <ac:spMkLst>
-            <pc:docMk/>
-            <pc:sldMk cId="237093369" sldId="283"/>
-            <ac:spMk id="2" creationId="{A233ED7C-B6A5-4EE5-B53E-783F754D3347}"/>
-          </ac:spMkLst>
-        </pc:spChg>
-        <pc:picChg chg="add mod">
-          <ac:chgData name="Tiago Janela" userId="ee1a79fe-c79c-4f34-9602-7f6f2f0482b3" providerId="ADAL" clId="{97693404-9C1B-400A-95DF-A7B72570E7A0}" dt="2026-02-17T11:10:19.140" v="217" actId="1076"/>
-          <ac:picMkLst>
-            <pc:docMk/>
-            <pc:sldMk cId="237093369" sldId="283"/>
-            <ac:picMk id="4" creationId="{4FA090B0-7C9B-9822-E35B-620E002E37C5}"/>
-          </ac:picMkLst>
-        </pc:picChg>
-        <pc:picChg chg="add mod">
-          <ac:chgData name="Tiago Janela" userId="ee1a79fe-c79c-4f34-9602-7f6f2f0482b3" providerId="ADAL" clId="{97693404-9C1B-400A-95DF-A7B72570E7A0}" dt="2026-02-17T11:12:23.236" v="223" actId="1076"/>
-          <ac:picMkLst>
-            <pc:docMk/>
-            <pc:sldMk cId="237093369" sldId="283"/>
-            <ac:picMk id="8" creationId="{EEE00D1D-8814-4A51-2880-2E6DEA971096}"/>
-          </ac:picMkLst>
-        </pc:picChg>
-      </pc:sldChg>
-      <pc:sldChg chg="addSp delSp modSp add del mod">
-        <pc:chgData name="Tiago Janela" userId="ee1a79fe-c79c-4f34-9602-7f6f2f0482b3" providerId="ADAL" clId="{97693404-9C1B-400A-95DF-A7B72570E7A0}" dt="2026-03-04T12:56:57.437" v="1506" actId="47"/>
-        <pc:sldMkLst>
-          <pc:docMk/>
-          <pc:sldMk cId="2286645179" sldId="284"/>
-        </pc:sldMkLst>
-      </pc:sldChg>
-      <pc:sldChg chg="addSp delSp modSp add del mod modShow">
-        <pc:chgData name="Tiago Janela" userId="ee1a79fe-c79c-4f34-9602-7f6f2f0482b3" providerId="ADAL" clId="{97693404-9C1B-400A-95DF-A7B72570E7A0}" dt="2026-03-09T10:28:34.266" v="5109" actId="47"/>
-        <pc:sldMkLst>
-          <pc:docMk/>
-          <pc:sldMk cId="1512688275" sldId="289"/>
-        </pc:sldMkLst>
-        <pc:spChg chg="mod">
-          <ac:chgData name="Tiago Janela" userId="ee1a79fe-c79c-4f34-9602-7f6f2f0482b3" providerId="ADAL" clId="{97693404-9C1B-400A-95DF-A7B72570E7A0}" dt="2026-03-04T13:32:03.522" v="2558" actId="20577"/>
-          <ac:spMkLst>
-            <pc:docMk/>
-            <pc:sldMk cId="1512688275" sldId="289"/>
-            <ac:spMk id="5" creationId="{E8A7F028-74CF-6C54-4DD5-3B4B5B71E2D8}"/>
-          </ac:spMkLst>
-        </pc:spChg>
-        <pc:spChg chg="mod">
-          <ac:chgData name="Tiago Janela" userId="ee1a79fe-c79c-4f34-9602-7f6f2f0482b3" providerId="ADAL" clId="{97693404-9C1B-400A-95DF-A7B72570E7A0}" dt="2026-02-18T13:37:13.121" v="874"/>
-          <ac:spMkLst>
-            <pc:docMk/>
-            <pc:sldMk cId="1512688275" sldId="289"/>
-            <ac:spMk id="163" creationId="{FCB0975A-D008-0F54-1C32-ED7E3F322A93}"/>
-          </ac:spMkLst>
-        </pc:spChg>
-        <pc:picChg chg="add mod">
-          <ac:chgData name="Tiago Janela" userId="ee1a79fe-c79c-4f34-9602-7f6f2f0482b3" providerId="ADAL" clId="{97693404-9C1B-400A-95DF-A7B72570E7A0}" dt="2026-03-04T14:15:47.569" v="3078" actId="1076"/>
-          <ac:picMkLst>
-            <pc:docMk/>
-            <pc:sldMk cId="1512688275" sldId="289"/>
-            <ac:picMk id="3" creationId="{F8FE564D-C14A-D361-F39B-D2C4FD46193B}"/>
-          </ac:picMkLst>
-        </pc:picChg>
-      </pc:sldChg>
-      <pc:sldChg chg="modSp mod ord">
-        <pc:chgData name="Tiago Janela" userId="ee1a79fe-c79c-4f34-9602-7f6f2f0482b3" providerId="ADAL" clId="{97693404-9C1B-400A-95DF-A7B72570E7A0}" dt="2026-03-09T10:33:25.226" v="5259" actId="20577"/>
-        <pc:sldMkLst>
-          <pc:docMk/>
-          <pc:sldMk cId="901468915" sldId="296"/>
-        </pc:sldMkLst>
-        <pc:spChg chg="mod">
-          <ac:chgData name="Tiago Janela" userId="ee1a79fe-c79c-4f34-9602-7f6f2f0482b3" providerId="ADAL" clId="{97693404-9C1B-400A-95DF-A7B72570E7A0}" dt="2026-03-09T10:33:25.226" v="5259" actId="20577"/>
-          <ac:spMkLst>
-            <pc:docMk/>
-            <pc:sldMk cId="901468915" sldId="296"/>
-            <ac:spMk id="164" creationId="{B6FA4745-5BA4-2D80-2549-988AFFB4E146}"/>
-          </ac:spMkLst>
-        </pc:spChg>
-      </pc:sldChg>
-      <pc:sldChg chg="modSp mod">
-        <pc:chgData name="Tiago Janela" userId="ee1a79fe-c79c-4f34-9602-7f6f2f0482b3" providerId="ADAL" clId="{97693404-9C1B-400A-95DF-A7B72570E7A0}" dt="2026-02-17T10:42:44.707" v="22" actId="20577"/>
-        <pc:sldMkLst>
-          <pc:docMk/>
-          <pc:sldMk cId="829672710" sldId="297"/>
-        </pc:sldMkLst>
-        <pc:spChg chg="mod">
-          <ac:chgData name="Tiago Janela" userId="ee1a79fe-c79c-4f34-9602-7f6f2f0482b3" providerId="ADAL" clId="{97693404-9C1B-400A-95DF-A7B72570E7A0}" dt="2026-02-17T10:42:44.707" v="22" actId="20577"/>
-          <ac:spMkLst>
-            <pc:docMk/>
-            <pc:sldMk cId="829672710" sldId="297"/>
-            <ac:spMk id="156" creationId="{00000000-0000-0000-0000-000000000000}"/>
-          </ac:spMkLst>
-        </pc:spChg>
-      </pc:sldChg>
       <pc:sldChg chg="modSp mod">
         <pc:chgData name="Tiago Janela" userId="ee1a79fe-c79c-4f34-9602-7f6f2f0482b3" providerId="ADAL" clId="{97693404-9C1B-400A-95DF-A7B72570E7A0}" dt="2026-03-09T10:32:29.235" v="5249" actId="20577"/>
         <pc:sldMkLst>
@@ -666,328 +316,6 @@
             <ac:spMk id="2" creationId="{870990D0-7AC5-46BA-6FC4-274F8E0A3ABE}"/>
           </ac:spMkLst>
         </pc:spChg>
-      </pc:sldChg>
-      <pc:sldChg chg="modSp add del mod">
-        <pc:chgData name="Tiago Janela" userId="ee1a79fe-c79c-4f34-9602-7f6f2f0482b3" providerId="ADAL" clId="{97693404-9C1B-400A-95DF-A7B72570E7A0}" dt="2026-03-04T12:57:02.180" v="1508" actId="47"/>
-        <pc:sldMkLst>
-          <pc:docMk/>
-          <pc:sldMk cId="3325464043" sldId="300"/>
-        </pc:sldMkLst>
-      </pc:sldChg>
-      <pc:sldChg chg="addSp delSp modSp add del mod">
-        <pc:chgData name="Tiago Janela" userId="ee1a79fe-c79c-4f34-9602-7f6f2f0482b3" providerId="ADAL" clId="{97693404-9C1B-400A-95DF-A7B72570E7A0}" dt="2026-03-04T12:56:58.303" v="1507" actId="47"/>
-        <pc:sldMkLst>
-          <pc:docMk/>
-          <pc:sldMk cId="1549526940" sldId="301"/>
-        </pc:sldMkLst>
-      </pc:sldChg>
-      <pc:sldChg chg="modSp add del mod ord modShow">
-        <pc:chgData name="Tiago Janela" userId="ee1a79fe-c79c-4f34-9602-7f6f2f0482b3" providerId="ADAL" clId="{97693404-9C1B-400A-95DF-A7B72570E7A0}" dt="2026-03-04T15:49:47.418" v="3108" actId="47"/>
-        <pc:sldMkLst>
-          <pc:docMk/>
-          <pc:sldMk cId="1735901252" sldId="302"/>
-        </pc:sldMkLst>
-        <pc:spChg chg="mod">
-          <ac:chgData name="Tiago Janela" userId="ee1a79fe-c79c-4f34-9602-7f6f2f0482b3" providerId="ADAL" clId="{97693404-9C1B-400A-95DF-A7B72570E7A0}" dt="2026-02-18T14:57:20.851" v="1269" actId="6549"/>
-          <ac:spMkLst>
-            <pc:docMk/>
-            <pc:sldMk cId="1735901252" sldId="302"/>
-            <ac:spMk id="5" creationId="{E8A7F028-74CF-6C54-4DD5-3B4B5B71E2D8}"/>
-          </ac:spMkLst>
-        </pc:spChg>
-      </pc:sldChg>
-      <pc:sldChg chg="addSp delSp modSp add mod ord">
-        <pc:chgData name="Tiago Janela" userId="ee1a79fe-c79c-4f34-9602-7f6f2f0482b3" providerId="ADAL" clId="{97693404-9C1B-400A-95DF-A7B72570E7A0}" dt="2026-03-05T10:55:03.980" v="3510" actId="6549"/>
-        <pc:sldMkLst>
-          <pc:docMk/>
-          <pc:sldMk cId="114778141" sldId="303"/>
-        </pc:sldMkLst>
-        <pc:spChg chg="add mod">
-          <ac:chgData name="Tiago Janela" userId="ee1a79fe-c79c-4f34-9602-7f6f2f0482b3" providerId="ADAL" clId="{97693404-9C1B-400A-95DF-A7B72570E7A0}" dt="2026-03-05T10:55:03.980" v="3510" actId="6549"/>
-          <ac:spMkLst>
-            <pc:docMk/>
-            <pc:sldMk cId="114778141" sldId="303"/>
-            <ac:spMk id="2" creationId="{3A594187-BB0C-FE87-8E79-972F5DD9EAE2}"/>
-          </ac:spMkLst>
-        </pc:spChg>
-        <pc:spChg chg="mod">
-          <ac:chgData name="Tiago Janela" userId="ee1a79fe-c79c-4f34-9602-7f6f2f0482b3" providerId="ADAL" clId="{97693404-9C1B-400A-95DF-A7B72570E7A0}" dt="2026-03-04T13:14:00.403" v="2164" actId="20577"/>
-          <ac:spMkLst>
-            <pc:docMk/>
-            <pc:sldMk cId="114778141" sldId="303"/>
-            <ac:spMk id="166" creationId="{73C6FAEE-CE23-BB36-58B3-A5E5504E1C3B}"/>
-          </ac:spMkLst>
-        </pc:spChg>
-        <pc:picChg chg="add mod">
-          <ac:chgData name="Tiago Janela" userId="ee1a79fe-c79c-4f34-9602-7f6f2f0482b3" providerId="ADAL" clId="{97693404-9C1B-400A-95DF-A7B72570E7A0}" dt="2026-03-05T10:53:17.064" v="3461"/>
-          <ac:picMkLst>
-            <pc:docMk/>
-            <pc:sldMk cId="114778141" sldId="303"/>
-            <ac:picMk id="3" creationId="{F7A1CE92-8480-32AA-303B-900FB583DC9A}"/>
-          </ac:picMkLst>
-        </pc:picChg>
-        <pc:picChg chg="add del mod">
-          <ac:chgData name="Tiago Janela" userId="ee1a79fe-c79c-4f34-9602-7f6f2f0482b3" providerId="ADAL" clId="{97693404-9C1B-400A-95DF-A7B72570E7A0}" dt="2026-03-05T10:53:28.398" v="3462" actId="478"/>
-          <ac:picMkLst>
-            <pc:docMk/>
-            <pc:sldMk cId="114778141" sldId="303"/>
-            <ac:picMk id="5" creationId="{16C4F416-280C-5702-243E-680D20284ADD}"/>
-          </ac:picMkLst>
-        </pc:picChg>
-      </pc:sldChg>
-      <pc:sldChg chg="addSp delSp modSp add del mod">
-        <pc:chgData name="Tiago Janela" userId="ee1a79fe-c79c-4f34-9602-7f6f2f0482b3" providerId="ADAL" clId="{97693404-9C1B-400A-95DF-A7B72570E7A0}" dt="2026-03-04T13:01:43.503" v="1711" actId="47"/>
-        <pc:sldMkLst>
-          <pc:docMk/>
-          <pc:sldMk cId="821539772" sldId="304"/>
-        </pc:sldMkLst>
-      </pc:sldChg>
-      <pc:sldChg chg="modSp add del mod">
-        <pc:chgData name="Tiago Janela" userId="ee1a79fe-c79c-4f34-9602-7f6f2f0482b3" providerId="ADAL" clId="{97693404-9C1B-400A-95DF-A7B72570E7A0}" dt="2026-03-04T13:23:29.410" v="2203" actId="47"/>
-        <pc:sldMkLst>
-          <pc:docMk/>
-          <pc:sldMk cId="2309601796" sldId="305"/>
-        </pc:sldMkLst>
-        <pc:spChg chg="mod">
-          <ac:chgData name="Tiago Janela" userId="ee1a79fe-c79c-4f34-9602-7f6f2f0482b3" providerId="ADAL" clId="{97693404-9C1B-400A-95DF-A7B72570E7A0}" dt="2026-02-27T11:05:59.764" v="1458" actId="15"/>
-          <ac:spMkLst>
-            <pc:docMk/>
-            <pc:sldMk cId="2309601796" sldId="305"/>
-            <ac:spMk id="2" creationId="{870990D0-7AC5-46BA-6FC4-274F8E0A3ABE}"/>
-          </ac:spMkLst>
-        </pc:spChg>
-        <pc:spChg chg="mod">
-          <ac:chgData name="Tiago Janela" userId="ee1a79fe-c79c-4f34-9602-7f6f2f0482b3" providerId="ADAL" clId="{97693404-9C1B-400A-95DF-A7B72570E7A0}" dt="2026-02-27T11:03:52.458" v="1363" actId="20577"/>
-          <ac:spMkLst>
-            <pc:docMk/>
-            <pc:sldMk cId="2309601796" sldId="305"/>
-            <ac:spMk id="163" creationId="{57944F4B-F502-E7CC-8790-8737702BC6AC}"/>
-          </ac:spMkLst>
-        </pc:spChg>
-      </pc:sldChg>
-      <pc:sldChg chg="modSp add mod">
-        <pc:chgData name="Tiago Janela" userId="ee1a79fe-c79c-4f34-9602-7f6f2f0482b3" providerId="ADAL" clId="{97693404-9C1B-400A-95DF-A7B72570E7A0}" dt="2026-03-09T10:32:38.571" v="5250" actId="113"/>
-        <pc:sldMkLst>
-          <pc:docMk/>
-          <pc:sldMk cId="1211845523" sldId="306"/>
-        </pc:sldMkLst>
-        <pc:spChg chg="mod">
-          <ac:chgData name="Tiago Janela" userId="ee1a79fe-c79c-4f34-9602-7f6f2f0482b3" providerId="ADAL" clId="{97693404-9C1B-400A-95DF-A7B72570E7A0}" dt="2026-03-09T10:32:38.571" v="5250" actId="113"/>
-          <ac:spMkLst>
-            <pc:docMk/>
-            <pc:sldMk cId="1211845523" sldId="306"/>
-            <ac:spMk id="2" creationId="{3A594187-BB0C-FE87-8E79-972F5DD9EAE2}"/>
-          </ac:spMkLst>
-        </pc:spChg>
-        <pc:spChg chg="mod">
-          <ac:chgData name="Tiago Janela" userId="ee1a79fe-c79c-4f34-9602-7f6f2f0482b3" providerId="ADAL" clId="{97693404-9C1B-400A-95DF-A7B72570E7A0}" dt="2026-03-04T13:13:51.930" v="2155" actId="20577"/>
-          <ac:spMkLst>
-            <pc:docMk/>
-            <pc:sldMk cId="1211845523" sldId="306"/>
-            <ac:spMk id="166" creationId="{73C6FAEE-CE23-BB36-58B3-A5E5504E1C3B}"/>
-          </ac:spMkLst>
-        </pc:spChg>
-        <pc:picChg chg="mod">
-          <ac:chgData name="Tiago Janela" userId="ee1a79fe-c79c-4f34-9602-7f6f2f0482b3" providerId="ADAL" clId="{97693404-9C1B-400A-95DF-A7B72570E7A0}" dt="2026-03-05T10:52:53.748" v="3459" actId="1076"/>
-          <ac:picMkLst>
-            <pc:docMk/>
-            <pc:sldMk cId="1211845523" sldId="306"/>
-            <ac:picMk id="5" creationId="{16C4F416-280C-5702-243E-680D20284ADD}"/>
-          </ac:picMkLst>
-        </pc:picChg>
-      </pc:sldChg>
-      <pc:sldChg chg="addSp delSp modSp add mod">
-        <pc:chgData name="Tiago Janela" userId="ee1a79fe-c79c-4f34-9602-7f6f2f0482b3" providerId="ADAL" clId="{97693404-9C1B-400A-95DF-A7B72570E7A0}" dt="2026-03-05T10:55:12.788" v="3513" actId="20577"/>
-        <pc:sldMkLst>
-          <pc:docMk/>
-          <pc:sldMk cId="4258501269" sldId="307"/>
-        </pc:sldMkLst>
-        <pc:spChg chg="mod">
-          <ac:chgData name="Tiago Janela" userId="ee1a79fe-c79c-4f34-9602-7f6f2f0482b3" providerId="ADAL" clId="{97693404-9C1B-400A-95DF-A7B72570E7A0}" dt="2026-03-05T10:55:12.788" v="3513" actId="20577"/>
-          <ac:spMkLst>
-            <pc:docMk/>
-            <pc:sldMk cId="4258501269" sldId="307"/>
-            <ac:spMk id="2" creationId="{3A594187-BB0C-FE87-8E79-972F5DD9EAE2}"/>
-          </ac:spMkLst>
-        </pc:spChg>
-        <pc:spChg chg="mod">
-          <ac:chgData name="Tiago Janela" userId="ee1a79fe-c79c-4f34-9602-7f6f2f0482b3" providerId="ADAL" clId="{97693404-9C1B-400A-95DF-A7B72570E7A0}" dt="2026-03-04T13:13:41.592" v="2147"/>
-          <ac:spMkLst>
-            <pc:docMk/>
-            <pc:sldMk cId="4258501269" sldId="307"/>
-            <ac:spMk id="166" creationId="{73C6FAEE-CE23-BB36-58B3-A5E5504E1C3B}"/>
-          </ac:spMkLst>
-        </pc:spChg>
-        <pc:picChg chg="add mod">
-          <ac:chgData name="Tiago Janela" userId="ee1a79fe-c79c-4f34-9602-7f6f2f0482b3" providerId="ADAL" clId="{97693404-9C1B-400A-95DF-A7B72570E7A0}" dt="2026-03-04T13:08:27.808" v="2136" actId="1076"/>
-          <ac:picMkLst>
-            <pc:docMk/>
-            <pc:sldMk cId="4258501269" sldId="307"/>
-            <ac:picMk id="3" creationId="{8E704CBB-B9BA-C9D1-3227-A6CD3868AFE7}"/>
-          </ac:picMkLst>
-        </pc:picChg>
-        <pc:picChg chg="del">
-          <ac:chgData name="Tiago Janela" userId="ee1a79fe-c79c-4f34-9602-7f6f2f0482b3" providerId="ADAL" clId="{97693404-9C1B-400A-95DF-A7B72570E7A0}" dt="2026-03-04T13:01:40.953" v="1709" actId="478"/>
-          <ac:picMkLst>
-            <pc:docMk/>
-            <pc:sldMk cId="4258501269" sldId="307"/>
-            <ac:picMk id="5" creationId="{16C4F416-280C-5702-243E-680D20284ADD}"/>
-          </ac:picMkLst>
-        </pc:picChg>
-      </pc:sldChg>
-      <pc:sldChg chg="addSp delSp modSp add mod">
-        <pc:chgData name="Tiago Janela" userId="ee1a79fe-c79c-4f34-9602-7f6f2f0482b3" providerId="ADAL" clId="{97693404-9C1B-400A-95DF-A7B72570E7A0}" dt="2026-03-09T10:32:58.339" v="5256" actId="113"/>
-        <pc:sldMkLst>
-          <pc:docMk/>
-          <pc:sldMk cId="467547607" sldId="308"/>
-        </pc:sldMkLst>
-        <pc:spChg chg="mod">
-          <ac:chgData name="Tiago Janela" userId="ee1a79fe-c79c-4f34-9602-7f6f2f0482b3" providerId="ADAL" clId="{97693404-9C1B-400A-95DF-A7B72570E7A0}" dt="2026-03-09T10:32:58.339" v="5256" actId="113"/>
-          <ac:spMkLst>
-            <pc:docMk/>
-            <pc:sldMk cId="467547607" sldId="308"/>
-            <ac:spMk id="2" creationId="{3A594187-BB0C-FE87-8E79-972F5DD9EAE2}"/>
-          </ac:spMkLst>
-        </pc:spChg>
-        <pc:spChg chg="mod">
-          <ac:chgData name="Tiago Janela" userId="ee1a79fe-c79c-4f34-9602-7f6f2f0482b3" providerId="ADAL" clId="{97693404-9C1B-400A-95DF-A7B72570E7A0}" dt="2026-03-04T13:13:33.588" v="2145" actId="20577"/>
-          <ac:spMkLst>
-            <pc:docMk/>
-            <pc:sldMk cId="467547607" sldId="308"/>
-            <ac:spMk id="166" creationId="{73C6FAEE-CE23-BB36-58B3-A5E5504E1C3B}"/>
-          </ac:spMkLst>
-        </pc:spChg>
-        <pc:picChg chg="del">
-          <ac:chgData name="Tiago Janela" userId="ee1a79fe-c79c-4f34-9602-7f6f2f0482b3" providerId="ADAL" clId="{97693404-9C1B-400A-95DF-A7B72570E7A0}" dt="2026-03-04T13:08:32.120" v="2137" actId="478"/>
-          <ac:picMkLst>
-            <pc:docMk/>
-            <pc:sldMk cId="467547607" sldId="308"/>
-            <ac:picMk id="3" creationId="{8E704CBB-B9BA-C9D1-3227-A6CD3868AFE7}"/>
-          </ac:picMkLst>
-        </pc:picChg>
-        <pc:picChg chg="add mod">
-          <ac:chgData name="Tiago Janela" userId="ee1a79fe-c79c-4f34-9602-7f6f2f0482b3" providerId="ADAL" clId="{97693404-9C1B-400A-95DF-A7B72570E7A0}" dt="2026-03-05T11:04:31.708" v="3761" actId="1076"/>
-          <ac:picMkLst>
-            <pc:docMk/>
-            <pc:sldMk cId="467547607" sldId="308"/>
-            <ac:picMk id="4" creationId="{088487E6-6EDF-5379-BFE0-AE14A850C52A}"/>
-          </ac:picMkLst>
-        </pc:picChg>
-      </pc:sldChg>
-      <pc:sldChg chg="modSp add del mod">
-        <pc:chgData name="Tiago Janela" userId="ee1a79fe-c79c-4f34-9602-7f6f2f0482b3" providerId="ADAL" clId="{97693404-9C1B-400A-95DF-A7B72570E7A0}" dt="2026-03-04T13:46:26.076" v="3074" actId="47"/>
-        <pc:sldMkLst>
-          <pc:docMk/>
-          <pc:sldMk cId="3166687561" sldId="309"/>
-        </pc:sldMkLst>
-        <pc:spChg chg="mod">
-          <ac:chgData name="Tiago Janela" userId="ee1a79fe-c79c-4f34-9602-7f6f2f0482b3" providerId="ADAL" clId="{97693404-9C1B-400A-95DF-A7B72570E7A0}" dt="2026-03-04T13:42:35.307" v="2999" actId="404"/>
-          <ac:spMkLst>
-            <pc:docMk/>
-            <pc:sldMk cId="3166687561" sldId="309"/>
-            <ac:spMk id="5" creationId="{E8A7F028-74CF-6C54-4DD5-3B4B5B71E2D8}"/>
-          </ac:spMkLst>
-        </pc:spChg>
-      </pc:sldChg>
-      <pc:sldChg chg="addSp delSp modSp add del mod modShow">
-        <pc:chgData name="Tiago Janela" userId="ee1a79fe-c79c-4f34-9602-7f6f2f0482b3" providerId="ADAL" clId="{97693404-9C1B-400A-95DF-A7B72570E7A0}" dt="2026-03-09T10:28:35" v="5110" actId="47"/>
-        <pc:sldMkLst>
-          <pc:docMk/>
-          <pc:sldMk cId="1164058602" sldId="310"/>
-        </pc:sldMkLst>
-        <pc:spChg chg="mod">
-          <ac:chgData name="Tiago Janela" userId="ee1a79fe-c79c-4f34-9602-7f6f2f0482b3" providerId="ADAL" clId="{97693404-9C1B-400A-95DF-A7B72570E7A0}" dt="2026-03-04T14:15:29.937" v="3077" actId="14100"/>
-          <ac:spMkLst>
-            <pc:docMk/>
-            <pc:sldMk cId="1164058602" sldId="310"/>
-            <ac:spMk id="5" creationId="{E8A7F028-74CF-6C54-4DD5-3B4B5B71E2D8}"/>
-          </ac:spMkLst>
-        </pc:spChg>
-        <pc:graphicFrameChg chg="add mod modGraphic">
-          <ac:chgData name="Tiago Janela" userId="ee1a79fe-c79c-4f34-9602-7f6f2f0482b3" providerId="ADAL" clId="{97693404-9C1B-400A-95DF-A7B72570E7A0}" dt="2026-03-04T13:45:45.143" v="3066" actId="1076"/>
-          <ac:graphicFrameMkLst>
-            <pc:docMk/>
-            <pc:sldMk cId="1164058602" sldId="310"/>
-            <ac:graphicFrameMk id="6" creationId="{9DFEAA2A-A89F-EE13-4797-3A5DD610ED30}"/>
-          </ac:graphicFrameMkLst>
-        </pc:graphicFrameChg>
-        <pc:picChg chg="mod">
-          <ac:chgData name="Tiago Janela" userId="ee1a79fe-c79c-4f34-9602-7f6f2f0482b3" providerId="ADAL" clId="{97693404-9C1B-400A-95DF-A7B72570E7A0}" dt="2026-03-04T13:46:57.531" v="3076" actId="1076"/>
-          <ac:picMkLst>
-            <pc:docMk/>
-            <pc:sldMk cId="1164058602" sldId="310"/>
-            <ac:picMk id="3" creationId="{F8FE564D-C14A-D361-F39B-D2C4FD46193B}"/>
-          </ac:picMkLst>
-        </pc:picChg>
-        <pc:picChg chg="add del">
-          <ac:chgData name="Tiago Janela" userId="ee1a79fe-c79c-4f34-9602-7f6f2f0482b3" providerId="ADAL" clId="{97693404-9C1B-400A-95DF-A7B72570E7A0}" dt="2026-03-04T13:33:49.807" v="2723" actId="22"/>
-          <ac:picMkLst>
-            <pc:docMk/>
-            <pc:sldMk cId="1164058602" sldId="310"/>
-            <ac:picMk id="4" creationId="{D89A0267-3387-94D3-598E-476090DAE2B8}"/>
-          </ac:picMkLst>
-        </pc:picChg>
-      </pc:sldChg>
-      <pc:sldChg chg="addSp delSp modSp add mod">
-        <pc:chgData name="Tiago Janela" userId="ee1a79fe-c79c-4f34-9602-7f6f2f0482b3" providerId="ADAL" clId="{97693404-9C1B-400A-95DF-A7B72570E7A0}" dt="2026-03-05T13:51:09.867" v="4389" actId="207"/>
-        <pc:sldMkLst>
-          <pc:docMk/>
-          <pc:sldMk cId="1772121027" sldId="311"/>
-        </pc:sldMkLst>
-        <pc:spChg chg="mod">
-          <ac:chgData name="Tiago Janela" userId="ee1a79fe-c79c-4f34-9602-7f6f2f0482b3" providerId="ADAL" clId="{97693404-9C1B-400A-95DF-A7B72570E7A0}" dt="2026-03-05T13:51:09.867" v="4389" actId="207"/>
-          <ac:spMkLst>
-            <pc:docMk/>
-            <pc:sldMk cId="1772121027" sldId="311"/>
-            <ac:spMk id="170" creationId="{2B43687A-3834-1918-AA00-F4656042D038}"/>
-          </ac:spMkLst>
-        </pc:spChg>
-        <pc:grpChg chg="del">
-          <ac:chgData name="Tiago Janela" userId="ee1a79fe-c79c-4f34-9602-7f6f2f0482b3" providerId="ADAL" clId="{97693404-9C1B-400A-95DF-A7B72570E7A0}" dt="2026-03-05T11:20:01.605" v="3926" actId="478"/>
-          <ac:grpSpMkLst>
-            <pc:docMk/>
-            <pc:sldMk cId="1772121027" sldId="311"/>
-            <ac:grpSpMk id="8" creationId="{B81890E7-8BF7-7B83-7AA2-CCCFC1B52654}"/>
-          </ac:grpSpMkLst>
-        </pc:grpChg>
-        <pc:picChg chg="add mod modCrop">
-          <ac:chgData name="Tiago Janela" userId="ee1a79fe-c79c-4f34-9602-7f6f2f0482b3" providerId="ADAL" clId="{97693404-9C1B-400A-95DF-A7B72570E7A0}" dt="2026-03-05T11:45:45.752" v="4347" actId="1076"/>
-          <ac:picMkLst>
-            <pc:docMk/>
-            <pc:sldMk cId="1772121027" sldId="311"/>
-            <ac:picMk id="10" creationId="{5E2BD8C7-1DEE-FFD6-A4F6-CF1BAC02919F}"/>
-          </ac:picMkLst>
-        </pc:picChg>
-        <pc:picChg chg="add mod modCrop">
-          <ac:chgData name="Tiago Janela" userId="ee1a79fe-c79c-4f34-9602-7f6f2f0482b3" providerId="ADAL" clId="{97693404-9C1B-400A-95DF-A7B72570E7A0}" dt="2026-03-05T11:45:55.200" v="4350" actId="1076"/>
-          <ac:picMkLst>
-            <pc:docMk/>
-            <pc:sldMk cId="1772121027" sldId="311"/>
-            <ac:picMk id="13" creationId="{C6E47417-9E80-A00A-554F-834C3597206A}"/>
-          </ac:picMkLst>
-        </pc:picChg>
-        <pc:picChg chg="add mod modCrop">
-          <ac:chgData name="Tiago Janela" userId="ee1a79fe-c79c-4f34-9602-7f6f2f0482b3" providerId="ADAL" clId="{97693404-9C1B-400A-95DF-A7B72570E7A0}" dt="2026-03-05T11:45:52.184" v="4349" actId="1076"/>
-          <ac:picMkLst>
-            <pc:docMk/>
-            <pc:sldMk cId="1772121027" sldId="311"/>
-            <ac:picMk id="15" creationId="{476DDCBA-FBEF-3BA4-1FAB-879D873364E7}"/>
-          </ac:picMkLst>
-        </pc:picChg>
-      </pc:sldChg>
-      <pc:sldChg chg="add del mod modShow">
-        <pc:chgData name="Tiago Janela" userId="ee1a79fe-c79c-4f34-9602-7f6f2f0482b3" providerId="ADAL" clId="{97693404-9C1B-400A-95DF-A7B72570E7A0}" dt="2026-03-05T11:09:04.534" v="3920" actId="47"/>
-        <pc:sldMkLst>
-          <pc:docMk/>
-          <pc:sldMk cId="3374331074" sldId="311"/>
-        </pc:sldMkLst>
-      </pc:sldChg>
-      <pc:sldChg chg="add del ord">
-        <pc:chgData name="Tiago Janela" userId="ee1a79fe-c79c-4f34-9602-7f6f2f0482b3" providerId="ADAL" clId="{97693404-9C1B-400A-95DF-A7B72570E7A0}" dt="2026-03-05T11:00:14.847" v="3550" actId="47"/>
-        <pc:sldMkLst>
-          <pc:docMk/>
-          <pc:sldMk cId="3658891486" sldId="311"/>
-        </pc:sldMkLst>
       </pc:sldChg>
     </pc:docChg>
   </pc:docChgLst>
@@ -9457,7 +8785,7 @@
                 </a:solidFill>
                 <a:latin typeface="Century Gothic"/>
               </a:rPr>
-              <a:t>‹#›</a:t>
+              <a:t>‹nº›</a:t>
             </a:fld>
             <a:endParaRPr lang="en-GB" sz="1200" b="0" strike="noStrike" spc="-1">
               <a:latin typeface="Times New Roman"/>
@@ -10023,7 +9351,7 @@
         <p:fade/>
       </p:transition>
     </mc:Choice>
-    <mc:Fallback xmlns="" xmlns:p15="http://schemas.microsoft.com/office/powerpoint/2012/main">
+    <mc:Fallback xmlns:p15="http://schemas.microsoft.com/office/powerpoint/2012/main" xmlns="">
       <p:transition spd="med">
         <p:fade/>
       </p:transition>
@@ -10452,7 +9780,7 @@
         <p:fade/>
       </p:transition>
     </mc:Choice>
-    <mc:Fallback xmlns="" xmlns:p15="http://schemas.microsoft.com/office/powerpoint/2012/main">
+    <mc:Fallback xmlns:p15="http://schemas.microsoft.com/office/powerpoint/2012/main" xmlns="">
       <p:transition spd="med">
         <p:fade/>
       </p:transition>
@@ -11213,7 +10541,7 @@
         <p:fade/>
       </p:transition>
     </mc:Choice>
-    <mc:Fallback xmlns="" xmlns:p15="http://schemas.microsoft.com/office/powerpoint/2012/main">
+    <mc:Fallback xmlns:p15="http://schemas.microsoft.com/office/powerpoint/2012/main" xmlns="">
       <p:transition spd="med">
         <p:fade/>
       </p:transition>
@@ -11792,7 +11120,7 @@
         <p:fade/>
       </p:transition>
     </mc:Choice>
-    <mc:Fallback xmlns="" xmlns:p15="http://schemas.microsoft.com/office/powerpoint/2012/main">
+    <mc:Fallback xmlns:p15="http://schemas.microsoft.com/office/powerpoint/2012/main" xmlns="">
       <p:transition spd="med">
         <p:fade/>
       </p:transition>
@@ -12407,7 +11735,7 @@
         <p:fade/>
       </p:transition>
     </mc:Choice>
-    <mc:Fallback xmlns="" xmlns:p15="http://schemas.microsoft.com/office/powerpoint/2012/main">
+    <mc:Fallback xmlns:p15="http://schemas.microsoft.com/office/powerpoint/2012/main" xmlns="">
       <p:transition spd="med">
         <p:fade/>
       </p:transition>
@@ -13723,13 +13051,13 @@
   <p:clrMapOvr>
     <a:masterClrMapping/>
   </p:clrMapOvr>
-  <mc:AlternateContent xmlns:mc="http://schemas.openxmlformats.org/markup-compatibility/2006">
-    <mc:Choice xmlns:p14="http://schemas.microsoft.com/office/powerpoint/2010/main" Requires="p14">
+  <mc:AlternateContent xmlns:mc="http://schemas.openxmlformats.org/markup-compatibility/2006" xmlns:p14="http://schemas.microsoft.com/office/powerpoint/2010/main">
+    <mc:Choice Requires="p14">
       <p:transition spd="med" p14:dur="700">
         <p:fade/>
       </p:transition>
     </mc:Choice>
-    <mc:Fallback>
+    <mc:Fallback xmlns="">
       <p:transition spd="med">
         <p:fade/>
       </p:transition>

</xml_diff>

<commit_message>
Update presentation slides with new graphical abstract and revised figures
</commit_message>
<xml_diff>
--- a/slides/AI_Agent_Explainability.pptx
+++ b/slides/AI_Agent_Explainability.pptx
@@ -13,8 +13,10 @@
     <p:sldId id="300" r:id="rId7"/>
     <p:sldId id="302" r:id="rId8"/>
     <p:sldId id="305" r:id="rId9"/>
-    <p:sldId id="303" r:id="rId10"/>
-    <p:sldId id="304" r:id="rId11"/>
+    <p:sldId id="306" r:id="rId10"/>
+    <p:sldId id="307" r:id="rId11"/>
+    <p:sldId id="303" r:id="rId12"/>
+    <p:sldId id="304" r:id="rId13"/>
   </p:sldIdLst>
   <p:sldSz cx="9144000" cy="6858000" type="screen4x3"/>
   <p:notesSz cx="7559675" cy="10691813"/>
@@ -163,30 +165,6 @@
     </pc:docChg>
   </pc:docChgLst>
   <pc:docChgLst>
-    <pc:chgData name="Tiago Janela" userId="ee1a79fe-c79c-4f34-9602-7f6f2f0482b3" providerId="ADAL" clId="{A1A622BE-A8AD-47B7-8802-BAC61BCE5126}"/>
-    <pc:docChg chg="undo custSel modSld">
-      <pc:chgData name="Tiago Janela" userId="ee1a79fe-c79c-4f34-9602-7f6f2f0482b3" providerId="ADAL" clId="{A1A622BE-A8AD-47B7-8802-BAC61BCE5126}" dt="2026-04-02T12:40:40.607" v="50" actId="478"/>
-      <pc:docMkLst>
-        <pc:docMk/>
-      </pc:docMkLst>
-      <pc:sldChg chg="addSp delSp modSp mod">
-        <pc:chgData name="Tiago Janela" userId="ee1a79fe-c79c-4f34-9602-7f6f2f0482b3" providerId="ADAL" clId="{A1A622BE-A8AD-47B7-8802-BAC61BCE5126}" dt="2026-04-02T12:40:40.607" v="50" actId="478"/>
-        <pc:sldMkLst>
-          <pc:docMk/>
-          <pc:sldMk cId="1707478755" sldId="299"/>
-        </pc:sldMkLst>
-        <pc:graphicFrameChg chg="add del modGraphic">
-          <ac:chgData name="Tiago Janela" userId="ee1a79fe-c79c-4f34-9602-7f6f2f0482b3" providerId="ADAL" clId="{A1A622BE-A8AD-47B7-8802-BAC61BCE5126}" dt="2026-04-02T12:40:40.607" v="50" actId="478"/>
-          <ac:graphicFrameMkLst>
-            <pc:docMk/>
-            <pc:sldMk cId="1707478755" sldId="299"/>
-            <ac:graphicFrameMk id="4" creationId="{689F2044-8E26-DCF5-DE2D-9AD979C8C1EE}"/>
-          </ac:graphicFrameMkLst>
-        </pc:graphicFrameChg>
-      </pc:sldChg>
-    </pc:docChg>
-  </pc:docChgLst>
-  <pc:docChgLst>
     <pc:chgData name="Tiago Janela" userId="ee1a79fe-c79c-4f34-9602-7f6f2f0482b3" providerId="ADAL" clId="{6BE67FA1-4A27-48B9-BA6A-E25A9786A9CC}"/>
     <pc:docChg chg="undo custSel addSld modSld sldOrd">
       <pc:chgData name="Tiago Janela" userId="ee1a79fe-c79c-4f34-9602-7f6f2f0482b3" providerId="ADAL" clId="{6BE67FA1-4A27-48B9-BA6A-E25A9786A9CC}" dt="2026-03-20T13:52:23.099" v="1063" actId="20577"/>
@@ -292,6 +270,30 @@
             <ac:picMk id="6" creationId="{D3BA145D-265C-C0B1-7C0E-2EE32552E491}"/>
           </ac:picMkLst>
         </pc:picChg>
+      </pc:sldChg>
+    </pc:docChg>
+  </pc:docChgLst>
+  <pc:docChgLst>
+    <pc:chgData name="Tiago Janela" userId="ee1a79fe-c79c-4f34-9602-7f6f2f0482b3" providerId="ADAL" clId="{A1A622BE-A8AD-47B7-8802-BAC61BCE5126}"/>
+    <pc:docChg chg="undo custSel modSld">
+      <pc:chgData name="Tiago Janela" userId="ee1a79fe-c79c-4f34-9602-7f6f2f0482b3" providerId="ADAL" clId="{A1A622BE-A8AD-47B7-8802-BAC61BCE5126}" dt="2026-04-02T12:40:40.607" v="50" actId="478"/>
+      <pc:docMkLst>
+        <pc:docMk/>
+      </pc:docMkLst>
+      <pc:sldChg chg="addSp delSp modSp mod">
+        <pc:chgData name="Tiago Janela" userId="ee1a79fe-c79c-4f34-9602-7f6f2f0482b3" providerId="ADAL" clId="{A1A622BE-A8AD-47B7-8802-BAC61BCE5126}" dt="2026-04-02T12:40:40.607" v="50" actId="478"/>
+        <pc:sldMkLst>
+          <pc:docMk/>
+          <pc:sldMk cId="1707478755" sldId="299"/>
+        </pc:sldMkLst>
+        <pc:graphicFrameChg chg="add del modGraphic">
+          <ac:chgData name="Tiago Janela" userId="ee1a79fe-c79c-4f34-9602-7f6f2f0482b3" providerId="ADAL" clId="{A1A622BE-A8AD-47B7-8802-BAC61BCE5126}" dt="2026-04-02T12:40:40.607" v="50" actId="478"/>
+          <ac:graphicFrameMkLst>
+            <pc:docMk/>
+            <pc:sldMk cId="1707478755" sldId="299"/>
+            <ac:graphicFrameMk id="4" creationId="{689F2044-8E26-DCF5-DE2D-9AD979C8C1EE}"/>
+          </ac:graphicFrameMkLst>
+        </pc:graphicFrameChg>
       </pc:sldChg>
     </pc:docChg>
   </pc:docChgLst>
@@ -8785,7 +8787,7 @@
                 </a:solidFill>
                 <a:latin typeface="Century Gothic"/>
               </a:rPr>
-              <a:t>‹nº›</a:t>
+              <a:t>‹#›</a:t>
             </a:fld>
             <a:endParaRPr lang="en-GB" sz="1200" b="0" strike="noStrike" spc="-1">
               <a:latin typeface="Times New Roman"/>
@@ -9345,18 +9347,1235 @@
   <p:clrMapOvr>
     <a:masterClrMapping/>
   </p:clrMapOvr>
-  <mc:AlternateContent xmlns:mc="http://schemas.openxmlformats.org/markup-compatibility/2006" xmlns:p14="http://schemas.microsoft.com/office/powerpoint/2010/main">
-    <mc:Choice Requires="p14">
-      <p:transition spd="med" p14:dur="700">
-        <p:fade/>
-      </p:transition>
-    </mc:Choice>
-    <mc:Fallback xmlns:p15="http://schemas.microsoft.com/office/powerpoint/2012/main" xmlns="">
-      <p:transition spd="med">
-        <p:fade/>
-      </p:transition>
-    </mc:Fallback>
-  </mc:AlternateContent>
+</p:sld>
+</file>
+
+<file path=ppt/slides/slide10.xml><?xml version="1.0" encoding="utf-8"?>
+<p:sld xmlns:a="http://schemas.openxmlformats.org/drawingml/2006/main" xmlns:r="http://schemas.openxmlformats.org/officeDocument/2006/relationships" xmlns:p="http://schemas.openxmlformats.org/presentationml/2006/main">
+  <p:cSld>
+    <p:spTree>
+      <p:nvGrpSpPr>
+        <p:cNvPr id="1" name="">
+          <a:extLst>
+            <a:ext uri="{FF2B5EF4-FFF2-40B4-BE49-F238E27FC236}">
+              <a16:creationId xmlns:a16="http://schemas.microsoft.com/office/drawing/2014/main" id="{A6515F23-0912-A838-23CE-B8F00573A2DA}"/>
+            </a:ext>
+          </a:extLst>
+        </p:cNvPr>
+        <p:cNvGrpSpPr/>
+        <p:nvPr/>
+      </p:nvGrpSpPr>
+      <p:grpSpPr>
+        <a:xfrm>
+          <a:off x="0" y="0"/>
+          <a:ext cx="0" cy="0"/>
+          <a:chOff x="0" y="0"/>
+          <a:chExt cx="0" cy="0"/>
+        </a:xfrm>
+      </p:grpSpPr>
+      <p:sp>
+        <p:nvSpPr>
+          <p:cNvPr id="163" name="PlaceHolder 1">
+            <a:extLst>
+              <a:ext uri="{FF2B5EF4-FFF2-40B4-BE49-F238E27FC236}">
+                <a16:creationId xmlns:a16="http://schemas.microsoft.com/office/drawing/2014/main" id="{57944F4B-F502-E7CC-8790-8737702BC6AC}"/>
+              </a:ext>
+            </a:extLst>
+          </p:cNvPr>
+          <p:cNvSpPr>
+            <a:spLocks noGrp="1"/>
+          </p:cNvSpPr>
+          <p:nvPr>
+            <p:ph type="title"/>
+          </p:nvPr>
+        </p:nvSpPr>
+        <p:spPr>
+          <a:xfrm>
+            <a:off x="380880" y="228600"/>
+            <a:ext cx="8380080" cy="837720"/>
+          </a:xfrm>
+          <a:prstGeom prst="rect">
+            <a:avLst/>
+          </a:prstGeom>
+          <a:noFill/>
+          <a:ln w="0">
+            <a:noFill/>
+          </a:ln>
+        </p:spPr>
+        <p:txBody>
+          <a:bodyPr numCol="1" spcCol="0" anchor="ctr">
+            <a:noAutofit/>
+          </a:bodyPr>
+          <a:lstStyle/>
+          <a:p>
+            <a:pPr>
+              <a:lnSpc>
+                <a:spcPct val="100000"/>
+              </a:lnSpc>
+              <a:buNone/>
+            </a:pPr>
+            <a:r>
+              <a:rPr lang="en-US" sz="3200" b="0" strike="noStrike" spc="-1" dirty="0">
+                <a:solidFill>
+                  <a:srgbClr val="0064C8"/>
+                </a:solidFill>
+                <a:latin typeface="Century Gothic"/>
+              </a:rPr>
+              <a:t>To do list</a:t>
+            </a:r>
+            <a:endParaRPr lang="en-US" sz="3200" b="0" strike="noStrike" spc="-1" dirty="0">
+              <a:solidFill>
+                <a:srgbClr val="000000"/>
+              </a:solidFill>
+              <a:latin typeface="Century Gothic"/>
+            </a:endParaRPr>
+          </a:p>
+        </p:txBody>
+      </p:sp>
+      <p:sp>
+        <p:nvSpPr>
+          <p:cNvPr id="165" name="PlaceHolder 3">
+            <a:extLst>
+              <a:ext uri="{FF2B5EF4-FFF2-40B4-BE49-F238E27FC236}">
+                <a16:creationId xmlns:a16="http://schemas.microsoft.com/office/drawing/2014/main" id="{2EFBEA53-7B78-D9A1-93EF-9608A3193D27}"/>
+              </a:ext>
+            </a:extLst>
+          </p:cNvPr>
+          <p:cNvSpPr>
+            <a:spLocks noGrp="1"/>
+          </p:cNvSpPr>
+          <p:nvPr>
+            <p:ph type="sldNum"/>
+          </p:nvPr>
+        </p:nvSpPr>
+        <p:spPr>
+          <a:xfrm>
+            <a:off x="8376840" y="5692680"/>
+            <a:ext cx="384120" cy="364680"/>
+          </a:xfrm>
+          <a:prstGeom prst="rect">
+            <a:avLst/>
+          </a:prstGeom>
+          <a:noFill/>
+          <a:ln w="0">
+            <a:noFill/>
+          </a:ln>
+        </p:spPr>
+        <p:txBody>
+          <a:bodyPr anchor="ctr">
+            <a:noAutofit/>
+          </a:bodyPr>
+          <a:lstStyle/>
+          <a:p>
+            <a:pPr algn="r">
+              <a:lnSpc>
+                <a:spcPct val="100000"/>
+              </a:lnSpc>
+              <a:buNone/>
+            </a:pPr>
+            <a:fld id="{8BD7C522-1E12-40C3-B25E-5F0462E20B22}" type="slidenum">
+              <a:rPr lang="en-US" sz="1200" b="0" strike="noStrike" spc="-1">
+                <a:solidFill>
+                  <a:srgbClr val="8B8B8B"/>
+                </a:solidFill>
+                <a:latin typeface="Century Gothic"/>
+              </a:rPr>
+              <a:t>10</a:t>
+            </a:fld>
+            <a:endParaRPr lang="en-GB" sz="1200" b="0" strike="noStrike" spc="-1" dirty="0">
+              <a:latin typeface="Times New Roman"/>
+            </a:endParaRPr>
+          </a:p>
+        </p:txBody>
+      </p:sp>
+      <p:sp>
+        <p:nvSpPr>
+          <p:cNvPr id="7" name="PlaceHolder 2">
+            <a:extLst>
+              <a:ext uri="{FF2B5EF4-FFF2-40B4-BE49-F238E27FC236}">
+                <a16:creationId xmlns:a16="http://schemas.microsoft.com/office/drawing/2014/main" id="{66DE14D4-64D4-6D1F-DD92-BC16D674C58B}"/>
+              </a:ext>
+            </a:extLst>
+          </p:cNvPr>
+          <p:cNvSpPr txBox="1">
+            <a:spLocks/>
+          </p:cNvSpPr>
+          <p:nvPr/>
+        </p:nvSpPr>
+        <p:spPr>
+          <a:xfrm>
+            <a:off x="380880" y="1371598"/>
+            <a:ext cx="8109070" cy="4559301"/>
+          </a:xfrm>
+          <a:prstGeom prst="rect">
+            <a:avLst/>
+          </a:prstGeom>
+          <a:noFill/>
+          <a:ln w="0">
+            <a:noFill/>
+          </a:ln>
+        </p:spPr>
+        <p:txBody>
+          <a:bodyPr numCol="1" spcCol="0" anchor="t">
+            <a:noAutofit/>
+          </a:bodyPr>
+          <a:lstStyle>
+            <a:lvl1pPr marL="228600" indent="-228600" algn="l" defTabSz="914400" rtl="0" eaLnBrk="1" latinLnBrk="0" hangingPunct="1">
+              <a:lnSpc>
+                <a:spcPct val="90000"/>
+              </a:lnSpc>
+              <a:spcBef>
+                <a:spcPts val="1000"/>
+              </a:spcBef>
+              <a:buFont typeface="Arial" panose="020B0604020202020204" pitchFamily="34" charset="0"/>
+              <a:buChar char="•"/>
+              <a:defRPr sz="2800" kern="1200">
+                <a:solidFill>
+                  <a:schemeClr val="tx1"/>
+                </a:solidFill>
+                <a:latin typeface="+mn-lt"/>
+                <a:ea typeface="+mn-ea"/>
+                <a:cs typeface="+mn-cs"/>
+              </a:defRPr>
+            </a:lvl1pPr>
+            <a:lvl2pPr marL="685800" indent="-228600" algn="l" defTabSz="914400" rtl="0" eaLnBrk="1" latinLnBrk="0" hangingPunct="1">
+              <a:lnSpc>
+                <a:spcPct val="90000"/>
+              </a:lnSpc>
+              <a:spcBef>
+                <a:spcPts val="500"/>
+              </a:spcBef>
+              <a:buFont typeface="Arial" panose="020B0604020202020204" pitchFamily="34" charset="0"/>
+              <a:buChar char="•"/>
+              <a:defRPr sz="2400" kern="1200">
+                <a:solidFill>
+                  <a:schemeClr val="tx1"/>
+                </a:solidFill>
+                <a:latin typeface="+mn-lt"/>
+                <a:ea typeface="+mn-ea"/>
+                <a:cs typeface="+mn-cs"/>
+              </a:defRPr>
+            </a:lvl2pPr>
+            <a:lvl3pPr marL="1143000" indent="-228600" algn="l" defTabSz="914400" rtl="0" eaLnBrk="1" latinLnBrk="0" hangingPunct="1">
+              <a:lnSpc>
+                <a:spcPct val="90000"/>
+              </a:lnSpc>
+              <a:spcBef>
+                <a:spcPts val="500"/>
+              </a:spcBef>
+              <a:buFont typeface="Arial" panose="020B0604020202020204" pitchFamily="34" charset="0"/>
+              <a:buChar char="•"/>
+              <a:defRPr sz="2000" kern="1200">
+                <a:solidFill>
+                  <a:schemeClr val="tx1"/>
+                </a:solidFill>
+                <a:latin typeface="+mn-lt"/>
+                <a:ea typeface="+mn-ea"/>
+                <a:cs typeface="+mn-cs"/>
+              </a:defRPr>
+            </a:lvl3pPr>
+            <a:lvl4pPr marL="1600200" indent="-228600" algn="l" defTabSz="914400" rtl="0" eaLnBrk="1" latinLnBrk="0" hangingPunct="1">
+              <a:lnSpc>
+                <a:spcPct val="90000"/>
+              </a:lnSpc>
+              <a:spcBef>
+                <a:spcPts val="500"/>
+              </a:spcBef>
+              <a:buFont typeface="Arial" panose="020B0604020202020204" pitchFamily="34" charset="0"/>
+              <a:buChar char="•"/>
+              <a:defRPr sz="1800" kern="1200">
+                <a:solidFill>
+                  <a:schemeClr val="tx1"/>
+                </a:solidFill>
+                <a:latin typeface="+mn-lt"/>
+                <a:ea typeface="+mn-ea"/>
+                <a:cs typeface="+mn-cs"/>
+              </a:defRPr>
+            </a:lvl4pPr>
+            <a:lvl5pPr marL="2057400" indent="-228600" algn="l" defTabSz="914400" rtl="0" eaLnBrk="1" latinLnBrk="0" hangingPunct="1">
+              <a:lnSpc>
+                <a:spcPct val="90000"/>
+              </a:lnSpc>
+              <a:spcBef>
+                <a:spcPts val="500"/>
+              </a:spcBef>
+              <a:buFont typeface="Arial" panose="020B0604020202020204" pitchFamily="34" charset="0"/>
+              <a:buChar char="•"/>
+              <a:defRPr sz="1800" kern="1200">
+                <a:solidFill>
+                  <a:schemeClr val="tx1"/>
+                </a:solidFill>
+                <a:latin typeface="+mn-lt"/>
+                <a:ea typeface="+mn-ea"/>
+                <a:cs typeface="+mn-cs"/>
+              </a:defRPr>
+            </a:lvl5pPr>
+            <a:lvl6pPr marL="2514600" indent="-228600" algn="l" defTabSz="914400" rtl="0" eaLnBrk="1" latinLnBrk="0" hangingPunct="1">
+              <a:lnSpc>
+                <a:spcPct val="90000"/>
+              </a:lnSpc>
+              <a:spcBef>
+                <a:spcPts val="500"/>
+              </a:spcBef>
+              <a:buFont typeface="Arial" panose="020B0604020202020204" pitchFamily="34" charset="0"/>
+              <a:buChar char="•"/>
+              <a:defRPr sz="1800" kern="1200">
+                <a:solidFill>
+                  <a:schemeClr val="tx1"/>
+                </a:solidFill>
+                <a:latin typeface="+mn-lt"/>
+                <a:ea typeface="+mn-ea"/>
+                <a:cs typeface="+mn-cs"/>
+              </a:defRPr>
+            </a:lvl6pPr>
+            <a:lvl7pPr marL="2971800" indent="-228600" algn="l" defTabSz="914400" rtl="0" eaLnBrk="1" latinLnBrk="0" hangingPunct="1">
+              <a:lnSpc>
+                <a:spcPct val="90000"/>
+              </a:lnSpc>
+              <a:spcBef>
+                <a:spcPts val="500"/>
+              </a:spcBef>
+              <a:buFont typeface="Arial" panose="020B0604020202020204" pitchFamily="34" charset="0"/>
+              <a:buChar char="•"/>
+              <a:defRPr sz="1800" kern="1200">
+                <a:solidFill>
+                  <a:schemeClr val="tx1"/>
+                </a:solidFill>
+                <a:latin typeface="+mn-lt"/>
+                <a:ea typeface="+mn-ea"/>
+                <a:cs typeface="+mn-cs"/>
+              </a:defRPr>
+            </a:lvl7pPr>
+            <a:lvl8pPr marL="3429000" indent="-228600" algn="l" defTabSz="914400" rtl="0" eaLnBrk="1" latinLnBrk="0" hangingPunct="1">
+              <a:lnSpc>
+                <a:spcPct val="90000"/>
+              </a:lnSpc>
+              <a:spcBef>
+                <a:spcPts val="500"/>
+              </a:spcBef>
+              <a:buFont typeface="Arial" panose="020B0604020202020204" pitchFamily="34" charset="0"/>
+              <a:buChar char="•"/>
+              <a:defRPr sz="1800" kern="1200">
+                <a:solidFill>
+                  <a:schemeClr val="tx1"/>
+                </a:solidFill>
+                <a:latin typeface="+mn-lt"/>
+                <a:ea typeface="+mn-ea"/>
+                <a:cs typeface="+mn-cs"/>
+              </a:defRPr>
+            </a:lvl8pPr>
+            <a:lvl9pPr marL="3886200" indent="-228600" algn="l" defTabSz="914400" rtl="0" eaLnBrk="1" latinLnBrk="0" hangingPunct="1">
+              <a:lnSpc>
+                <a:spcPct val="90000"/>
+              </a:lnSpc>
+              <a:spcBef>
+                <a:spcPts val="500"/>
+              </a:spcBef>
+              <a:buFont typeface="Arial" panose="020B0604020202020204" pitchFamily="34" charset="0"/>
+              <a:buChar char="•"/>
+              <a:defRPr sz="1800" kern="1200">
+                <a:solidFill>
+                  <a:schemeClr val="tx1"/>
+                </a:solidFill>
+                <a:latin typeface="+mn-lt"/>
+                <a:ea typeface="+mn-ea"/>
+                <a:cs typeface="+mn-cs"/>
+              </a:defRPr>
+            </a:lvl9pPr>
+          </a:lstStyle>
+          <a:p>
+            <a:pPr>
+              <a:lnSpc>
+                <a:spcPct val="100000"/>
+              </a:lnSpc>
+              <a:spcBef>
+                <a:spcPts val="400"/>
+              </a:spcBef>
+              <a:buClr>
+                <a:srgbClr val="0064C8"/>
+              </a:buClr>
+              <a:buFont typeface="Wingdings" panose="05000000000000000000" pitchFamily="2" charset="2"/>
+              <a:buChar char="§"/>
+            </a:pPr>
+            <a:r>
+              <a:rPr lang="en-US" sz="2000" spc="-1" dirty="0">
+                <a:solidFill>
+                  <a:srgbClr val="000000"/>
+                </a:solidFill>
+                <a:latin typeface="Century Gothic"/>
+              </a:rPr>
+              <a:t>Integrate with cluster for faster inference and explore larger LLMs</a:t>
+            </a:r>
+          </a:p>
+          <a:p>
+            <a:pPr>
+              <a:lnSpc>
+                <a:spcPct val="100000"/>
+              </a:lnSpc>
+              <a:spcBef>
+                <a:spcPts val="400"/>
+              </a:spcBef>
+              <a:buClr>
+                <a:srgbClr val="0064C8"/>
+              </a:buClr>
+              <a:buFont typeface="Wingdings" panose="05000000000000000000" pitchFamily="2" charset="2"/>
+              <a:buChar char="§"/>
+            </a:pPr>
+            <a:endParaRPr lang="en-US" sz="2000" spc="-1" dirty="0">
+              <a:solidFill>
+                <a:srgbClr val="000000"/>
+              </a:solidFill>
+              <a:latin typeface="Century Gothic"/>
+            </a:endParaRPr>
+          </a:p>
+          <a:p>
+            <a:pPr lvl="1">
+              <a:lnSpc>
+                <a:spcPct val="100000"/>
+              </a:lnSpc>
+              <a:spcBef>
+                <a:spcPts val="400"/>
+              </a:spcBef>
+              <a:buClr>
+                <a:srgbClr val="0064C8"/>
+              </a:buClr>
+              <a:buFont typeface="Wingdings" panose="05000000000000000000" pitchFamily="2" charset="2"/>
+              <a:buChar char="§"/>
+            </a:pPr>
+            <a:r>
+              <a:rPr lang="en-US" sz="1600" spc="-1" dirty="0">
+                <a:solidFill>
+                  <a:srgbClr val="000000"/>
+                </a:solidFill>
+                <a:latin typeface="Century Gothic"/>
+              </a:rPr>
+              <a:t>It works already on the workstations with medium-to-large LLMs</a:t>
+            </a:r>
+          </a:p>
+          <a:p>
+            <a:pPr marL="0" indent="0">
+              <a:lnSpc>
+                <a:spcPct val="100000"/>
+              </a:lnSpc>
+              <a:spcBef>
+                <a:spcPts val="400"/>
+              </a:spcBef>
+              <a:buClr>
+                <a:srgbClr val="0064C8"/>
+              </a:buClr>
+              <a:buNone/>
+            </a:pPr>
+            <a:endParaRPr lang="en-US" sz="2000" spc="-1" dirty="0">
+              <a:solidFill>
+                <a:srgbClr val="000000"/>
+              </a:solidFill>
+              <a:latin typeface="Century Gothic"/>
+            </a:endParaRPr>
+          </a:p>
+          <a:p>
+            <a:pPr>
+              <a:lnSpc>
+                <a:spcPct val="100000"/>
+              </a:lnSpc>
+              <a:spcBef>
+                <a:spcPts val="400"/>
+              </a:spcBef>
+              <a:buClr>
+                <a:srgbClr val="0064C8"/>
+              </a:buClr>
+              <a:buFont typeface="Wingdings" panose="05000000000000000000" pitchFamily="2" charset="2"/>
+              <a:buChar char="§"/>
+            </a:pPr>
+            <a:r>
+              <a:rPr lang="en-US" sz="2000" spc="-1" dirty="0">
+                <a:solidFill>
+                  <a:srgbClr val="000000"/>
+                </a:solidFill>
+                <a:latin typeface="Century Gothic"/>
+              </a:rPr>
+              <a:t>Clean up the repository and make it available </a:t>
+            </a:r>
+          </a:p>
+          <a:p>
+            <a:pPr>
+              <a:lnSpc>
+                <a:spcPct val="100000"/>
+              </a:lnSpc>
+              <a:spcBef>
+                <a:spcPts val="400"/>
+              </a:spcBef>
+              <a:buClr>
+                <a:srgbClr val="0064C8"/>
+              </a:buClr>
+              <a:buFont typeface="Wingdings" panose="05000000000000000000" pitchFamily="2" charset="2"/>
+              <a:buChar char="§"/>
+            </a:pPr>
+            <a:endParaRPr lang="en-US" sz="2000" spc="-1" dirty="0">
+              <a:solidFill>
+                <a:srgbClr val="000000"/>
+              </a:solidFill>
+              <a:latin typeface="Century Gothic"/>
+            </a:endParaRPr>
+          </a:p>
+          <a:p>
+            <a:pPr lvl="1">
+              <a:lnSpc>
+                <a:spcPct val="100000"/>
+              </a:lnSpc>
+              <a:spcBef>
+                <a:spcPts val="400"/>
+              </a:spcBef>
+              <a:buClr>
+                <a:srgbClr val="0064C8"/>
+              </a:buClr>
+              <a:buFont typeface="Wingdings" panose="05000000000000000000" pitchFamily="2" charset="2"/>
+              <a:buChar char="§"/>
+            </a:pPr>
+            <a:r>
+              <a:rPr lang="en-US" sz="1600" spc="-1" dirty="0">
+                <a:solidFill>
+                  <a:srgbClr val="000000"/>
+                </a:solidFill>
+                <a:latin typeface="Century Gothic"/>
+              </a:rPr>
+              <a:t>An “organization repository” is available for the whole lab to ease the integration of new components</a:t>
+            </a:r>
+          </a:p>
+          <a:p>
+            <a:pPr>
+              <a:lnSpc>
+                <a:spcPct val="100000"/>
+              </a:lnSpc>
+              <a:spcBef>
+                <a:spcPts val="400"/>
+              </a:spcBef>
+              <a:buClr>
+                <a:srgbClr val="0064C8"/>
+              </a:buClr>
+              <a:buFont typeface="Wingdings" panose="05000000000000000000" pitchFamily="2" charset="2"/>
+              <a:buChar char="§"/>
+            </a:pPr>
+            <a:endParaRPr lang="en-US" sz="2000" spc="-1" dirty="0">
+              <a:solidFill>
+                <a:srgbClr val="000000"/>
+              </a:solidFill>
+              <a:latin typeface="Century Gothic"/>
+            </a:endParaRPr>
+          </a:p>
+          <a:p>
+            <a:pPr>
+              <a:lnSpc>
+                <a:spcPct val="100000"/>
+              </a:lnSpc>
+              <a:spcBef>
+                <a:spcPts val="400"/>
+              </a:spcBef>
+              <a:buClr>
+                <a:srgbClr val="0064C8"/>
+              </a:buClr>
+              <a:buFont typeface="Wingdings" panose="05000000000000000000" pitchFamily="2" charset="2"/>
+              <a:buChar char="§"/>
+            </a:pPr>
+            <a:r>
+              <a:rPr lang="en-US" sz="2000" spc="-1" dirty="0">
+                <a:solidFill>
+                  <a:srgbClr val="000000"/>
+                </a:solidFill>
+                <a:latin typeface="Century Gothic"/>
+              </a:rPr>
+              <a:t>Make a guide for lab members for the implementation of AI agents</a:t>
+            </a:r>
+          </a:p>
+          <a:p>
+            <a:pPr>
+              <a:lnSpc>
+                <a:spcPct val="100000"/>
+              </a:lnSpc>
+              <a:spcBef>
+                <a:spcPts val="400"/>
+              </a:spcBef>
+              <a:buClr>
+                <a:srgbClr val="0064C8"/>
+              </a:buClr>
+              <a:buFont typeface="Wingdings" panose="05000000000000000000" pitchFamily="2" charset="2"/>
+              <a:buChar char="§"/>
+            </a:pPr>
+            <a:endParaRPr lang="en-US" sz="2000" spc="-1" dirty="0">
+              <a:solidFill>
+                <a:srgbClr val="000000"/>
+              </a:solidFill>
+              <a:latin typeface="Century Gothic"/>
+            </a:endParaRPr>
+          </a:p>
+          <a:p>
+            <a:pPr>
+              <a:lnSpc>
+                <a:spcPct val="100000"/>
+              </a:lnSpc>
+              <a:spcBef>
+                <a:spcPts val="400"/>
+              </a:spcBef>
+              <a:buClr>
+                <a:srgbClr val="0064C8"/>
+              </a:buClr>
+              <a:buFont typeface="Wingdings" panose="05000000000000000000" pitchFamily="2" charset="2"/>
+              <a:buChar char="§"/>
+            </a:pPr>
+            <a:endParaRPr lang="en-US" sz="1800" spc="-1" dirty="0">
+              <a:solidFill>
+                <a:srgbClr val="000000"/>
+              </a:solidFill>
+              <a:latin typeface="Century Gothic"/>
+            </a:endParaRPr>
+          </a:p>
+          <a:p>
+            <a:pPr marL="343080" indent="-343080">
+              <a:lnSpc>
+                <a:spcPct val="100000"/>
+              </a:lnSpc>
+              <a:spcBef>
+                <a:spcPts val="400"/>
+              </a:spcBef>
+              <a:spcAft>
+                <a:spcPts val="601"/>
+              </a:spcAft>
+              <a:buClr>
+                <a:srgbClr val="0064C8"/>
+              </a:buClr>
+              <a:buFont typeface="Wingdings 2" charset="2"/>
+              <a:buChar char=""/>
+            </a:pPr>
+            <a:endParaRPr lang="en-US" sz="2000" b="1" spc="-1" dirty="0">
+              <a:solidFill>
+                <a:srgbClr val="000000"/>
+              </a:solidFill>
+              <a:latin typeface="Century Gothic"/>
+            </a:endParaRPr>
+          </a:p>
+        </p:txBody>
+      </p:sp>
+    </p:spTree>
+    <p:extLst>
+      <p:ext uri="{BB962C8B-B14F-4D97-AF65-F5344CB8AC3E}">
+        <p14:creationId xmlns:p14="http://schemas.microsoft.com/office/powerpoint/2010/main" val="3727029337"/>
+      </p:ext>
+    </p:extLst>
+  </p:cSld>
+  <p:clrMapOvr>
+    <a:masterClrMapping/>
+  </p:clrMapOvr>
+</p:sld>
+</file>
+
+<file path=ppt/slides/slide11.xml><?xml version="1.0" encoding="utf-8"?>
+<p:sld xmlns:a="http://schemas.openxmlformats.org/drawingml/2006/main" xmlns:r="http://schemas.openxmlformats.org/officeDocument/2006/relationships" xmlns:p="http://schemas.openxmlformats.org/presentationml/2006/main">
+  <p:cSld>
+    <p:spTree>
+      <p:nvGrpSpPr>
+        <p:cNvPr id="1" name="">
+          <a:extLst>
+            <a:ext uri="{FF2B5EF4-FFF2-40B4-BE49-F238E27FC236}">
+              <a16:creationId xmlns:a16="http://schemas.microsoft.com/office/drawing/2014/main" id="{A6515F23-0912-A838-23CE-B8F00573A2DA}"/>
+            </a:ext>
+          </a:extLst>
+        </p:cNvPr>
+        <p:cNvGrpSpPr/>
+        <p:nvPr/>
+      </p:nvGrpSpPr>
+      <p:grpSpPr>
+        <a:xfrm>
+          <a:off x="0" y="0"/>
+          <a:ext cx="0" cy="0"/>
+          <a:chOff x="0" y="0"/>
+          <a:chExt cx="0" cy="0"/>
+        </a:xfrm>
+      </p:grpSpPr>
+      <p:sp>
+        <p:nvSpPr>
+          <p:cNvPr id="163" name="PlaceHolder 1">
+            <a:extLst>
+              <a:ext uri="{FF2B5EF4-FFF2-40B4-BE49-F238E27FC236}">
+                <a16:creationId xmlns:a16="http://schemas.microsoft.com/office/drawing/2014/main" id="{57944F4B-F502-E7CC-8790-8737702BC6AC}"/>
+              </a:ext>
+            </a:extLst>
+          </p:cNvPr>
+          <p:cNvSpPr>
+            <a:spLocks noGrp="1"/>
+          </p:cNvSpPr>
+          <p:nvPr>
+            <p:ph type="title"/>
+          </p:nvPr>
+        </p:nvSpPr>
+        <p:spPr>
+          <a:xfrm>
+            <a:off x="380880" y="228600"/>
+            <a:ext cx="8380080" cy="837720"/>
+          </a:xfrm>
+          <a:prstGeom prst="rect">
+            <a:avLst/>
+          </a:prstGeom>
+          <a:noFill/>
+          <a:ln w="0">
+            <a:noFill/>
+          </a:ln>
+        </p:spPr>
+        <p:txBody>
+          <a:bodyPr numCol="1" spcCol="0" anchor="ctr">
+            <a:noAutofit/>
+          </a:bodyPr>
+          <a:lstStyle/>
+          <a:p>
+            <a:pPr>
+              <a:lnSpc>
+                <a:spcPct val="100000"/>
+              </a:lnSpc>
+              <a:buNone/>
+            </a:pPr>
+            <a:r>
+              <a:rPr lang="en-US" sz="3200" b="0" strike="noStrike" spc="-1" dirty="0">
+                <a:solidFill>
+                  <a:srgbClr val="0064C8"/>
+                </a:solidFill>
+                <a:latin typeface="Century Gothic"/>
+              </a:rPr>
+              <a:t>Framing</a:t>
+            </a:r>
+            <a:endParaRPr lang="en-US" sz="3200" b="0" strike="noStrike" spc="-1" dirty="0">
+              <a:solidFill>
+                <a:srgbClr val="000000"/>
+              </a:solidFill>
+              <a:latin typeface="Century Gothic"/>
+            </a:endParaRPr>
+          </a:p>
+        </p:txBody>
+      </p:sp>
+      <p:sp>
+        <p:nvSpPr>
+          <p:cNvPr id="165" name="PlaceHolder 3">
+            <a:extLst>
+              <a:ext uri="{FF2B5EF4-FFF2-40B4-BE49-F238E27FC236}">
+                <a16:creationId xmlns:a16="http://schemas.microsoft.com/office/drawing/2014/main" id="{2EFBEA53-7B78-D9A1-93EF-9608A3193D27}"/>
+              </a:ext>
+            </a:extLst>
+          </p:cNvPr>
+          <p:cNvSpPr>
+            <a:spLocks noGrp="1"/>
+          </p:cNvSpPr>
+          <p:nvPr>
+            <p:ph type="sldNum"/>
+          </p:nvPr>
+        </p:nvSpPr>
+        <p:spPr>
+          <a:xfrm>
+            <a:off x="8376840" y="5692680"/>
+            <a:ext cx="384120" cy="364680"/>
+          </a:xfrm>
+          <a:prstGeom prst="rect">
+            <a:avLst/>
+          </a:prstGeom>
+          <a:noFill/>
+          <a:ln w="0">
+            <a:noFill/>
+          </a:ln>
+        </p:spPr>
+        <p:txBody>
+          <a:bodyPr anchor="ctr">
+            <a:noAutofit/>
+          </a:bodyPr>
+          <a:lstStyle/>
+          <a:p>
+            <a:pPr algn="r">
+              <a:lnSpc>
+                <a:spcPct val="100000"/>
+              </a:lnSpc>
+              <a:buNone/>
+            </a:pPr>
+            <a:fld id="{8BD7C522-1E12-40C3-B25E-5F0462E20B22}" type="slidenum">
+              <a:rPr lang="en-US" sz="1200" b="0" strike="noStrike" spc="-1">
+                <a:solidFill>
+                  <a:srgbClr val="8B8B8B"/>
+                </a:solidFill>
+                <a:latin typeface="Century Gothic"/>
+              </a:rPr>
+              <a:t>11</a:t>
+            </a:fld>
+            <a:endParaRPr lang="en-GB" sz="1200" b="0" strike="noStrike" spc="-1" dirty="0">
+              <a:latin typeface="Times New Roman"/>
+            </a:endParaRPr>
+          </a:p>
+        </p:txBody>
+      </p:sp>
+      <p:sp>
+        <p:nvSpPr>
+          <p:cNvPr id="7" name="PlaceHolder 2">
+            <a:extLst>
+              <a:ext uri="{FF2B5EF4-FFF2-40B4-BE49-F238E27FC236}">
+                <a16:creationId xmlns:a16="http://schemas.microsoft.com/office/drawing/2014/main" id="{66DE14D4-64D4-6D1F-DD92-BC16D674C58B}"/>
+              </a:ext>
+            </a:extLst>
+          </p:cNvPr>
+          <p:cNvSpPr txBox="1">
+            <a:spLocks/>
+          </p:cNvSpPr>
+          <p:nvPr/>
+        </p:nvSpPr>
+        <p:spPr>
+          <a:xfrm>
+            <a:off x="380880" y="1371598"/>
+            <a:ext cx="8109070" cy="4559301"/>
+          </a:xfrm>
+          <a:prstGeom prst="rect">
+            <a:avLst/>
+          </a:prstGeom>
+          <a:noFill/>
+          <a:ln w="0">
+            <a:noFill/>
+          </a:ln>
+        </p:spPr>
+        <p:txBody>
+          <a:bodyPr numCol="1" spcCol="0" anchor="t">
+            <a:noAutofit/>
+          </a:bodyPr>
+          <a:lstStyle>
+            <a:lvl1pPr marL="228600" indent="-228600" algn="l" defTabSz="914400" rtl="0" eaLnBrk="1" latinLnBrk="0" hangingPunct="1">
+              <a:lnSpc>
+                <a:spcPct val="90000"/>
+              </a:lnSpc>
+              <a:spcBef>
+                <a:spcPts val="1000"/>
+              </a:spcBef>
+              <a:buFont typeface="Arial" panose="020B0604020202020204" pitchFamily="34" charset="0"/>
+              <a:buChar char="•"/>
+              <a:defRPr sz="2800" kern="1200">
+                <a:solidFill>
+                  <a:schemeClr val="tx1"/>
+                </a:solidFill>
+                <a:latin typeface="+mn-lt"/>
+                <a:ea typeface="+mn-ea"/>
+                <a:cs typeface="+mn-cs"/>
+              </a:defRPr>
+            </a:lvl1pPr>
+            <a:lvl2pPr marL="685800" indent="-228600" algn="l" defTabSz="914400" rtl="0" eaLnBrk="1" latinLnBrk="0" hangingPunct="1">
+              <a:lnSpc>
+                <a:spcPct val="90000"/>
+              </a:lnSpc>
+              <a:spcBef>
+                <a:spcPts val="500"/>
+              </a:spcBef>
+              <a:buFont typeface="Arial" panose="020B0604020202020204" pitchFamily="34" charset="0"/>
+              <a:buChar char="•"/>
+              <a:defRPr sz="2400" kern="1200">
+                <a:solidFill>
+                  <a:schemeClr val="tx1"/>
+                </a:solidFill>
+                <a:latin typeface="+mn-lt"/>
+                <a:ea typeface="+mn-ea"/>
+                <a:cs typeface="+mn-cs"/>
+              </a:defRPr>
+            </a:lvl2pPr>
+            <a:lvl3pPr marL="1143000" indent="-228600" algn="l" defTabSz="914400" rtl="0" eaLnBrk="1" latinLnBrk="0" hangingPunct="1">
+              <a:lnSpc>
+                <a:spcPct val="90000"/>
+              </a:lnSpc>
+              <a:spcBef>
+                <a:spcPts val="500"/>
+              </a:spcBef>
+              <a:buFont typeface="Arial" panose="020B0604020202020204" pitchFamily="34" charset="0"/>
+              <a:buChar char="•"/>
+              <a:defRPr sz="2000" kern="1200">
+                <a:solidFill>
+                  <a:schemeClr val="tx1"/>
+                </a:solidFill>
+                <a:latin typeface="+mn-lt"/>
+                <a:ea typeface="+mn-ea"/>
+                <a:cs typeface="+mn-cs"/>
+              </a:defRPr>
+            </a:lvl3pPr>
+            <a:lvl4pPr marL="1600200" indent="-228600" algn="l" defTabSz="914400" rtl="0" eaLnBrk="1" latinLnBrk="0" hangingPunct="1">
+              <a:lnSpc>
+                <a:spcPct val="90000"/>
+              </a:lnSpc>
+              <a:spcBef>
+                <a:spcPts val="500"/>
+              </a:spcBef>
+              <a:buFont typeface="Arial" panose="020B0604020202020204" pitchFamily="34" charset="0"/>
+              <a:buChar char="•"/>
+              <a:defRPr sz="1800" kern="1200">
+                <a:solidFill>
+                  <a:schemeClr val="tx1"/>
+                </a:solidFill>
+                <a:latin typeface="+mn-lt"/>
+                <a:ea typeface="+mn-ea"/>
+                <a:cs typeface="+mn-cs"/>
+              </a:defRPr>
+            </a:lvl4pPr>
+            <a:lvl5pPr marL="2057400" indent="-228600" algn="l" defTabSz="914400" rtl="0" eaLnBrk="1" latinLnBrk="0" hangingPunct="1">
+              <a:lnSpc>
+                <a:spcPct val="90000"/>
+              </a:lnSpc>
+              <a:spcBef>
+                <a:spcPts val="500"/>
+              </a:spcBef>
+              <a:buFont typeface="Arial" panose="020B0604020202020204" pitchFamily="34" charset="0"/>
+              <a:buChar char="•"/>
+              <a:defRPr sz="1800" kern="1200">
+                <a:solidFill>
+                  <a:schemeClr val="tx1"/>
+                </a:solidFill>
+                <a:latin typeface="+mn-lt"/>
+                <a:ea typeface="+mn-ea"/>
+                <a:cs typeface="+mn-cs"/>
+              </a:defRPr>
+            </a:lvl5pPr>
+            <a:lvl6pPr marL="2514600" indent="-228600" algn="l" defTabSz="914400" rtl="0" eaLnBrk="1" latinLnBrk="0" hangingPunct="1">
+              <a:lnSpc>
+                <a:spcPct val="90000"/>
+              </a:lnSpc>
+              <a:spcBef>
+                <a:spcPts val="500"/>
+              </a:spcBef>
+              <a:buFont typeface="Arial" panose="020B0604020202020204" pitchFamily="34" charset="0"/>
+              <a:buChar char="•"/>
+              <a:defRPr sz="1800" kern="1200">
+                <a:solidFill>
+                  <a:schemeClr val="tx1"/>
+                </a:solidFill>
+                <a:latin typeface="+mn-lt"/>
+                <a:ea typeface="+mn-ea"/>
+                <a:cs typeface="+mn-cs"/>
+              </a:defRPr>
+            </a:lvl6pPr>
+            <a:lvl7pPr marL="2971800" indent="-228600" algn="l" defTabSz="914400" rtl="0" eaLnBrk="1" latinLnBrk="0" hangingPunct="1">
+              <a:lnSpc>
+                <a:spcPct val="90000"/>
+              </a:lnSpc>
+              <a:spcBef>
+                <a:spcPts val="500"/>
+              </a:spcBef>
+              <a:buFont typeface="Arial" panose="020B0604020202020204" pitchFamily="34" charset="0"/>
+              <a:buChar char="•"/>
+              <a:defRPr sz="1800" kern="1200">
+                <a:solidFill>
+                  <a:schemeClr val="tx1"/>
+                </a:solidFill>
+                <a:latin typeface="+mn-lt"/>
+                <a:ea typeface="+mn-ea"/>
+                <a:cs typeface="+mn-cs"/>
+              </a:defRPr>
+            </a:lvl7pPr>
+            <a:lvl8pPr marL="3429000" indent="-228600" algn="l" defTabSz="914400" rtl="0" eaLnBrk="1" latinLnBrk="0" hangingPunct="1">
+              <a:lnSpc>
+                <a:spcPct val="90000"/>
+              </a:lnSpc>
+              <a:spcBef>
+                <a:spcPts val="500"/>
+              </a:spcBef>
+              <a:buFont typeface="Arial" panose="020B0604020202020204" pitchFamily="34" charset="0"/>
+              <a:buChar char="•"/>
+              <a:defRPr sz="1800" kern="1200">
+                <a:solidFill>
+                  <a:schemeClr val="tx1"/>
+                </a:solidFill>
+                <a:latin typeface="+mn-lt"/>
+                <a:ea typeface="+mn-ea"/>
+                <a:cs typeface="+mn-cs"/>
+              </a:defRPr>
+            </a:lvl8pPr>
+            <a:lvl9pPr marL="3886200" indent="-228600" algn="l" defTabSz="914400" rtl="0" eaLnBrk="1" latinLnBrk="0" hangingPunct="1">
+              <a:lnSpc>
+                <a:spcPct val="90000"/>
+              </a:lnSpc>
+              <a:spcBef>
+                <a:spcPts val="500"/>
+              </a:spcBef>
+              <a:buFont typeface="Arial" panose="020B0604020202020204" pitchFamily="34" charset="0"/>
+              <a:buChar char="•"/>
+              <a:defRPr sz="1800" kern="1200">
+                <a:solidFill>
+                  <a:schemeClr val="tx1"/>
+                </a:solidFill>
+                <a:latin typeface="+mn-lt"/>
+                <a:ea typeface="+mn-ea"/>
+                <a:cs typeface="+mn-cs"/>
+              </a:defRPr>
+            </a:lvl9pPr>
+          </a:lstStyle>
+          <a:p>
+            <a:pPr>
+              <a:lnSpc>
+                <a:spcPct val="100000"/>
+              </a:lnSpc>
+              <a:spcBef>
+                <a:spcPts val="400"/>
+              </a:spcBef>
+              <a:buClr>
+                <a:srgbClr val="0064C8"/>
+              </a:buClr>
+              <a:buFont typeface="Wingdings" panose="05000000000000000000" pitchFamily="2" charset="2"/>
+              <a:buChar char="§"/>
+            </a:pPr>
+            <a:r>
+              <a:rPr lang="en-US" sz="2000" spc="-1" dirty="0">
+                <a:solidFill>
+                  <a:srgbClr val="000000"/>
+                </a:solidFill>
+                <a:latin typeface="Century Gothic"/>
+              </a:rPr>
+              <a:t>How to frame the project:</a:t>
+            </a:r>
+          </a:p>
+          <a:p>
+            <a:pPr lvl="1">
+              <a:lnSpc>
+                <a:spcPct val="100000"/>
+              </a:lnSpc>
+              <a:spcBef>
+                <a:spcPts val="400"/>
+              </a:spcBef>
+              <a:buClr>
+                <a:srgbClr val="0064C8"/>
+              </a:buClr>
+              <a:buFont typeface="Wingdings" panose="05000000000000000000" pitchFamily="2" charset="2"/>
+              <a:buChar char="§"/>
+            </a:pPr>
+            <a:r>
+              <a:rPr lang="en-US" sz="1600" spc="-1" dirty="0">
+                <a:solidFill>
+                  <a:srgbClr val="000000"/>
+                </a:solidFill>
+                <a:latin typeface="Century Gothic"/>
+              </a:rPr>
+              <a:t>A proof-of-concept study?</a:t>
+            </a:r>
+          </a:p>
+          <a:p>
+            <a:pPr lvl="1">
+              <a:lnSpc>
+                <a:spcPct val="100000"/>
+              </a:lnSpc>
+              <a:spcBef>
+                <a:spcPts val="400"/>
+              </a:spcBef>
+              <a:buClr>
+                <a:srgbClr val="0064C8"/>
+              </a:buClr>
+              <a:buFont typeface="Wingdings" panose="05000000000000000000" pitchFamily="2" charset="2"/>
+              <a:buChar char="§"/>
+            </a:pPr>
+            <a:r>
+              <a:rPr lang="en-US" sz="1600" spc="-1" dirty="0">
+                <a:solidFill>
+                  <a:srgbClr val="000000"/>
+                </a:solidFill>
+                <a:latin typeface="Century Gothic"/>
+              </a:rPr>
+              <a:t>An explainability platform for XAI applied to molecular design?</a:t>
+            </a:r>
+          </a:p>
+          <a:p>
+            <a:pPr lvl="1">
+              <a:lnSpc>
+                <a:spcPct val="100000"/>
+              </a:lnSpc>
+              <a:spcBef>
+                <a:spcPts val="400"/>
+              </a:spcBef>
+              <a:buClr>
+                <a:srgbClr val="0064C8"/>
+              </a:buClr>
+              <a:buFont typeface="Wingdings" panose="05000000000000000000" pitchFamily="2" charset="2"/>
+              <a:buChar char="§"/>
+            </a:pPr>
+            <a:r>
+              <a:rPr lang="en-US" sz="1600" spc="-1" dirty="0">
+                <a:solidFill>
+                  <a:srgbClr val="000000"/>
+                </a:solidFill>
+                <a:latin typeface="Century Gothic"/>
+              </a:rPr>
+              <a:t>An explainability platform for XAI specific to molecular selectivity?</a:t>
+            </a:r>
+          </a:p>
+          <a:p>
+            <a:pPr lvl="1">
+              <a:lnSpc>
+                <a:spcPct val="100000"/>
+              </a:lnSpc>
+              <a:spcBef>
+                <a:spcPts val="400"/>
+              </a:spcBef>
+              <a:buClr>
+                <a:srgbClr val="0064C8"/>
+              </a:buClr>
+              <a:buFont typeface="Wingdings" panose="05000000000000000000" pitchFamily="2" charset="2"/>
+              <a:buChar char="§"/>
+            </a:pPr>
+            <a:r>
+              <a:rPr lang="en-US" sz="1600" spc="-1" dirty="0">
+                <a:solidFill>
+                  <a:srgbClr val="000000"/>
+                </a:solidFill>
+                <a:latin typeface="Century Gothic"/>
+              </a:rPr>
+              <a:t>A modular </a:t>
+            </a:r>
+            <a:r>
+              <a:rPr lang="en-US" sz="1600" spc="-1" dirty="0" err="1">
+                <a:solidFill>
+                  <a:srgbClr val="000000"/>
+                </a:solidFill>
+                <a:latin typeface="Century Gothic"/>
+              </a:rPr>
+              <a:t>explainability</a:t>
+            </a:r>
+            <a:r>
+              <a:rPr lang="en-US" sz="1600" spc="-1" dirty="0">
+                <a:solidFill>
+                  <a:srgbClr val="000000"/>
+                </a:solidFill>
+                <a:latin typeface="Century Gothic"/>
+              </a:rPr>
+              <a:t>-enhanced platform for </a:t>
+            </a:r>
+            <a:r>
+              <a:rPr lang="en-US" sz="1600" spc="-1" dirty="0" err="1">
+                <a:solidFill>
+                  <a:srgbClr val="000000"/>
+                </a:solidFill>
+                <a:latin typeface="Century Gothic"/>
+              </a:rPr>
+              <a:t>chemoinformatics</a:t>
+            </a:r>
+            <a:r>
+              <a:rPr lang="en-US" sz="1600" spc="-1" dirty="0">
+                <a:solidFill>
+                  <a:srgbClr val="000000"/>
+                </a:solidFill>
+                <a:latin typeface="Century Gothic"/>
+              </a:rPr>
+              <a:t>? </a:t>
+            </a:r>
+          </a:p>
+          <a:p>
+            <a:pPr lvl="1">
+              <a:lnSpc>
+                <a:spcPct val="100000"/>
+              </a:lnSpc>
+              <a:spcBef>
+                <a:spcPts val="400"/>
+              </a:spcBef>
+              <a:buClr>
+                <a:srgbClr val="0064C8"/>
+              </a:buClr>
+              <a:buFont typeface="Wingdings" panose="05000000000000000000" pitchFamily="2" charset="2"/>
+              <a:buChar char="§"/>
+            </a:pPr>
+            <a:endParaRPr lang="en-US" sz="1600" spc="-1" dirty="0">
+              <a:solidFill>
+                <a:srgbClr val="000000"/>
+              </a:solidFill>
+              <a:latin typeface="Century Gothic"/>
+            </a:endParaRPr>
+          </a:p>
+          <a:p>
+            <a:pPr lvl="1">
+              <a:lnSpc>
+                <a:spcPct val="100000"/>
+              </a:lnSpc>
+              <a:spcBef>
+                <a:spcPts val="400"/>
+              </a:spcBef>
+              <a:buClr>
+                <a:srgbClr val="0064C8"/>
+              </a:buClr>
+              <a:buFont typeface="Wingdings" panose="05000000000000000000" pitchFamily="2" charset="2"/>
+              <a:buChar char="§"/>
+            </a:pPr>
+            <a:endParaRPr lang="en-US" sz="1600" spc="-1" dirty="0">
+              <a:solidFill>
+                <a:srgbClr val="000000"/>
+              </a:solidFill>
+              <a:latin typeface="Century Gothic"/>
+            </a:endParaRPr>
+          </a:p>
+          <a:p>
+            <a:pPr>
+              <a:lnSpc>
+                <a:spcPct val="100000"/>
+              </a:lnSpc>
+              <a:spcBef>
+                <a:spcPts val="400"/>
+              </a:spcBef>
+              <a:buClr>
+                <a:srgbClr val="0064C8"/>
+              </a:buClr>
+              <a:buFont typeface="Wingdings" panose="05000000000000000000" pitchFamily="2" charset="2"/>
+              <a:buChar char="§"/>
+            </a:pPr>
+            <a:endParaRPr lang="en-US" sz="2000" spc="-1" dirty="0">
+              <a:solidFill>
+                <a:srgbClr val="000000"/>
+              </a:solidFill>
+              <a:latin typeface="Century Gothic"/>
+            </a:endParaRPr>
+          </a:p>
+          <a:p>
+            <a:pPr>
+              <a:lnSpc>
+                <a:spcPct val="100000"/>
+              </a:lnSpc>
+              <a:spcBef>
+                <a:spcPts val="400"/>
+              </a:spcBef>
+              <a:buClr>
+                <a:srgbClr val="0064C8"/>
+              </a:buClr>
+              <a:buFont typeface="Wingdings" panose="05000000000000000000" pitchFamily="2" charset="2"/>
+              <a:buChar char="§"/>
+            </a:pPr>
+            <a:endParaRPr lang="en-US" sz="1800" spc="-1" dirty="0">
+              <a:solidFill>
+                <a:srgbClr val="000000"/>
+              </a:solidFill>
+              <a:latin typeface="Century Gothic"/>
+            </a:endParaRPr>
+          </a:p>
+          <a:p>
+            <a:pPr marL="343080" indent="-343080">
+              <a:lnSpc>
+                <a:spcPct val="100000"/>
+              </a:lnSpc>
+              <a:spcBef>
+                <a:spcPts val="400"/>
+              </a:spcBef>
+              <a:spcAft>
+                <a:spcPts val="601"/>
+              </a:spcAft>
+              <a:buClr>
+                <a:srgbClr val="0064C8"/>
+              </a:buClr>
+              <a:buFont typeface="Wingdings 2" charset="2"/>
+              <a:buChar char=""/>
+            </a:pPr>
+            <a:endParaRPr lang="en-US" sz="2000" b="1" spc="-1" dirty="0">
+              <a:solidFill>
+                <a:srgbClr val="000000"/>
+              </a:solidFill>
+              <a:latin typeface="Century Gothic"/>
+            </a:endParaRPr>
+          </a:p>
+        </p:txBody>
+      </p:sp>
+    </p:spTree>
+    <p:extLst>
+      <p:ext uri="{BB962C8B-B14F-4D97-AF65-F5344CB8AC3E}">
+        <p14:creationId xmlns:p14="http://schemas.microsoft.com/office/powerpoint/2010/main" val="1594879052"/>
+      </p:ext>
+    </p:extLst>
+  </p:cSld>
+  <p:clrMapOvr>
+    <a:masterClrMapping/>
+  </p:clrMapOvr>
 </p:sld>
 </file>
 
@@ -9730,7 +10949,7 @@
       </p:sp>
       <p:pic>
         <p:nvPicPr>
-          <p:cNvPr id="4" name="Picture 3" descr="A diagram of different types of chemistry&#10;&#10;AI-generated content may be incorrect.">
+          <p:cNvPr id="4" name="Picture 3">
             <a:extLst>
               <a:ext uri="{FF2B5EF4-FFF2-40B4-BE49-F238E27FC236}">
                 <a16:creationId xmlns:a16="http://schemas.microsoft.com/office/drawing/2014/main" id="{A9172708-06AB-AE7A-4BC0-05B1328EE700}"/>
@@ -9750,14 +10969,13 @@
               </a:ext>
             </a:extLst>
           </a:blip>
-          <a:stretch>
-            <a:fillRect/>
-          </a:stretch>
+          <a:srcRect/>
+          <a:stretch/>
         </p:blipFill>
         <p:spPr>
           <a:xfrm>
-            <a:off x="665429" y="2123180"/>
-            <a:ext cx="7810981" cy="3363221"/>
+            <a:off x="666509" y="2127309"/>
+            <a:ext cx="7810981" cy="3354962"/>
           </a:xfrm>
           <a:prstGeom prst="rect">
             <a:avLst/>
@@ -9774,18 +10992,6 @@
   <p:clrMapOvr>
     <a:masterClrMapping/>
   </p:clrMapOvr>
-  <mc:AlternateContent xmlns:mc="http://schemas.openxmlformats.org/markup-compatibility/2006" xmlns:p14="http://schemas.microsoft.com/office/powerpoint/2010/main">
-    <mc:Choice Requires="p14">
-      <p:transition spd="med" p14:dur="700">
-        <p:fade/>
-      </p:transition>
-    </mc:Choice>
-    <mc:Fallback xmlns:p15="http://schemas.microsoft.com/office/powerpoint/2012/main" xmlns="">
-      <p:transition spd="med">
-        <p:fade/>
-      </p:transition>
-    </mc:Fallback>
-  </mc:AlternateContent>
 </p:sld>
 </file>
 
@@ -10170,7 +11376,7 @@
               <a:t>LM Studio + Open Source LLM (GPT-OSS, </a:t>
             </a:r>
             <a:r>
-              <a:rPr lang="en-US" sz="1600" spc="-1" dirty="0" err="1">
+              <a:rPr lang="en-US" sz="1600" b="1" spc="-1" dirty="0" err="1">
                 <a:solidFill>
                   <a:srgbClr val="000000"/>
                 </a:solidFill>
@@ -10179,22 +11385,13 @@
               <a:t>Qwen</a:t>
             </a:r>
             <a:r>
-              <a:rPr lang="en-US" sz="1600" spc="-1" dirty="0">
+              <a:rPr lang="en-US" sz="1600" b="1" spc="-1" dirty="0">
                 <a:solidFill>
                   <a:srgbClr val="000000"/>
                 </a:solidFill>
                 <a:latin typeface="Century Gothic"/>
               </a:rPr>
-              <a:t> 3.5, </a:t>
-            </a:r>
-            <a:r>
-              <a:rPr lang="en-US" sz="1600" spc="-1" dirty="0" err="1">
-                <a:solidFill>
-                  <a:srgbClr val="000000"/>
-                </a:solidFill>
-                <a:latin typeface="Century Gothic"/>
-              </a:rPr>
-              <a:t>etc</a:t>
+              <a:t> 3.5</a:t>
             </a:r>
             <a:r>
               <a:rPr lang="en-US" sz="1600" spc="-1" dirty="0">
@@ -10203,7 +11400,7 @@
                 </a:solidFill>
                 <a:latin typeface="Century Gothic"/>
               </a:rPr>
-              <a:t>)</a:t>
+              <a:t>, Gemma 4, etc.)</a:t>
             </a:r>
             <a:br>
               <a:rPr lang="en-US" sz="1600" spc="-1" dirty="0">
@@ -10213,7 +11410,7 @@
                 <a:latin typeface="Century Gothic"/>
               </a:rPr>
             </a:br>
-            <a:endParaRPr lang="en-US" sz="2000" spc="-1" dirty="0">
+            <a:endParaRPr lang="en-US" sz="1600" spc="-1" dirty="0">
               <a:solidFill>
                 <a:srgbClr val="000000"/>
               </a:solidFill>
@@ -10241,7 +11438,7 @@
                 </a:solidFill>
                 <a:latin typeface="Century Gothic"/>
               </a:rPr>
-              <a:t>Explainability methods</a:t>
+              <a:t>ML models</a:t>
             </a:r>
           </a:p>
           <a:p>
@@ -10265,38 +11462,8 @@
                 </a:solidFill>
                 <a:latin typeface="Century Gothic"/>
               </a:rPr>
-              <a:t>SHAP</a:t>
+              <a:t>Traditional ML – RF, SVM</a:t>
             </a:r>
-          </a:p>
-          <a:p>
-            <a:pPr lvl="1">
-              <a:lnSpc>
-                <a:spcPct val="100000"/>
-              </a:lnSpc>
-              <a:spcBef>
-                <a:spcPts val="400"/>
-              </a:spcBef>
-              <a:buClr>
-                <a:srgbClr val="0064C8"/>
-              </a:buClr>
-              <a:buFont typeface="Symbol" panose="05050102010706020507" pitchFamily="18" charset="2"/>
-              <a:buChar char="-"/>
-            </a:pPr>
-            <a:r>
-              <a:rPr lang="en-US" sz="1600" spc="-1" dirty="0" err="1">
-                <a:solidFill>
-                  <a:srgbClr val="000000"/>
-                </a:solidFill>
-                <a:latin typeface="Century Gothic"/>
-              </a:rPr>
-              <a:t>MolAnchor</a:t>
-            </a:r>
-            <a:endParaRPr lang="en-US" sz="1600" spc="-1" dirty="0">
-              <a:solidFill>
-                <a:srgbClr val="000000"/>
-              </a:solidFill>
-              <a:latin typeface="Century Gothic"/>
-            </a:endParaRPr>
           </a:p>
           <a:p>
             <a:pPr lvl="1">
@@ -10319,68 +11486,8 @@
                 </a:solidFill>
                 <a:latin typeface="Century Gothic"/>
               </a:rPr>
-              <a:t>Counterfactuals</a:t>
+              <a:t>NNs – DNN, GNN</a:t>
             </a:r>
-          </a:p>
-          <a:p>
-            <a:pPr lvl="1">
-              <a:lnSpc>
-                <a:spcPct val="100000"/>
-              </a:lnSpc>
-              <a:spcBef>
-                <a:spcPts val="400"/>
-              </a:spcBef>
-              <a:buClr>
-                <a:srgbClr val="0064C8"/>
-              </a:buClr>
-              <a:buFont typeface="Symbol" panose="05050102010706020507" pitchFamily="18" charset="2"/>
-              <a:buChar char="-"/>
-            </a:pPr>
-            <a:r>
-              <a:rPr lang="en-US" sz="1600" spc="-1" dirty="0" err="1">
-                <a:solidFill>
-                  <a:srgbClr val="000000"/>
-                </a:solidFill>
-                <a:latin typeface="Century Gothic"/>
-              </a:rPr>
-              <a:t>MolCE</a:t>
-            </a:r>
-            <a:endParaRPr lang="en-US" sz="1600" spc="-1" dirty="0">
-              <a:solidFill>
-                <a:srgbClr val="000000"/>
-              </a:solidFill>
-              <a:latin typeface="Century Gothic"/>
-            </a:endParaRPr>
-          </a:p>
-          <a:p>
-            <a:pPr lvl="1">
-              <a:lnSpc>
-                <a:spcPct val="100000"/>
-              </a:lnSpc>
-              <a:spcBef>
-                <a:spcPts val="400"/>
-              </a:spcBef>
-              <a:buClr>
-                <a:srgbClr val="0064C8"/>
-              </a:buClr>
-              <a:buFont typeface="Symbol" panose="05050102010706020507" pitchFamily="18" charset="2"/>
-              <a:buChar char="-"/>
-            </a:pPr>
-            <a:r>
-              <a:rPr lang="en-US" sz="1600" spc="-1" dirty="0" err="1">
-                <a:solidFill>
-                  <a:srgbClr val="000000"/>
-                </a:solidFill>
-                <a:latin typeface="Century Gothic"/>
-              </a:rPr>
-              <a:t>EdgeSHAPer</a:t>
-            </a:r>
-            <a:endParaRPr lang="en-US" sz="1600" spc="-1" dirty="0">
-              <a:solidFill>
-                <a:srgbClr val="000000"/>
-              </a:solidFill>
-              <a:latin typeface="Century Gothic"/>
-            </a:endParaRPr>
           </a:p>
           <a:p>
             <a:pPr lvl="1">
@@ -10418,13 +11525,22 @@
               <a:buChar char="§"/>
             </a:pPr>
             <a:r>
-              <a:rPr lang="en-US" sz="2000" spc="-1" dirty="0">
+              <a:rPr lang="en-US" sz="2000" spc="-1" dirty="0" err="1">
                 <a:solidFill>
                   <a:srgbClr val="000000"/>
                 </a:solidFill>
                 <a:latin typeface="Century Gothic"/>
               </a:rPr>
-              <a:t>ML models</a:t>
+              <a:t>Explainability</a:t>
+            </a:r>
+            <a:r>
+              <a:rPr lang="en-US" sz="2000" spc="-1" dirty="0">
+                <a:solidFill>
+                  <a:srgbClr val="000000"/>
+                </a:solidFill>
+                <a:latin typeface="Century Gothic"/>
+              </a:rPr>
+              <a:t> methods</a:t>
             </a:r>
           </a:p>
           <a:p>
@@ -10448,8 +11564,38 @@
                 </a:solidFill>
                 <a:latin typeface="Century Gothic"/>
               </a:rPr>
-              <a:t>Traditional ML – RF, SVM</a:t>
+              <a:t>SHAP</a:t>
             </a:r>
+          </a:p>
+          <a:p>
+            <a:pPr lvl="1">
+              <a:lnSpc>
+                <a:spcPct val="100000"/>
+              </a:lnSpc>
+              <a:spcBef>
+                <a:spcPts val="400"/>
+              </a:spcBef>
+              <a:buClr>
+                <a:srgbClr val="0064C8"/>
+              </a:buClr>
+              <a:buFont typeface="Symbol" panose="05050102010706020507" pitchFamily="18" charset="2"/>
+              <a:buChar char="-"/>
+            </a:pPr>
+            <a:r>
+              <a:rPr lang="en-US" sz="1600" spc="-1" dirty="0" err="1">
+                <a:solidFill>
+                  <a:srgbClr val="000000"/>
+                </a:solidFill>
+                <a:latin typeface="Century Gothic"/>
+              </a:rPr>
+              <a:t>MolAnchor</a:t>
+            </a:r>
+            <a:endParaRPr lang="en-US" sz="1600" spc="-1" dirty="0">
+              <a:solidFill>
+                <a:srgbClr val="000000"/>
+              </a:solidFill>
+              <a:latin typeface="Century Gothic"/>
+            </a:endParaRPr>
           </a:p>
           <a:p>
             <a:pPr lvl="1">
@@ -10472,11 +11618,71 @@
                 </a:solidFill>
                 <a:latin typeface="Century Gothic"/>
               </a:rPr>
-              <a:t>NNs – DNN, GNN</a:t>
+              <a:t>Counterfactuals</a:t>
             </a:r>
           </a:p>
           <a:p>
             <a:pPr lvl="1">
+              <a:lnSpc>
+                <a:spcPct val="100000"/>
+              </a:lnSpc>
+              <a:spcBef>
+                <a:spcPts val="400"/>
+              </a:spcBef>
+              <a:buClr>
+                <a:srgbClr val="0064C8"/>
+              </a:buClr>
+              <a:buFont typeface="Symbol" panose="05050102010706020507" pitchFamily="18" charset="2"/>
+              <a:buChar char="-"/>
+            </a:pPr>
+            <a:r>
+              <a:rPr lang="en-US" sz="1600" spc="-1" dirty="0" err="1">
+                <a:solidFill>
+                  <a:srgbClr val="000000"/>
+                </a:solidFill>
+                <a:latin typeface="Century Gothic"/>
+              </a:rPr>
+              <a:t>MolCE</a:t>
+            </a:r>
+            <a:endParaRPr lang="en-US" sz="1600" spc="-1" dirty="0">
+              <a:solidFill>
+                <a:srgbClr val="000000"/>
+              </a:solidFill>
+              <a:latin typeface="Century Gothic"/>
+            </a:endParaRPr>
+          </a:p>
+          <a:p>
+            <a:pPr lvl="1">
+              <a:lnSpc>
+                <a:spcPct val="100000"/>
+              </a:lnSpc>
+              <a:spcBef>
+                <a:spcPts val="400"/>
+              </a:spcBef>
+              <a:buClr>
+                <a:srgbClr val="0064C8"/>
+              </a:buClr>
+              <a:buFont typeface="Symbol" panose="05050102010706020507" pitchFamily="18" charset="2"/>
+              <a:buChar char="-"/>
+            </a:pPr>
+            <a:r>
+              <a:rPr lang="en-US" sz="1600" spc="-1" dirty="0" err="1">
+                <a:solidFill>
+                  <a:srgbClr val="000000"/>
+                </a:solidFill>
+                <a:latin typeface="Century Gothic"/>
+              </a:rPr>
+              <a:t>EdgeSHAPer</a:t>
+            </a:r>
+            <a:endParaRPr lang="en-US" sz="1600" spc="-1" dirty="0">
+              <a:solidFill>
+                <a:srgbClr val="000000"/>
+              </a:solidFill>
+              <a:latin typeface="Century Gothic"/>
+            </a:endParaRPr>
+          </a:p>
+          <a:p>
+            <a:pPr marL="457200" lvl="1" indent="0">
               <a:lnSpc>
                 <a:spcPct val="100000"/>
               </a:lnSpc>
@@ -10489,8 +11695,7 @@
               <a:buClr>
                 <a:srgbClr val="0064C8"/>
               </a:buClr>
-              <a:buFont typeface="Wingdings" panose="05000000000000000000" pitchFamily="2" charset="2"/>
-              <a:buChar char="§"/>
+              <a:buNone/>
             </a:pPr>
             <a:endParaRPr lang="en-US" sz="1600" spc="-1" dirty="0">
               <a:solidFill>
@@ -10535,18 +11740,6 @@
   <p:clrMapOvr>
     <a:masterClrMapping/>
   </p:clrMapOvr>
-  <mc:AlternateContent xmlns:mc="http://schemas.openxmlformats.org/markup-compatibility/2006" xmlns:p14="http://schemas.microsoft.com/office/powerpoint/2010/main">
-    <mc:Choice Requires="p14">
-      <p:transition spd="med" p14:dur="700">
-        <p:fade/>
-      </p:transition>
-    </mc:Choice>
-    <mc:Fallback xmlns:p15="http://schemas.microsoft.com/office/powerpoint/2012/main" xmlns="">
-      <p:transition spd="med">
-        <p:fade/>
-      </p:transition>
-    </mc:Fallback>
-  </mc:AlternateContent>
 </p:sld>
 </file>
 
@@ -11114,18 +12307,6 @@
   <p:clrMapOvr>
     <a:masterClrMapping/>
   </p:clrMapOvr>
-  <mc:AlternateContent xmlns:mc="http://schemas.openxmlformats.org/markup-compatibility/2006" xmlns:p14="http://schemas.microsoft.com/office/powerpoint/2010/main">
-    <mc:Choice Requires="p14">
-      <p:transition spd="med" p14:dur="700">
-        <p:fade/>
-      </p:transition>
-    </mc:Choice>
-    <mc:Fallback xmlns:p15="http://schemas.microsoft.com/office/powerpoint/2012/main" xmlns="">
-      <p:transition spd="med">
-        <p:fade/>
-      </p:transition>
-    </mc:Fallback>
-  </mc:AlternateContent>
 </p:sld>
 </file>
 
@@ -11729,18 +12910,6 @@
   <p:clrMapOvr>
     <a:masterClrMapping/>
   </p:clrMapOvr>
-  <mc:AlternateContent xmlns:mc="http://schemas.openxmlformats.org/markup-compatibility/2006" xmlns:p14="http://schemas.microsoft.com/office/powerpoint/2010/main">
-    <mc:Choice Requires="p14">
-      <p:transition spd="med" p14:dur="700">
-        <p:fade/>
-      </p:transition>
-    </mc:Choice>
-    <mc:Fallback xmlns:p15="http://schemas.microsoft.com/office/powerpoint/2012/main" xmlns="">
-      <p:transition spd="med">
-        <p:fade/>
-      </p:transition>
-    </mc:Fallback>
-  </mc:AlternateContent>
 </p:sld>
 </file>
 
@@ -12397,18 +13566,6 @@
   <p:clrMapOvr>
     <a:masterClrMapping/>
   </p:clrMapOvr>
-  <mc:AlternateContent xmlns:mc="http://schemas.openxmlformats.org/markup-compatibility/2006" xmlns:p14="http://schemas.microsoft.com/office/powerpoint/2010/main">
-    <mc:Choice Requires="p14">
-      <p:transition spd="med" p14:dur="700">
-        <p:fade/>
-      </p:transition>
-    </mc:Choice>
-    <mc:Fallback xmlns="">
-      <p:transition spd="med">
-        <p:fade/>
-      </p:transition>
-    </mc:Fallback>
-  </mc:AlternateContent>
 </p:sld>
 </file>
 
@@ -13051,18 +14208,6 @@
   <p:clrMapOvr>
     <a:masterClrMapping/>
   </p:clrMapOvr>
-  <mc:AlternateContent xmlns:mc="http://schemas.openxmlformats.org/markup-compatibility/2006" xmlns:p14="http://schemas.microsoft.com/office/powerpoint/2010/main">
-    <mc:Choice Requires="p14">
-      <p:transition spd="med" p14:dur="700">
-        <p:fade/>
-      </p:transition>
-    </mc:Choice>
-    <mc:Fallback xmlns="">
-      <p:transition spd="med">
-        <p:fade/>
-      </p:transition>
-    </mc:Fallback>
-  </mc:AlternateContent>
 </p:sld>
 </file>
 
@@ -13137,7 +14282,16 @@
                 </a:solidFill>
                 <a:latin typeface="Century Gothic"/>
               </a:rPr>
-              <a:t>To do list</a:t>
+              <a:t>Exemplary answer output </a:t>
+            </a:r>
+            <a:r>
+              <a:rPr lang="en-US" sz="3200" b="0" strike="noStrike" spc="-1" dirty="0" err="1">
+                <a:solidFill>
+                  <a:srgbClr val="0064C8"/>
+                </a:solidFill>
+                <a:latin typeface="Century Gothic"/>
+              </a:rPr>
+              <a:t>EdgeSHAPer</a:t>
             </a:r>
             <a:endParaRPr lang="en-US" sz="3200" b="0" strike="noStrike" spc="-1" dirty="0">
               <a:solidFill>
@@ -13220,8 +14374,8 @@
         </p:nvSpPr>
         <p:spPr>
           <a:xfrm>
-            <a:off x="380880" y="1371598"/>
-            <a:ext cx="8109070" cy="4559301"/>
+            <a:off x="374529" y="1371598"/>
+            <a:ext cx="4251523" cy="4559301"/>
           </a:xfrm>
           <a:prstGeom prst="rect">
             <a:avLst/>
@@ -13420,25 +14574,7 @@
                 </a:solidFill>
                 <a:latin typeface="Century Gothic"/>
               </a:rPr>
-              <a:t>Add and properly implement missing XAI methods (</a:t>
-            </a:r>
-            <a:r>
-              <a:rPr lang="en-US" sz="2000" spc="-1" dirty="0" err="1">
-                <a:solidFill>
-                  <a:srgbClr val="000000"/>
-                </a:solidFill>
-                <a:latin typeface="Century Gothic"/>
-              </a:rPr>
-              <a:t>EdgeSHAPer</a:t>
-            </a:r>
-            <a:r>
-              <a:rPr lang="en-US" sz="2000" spc="-1" dirty="0">
-                <a:solidFill>
-                  <a:srgbClr val="000000"/>
-                </a:solidFill>
-                <a:latin typeface="Century Gothic"/>
-              </a:rPr>
-              <a:t> and Counterfactuals)</a:t>
+              <a:t>Prompt: Train a GNN model on a binary dataset and explain a correctly predicted active compound</a:t>
             </a:r>
           </a:p>
           <a:p>
@@ -13476,29 +14612,6 @@
               <a:buFont typeface="Wingdings" panose="05000000000000000000" pitchFamily="2" charset="2"/>
               <a:buChar char="§"/>
             </a:pPr>
-            <a:r>
-              <a:rPr lang="en-US" sz="2000" spc="-1" dirty="0">
-                <a:solidFill>
-                  <a:srgbClr val="000000"/>
-                </a:solidFill>
-                <a:latin typeface="Century Gothic"/>
-              </a:rPr>
-              <a:t>Integrate with cluster for faster inference and explore larger LLMs</a:t>
-            </a:r>
-          </a:p>
-          <a:p>
-            <a:pPr marL="0" indent="0">
-              <a:lnSpc>
-                <a:spcPct val="100000"/>
-              </a:lnSpc>
-              <a:spcBef>
-                <a:spcPts val="400"/>
-              </a:spcBef>
-              <a:buClr>
-                <a:srgbClr val="0064C8"/>
-              </a:buClr>
-              <a:buNone/>
-            </a:pPr>
             <a:endParaRPr lang="en-US" sz="2000" spc="-1" dirty="0">
               <a:solidFill>
                 <a:srgbClr val="000000"/>
@@ -13527,7 +14640,7 @@
                 </a:solidFill>
                 <a:latin typeface="Century Gothic"/>
               </a:rPr>
-              <a:t>Clean up the repository and make it available </a:t>
+              <a:t>LLM selects the architecture</a:t>
             </a:r>
           </a:p>
           <a:p>
@@ -13552,30 +14665,6 @@
             </a:endParaRPr>
           </a:p>
           <a:p>
-            <a:pPr lvl="1">
-              <a:lnSpc>
-                <a:spcPct val="100000"/>
-              </a:lnSpc>
-              <a:spcBef>
-                <a:spcPts val="400"/>
-              </a:spcBef>
-              <a:buClr>
-                <a:srgbClr val="0064C8"/>
-              </a:buClr>
-              <a:buFont typeface="Wingdings" panose="05000000000000000000" pitchFamily="2" charset="2"/>
-              <a:buChar char="§"/>
-            </a:pPr>
-            <a:r>
-              <a:rPr lang="en-US" sz="1600" spc="-1" dirty="0">
-                <a:solidFill>
-                  <a:srgbClr val="000000"/>
-                </a:solidFill>
-                <a:latin typeface="Century Gothic"/>
-              </a:rPr>
-              <a:t>An “organization repository” is available for the whole lab to ease the integration of new components</a:t>
-            </a:r>
-          </a:p>
-          <a:p>
             <a:pPr>
               <a:lnSpc>
                 <a:spcPct val="100000"/>
@@ -13617,8 +14706,49 @@
                 </a:solidFill>
                 <a:latin typeface="Century Gothic"/>
               </a:rPr>
-              <a:t>Make a guide for lab members for the implementation of AI agents</a:t>
+              <a:t>Reports results</a:t>
             </a:r>
+          </a:p>
+          <a:p>
+            <a:pPr>
+              <a:lnSpc>
+                <a:spcPct val="100000"/>
+              </a:lnSpc>
+              <a:spcBef>
+                <a:spcPts val="400"/>
+              </a:spcBef>
+              <a:buClr>
+                <a:srgbClr val="0064C8"/>
+              </a:buClr>
+              <a:buFont typeface="Wingdings" panose="05000000000000000000" pitchFamily="2" charset="2"/>
+              <a:buChar char="§"/>
+            </a:pPr>
+            <a:endParaRPr lang="en-US" sz="2000" spc="-1" dirty="0">
+              <a:solidFill>
+                <a:srgbClr val="000000"/>
+              </a:solidFill>
+              <a:latin typeface="Century Gothic"/>
+            </a:endParaRPr>
+          </a:p>
+          <a:p>
+            <a:pPr marL="0" indent="0">
+              <a:lnSpc>
+                <a:spcPct val="100000"/>
+              </a:lnSpc>
+              <a:spcBef>
+                <a:spcPts val="400"/>
+              </a:spcBef>
+              <a:buClr>
+                <a:srgbClr val="0064C8"/>
+              </a:buClr>
+              <a:buNone/>
+            </a:pPr>
+            <a:endParaRPr lang="en-US" sz="2000" spc="-1" dirty="0">
+              <a:solidFill>
+                <a:srgbClr val="000000"/>
+              </a:solidFill>
+              <a:latin typeface="Century Gothic"/>
+            </a:endParaRPr>
           </a:p>
           <a:p>
             <a:pPr>
@@ -13688,28 +14818,106 @@
           </a:p>
         </p:txBody>
       </p:sp>
+      <p:pic>
+        <p:nvPicPr>
+          <p:cNvPr id="3" name="Picture 2">
+            <a:extLst>
+              <a:ext uri="{FF2B5EF4-FFF2-40B4-BE49-F238E27FC236}">
+                <a16:creationId xmlns:a16="http://schemas.microsoft.com/office/drawing/2014/main" id="{9DA85E66-1EFD-47C3-862B-21979C1F5C6F}"/>
+              </a:ext>
+            </a:extLst>
+          </p:cNvPr>
+          <p:cNvPicPr>
+            <a:picLocks noChangeAspect="1"/>
+          </p:cNvPicPr>
+          <p:nvPr/>
+        </p:nvPicPr>
+        <p:blipFill>
+          <a:blip r:embed="rId2"/>
+          <a:stretch>
+            <a:fillRect/>
+          </a:stretch>
+        </p:blipFill>
+        <p:spPr>
+          <a:xfrm>
+            <a:off x="4875563" y="1174421"/>
+            <a:ext cx="3804481" cy="2612989"/>
+          </a:xfrm>
+          <a:prstGeom prst="rect">
+            <a:avLst/>
+          </a:prstGeom>
+        </p:spPr>
+      </p:pic>
+      <p:pic>
+        <p:nvPicPr>
+          <p:cNvPr id="6" name="Picture 5">
+            <a:extLst>
+              <a:ext uri="{FF2B5EF4-FFF2-40B4-BE49-F238E27FC236}">
+                <a16:creationId xmlns:a16="http://schemas.microsoft.com/office/drawing/2014/main" id="{CBEE4EBE-BE81-4F15-9C55-5A2351D36FE7}"/>
+              </a:ext>
+            </a:extLst>
+          </p:cNvPr>
+          <p:cNvPicPr>
+            <a:picLocks noChangeAspect="1"/>
+          </p:cNvPicPr>
+          <p:nvPr/>
+        </p:nvPicPr>
+        <p:blipFill>
+          <a:blip r:embed="rId3"/>
+          <a:stretch>
+            <a:fillRect/>
+          </a:stretch>
+        </p:blipFill>
+        <p:spPr>
+          <a:xfrm>
+            <a:off x="4875563" y="4610647"/>
+            <a:ext cx="3804480" cy="1131062"/>
+          </a:xfrm>
+          <a:prstGeom prst="rect">
+            <a:avLst/>
+          </a:prstGeom>
+        </p:spPr>
+      </p:pic>
+      <p:pic>
+        <p:nvPicPr>
+          <p:cNvPr id="10" name="Picture 9">
+            <a:extLst>
+              <a:ext uri="{FF2B5EF4-FFF2-40B4-BE49-F238E27FC236}">
+                <a16:creationId xmlns:a16="http://schemas.microsoft.com/office/drawing/2014/main" id="{AFB3B521-7DFA-48D0-AB2D-3890673F8FD3}"/>
+              </a:ext>
+            </a:extLst>
+          </p:cNvPr>
+          <p:cNvPicPr>
+            <a:picLocks noChangeAspect="1"/>
+          </p:cNvPicPr>
+          <p:nvPr/>
+        </p:nvPicPr>
+        <p:blipFill>
+          <a:blip r:embed="rId4"/>
+          <a:stretch>
+            <a:fillRect/>
+          </a:stretch>
+        </p:blipFill>
+        <p:spPr>
+          <a:xfrm>
+            <a:off x="4875563" y="3786896"/>
+            <a:ext cx="3804480" cy="833290"/>
+          </a:xfrm>
+          <a:prstGeom prst="rect">
+            <a:avLst/>
+          </a:prstGeom>
+        </p:spPr>
+      </p:pic>
     </p:spTree>
     <p:extLst>
       <p:ext uri="{BB962C8B-B14F-4D97-AF65-F5344CB8AC3E}">
-        <p14:creationId xmlns:p14="http://schemas.microsoft.com/office/powerpoint/2010/main" val="3727029337"/>
+        <p14:creationId xmlns:p14="http://schemas.microsoft.com/office/powerpoint/2010/main" val="1512285611"/>
       </p:ext>
     </p:extLst>
   </p:cSld>
   <p:clrMapOvr>
     <a:masterClrMapping/>
   </p:clrMapOvr>
-  <mc:AlternateContent xmlns:mc="http://schemas.openxmlformats.org/markup-compatibility/2006" xmlns:p14="http://schemas.microsoft.com/office/powerpoint/2010/main">
-    <mc:Choice Requires="p14">
-      <p:transition spd="med" p14:dur="700">
-        <p:fade/>
-      </p:transition>
-    </mc:Choice>
-    <mc:Fallback xmlns="">
-      <p:transition spd="med">
-        <p:fade/>
-      </p:transition>
-    </mc:Fallback>
-  </mc:AlternateContent>
 </p:sld>
 </file>
 
@@ -13784,7 +14992,16 @@
                 </a:solidFill>
                 <a:latin typeface="Century Gothic"/>
               </a:rPr>
-              <a:t>Framing</a:t>
+              <a:t>Exemplary answer output </a:t>
+            </a:r>
+            <a:r>
+              <a:rPr lang="en-US" sz="3200" b="0" strike="noStrike" spc="-1" dirty="0" err="1">
+                <a:solidFill>
+                  <a:srgbClr val="0064C8"/>
+                </a:solidFill>
+                <a:latin typeface="Century Gothic"/>
+              </a:rPr>
+              <a:t>EdgeSHAPer</a:t>
             </a:r>
             <a:endParaRPr lang="en-US" sz="3200" b="0" strike="noStrike" spc="-1" dirty="0">
               <a:solidFill>
@@ -13867,8 +15084,8 @@
         </p:nvSpPr>
         <p:spPr>
           <a:xfrm>
-            <a:off x="380880" y="1371598"/>
-            <a:ext cx="8109070" cy="4559301"/>
+            <a:off x="374529" y="1371598"/>
+            <a:ext cx="4251523" cy="4559301"/>
           </a:xfrm>
           <a:prstGeom prst="rect">
             <a:avLst/>
@@ -14067,11 +15284,68 @@
                 </a:solidFill>
                 <a:latin typeface="Century Gothic"/>
               </a:rPr>
-              <a:t>How to frame the project:</a:t>
+              <a:t>Explanation with </a:t>
             </a:r>
-          </a:p>
-          <a:p>
-            <a:pPr lvl="1">
+            <a:r>
+              <a:rPr lang="en-US" sz="2000" spc="-1" dirty="0" err="1">
+                <a:solidFill>
+                  <a:srgbClr val="000000"/>
+                </a:solidFill>
+                <a:latin typeface="Century Gothic"/>
+              </a:rPr>
+              <a:t>EdgeSHAPer</a:t>
+            </a:r>
+            <a:endParaRPr lang="en-US" sz="2000" spc="-1" dirty="0">
+              <a:solidFill>
+                <a:srgbClr val="000000"/>
+              </a:solidFill>
+              <a:latin typeface="Century Gothic"/>
+            </a:endParaRPr>
+          </a:p>
+          <a:p>
+            <a:pPr>
+              <a:lnSpc>
+                <a:spcPct val="100000"/>
+              </a:lnSpc>
+              <a:spcBef>
+                <a:spcPts val="400"/>
+              </a:spcBef>
+              <a:buClr>
+                <a:srgbClr val="0064C8"/>
+              </a:buClr>
+              <a:buFont typeface="Wingdings" panose="05000000000000000000" pitchFamily="2" charset="2"/>
+              <a:buChar char="§"/>
+            </a:pPr>
+            <a:endParaRPr lang="en-US" sz="2000" spc="-1" dirty="0">
+              <a:solidFill>
+                <a:srgbClr val="000000"/>
+              </a:solidFill>
+              <a:latin typeface="Century Gothic"/>
+            </a:endParaRPr>
+          </a:p>
+          <a:p>
+            <a:pPr>
+              <a:lnSpc>
+                <a:spcPct val="100000"/>
+              </a:lnSpc>
+              <a:spcBef>
+                <a:spcPts val="400"/>
+              </a:spcBef>
+              <a:buClr>
+                <a:srgbClr val="0064C8"/>
+              </a:buClr>
+              <a:buFont typeface="Wingdings" panose="05000000000000000000" pitchFamily="2" charset="2"/>
+              <a:buChar char="§"/>
+            </a:pPr>
+            <a:endParaRPr lang="en-US" sz="2000" spc="-1" dirty="0">
+              <a:solidFill>
+                <a:srgbClr val="000000"/>
+              </a:solidFill>
+              <a:latin typeface="Century Gothic"/>
+            </a:endParaRPr>
+          </a:p>
+          <a:p>
+            <a:pPr>
               <a:lnSpc>
                 <a:spcPct val="100000"/>
               </a:lnSpc>
@@ -14085,17 +15359,59 @@
               <a:buChar char="§"/>
             </a:pPr>
             <a:r>
-              <a:rPr lang="en-US" sz="1600" spc="-1" dirty="0">
+              <a:rPr lang="en-US" sz="2000" spc="-1" dirty="0">
                 <a:solidFill>
                   <a:srgbClr val="000000"/>
                 </a:solidFill>
                 <a:latin typeface="Century Gothic"/>
               </a:rPr>
-              <a:t>A proof-of-concept study?</a:t>
+              <a:t>Visualization</a:t>
             </a:r>
           </a:p>
           <a:p>
-            <a:pPr lvl="1">
+            <a:pPr>
+              <a:lnSpc>
+                <a:spcPct val="100000"/>
+              </a:lnSpc>
+              <a:spcBef>
+                <a:spcPts val="400"/>
+              </a:spcBef>
+              <a:buClr>
+                <a:srgbClr val="0064C8"/>
+              </a:buClr>
+              <a:buFont typeface="Wingdings" panose="05000000000000000000" pitchFamily="2" charset="2"/>
+              <a:buChar char="§"/>
+            </a:pPr>
+            <a:endParaRPr lang="en-US" sz="2000" spc="-1" dirty="0">
+              <a:solidFill>
+                <a:srgbClr val="000000"/>
+              </a:solidFill>
+              <a:latin typeface="Century Gothic"/>
+            </a:endParaRPr>
+          </a:p>
+          <a:p>
+            <a:pPr>
+              <a:lnSpc>
+                <a:spcPct val="100000"/>
+              </a:lnSpc>
+              <a:spcBef>
+                <a:spcPts val="400"/>
+              </a:spcBef>
+              <a:buClr>
+                <a:srgbClr val="0064C8"/>
+              </a:buClr>
+              <a:buFont typeface="Wingdings" panose="05000000000000000000" pitchFamily="2" charset="2"/>
+              <a:buChar char="§"/>
+            </a:pPr>
+            <a:endParaRPr lang="en-US" sz="2000" spc="-1" dirty="0">
+              <a:solidFill>
+                <a:srgbClr val="000000"/>
+              </a:solidFill>
+              <a:latin typeface="Century Gothic"/>
+            </a:endParaRPr>
+          </a:p>
+          <a:p>
+            <a:pPr>
               <a:lnSpc>
                 <a:spcPct val="100000"/>
               </a:lnSpc>
@@ -14109,17 +15425,17 @@
               <a:buChar char="§"/>
             </a:pPr>
             <a:r>
-              <a:rPr lang="en-US" sz="1600" spc="-1" dirty="0">
+              <a:rPr lang="en-US" sz="2000" b="1" spc="-1" dirty="0">
                 <a:solidFill>
                   <a:srgbClr val="000000"/>
                 </a:solidFill>
                 <a:latin typeface="Century Gothic"/>
               </a:rPr>
-              <a:t>An explainability platform for XAI applied to molecular design?</a:t>
+              <a:t>Interpretation by LLM </a:t>
             </a:r>
           </a:p>
           <a:p>
-            <a:pPr lvl="1">
+            <a:pPr>
               <a:lnSpc>
                 <a:spcPct val="100000"/>
               </a:lnSpc>
@@ -14132,91 +15448,7 @@
               <a:buFont typeface="Wingdings" panose="05000000000000000000" pitchFamily="2" charset="2"/>
               <a:buChar char="§"/>
             </a:pPr>
-            <a:r>
-              <a:rPr lang="en-US" sz="1600" spc="-1" dirty="0">
-                <a:solidFill>
-                  <a:srgbClr val="000000"/>
-                </a:solidFill>
-                <a:latin typeface="Century Gothic"/>
-              </a:rPr>
-              <a:t>An explainability platform for XAI specific to molecular selectivity?</a:t>
-            </a:r>
-          </a:p>
-          <a:p>
-            <a:pPr lvl="1">
-              <a:lnSpc>
-                <a:spcPct val="100000"/>
-              </a:lnSpc>
-              <a:spcBef>
-                <a:spcPts val="400"/>
-              </a:spcBef>
-              <a:buClr>
-                <a:srgbClr val="0064C8"/>
-              </a:buClr>
-              <a:buFont typeface="Wingdings" panose="05000000000000000000" pitchFamily="2" charset="2"/>
-              <a:buChar char="§"/>
-            </a:pPr>
-            <a:r>
-              <a:rPr lang="en-US" sz="1600" spc="-1" dirty="0">
-                <a:solidFill>
-                  <a:srgbClr val="000000"/>
-                </a:solidFill>
-                <a:latin typeface="Century Gothic"/>
-              </a:rPr>
-              <a:t>A modular </a:t>
-            </a:r>
-            <a:r>
-              <a:rPr lang="en-US" sz="1600" spc="-1" dirty="0" err="1">
-                <a:solidFill>
-                  <a:srgbClr val="000000"/>
-                </a:solidFill>
-                <a:latin typeface="Century Gothic"/>
-              </a:rPr>
-              <a:t>explainability</a:t>
-            </a:r>
-            <a:r>
-              <a:rPr lang="en-US" sz="1600" spc="-1" dirty="0">
-                <a:solidFill>
-                  <a:srgbClr val="000000"/>
-                </a:solidFill>
-                <a:latin typeface="Century Gothic"/>
-              </a:rPr>
-              <a:t>-enhanced platform for </a:t>
-            </a:r>
-            <a:r>
-              <a:rPr lang="en-US" sz="1600" spc="-1" dirty="0" err="1">
-                <a:solidFill>
-                  <a:srgbClr val="000000"/>
-                </a:solidFill>
-                <a:latin typeface="Century Gothic"/>
-              </a:rPr>
-              <a:t>chemoinformatics</a:t>
-            </a:r>
-            <a:r>
-              <a:rPr lang="en-US" sz="1600" spc="-1" dirty="0">
-                <a:solidFill>
-                  <a:srgbClr val="000000"/>
-                </a:solidFill>
-                <a:latin typeface="Century Gothic"/>
-              </a:rPr>
-              <a:t>? </a:t>
-            </a:r>
-          </a:p>
-          <a:p>
-            <a:pPr lvl="1">
-              <a:lnSpc>
-                <a:spcPct val="100000"/>
-              </a:lnSpc>
-              <a:spcBef>
-                <a:spcPts val="400"/>
-              </a:spcBef>
-              <a:buClr>
-                <a:srgbClr val="0064C8"/>
-              </a:buClr>
-              <a:buFont typeface="Wingdings" panose="05000000000000000000" pitchFamily="2" charset="2"/>
-              <a:buChar char="§"/>
-            </a:pPr>
-            <a:endParaRPr lang="en-US" sz="1600" spc="-1" dirty="0">
+            <a:endParaRPr lang="en-US" sz="2000" spc="-1" dirty="0">
               <a:solidFill>
                 <a:srgbClr val="000000"/>
               </a:solidFill>
@@ -14224,7 +15456,7 @@
             </a:endParaRPr>
           </a:p>
           <a:p>
-            <a:pPr lvl="1">
+            <a:pPr marL="0" indent="0">
               <a:lnSpc>
                 <a:spcPct val="100000"/>
               </a:lnSpc>
@@ -14234,10 +15466,9 @@
               <a:buClr>
                 <a:srgbClr val="0064C8"/>
               </a:buClr>
-              <a:buFont typeface="Wingdings" panose="05000000000000000000" pitchFamily="2" charset="2"/>
-              <a:buChar char="§"/>
+              <a:buNone/>
             </a:pPr>
-            <a:endParaRPr lang="en-US" sz="1600" spc="-1" dirty="0">
+            <a:endParaRPr lang="en-US" sz="2000" spc="-1" dirty="0">
               <a:solidFill>
                 <a:srgbClr val="000000"/>
               </a:solidFill>
@@ -14312,28 +15543,114 @@
           </a:p>
         </p:txBody>
       </p:sp>
+      <p:pic>
+        <p:nvPicPr>
+          <p:cNvPr id="4" name="Graphic 3" descr="Warning with solid fill">
+            <a:extLst>
+              <a:ext uri="{FF2B5EF4-FFF2-40B4-BE49-F238E27FC236}">
+                <a16:creationId xmlns:a16="http://schemas.microsoft.com/office/drawing/2014/main" id="{E98D6943-8123-432E-B888-F72E412B7491}"/>
+              </a:ext>
+            </a:extLst>
+          </p:cNvPr>
+          <p:cNvPicPr>
+            <a:picLocks noChangeAspect="1"/>
+          </p:cNvPicPr>
+          <p:nvPr/>
+        </p:nvPicPr>
+        <p:blipFill>
+          <a:blip r:embed="rId2">
+            <a:extLst>
+              <a:ext uri="{28A0092B-C50C-407E-A947-70E740481C1C}">
+                <a14:useLocalDpi xmlns:a14="http://schemas.microsoft.com/office/drawing/2010/main" val="0"/>
+              </a:ext>
+              <a:ext uri="{96DAC541-7B7A-43D3-8B79-37D633B846F1}">
+                <asvg:svgBlip xmlns:asvg="http://schemas.microsoft.com/office/drawing/2016/SVG/main" r:embed="rId3"/>
+              </a:ext>
+            </a:extLst>
+          </a:blip>
+          <a:stretch>
+            <a:fillRect/>
+          </a:stretch>
+        </p:blipFill>
+        <p:spPr>
+          <a:xfrm>
+            <a:off x="3452648" y="3342695"/>
+            <a:ext cx="657242" cy="657242"/>
+          </a:xfrm>
+          <a:prstGeom prst="rect">
+            <a:avLst/>
+          </a:prstGeom>
+        </p:spPr>
+      </p:pic>
+      <p:pic>
+        <p:nvPicPr>
+          <p:cNvPr id="8" name="Picture 7">
+            <a:extLst>
+              <a:ext uri="{FF2B5EF4-FFF2-40B4-BE49-F238E27FC236}">
+                <a16:creationId xmlns:a16="http://schemas.microsoft.com/office/drawing/2014/main" id="{5867E8F3-108A-471B-965A-75C4C333D304}"/>
+              </a:ext>
+            </a:extLst>
+          </p:cNvPr>
+          <p:cNvPicPr>
+            <a:picLocks noChangeAspect="1"/>
+          </p:cNvPicPr>
+          <p:nvPr/>
+        </p:nvPicPr>
+        <p:blipFill rotWithShape="1">
+          <a:blip r:embed="rId4"/>
+          <a:srcRect b="25455"/>
+          <a:stretch/>
+        </p:blipFill>
+        <p:spPr>
+          <a:xfrm>
+            <a:off x="4698409" y="1007015"/>
+            <a:ext cx="3927583" cy="2081278"/>
+          </a:xfrm>
+          <a:prstGeom prst="rect">
+            <a:avLst/>
+          </a:prstGeom>
+        </p:spPr>
+      </p:pic>
+      <p:pic>
+        <p:nvPicPr>
+          <p:cNvPr id="11" name="Picture 10">
+            <a:extLst>
+              <a:ext uri="{FF2B5EF4-FFF2-40B4-BE49-F238E27FC236}">
+                <a16:creationId xmlns:a16="http://schemas.microsoft.com/office/drawing/2014/main" id="{9C2944AD-320D-42C0-A96F-022974D408EA}"/>
+              </a:ext>
+            </a:extLst>
+          </p:cNvPr>
+          <p:cNvPicPr>
+            <a:picLocks noChangeAspect="1"/>
+          </p:cNvPicPr>
+          <p:nvPr/>
+        </p:nvPicPr>
+        <p:blipFill>
+          <a:blip r:embed="rId5"/>
+          <a:stretch>
+            <a:fillRect/>
+          </a:stretch>
+        </p:blipFill>
+        <p:spPr>
+          <a:xfrm>
+            <a:off x="4698409" y="3088293"/>
+            <a:ext cx="3927582" cy="3038243"/>
+          </a:xfrm>
+          <a:prstGeom prst="rect">
+            <a:avLst/>
+          </a:prstGeom>
+        </p:spPr>
+      </p:pic>
     </p:spTree>
     <p:extLst>
       <p:ext uri="{BB962C8B-B14F-4D97-AF65-F5344CB8AC3E}">
-        <p14:creationId xmlns:p14="http://schemas.microsoft.com/office/powerpoint/2010/main" val="1594879052"/>
+        <p14:creationId xmlns:p14="http://schemas.microsoft.com/office/powerpoint/2010/main" val="44043232"/>
       </p:ext>
     </p:extLst>
   </p:cSld>
   <p:clrMapOvr>
     <a:masterClrMapping/>
   </p:clrMapOvr>
-  <mc:AlternateContent xmlns:mc="http://schemas.openxmlformats.org/markup-compatibility/2006" xmlns:p14="http://schemas.microsoft.com/office/powerpoint/2010/main">
-    <mc:Choice Requires="p14">
-      <p:transition spd="med" p14:dur="700">
-        <p:fade/>
-      </p:transition>
-    </mc:Choice>
-    <mc:Fallback xmlns="">
-      <p:transition spd="med">
-        <p:fade/>
-      </p:transition>
-    </mc:Fallback>
-  </mc:AlternateContent>
 </p:sld>
 </file>
 

</xml_diff>

<commit_message>
Add black-and-white atom palette option for molecule visualization on edgeshaper
</commit_message>
<xml_diff>
--- a/slides/AI_Agent_Explainability.pptx
+++ b/slides/AI_Agent_Explainability.pptx
@@ -5,18 +5,23 @@
     <p:sldMasterId id="2147483648" r:id="rId1"/>
     <p:sldMasterId id="2147483661" r:id="rId2"/>
   </p:sldMasterIdLst>
+  <p:notesMasterIdLst>
+    <p:notesMasterId r:id="rId16"/>
+  </p:notesMasterIdLst>
   <p:sldIdLst>
     <p:sldId id="297" r:id="rId3"/>
     <p:sldId id="298" r:id="rId4"/>
     <p:sldId id="299" r:id="rId5"/>
-    <p:sldId id="301" r:id="rId6"/>
+    <p:sldId id="519" r:id="rId6"/>
     <p:sldId id="300" r:id="rId7"/>
     <p:sldId id="302" r:id="rId8"/>
     <p:sldId id="305" r:id="rId9"/>
     <p:sldId id="306" r:id="rId10"/>
     <p:sldId id="307" r:id="rId11"/>
-    <p:sldId id="303" r:id="rId12"/>
-    <p:sldId id="304" r:id="rId13"/>
+    <p:sldId id="556" r:id="rId12"/>
+    <p:sldId id="303" r:id="rId13"/>
+    <p:sldId id="304" r:id="rId14"/>
+    <p:sldId id="301" r:id="rId15"/>
   </p:sldIdLst>
   <p:sldSz cx="9144000" cy="6858000" type="screen4x3"/>
   <p:notesSz cx="7559675" cy="10691813"/>
@@ -125,45 +130,6 @@
 
 <file path=ppt/changesInfos/changesInfo1.xml><?xml version="1.0" encoding="utf-8"?>
 <pc:chgInfo xmlns:a="http://schemas.openxmlformats.org/drawingml/2006/main" xmlns:r="http://schemas.openxmlformats.org/officeDocument/2006/relationships" xmlns:ac="http://schemas.microsoft.com/office/drawing/2013/main/command" xmlns:pc="http://schemas.microsoft.com/office/powerpoint/2013/main/command">
-  <pc:docChgLst>
-    <pc:chgData name="Tiago Janela" userId="ee1a79fe-c79c-4f34-9602-7f6f2f0482b3" providerId="ADAL" clId="{67D2C233-DF3C-4C6D-9040-D7553E3BCB8A}"/>
-    <pc:docChg chg="delSld modSld">
-      <pc:chgData name="Tiago Janela" userId="ee1a79fe-c79c-4f34-9602-7f6f2f0482b3" providerId="ADAL" clId="{67D2C233-DF3C-4C6D-9040-D7553E3BCB8A}" dt="2026-03-16T14:03:02.466" v="54" actId="20577"/>
-      <pc:docMkLst>
-        <pc:docMk/>
-      </pc:docMkLst>
-      <pc:sldChg chg="modSp mod">
-        <pc:chgData name="Tiago Janela" userId="ee1a79fe-c79c-4f34-9602-7f6f2f0482b3" providerId="ADAL" clId="{67D2C233-DF3C-4C6D-9040-D7553E3BCB8A}" dt="2026-03-16T14:03:02.466" v="54" actId="20577"/>
-        <pc:sldMkLst>
-          <pc:docMk/>
-          <pc:sldMk cId="829672710" sldId="297"/>
-        </pc:sldMkLst>
-        <pc:spChg chg="mod">
-          <ac:chgData name="Tiago Janela" userId="ee1a79fe-c79c-4f34-9602-7f6f2f0482b3" providerId="ADAL" clId="{67D2C233-DF3C-4C6D-9040-D7553E3BCB8A}" dt="2026-03-16T14:03:02.466" v="54" actId="20577"/>
-          <ac:spMkLst>
-            <pc:docMk/>
-            <pc:sldMk cId="829672710" sldId="297"/>
-            <ac:spMk id="156" creationId="{00000000-0000-0000-0000-000000000000}"/>
-          </ac:spMkLst>
-        </pc:spChg>
-      </pc:sldChg>
-      <pc:sldChg chg="modSp mod">
-        <pc:chgData name="Tiago Janela" userId="ee1a79fe-c79c-4f34-9602-7f6f2f0482b3" providerId="ADAL" clId="{67D2C233-DF3C-4C6D-9040-D7553E3BCB8A}" dt="2026-03-16T14:02:34.148" v="0" actId="20577"/>
-        <pc:sldMkLst>
-          <pc:docMk/>
-          <pc:sldMk cId="721732568" sldId="298"/>
-        </pc:sldMkLst>
-        <pc:spChg chg="mod">
-          <ac:chgData name="Tiago Janela" userId="ee1a79fe-c79c-4f34-9602-7f6f2f0482b3" providerId="ADAL" clId="{67D2C233-DF3C-4C6D-9040-D7553E3BCB8A}" dt="2026-03-16T14:02:34.148" v="0" actId="20577"/>
-          <ac:spMkLst>
-            <pc:docMk/>
-            <pc:sldMk cId="721732568" sldId="298"/>
-            <ac:spMk id="2" creationId="{870990D0-7AC5-46BA-6FC4-274F8E0A3ABE}"/>
-          </ac:spMkLst>
-        </pc:spChg>
-      </pc:sldChg>
-    </pc:docChg>
-  </pc:docChgLst>
   <pc:docChgLst>
     <pc:chgData name="Tiago Janela" userId="ee1a79fe-c79c-4f34-9602-7f6f2f0482b3" providerId="ADAL" clId="{6BE67FA1-4A27-48B9-BA6A-E25A9786A9CC}"/>
     <pc:docChg chg="undo custSel addSld modSld sldOrd">
@@ -298,6 +264,90 @@
     </pc:docChg>
   </pc:docChgLst>
   <pc:docChgLst>
+    <pc:chgData name="Tiago Janela" userId="ee1a79fe-c79c-4f34-9602-7f6f2f0482b3" providerId="ADAL" clId="{FF6951D0-D029-4985-BC76-70E5B4A62478}"/>
+    <pc:docChg chg="addSld modSld sldOrd">
+      <pc:chgData name="Tiago Janela" userId="ee1a79fe-c79c-4f34-9602-7f6f2f0482b3" providerId="ADAL" clId="{FF6951D0-D029-4985-BC76-70E5B4A62478}" dt="2026-04-24T09:48:18.185" v="6"/>
+      <pc:docMkLst>
+        <pc:docMk/>
+      </pc:docMkLst>
+      <pc:sldChg chg="modSp mod">
+        <pc:chgData name="Tiago Janela" userId="ee1a79fe-c79c-4f34-9602-7f6f2f0482b3" providerId="ADAL" clId="{FF6951D0-D029-4985-BC76-70E5B4A62478}" dt="2026-04-24T09:45:33.131" v="1" actId="20577"/>
+        <pc:sldMkLst>
+          <pc:docMk/>
+          <pc:sldMk cId="1707478755" sldId="299"/>
+        </pc:sldMkLst>
+        <pc:spChg chg="mod">
+          <ac:chgData name="Tiago Janela" userId="ee1a79fe-c79c-4f34-9602-7f6f2f0482b3" providerId="ADAL" clId="{FF6951D0-D029-4985-BC76-70E5B4A62478}" dt="2026-04-24T09:45:33.131" v="1" actId="20577"/>
+          <ac:spMkLst>
+            <pc:docMk/>
+            <pc:sldMk cId="1707478755" sldId="299"/>
+            <ac:spMk id="2" creationId="{870990D0-7AC5-46BA-6FC4-274F8E0A3ABE}"/>
+          </ac:spMkLst>
+        </pc:spChg>
+      </pc:sldChg>
+      <pc:sldChg chg="mod ord modShow">
+        <pc:chgData name="Tiago Janela" userId="ee1a79fe-c79c-4f34-9602-7f6f2f0482b3" providerId="ADAL" clId="{FF6951D0-D029-4985-BC76-70E5B4A62478}" dt="2026-04-24T09:47:45.785" v="5"/>
+        <pc:sldMkLst>
+          <pc:docMk/>
+          <pc:sldMk cId="2375808848" sldId="301"/>
+        </pc:sldMkLst>
+      </pc:sldChg>
+      <pc:sldChg chg="add">
+        <pc:chgData name="Tiago Janela" userId="ee1a79fe-c79c-4f34-9602-7f6f2f0482b3" providerId="ADAL" clId="{FF6951D0-D029-4985-BC76-70E5B4A62478}" dt="2026-04-24T09:47:35.256" v="2"/>
+        <pc:sldMkLst>
+          <pc:docMk/>
+          <pc:sldMk cId="921095034" sldId="519"/>
+        </pc:sldMkLst>
+      </pc:sldChg>
+      <pc:sldChg chg="add">
+        <pc:chgData name="Tiago Janela" userId="ee1a79fe-c79c-4f34-9602-7f6f2f0482b3" providerId="ADAL" clId="{FF6951D0-D029-4985-BC76-70E5B4A62478}" dt="2026-04-24T09:48:18.185" v="6"/>
+        <pc:sldMkLst>
+          <pc:docMk/>
+          <pc:sldMk cId="2674446027" sldId="556"/>
+        </pc:sldMkLst>
+      </pc:sldChg>
+    </pc:docChg>
+  </pc:docChgLst>
+  <pc:docChgLst>
+    <pc:chgData name="Tiago Janela" userId="ee1a79fe-c79c-4f34-9602-7f6f2f0482b3" providerId="ADAL" clId="{67D2C233-DF3C-4C6D-9040-D7553E3BCB8A}"/>
+    <pc:docChg chg="delSld modSld">
+      <pc:chgData name="Tiago Janela" userId="ee1a79fe-c79c-4f34-9602-7f6f2f0482b3" providerId="ADAL" clId="{67D2C233-DF3C-4C6D-9040-D7553E3BCB8A}" dt="2026-03-16T14:03:02.466" v="54" actId="20577"/>
+      <pc:docMkLst>
+        <pc:docMk/>
+      </pc:docMkLst>
+      <pc:sldChg chg="modSp mod">
+        <pc:chgData name="Tiago Janela" userId="ee1a79fe-c79c-4f34-9602-7f6f2f0482b3" providerId="ADAL" clId="{67D2C233-DF3C-4C6D-9040-D7553E3BCB8A}" dt="2026-03-16T14:03:02.466" v="54" actId="20577"/>
+        <pc:sldMkLst>
+          <pc:docMk/>
+          <pc:sldMk cId="829672710" sldId="297"/>
+        </pc:sldMkLst>
+        <pc:spChg chg="mod">
+          <ac:chgData name="Tiago Janela" userId="ee1a79fe-c79c-4f34-9602-7f6f2f0482b3" providerId="ADAL" clId="{67D2C233-DF3C-4C6D-9040-D7553E3BCB8A}" dt="2026-03-16T14:03:02.466" v="54" actId="20577"/>
+          <ac:spMkLst>
+            <pc:docMk/>
+            <pc:sldMk cId="829672710" sldId="297"/>
+            <ac:spMk id="156" creationId="{00000000-0000-0000-0000-000000000000}"/>
+          </ac:spMkLst>
+        </pc:spChg>
+      </pc:sldChg>
+      <pc:sldChg chg="modSp mod">
+        <pc:chgData name="Tiago Janela" userId="ee1a79fe-c79c-4f34-9602-7f6f2f0482b3" providerId="ADAL" clId="{67D2C233-DF3C-4C6D-9040-D7553E3BCB8A}" dt="2026-03-16T14:02:34.148" v="0" actId="20577"/>
+        <pc:sldMkLst>
+          <pc:docMk/>
+          <pc:sldMk cId="721732568" sldId="298"/>
+        </pc:sldMkLst>
+        <pc:spChg chg="mod">
+          <ac:chgData name="Tiago Janela" userId="ee1a79fe-c79c-4f34-9602-7f6f2f0482b3" providerId="ADAL" clId="{67D2C233-DF3C-4C6D-9040-D7553E3BCB8A}" dt="2026-03-16T14:02:34.148" v="0" actId="20577"/>
+          <ac:spMkLst>
+            <pc:docMk/>
+            <pc:sldMk cId="721732568" sldId="298"/>
+            <ac:spMk id="2" creationId="{870990D0-7AC5-46BA-6FC4-274F8E0A3ABE}"/>
+          </ac:spMkLst>
+        </pc:spChg>
+      </pc:sldChg>
+    </pc:docChg>
+  </pc:docChgLst>
+  <pc:docChgLst>
     <pc:chgData name="Tiago Janela" userId="ee1a79fe-c79c-4f34-9602-7f6f2f0482b3" providerId="ADAL" clId="{97693404-9C1B-400A-95DF-A7B72570E7A0}"/>
     <pc:docChg chg="undo custSel addSld delSld modSld sldOrd">
       <pc:chgData name="Tiago Janela" userId="ee1a79fe-c79c-4f34-9602-7f6f2f0482b3" providerId="ADAL" clId="{97693404-9C1B-400A-95DF-A7B72570E7A0}" dt="2026-03-09T10:33:25.226" v="5259" actId="20577"/>
@@ -322,6 +372,592 @@
     </pc:docChg>
   </pc:docChgLst>
 </pc:chgInfo>
+</file>
+
+<file path=ppt/notesMasters/notesMaster1.xml><?xml version="1.0" encoding="utf-8"?>
+<p:notesMaster xmlns:a="http://schemas.openxmlformats.org/drawingml/2006/main" xmlns:r="http://schemas.openxmlformats.org/officeDocument/2006/relationships" xmlns:p="http://schemas.openxmlformats.org/presentationml/2006/main">
+  <p:cSld>
+    <p:bg>
+      <p:bgRef idx="1001">
+        <a:schemeClr val="bg1"/>
+      </p:bgRef>
+    </p:bg>
+    <p:spTree>
+      <p:nvGrpSpPr>
+        <p:cNvPr id="1" name=""/>
+        <p:cNvGrpSpPr/>
+        <p:nvPr/>
+      </p:nvGrpSpPr>
+      <p:grpSpPr>
+        <a:xfrm>
+          <a:off x="0" y="0"/>
+          <a:ext cx="0" cy="0"/>
+          <a:chOff x="0" y="0"/>
+          <a:chExt cx="0" cy="0"/>
+        </a:xfrm>
+      </p:grpSpPr>
+      <p:sp>
+        <p:nvSpPr>
+          <p:cNvPr id="2" name="Header Placeholder 1"/>
+          <p:cNvSpPr>
+            <a:spLocks noGrp="1"/>
+          </p:cNvSpPr>
+          <p:nvPr>
+            <p:ph type="hdr" sz="quarter"/>
+          </p:nvPr>
+        </p:nvSpPr>
+        <p:spPr>
+          <a:xfrm>
+            <a:off x="0" y="0"/>
+            <a:ext cx="3276600" cy="536575"/>
+          </a:xfrm>
+          <a:prstGeom prst="rect">
+            <a:avLst/>
+          </a:prstGeom>
+        </p:spPr>
+        <p:txBody>
+          <a:bodyPr vert="horz" lIns="91440" tIns="45720" rIns="91440" bIns="45720" rtlCol="0"/>
+          <a:lstStyle>
+            <a:lvl1pPr algn="l">
+              <a:defRPr sz="1200"/>
+            </a:lvl1pPr>
+          </a:lstStyle>
+          <a:p>
+            <a:endParaRPr lang="de-DE"/>
+          </a:p>
+        </p:txBody>
+      </p:sp>
+      <p:sp>
+        <p:nvSpPr>
+          <p:cNvPr id="3" name="Date Placeholder 2"/>
+          <p:cNvSpPr>
+            <a:spLocks noGrp="1"/>
+          </p:cNvSpPr>
+          <p:nvPr>
+            <p:ph type="dt" idx="1"/>
+          </p:nvPr>
+        </p:nvSpPr>
+        <p:spPr>
+          <a:xfrm>
+            <a:off x="4281488" y="0"/>
+            <a:ext cx="3276600" cy="536575"/>
+          </a:xfrm>
+          <a:prstGeom prst="rect">
+            <a:avLst/>
+          </a:prstGeom>
+        </p:spPr>
+        <p:txBody>
+          <a:bodyPr vert="horz" lIns="91440" tIns="45720" rIns="91440" bIns="45720" rtlCol="0"/>
+          <a:lstStyle>
+            <a:lvl1pPr algn="r">
+              <a:defRPr sz="1200"/>
+            </a:lvl1pPr>
+          </a:lstStyle>
+          <a:p>
+            <a:fld id="{8895F6FA-647C-4311-838E-A4FEC80CEF77}" type="datetimeFigureOut">
+              <a:rPr lang="de-DE" smtClean="0"/>
+              <a:t>24.04.2026</a:t>
+            </a:fld>
+            <a:endParaRPr lang="de-DE"/>
+          </a:p>
+        </p:txBody>
+      </p:sp>
+      <p:sp>
+        <p:nvSpPr>
+          <p:cNvPr id="4" name="Slide Image Placeholder 3"/>
+          <p:cNvSpPr>
+            <a:spLocks noGrp="1" noRot="1" noChangeAspect="1"/>
+          </p:cNvSpPr>
+          <p:nvPr>
+            <p:ph type="sldImg" idx="2"/>
+          </p:nvPr>
+        </p:nvSpPr>
+        <p:spPr>
+          <a:xfrm>
+            <a:off x="1374775" y="1336675"/>
+            <a:ext cx="4810125" cy="3608388"/>
+          </a:xfrm>
+          <a:prstGeom prst="rect">
+            <a:avLst/>
+          </a:prstGeom>
+          <a:noFill/>
+          <a:ln w="12700">
+            <a:solidFill>
+              <a:prstClr val="black"/>
+            </a:solidFill>
+          </a:ln>
+        </p:spPr>
+        <p:txBody>
+          <a:bodyPr vert="horz" lIns="91440" tIns="45720" rIns="91440" bIns="45720" rtlCol="0" anchor="ctr"/>
+          <a:lstStyle/>
+          <a:p>
+            <a:endParaRPr lang="de-DE"/>
+          </a:p>
+        </p:txBody>
+      </p:sp>
+      <p:sp>
+        <p:nvSpPr>
+          <p:cNvPr id="5" name="Notes Placeholder 4"/>
+          <p:cNvSpPr>
+            <a:spLocks noGrp="1"/>
+          </p:cNvSpPr>
+          <p:nvPr>
+            <p:ph type="body" sz="quarter" idx="3"/>
+          </p:nvPr>
+        </p:nvSpPr>
+        <p:spPr>
+          <a:xfrm>
+            <a:off x="755650" y="5145088"/>
+            <a:ext cx="6048375" cy="4210050"/>
+          </a:xfrm>
+          <a:prstGeom prst="rect">
+            <a:avLst/>
+          </a:prstGeom>
+        </p:spPr>
+        <p:txBody>
+          <a:bodyPr vert="horz" lIns="91440" tIns="45720" rIns="91440" bIns="45720" rtlCol="0"/>
+          <a:lstStyle/>
+          <a:p>
+            <a:pPr lvl="0"/>
+            <a:r>
+              <a:rPr lang="en-US"/>
+              <a:t>Click to edit Master text styles</a:t>
+            </a:r>
+          </a:p>
+          <a:p>
+            <a:pPr lvl="1"/>
+            <a:r>
+              <a:rPr lang="en-US"/>
+              <a:t>Second level</a:t>
+            </a:r>
+          </a:p>
+          <a:p>
+            <a:pPr lvl="2"/>
+            <a:r>
+              <a:rPr lang="en-US"/>
+              <a:t>Third level</a:t>
+            </a:r>
+          </a:p>
+          <a:p>
+            <a:pPr lvl="3"/>
+            <a:r>
+              <a:rPr lang="en-US"/>
+              <a:t>Fourth level</a:t>
+            </a:r>
+          </a:p>
+          <a:p>
+            <a:pPr lvl="4"/>
+            <a:r>
+              <a:rPr lang="en-US"/>
+              <a:t>Fifth level</a:t>
+            </a:r>
+            <a:endParaRPr lang="de-DE"/>
+          </a:p>
+        </p:txBody>
+      </p:sp>
+      <p:sp>
+        <p:nvSpPr>
+          <p:cNvPr id="6" name="Footer Placeholder 5"/>
+          <p:cNvSpPr>
+            <a:spLocks noGrp="1"/>
+          </p:cNvSpPr>
+          <p:nvPr>
+            <p:ph type="ftr" sz="quarter" idx="4"/>
+          </p:nvPr>
+        </p:nvSpPr>
+        <p:spPr>
+          <a:xfrm>
+            <a:off x="0" y="10155238"/>
+            <a:ext cx="3276600" cy="536575"/>
+          </a:xfrm>
+          <a:prstGeom prst="rect">
+            <a:avLst/>
+          </a:prstGeom>
+        </p:spPr>
+        <p:txBody>
+          <a:bodyPr vert="horz" lIns="91440" tIns="45720" rIns="91440" bIns="45720" rtlCol="0" anchor="b"/>
+          <a:lstStyle>
+            <a:lvl1pPr algn="l">
+              <a:defRPr sz="1200"/>
+            </a:lvl1pPr>
+          </a:lstStyle>
+          <a:p>
+            <a:endParaRPr lang="de-DE"/>
+          </a:p>
+        </p:txBody>
+      </p:sp>
+      <p:sp>
+        <p:nvSpPr>
+          <p:cNvPr id="7" name="Slide Number Placeholder 6"/>
+          <p:cNvSpPr>
+            <a:spLocks noGrp="1"/>
+          </p:cNvSpPr>
+          <p:nvPr>
+            <p:ph type="sldNum" sz="quarter" idx="5"/>
+          </p:nvPr>
+        </p:nvSpPr>
+        <p:spPr>
+          <a:xfrm>
+            <a:off x="4281488" y="10155238"/>
+            <a:ext cx="3276600" cy="536575"/>
+          </a:xfrm>
+          <a:prstGeom prst="rect">
+            <a:avLst/>
+          </a:prstGeom>
+        </p:spPr>
+        <p:txBody>
+          <a:bodyPr vert="horz" lIns="91440" tIns="45720" rIns="91440" bIns="45720" rtlCol="0" anchor="b"/>
+          <a:lstStyle>
+            <a:lvl1pPr algn="r">
+              <a:defRPr sz="1200"/>
+            </a:lvl1pPr>
+          </a:lstStyle>
+          <a:p>
+            <a:fld id="{B1CB59DE-A395-4FE1-AF6E-B266016DC7B6}" type="slidenum">
+              <a:rPr lang="de-DE" smtClean="0"/>
+              <a:t>‹#›</a:t>
+            </a:fld>
+            <a:endParaRPr lang="de-DE"/>
+          </a:p>
+        </p:txBody>
+      </p:sp>
+    </p:spTree>
+    <p:extLst>
+      <p:ext uri="{BB962C8B-B14F-4D97-AF65-F5344CB8AC3E}">
+        <p14:creationId xmlns:p14="http://schemas.microsoft.com/office/powerpoint/2010/main" val="3301869723"/>
+      </p:ext>
+    </p:extLst>
+  </p:cSld>
+  <p:clrMap bg1="lt1" tx1="dk1" bg2="lt2" tx2="dk2" accent1="accent1" accent2="accent2" accent3="accent3" accent4="accent4" accent5="accent5" accent6="accent6" hlink="hlink" folHlink="folHlink"/>
+  <p:notesStyle>
+    <a:lvl1pPr marL="0" algn="l" defTabSz="914400" rtl="0" eaLnBrk="1" latinLnBrk="0" hangingPunct="1">
+      <a:defRPr sz="1200" kern="1200">
+        <a:solidFill>
+          <a:schemeClr val="tx1"/>
+        </a:solidFill>
+        <a:latin typeface="+mn-lt"/>
+        <a:ea typeface="+mn-ea"/>
+        <a:cs typeface="+mn-cs"/>
+      </a:defRPr>
+    </a:lvl1pPr>
+    <a:lvl2pPr marL="457200" algn="l" defTabSz="914400" rtl="0" eaLnBrk="1" latinLnBrk="0" hangingPunct="1">
+      <a:defRPr sz="1200" kern="1200">
+        <a:solidFill>
+          <a:schemeClr val="tx1"/>
+        </a:solidFill>
+        <a:latin typeface="+mn-lt"/>
+        <a:ea typeface="+mn-ea"/>
+        <a:cs typeface="+mn-cs"/>
+      </a:defRPr>
+    </a:lvl2pPr>
+    <a:lvl3pPr marL="914400" algn="l" defTabSz="914400" rtl="0" eaLnBrk="1" latinLnBrk="0" hangingPunct="1">
+      <a:defRPr sz="1200" kern="1200">
+        <a:solidFill>
+          <a:schemeClr val="tx1"/>
+        </a:solidFill>
+        <a:latin typeface="+mn-lt"/>
+        <a:ea typeface="+mn-ea"/>
+        <a:cs typeface="+mn-cs"/>
+      </a:defRPr>
+    </a:lvl3pPr>
+    <a:lvl4pPr marL="1371600" algn="l" defTabSz="914400" rtl="0" eaLnBrk="1" latinLnBrk="0" hangingPunct="1">
+      <a:defRPr sz="1200" kern="1200">
+        <a:solidFill>
+          <a:schemeClr val="tx1"/>
+        </a:solidFill>
+        <a:latin typeface="+mn-lt"/>
+        <a:ea typeface="+mn-ea"/>
+        <a:cs typeface="+mn-cs"/>
+      </a:defRPr>
+    </a:lvl4pPr>
+    <a:lvl5pPr marL="1828800" algn="l" defTabSz="914400" rtl="0" eaLnBrk="1" latinLnBrk="0" hangingPunct="1">
+      <a:defRPr sz="1200" kern="1200">
+        <a:solidFill>
+          <a:schemeClr val="tx1"/>
+        </a:solidFill>
+        <a:latin typeface="+mn-lt"/>
+        <a:ea typeface="+mn-ea"/>
+        <a:cs typeface="+mn-cs"/>
+      </a:defRPr>
+    </a:lvl5pPr>
+    <a:lvl6pPr marL="2286000" algn="l" defTabSz="914400" rtl="0" eaLnBrk="1" latinLnBrk="0" hangingPunct="1">
+      <a:defRPr sz="1200" kern="1200">
+        <a:solidFill>
+          <a:schemeClr val="tx1"/>
+        </a:solidFill>
+        <a:latin typeface="+mn-lt"/>
+        <a:ea typeface="+mn-ea"/>
+        <a:cs typeface="+mn-cs"/>
+      </a:defRPr>
+    </a:lvl6pPr>
+    <a:lvl7pPr marL="2743200" algn="l" defTabSz="914400" rtl="0" eaLnBrk="1" latinLnBrk="0" hangingPunct="1">
+      <a:defRPr sz="1200" kern="1200">
+        <a:solidFill>
+          <a:schemeClr val="tx1"/>
+        </a:solidFill>
+        <a:latin typeface="+mn-lt"/>
+        <a:ea typeface="+mn-ea"/>
+        <a:cs typeface="+mn-cs"/>
+      </a:defRPr>
+    </a:lvl7pPr>
+    <a:lvl8pPr marL="3200400" algn="l" defTabSz="914400" rtl="0" eaLnBrk="1" latinLnBrk="0" hangingPunct="1">
+      <a:defRPr sz="1200" kern="1200">
+        <a:solidFill>
+          <a:schemeClr val="tx1"/>
+        </a:solidFill>
+        <a:latin typeface="+mn-lt"/>
+        <a:ea typeface="+mn-ea"/>
+        <a:cs typeface="+mn-cs"/>
+      </a:defRPr>
+    </a:lvl8pPr>
+    <a:lvl9pPr marL="3657600" algn="l" defTabSz="914400" rtl="0" eaLnBrk="1" latinLnBrk="0" hangingPunct="1">
+      <a:defRPr sz="1200" kern="1200">
+        <a:solidFill>
+          <a:schemeClr val="tx1"/>
+        </a:solidFill>
+        <a:latin typeface="+mn-lt"/>
+        <a:ea typeface="+mn-ea"/>
+        <a:cs typeface="+mn-cs"/>
+      </a:defRPr>
+    </a:lvl9pPr>
+  </p:notesStyle>
+</p:notesMaster>
+</file>
+
+<file path=ppt/notesSlides/notesSlide1.xml><?xml version="1.0" encoding="utf-8"?>
+<p:notes xmlns:a="http://schemas.openxmlformats.org/drawingml/2006/main" xmlns:r="http://schemas.openxmlformats.org/officeDocument/2006/relationships" xmlns:p="http://schemas.openxmlformats.org/presentationml/2006/main">
+  <p:cSld>
+    <p:spTree>
+      <p:nvGrpSpPr>
+        <p:cNvPr id="1" name=""/>
+        <p:cNvGrpSpPr/>
+        <p:nvPr/>
+      </p:nvGrpSpPr>
+      <p:grpSpPr>
+        <a:xfrm>
+          <a:off x="0" y="0"/>
+          <a:ext cx="0" cy="0"/>
+          <a:chOff x="0" y="0"/>
+          <a:chExt cx="0" cy="0"/>
+        </a:xfrm>
+      </p:grpSpPr>
+      <p:sp>
+        <p:nvSpPr>
+          <p:cNvPr id="2" name="Marcador de Posição da Imagem do Diapositivo 1"/>
+          <p:cNvSpPr>
+            <a:spLocks noGrp="1" noRot="1" noChangeAspect="1"/>
+          </p:cNvSpPr>
+          <p:nvPr>
+            <p:ph type="sldImg"/>
+          </p:nvPr>
+        </p:nvSpPr>
+        <p:spPr/>
+      </p:sp>
+      <p:sp>
+        <p:nvSpPr>
+          <p:cNvPr id="3" name="Marcador de Posição de Notas 2"/>
+          <p:cNvSpPr>
+            <a:spLocks noGrp="1"/>
+          </p:cNvSpPr>
+          <p:nvPr>
+            <p:ph type="body" idx="1"/>
+          </p:nvPr>
+        </p:nvSpPr>
+        <p:spPr/>
+        <p:txBody>
+          <a:bodyPr/>
+          <a:lstStyle/>
+          <a:p>
+            <a:r>
+              <a:rPr lang="en-US" dirty="0"/>
+              <a:t>Here's a concrete example. </a:t>
+            </a:r>
+          </a:p>
+          <a:p>
+            <a:endParaRPr lang="en-US" dirty="0"/>
+          </a:p>
+          <a:p>
+            <a:r>
+              <a:rPr lang="en-US" dirty="0"/>
+              <a:t>The user asks the system to take a kinase selectivity dataset, split it using scaffold partitioning, train a random forest with cross-validated hyperparameter optimization, and report performance. </a:t>
+            </a:r>
+          </a:p>
+          <a:p>
+            <a:endParaRPr lang="en-US" dirty="0"/>
+          </a:p>
+          <a:p>
+            <a:r>
+              <a:rPr lang="en-US" dirty="0"/>
+              <a:t>The agent handles all of this autonomously. This workflow would normally require writing and debugging a Python script — here it's done through a text prompt.</a:t>
+            </a:r>
+            <a:endParaRPr lang="pt-PT" dirty="0"/>
+          </a:p>
+        </p:txBody>
+      </p:sp>
+      <p:sp>
+        <p:nvSpPr>
+          <p:cNvPr id="4" name="Marcador de Posição do Número do Diapositivo 3"/>
+          <p:cNvSpPr>
+            <a:spLocks noGrp="1"/>
+          </p:cNvSpPr>
+          <p:nvPr>
+            <p:ph type="sldNum" sz="quarter" idx="5"/>
+          </p:nvPr>
+        </p:nvSpPr>
+        <p:spPr/>
+        <p:txBody>
+          <a:bodyPr/>
+          <a:lstStyle/>
+          <a:p>
+            <a:fld id="{A8F1D436-8E8C-482D-8D71-F0E649122FF1}" type="slidenum">
+              <a:rPr lang="de-DE" smtClean="0"/>
+              <a:t>4</a:t>
+            </a:fld>
+            <a:endParaRPr lang="de-DE"/>
+          </a:p>
+        </p:txBody>
+      </p:sp>
+    </p:spTree>
+    <p:extLst>
+      <p:ext uri="{BB962C8B-B14F-4D97-AF65-F5344CB8AC3E}">
+        <p14:creationId xmlns:p14="http://schemas.microsoft.com/office/powerpoint/2010/main" val="2609654911"/>
+      </p:ext>
+    </p:extLst>
+  </p:cSld>
+  <p:clrMapOvr>
+    <a:masterClrMapping/>
+  </p:clrMapOvr>
+</p:notes>
+</file>
+
+<file path=ppt/notesSlides/notesSlide2.xml><?xml version="1.0" encoding="utf-8"?>
+<p:notes xmlns:a="http://schemas.openxmlformats.org/drawingml/2006/main" xmlns:r="http://schemas.openxmlformats.org/officeDocument/2006/relationships" xmlns:p="http://schemas.openxmlformats.org/presentationml/2006/main">
+  <p:cSld>
+    <p:spTree>
+      <p:nvGrpSpPr>
+        <p:cNvPr id="1" name="">
+          <a:extLst>
+            <a:ext uri="{FF2B5EF4-FFF2-40B4-BE49-F238E27FC236}">
+              <a16:creationId xmlns:a16="http://schemas.microsoft.com/office/drawing/2014/main" id="{3545D11D-EA46-9A83-3E55-EA32102FD929}"/>
+            </a:ext>
+          </a:extLst>
+        </p:cNvPr>
+        <p:cNvGrpSpPr/>
+        <p:nvPr/>
+      </p:nvGrpSpPr>
+      <p:grpSpPr>
+        <a:xfrm>
+          <a:off x="0" y="0"/>
+          <a:ext cx="0" cy="0"/>
+          <a:chOff x="0" y="0"/>
+          <a:chExt cx="0" cy="0"/>
+        </a:xfrm>
+      </p:grpSpPr>
+      <p:sp>
+        <p:nvSpPr>
+          <p:cNvPr id="2" name="Marcador de Posição da Imagem do Diapositivo 1">
+            <a:extLst>
+              <a:ext uri="{FF2B5EF4-FFF2-40B4-BE49-F238E27FC236}">
+                <a16:creationId xmlns:a16="http://schemas.microsoft.com/office/drawing/2014/main" id="{82B54D5D-CDA7-0157-77E7-1FDE8EDD9C48}"/>
+              </a:ext>
+            </a:extLst>
+          </p:cNvPr>
+          <p:cNvSpPr>
+            <a:spLocks noGrp="1" noRot="1" noChangeAspect="1"/>
+          </p:cNvSpPr>
+          <p:nvPr>
+            <p:ph type="sldImg"/>
+          </p:nvPr>
+        </p:nvSpPr>
+        <p:spPr/>
+      </p:sp>
+      <p:sp>
+        <p:nvSpPr>
+          <p:cNvPr id="3" name="Marcador de Posição de Notas 2">
+            <a:extLst>
+              <a:ext uri="{FF2B5EF4-FFF2-40B4-BE49-F238E27FC236}">
+                <a16:creationId xmlns:a16="http://schemas.microsoft.com/office/drawing/2014/main" id="{15DF8A04-46B2-BA00-FB5D-DACB585F0168}"/>
+              </a:ext>
+            </a:extLst>
+          </p:cNvPr>
+          <p:cNvSpPr>
+            <a:spLocks noGrp="1"/>
+          </p:cNvSpPr>
+          <p:nvPr>
+            <p:ph type="body" idx="1"/>
+          </p:nvPr>
+        </p:nvSpPr>
+        <p:spPr/>
+        <p:txBody>
+          <a:bodyPr/>
+          <a:lstStyle/>
+          <a:p>
+            <a:r>
+              <a:rPr lang="en-US" dirty="0"/>
+              <a:t>The practical advantages: it serves as a visual aid for medicinal chemists, increasing trust in ML predictions through transparency. </a:t>
+            </a:r>
+          </a:p>
+          <a:p>
+            <a:endParaRPr lang="en-US" dirty="0"/>
+          </a:p>
+          <a:p>
+            <a:r>
+              <a:rPr lang="en-US" dirty="0"/>
+              <a:t>It's fully integrated with an LLM, so it's ready to use. </a:t>
+            </a:r>
+          </a:p>
+          <a:p>
+            <a:endParaRPr lang="en-US" dirty="0"/>
+          </a:p>
+          <a:p>
+            <a:r>
+              <a:rPr lang="en-US" dirty="0"/>
+              <a:t>And it's built on open-source models, making it accessible and adaptable to different needs</a:t>
+            </a:r>
+            <a:endParaRPr lang="pt-PT" dirty="0"/>
+          </a:p>
+        </p:txBody>
+      </p:sp>
+      <p:sp>
+        <p:nvSpPr>
+          <p:cNvPr id="4" name="Marcador de Posição do Número do Diapositivo 3">
+            <a:extLst>
+              <a:ext uri="{FF2B5EF4-FFF2-40B4-BE49-F238E27FC236}">
+                <a16:creationId xmlns:a16="http://schemas.microsoft.com/office/drawing/2014/main" id="{A3FB29BA-E2DC-742B-7EFE-FDB07589800A}"/>
+              </a:ext>
+            </a:extLst>
+          </p:cNvPr>
+          <p:cNvSpPr>
+            <a:spLocks noGrp="1"/>
+          </p:cNvSpPr>
+          <p:nvPr>
+            <p:ph type="sldNum" sz="quarter" idx="5"/>
+          </p:nvPr>
+        </p:nvSpPr>
+        <p:spPr/>
+        <p:txBody>
+          <a:bodyPr/>
+          <a:lstStyle/>
+          <a:p>
+            <a:fld id="{A8F1D436-8E8C-482D-8D71-F0E649122FF1}" type="slidenum">
+              <a:rPr lang="de-DE" smtClean="0"/>
+              <a:t>10</a:t>
+            </a:fld>
+            <a:endParaRPr lang="de-DE"/>
+          </a:p>
+        </p:txBody>
+      </p:sp>
+    </p:spTree>
+    <p:extLst>
+      <p:ext uri="{BB962C8B-B14F-4D97-AF65-F5344CB8AC3E}">
+        <p14:creationId xmlns:p14="http://schemas.microsoft.com/office/powerpoint/2010/main" val="2535246732"/>
+      </p:ext>
+    </p:extLst>
+  </p:cSld>
+  <p:clrMapOvr>
+    <a:masterClrMapping/>
+  </p:clrMapOvr>
+</p:notes>
 </file>
 
 <file path=ppt/slideLayouts/slideLayout1.xml><?xml version="1.0" encoding="utf-8"?>
@@ -9358,7 +9994,7 @@
         <p:cNvPr id="1" name="">
           <a:extLst>
             <a:ext uri="{FF2B5EF4-FFF2-40B4-BE49-F238E27FC236}">
-              <a16:creationId xmlns:a16="http://schemas.microsoft.com/office/drawing/2014/main" id="{A6515F23-0912-A838-23CE-B8F00573A2DA}"/>
+              <a16:creationId xmlns:a16="http://schemas.microsoft.com/office/drawing/2014/main" id="{BBB5A1B2-7A92-53AE-94A1-C4092E55B578}"/>
             </a:ext>
           </a:extLst>
         </p:cNvPr>
@@ -9375,10 +10011,10 @@
       </p:grpSpPr>
       <p:sp>
         <p:nvSpPr>
-          <p:cNvPr id="163" name="PlaceHolder 1">
+          <p:cNvPr id="158" name="PlaceHolder 1">
             <a:extLst>
               <a:ext uri="{FF2B5EF4-FFF2-40B4-BE49-F238E27FC236}">
-                <a16:creationId xmlns:a16="http://schemas.microsoft.com/office/drawing/2014/main" id="{57944F4B-F502-E7CC-8790-8737702BC6AC}"/>
+                <a16:creationId xmlns:a16="http://schemas.microsoft.com/office/drawing/2014/main" id="{F4F64255-0CB6-D441-EB42-A827943DC4A3}"/>
               </a:ext>
             </a:extLst>
           </p:cNvPr>
@@ -9412,16 +10048,15 @@
               <a:lnSpc>
                 <a:spcPct val="100000"/>
               </a:lnSpc>
-              <a:buNone/>
             </a:pPr>
             <a:r>
-              <a:rPr lang="en-US" sz="3200" b="0" strike="noStrike" spc="-1" dirty="0">
+              <a:rPr lang="en-US" sz="3200" spc="-1" dirty="0">
                 <a:solidFill>
                   <a:srgbClr val="0064C8"/>
                 </a:solidFill>
                 <a:latin typeface="Century Gothic"/>
               </a:rPr>
-              <a:t>To do list</a:t>
+              <a:t>Agent Advantages and Improvements</a:t>
             </a:r>
             <a:endParaRPr lang="en-US" sz="3200" b="0" strike="noStrike" spc="-1" dirty="0">
               <a:solidFill>
@@ -9434,10 +10069,235 @@
       </p:sp>
       <p:sp>
         <p:nvSpPr>
-          <p:cNvPr id="165" name="PlaceHolder 3">
+          <p:cNvPr id="159" name="PlaceHolder 2">
             <a:extLst>
               <a:ext uri="{FF2B5EF4-FFF2-40B4-BE49-F238E27FC236}">
-                <a16:creationId xmlns:a16="http://schemas.microsoft.com/office/drawing/2014/main" id="{2EFBEA53-7B78-D9A1-93EF-9608A3193D27}"/>
+                <a16:creationId xmlns:a16="http://schemas.microsoft.com/office/drawing/2014/main" id="{D59FF44B-6222-67BD-CD20-4D01B6DF9761}"/>
+              </a:ext>
+            </a:extLst>
+          </p:cNvPr>
+          <p:cNvSpPr>
+            <a:spLocks noGrp="1"/>
+          </p:cNvSpPr>
+          <p:nvPr>
+            <p:ph/>
+          </p:nvPr>
+        </p:nvSpPr>
+        <p:spPr>
+          <a:xfrm>
+            <a:off x="382679" y="1371600"/>
+            <a:ext cx="8378281" cy="4321079"/>
+          </a:xfrm>
+          <a:prstGeom prst="rect">
+            <a:avLst/>
+          </a:prstGeom>
+          <a:noFill/>
+          <a:ln w="0">
+            <a:noFill/>
+          </a:ln>
+        </p:spPr>
+        <p:txBody>
+          <a:bodyPr numCol="1" spcCol="0" anchor="t">
+            <a:noAutofit/>
+          </a:bodyPr>
+          <a:lstStyle/>
+          <a:p>
+            <a:pPr marL="0" indent="0">
+              <a:spcBef>
+                <a:spcPts val="400"/>
+              </a:spcBef>
+              <a:spcAft>
+                <a:spcPts val="2400"/>
+              </a:spcAft>
+              <a:buClr>
+                <a:srgbClr val="0070C0"/>
+              </a:buClr>
+              <a:buNone/>
+            </a:pPr>
+            <a:r>
+              <a:rPr lang="en-US" sz="2000" b="1" strike="noStrike" spc="-1" dirty="0">
+                <a:latin typeface="Century Gothic"/>
+              </a:rPr>
+              <a:t>Practical advantages</a:t>
+            </a:r>
+            <a:r>
+              <a:rPr lang="en-US" sz="2000" strike="noStrike" spc="-1" dirty="0">
+                <a:latin typeface="Century Gothic"/>
+              </a:rPr>
+              <a:t> </a:t>
+            </a:r>
+          </a:p>
+          <a:p>
+            <a:pPr>
+              <a:spcBef>
+                <a:spcPts val="400"/>
+              </a:spcBef>
+              <a:spcAft>
+                <a:spcPts val="2400"/>
+              </a:spcAft>
+              <a:buClr>
+                <a:srgbClr val="0070C0"/>
+              </a:buClr>
+              <a:buFont typeface="Wingdings" panose="05000000000000000000" pitchFamily="2" charset="2"/>
+              <a:buChar char="§"/>
+            </a:pPr>
+            <a:r>
+              <a:rPr lang="en-US" sz="1800" spc="-1" dirty="0">
+                <a:latin typeface="Century Gothic"/>
+              </a:rPr>
+              <a:t>Visual aid for chemists → Increase transparency in ML predictions  </a:t>
+            </a:r>
+          </a:p>
+          <a:p>
+            <a:pPr>
+              <a:spcBef>
+                <a:spcPts val="400"/>
+              </a:spcBef>
+              <a:spcAft>
+                <a:spcPts val="2400"/>
+              </a:spcAft>
+              <a:buClr>
+                <a:srgbClr val="0070C0"/>
+              </a:buClr>
+              <a:buFont typeface="Wingdings" panose="05000000000000000000" pitchFamily="2" charset="2"/>
+              <a:buChar char="§"/>
+            </a:pPr>
+            <a:r>
+              <a:rPr lang="en-US" sz="1800" spc="-1" dirty="0">
+                <a:latin typeface="Century Gothic"/>
+              </a:rPr>
+              <a:t>Built on Open-source LLMs → Accessible to the community</a:t>
+            </a:r>
+          </a:p>
+          <a:p>
+            <a:pPr marL="0" indent="0">
+              <a:spcBef>
+                <a:spcPts val="400"/>
+              </a:spcBef>
+              <a:spcAft>
+                <a:spcPts val="2400"/>
+              </a:spcAft>
+              <a:buClr>
+                <a:srgbClr val="0070C0"/>
+              </a:buClr>
+              <a:buNone/>
+            </a:pPr>
+            <a:r>
+              <a:rPr lang="en-US" sz="2000" b="1" spc="-1" dirty="0">
+                <a:latin typeface="Century Gothic"/>
+              </a:rPr>
+              <a:t>Points to evaluate and improve</a:t>
+            </a:r>
+          </a:p>
+          <a:p>
+            <a:pPr>
+              <a:spcBef>
+                <a:spcPts val="400"/>
+              </a:spcBef>
+              <a:spcAft>
+                <a:spcPts val="2400"/>
+              </a:spcAft>
+              <a:buClr>
+                <a:srgbClr val="0070C0"/>
+              </a:buClr>
+              <a:buFont typeface="Wingdings" panose="05000000000000000000" pitchFamily="2" charset="2"/>
+              <a:buChar char="§"/>
+            </a:pPr>
+            <a:r>
+              <a:rPr lang="en-US" sz="1800" spc="-1" dirty="0">
+                <a:latin typeface="Century Gothic"/>
+              </a:rPr>
+              <a:t>Susceptibility to LLM hallucinations →  Use domain-specific models</a:t>
+            </a:r>
+            <a:endParaRPr lang="en-US" sz="1800" b="1" spc="-1" dirty="0">
+              <a:latin typeface="Century Gothic"/>
+            </a:endParaRPr>
+          </a:p>
+          <a:p>
+            <a:pPr>
+              <a:spcBef>
+                <a:spcPts val="400"/>
+              </a:spcBef>
+              <a:spcAft>
+                <a:spcPts val="2400"/>
+              </a:spcAft>
+              <a:buClr>
+                <a:srgbClr val="0070C0"/>
+              </a:buClr>
+              <a:buFont typeface="Wingdings" panose="05000000000000000000" pitchFamily="2" charset="2"/>
+              <a:buChar char="§"/>
+            </a:pPr>
+            <a:r>
+              <a:rPr lang="en-US" sz="1800" spc="-1" dirty="0">
+                <a:latin typeface="Century Gothic"/>
+              </a:rPr>
+              <a:t>Requires careful prompt curation → Addition of interactive chat feature</a:t>
+            </a:r>
+            <a:endParaRPr lang="en-US" sz="1800" b="1" spc="-1" dirty="0">
+              <a:latin typeface="Century Gothic"/>
+            </a:endParaRPr>
+          </a:p>
+          <a:p>
+            <a:pPr>
+              <a:spcBef>
+                <a:spcPts val="400"/>
+              </a:spcBef>
+              <a:spcAft>
+                <a:spcPts val="2400"/>
+              </a:spcAft>
+              <a:buClr>
+                <a:srgbClr val="0070C0"/>
+              </a:buClr>
+              <a:buFont typeface="Wingdings" panose="05000000000000000000" pitchFamily="2" charset="2"/>
+              <a:buChar char="§"/>
+            </a:pPr>
+            <a:endParaRPr lang="en-US" sz="1800" spc="-1" dirty="0">
+              <a:latin typeface="Century Gothic"/>
+            </a:endParaRPr>
+          </a:p>
+          <a:p>
+            <a:pPr marL="0" indent="0">
+              <a:spcBef>
+                <a:spcPts val="400"/>
+              </a:spcBef>
+              <a:spcAft>
+                <a:spcPts val="2400"/>
+              </a:spcAft>
+              <a:buClr>
+                <a:srgbClr val="0070C0"/>
+              </a:buClr>
+              <a:buNone/>
+            </a:pPr>
+            <a:endParaRPr lang="en-US" sz="2000" spc="-1" dirty="0">
+              <a:latin typeface="Century Gothic"/>
+            </a:endParaRPr>
+          </a:p>
+          <a:p>
+            <a:pPr lvl="1">
+              <a:spcBef>
+                <a:spcPts val="400"/>
+              </a:spcBef>
+              <a:spcAft>
+                <a:spcPts val="2400"/>
+              </a:spcAft>
+              <a:buClr>
+                <a:srgbClr val="0070C0"/>
+              </a:buClr>
+              <a:buFont typeface="Wingdings" panose="05000000000000000000" pitchFamily="2" charset="2"/>
+              <a:buChar char="§"/>
+            </a:pPr>
+            <a:endParaRPr lang="en-US" sz="1400" strike="noStrike" spc="-1" dirty="0">
+              <a:latin typeface="Century Gothic"/>
+            </a:endParaRPr>
+          </a:p>
+        </p:txBody>
+      </p:sp>
+      <p:sp>
+        <p:nvSpPr>
+          <p:cNvPr id="160" name="PlaceHolder 3">
+            <a:extLst>
+              <a:ext uri="{FF2B5EF4-FFF2-40B4-BE49-F238E27FC236}">
+                <a16:creationId xmlns:a16="http://schemas.microsoft.com/office/drawing/2014/main" id="{0DF1A3F0-772D-A247-0D44-2C215E694721}"/>
               </a:ext>
             </a:extLst>
           </p:cNvPr>
@@ -9473,7 +10333,7 @@
               </a:lnSpc>
               <a:buNone/>
             </a:pPr>
-            <a:fld id="{8BD7C522-1E12-40C3-B25E-5F0462E20B22}" type="slidenum">
+            <a:fld id="{7D48D3EA-1A87-4EB3-8072-3AEE88103579}" type="slidenum">
               <a:rPr lang="en-US" sz="1200" b="0" strike="noStrike" spc="-1">
                 <a:solidFill>
                   <a:srgbClr val="8B8B8B"/>
@@ -9482,474 +10342,8 @@
               </a:rPr>
               <a:t>10</a:t>
             </a:fld>
-            <a:endParaRPr lang="en-GB" sz="1200" b="0" strike="noStrike" spc="-1" dirty="0">
+            <a:endParaRPr lang="en-GB" sz="1200" b="0" strike="noStrike" spc="-1">
               <a:latin typeface="Times New Roman"/>
-            </a:endParaRPr>
-          </a:p>
-        </p:txBody>
-      </p:sp>
-      <p:sp>
-        <p:nvSpPr>
-          <p:cNvPr id="7" name="PlaceHolder 2">
-            <a:extLst>
-              <a:ext uri="{FF2B5EF4-FFF2-40B4-BE49-F238E27FC236}">
-                <a16:creationId xmlns:a16="http://schemas.microsoft.com/office/drawing/2014/main" id="{66DE14D4-64D4-6D1F-DD92-BC16D674C58B}"/>
-              </a:ext>
-            </a:extLst>
-          </p:cNvPr>
-          <p:cNvSpPr txBox="1">
-            <a:spLocks/>
-          </p:cNvSpPr>
-          <p:nvPr/>
-        </p:nvSpPr>
-        <p:spPr>
-          <a:xfrm>
-            <a:off x="380880" y="1371598"/>
-            <a:ext cx="8109070" cy="4559301"/>
-          </a:xfrm>
-          <a:prstGeom prst="rect">
-            <a:avLst/>
-          </a:prstGeom>
-          <a:noFill/>
-          <a:ln w="0">
-            <a:noFill/>
-          </a:ln>
-        </p:spPr>
-        <p:txBody>
-          <a:bodyPr numCol="1" spcCol="0" anchor="t">
-            <a:noAutofit/>
-          </a:bodyPr>
-          <a:lstStyle>
-            <a:lvl1pPr marL="228600" indent="-228600" algn="l" defTabSz="914400" rtl="0" eaLnBrk="1" latinLnBrk="0" hangingPunct="1">
-              <a:lnSpc>
-                <a:spcPct val="90000"/>
-              </a:lnSpc>
-              <a:spcBef>
-                <a:spcPts val="1000"/>
-              </a:spcBef>
-              <a:buFont typeface="Arial" panose="020B0604020202020204" pitchFamily="34" charset="0"/>
-              <a:buChar char="•"/>
-              <a:defRPr sz="2800" kern="1200">
-                <a:solidFill>
-                  <a:schemeClr val="tx1"/>
-                </a:solidFill>
-                <a:latin typeface="+mn-lt"/>
-                <a:ea typeface="+mn-ea"/>
-                <a:cs typeface="+mn-cs"/>
-              </a:defRPr>
-            </a:lvl1pPr>
-            <a:lvl2pPr marL="685800" indent="-228600" algn="l" defTabSz="914400" rtl="0" eaLnBrk="1" latinLnBrk="0" hangingPunct="1">
-              <a:lnSpc>
-                <a:spcPct val="90000"/>
-              </a:lnSpc>
-              <a:spcBef>
-                <a:spcPts val="500"/>
-              </a:spcBef>
-              <a:buFont typeface="Arial" panose="020B0604020202020204" pitchFamily="34" charset="0"/>
-              <a:buChar char="•"/>
-              <a:defRPr sz="2400" kern="1200">
-                <a:solidFill>
-                  <a:schemeClr val="tx1"/>
-                </a:solidFill>
-                <a:latin typeface="+mn-lt"/>
-                <a:ea typeface="+mn-ea"/>
-                <a:cs typeface="+mn-cs"/>
-              </a:defRPr>
-            </a:lvl2pPr>
-            <a:lvl3pPr marL="1143000" indent="-228600" algn="l" defTabSz="914400" rtl="0" eaLnBrk="1" latinLnBrk="0" hangingPunct="1">
-              <a:lnSpc>
-                <a:spcPct val="90000"/>
-              </a:lnSpc>
-              <a:spcBef>
-                <a:spcPts val="500"/>
-              </a:spcBef>
-              <a:buFont typeface="Arial" panose="020B0604020202020204" pitchFamily="34" charset="0"/>
-              <a:buChar char="•"/>
-              <a:defRPr sz="2000" kern="1200">
-                <a:solidFill>
-                  <a:schemeClr val="tx1"/>
-                </a:solidFill>
-                <a:latin typeface="+mn-lt"/>
-                <a:ea typeface="+mn-ea"/>
-                <a:cs typeface="+mn-cs"/>
-              </a:defRPr>
-            </a:lvl3pPr>
-            <a:lvl4pPr marL="1600200" indent="-228600" algn="l" defTabSz="914400" rtl="0" eaLnBrk="1" latinLnBrk="0" hangingPunct="1">
-              <a:lnSpc>
-                <a:spcPct val="90000"/>
-              </a:lnSpc>
-              <a:spcBef>
-                <a:spcPts val="500"/>
-              </a:spcBef>
-              <a:buFont typeface="Arial" panose="020B0604020202020204" pitchFamily="34" charset="0"/>
-              <a:buChar char="•"/>
-              <a:defRPr sz="1800" kern="1200">
-                <a:solidFill>
-                  <a:schemeClr val="tx1"/>
-                </a:solidFill>
-                <a:latin typeface="+mn-lt"/>
-                <a:ea typeface="+mn-ea"/>
-                <a:cs typeface="+mn-cs"/>
-              </a:defRPr>
-            </a:lvl4pPr>
-            <a:lvl5pPr marL="2057400" indent="-228600" algn="l" defTabSz="914400" rtl="0" eaLnBrk="1" latinLnBrk="0" hangingPunct="1">
-              <a:lnSpc>
-                <a:spcPct val="90000"/>
-              </a:lnSpc>
-              <a:spcBef>
-                <a:spcPts val="500"/>
-              </a:spcBef>
-              <a:buFont typeface="Arial" panose="020B0604020202020204" pitchFamily="34" charset="0"/>
-              <a:buChar char="•"/>
-              <a:defRPr sz="1800" kern="1200">
-                <a:solidFill>
-                  <a:schemeClr val="tx1"/>
-                </a:solidFill>
-                <a:latin typeface="+mn-lt"/>
-                <a:ea typeface="+mn-ea"/>
-                <a:cs typeface="+mn-cs"/>
-              </a:defRPr>
-            </a:lvl5pPr>
-            <a:lvl6pPr marL="2514600" indent="-228600" algn="l" defTabSz="914400" rtl="0" eaLnBrk="1" latinLnBrk="0" hangingPunct="1">
-              <a:lnSpc>
-                <a:spcPct val="90000"/>
-              </a:lnSpc>
-              <a:spcBef>
-                <a:spcPts val="500"/>
-              </a:spcBef>
-              <a:buFont typeface="Arial" panose="020B0604020202020204" pitchFamily="34" charset="0"/>
-              <a:buChar char="•"/>
-              <a:defRPr sz="1800" kern="1200">
-                <a:solidFill>
-                  <a:schemeClr val="tx1"/>
-                </a:solidFill>
-                <a:latin typeface="+mn-lt"/>
-                <a:ea typeface="+mn-ea"/>
-                <a:cs typeface="+mn-cs"/>
-              </a:defRPr>
-            </a:lvl6pPr>
-            <a:lvl7pPr marL="2971800" indent="-228600" algn="l" defTabSz="914400" rtl="0" eaLnBrk="1" latinLnBrk="0" hangingPunct="1">
-              <a:lnSpc>
-                <a:spcPct val="90000"/>
-              </a:lnSpc>
-              <a:spcBef>
-                <a:spcPts val="500"/>
-              </a:spcBef>
-              <a:buFont typeface="Arial" panose="020B0604020202020204" pitchFamily="34" charset="0"/>
-              <a:buChar char="•"/>
-              <a:defRPr sz="1800" kern="1200">
-                <a:solidFill>
-                  <a:schemeClr val="tx1"/>
-                </a:solidFill>
-                <a:latin typeface="+mn-lt"/>
-                <a:ea typeface="+mn-ea"/>
-                <a:cs typeface="+mn-cs"/>
-              </a:defRPr>
-            </a:lvl7pPr>
-            <a:lvl8pPr marL="3429000" indent="-228600" algn="l" defTabSz="914400" rtl="0" eaLnBrk="1" latinLnBrk="0" hangingPunct="1">
-              <a:lnSpc>
-                <a:spcPct val="90000"/>
-              </a:lnSpc>
-              <a:spcBef>
-                <a:spcPts val="500"/>
-              </a:spcBef>
-              <a:buFont typeface="Arial" panose="020B0604020202020204" pitchFamily="34" charset="0"/>
-              <a:buChar char="•"/>
-              <a:defRPr sz="1800" kern="1200">
-                <a:solidFill>
-                  <a:schemeClr val="tx1"/>
-                </a:solidFill>
-                <a:latin typeface="+mn-lt"/>
-                <a:ea typeface="+mn-ea"/>
-                <a:cs typeface="+mn-cs"/>
-              </a:defRPr>
-            </a:lvl8pPr>
-            <a:lvl9pPr marL="3886200" indent="-228600" algn="l" defTabSz="914400" rtl="0" eaLnBrk="1" latinLnBrk="0" hangingPunct="1">
-              <a:lnSpc>
-                <a:spcPct val="90000"/>
-              </a:lnSpc>
-              <a:spcBef>
-                <a:spcPts val="500"/>
-              </a:spcBef>
-              <a:buFont typeface="Arial" panose="020B0604020202020204" pitchFamily="34" charset="0"/>
-              <a:buChar char="•"/>
-              <a:defRPr sz="1800" kern="1200">
-                <a:solidFill>
-                  <a:schemeClr val="tx1"/>
-                </a:solidFill>
-                <a:latin typeface="+mn-lt"/>
-                <a:ea typeface="+mn-ea"/>
-                <a:cs typeface="+mn-cs"/>
-              </a:defRPr>
-            </a:lvl9pPr>
-          </a:lstStyle>
-          <a:p>
-            <a:pPr>
-              <a:lnSpc>
-                <a:spcPct val="100000"/>
-              </a:lnSpc>
-              <a:spcBef>
-                <a:spcPts val="400"/>
-              </a:spcBef>
-              <a:buClr>
-                <a:srgbClr val="0064C8"/>
-              </a:buClr>
-              <a:buFont typeface="Wingdings" panose="05000000000000000000" pitchFamily="2" charset="2"/>
-              <a:buChar char="§"/>
-            </a:pPr>
-            <a:r>
-              <a:rPr lang="en-US" sz="2000" spc="-1" dirty="0">
-                <a:solidFill>
-                  <a:srgbClr val="000000"/>
-                </a:solidFill>
-                <a:latin typeface="Century Gothic"/>
-              </a:rPr>
-              <a:t>Integrate with cluster for faster inference and explore larger LLMs</a:t>
-            </a:r>
-          </a:p>
-          <a:p>
-            <a:pPr>
-              <a:lnSpc>
-                <a:spcPct val="100000"/>
-              </a:lnSpc>
-              <a:spcBef>
-                <a:spcPts val="400"/>
-              </a:spcBef>
-              <a:buClr>
-                <a:srgbClr val="0064C8"/>
-              </a:buClr>
-              <a:buFont typeface="Wingdings" panose="05000000000000000000" pitchFamily="2" charset="2"/>
-              <a:buChar char="§"/>
-            </a:pPr>
-            <a:endParaRPr lang="en-US" sz="2000" spc="-1" dirty="0">
-              <a:solidFill>
-                <a:srgbClr val="000000"/>
-              </a:solidFill>
-              <a:latin typeface="Century Gothic"/>
-            </a:endParaRPr>
-          </a:p>
-          <a:p>
-            <a:pPr lvl="1">
-              <a:lnSpc>
-                <a:spcPct val="100000"/>
-              </a:lnSpc>
-              <a:spcBef>
-                <a:spcPts val="400"/>
-              </a:spcBef>
-              <a:buClr>
-                <a:srgbClr val="0064C8"/>
-              </a:buClr>
-              <a:buFont typeface="Wingdings" panose="05000000000000000000" pitchFamily="2" charset="2"/>
-              <a:buChar char="§"/>
-            </a:pPr>
-            <a:r>
-              <a:rPr lang="en-US" sz="1600" spc="-1" dirty="0">
-                <a:solidFill>
-                  <a:srgbClr val="000000"/>
-                </a:solidFill>
-                <a:latin typeface="Century Gothic"/>
-              </a:rPr>
-              <a:t>It works already on the workstations with medium-to-large LLMs</a:t>
-            </a:r>
-          </a:p>
-          <a:p>
-            <a:pPr marL="0" indent="0">
-              <a:lnSpc>
-                <a:spcPct val="100000"/>
-              </a:lnSpc>
-              <a:spcBef>
-                <a:spcPts val="400"/>
-              </a:spcBef>
-              <a:buClr>
-                <a:srgbClr val="0064C8"/>
-              </a:buClr>
-              <a:buNone/>
-            </a:pPr>
-            <a:endParaRPr lang="en-US" sz="2000" spc="-1" dirty="0">
-              <a:solidFill>
-                <a:srgbClr val="000000"/>
-              </a:solidFill>
-              <a:latin typeface="Century Gothic"/>
-            </a:endParaRPr>
-          </a:p>
-          <a:p>
-            <a:pPr>
-              <a:lnSpc>
-                <a:spcPct val="100000"/>
-              </a:lnSpc>
-              <a:spcBef>
-                <a:spcPts val="400"/>
-              </a:spcBef>
-              <a:buClr>
-                <a:srgbClr val="0064C8"/>
-              </a:buClr>
-              <a:buFont typeface="Wingdings" panose="05000000000000000000" pitchFamily="2" charset="2"/>
-              <a:buChar char="§"/>
-            </a:pPr>
-            <a:r>
-              <a:rPr lang="en-US" sz="2000" spc="-1" dirty="0">
-                <a:solidFill>
-                  <a:srgbClr val="000000"/>
-                </a:solidFill>
-                <a:latin typeface="Century Gothic"/>
-              </a:rPr>
-              <a:t>Clean up the repository and make it available </a:t>
-            </a:r>
-          </a:p>
-          <a:p>
-            <a:pPr>
-              <a:lnSpc>
-                <a:spcPct val="100000"/>
-              </a:lnSpc>
-              <a:spcBef>
-                <a:spcPts val="400"/>
-              </a:spcBef>
-              <a:buClr>
-                <a:srgbClr val="0064C8"/>
-              </a:buClr>
-              <a:buFont typeface="Wingdings" panose="05000000000000000000" pitchFamily="2" charset="2"/>
-              <a:buChar char="§"/>
-            </a:pPr>
-            <a:endParaRPr lang="en-US" sz="2000" spc="-1" dirty="0">
-              <a:solidFill>
-                <a:srgbClr val="000000"/>
-              </a:solidFill>
-              <a:latin typeface="Century Gothic"/>
-            </a:endParaRPr>
-          </a:p>
-          <a:p>
-            <a:pPr lvl="1">
-              <a:lnSpc>
-                <a:spcPct val="100000"/>
-              </a:lnSpc>
-              <a:spcBef>
-                <a:spcPts val="400"/>
-              </a:spcBef>
-              <a:buClr>
-                <a:srgbClr val="0064C8"/>
-              </a:buClr>
-              <a:buFont typeface="Wingdings" panose="05000000000000000000" pitchFamily="2" charset="2"/>
-              <a:buChar char="§"/>
-            </a:pPr>
-            <a:r>
-              <a:rPr lang="en-US" sz="1600" spc="-1" dirty="0">
-                <a:solidFill>
-                  <a:srgbClr val="000000"/>
-                </a:solidFill>
-                <a:latin typeface="Century Gothic"/>
-              </a:rPr>
-              <a:t>An “organization repository” is available for the whole lab to ease the integration of new components</a:t>
-            </a:r>
-          </a:p>
-          <a:p>
-            <a:pPr>
-              <a:lnSpc>
-                <a:spcPct val="100000"/>
-              </a:lnSpc>
-              <a:spcBef>
-                <a:spcPts val="400"/>
-              </a:spcBef>
-              <a:buClr>
-                <a:srgbClr val="0064C8"/>
-              </a:buClr>
-              <a:buFont typeface="Wingdings" panose="05000000000000000000" pitchFamily="2" charset="2"/>
-              <a:buChar char="§"/>
-            </a:pPr>
-            <a:endParaRPr lang="en-US" sz="2000" spc="-1" dirty="0">
-              <a:solidFill>
-                <a:srgbClr val="000000"/>
-              </a:solidFill>
-              <a:latin typeface="Century Gothic"/>
-            </a:endParaRPr>
-          </a:p>
-          <a:p>
-            <a:pPr>
-              <a:lnSpc>
-                <a:spcPct val="100000"/>
-              </a:lnSpc>
-              <a:spcBef>
-                <a:spcPts val="400"/>
-              </a:spcBef>
-              <a:buClr>
-                <a:srgbClr val="0064C8"/>
-              </a:buClr>
-              <a:buFont typeface="Wingdings" panose="05000000000000000000" pitchFamily="2" charset="2"/>
-              <a:buChar char="§"/>
-            </a:pPr>
-            <a:r>
-              <a:rPr lang="en-US" sz="2000" spc="-1" dirty="0">
-                <a:solidFill>
-                  <a:srgbClr val="000000"/>
-                </a:solidFill>
-                <a:latin typeface="Century Gothic"/>
-              </a:rPr>
-              <a:t>Make a guide for lab members for the implementation of AI agents</a:t>
-            </a:r>
-          </a:p>
-          <a:p>
-            <a:pPr>
-              <a:lnSpc>
-                <a:spcPct val="100000"/>
-              </a:lnSpc>
-              <a:spcBef>
-                <a:spcPts val="400"/>
-              </a:spcBef>
-              <a:buClr>
-                <a:srgbClr val="0064C8"/>
-              </a:buClr>
-              <a:buFont typeface="Wingdings" panose="05000000000000000000" pitchFamily="2" charset="2"/>
-              <a:buChar char="§"/>
-            </a:pPr>
-            <a:endParaRPr lang="en-US" sz="2000" spc="-1" dirty="0">
-              <a:solidFill>
-                <a:srgbClr val="000000"/>
-              </a:solidFill>
-              <a:latin typeface="Century Gothic"/>
-            </a:endParaRPr>
-          </a:p>
-          <a:p>
-            <a:pPr>
-              <a:lnSpc>
-                <a:spcPct val="100000"/>
-              </a:lnSpc>
-              <a:spcBef>
-                <a:spcPts val="400"/>
-              </a:spcBef>
-              <a:buClr>
-                <a:srgbClr val="0064C8"/>
-              </a:buClr>
-              <a:buFont typeface="Wingdings" panose="05000000000000000000" pitchFamily="2" charset="2"/>
-              <a:buChar char="§"/>
-            </a:pPr>
-            <a:endParaRPr lang="en-US" sz="1800" spc="-1" dirty="0">
-              <a:solidFill>
-                <a:srgbClr val="000000"/>
-              </a:solidFill>
-              <a:latin typeface="Century Gothic"/>
-            </a:endParaRPr>
-          </a:p>
-          <a:p>
-            <a:pPr marL="343080" indent="-343080">
-              <a:lnSpc>
-                <a:spcPct val="100000"/>
-              </a:lnSpc>
-              <a:spcBef>
-                <a:spcPts val="400"/>
-              </a:spcBef>
-              <a:spcAft>
-                <a:spcPts val="601"/>
-              </a:spcAft>
-              <a:buClr>
-                <a:srgbClr val="0064C8"/>
-              </a:buClr>
-              <a:buFont typeface="Wingdings 2" charset="2"/>
-              <a:buChar char=""/>
-            </a:pPr>
-            <a:endParaRPr lang="en-US" sz="2000" b="1" spc="-1" dirty="0">
-              <a:solidFill>
-                <a:srgbClr val="000000"/>
-              </a:solidFill>
-              <a:latin typeface="Century Gothic"/>
             </a:endParaRPr>
           </a:p>
         </p:txBody>
@@ -9957,7 +10351,7 @@
     </p:spTree>
     <p:extLst>
       <p:ext uri="{BB962C8B-B14F-4D97-AF65-F5344CB8AC3E}">
-        <p14:creationId xmlns:p14="http://schemas.microsoft.com/office/powerpoint/2010/main" val="3727029337"/>
+        <p14:creationId xmlns:p14="http://schemas.microsoft.com/office/powerpoint/2010/main" val="2674446027"/>
       </p:ext>
     </p:extLst>
   </p:cSld>
@@ -10038,7 +10432,7 @@
                 </a:solidFill>
                 <a:latin typeface="Century Gothic"/>
               </a:rPr>
-              <a:t>Framing</a:t>
+              <a:t>To do list</a:t>
             </a:r>
             <a:endParaRPr lang="en-US" sz="3200" b="0" strike="noStrike" spc="-1" dirty="0">
               <a:solidFill>
@@ -10321,8 +10715,29 @@
                 </a:solidFill>
                 <a:latin typeface="Century Gothic"/>
               </a:rPr>
-              <a:t>How to frame the project:</a:t>
+              <a:t>Integrate with cluster for faster inference and explore larger LLMs</a:t>
             </a:r>
+          </a:p>
+          <a:p>
+            <a:pPr>
+              <a:lnSpc>
+                <a:spcPct val="100000"/>
+              </a:lnSpc>
+              <a:spcBef>
+                <a:spcPts val="400"/>
+              </a:spcBef>
+              <a:buClr>
+                <a:srgbClr val="0064C8"/>
+              </a:buClr>
+              <a:buFont typeface="Wingdings" panose="05000000000000000000" pitchFamily="2" charset="2"/>
+              <a:buChar char="§"/>
+            </a:pPr>
+            <a:endParaRPr lang="en-US" sz="2000" spc="-1" dirty="0">
+              <a:solidFill>
+                <a:srgbClr val="000000"/>
+              </a:solidFill>
+              <a:latin typeface="Century Gothic"/>
+            </a:endParaRPr>
           </a:p>
           <a:p>
             <a:pPr lvl="1">
@@ -10345,8 +10760,73 @@
                 </a:solidFill>
                 <a:latin typeface="Century Gothic"/>
               </a:rPr>
-              <a:t>A proof-of-concept study?</a:t>
+              <a:t>It works already on the workstations with medium-to-large LLMs</a:t>
             </a:r>
+          </a:p>
+          <a:p>
+            <a:pPr marL="0" indent="0">
+              <a:lnSpc>
+                <a:spcPct val="100000"/>
+              </a:lnSpc>
+              <a:spcBef>
+                <a:spcPts val="400"/>
+              </a:spcBef>
+              <a:buClr>
+                <a:srgbClr val="0064C8"/>
+              </a:buClr>
+              <a:buNone/>
+            </a:pPr>
+            <a:endParaRPr lang="en-US" sz="2000" spc="-1" dirty="0">
+              <a:solidFill>
+                <a:srgbClr val="000000"/>
+              </a:solidFill>
+              <a:latin typeface="Century Gothic"/>
+            </a:endParaRPr>
+          </a:p>
+          <a:p>
+            <a:pPr>
+              <a:lnSpc>
+                <a:spcPct val="100000"/>
+              </a:lnSpc>
+              <a:spcBef>
+                <a:spcPts val="400"/>
+              </a:spcBef>
+              <a:buClr>
+                <a:srgbClr val="0064C8"/>
+              </a:buClr>
+              <a:buFont typeface="Wingdings" panose="05000000000000000000" pitchFamily="2" charset="2"/>
+              <a:buChar char="§"/>
+            </a:pPr>
+            <a:r>
+              <a:rPr lang="en-US" sz="2000" spc="-1" dirty="0">
+                <a:solidFill>
+                  <a:srgbClr val="000000"/>
+                </a:solidFill>
+                <a:latin typeface="Century Gothic"/>
+              </a:rPr>
+              <a:t>Clean up the repository and make it available </a:t>
+            </a:r>
+          </a:p>
+          <a:p>
+            <a:pPr>
+              <a:lnSpc>
+                <a:spcPct val="100000"/>
+              </a:lnSpc>
+              <a:spcBef>
+                <a:spcPts val="400"/>
+              </a:spcBef>
+              <a:buClr>
+                <a:srgbClr val="0064C8"/>
+              </a:buClr>
+              <a:buFont typeface="Wingdings" panose="05000000000000000000" pitchFamily="2" charset="2"/>
+              <a:buChar char="§"/>
+            </a:pPr>
+            <a:endParaRPr lang="en-US" sz="2000" spc="-1" dirty="0">
+              <a:solidFill>
+                <a:srgbClr val="000000"/>
+              </a:solidFill>
+              <a:latin typeface="Century Gothic"/>
+            </a:endParaRPr>
           </a:p>
           <a:p>
             <a:pPr lvl="1">
@@ -10369,11 +10849,32 @@
                 </a:solidFill>
                 <a:latin typeface="Century Gothic"/>
               </a:rPr>
-              <a:t>An explainability platform for XAI applied to molecular design?</a:t>
+              <a:t>An “organization repository” is available for the whole lab to ease the integration of new components</a:t>
             </a:r>
           </a:p>
           <a:p>
-            <a:pPr lvl="1">
+            <a:pPr>
+              <a:lnSpc>
+                <a:spcPct val="100000"/>
+              </a:lnSpc>
+              <a:spcBef>
+                <a:spcPts val="400"/>
+              </a:spcBef>
+              <a:buClr>
+                <a:srgbClr val="0064C8"/>
+              </a:buClr>
+              <a:buFont typeface="Wingdings" panose="05000000000000000000" pitchFamily="2" charset="2"/>
+              <a:buChar char="§"/>
+            </a:pPr>
+            <a:endParaRPr lang="en-US" sz="2000" spc="-1" dirty="0">
+              <a:solidFill>
+                <a:srgbClr val="000000"/>
+              </a:solidFill>
+              <a:latin typeface="Century Gothic"/>
+            </a:endParaRPr>
+          </a:p>
+          <a:p>
+            <a:pPr>
               <a:lnSpc>
                 <a:spcPct val="100000"/>
               </a:lnSpc>
@@ -10387,116 +10888,14 @@
               <a:buChar char="§"/>
             </a:pPr>
             <a:r>
-              <a:rPr lang="en-US" sz="1600" spc="-1" dirty="0">
+              <a:rPr lang="en-US" sz="2000" spc="-1" dirty="0">
                 <a:solidFill>
                   <a:srgbClr val="000000"/>
                 </a:solidFill>
                 <a:latin typeface="Century Gothic"/>
               </a:rPr>
-              <a:t>An explainability platform for XAI specific to molecular selectivity?</a:t>
+              <a:t>Make a guide for lab members for the implementation of AI agents</a:t>
             </a:r>
-          </a:p>
-          <a:p>
-            <a:pPr lvl="1">
-              <a:lnSpc>
-                <a:spcPct val="100000"/>
-              </a:lnSpc>
-              <a:spcBef>
-                <a:spcPts val="400"/>
-              </a:spcBef>
-              <a:buClr>
-                <a:srgbClr val="0064C8"/>
-              </a:buClr>
-              <a:buFont typeface="Wingdings" panose="05000000000000000000" pitchFamily="2" charset="2"/>
-              <a:buChar char="§"/>
-            </a:pPr>
-            <a:r>
-              <a:rPr lang="en-US" sz="1600" spc="-1" dirty="0">
-                <a:solidFill>
-                  <a:srgbClr val="000000"/>
-                </a:solidFill>
-                <a:latin typeface="Century Gothic"/>
-              </a:rPr>
-              <a:t>A modular </a:t>
-            </a:r>
-            <a:r>
-              <a:rPr lang="en-US" sz="1600" spc="-1" dirty="0" err="1">
-                <a:solidFill>
-                  <a:srgbClr val="000000"/>
-                </a:solidFill>
-                <a:latin typeface="Century Gothic"/>
-              </a:rPr>
-              <a:t>explainability</a:t>
-            </a:r>
-            <a:r>
-              <a:rPr lang="en-US" sz="1600" spc="-1" dirty="0">
-                <a:solidFill>
-                  <a:srgbClr val="000000"/>
-                </a:solidFill>
-                <a:latin typeface="Century Gothic"/>
-              </a:rPr>
-              <a:t>-enhanced platform for </a:t>
-            </a:r>
-            <a:r>
-              <a:rPr lang="en-US" sz="1600" spc="-1" dirty="0" err="1">
-                <a:solidFill>
-                  <a:srgbClr val="000000"/>
-                </a:solidFill>
-                <a:latin typeface="Century Gothic"/>
-              </a:rPr>
-              <a:t>chemoinformatics</a:t>
-            </a:r>
-            <a:r>
-              <a:rPr lang="en-US" sz="1600" spc="-1" dirty="0">
-                <a:solidFill>
-                  <a:srgbClr val="000000"/>
-                </a:solidFill>
-                <a:latin typeface="Century Gothic"/>
-              </a:rPr>
-              <a:t>? </a:t>
-            </a:r>
-          </a:p>
-          <a:p>
-            <a:pPr lvl="1">
-              <a:lnSpc>
-                <a:spcPct val="100000"/>
-              </a:lnSpc>
-              <a:spcBef>
-                <a:spcPts val="400"/>
-              </a:spcBef>
-              <a:buClr>
-                <a:srgbClr val="0064C8"/>
-              </a:buClr>
-              <a:buFont typeface="Wingdings" panose="05000000000000000000" pitchFamily="2" charset="2"/>
-              <a:buChar char="§"/>
-            </a:pPr>
-            <a:endParaRPr lang="en-US" sz="1600" spc="-1" dirty="0">
-              <a:solidFill>
-                <a:srgbClr val="000000"/>
-              </a:solidFill>
-              <a:latin typeface="Century Gothic"/>
-            </a:endParaRPr>
-          </a:p>
-          <a:p>
-            <a:pPr lvl="1">
-              <a:lnSpc>
-                <a:spcPct val="100000"/>
-              </a:lnSpc>
-              <a:spcBef>
-                <a:spcPts val="400"/>
-              </a:spcBef>
-              <a:buClr>
-                <a:srgbClr val="0064C8"/>
-              </a:buClr>
-              <a:buFont typeface="Wingdings" panose="05000000000000000000" pitchFamily="2" charset="2"/>
-              <a:buChar char="§"/>
-            </a:pPr>
-            <a:endParaRPr lang="en-US" sz="1600" spc="-1" dirty="0">
-              <a:solidFill>
-                <a:srgbClr val="000000"/>
-              </a:solidFill>
-              <a:latin typeface="Century Gothic"/>
-            </a:endParaRPr>
           </a:p>
           <a:p>
             <a:pPr>
@@ -10569,7 +10968,1186 @@
     </p:spTree>
     <p:extLst>
       <p:ext uri="{BB962C8B-B14F-4D97-AF65-F5344CB8AC3E}">
+        <p14:creationId xmlns:p14="http://schemas.microsoft.com/office/powerpoint/2010/main" val="3727029337"/>
+      </p:ext>
+    </p:extLst>
+  </p:cSld>
+  <p:clrMapOvr>
+    <a:masterClrMapping/>
+  </p:clrMapOvr>
+</p:sld>
+</file>
+
+<file path=ppt/slides/slide12.xml><?xml version="1.0" encoding="utf-8"?>
+<p:sld xmlns:a="http://schemas.openxmlformats.org/drawingml/2006/main" xmlns:r="http://schemas.openxmlformats.org/officeDocument/2006/relationships" xmlns:p="http://schemas.openxmlformats.org/presentationml/2006/main">
+  <p:cSld>
+    <p:spTree>
+      <p:nvGrpSpPr>
+        <p:cNvPr id="1" name="">
+          <a:extLst>
+            <a:ext uri="{FF2B5EF4-FFF2-40B4-BE49-F238E27FC236}">
+              <a16:creationId xmlns:a16="http://schemas.microsoft.com/office/drawing/2014/main" id="{A6515F23-0912-A838-23CE-B8F00573A2DA}"/>
+            </a:ext>
+          </a:extLst>
+        </p:cNvPr>
+        <p:cNvGrpSpPr/>
+        <p:nvPr/>
+      </p:nvGrpSpPr>
+      <p:grpSpPr>
+        <a:xfrm>
+          <a:off x="0" y="0"/>
+          <a:ext cx="0" cy="0"/>
+          <a:chOff x="0" y="0"/>
+          <a:chExt cx="0" cy="0"/>
+        </a:xfrm>
+      </p:grpSpPr>
+      <p:sp>
+        <p:nvSpPr>
+          <p:cNvPr id="163" name="PlaceHolder 1">
+            <a:extLst>
+              <a:ext uri="{FF2B5EF4-FFF2-40B4-BE49-F238E27FC236}">
+                <a16:creationId xmlns:a16="http://schemas.microsoft.com/office/drawing/2014/main" id="{57944F4B-F502-E7CC-8790-8737702BC6AC}"/>
+              </a:ext>
+            </a:extLst>
+          </p:cNvPr>
+          <p:cNvSpPr>
+            <a:spLocks noGrp="1"/>
+          </p:cNvSpPr>
+          <p:nvPr>
+            <p:ph type="title"/>
+          </p:nvPr>
+        </p:nvSpPr>
+        <p:spPr>
+          <a:xfrm>
+            <a:off x="380880" y="228600"/>
+            <a:ext cx="8380080" cy="837720"/>
+          </a:xfrm>
+          <a:prstGeom prst="rect">
+            <a:avLst/>
+          </a:prstGeom>
+          <a:noFill/>
+          <a:ln w="0">
+            <a:noFill/>
+          </a:ln>
+        </p:spPr>
+        <p:txBody>
+          <a:bodyPr numCol="1" spcCol="0" anchor="ctr">
+            <a:noAutofit/>
+          </a:bodyPr>
+          <a:lstStyle/>
+          <a:p>
+            <a:pPr>
+              <a:lnSpc>
+                <a:spcPct val="100000"/>
+              </a:lnSpc>
+              <a:buNone/>
+            </a:pPr>
+            <a:r>
+              <a:rPr lang="en-US" sz="3200" b="0" strike="noStrike" spc="-1" dirty="0">
+                <a:solidFill>
+                  <a:srgbClr val="0064C8"/>
+                </a:solidFill>
+                <a:latin typeface="Century Gothic"/>
+              </a:rPr>
+              <a:t>Framing</a:t>
+            </a:r>
+            <a:endParaRPr lang="en-US" sz="3200" b="0" strike="noStrike" spc="-1" dirty="0">
+              <a:solidFill>
+                <a:srgbClr val="000000"/>
+              </a:solidFill>
+              <a:latin typeface="Century Gothic"/>
+            </a:endParaRPr>
+          </a:p>
+        </p:txBody>
+      </p:sp>
+      <p:sp>
+        <p:nvSpPr>
+          <p:cNvPr id="165" name="PlaceHolder 3">
+            <a:extLst>
+              <a:ext uri="{FF2B5EF4-FFF2-40B4-BE49-F238E27FC236}">
+                <a16:creationId xmlns:a16="http://schemas.microsoft.com/office/drawing/2014/main" id="{2EFBEA53-7B78-D9A1-93EF-9608A3193D27}"/>
+              </a:ext>
+            </a:extLst>
+          </p:cNvPr>
+          <p:cNvSpPr>
+            <a:spLocks noGrp="1"/>
+          </p:cNvSpPr>
+          <p:nvPr>
+            <p:ph type="sldNum"/>
+          </p:nvPr>
+        </p:nvSpPr>
+        <p:spPr>
+          <a:xfrm>
+            <a:off x="8376840" y="5692680"/>
+            <a:ext cx="384120" cy="364680"/>
+          </a:xfrm>
+          <a:prstGeom prst="rect">
+            <a:avLst/>
+          </a:prstGeom>
+          <a:noFill/>
+          <a:ln w="0">
+            <a:noFill/>
+          </a:ln>
+        </p:spPr>
+        <p:txBody>
+          <a:bodyPr anchor="ctr">
+            <a:noAutofit/>
+          </a:bodyPr>
+          <a:lstStyle/>
+          <a:p>
+            <a:pPr algn="r">
+              <a:lnSpc>
+                <a:spcPct val="100000"/>
+              </a:lnSpc>
+              <a:buNone/>
+            </a:pPr>
+            <a:fld id="{8BD7C522-1E12-40C3-B25E-5F0462E20B22}" type="slidenum">
+              <a:rPr lang="en-US" sz="1200" b="0" strike="noStrike" spc="-1">
+                <a:solidFill>
+                  <a:srgbClr val="8B8B8B"/>
+                </a:solidFill>
+                <a:latin typeface="Century Gothic"/>
+              </a:rPr>
+              <a:t>12</a:t>
+            </a:fld>
+            <a:endParaRPr lang="en-GB" sz="1200" b="0" strike="noStrike" spc="-1" dirty="0">
+              <a:latin typeface="Times New Roman"/>
+            </a:endParaRPr>
+          </a:p>
+        </p:txBody>
+      </p:sp>
+      <p:sp>
+        <p:nvSpPr>
+          <p:cNvPr id="7" name="PlaceHolder 2">
+            <a:extLst>
+              <a:ext uri="{FF2B5EF4-FFF2-40B4-BE49-F238E27FC236}">
+                <a16:creationId xmlns:a16="http://schemas.microsoft.com/office/drawing/2014/main" id="{66DE14D4-64D4-6D1F-DD92-BC16D674C58B}"/>
+              </a:ext>
+            </a:extLst>
+          </p:cNvPr>
+          <p:cNvSpPr txBox="1">
+            <a:spLocks/>
+          </p:cNvSpPr>
+          <p:nvPr/>
+        </p:nvSpPr>
+        <p:spPr>
+          <a:xfrm>
+            <a:off x="380880" y="1371598"/>
+            <a:ext cx="8109070" cy="4559301"/>
+          </a:xfrm>
+          <a:prstGeom prst="rect">
+            <a:avLst/>
+          </a:prstGeom>
+          <a:noFill/>
+          <a:ln w="0">
+            <a:noFill/>
+          </a:ln>
+        </p:spPr>
+        <p:txBody>
+          <a:bodyPr numCol="1" spcCol="0" anchor="t">
+            <a:noAutofit/>
+          </a:bodyPr>
+          <a:lstStyle>
+            <a:lvl1pPr marL="228600" indent="-228600" algn="l" defTabSz="914400" rtl="0" eaLnBrk="1" latinLnBrk="0" hangingPunct="1">
+              <a:lnSpc>
+                <a:spcPct val="90000"/>
+              </a:lnSpc>
+              <a:spcBef>
+                <a:spcPts val="1000"/>
+              </a:spcBef>
+              <a:buFont typeface="Arial" panose="020B0604020202020204" pitchFamily="34" charset="0"/>
+              <a:buChar char="•"/>
+              <a:defRPr sz="2800" kern="1200">
+                <a:solidFill>
+                  <a:schemeClr val="tx1"/>
+                </a:solidFill>
+                <a:latin typeface="+mn-lt"/>
+                <a:ea typeface="+mn-ea"/>
+                <a:cs typeface="+mn-cs"/>
+              </a:defRPr>
+            </a:lvl1pPr>
+            <a:lvl2pPr marL="685800" indent="-228600" algn="l" defTabSz="914400" rtl="0" eaLnBrk="1" latinLnBrk="0" hangingPunct="1">
+              <a:lnSpc>
+                <a:spcPct val="90000"/>
+              </a:lnSpc>
+              <a:spcBef>
+                <a:spcPts val="500"/>
+              </a:spcBef>
+              <a:buFont typeface="Arial" panose="020B0604020202020204" pitchFamily="34" charset="0"/>
+              <a:buChar char="•"/>
+              <a:defRPr sz="2400" kern="1200">
+                <a:solidFill>
+                  <a:schemeClr val="tx1"/>
+                </a:solidFill>
+                <a:latin typeface="+mn-lt"/>
+                <a:ea typeface="+mn-ea"/>
+                <a:cs typeface="+mn-cs"/>
+              </a:defRPr>
+            </a:lvl2pPr>
+            <a:lvl3pPr marL="1143000" indent="-228600" algn="l" defTabSz="914400" rtl="0" eaLnBrk="1" latinLnBrk="0" hangingPunct="1">
+              <a:lnSpc>
+                <a:spcPct val="90000"/>
+              </a:lnSpc>
+              <a:spcBef>
+                <a:spcPts val="500"/>
+              </a:spcBef>
+              <a:buFont typeface="Arial" panose="020B0604020202020204" pitchFamily="34" charset="0"/>
+              <a:buChar char="•"/>
+              <a:defRPr sz="2000" kern="1200">
+                <a:solidFill>
+                  <a:schemeClr val="tx1"/>
+                </a:solidFill>
+                <a:latin typeface="+mn-lt"/>
+                <a:ea typeface="+mn-ea"/>
+                <a:cs typeface="+mn-cs"/>
+              </a:defRPr>
+            </a:lvl3pPr>
+            <a:lvl4pPr marL="1600200" indent="-228600" algn="l" defTabSz="914400" rtl="0" eaLnBrk="1" latinLnBrk="0" hangingPunct="1">
+              <a:lnSpc>
+                <a:spcPct val="90000"/>
+              </a:lnSpc>
+              <a:spcBef>
+                <a:spcPts val="500"/>
+              </a:spcBef>
+              <a:buFont typeface="Arial" panose="020B0604020202020204" pitchFamily="34" charset="0"/>
+              <a:buChar char="•"/>
+              <a:defRPr sz="1800" kern="1200">
+                <a:solidFill>
+                  <a:schemeClr val="tx1"/>
+                </a:solidFill>
+                <a:latin typeface="+mn-lt"/>
+                <a:ea typeface="+mn-ea"/>
+                <a:cs typeface="+mn-cs"/>
+              </a:defRPr>
+            </a:lvl4pPr>
+            <a:lvl5pPr marL="2057400" indent="-228600" algn="l" defTabSz="914400" rtl="0" eaLnBrk="1" latinLnBrk="0" hangingPunct="1">
+              <a:lnSpc>
+                <a:spcPct val="90000"/>
+              </a:lnSpc>
+              <a:spcBef>
+                <a:spcPts val="500"/>
+              </a:spcBef>
+              <a:buFont typeface="Arial" panose="020B0604020202020204" pitchFamily="34" charset="0"/>
+              <a:buChar char="•"/>
+              <a:defRPr sz="1800" kern="1200">
+                <a:solidFill>
+                  <a:schemeClr val="tx1"/>
+                </a:solidFill>
+                <a:latin typeface="+mn-lt"/>
+                <a:ea typeface="+mn-ea"/>
+                <a:cs typeface="+mn-cs"/>
+              </a:defRPr>
+            </a:lvl5pPr>
+            <a:lvl6pPr marL="2514600" indent="-228600" algn="l" defTabSz="914400" rtl="0" eaLnBrk="1" latinLnBrk="0" hangingPunct="1">
+              <a:lnSpc>
+                <a:spcPct val="90000"/>
+              </a:lnSpc>
+              <a:spcBef>
+                <a:spcPts val="500"/>
+              </a:spcBef>
+              <a:buFont typeface="Arial" panose="020B0604020202020204" pitchFamily="34" charset="0"/>
+              <a:buChar char="•"/>
+              <a:defRPr sz="1800" kern="1200">
+                <a:solidFill>
+                  <a:schemeClr val="tx1"/>
+                </a:solidFill>
+                <a:latin typeface="+mn-lt"/>
+                <a:ea typeface="+mn-ea"/>
+                <a:cs typeface="+mn-cs"/>
+              </a:defRPr>
+            </a:lvl6pPr>
+            <a:lvl7pPr marL="2971800" indent="-228600" algn="l" defTabSz="914400" rtl="0" eaLnBrk="1" latinLnBrk="0" hangingPunct="1">
+              <a:lnSpc>
+                <a:spcPct val="90000"/>
+              </a:lnSpc>
+              <a:spcBef>
+                <a:spcPts val="500"/>
+              </a:spcBef>
+              <a:buFont typeface="Arial" panose="020B0604020202020204" pitchFamily="34" charset="0"/>
+              <a:buChar char="•"/>
+              <a:defRPr sz="1800" kern="1200">
+                <a:solidFill>
+                  <a:schemeClr val="tx1"/>
+                </a:solidFill>
+                <a:latin typeface="+mn-lt"/>
+                <a:ea typeface="+mn-ea"/>
+                <a:cs typeface="+mn-cs"/>
+              </a:defRPr>
+            </a:lvl7pPr>
+            <a:lvl8pPr marL="3429000" indent="-228600" algn="l" defTabSz="914400" rtl="0" eaLnBrk="1" latinLnBrk="0" hangingPunct="1">
+              <a:lnSpc>
+                <a:spcPct val="90000"/>
+              </a:lnSpc>
+              <a:spcBef>
+                <a:spcPts val="500"/>
+              </a:spcBef>
+              <a:buFont typeface="Arial" panose="020B0604020202020204" pitchFamily="34" charset="0"/>
+              <a:buChar char="•"/>
+              <a:defRPr sz="1800" kern="1200">
+                <a:solidFill>
+                  <a:schemeClr val="tx1"/>
+                </a:solidFill>
+                <a:latin typeface="+mn-lt"/>
+                <a:ea typeface="+mn-ea"/>
+                <a:cs typeface="+mn-cs"/>
+              </a:defRPr>
+            </a:lvl8pPr>
+            <a:lvl9pPr marL="3886200" indent="-228600" algn="l" defTabSz="914400" rtl="0" eaLnBrk="1" latinLnBrk="0" hangingPunct="1">
+              <a:lnSpc>
+                <a:spcPct val="90000"/>
+              </a:lnSpc>
+              <a:spcBef>
+                <a:spcPts val="500"/>
+              </a:spcBef>
+              <a:buFont typeface="Arial" panose="020B0604020202020204" pitchFamily="34" charset="0"/>
+              <a:buChar char="•"/>
+              <a:defRPr sz="1800" kern="1200">
+                <a:solidFill>
+                  <a:schemeClr val="tx1"/>
+                </a:solidFill>
+                <a:latin typeface="+mn-lt"/>
+                <a:ea typeface="+mn-ea"/>
+                <a:cs typeface="+mn-cs"/>
+              </a:defRPr>
+            </a:lvl9pPr>
+          </a:lstStyle>
+          <a:p>
+            <a:pPr>
+              <a:lnSpc>
+                <a:spcPct val="100000"/>
+              </a:lnSpc>
+              <a:spcBef>
+                <a:spcPts val="400"/>
+              </a:spcBef>
+              <a:buClr>
+                <a:srgbClr val="0064C8"/>
+              </a:buClr>
+              <a:buFont typeface="Wingdings" panose="05000000000000000000" pitchFamily="2" charset="2"/>
+              <a:buChar char="§"/>
+            </a:pPr>
+            <a:r>
+              <a:rPr lang="en-US" sz="2000" spc="-1" dirty="0">
+                <a:solidFill>
+                  <a:srgbClr val="000000"/>
+                </a:solidFill>
+                <a:latin typeface="Century Gothic"/>
+              </a:rPr>
+              <a:t>How to frame the project:</a:t>
+            </a:r>
+          </a:p>
+          <a:p>
+            <a:pPr lvl="1">
+              <a:lnSpc>
+                <a:spcPct val="100000"/>
+              </a:lnSpc>
+              <a:spcBef>
+                <a:spcPts val="400"/>
+              </a:spcBef>
+              <a:buClr>
+                <a:srgbClr val="0064C8"/>
+              </a:buClr>
+              <a:buFont typeface="Wingdings" panose="05000000000000000000" pitchFamily="2" charset="2"/>
+              <a:buChar char="§"/>
+            </a:pPr>
+            <a:r>
+              <a:rPr lang="en-US" sz="1600" spc="-1" dirty="0">
+                <a:solidFill>
+                  <a:srgbClr val="000000"/>
+                </a:solidFill>
+                <a:latin typeface="Century Gothic"/>
+              </a:rPr>
+              <a:t>A proof-of-concept study?</a:t>
+            </a:r>
+          </a:p>
+          <a:p>
+            <a:pPr lvl="1">
+              <a:lnSpc>
+                <a:spcPct val="100000"/>
+              </a:lnSpc>
+              <a:spcBef>
+                <a:spcPts val="400"/>
+              </a:spcBef>
+              <a:buClr>
+                <a:srgbClr val="0064C8"/>
+              </a:buClr>
+              <a:buFont typeface="Wingdings" panose="05000000000000000000" pitchFamily="2" charset="2"/>
+              <a:buChar char="§"/>
+            </a:pPr>
+            <a:r>
+              <a:rPr lang="en-US" sz="1600" spc="-1" dirty="0">
+                <a:solidFill>
+                  <a:srgbClr val="000000"/>
+                </a:solidFill>
+                <a:latin typeface="Century Gothic"/>
+              </a:rPr>
+              <a:t>An explainability platform for XAI applied to molecular design?</a:t>
+            </a:r>
+          </a:p>
+          <a:p>
+            <a:pPr lvl="1">
+              <a:lnSpc>
+                <a:spcPct val="100000"/>
+              </a:lnSpc>
+              <a:spcBef>
+                <a:spcPts val="400"/>
+              </a:spcBef>
+              <a:buClr>
+                <a:srgbClr val="0064C8"/>
+              </a:buClr>
+              <a:buFont typeface="Wingdings" panose="05000000000000000000" pitchFamily="2" charset="2"/>
+              <a:buChar char="§"/>
+            </a:pPr>
+            <a:r>
+              <a:rPr lang="en-US" sz="1600" spc="-1" dirty="0">
+                <a:solidFill>
+                  <a:srgbClr val="000000"/>
+                </a:solidFill>
+                <a:latin typeface="Century Gothic"/>
+              </a:rPr>
+              <a:t>An explainability platform for XAI specific to molecular selectivity?</a:t>
+            </a:r>
+          </a:p>
+          <a:p>
+            <a:pPr lvl="1">
+              <a:lnSpc>
+                <a:spcPct val="100000"/>
+              </a:lnSpc>
+              <a:spcBef>
+                <a:spcPts val="400"/>
+              </a:spcBef>
+              <a:buClr>
+                <a:srgbClr val="0064C8"/>
+              </a:buClr>
+              <a:buFont typeface="Wingdings" panose="05000000000000000000" pitchFamily="2" charset="2"/>
+              <a:buChar char="§"/>
+            </a:pPr>
+            <a:r>
+              <a:rPr lang="en-US" sz="1600" spc="-1" dirty="0">
+                <a:solidFill>
+                  <a:srgbClr val="000000"/>
+                </a:solidFill>
+                <a:latin typeface="Century Gothic"/>
+              </a:rPr>
+              <a:t>A modular </a:t>
+            </a:r>
+            <a:r>
+              <a:rPr lang="en-US" sz="1600" spc="-1" dirty="0" err="1">
+                <a:solidFill>
+                  <a:srgbClr val="000000"/>
+                </a:solidFill>
+                <a:latin typeface="Century Gothic"/>
+              </a:rPr>
+              <a:t>explainability</a:t>
+            </a:r>
+            <a:r>
+              <a:rPr lang="en-US" sz="1600" spc="-1" dirty="0">
+                <a:solidFill>
+                  <a:srgbClr val="000000"/>
+                </a:solidFill>
+                <a:latin typeface="Century Gothic"/>
+              </a:rPr>
+              <a:t>-enhanced platform for </a:t>
+            </a:r>
+            <a:r>
+              <a:rPr lang="en-US" sz="1600" spc="-1" dirty="0" err="1">
+                <a:solidFill>
+                  <a:srgbClr val="000000"/>
+                </a:solidFill>
+                <a:latin typeface="Century Gothic"/>
+              </a:rPr>
+              <a:t>chemoinformatics</a:t>
+            </a:r>
+            <a:r>
+              <a:rPr lang="en-US" sz="1600" spc="-1" dirty="0">
+                <a:solidFill>
+                  <a:srgbClr val="000000"/>
+                </a:solidFill>
+                <a:latin typeface="Century Gothic"/>
+              </a:rPr>
+              <a:t>? </a:t>
+            </a:r>
+          </a:p>
+          <a:p>
+            <a:pPr lvl="1">
+              <a:lnSpc>
+                <a:spcPct val="100000"/>
+              </a:lnSpc>
+              <a:spcBef>
+                <a:spcPts val="400"/>
+              </a:spcBef>
+              <a:buClr>
+                <a:srgbClr val="0064C8"/>
+              </a:buClr>
+              <a:buFont typeface="Wingdings" panose="05000000000000000000" pitchFamily="2" charset="2"/>
+              <a:buChar char="§"/>
+            </a:pPr>
+            <a:endParaRPr lang="en-US" sz="1600" spc="-1" dirty="0">
+              <a:solidFill>
+                <a:srgbClr val="000000"/>
+              </a:solidFill>
+              <a:latin typeface="Century Gothic"/>
+            </a:endParaRPr>
+          </a:p>
+          <a:p>
+            <a:pPr lvl="1">
+              <a:lnSpc>
+                <a:spcPct val="100000"/>
+              </a:lnSpc>
+              <a:spcBef>
+                <a:spcPts val="400"/>
+              </a:spcBef>
+              <a:buClr>
+                <a:srgbClr val="0064C8"/>
+              </a:buClr>
+              <a:buFont typeface="Wingdings" panose="05000000000000000000" pitchFamily="2" charset="2"/>
+              <a:buChar char="§"/>
+            </a:pPr>
+            <a:endParaRPr lang="en-US" sz="1600" spc="-1" dirty="0">
+              <a:solidFill>
+                <a:srgbClr val="000000"/>
+              </a:solidFill>
+              <a:latin typeface="Century Gothic"/>
+            </a:endParaRPr>
+          </a:p>
+          <a:p>
+            <a:pPr>
+              <a:lnSpc>
+                <a:spcPct val="100000"/>
+              </a:lnSpc>
+              <a:spcBef>
+                <a:spcPts val="400"/>
+              </a:spcBef>
+              <a:buClr>
+                <a:srgbClr val="0064C8"/>
+              </a:buClr>
+              <a:buFont typeface="Wingdings" panose="05000000000000000000" pitchFamily="2" charset="2"/>
+              <a:buChar char="§"/>
+            </a:pPr>
+            <a:endParaRPr lang="en-US" sz="2000" spc="-1" dirty="0">
+              <a:solidFill>
+                <a:srgbClr val="000000"/>
+              </a:solidFill>
+              <a:latin typeface="Century Gothic"/>
+            </a:endParaRPr>
+          </a:p>
+          <a:p>
+            <a:pPr>
+              <a:lnSpc>
+                <a:spcPct val="100000"/>
+              </a:lnSpc>
+              <a:spcBef>
+                <a:spcPts val="400"/>
+              </a:spcBef>
+              <a:buClr>
+                <a:srgbClr val="0064C8"/>
+              </a:buClr>
+              <a:buFont typeface="Wingdings" panose="05000000000000000000" pitchFamily="2" charset="2"/>
+              <a:buChar char="§"/>
+            </a:pPr>
+            <a:endParaRPr lang="en-US" sz="1800" spc="-1" dirty="0">
+              <a:solidFill>
+                <a:srgbClr val="000000"/>
+              </a:solidFill>
+              <a:latin typeface="Century Gothic"/>
+            </a:endParaRPr>
+          </a:p>
+          <a:p>
+            <a:pPr marL="343080" indent="-343080">
+              <a:lnSpc>
+                <a:spcPct val="100000"/>
+              </a:lnSpc>
+              <a:spcBef>
+                <a:spcPts val="400"/>
+              </a:spcBef>
+              <a:spcAft>
+                <a:spcPts val="601"/>
+              </a:spcAft>
+              <a:buClr>
+                <a:srgbClr val="0064C8"/>
+              </a:buClr>
+              <a:buFont typeface="Wingdings 2" charset="2"/>
+              <a:buChar char=""/>
+            </a:pPr>
+            <a:endParaRPr lang="en-US" sz="2000" b="1" spc="-1" dirty="0">
+              <a:solidFill>
+                <a:srgbClr val="000000"/>
+              </a:solidFill>
+              <a:latin typeface="Century Gothic"/>
+            </a:endParaRPr>
+          </a:p>
+        </p:txBody>
+      </p:sp>
+    </p:spTree>
+    <p:extLst>
+      <p:ext uri="{BB962C8B-B14F-4D97-AF65-F5344CB8AC3E}">
         <p14:creationId xmlns:p14="http://schemas.microsoft.com/office/powerpoint/2010/main" val="1594879052"/>
+      </p:ext>
+    </p:extLst>
+  </p:cSld>
+  <p:clrMapOvr>
+    <a:masterClrMapping/>
+  </p:clrMapOvr>
+</p:sld>
+</file>
+
+<file path=ppt/slides/slide13.xml><?xml version="1.0" encoding="utf-8"?>
+<p:sld xmlns:a="http://schemas.openxmlformats.org/drawingml/2006/main" xmlns:r="http://schemas.openxmlformats.org/officeDocument/2006/relationships" xmlns:p="http://schemas.openxmlformats.org/presentationml/2006/main" show="0">
+  <p:cSld>
+    <p:spTree>
+      <p:nvGrpSpPr>
+        <p:cNvPr id="1" name="">
+          <a:extLst>
+            <a:ext uri="{FF2B5EF4-FFF2-40B4-BE49-F238E27FC236}">
+              <a16:creationId xmlns:a16="http://schemas.microsoft.com/office/drawing/2014/main" id="{A6515F23-0912-A838-23CE-B8F00573A2DA}"/>
+            </a:ext>
+          </a:extLst>
+        </p:cNvPr>
+        <p:cNvGrpSpPr/>
+        <p:nvPr/>
+      </p:nvGrpSpPr>
+      <p:grpSpPr>
+        <a:xfrm>
+          <a:off x="0" y="0"/>
+          <a:ext cx="0" cy="0"/>
+          <a:chOff x="0" y="0"/>
+          <a:chExt cx="0" cy="0"/>
+        </a:xfrm>
+      </p:grpSpPr>
+      <p:sp>
+        <p:nvSpPr>
+          <p:cNvPr id="163" name="PlaceHolder 1">
+            <a:extLst>
+              <a:ext uri="{FF2B5EF4-FFF2-40B4-BE49-F238E27FC236}">
+                <a16:creationId xmlns:a16="http://schemas.microsoft.com/office/drawing/2014/main" id="{57944F4B-F502-E7CC-8790-8737702BC6AC}"/>
+              </a:ext>
+            </a:extLst>
+          </p:cNvPr>
+          <p:cNvSpPr>
+            <a:spLocks noGrp="1"/>
+          </p:cNvSpPr>
+          <p:nvPr>
+            <p:ph type="title"/>
+          </p:nvPr>
+        </p:nvSpPr>
+        <p:spPr>
+          <a:xfrm>
+            <a:off x="380880" y="228600"/>
+            <a:ext cx="8380080" cy="837720"/>
+          </a:xfrm>
+          <a:prstGeom prst="rect">
+            <a:avLst/>
+          </a:prstGeom>
+          <a:noFill/>
+          <a:ln w="0">
+            <a:noFill/>
+          </a:ln>
+        </p:spPr>
+        <p:txBody>
+          <a:bodyPr numCol="1" spcCol="0" anchor="ctr">
+            <a:noAutofit/>
+          </a:bodyPr>
+          <a:lstStyle/>
+          <a:p>
+            <a:pPr>
+              <a:lnSpc>
+                <a:spcPct val="100000"/>
+              </a:lnSpc>
+              <a:buNone/>
+            </a:pPr>
+            <a:r>
+              <a:rPr lang="en-US" sz="3200" b="0" strike="noStrike" spc="-1" dirty="0">
+                <a:solidFill>
+                  <a:srgbClr val="0064C8"/>
+                </a:solidFill>
+                <a:latin typeface="Century Gothic"/>
+              </a:rPr>
+              <a:t>Exemplary answer output</a:t>
+            </a:r>
+            <a:endParaRPr lang="en-US" sz="3200" b="0" strike="noStrike" spc="-1" dirty="0">
+              <a:solidFill>
+                <a:srgbClr val="000000"/>
+              </a:solidFill>
+              <a:latin typeface="Century Gothic"/>
+            </a:endParaRPr>
+          </a:p>
+        </p:txBody>
+      </p:sp>
+      <p:sp>
+        <p:nvSpPr>
+          <p:cNvPr id="165" name="PlaceHolder 3">
+            <a:extLst>
+              <a:ext uri="{FF2B5EF4-FFF2-40B4-BE49-F238E27FC236}">
+                <a16:creationId xmlns:a16="http://schemas.microsoft.com/office/drawing/2014/main" id="{2EFBEA53-7B78-D9A1-93EF-9608A3193D27}"/>
+              </a:ext>
+            </a:extLst>
+          </p:cNvPr>
+          <p:cNvSpPr>
+            <a:spLocks noGrp="1"/>
+          </p:cNvSpPr>
+          <p:nvPr>
+            <p:ph type="sldNum"/>
+          </p:nvPr>
+        </p:nvSpPr>
+        <p:spPr>
+          <a:xfrm>
+            <a:off x="8376840" y="5692680"/>
+            <a:ext cx="384120" cy="364680"/>
+          </a:xfrm>
+          <a:prstGeom prst="rect">
+            <a:avLst/>
+          </a:prstGeom>
+          <a:noFill/>
+          <a:ln w="0">
+            <a:noFill/>
+          </a:ln>
+        </p:spPr>
+        <p:txBody>
+          <a:bodyPr anchor="ctr">
+            <a:noAutofit/>
+          </a:bodyPr>
+          <a:lstStyle/>
+          <a:p>
+            <a:pPr algn="r">
+              <a:lnSpc>
+                <a:spcPct val="100000"/>
+              </a:lnSpc>
+              <a:buNone/>
+            </a:pPr>
+            <a:fld id="{8BD7C522-1E12-40C3-B25E-5F0462E20B22}" type="slidenum">
+              <a:rPr lang="en-US" sz="1200" b="0" strike="noStrike" spc="-1">
+                <a:solidFill>
+                  <a:srgbClr val="8B8B8B"/>
+                </a:solidFill>
+                <a:latin typeface="Century Gothic"/>
+              </a:rPr>
+              <a:t>13</a:t>
+            </a:fld>
+            <a:endParaRPr lang="en-GB" sz="1200" b="0" strike="noStrike" spc="-1" dirty="0">
+              <a:latin typeface="Times New Roman"/>
+            </a:endParaRPr>
+          </a:p>
+        </p:txBody>
+      </p:sp>
+      <p:sp>
+        <p:nvSpPr>
+          <p:cNvPr id="2" name="PlaceHolder 2">
+            <a:extLst>
+              <a:ext uri="{FF2B5EF4-FFF2-40B4-BE49-F238E27FC236}">
+                <a16:creationId xmlns:a16="http://schemas.microsoft.com/office/drawing/2014/main" id="{870990D0-7AC5-46BA-6FC4-274F8E0A3ABE}"/>
+              </a:ext>
+            </a:extLst>
+          </p:cNvPr>
+          <p:cNvSpPr txBox="1">
+            <a:spLocks/>
+          </p:cNvSpPr>
+          <p:nvPr/>
+        </p:nvSpPr>
+        <p:spPr>
+          <a:xfrm>
+            <a:off x="380880" y="1371598"/>
+            <a:ext cx="3306353" cy="4559301"/>
+          </a:xfrm>
+          <a:prstGeom prst="rect">
+            <a:avLst/>
+          </a:prstGeom>
+          <a:noFill/>
+          <a:ln w="0">
+            <a:noFill/>
+          </a:ln>
+        </p:spPr>
+        <p:txBody>
+          <a:bodyPr numCol="1" spcCol="0" anchor="t">
+            <a:noAutofit/>
+          </a:bodyPr>
+          <a:lstStyle>
+            <a:lvl1pPr marL="228600" indent="-228600" algn="l" defTabSz="914400" rtl="0" eaLnBrk="1" latinLnBrk="0" hangingPunct="1">
+              <a:lnSpc>
+                <a:spcPct val="90000"/>
+              </a:lnSpc>
+              <a:spcBef>
+                <a:spcPts val="1000"/>
+              </a:spcBef>
+              <a:buFont typeface="Arial" panose="020B0604020202020204" pitchFamily="34" charset="0"/>
+              <a:buChar char="•"/>
+              <a:defRPr sz="2800" kern="1200">
+                <a:solidFill>
+                  <a:schemeClr val="tx1"/>
+                </a:solidFill>
+                <a:latin typeface="+mn-lt"/>
+                <a:ea typeface="+mn-ea"/>
+                <a:cs typeface="+mn-cs"/>
+              </a:defRPr>
+            </a:lvl1pPr>
+            <a:lvl2pPr marL="685800" indent="-228600" algn="l" defTabSz="914400" rtl="0" eaLnBrk="1" latinLnBrk="0" hangingPunct="1">
+              <a:lnSpc>
+                <a:spcPct val="90000"/>
+              </a:lnSpc>
+              <a:spcBef>
+                <a:spcPts val="500"/>
+              </a:spcBef>
+              <a:buFont typeface="Arial" panose="020B0604020202020204" pitchFamily="34" charset="0"/>
+              <a:buChar char="•"/>
+              <a:defRPr sz="2400" kern="1200">
+                <a:solidFill>
+                  <a:schemeClr val="tx1"/>
+                </a:solidFill>
+                <a:latin typeface="+mn-lt"/>
+                <a:ea typeface="+mn-ea"/>
+                <a:cs typeface="+mn-cs"/>
+              </a:defRPr>
+            </a:lvl2pPr>
+            <a:lvl3pPr marL="1143000" indent="-228600" algn="l" defTabSz="914400" rtl="0" eaLnBrk="1" latinLnBrk="0" hangingPunct="1">
+              <a:lnSpc>
+                <a:spcPct val="90000"/>
+              </a:lnSpc>
+              <a:spcBef>
+                <a:spcPts val="500"/>
+              </a:spcBef>
+              <a:buFont typeface="Arial" panose="020B0604020202020204" pitchFamily="34" charset="0"/>
+              <a:buChar char="•"/>
+              <a:defRPr sz="2000" kern="1200">
+                <a:solidFill>
+                  <a:schemeClr val="tx1"/>
+                </a:solidFill>
+                <a:latin typeface="+mn-lt"/>
+                <a:ea typeface="+mn-ea"/>
+                <a:cs typeface="+mn-cs"/>
+              </a:defRPr>
+            </a:lvl3pPr>
+            <a:lvl4pPr marL="1600200" indent="-228600" algn="l" defTabSz="914400" rtl="0" eaLnBrk="1" latinLnBrk="0" hangingPunct="1">
+              <a:lnSpc>
+                <a:spcPct val="90000"/>
+              </a:lnSpc>
+              <a:spcBef>
+                <a:spcPts val="500"/>
+              </a:spcBef>
+              <a:buFont typeface="Arial" panose="020B0604020202020204" pitchFamily="34" charset="0"/>
+              <a:buChar char="•"/>
+              <a:defRPr sz="1800" kern="1200">
+                <a:solidFill>
+                  <a:schemeClr val="tx1"/>
+                </a:solidFill>
+                <a:latin typeface="+mn-lt"/>
+                <a:ea typeface="+mn-ea"/>
+                <a:cs typeface="+mn-cs"/>
+              </a:defRPr>
+            </a:lvl4pPr>
+            <a:lvl5pPr marL="2057400" indent="-228600" algn="l" defTabSz="914400" rtl="0" eaLnBrk="1" latinLnBrk="0" hangingPunct="1">
+              <a:lnSpc>
+                <a:spcPct val="90000"/>
+              </a:lnSpc>
+              <a:spcBef>
+                <a:spcPts val="500"/>
+              </a:spcBef>
+              <a:buFont typeface="Arial" panose="020B0604020202020204" pitchFamily="34" charset="0"/>
+              <a:buChar char="•"/>
+              <a:defRPr sz="1800" kern="1200">
+                <a:solidFill>
+                  <a:schemeClr val="tx1"/>
+                </a:solidFill>
+                <a:latin typeface="+mn-lt"/>
+                <a:ea typeface="+mn-ea"/>
+                <a:cs typeface="+mn-cs"/>
+              </a:defRPr>
+            </a:lvl5pPr>
+            <a:lvl6pPr marL="2514600" indent="-228600" algn="l" defTabSz="914400" rtl="0" eaLnBrk="1" latinLnBrk="0" hangingPunct="1">
+              <a:lnSpc>
+                <a:spcPct val="90000"/>
+              </a:lnSpc>
+              <a:spcBef>
+                <a:spcPts val="500"/>
+              </a:spcBef>
+              <a:buFont typeface="Arial" panose="020B0604020202020204" pitchFamily="34" charset="0"/>
+              <a:buChar char="•"/>
+              <a:defRPr sz="1800" kern="1200">
+                <a:solidFill>
+                  <a:schemeClr val="tx1"/>
+                </a:solidFill>
+                <a:latin typeface="+mn-lt"/>
+                <a:ea typeface="+mn-ea"/>
+                <a:cs typeface="+mn-cs"/>
+              </a:defRPr>
+            </a:lvl6pPr>
+            <a:lvl7pPr marL="2971800" indent="-228600" algn="l" defTabSz="914400" rtl="0" eaLnBrk="1" latinLnBrk="0" hangingPunct="1">
+              <a:lnSpc>
+                <a:spcPct val="90000"/>
+              </a:lnSpc>
+              <a:spcBef>
+                <a:spcPts val="500"/>
+              </a:spcBef>
+              <a:buFont typeface="Arial" panose="020B0604020202020204" pitchFamily="34" charset="0"/>
+              <a:buChar char="•"/>
+              <a:defRPr sz="1800" kern="1200">
+                <a:solidFill>
+                  <a:schemeClr val="tx1"/>
+                </a:solidFill>
+                <a:latin typeface="+mn-lt"/>
+                <a:ea typeface="+mn-ea"/>
+                <a:cs typeface="+mn-cs"/>
+              </a:defRPr>
+            </a:lvl7pPr>
+            <a:lvl8pPr marL="3429000" indent="-228600" algn="l" defTabSz="914400" rtl="0" eaLnBrk="1" latinLnBrk="0" hangingPunct="1">
+              <a:lnSpc>
+                <a:spcPct val="90000"/>
+              </a:lnSpc>
+              <a:spcBef>
+                <a:spcPts val="500"/>
+              </a:spcBef>
+              <a:buFont typeface="Arial" panose="020B0604020202020204" pitchFamily="34" charset="0"/>
+              <a:buChar char="•"/>
+              <a:defRPr sz="1800" kern="1200">
+                <a:solidFill>
+                  <a:schemeClr val="tx1"/>
+                </a:solidFill>
+                <a:latin typeface="+mn-lt"/>
+                <a:ea typeface="+mn-ea"/>
+                <a:cs typeface="+mn-cs"/>
+              </a:defRPr>
+            </a:lvl8pPr>
+            <a:lvl9pPr marL="3886200" indent="-228600" algn="l" defTabSz="914400" rtl="0" eaLnBrk="1" latinLnBrk="0" hangingPunct="1">
+              <a:lnSpc>
+                <a:spcPct val="90000"/>
+              </a:lnSpc>
+              <a:spcBef>
+                <a:spcPts val="500"/>
+              </a:spcBef>
+              <a:buFont typeface="Arial" panose="020B0604020202020204" pitchFamily="34" charset="0"/>
+              <a:buChar char="•"/>
+              <a:defRPr sz="1800" kern="1200">
+                <a:solidFill>
+                  <a:schemeClr val="tx1"/>
+                </a:solidFill>
+                <a:latin typeface="+mn-lt"/>
+                <a:ea typeface="+mn-ea"/>
+                <a:cs typeface="+mn-cs"/>
+              </a:defRPr>
+            </a:lvl9pPr>
+          </a:lstStyle>
+          <a:p>
+            <a:pPr>
+              <a:lnSpc>
+                <a:spcPct val="100000"/>
+              </a:lnSpc>
+              <a:spcBef>
+                <a:spcPts val="400"/>
+              </a:spcBef>
+              <a:buClr>
+                <a:srgbClr val="0064C8"/>
+              </a:buClr>
+              <a:buFont typeface="Wingdings" panose="05000000000000000000" pitchFamily="2" charset="2"/>
+              <a:buChar char="§"/>
+            </a:pPr>
+            <a:r>
+              <a:rPr lang="en-US" sz="2000" spc="-1" dirty="0">
+                <a:solidFill>
+                  <a:srgbClr val="000000"/>
+                </a:solidFill>
+                <a:latin typeface="Century Gothic"/>
+              </a:rPr>
+              <a:t>Build an ML model for a given dataset</a:t>
+            </a:r>
+          </a:p>
+          <a:p>
+            <a:pPr>
+              <a:lnSpc>
+                <a:spcPct val="100000"/>
+              </a:lnSpc>
+              <a:spcBef>
+                <a:spcPts val="400"/>
+              </a:spcBef>
+              <a:buClr>
+                <a:srgbClr val="0064C8"/>
+              </a:buClr>
+              <a:buFont typeface="Wingdings" panose="05000000000000000000" pitchFamily="2" charset="2"/>
+              <a:buChar char="§"/>
+            </a:pPr>
+            <a:endParaRPr lang="en-US" sz="2000" spc="-1" dirty="0">
+              <a:solidFill>
+                <a:srgbClr val="000000"/>
+              </a:solidFill>
+              <a:latin typeface="Century Gothic"/>
+            </a:endParaRPr>
+          </a:p>
+          <a:p>
+            <a:pPr>
+              <a:lnSpc>
+                <a:spcPct val="100000"/>
+              </a:lnSpc>
+              <a:spcBef>
+                <a:spcPts val="400"/>
+              </a:spcBef>
+              <a:buClr>
+                <a:srgbClr val="0064C8"/>
+              </a:buClr>
+              <a:buFont typeface="Wingdings" panose="05000000000000000000" pitchFamily="2" charset="2"/>
+              <a:buChar char="§"/>
+            </a:pPr>
+            <a:r>
+              <a:rPr lang="en-US" sz="2000" spc="-1" dirty="0">
+                <a:solidFill>
+                  <a:srgbClr val="000000"/>
+                </a:solidFill>
+                <a:latin typeface="Century Gothic"/>
+              </a:rPr>
+              <a:t>Get a complete report</a:t>
+            </a:r>
+          </a:p>
+          <a:p>
+            <a:pPr lvl="1">
+              <a:lnSpc>
+                <a:spcPct val="100000"/>
+              </a:lnSpc>
+              <a:spcBef>
+                <a:spcPts val="400"/>
+              </a:spcBef>
+              <a:buClr>
+                <a:srgbClr val="0064C8"/>
+              </a:buClr>
+              <a:buFont typeface="Symbol" panose="05050102010706020507" pitchFamily="18" charset="2"/>
+              <a:buChar char="-"/>
+            </a:pPr>
+            <a:r>
+              <a:rPr lang="en-US" sz="1800" spc="-1" dirty="0">
+                <a:solidFill>
+                  <a:srgbClr val="000000"/>
+                </a:solidFill>
+                <a:latin typeface="Century Gothic"/>
+              </a:rPr>
+              <a:t>Dataset summary</a:t>
+            </a:r>
+          </a:p>
+          <a:p>
+            <a:pPr lvl="1">
+              <a:lnSpc>
+                <a:spcPct val="100000"/>
+              </a:lnSpc>
+              <a:spcBef>
+                <a:spcPts val="400"/>
+              </a:spcBef>
+              <a:buClr>
+                <a:srgbClr val="0064C8"/>
+              </a:buClr>
+              <a:buFont typeface="Symbol" panose="05050102010706020507" pitchFamily="18" charset="2"/>
+              <a:buChar char="-"/>
+            </a:pPr>
+            <a:r>
+              <a:rPr lang="en-US" sz="1800" spc="-1" dirty="0">
+                <a:solidFill>
+                  <a:srgbClr val="000000"/>
+                </a:solidFill>
+                <a:latin typeface="Century Gothic"/>
+              </a:rPr>
+              <a:t>Data split statistics</a:t>
+            </a:r>
+          </a:p>
+          <a:p>
+            <a:pPr lvl="1">
+              <a:lnSpc>
+                <a:spcPct val="100000"/>
+              </a:lnSpc>
+              <a:spcBef>
+                <a:spcPts val="400"/>
+              </a:spcBef>
+              <a:buClr>
+                <a:srgbClr val="0064C8"/>
+              </a:buClr>
+              <a:buFont typeface="Symbol" panose="05050102010706020507" pitchFamily="18" charset="2"/>
+              <a:buChar char="-"/>
+            </a:pPr>
+            <a:r>
+              <a:rPr lang="en-US" sz="1800" spc="-1" dirty="0">
+                <a:solidFill>
+                  <a:srgbClr val="000000"/>
+                </a:solidFill>
+                <a:latin typeface="Century Gothic"/>
+              </a:rPr>
+              <a:t>Model training information</a:t>
+            </a:r>
+          </a:p>
+          <a:p>
+            <a:pPr lvl="1">
+              <a:lnSpc>
+                <a:spcPct val="100000"/>
+              </a:lnSpc>
+              <a:spcBef>
+                <a:spcPts val="400"/>
+              </a:spcBef>
+              <a:buClr>
+                <a:srgbClr val="0064C8"/>
+              </a:buClr>
+              <a:buFont typeface="Symbol" panose="05050102010706020507" pitchFamily="18" charset="2"/>
+              <a:buChar char="-"/>
+            </a:pPr>
+            <a:r>
+              <a:rPr lang="en-US" sz="1800" spc="-1" dirty="0">
+                <a:solidFill>
+                  <a:srgbClr val="000000"/>
+                </a:solidFill>
+                <a:latin typeface="Century Gothic"/>
+              </a:rPr>
+              <a:t>Test set performance </a:t>
+            </a:r>
+          </a:p>
+          <a:p>
+            <a:pPr marL="343080" indent="-343080">
+              <a:lnSpc>
+                <a:spcPct val="100000"/>
+              </a:lnSpc>
+              <a:spcBef>
+                <a:spcPts val="400"/>
+              </a:spcBef>
+              <a:spcAft>
+                <a:spcPts val="601"/>
+              </a:spcAft>
+              <a:buClr>
+                <a:srgbClr val="0064C8"/>
+              </a:buClr>
+              <a:buFont typeface="Wingdings 2" charset="2"/>
+              <a:buChar char=""/>
+            </a:pPr>
+            <a:endParaRPr lang="en-US" sz="2000" b="1" spc="-1" dirty="0">
+              <a:solidFill>
+                <a:srgbClr val="000000"/>
+              </a:solidFill>
+              <a:latin typeface="Century Gothic"/>
+            </a:endParaRPr>
+          </a:p>
+        </p:txBody>
+      </p:sp>
+      <p:pic>
+        <p:nvPicPr>
+          <p:cNvPr id="6" name="Picture 5">
+            <a:extLst>
+              <a:ext uri="{FF2B5EF4-FFF2-40B4-BE49-F238E27FC236}">
+                <a16:creationId xmlns:a16="http://schemas.microsoft.com/office/drawing/2014/main" id="{D3BA145D-265C-C0B1-7C0E-2EE32552E491}"/>
+              </a:ext>
+            </a:extLst>
+          </p:cNvPr>
+          <p:cNvPicPr>
+            <a:picLocks noChangeAspect="1"/>
+          </p:cNvPicPr>
+          <p:nvPr/>
+        </p:nvPicPr>
+        <p:blipFill>
+          <a:blip r:embed="rId2"/>
+          <a:stretch>
+            <a:fillRect/>
+          </a:stretch>
+        </p:blipFill>
+        <p:spPr>
+          <a:xfrm>
+            <a:off x="3817354" y="1196437"/>
+            <a:ext cx="4943606" cy="4598149"/>
+          </a:xfrm>
+          <a:prstGeom prst="rect">
+            <a:avLst/>
+          </a:prstGeom>
+        </p:spPr>
+      </p:pic>
+    </p:spTree>
+    <p:extLst>
+      <p:ext uri="{BB962C8B-B14F-4D97-AF65-F5344CB8AC3E}">
+        <p14:creationId xmlns:p14="http://schemas.microsoft.com/office/powerpoint/2010/main" val="2375808848"/>
       </p:ext>
     </p:extLst>
   </p:cSld>
@@ -11391,7 +12969,7 @@
                 </a:solidFill>
                 <a:latin typeface="Century Gothic"/>
               </a:rPr>
-              <a:t> 3.5</a:t>
+              <a:t> 3.6</a:t>
             </a:r>
             <a:r>
               <a:rPr lang="en-US" sz="1600" spc="-1" dirty="0">
@@ -11751,7 +13329,7 @@
         <p:cNvPr id="1" name="">
           <a:extLst>
             <a:ext uri="{FF2B5EF4-FFF2-40B4-BE49-F238E27FC236}">
-              <a16:creationId xmlns:a16="http://schemas.microsoft.com/office/drawing/2014/main" id="{A6515F23-0912-A838-23CE-B8F00573A2DA}"/>
+              <a16:creationId xmlns:a16="http://schemas.microsoft.com/office/drawing/2014/main" id="{C3CB66AB-4C34-335D-C637-6159F7C9EC35}"/>
             </a:ext>
           </a:extLst>
         </p:cNvPr>
@@ -11771,7 +13349,7 @@
           <p:cNvPr id="163" name="PlaceHolder 1">
             <a:extLst>
               <a:ext uri="{FF2B5EF4-FFF2-40B4-BE49-F238E27FC236}">
-                <a16:creationId xmlns:a16="http://schemas.microsoft.com/office/drawing/2014/main" id="{57944F4B-F502-E7CC-8790-8737702BC6AC}"/>
+                <a16:creationId xmlns:a16="http://schemas.microsoft.com/office/drawing/2014/main" id="{F82143BD-207C-0F21-595D-2BC5AB956A76}"/>
               </a:ext>
             </a:extLst>
           </p:cNvPr>
@@ -11808,13 +13386,40 @@
               <a:buNone/>
             </a:pPr>
             <a:r>
-              <a:rPr lang="en-US" sz="3200" b="0" strike="noStrike" spc="-1" dirty="0">
+              <a:rPr lang="pt-PT" sz="3200" b="0" strike="noStrike" spc="-1" dirty="0" err="1">
                 <a:solidFill>
                   <a:srgbClr val="0064C8"/>
                 </a:solidFill>
                 <a:latin typeface="Century Gothic"/>
               </a:rPr>
-              <a:t>Exemplary answer output</a:t>
+              <a:t>Practical</a:t>
+            </a:r>
+            <a:r>
+              <a:rPr lang="pt-PT" sz="3200" b="0" strike="noStrike" spc="-1" dirty="0">
+                <a:solidFill>
+                  <a:srgbClr val="0064C8"/>
+                </a:solidFill>
+                <a:latin typeface="Century Gothic"/>
+              </a:rPr>
+              <a:t> </a:t>
+            </a:r>
+            <a:r>
+              <a:rPr lang="pt-PT" sz="3200" b="0" strike="noStrike" spc="-1" dirty="0" err="1">
+                <a:solidFill>
+                  <a:srgbClr val="0064C8"/>
+                </a:solidFill>
+                <a:latin typeface="Century Gothic"/>
+              </a:rPr>
+              <a:t>Example</a:t>
+            </a:r>
+            <a:r>
+              <a:rPr lang="pt-PT" sz="3200" b="0" strike="noStrike" spc="-1" dirty="0">
+                <a:solidFill>
+                  <a:srgbClr val="0064C8"/>
+                </a:solidFill>
+                <a:latin typeface="Century Gothic"/>
+              </a:rPr>
+              <a:t> - ML</a:t>
             </a:r>
             <a:endParaRPr lang="en-US" sz="3200" b="0" strike="noStrike" spc="-1" dirty="0">
               <a:solidFill>
@@ -11830,7 +13435,7 @@
           <p:cNvPr id="165" name="PlaceHolder 3">
             <a:extLst>
               <a:ext uri="{FF2B5EF4-FFF2-40B4-BE49-F238E27FC236}">
-                <a16:creationId xmlns:a16="http://schemas.microsoft.com/office/drawing/2014/main" id="{2EFBEA53-7B78-D9A1-93EF-9608A3193D27}"/>
+                <a16:creationId xmlns:a16="http://schemas.microsoft.com/office/drawing/2014/main" id="{44B88D20-671C-6A36-AD5A-B00142FEB557}"/>
               </a:ext>
             </a:extLst>
           </p:cNvPr>
@@ -11883,10 +13488,10 @@
       </p:sp>
       <p:sp>
         <p:nvSpPr>
-          <p:cNvPr id="2" name="PlaceHolder 2">
+          <p:cNvPr id="7" name="PlaceHolder 2">
             <a:extLst>
               <a:ext uri="{FF2B5EF4-FFF2-40B4-BE49-F238E27FC236}">
-                <a16:creationId xmlns:a16="http://schemas.microsoft.com/office/drawing/2014/main" id="{870990D0-7AC5-46BA-6FC4-274F8E0A3ABE}"/>
+                <a16:creationId xmlns:a16="http://schemas.microsoft.com/office/drawing/2014/main" id="{CFDAB819-6BAF-B7C7-0B20-F55019CACA6B}"/>
               </a:ext>
             </a:extLst>
           </p:cNvPr>
@@ -11898,7 +13503,7 @@
         <p:spPr>
           <a:xfrm>
             <a:off x="380880" y="1371598"/>
-            <a:ext cx="3306353" cy="4559301"/>
+            <a:ext cx="4190040" cy="4559301"/>
           </a:xfrm>
           <a:prstGeom prst="rect">
             <a:avLst/>
@@ -12077,6 +13682,46 @@
             </a:lvl9pPr>
           </a:lstStyle>
           <a:p>
+            <a:pPr marL="0" indent="0">
+              <a:lnSpc>
+                <a:spcPct val="100000"/>
+              </a:lnSpc>
+              <a:spcBef>
+                <a:spcPts val="400"/>
+              </a:spcBef>
+              <a:buClr>
+                <a:srgbClr val="0064C8"/>
+              </a:buClr>
+              <a:buNone/>
+            </a:pPr>
+            <a:r>
+              <a:rPr lang="en-US" sz="2000" b="1" strike="noStrike" spc="-1" dirty="0">
+                <a:latin typeface="Century Gothic"/>
+              </a:rPr>
+              <a:t>ML prompt</a:t>
+            </a:r>
+          </a:p>
+          <a:p>
+            <a:pPr marL="0" indent="0">
+              <a:lnSpc>
+                <a:spcPct val="100000"/>
+              </a:lnSpc>
+              <a:spcBef>
+                <a:spcPts val="400"/>
+              </a:spcBef>
+              <a:buClr>
+                <a:srgbClr val="0064C8"/>
+              </a:buClr>
+              <a:buNone/>
+            </a:pPr>
+            <a:endParaRPr lang="en-US" sz="2000" spc="-1" dirty="0">
+              <a:solidFill>
+                <a:srgbClr val="000000"/>
+              </a:solidFill>
+              <a:latin typeface="Century Gothic"/>
+            </a:endParaRPr>
+          </a:p>
+          <a:p>
             <a:pPr>
               <a:lnSpc>
                 <a:spcPct val="100000"/>
@@ -12091,13 +13736,13 @@
               <a:buChar char="§"/>
             </a:pPr>
             <a:r>
-              <a:rPr lang="en-US" sz="2000" spc="-1" dirty="0">
+              <a:rPr lang="en-US" sz="1400" spc="-1" dirty="0">
                 <a:solidFill>
                   <a:srgbClr val="000000"/>
                 </a:solidFill>
                 <a:latin typeface="Century Gothic"/>
               </a:rPr>
-              <a:t>Build an ML model for a given dataset</a:t>
+              <a:t>For the given curated dataset ‘kinase_selectivity.csv’</a:t>
             </a:r>
           </a:p>
           <a:p>
@@ -12114,7 +13759,7 @@
               <a:buFont typeface="Wingdings" panose="05000000000000000000" pitchFamily="2" charset="2"/>
               <a:buChar char="§"/>
             </a:pPr>
-            <a:endParaRPr lang="en-US" sz="2000" spc="-1" dirty="0">
+            <a:endParaRPr lang="en-US" sz="1400" spc="-1" dirty="0">
               <a:solidFill>
                 <a:srgbClr val="000000"/>
               </a:solidFill>
@@ -12136,17 +13781,17 @@
               <a:buChar char="§"/>
             </a:pPr>
             <a:r>
-              <a:rPr lang="en-US" sz="2000" spc="-1" dirty="0">
+              <a:rPr lang="en-US" sz="1400" spc="-1" dirty="0">
                 <a:solidFill>
                   <a:srgbClr val="000000"/>
                 </a:solidFill>
                 <a:latin typeface="Century Gothic"/>
               </a:rPr>
-              <a:t>Get a complete report</a:t>
+              <a:t>Split the data using a scaffold split using a ratio of  80%/20% train/test</a:t>
             </a:r>
           </a:p>
           <a:p>
-            <a:pPr lvl="1">
+            <a:pPr>
               <a:lnSpc>
                 <a:spcPct val="100000"/>
               </a:lnSpc>
@@ -12156,21 +13801,18 @@
               <a:buClr>
                 <a:srgbClr val="0064C8"/>
               </a:buClr>
-              <a:buFont typeface="Symbol" panose="05050102010706020507" pitchFamily="18" charset="2"/>
-              <a:buChar char="-"/>
+              <a:buFont typeface="Wingdings" panose="05000000000000000000" pitchFamily="2" charset="2"/>
+              <a:buChar char="§"/>
             </a:pPr>
-            <a:r>
-              <a:rPr lang="en-US" sz="1800" spc="-1" dirty="0">
-                <a:solidFill>
-                  <a:srgbClr val="000000"/>
-                </a:solidFill>
-                <a:latin typeface="Century Gothic"/>
-              </a:rPr>
-              <a:t>Dataset summary</a:t>
-            </a:r>
-          </a:p>
-          <a:p>
-            <a:pPr lvl="1">
+            <a:endParaRPr lang="en-US" sz="1400" spc="-1" dirty="0">
+              <a:solidFill>
+                <a:srgbClr val="000000"/>
+              </a:solidFill>
+              <a:latin typeface="Century Gothic"/>
+            </a:endParaRPr>
+          </a:p>
+          <a:p>
+            <a:pPr>
               <a:lnSpc>
                 <a:spcPct val="100000"/>
               </a:lnSpc>
@@ -12180,21 +13822,21 @@
               <a:buClr>
                 <a:srgbClr val="0064C8"/>
               </a:buClr>
-              <a:buFont typeface="Symbol" panose="05050102010706020507" pitchFamily="18" charset="2"/>
-              <a:buChar char="-"/>
+              <a:buFont typeface="Wingdings" panose="05000000000000000000" pitchFamily="2" charset="2"/>
+              <a:buChar char="§"/>
             </a:pPr>
             <a:r>
-              <a:rPr lang="en-US" sz="1800" spc="-1" dirty="0">
+              <a:rPr lang="en-US" sz="1400" spc="-1" dirty="0">
                 <a:solidFill>
                   <a:srgbClr val="000000"/>
                 </a:solidFill>
                 <a:latin typeface="Century Gothic"/>
               </a:rPr>
-              <a:t>Data split statistics</a:t>
+              <a:t>Train an RF model and perform a 5-fold CV for hyperparameter optimization</a:t>
             </a:r>
           </a:p>
           <a:p>
-            <a:pPr lvl="1">
+            <a:pPr>
               <a:lnSpc>
                 <a:spcPct val="100000"/>
               </a:lnSpc>
@@ -12204,21 +13846,18 @@
               <a:buClr>
                 <a:srgbClr val="0064C8"/>
               </a:buClr>
-              <a:buFont typeface="Symbol" panose="05050102010706020507" pitchFamily="18" charset="2"/>
-              <a:buChar char="-"/>
+              <a:buFont typeface="Wingdings" panose="05000000000000000000" pitchFamily="2" charset="2"/>
+              <a:buChar char="§"/>
             </a:pPr>
-            <a:r>
-              <a:rPr lang="en-US" sz="1800" spc="-1" dirty="0">
-                <a:solidFill>
-                  <a:srgbClr val="000000"/>
-                </a:solidFill>
-                <a:latin typeface="Century Gothic"/>
-              </a:rPr>
-              <a:t>Model training information</a:t>
-            </a:r>
-          </a:p>
-          <a:p>
-            <a:pPr lvl="1">
+            <a:endParaRPr lang="en-US" sz="1400" spc="-1" dirty="0">
+              <a:solidFill>
+                <a:srgbClr val="000000"/>
+              </a:solidFill>
+              <a:latin typeface="Century Gothic"/>
+            </a:endParaRPr>
+          </a:p>
+          <a:p>
+            <a:pPr>
               <a:lnSpc>
                 <a:spcPct val="100000"/>
               </a:lnSpc>
@@ -12228,18 +13867,45 @@
               <a:buClr>
                 <a:srgbClr val="0064C8"/>
               </a:buClr>
-              <a:buFont typeface="Symbol" panose="05050102010706020507" pitchFamily="18" charset="2"/>
-              <a:buChar char="-"/>
+              <a:buFont typeface="Wingdings" panose="05000000000000000000" pitchFamily="2" charset="2"/>
+              <a:buChar char="§"/>
             </a:pPr>
             <a:r>
-              <a:rPr lang="en-US" sz="1800" spc="-1" dirty="0">
+              <a:rPr lang="en-US" sz="1400" spc="-1" dirty="0">
                 <a:solidFill>
                   <a:srgbClr val="000000"/>
                 </a:solidFill>
                 <a:latin typeface="Century Gothic"/>
               </a:rPr>
-              <a:t>Test set performance </a:t>
+              <a:t>Calculate and display the test set performance using appropriate metrics</a:t>
             </a:r>
+            <a:endParaRPr lang="en-US" sz="1600" spc="-1" dirty="0">
+              <a:solidFill>
+                <a:srgbClr val="000000"/>
+              </a:solidFill>
+              <a:latin typeface="Century Gothic"/>
+            </a:endParaRPr>
+          </a:p>
+          <a:p>
+            <a:pPr>
+              <a:lnSpc>
+                <a:spcPct val="100000"/>
+              </a:lnSpc>
+              <a:spcBef>
+                <a:spcPts val="400"/>
+              </a:spcBef>
+              <a:buClr>
+                <a:srgbClr val="0064C8"/>
+              </a:buClr>
+              <a:buFont typeface="Wingdings" panose="05000000000000000000" pitchFamily="2" charset="2"/>
+              <a:buChar char="§"/>
+            </a:pPr>
+            <a:endParaRPr lang="en-US" sz="1800" spc="-1" dirty="0">
+              <a:solidFill>
+                <a:srgbClr val="000000"/>
+              </a:solidFill>
+              <a:latin typeface="Century Gothic"/>
+            </a:endParaRPr>
           </a:p>
           <a:p>
             <a:pPr marL="343080" indent="-343080">
@@ -12269,10 +13935,10 @@
       </p:sp>
       <p:pic>
         <p:nvPicPr>
-          <p:cNvPr id="6" name="Picture 5">
+          <p:cNvPr id="3" name="Picture 2">
             <a:extLst>
               <a:ext uri="{FF2B5EF4-FFF2-40B4-BE49-F238E27FC236}">
-                <a16:creationId xmlns:a16="http://schemas.microsoft.com/office/drawing/2014/main" id="{D3BA145D-265C-C0B1-7C0E-2EE32552E491}"/>
+                <a16:creationId xmlns:a16="http://schemas.microsoft.com/office/drawing/2014/main" id="{26877CA3-72FB-5BAD-B036-17D15BFC3DA0}"/>
               </a:ext>
             </a:extLst>
           </p:cNvPr>
@@ -12282,15 +13948,15 @@
           <p:nvPr/>
         </p:nvPicPr>
         <p:blipFill>
-          <a:blip r:embed="rId2"/>
+          <a:blip r:embed="rId3"/>
           <a:stretch>
             <a:fillRect/>
           </a:stretch>
         </p:blipFill>
         <p:spPr>
           <a:xfrm>
-            <a:off x="3817354" y="1196437"/>
-            <a:ext cx="4943606" cy="4598149"/>
+            <a:off x="4480608" y="1246234"/>
+            <a:ext cx="4140000" cy="4420744"/>
           </a:xfrm>
           <a:prstGeom prst="rect">
             <a:avLst/>
@@ -12300,7 +13966,7 @@
     </p:spTree>
     <p:extLst>
       <p:ext uri="{BB962C8B-B14F-4D97-AF65-F5344CB8AC3E}">
-        <p14:creationId xmlns:p14="http://schemas.microsoft.com/office/powerpoint/2010/main" val="2375808848"/>
+        <p14:creationId xmlns:p14="http://schemas.microsoft.com/office/powerpoint/2010/main" val="921095034"/>
       </p:ext>
     </p:extLst>
   </p:cSld>
@@ -16108,4 +17774,319 @@
   <a:objectDefaults/>
   <a:extraClrSchemeLst/>
 </a:theme>
+</file>
+
+<file path=ppt/theme/theme3.xml><?xml version="1.0" encoding="utf-8"?>
+<a:theme xmlns:a="http://schemas.openxmlformats.org/drawingml/2006/main" name="Office Theme">
+  <a:themeElements>
+    <a:clrScheme name="Office">
+      <a:dk1>
+        <a:sysClr val="windowText" lastClr="000000"/>
+      </a:dk1>
+      <a:lt1>
+        <a:sysClr val="window" lastClr="FFFFFF"/>
+      </a:lt1>
+      <a:dk2>
+        <a:srgbClr val="0E2841"/>
+      </a:dk2>
+      <a:lt2>
+        <a:srgbClr val="E8E8E8"/>
+      </a:lt2>
+      <a:accent1>
+        <a:srgbClr val="156082"/>
+      </a:accent1>
+      <a:accent2>
+        <a:srgbClr val="E97132"/>
+      </a:accent2>
+      <a:accent3>
+        <a:srgbClr val="196B24"/>
+      </a:accent3>
+      <a:accent4>
+        <a:srgbClr val="0F9ED5"/>
+      </a:accent4>
+      <a:accent5>
+        <a:srgbClr val="A02B93"/>
+      </a:accent5>
+      <a:accent6>
+        <a:srgbClr val="4EA72E"/>
+      </a:accent6>
+      <a:hlink>
+        <a:srgbClr val="467886"/>
+      </a:hlink>
+      <a:folHlink>
+        <a:srgbClr val="96607D"/>
+      </a:folHlink>
+    </a:clrScheme>
+    <a:fontScheme name="Office">
+      <a:majorFont>
+        <a:latin typeface="Aptos Display" panose="02110004020202020204"/>
+        <a:ea typeface=""/>
+        <a:cs typeface=""/>
+        <a:font script="Jpan" typeface="游ゴシック Light"/>
+        <a:font script="Hang" typeface="맑은 고딕"/>
+        <a:font script="Hans" typeface="等线 Light"/>
+        <a:font script="Hant" typeface="新細明體"/>
+        <a:font script="Arab" typeface="Times New Roman"/>
+        <a:font script="Hebr" typeface="Times New Roman"/>
+        <a:font script="Thai" typeface="Angsana New"/>
+        <a:font script="Ethi" typeface="Nyala"/>
+        <a:font script="Beng" typeface="Vrinda"/>
+        <a:font script="Gujr" typeface="Shruti"/>
+        <a:font script="Khmr" typeface="MoolBoran"/>
+        <a:font script="Knda" typeface="Tunga"/>
+        <a:font script="Guru" typeface="Raavi"/>
+        <a:font script="Cans" typeface="Euphemia"/>
+        <a:font script="Cher" typeface="Plantagenet Cherokee"/>
+        <a:font script="Yiii" typeface="Microsoft Yi Baiti"/>
+        <a:font script="Tibt" typeface="Microsoft Himalaya"/>
+        <a:font script="Thaa" typeface="MV Boli"/>
+        <a:font script="Deva" typeface="Mangal"/>
+        <a:font script="Telu" typeface="Gautami"/>
+        <a:font script="Taml" typeface="Latha"/>
+        <a:font script="Syrc" typeface="Estrangelo Edessa"/>
+        <a:font script="Orya" typeface="Kalinga"/>
+        <a:font script="Mlym" typeface="Kartika"/>
+        <a:font script="Laoo" typeface="DokChampa"/>
+        <a:font script="Sinh" typeface="Iskoola Pota"/>
+        <a:font script="Mong" typeface="Mongolian Baiti"/>
+        <a:font script="Viet" typeface="Times New Roman"/>
+        <a:font script="Uigh" typeface="Microsoft Uighur"/>
+        <a:font script="Geor" typeface="Sylfaen"/>
+        <a:font script="Armn" typeface="Arial"/>
+        <a:font script="Bugi" typeface="Leelawadee UI"/>
+        <a:font script="Bopo" typeface="Microsoft JhengHei"/>
+        <a:font script="Java" typeface="Javanese Text"/>
+        <a:font script="Lisu" typeface="Segoe UI"/>
+        <a:font script="Mymr" typeface="Myanmar Text"/>
+        <a:font script="Nkoo" typeface="Ebrima"/>
+        <a:font script="Olck" typeface="Nirmala UI"/>
+        <a:font script="Osma" typeface="Ebrima"/>
+        <a:font script="Phag" typeface="Phagspa"/>
+        <a:font script="Syrn" typeface="Estrangelo Edessa"/>
+        <a:font script="Syrj" typeface="Estrangelo Edessa"/>
+        <a:font script="Syre" typeface="Estrangelo Edessa"/>
+        <a:font script="Sora" typeface="Nirmala UI"/>
+        <a:font script="Tale" typeface="Microsoft Tai Le"/>
+        <a:font script="Talu" typeface="Microsoft New Tai Lue"/>
+        <a:font script="Tfng" typeface="Ebrima"/>
+      </a:majorFont>
+      <a:minorFont>
+        <a:latin typeface="Aptos" panose="02110004020202020204"/>
+        <a:ea typeface=""/>
+        <a:cs typeface=""/>
+        <a:font script="Jpan" typeface="游ゴシック"/>
+        <a:font script="Hang" typeface="맑은 고딕"/>
+        <a:font script="Hans" typeface="等线"/>
+        <a:font script="Hant" typeface="新細明體"/>
+        <a:font script="Arab" typeface="Arial"/>
+        <a:font script="Hebr" typeface="Arial"/>
+        <a:font script="Thai" typeface="Cordia New"/>
+        <a:font script="Ethi" typeface="Nyala"/>
+        <a:font script="Beng" typeface="Vrinda"/>
+        <a:font script="Gujr" typeface="Shruti"/>
+        <a:font script="Khmr" typeface="DaunPenh"/>
+        <a:font script="Knda" typeface="Tunga"/>
+        <a:font script="Guru" typeface="Raavi"/>
+        <a:font script="Cans" typeface="Euphemia"/>
+        <a:font script="Cher" typeface="Plantagenet Cherokee"/>
+        <a:font script="Yiii" typeface="Microsoft Yi Baiti"/>
+        <a:font script="Tibt" typeface="Microsoft Himalaya"/>
+        <a:font script="Thaa" typeface="MV Boli"/>
+        <a:font script="Deva" typeface="Mangal"/>
+        <a:font script="Telu" typeface="Gautami"/>
+        <a:font script="Taml" typeface="Latha"/>
+        <a:font script="Syrc" typeface="Estrangelo Edessa"/>
+        <a:font script="Orya" typeface="Kalinga"/>
+        <a:font script="Mlym" typeface="Kartika"/>
+        <a:font script="Laoo" typeface="DokChampa"/>
+        <a:font script="Sinh" typeface="Iskoola Pota"/>
+        <a:font script="Mong" typeface="Mongolian Baiti"/>
+        <a:font script="Viet" typeface="Arial"/>
+        <a:font script="Uigh" typeface="Microsoft Uighur"/>
+        <a:font script="Geor" typeface="Sylfaen"/>
+        <a:font script="Armn" typeface="Arial"/>
+        <a:font script="Bugi" typeface="Leelawadee UI"/>
+        <a:font script="Bopo" typeface="Microsoft JhengHei"/>
+        <a:font script="Java" typeface="Javanese Text"/>
+        <a:font script="Lisu" typeface="Segoe UI"/>
+        <a:font script="Mymr" typeface="Myanmar Text"/>
+        <a:font script="Nkoo" typeface="Ebrima"/>
+        <a:font script="Olck" typeface="Nirmala UI"/>
+        <a:font script="Osma" typeface="Ebrima"/>
+        <a:font script="Phag" typeface="Phagspa"/>
+        <a:font script="Syrn" typeface="Estrangelo Edessa"/>
+        <a:font script="Syrj" typeface="Estrangelo Edessa"/>
+        <a:font script="Syre" typeface="Estrangelo Edessa"/>
+        <a:font script="Sora" typeface="Nirmala UI"/>
+        <a:font script="Tale" typeface="Microsoft Tai Le"/>
+        <a:font script="Talu" typeface="Microsoft New Tai Lue"/>
+        <a:font script="Tfng" typeface="Ebrima"/>
+      </a:minorFont>
+    </a:fontScheme>
+    <a:fmtScheme name="Office">
+      <a:fillStyleLst>
+        <a:solidFill>
+          <a:schemeClr val="phClr"/>
+        </a:solidFill>
+        <a:gradFill rotWithShape="1">
+          <a:gsLst>
+            <a:gs pos="0">
+              <a:schemeClr val="phClr">
+                <a:lumMod val="110000"/>
+                <a:satMod val="105000"/>
+                <a:tint val="67000"/>
+              </a:schemeClr>
+            </a:gs>
+            <a:gs pos="50000">
+              <a:schemeClr val="phClr">
+                <a:lumMod val="105000"/>
+                <a:satMod val="103000"/>
+                <a:tint val="73000"/>
+              </a:schemeClr>
+            </a:gs>
+            <a:gs pos="100000">
+              <a:schemeClr val="phClr">
+                <a:lumMod val="105000"/>
+                <a:satMod val="109000"/>
+                <a:tint val="81000"/>
+              </a:schemeClr>
+            </a:gs>
+          </a:gsLst>
+          <a:lin ang="5400000" scaled="0"/>
+        </a:gradFill>
+        <a:gradFill rotWithShape="1">
+          <a:gsLst>
+            <a:gs pos="0">
+              <a:schemeClr val="phClr">
+                <a:satMod val="103000"/>
+                <a:lumMod val="102000"/>
+                <a:tint val="94000"/>
+              </a:schemeClr>
+            </a:gs>
+            <a:gs pos="50000">
+              <a:schemeClr val="phClr">
+                <a:satMod val="110000"/>
+                <a:lumMod val="100000"/>
+                <a:shade val="100000"/>
+              </a:schemeClr>
+            </a:gs>
+            <a:gs pos="100000">
+              <a:schemeClr val="phClr">
+                <a:lumMod val="99000"/>
+                <a:satMod val="120000"/>
+                <a:shade val="78000"/>
+              </a:schemeClr>
+            </a:gs>
+          </a:gsLst>
+          <a:lin ang="5400000" scaled="0"/>
+        </a:gradFill>
+      </a:fillStyleLst>
+      <a:lnStyleLst>
+        <a:ln w="12700" cap="flat" cmpd="sng" algn="ctr">
+          <a:solidFill>
+            <a:schemeClr val="phClr"/>
+          </a:solidFill>
+          <a:prstDash val="solid"/>
+          <a:miter lim="800000"/>
+        </a:ln>
+        <a:ln w="19050" cap="flat" cmpd="sng" algn="ctr">
+          <a:solidFill>
+            <a:schemeClr val="phClr"/>
+          </a:solidFill>
+          <a:prstDash val="solid"/>
+          <a:miter lim="800000"/>
+        </a:ln>
+        <a:ln w="25400" cap="flat" cmpd="sng" algn="ctr">
+          <a:solidFill>
+            <a:schemeClr val="phClr"/>
+          </a:solidFill>
+          <a:prstDash val="solid"/>
+          <a:miter lim="800000"/>
+        </a:ln>
+      </a:lnStyleLst>
+      <a:effectStyleLst>
+        <a:effectStyle>
+          <a:effectLst/>
+        </a:effectStyle>
+        <a:effectStyle>
+          <a:effectLst/>
+        </a:effectStyle>
+        <a:effectStyle>
+          <a:effectLst>
+            <a:outerShdw blurRad="57150" dist="19050" dir="5400000" algn="ctr" rotWithShape="0">
+              <a:srgbClr val="000000">
+                <a:alpha val="63000"/>
+              </a:srgbClr>
+            </a:outerShdw>
+          </a:effectLst>
+        </a:effectStyle>
+      </a:effectStyleLst>
+      <a:bgFillStyleLst>
+        <a:solidFill>
+          <a:schemeClr val="phClr"/>
+        </a:solidFill>
+        <a:solidFill>
+          <a:schemeClr val="phClr">
+            <a:tint val="95000"/>
+            <a:satMod val="170000"/>
+          </a:schemeClr>
+        </a:solidFill>
+        <a:gradFill rotWithShape="1">
+          <a:gsLst>
+            <a:gs pos="0">
+              <a:schemeClr val="phClr">
+                <a:tint val="93000"/>
+                <a:satMod val="150000"/>
+                <a:shade val="98000"/>
+                <a:lumMod val="102000"/>
+              </a:schemeClr>
+            </a:gs>
+            <a:gs pos="50000">
+              <a:schemeClr val="phClr">
+                <a:tint val="98000"/>
+                <a:satMod val="130000"/>
+                <a:shade val="90000"/>
+                <a:lumMod val="103000"/>
+              </a:schemeClr>
+            </a:gs>
+            <a:gs pos="100000">
+              <a:schemeClr val="phClr">
+                <a:shade val="63000"/>
+                <a:satMod val="120000"/>
+              </a:schemeClr>
+            </a:gs>
+          </a:gsLst>
+          <a:lin ang="5400000" scaled="0"/>
+        </a:gradFill>
+      </a:bgFillStyleLst>
+    </a:fmtScheme>
+  </a:themeElements>
+  <a:objectDefaults>
+    <a:lnDef>
+      <a:spPr/>
+      <a:bodyPr/>
+      <a:lstStyle/>
+      <a:style>
+        <a:lnRef idx="2">
+          <a:schemeClr val="accent1"/>
+        </a:lnRef>
+        <a:fillRef idx="0">
+          <a:schemeClr val="accent1"/>
+        </a:fillRef>
+        <a:effectRef idx="1">
+          <a:schemeClr val="accent1"/>
+        </a:effectRef>
+        <a:fontRef idx="minor">
+          <a:schemeClr val="tx1"/>
+        </a:fontRef>
+      </a:style>
+    </a:lnDef>
+  </a:objectDefaults>
+  <a:extraClrSchemeLst/>
+  <a:extLst>
+    <a:ext uri="{05A4C25C-085E-4340-85A3-A5531E510DB2}">
+      <thm15:themeFamily xmlns:thm15="http://schemas.microsoft.com/office/thememl/2012/main" name="Office Theme" id="{2E142A2C-CD16-42D6-873A-C26D2A0506FA}" vid="{1BDDFF52-6CD6-40A5-AB3C-68EB2F1E4D0A}"/>
+    </a:ext>
+  </a:extLst>
+</a:theme>
 </file>
</xml_diff>

<commit_message>
Update presentation slides for AI Agent Explainability and Figures
</commit_message>
<xml_diff>
--- a/slides/AI_Agent_Explainability.pptx
+++ b/slides/AI_Agent_Explainability.pptx
@@ -6,7 +6,7 @@
     <p:sldMasterId id="2147483661" r:id="rId2"/>
   </p:sldMasterIdLst>
   <p:notesMasterIdLst>
-    <p:notesMasterId r:id="rId16"/>
+    <p:notesMasterId r:id="rId18"/>
   </p:notesMasterIdLst>
   <p:sldIdLst>
     <p:sldId id="297" r:id="rId3"/>
@@ -16,12 +16,14 @@
     <p:sldId id="310" r:id="rId7"/>
     <p:sldId id="309" r:id="rId8"/>
     <p:sldId id="311" r:id="rId9"/>
-    <p:sldId id="312" r:id="rId10"/>
-    <p:sldId id="313" r:id="rId11"/>
-    <p:sldId id="314" r:id="rId12"/>
-    <p:sldId id="315" r:id="rId13"/>
-    <p:sldId id="316" r:id="rId14"/>
-    <p:sldId id="303" r:id="rId15"/>
+    <p:sldId id="317" r:id="rId10"/>
+    <p:sldId id="318" r:id="rId11"/>
+    <p:sldId id="312" r:id="rId12"/>
+    <p:sldId id="313" r:id="rId13"/>
+    <p:sldId id="314" r:id="rId14"/>
+    <p:sldId id="315" r:id="rId15"/>
+    <p:sldId id="316" r:id="rId16"/>
+    <p:sldId id="303" r:id="rId17"/>
   </p:sldIdLst>
   <p:sldSz cx="9144000" cy="6858000" type="screen4x3"/>
   <p:notesSz cx="7559675" cy="10691813"/>
@@ -130,45 +132,6 @@
 
 <file path=ppt/changesInfos/changesInfo1.xml><?xml version="1.0" encoding="utf-8"?>
 <pc:chgInfo xmlns:a="http://schemas.openxmlformats.org/drawingml/2006/main" xmlns:r="http://schemas.openxmlformats.org/officeDocument/2006/relationships" xmlns:ac="http://schemas.microsoft.com/office/drawing/2013/main/command" xmlns:pc="http://schemas.microsoft.com/office/powerpoint/2013/main/command">
-  <pc:docChgLst>
-    <pc:chgData name="Tiago Janela" userId="ee1a79fe-c79c-4f34-9602-7f6f2f0482b3" providerId="ADAL" clId="{67D2C233-DF3C-4C6D-9040-D7553E3BCB8A}"/>
-    <pc:docChg chg="delSld modSld">
-      <pc:chgData name="Tiago Janela" userId="ee1a79fe-c79c-4f34-9602-7f6f2f0482b3" providerId="ADAL" clId="{67D2C233-DF3C-4C6D-9040-D7553E3BCB8A}" dt="2026-03-16T14:03:02.466" v="54" actId="20577"/>
-      <pc:docMkLst>
-        <pc:docMk/>
-      </pc:docMkLst>
-      <pc:sldChg chg="modSp mod">
-        <pc:chgData name="Tiago Janela" userId="ee1a79fe-c79c-4f34-9602-7f6f2f0482b3" providerId="ADAL" clId="{67D2C233-DF3C-4C6D-9040-D7553E3BCB8A}" dt="2026-03-16T14:03:02.466" v="54" actId="20577"/>
-        <pc:sldMkLst>
-          <pc:docMk/>
-          <pc:sldMk cId="829672710" sldId="297"/>
-        </pc:sldMkLst>
-        <pc:spChg chg="mod">
-          <ac:chgData name="Tiago Janela" userId="ee1a79fe-c79c-4f34-9602-7f6f2f0482b3" providerId="ADAL" clId="{67D2C233-DF3C-4C6D-9040-D7553E3BCB8A}" dt="2026-03-16T14:03:02.466" v="54" actId="20577"/>
-          <ac:spMkLst>
-            <pc:docMk/>
-            <pc:sldMk cId="829672710" sldId="297"/>
-            <ac:spMk id="156" creationId="{00000000-0000-0000-0000-000000000000}"/>
-          </ac:spMkLst>
-        </pc:spChg>
-      </pc:sldChg>
-      <pc:sldChg chg="modSp mod">
-        <pc:chgData name="Tiago Janela" userId="ee1a79fe-c79c-4f34-9602-7f6f2f0482b3" providerId="ADAL" clId="{67D2C233-DF3C-4C6D-9040-D7553E3BCB8A}" dt="2026-03-16T14:02:34.148" v="0" actId="20577"/>
-        <pc:sldMkLst>
-          <pc:docMk/>
-          <pc:sldMk cId="721732568" sldId="298"/>
-        </pc:sldMkLst>
-        <pc:spChg chg="mod">
-          <ac:chgData name="Tiago Janela" userId="ee1a79fe-c79c-4f34-9602-7f6f2f0482b3" providerId="ADAL" clId="{67D2C233-DF3C-4C6D-9040-D7553E3BCB8A}" dt="2026-03-16T14:02:34.148" v="0" actId="20577"/>
-          <ac:spMkLst>
-            <pc:docMk/>
-            <pc:sldMk cId="721732568" sldId="298"/>
-            <ac:spMk id="2" creationId="{870990D0-7AC5-46BA-6FC4-274F8E0A3ABE}"/>
-          </ac:spMkLst>
-        </pc:spChg>
-      </pc:sldChg>
-    </pc:docChg>
-  </pc:docChgLst>
   <pc:docChgLst>
     <pc:chgData name="Tiago Janela" userId="ee1a79fe-c79c-4f34-9602-7f6f2f0482b3" providerId="ADAL" clId="{6BE67FA1-4A27-48B9-BA6A-E25A9786A9CC}"/>
     <pc:docChg chg="undo custSel addSld modSld sldOrd">
@@ -279,6 +242,1386 @@
     </pc:docChg>
   </pc:docChgLst>
   <pc:docChgLst>
+    <pc:chgData name="Tiago Janela" userId="ee1a79fe-c79c-4f34-9602-7f6f2f0482b3" providerId="ADAL" clId="{D59BA079-2D81-42B2-9E2D-198C5F90099E}"/>
+    <pc:docChg chg="undo custSel addSld modSld sldOrd">
+      <pc:chgData name="Tiago Janela" userId="ee1a79fe-c79c-4f34-9602-7f6f2f0482b3" providerId="ADAL" clId="{D59BA079-2D81-42B2-9E2D-198C5F90099E}" dt="2026-04-29T14:57:22.243" v="167"/>
+      <pc:docMkLst>
+        <pc:docMk/>
+      </pc:docMkLst>
+      <pc:sldChg chg="addSp delSp modSp mod">
+        <pc:chgData name="Tiago Janela" userId="ee1a79fe-c79c-4f34-9602-7f6f2f0482b3" providerId="ADAL" clId="{D59BA079-2D81-42B2-9E2D-198C5F90099E}" dt="2026-04-29T14:57:22.243" v="167"/>
+        <pc:sldMkLst>
+          <pc:docMk/>
+          <pc:sldMk cId="721732568" sldId="298"/>
+        </pc:sldMkLst>
+        <pc:picChg chg="add mod">
+          <ac:chgData name="Tiago Janela" userId="ee1a79fe-c79c-4f34-9602-7f6f2f0482b3" providerId="ADAL" clId="{D59BA079-2D81-42B2-9E2D-198C5F90099E}" dt="2026-04-29T14:57:22.243" v="167"/>
+          <ac:picMkLst>
+            <pc:docMk/>
+            <pc:sldMk cId="721732568" sldId="298"/>
+            <ac:picMk id="3" creationId="{C525295A-47E6-DB8C-78FD-5ACC25A8B445}"/>
+          </ac:picMkLst>
+        </pc:picChg>
+        <pc:picChg chg="del">
+          <ac:chgData name="Tiago Janela" userId="ee1a79fe-c79c-4f34-9602-7f6f2f0482b3" providerId="ADAL" clId="{D59BA079-2D81-42B2-9E2D-198C5F90099E}" dt="2026-04-29T14:57:21.959" v="166" actId="478"/>
+          <ac:picMkLst>
+            <pc:docMk/>
+            <pc:sldMk cId="721732568" sldId="298"/>
+            <ac:picMk id="4" creationId="{A9172708-06AB-AE7A-4BC0-05B1328EE700}"/>
+          </ac:picMkLst>
+        </pc:picChg>
+      </pc:sldChg>
+      <pc:sldChg chg="modSp mod">
+        <pc:chgData name="Tiago Janela" userId="ee1a79fe-c79c-4f34-9602-7f6f2f0482b3" providerId="ADAL" clId="{D59BA079-2D81-42B2-9E2D-198C5F90099E}" dt="2026-04-29T14:57:04.951" v="165" actId="20577"/>
+        <pc:sldMkLst>
+          <pc:docMk/>
+          <pc:sldMk cId="999010184" sldId="308"/>
+        </pc:sldMkLst>
+        <pc:spChg chg="mod">
+          <ac:chgData name="Tiago Janela" userId="ee1a79fe-c79c-4f34-9602-7f6f2f0482b3" providerId="ADAL" clId="{D59BA079-2D81-42B2-9E2D-198C5F90099E}" dt="2026-04-29T14:57:04.951" v="165" actId="20577"/>
+          <ac:spMkLst>
+            <pc:docMk/>
+            <pc:sldMk cId="999010184" sldId="308"/>
+            <ac:spMk id="2" creationId="{870990D0-7AC5-46BA-6FC4-274F8E0A3ABE}"/>
+          </ac:spMkLst>
+        </pc:spChg>
+      </pc:sldChg>
+      <pc:sldChg chg="mod modShow">
+        <pc:chgData name="Tiago Janela" userId="ee1a79fe-c79c-4f34-9602-7f6f2f0482b3" providerId="ADAL" clId="{D59BA079-2D81-42B2-9E2D-198C5F90099E}" dt="2026-04-29T14:47:27.062" v="156" actId="729"/>
+        <pc:sldMkLst>
+          <pc:docMk/>
+          <pc:sldMk cId="497639913" sldId="312"/>
+        </pc:sldMkLst>
+      </pc:sldChg>
+      <pc:sldChg chg="addSp delSp modSp add mod ord">
+        <pc:chgData name="Tiago Janela" userId="ee1a79fe-c79c-4f34-9602-7f6f2f0482b3" providerId="ADAL" clId="{D59BA079-2D81-42B2-9E2D-198C5F90099E}" dt="2026-04-29T14:47:28.386" v="158"/>
+        <pc:sldMkLst>
+          <pc:docMk/>
+          <pc:sldMk cId="3302856774" sldId="317"/>
+        </pc:sldMkLst>
+        <pc:spChg chg="add mod">
+          <ac:chgData name="Tiago Janela" userId="ee1a79fe-c79c-4f34-9602-7f6f2f0482b3" providerId="ADAL" clId="{D59BA079-2D81-42B2-9E2D-198C5F90099E}" dt="2026-04-29T14:39:49.159" v="28" actId="404"/>
+          <ac:spMkLst>
+            <pc:docMk/>
+            <pc:sldMk cId="3302856774" sldId="317"/>
+            <ac:spMk id="2" creationId="{9803C720-5E38-494F-5EED-73C1A8624CA2}"/>
+          </ac:spMkLst>
+        </pc:spChg>
+        <pc:spChg chg="mod">
+          <ac:chgData name="Tiago Janela" userId="ee1a79fe-c79c-4f34-9602-7f6f2f0482b3" providerId="ADAL" clId="{D59BA079-2D81-42B2-9E2D-198C5F90099E}" dt="2026-04-29T14:37:18.277" v="2"/>
+          <ac:spMkLst>
+            <pc:docMk/>
+            <pc:sldMk cId="3302856774" sldId="317"/>
+            <ac:spMk id="4" creationId="{29C55CA4-9FFE-F8C7-14D1-7771639D14E4}"/>
+          </ac:spMkLst>
+        </pc:spChg>
+        <pc:spChg chg="add mod">
+          <ac:chgData name="Tiago Janela" userId="ee1a79fe-c79c-4f34-9602-7f6f2f0482b3" providerId="ADAL" clId="{D59BA079-2D81-42B2-9E2D-198C5F90099E}" dt="2026-04-29T14:37:30.168" v="3" actId="164"/>
+          <ac:spMkLst>
+            <pc:docMk/>
+            <pc:sldMk cId="3302856774" sldId="317"/>
+            <ac:spMk id="7" creationId="{97128B13-4612-273D-93A3-BB4FE0ECD72E}"/>
+          </ac:spMkLst>
+        </pc:spChg>
+        <pc:spChg chg="add mod">
+          <ac:chgData name="Tiago Janela" userId="ee1a79fe-c79c-4f34-9602-7f6f2f0482b3" providerId="ADAL" clId="{D59BA079-2D81-42B2-9E2D-198C5F90099E}" dt="2026-04-29T14:39:51.630" v="29" actId="404"/>
+          <ac:spMkLst>
+            <pc:docMk/>
+            <pc:sldMk cId="3302856774" sldId="317"/>
+            <ac:spMk id="8" creationId="{BFA4F87D-A515-0617-5B19-E065DFAAA219}"/>
+          </ac:spMkLst>
+        </pc:spChg>
+        <pc:spChg chg="add mod">
+          <ac:chgData name="Tiago Janela" userId="ee1a79fe-c79c-4f34-9602-7f6f2f0482b3" providerId="ADAL" clId="{D59BA079-2D81-42B2-9E2D-198C5F90099E}" dt="2026-04-29T14:39:53.918" v="30" actId="404"/>
+          <ac:spMkLst>
+            <pc:docMk/>
+            <pc:sldMk cId="3302856774" sldId="317"/>
+            <ac:spMk id="9" creationId="{5B5E5C40-61E5-79E5-C05A-CA9180634650}"/>
+          </ac:spMkLst>
+        </pc:spChg>
+        <pc:spChg chg="add mod">
+          <ac:chgData name="Tiago Janela" userId="ee1a79fe-c79c-4f34-9602-7f6f2f0482b3" providerId="ADAL" clId="{D59BA079-2D81-42B2-9E2D-198C5F90099E}" dt="2026-04-29T14:37:30.168" v="3" actId="164"/>
+          <ac:spMkLst>
+            <pc:docMk/>
+            <pc:sldMk cId="3302856774" sldId="317"/>
+            <ac:spMk id="10" creationId="{A3301E51-4E33-A5C6-58D1-99F3B3249BC8}"/>
+          </ac:spMkLst>
+        </pc:spChg>
+        <pc:spChg chg="mod">
+          <ac:chgData name="Tiago Janela" userId="ee1a79fe-c79c-4f34-9602-7f6f2f0482b3" providerId="ADAL" clId="{D59BA079-2D81-42B2-9E2D-198C5F90099E}" dt="2026-04-29T14:37:57.832" v="16" actId="404"/>
+          <ac:spMkLst>
+            <pc:docMk/>
+            <pc:sldMk cId="3302856774" sldId="317"/>
+            <ac:spMk id="14" creationId="{52C02012-CF9D-7AF4-DB5E-4F719C94B012}"/>
+          </ac:spMkLst>
+        </pc:spChg>
+        <pc:spChg chg="mod">
+          <ac:chgData name="Tiago Janela" userId="ee1a79fe-c79c-4f34-9602-7f6f2f0482b3" providerId="ADAL" clId="{D59BA079-2D81-42B2-9E2D-198C5F90099E}" dt="2026-04-29T14:37:54.655" v="14" actId="404"/>
+          <ac:spMkLst>
+            <pc:docMk/>
+            <pc:sldMk cId="3302856774" sldId="317"/>
+            <ac:spMk id="17" creationId="{392DA2FC-B611-0481-11FA-589AFCCD6635}"/>
+          </ac:spMkLst>
+        </pc:spChg>
+        <pc:spChg chg="mod">
+          <ac:chgData name="Tiago Janela" userId="ee1a79fe-c79c-4f34-9602-7f6f2f0482b3" providerId="ADAL" clId="{D59BA079-2D81-42B2-9E2D-198C5F90099E}" dt="2026-04-29T14:42:14.331" v="134"/>
+          <ac:spMkLst>
+            <pc:docMk/>
+            <pc:sldMk cId="3302856774" sldId="317"/>
+            <ac:spMk id="22" creationId="{9CC3FB47-39F0-5B0D-9FE3-5C302988AB12}"/>
+          </ac:spMkLst>
+        </pc:spChg>
+        <pc:spChg chg="mod">
+          <ac:chgData name="Tiago Janela" userId="ee1a79fe-c79c-4f34-9602-7f6f2f0482b3" providerId="ADAL" clId="{D59BA079-2D81-42B2-9E2D-198C5F90099E}" dt="2026-04-29T14:42:14.331" v="134"/>
+          <ac:spMkLst>
+            <pc:docMk/>
+            <pc:sldMk cId="3302856774" sldId="317"/>
+            <ac:spMk id="24" creationId="{D4516D0B-2A98-E400-631F-146C1BCBCEC7}"/>
+          </ac:spMkLst>
+        </pc:spChg>
+        <pc:spChg chg="mod">
+          <ac:chgData name="Tiago Janela" userId="ee1a79fe-c79c-4f34-9602-7f6f2f0482b3" providerId="ADAL" clId="{D59BA079-2D81-42B2-9E2D-198C5F90099E}" dt="2026-04-29T14:42:14.331" v="134"/>
+          <ac:spMkLst>
+            <pc:docMk/>
+            <pc:sldMk cId="3302856774" sldId="317"/>
+            <ac:spMk id="27" creationId="{4BF8A661-D3F9-4D47-9A49-5561FB429D7F}"/>
+          </ac:spMkLst>
+        </pc:spChg>
+        <pc:spChg chg="mod">
+          <ac:chgData name="Tiago Janela" userId="ee1a79fe-c79c-4f34-9602-7f6f2f0482b3" providerId="ADAL" clId="{D59BA079-2D81-42B2-9E2D-198C5F90099E}" dt="2026-04-29T14:42:14.331" v="134"/>
+          <ac:spMkLst>
+            <pc:docMk/>
+            <pc:sldMk cId="3302856774" sldId="317"/>
+            <ac:spMk id="31" creationId="{44774A09-6C4B-273B-64E1-71CD435882F9}"/>
+          </ac:spMkLst>
+        </pc:spChg>
+        <pc:spChg chg="mod">
+          <ac:chgData name="Tiago Janela" userId="ee1a79fe-c79c-4f34-9602-7f6f2f0482b3" providerId="ADAL" clId="{D59BA079-2D81-42B2-9E2D-198C5F90099E}" dt="2026-04-29T14:42:14.331" v="134"/>
+          <ac:spMkLst>
+            <pc:docMk/>
+            <pc:sldMk cId="3302856774" sldId="317"/>
+            <ac:spMk id="33" creationId="{6622B3C1-0E2A-C553-0B73-EB0159100FA0}"/>
+          </ac:spMkLst>
+        </pc:spChg>
+        <pc:spChg chg="mod">
+          <ac:chgData name="Tiago Janela" userId="ee1a79fe-c79c-4f34-9602-7f6f2f0482b3" providerId="ADAL" clId="{D59BA079-2D81-42B2-9E2D-198C5F90099E}" dt="2026-04-29T14:42:14.331" v="134"/>
+          <ac:spMkLst>
+            <pc:docMk/>
+            <pc:sldMk cId="3302856774" sldId="317"/>
+            <ac:spMk id="36" creationId="{CA013FFA-B74D-DDEF-AD08-7B599268011E}"/>
+          </ac:spMkLst>
+        </pc:spChg>
+        <pc:spChg chg="mod">
+          <ac:chgData name="Tiago Janela" userId="ee1a79fe-c79c-4f34-9602-7f6f2f0482b3" providerId="ADAL" clId="{D59BA079-2D81-42B2-9E2D-198C5F90099E}" dt="2026-04-29T14:42:14.331" v="134"/>
+          <ac:spMkLst>
+            <pc:docMk/>
+            <pc:sldMk cId="3302856774" sldId="317"/>
+            <ac:spMk id="43" creationId="{E3A96CCB-CAB0-24CC-DA7A-8F66AABCC413}"/>
+          </ac:spMkLst>
+        </pc:spChg>
+        <pc:spChg chg="mod">
+          <ac:chgData name="Tiago Janela" userId="ee1a79fe-c79c-4f34-9602-7f6f2f0482b3" providerId="ADAL" clId="{D59BA079-2D81-42B2-9E2D-198C5F90099E}" dt="2026-04-29T14:42:14.331" v="134"/>
+          <ac:spMkLst>
+            <pc:docMk/>
+            <pc:sldMk cId="3302856774" sldId="317"/>
+            <ac:spMk id="48" creationId="{B76292A3-1097-26F8-291A-E16DB649542F}"/>
+          </ac:spMkLst>
+        </pc:spChg>
+        <pc:spChg chg="mod">
+          <ac:chgData name="Tiago Janela" userId="ee1a79fe-c79c-4f34-9602-7f6f2f0482b3" providerId="ADAL" clId="{D59BA079-2D81-42B2-9E2D-198C5F90099E}" dt="2026-04-29T14:42:57.418" v="138"/>
+          <ac:spMkLst>
+            <pc:docMk/>
+            <pc:sldMk cId="3302856774" sldId="317"/>
+            <ac:spMk id="52" creationId="{60CA6DF6-6A3C-EB5F-B0C1-931B63D4E833}"/>
+          </ac:spMkLst>
+        </pc:spChg>
+        <pc:spChg chg="mod">
+          <ac:chgData name="Tiago Janela" userId="ee1a79fe-c79c-4f34-9602-7f6f2f0482b3" providerId="ADAL" clId="{D59BA079-2D81-42B2-9E2D-198C5F90099E}" dt="2026-04-29T14:42:57.418" v="138"/>
+          <ac:spMkLst>
+            <pc:docMk/>
+            <pc:sldMk cId="3302856774" sldId="317"/>
+            <ac:spMk id="54" creationId="{31A4D069-120D-BD5C-8246-2FAD55A8EBC0}"/>
+          </ac:spMkLst>
+        </pc:spChg>
+        <pc:spChg chg="mod">
+          <ac:chgData name="Tiago Janela" userId="ee1a79fe-c79c-4f34-9602-7f6f2f0482b3" providerId="ADAL" clId="{D59BA079-2D81-42B2-9E2D-198C5F90099E}" dt="2026-04-29T14:42:57.418" v="138"/>
+          <ac:spMkLst>
+            <pc:docMk/>
+            <pc:sldMk cId="3302856774" sldId="317"/>
+            <ac:spMk id="57" creationId="{8A8C5BFC-C55D-6AB2-E369-A8B84D61F6E4}"/>
+          </ac:spMkLst>
+        </pc:spChg>
+        <pc:spChg chg="mod">
+          <ac:chgData name="Tiago Janela" userId="ee1a79fe-c79c-4f34-9602-7f6f2f0482b3" providerId="ADAL" clId="{D59BA079-2D81-42B2-9E2D-198C5F90099E}" dt="2026-04-29T14:42:57.418" v="138"/>
+          <ac:spMkLst>
+            <pc:docMk/>
+            <pc:sldMk cId="3302856774" sldId="317"/>
+            <ac:spMk id="61" creationId="{98352965-0265-CA6D-C6A6-29212BEA4C15}"/>
+          </ac:spMkLst>
+        </pc:spChg>
+        <pc:spChg chg="mod">
+          <ac:chgData name="Tiago Janela" userId="ee1a79fe-c79c-4f34-9602-7f6f2f0482b3" providerId="ADAL" clId="{D59BA079-2D81-42B2-9E2D-198C5F90099E}" dt="2026-04-29T14:42:57.418" v="138"/>
+          <ac:spMkLst>
+            <pc:docMk/>
+            <pc:sldMk cId="3302856774" sldId="317"/>
+            <ac:spMk id="63" creationId="{A392F33B-6C93-58AE-6C45-5B25938C50D8}"/>
+          </ac:spMkLst>
+        </pc:spChg>
+        <pc:spChg chg="mod">
+          <ac:chgData name="Tiago Janela" userId="ee1a79fe-c79c-4f34-9602-7f6f2f0482b3" providerId="ADAL" clId="{D59BA079-2D81-42B2-9E2D-198C5F90099E}" dt="2026-04-29T14:42:57.418" v="138"/>
+          <ac:spMkLst>
+            <pc:docMk/>
+            <pc:sldMk cId="3302856774" sldId="317"/>
+            <ac:spMk id="130" creationId="{A9AE43EA-80B3-40AE-568E-1635AA6D6A0C}"/>
+          </ac:spMkLst>
+        </pc:spChg>
+        <pc:spChg chg="mod">
+          <ac:chgData name="Tiago Janela" userId="ee1a79fe-c79c-4f34-9602-7f6f2f0482b3" providerId="ADAL" clId="{D59BA079-2D81-42B2-9E2D-198C5F90099E}" dt="2026-04-29T14:42:57.418" v="138"/>
+          <ac:spMkLst>
+            <pc:docMk/>
+            <pc:sldMk cId="3302856774" sldId="317"/>
+            <ac:spMk id="137" creationId="{697EABE1-46D8-0746-E245-58B587C3A93C}"/>
+          </ac:spMkLst>
+        </pc:spChg>
+        <pc:spChg chg="mod">
+          <ac:chgData name="Tiago Janela" userId="ee1a79fe-c79c-4f34-9602-7f6f2f0482b3" providerId="ADAL" clId="{D59BA079-2D81-42B2-9E2D-198C5F90099E}" dt="2026-04-29T14:42:57.418" v="138"/>
+          <ac:spMkLst>
+            <pc:docMk/>
+            <pc:sldMk cId="3302856774" sldId="317"/>
+            <ac:spMk id="142" creationId="{B652AC61-841B-D06B-43EB-A02027AE39AC}"/>
+          </ac:spMkLst>
+        </pc:spChg>
+        <pc:grpChg chg="add mod">
+          <ac:chgData name="Tiago Janela" userId="ee1a79fe-c79c-4f34-9602-7f6f2f0482b3" providerId="ADAL" clId="{D59BA079-2D81-42B2-9E2D-198C5F90099E}" dt="2026-04-29T14:37:30.168" v="3" actId="164"/>
+          <ac:grpSpMkLst>
+            <pc:docMk/>
+            <pc:sldMk cId="3302856774" sldId="317"/>
+            <ac:grpSpMk id="3" creationId="{98A01790-818B-0A8F-30E5-1112281C9B36}"/>
+          </ac:grpSpMkLst>
+        </pc:grpChg>
+        <pc:grpChg chg="add mod">
+          <ac:chgData name="Tiago Janela" userId="ee1a79fe-c79c-4f34-9602-7f6f2f0482b3" providerId="ADAL" clId="{D59BA079-2D81-42B2-9E2D-198C5F90099E}" dt="2026-04-29T14:37:30.168" v="3" actId="164"/>
+          <ac:grpSpMkLst>
+            <pc:docMk/>
+            <pc:sldMk cId="3302856774" sldId="317"/>
+            <ac:grpSpMk id="11" creationId="{40F85673-9AEE-ADD3-DCC6-1FAEC5F6565D}"/>
+          </ac:grpSpMkLst>
+        </pc:grpChg>
+        <pc:grpChg chg="add mod">
+          <ac:chgData name="Tiago Janela" userId="ee1a79fe-c79c-4f34-9602-7f6f2f0482b3" providerId="ADAL" clId="{D59BA079-2D81-42B2-9E2D-198C5F90099E}" dt="2026-04-29T14:37:30.168" v="3" actId="164"/>
+          <ac:grpSpMkLst>
+            <pc:docMk/>
+            <pc:sldMk cId="3302856774" sldId="317"/>
+            <ac:grpSpMk id="15" creationId="{2413F157-B8CA-D703-62EE-D4B833AB7125}"/>
+          </ac:grpSpMkLst>
+        </pc:grpChg>
+        <pc:grpChg chg="add del mod">
+          <ac:chgData name="Tiago Janela" userId="ee1a79fe-c79c-4f34-9602-7f6f2f0482b3" providerId="ADAL" clId="{D59BA079-2D81-42B2-9E2D-198C5F90099E}" dt="2026-04-29T14:43:11.891" v="143" actId="1036"/>
+          <ac:grpSpMkLst>
+            <pc:docMk/>
+            <pc:sldMk cId="3302856774" sldId="317"/>
+            <ac:grpSpMk id="20" creationId="{81A65B80-1110-F1AF-A893-8B82ECA10662}"/>
+          </ac:grpSpMkLst>
+        </pc:grpChg>
+        <pc:grpChg chg="add del mod">
+          <ac:chgData name="Tiago Janela" userId="ee1a79fe-c79c-4f34-9602-7f6f2f0482b3" providerId="ADAL" clId="{D59BA079-2D81-42B2-9E2D-198C5F90099E}" dt="2026-04-29T14:42:50.916" v="137" actId="478"/>
+          <ac:grpSpMkLst>
+            <pc:docMk/>
+            <pc:sldMk cId="3302856774" sldId="317"/>
+            <ac:grpSpMk id="21" creationId="{E76901E6-0AA2-A336-7D24-0C02B1DF5BE9}"/>
+          </ac:grpSpMkLst>
+        </pc:grpChg>
+        <pc:grpChg chg="mod">
+          <ac:chgData name="Tiago Janela" userId="ee1a79fe-c79c-4f34-9602-7f6f2f0482b3" providerId="ADAL" clId="{D59BA079-2D81-42B2-9E2D-198C5F90099E}" dt="2026-04-29T14:42:14.331" v="134"/>
+          <ac:grpSpMkLst>
+            <pc:docMk/>
+            <pc:sldMk cId="3302856774" sldId="317"/>
+            <ac:grpSpMk id="23" creationId="{9B222EA0-2467-6E91-A486-2373D1C9EE47}"/>
+          </ac:grpSpMkLst>
+        </pc:grpChg>
+        <pc:grpChg chg="mod">
+          <ac:chgData name="Tiago Janela" userId="ee1a79fe-c79c-4f34-9602-7f6f2f0482b3" providerId="ADAL" clId="{D59BA079-2D81-42B2-9E2D-198C5F90099E}" dt="2026-04-29T14:42:14.331" v="134"/>
+          <ac:grpSpMkLst>
+            <pc:docMk/>
+            <pc:sldMk cId="3302856774" sldId="317"/>
+            <ac:grpSpMk id="25" creationId="{4E9843BD-4512-2977-7CCC-61E40C412881}"/>
+          </ac:grpSpMkLst>
+        </pc:grpChg>
+        <pc:grpChg chg="mod">
+          <ac:chgData name="Tiago Janela" userId="ee1a79fe-c79c-4f34-9602-7f6f2f0482b3" providerId="ADAL" clId="{D59BA079-2D81-42B2-9E2D-198C5F90099E}" dt="2026-04-29T14:42:14.331" v="134"/>
+          <ac:grpSpMkLst>
+            <pc:docMk/>
+            <pc:sldMk cId="3302856774" sldId="317"/>
+            <ac:grpSpMk id="26" creationId="{BFAB994F-6FC4-00CE-F521-A4E3AD19D1B9}"/>
+          </ac:grpSpMkLst>
+        </pc:grpChg>
+        <pc:grpChg chg="mod">
+          <ac:chgData name="Tiago Janela" userId="ee1a79fe-c79c-4f34-9602-7f6f2f0482b3" providerId="ADAL" clId="{D59BA079-2D81-42B2-9E2D-198C5F90099E}" dt="2026-04-29T14:42:14.331" v="134"/>
+          <ac:grpSpMkLst>
+            <pc:docMk/>
+            <pc:sldMk cId="3302856774" sldId="317"/>
+            <ac:grpSpMk id="28" creationId="{6F0DCE0A-5641-FEB6-7594-1E91F7584750}"/>
+          </ac:grpSpMkLst>
+        </pc:grpChg>
+        <pc:grpChg chg="mod">
+          <ac:chgData name="Tiago Janela" userId="ee1a79fe-c79c-4f34-9602-7f6f2f0482b3" providerId="ADAL" clId="{D59BA079-2D81-42B2-9E2D-198C5F90099E}" dt="2026-04-29T14:42:14.331" v="134"/>
+          <ac:grpSpMkLst>
+            <pc:docMk/>
+            <pc:sldMk cId="3302856774" sldId="317"/>
+            <ac:grpSpMk id="29" creationId="{42387771-3D9F-24D8-0222-869AAC4FE230}"/>
+          </ac:grpSpMkLst>
+        </pc:grpChg>
+        <pc:grpChg chg="mod">
+          <ac:chgData name="Tiago Janela" userId="ee1a79fe-c79c-4f34-9602-7f6f2f0482b3" providerId="ADAL" clId="{D59BA079-2D81-42B2-9E2D-198C5F90099E}" dt="2026-04-29T14:42:14.331" v="134"/>
+          <ac:grpSpMkLst>
+            <pc:docMk/>
+            <pc:sldMk cId="3302856774" sldId="317"/>
+            <ac:grpSpMk id="34" creationId="{94A6386A-36AC-6D99-1B1A-D7A1B571D9E0}"/>
+          </ac:grpSpMkLst>
+        </pc:grpChg>
+        <pc:grpChg chg="mod">
+          <ac:chgData name="Tiago Janela" userId="ee1a79fe-c79c-4f34-9602-7f6f2f0482b3" providerId="ADAL" clId="{D59BA079-2D81-42B2-9E2D-198C5F90099E}" dt="2026-04-29T14:42:14.331" v="134"/>
+          <ac:grpSpMkLst>
+            <pc:docMk/>
+            <pc:sldMk cId="3302856774" sldId="317"/>
+            <ac:grpSpMk id="35" creationId="{B02AC1A3-27E6-6ABA-6C7B-50AC760E849C}"/>
+          </ac:grpSpMkLst>
+        </pc:grpChg>
+        <pc:grpChg chg="mod">
+          <ac:chgData name="Tiago Janela" userId="ee1a79fe-c79c-4f34-9602-7f6f2f0482b3" providerId="ADAL" clId="{D59BA079-2D81-42B2-9E2D-198C5F90099E}" dt="2026-04-29T14:42:14.331" v="134"/>
+          <ac:grpSpMkLst>
+            <pc:docMk/>
+            <pc:sldMk cId="3302856774" sldId="317"/>
+            <ac:grpSpMk id="41" creationId="{4E5A09CE-1CD6-D186-4A4D-58DA99ED176A}"/>
+          </ac:grpSpMkLst>
+        </pc:grpChg>
+        <pc:grpChg chg="mod">
+          <ac:chgData name="Tiago Janela" userId="ee1a79fe-c79c-4f34-9602-7f6f2f0482b3" providerId="ADAL" clId="{D59BA079-2D81-42B2-9E2D-198C5F90099E}" dt="2026-04-29T14:42:14.331" v="134"/>
+          <ac:grpSpMkLst>
+            <pc:docMk/>
+            <pc:sldMk cId="3302856774" sldId="317"/>
+            <ac:grpSpMk id="42" creationId="{F6CF8A19-29FE-85EA-6A0F-F0F0F244A9C3}"/>
+          </ac:grpSpMkLst>
+        </pc:grpChg>
+        <pc:grpChg chg="add del mod">
+          <ac:chgData name="Tiago Janela" userId="ee1a79fe-c79c-4f34-9602-7f6f2f0482b3" providerId="ADAL" clId="{D59BA079-2D81-42B2-9E2D-198C5F90099E}" dt="2026-04-29T14:43:00.950" v="139" actId="478"/>
+          <ac:grpSpMkLst>
+            <pc:docMk/>
+            <pc:sldMk cId="3302856774" sldId="317"/>
+            <ac:grpSpMk id="51" creationId="{42BD465A-122F-A8EC-9337-FEB1792B1BDF}"/>
+          </ac:grpSpMkLst>
+        </pc:grpChg>
+        <pc:grpChg chg="mod">
+          <ac:chgData name="Tiago Janela" userId="ee1a79fe-c79c-4f34-9602-7f6f2f0482b3" providerId="ADAL" clId="{D59BA079-2D81-42B2-9E2D-198C5F90099E}" dt="2026-04-29T14:42:57.418" v="138"/>
+          <ac:grpSpMkLst>
+            <pc:docMk/>
+            <pc:sldMk cId="3302856774" sldId="317"/>
+            <ac:grpSpMk id="53" creationId="{10DFA937-B03E-C395-932B-6931E43FAB28}"/>
+          </ac:grpSpMkLst>
+        </pc:grpChg>
+        <pc:grpChg chg="mod">
+          <ac:chgData name="Tiago Janela" userId="ee1a79fe-c79c-4f34-9602-7f6f2f0482b3" providerId="ADAL" clId="{D59BA079-2D81-42B2-9E2D-198C5F90099E}" dt="2026-04-29T14:42:57.418" v="138"/>
+          <ac:grpSpMkLst>
+            <pc:docMk/>
+            <pc:sldMk cId="3302856774" sldId="317"/>
+            <ac:grpSpMk id="55" creationId="{FBE245D5-B6B9-DC0C-CE09-9437236832FC}"/>
+          </ac:grpSpMkLst>
+        </pc:grpChg>
+        <pc:grpChg chg="mod">
+          <ac:chgData name="Tiago Janela" userId="ee1a79fe-c79c-4f34-9602-7f6f2f0482b3" providerId="ADAL" clId="{D59BA079-2D81-42B2-9E2D-198C5F90099E}" dt="2026-04-29T14:42:57.418" v="138"/>
+          <ac:grpSpMkLst>
+            <pc:docMk/>
+            <pc:sldMk cId="3302856774" sldId="317"/>
+            <ac:grpSpMk id="56" creationId="{5FEF2E16-74B4-316E-97A0-D3C78613EF1C}"/>
+          </ac:grpSpMkLst>
+        </pc:grpChg>
+        <pc:grpChg chg="mod">
+          <ac:chgData name="Tiago Janela" userId="ee1a79fe-c79c-4f34-9602-7f6f2f0482b3" providerId="ADAL" clId="{D59BA079-2D81-42B2-9E2D-198C5F90099E}" dt="2026-04-29T14:42:57.418" v="138"/>
+          <ac:grpSpMkLst>
+            <pc:docMk/>
+            <pc:sldMk cId="3302856774" sldId="317"/>
+            <ac:grpSpMk id="58" creationId="{AC6EF26A-1536-DB79-1625-187EA1E91A86}"/>
+          </ac:grpSpMkLst>
+        </pc:grpChg>
+        <pc:grpChg chg="mod">
+          <ac:chgData name="Tiago Janela" userId="ee1a79fe-c79c-4f34-9602-7f6f2f0482b3" providerId="ADAL" clId="{D59BA079-2D81-42B2-9E2D-198C5F90099E}" dt="2026-04-29T14:42:57.418" v="138"/>
+          <ac:grpSpMkLst>
+            <pc:docMk/>
+            <pc:sldMk cId="3302856774" sldId="317"/>
+            <ac:grpSpMk id="59" creationId="{CD6CFF60-9C4D-BE66-9802-569670A8A8B5}"/>
+          </ac:grpSpMkLst>
+        </pc:grpChg>
+        <pc:grpChg chg="mod">
+          <ac:chgData name="Tiago Janela" userId="ee1a79fe-c79c-4f34-9602-7f6f2f0482b3" providerId="ADAL" clId="{D59BA079-2D81-42B2-9E2D-198C5F90099E}" dt="2026-04-29T14:42:57.418" v="138"/>
+          <ac:grpSpMkLst>
+            <pc:docMk/>
+            <pc:sldMk cId="3302856774" sldId="317"/>
+            <ac:grpSpMk id="128" creationId="{5023F48A-74A8-8B3A-7CDE-822D6AF916AB}"/>
+          </ac:grpSpMkLst>
+        </pc:grpChg>
+        <pc:grpChg chg="mod">
+          <ac:chgData name="Tiago Janela" userId="ee1a79fe-c79c-4f34-9602-7f6f2f0482b3" providerId="ADAL" clId="{D59BA079-2D81-42B2-9E2D-198C5F90099E}" dt="2026-04-29T14:42:57.418" v="138"/>
+          <ac:grpSpMkLst>
+            <pc:docMk/>
+            <pc:sldMk cId="3302856774" sldId="317"/>
+            <ac:grpSpMk id="129" creationId="{6AE9F94F-0134-8D3E-564D-AF13DD06A9AA}"/>
+          </ac:grpSpMkLst>
+        </pc:grpChg>
+        <pc:grpChg chg="mod">
+          <ac:chgData name="Tiago Janela" userId="ee1a79fe-c79c-4f34-9602-7f6f2f0482b3" providerId="ADAL" clId="{D59BA079-2D81-42B2-9E2D-198C5F90099E}" dt="2026-04-29T14:42:57.418" v="138"/>
+          <ac:grpSpMkLst>
+            <pc:docMk/>
+            <pc:sldMk cId="3302856774" sldId="317"/>
+            <ac:grpSpMk id="135" creationId="{22DF0F80-4E5A-4C07-C819-A9FF2DA9A356}"/>
+          </ac:grpSpMkLst>
+        </pc:grpChg>
+        <pc:grpChg chg="mod">
+          <ac:chgData name="Tiago Janela" userId="ee1a79fe-c79c-4f34-9602-7f6f2f0482b3" providerId="ADAL" clId="{D59BA079-2D81-42B2-9E2D-198C5F90099E}" dt="2026-04-29T14:42:57.418" v="138"/>
+          <ac:grpSpMkLst>
+            <pc:docMk/>
+            <pc:sldMk cId="3302856774" sldId="317"/>
+            <ac:grpSpMk id="136" creationId="{25D4461D-AC2D-43D9-AA69-D94B5AEEFAF2}"/>
+          </ac:grpSpMkLst>
+        </pc:grpChg>
+        <pc:picChg chg="mod">
+          <ac:chgData name="Tiago Janela" userId="ee1a79fe-c79c-4f34-9602-7f6f2f0482b3" providerId="ADAL" clId="{D59BA079-2D81-42B2-9E2D-198C5F90099E}" dt="2026-04-29T14:37:18.277" v="2"/>
+          <ac:picMkLst>
+            <pc:docMk/>
+            <pc:sldMk cId="3302856774" sldId="317"/>
+            <ac:picMk id="5" creationId="{BC3098E3-543E-39F7-8A4E-3EA3BD9DACFE}"/>
+          </ac:picMkLst>
+        </pc:picChg>
+        <pc:picChg chg="mod">
+          <ac:chgData name="Tiago Janela" userId="ee1a79fe-c79c-4f34-9602-7f6f2f0482b3" providerId="ADAL" clId="{D59BA079-2D81-42B2-9E2D-198C5F90099E}" dt="2026-04-29T14:37:18.277" v="2"/>
+          <ac:picMkLst>
+            <pc:docMk/>
+            <pc:sldMk cId="3302856774" sldId="317"/>
+            <ac:picMk id="6" creationId="{A6C08A7B-D7B2-8D7E-7551-DA70599DDC7E}"/>
+          </ac:picMkLst>
+        </pc:picChg>
+        <pc:picChg chg="del">
+          <ac:chgData name="Tiago Janela" userId="ee1a79fe-c79c-4f34-9602-7f6f2f0482b3" providerId="ADAL" clId="{D59BA079-2D81-42B2-9E2D-198C5F90099E}" dt="2026-04-29T14:37:06.137" v="1" actId="478"/>
+          <ac:picMkLst>
+            <pc:docMk/>
+            <pc:sldMk cId="3302856774" sldId="317"/>
+            <ac:picMk id="12" creationId="{E40230FB-91FB-0DC9-7BD8-1BE8E2E79A66}"/>
+          </ac:picMkLst>
+        </pc:picChg>
+        <pc:picChg chg="add mod">
+          <ac:chgData name="Tiago Janela" userId="ee1a79fe-c79c-4f34-9602-7f6f2f0482b3" providerId="ADAL" clId="{D59BA079-2D81-42B2-9E2D-198C5F90099E}" dt="2026-04-29T14:37:30.168" v="3" actId="164"/>
+          <ac:picMkLst>
+            <pc:docMk/>
+            <pc:sldMk cId="3302856774" sldId="317"/>
+            <ac:picMk id="18" creationId="{B00FBE90-B9A0-71D7-78B9-0470979D39BB}"/>
+          </ac:picMkLst>
+        </pc:picChg>
+        <pc:picChg chg="add mod">
+          <ac:chgData name="Tiago Janela" userId="ee1a79fe-c79c-4f34-9602-7f6f2f0482b3" providerId="ADAL" clId="{D59BA079-2D81-42B2-9E2D-198C5F90099E}" dt="2026-04-29T14:37:30.168" v="3" actId="164"/>
+          <ac:picMkLst>
+            <pc:docMk/>
+            <pc:sldMk cId="3302856774" sldId="317"/>
+            <ac:picMk id="19" creationId="{8503AC68-78EB-31F3-DB36-6A64117ACE03}"/>
+          </ac:picMkLst>
+        </pc:picChg>
+        <pc:picChg chg="mod">
+          <ac:chgData name="Tiago Janela" userId="ee1a79fe-c79c-4f34-9602-7f6f2f0482b3" providerId="ADAL" clId="{D59BA079-2D81-42B2-9E2D-198C5F90099E}" dt="2026-04-29T14:42:14.331" v="134"/>
+          <ac:picMkLst>
+            <pc:docMk/>
+            <pc:sldMk cId="3302856774" sldId="317"/>
+            <ac:picMk id="37" creationId="{5A062627-B1F3-C462-7ADA-A705ABE7B6C9}"/>
+          </ac:picMkLst>
+        </pc:picChg>
+        <pc:picChg chg="mod">
+          <ac:chgData name="Tiago Janela" userId="ee1a79fe-c79c-4f34-9602-7f6f2f0482b3" providerId="ADAL" clId="{D59BA079-2D81-42B2-9E2D-198C5F90099E}" dt="2026-04-29T14:42:14.331" v="134"/>
+          <ac:picMkLst>
+            <pc:docMk/>
+            <pc:sldMk cId="3302856774" sldId="317"/>
+            <ac:picMk id="38" creationId="{79353257-7DC2-5C9B-EEB8-21904C964F3C}"/>
+          </ac:picMkLst>
+        </pc:picChg>
+        <pc:picChg chg="mod">
+          <ac:chgData name="Tiago Janela" userId="ee1a79fe-c79c-4f34-9602-7f6f2f0482b3" providerId="ADAL" clId="{D59BA079-2D81-42B2-9E2D-198C5F90099E}" dt="2026-04-29T14:42:14.331" v="134"/>
+          <ac:picMkLst>
+            <pc:docMk/>
+            <pc:sldMk cId="3302856774" sldId="317"/>
+            <ac:picMk id="39" creationId="{48AFFD95-0148-C55F-10A4-AD2331630B8C}"/>
+          </ac:picMkLst>
+        </pc:picChg>
+        <pc:picChg chg="mod">
+          <ac:chgData name="Tiago Janela" userId="ee1a79fe-c79c-4f34-9602-7f6f2f0482b3" providerId="ADAL" clId="{D59BA079-2D81-42B2-9E2D-198C5F90099E}" dt="2026-04-29T14:42:14.331" v="134"/>
+          <ac:picMkLst>
+            <pc:docMk/>
+            <pc:sldMk cId="3302856774" sldId="317"/>
+            <ac:picMk id="40" creationId="{05AC4806-6F86-A8B2-2E15-0EBAAD3ABE7B}"/>
+          </ac:picMkLst>
+        </pc:picChg>
+        <pc:picChg chg="mod">
+          <ac:chgData name="Tiago Janela" userId="ee1a79fe-c79c-4f34-9602-7f6f2f0482b3" providerId="ADAL" clId="{D59BA079-2D81-42B2-9E2D-198C5F90099E}" dt="2026-04-29T14:42:14.331" v="134"/>
+          <ac:picMkLst>
+            <pc:docMk/>
+            <pc:sldMk cId="3302856774" sldId="317"/>
+            <ac:picMk id="44" creationId="{729D28AB-18FE-2B67-0111-A7DB7B32B9CD}"/>
+          </ac:picMkLst>
+        </pc:picChg>
+        <pc:picChg chg="mod">
+          <ac:chgData name="Tiago Janela" userId="ee1a79fe-c79c-4f34-9602-7f6f2f0482b3" providerId="ADAL" clId="{D59BA079-2D81-42B2-9E2D-198C5F90099E}" dt="2026-04-29T14:42:14.331" v="134"/>
+          <ac:picMkLst>
+            <pc:docMk/>
+            <pc:sldMk cId="3302856774" sldId="317"/>
+            <ac:picMk id="45" creationId="{E10A6266-FE52-CC59-8FB1-FB3B6C6390E2}"/>
+          </ac:picMkLst>
+        </pc:picChg>
+        <pc:picChg chg="mod">
+          <ac:chgData name="Tiago Janela" userId="ee1a79fe-c79c-4f34-9602-7f6f2f0482b3" providerId="ADAL" clId="{D59BA079-2D81-42B2-9E2D-198C5F90099E}" dt="2026-04-29T14:42:14.331" v="134"/>
+          <ac:picMkLst>
+            <pc:docMk/>
+            <pc:sldMk cId="3302856774" sldId="317"/>
+            <ac:picMk id="46" creationId="{EE09EFDC-BBB3-FF5C-1B89-E9BE7CD3FD74}"/>
+          </ac:picMkLst>
+        </pc:picChg>
+        <pc:picChg chg="mod">
+          <ac:chgData name="Tiago Janela" userId="ee1a79fe-c79c-4f34-9602-7f6f2f0482b3" providerId="ADAL" clId="{D59BA079-2D81-42B2-9E2D-198C5F90099E}" dt="2026-04-29T14:42:14.331" v="134"/>
+          <ac:picMkLst>
+            <pc:docMk/>
+            <pc:sldMk cId="3302856774" sldId="317"/>
+            <ac:picMk id="47" creationId="{40CEBF56-5969-CEB0-9ABA-D55A18510E41}"/>
+          </ac:picMkLst>
+        </pc:picChg>
+        <pc:picChg chg="mod">
+          <ac:chgData name="Tiago Janela" userId="ee1a79fe-c79c-4f34-9602-7f6f2f0482b3" providerId="ADAL" clId="{D59BA079-2D81-42B2-9E2D-198C5F90099E}" dt="2026-04-29T14:42:14.331" v="134"/>
+          <ac:picMkLst>
+            <pc:docMk/>
+            <pc:sldMk cId="3302856774" sldId="317"/>
+            <ac:picMk id="49" creationId="{ACE533E9-FD22-5418-4406-30971C1189F3}"/>
+          </ac:picMkLst>
+        </pc:picChg>
+        <pc:picChg chg="mod">
+          <ac:chgData name="Tiago Janela" userId="ee1a79fe-c79c-4f34-9602-7f6f2f0482b3" providerId="ADAL" clId="{D59BA079-2D81-42B2-9E2D-198C5F90099E}" dt="2026-04-29T14:42:14.331" v="134"/>
+          <ac:picMkLst>
+            <pc:docMk/>
+            <pc:sldMk cId="3302856774" sldId="317"/>
+            <ac:picMk id="50" creationId="{86A59E1C-C71E-1F73-DFE8-35344EDC0E18}"/>
+          </ac:picMkLst>
+        </pc:picChg>
+        <pc:picChg chg="mod">
+          <ac:chgData name="Tiago Janela" userId="ee1a79fe-c79c-4f34-9602-7f6f2f0482b3" providerId="ADAL" clId="{D59BA079-2D81-42B2-9E2D-198C5F90099E}" dt="2026-04-29T14:42:57.418" v="138"/>
+          <ac:picMkLst>
+            <pc:docMk/>
+            <pc:sldMk cId="3302856774" sldId="317"/>
+            <ac:picMk id="131" creationId="{548E2493-2B00-8053-2961-3DB8BF281F8A}"/>
+          </ac:picMkLst>
+        </pc:picChg>
+        <pc:picChg chg="mod">
+          <ac:chgData name="Tiago Janela" userId="ee1a79fe-c79c-4f34-9602-7f6f2f0482b3" providerId="ADAL" clId="{D59BA079-2D81-42B2-9E2D-198C5F90099E}" dt="2026-04-29T14:42:57.418" v="138"/>
+          <ac:picMkLst>
+            <pc:docMk/>
+            <pc:sldMk cId="3302856774" sldId="317"/>
+            <ac:picMk id="132" creationId="{352C41BE-E6C8-EE00-56D8-58664D1003C9}"/>
+          </ac:picMkLst>
+        </pc:picChg>
+        <pc:picChg chg="mod">
+          <ac:chgData name="Tiago Janela" userId="ee1a79fe-c79c-4f34-9602-7f6f2f0482b3" providerId="ADAL" clId="{D59BA079-2D81-42B2-9E2D-198C5F90099E}" dt="2026-04-29T14:42:57.418" v="138"/>
+          <ac:picMkLst>
+            <pc:docMk/>
+            <pc:sldMk cId="3302856774" sldId="317"/>
+            <ac:picMk id="133" creationId="{26C4696E-7AE5-1D45-A539-5FB36DB93C67}"/>
+          </ac:picMkLst>
+        </pc:picChg>
+        <pc:picChg chg="mod">
+          <ac:chgData name="Tiago Janela" userId="ee1a79fe-c79c-4f34-9602-7f6f2f0482b3" providerId="ADAL" clId="{D59BA079-2D81-42B2-9E2D-198C5F90099E}" dt="2026-04-29T14:42:57.418" v="138"/>
+          <ac:picMkLst>
+            <pc:docMk/>
+            <pc:sldMk cId="3302856774" sldId="317"/>
+            <ac:picMk id="134" creationId="{B79D68F7-04EA-0BE9-53D3-FBE7BB88272D}"/>
+          </ac:picMkLst>
+        </pc:picChg>
+        <pc:picChg chg="mod">
+          <ac:chgData name="Tiago Janela" userId="ee1a79fe-c79c-4f34-9602-7f6f2f0482b3" providerId="ADAL" clId="{D59BA079-2D81-42B2-9E2D-198C5F90099E}" dt="2026-04-29T14:42:57.418" v="138"/>
+          <ac:picMkLst>
+            <pc:docMk/>
+            <pc:sldMk cId="3302856774" sldId="317"/>
+            <ac:picMk id="138" creationId="{15E7A7FC-F84F-3F84-7B69-556CB5BB8D4A}"/>
+          </ac:picMkLst>
+        </pc:picChg>
+        <pc:picChg chg="mod">
+          <ac:chgData name="Tiago Janela" userId="ee1a79fe-c79c-4f34-9602-7f6f2f0482b3" providerId="ADAL" clId="{D59BA079-2D81-42B2-9E2D-198C5F90099E}" dt="2026-04-29T14:42:57.418" v="138"/>
+          <ac:picMkLst>
+            <pc:docMk/>
+            <pc:sldMk cId="3302856774" sldId="317"/>
+            <ac:picMk id="139" creationId="{4577094C-3548-3D19-8E9B-03EE616373EE}"/>
+          </ac:picMkLst>
+        </pc:picChg>
+        <pc:picChg chg="mod">
+          <ac:chgData name="Tiago Janela" userId="ee1a79fe-c79c-4f34-9602-7f6f2f0482b3" providerId="ADAL" clId="{D59BA079-2D81-42B2-9E2D-198C5F90099E}" dt="2026-04-29T14:42:57.418" v="138"/>
+          <ac:picMkLst>
+            <pc:docMk/>
+            <pc:sldMk cId="3302856774" sldId="317"/>
+            <ac:picMk id="140" creationId="{69AF3AF4-DF25-CD3C-EE20-C34C06D80285}"/>
+          </ac:picMkLst>
+        </pc:picChg>
+        <pc:picChg chg="mod">
+          <ac:chgData name="Tiago Janela" userId="ee1a79fe-c79c-4f34-9602-7f6f2f0482b3" providerId="ADAL" clId="{D59BA079-2D81-42B2-9E2D-198C5F90099E}" dt="2026-04-29T14:42:57.418" v="138"/>
+          <ac:picMkLst>
+            <pc:docMk/>
+            <pc:sldMk cId="3302856774" sldId="317"/>
+            <ac:picMk id="141" creationId="{984FA4EB-2B6B-71D9-0BCE-6CE238247E34}"/>
+          </ac:picMkLst>
+        </pc:picChg>
+        <pc:picChg chg="mod">
+          <ac:chgData name="Tiago Janela" userId="ee1a79fe-c79c-4f34-9602-7f6f2f0482b3" providerId="ADAL" clId="{D59BA079-2D81-42B2-9E2D-198C5F90099E}" dt="2026-04-29T14:42:57.418" v="138"/>
+          <ac:picMkLst>
+            <pc:docMk/>
+            <pc:sldMk cId="3302856774" sldId="317"/>
+            <ac:picMk id="143" creationId="{5B2AAD25-27B9-BD60-6444-A51217E4BE2C}"/>
+          </ac:picMkLst>
+        </pc:picChg>
+        <pc:picChg chg="mod">
+          <ac:chgData name="Tiago Janela" userId="ee1a79fe-c79c-4f34-9602-7f6f2f0482b3" providerId="ADAL" clId="{D59BA079-2D81-42B2-9E2D-198C5F90099E}" dt="2026-04-29T14:42:57.418" v="138"/>
+          <ac:picMkLst>
+            <pc:docMk/>
+            <pc:sldMk cId="3302856774" sldId="317"/>
+            <ac:picMk id="144" creationId="{57D8D600-D195-B782-38BF-874E9B51B19C}"/>
+          </ac:picMkLst>
+        </pc:picChg>
+        <pc:cxnChg chg="mod">
+          <ac:chgData name="Tiago Janela" userId="ee1a79fe-c79c-4f34-9602-7f6f2f0482b3" providerId="ADAL" clId="{D59BA079-2D81-42B2-9E2D-198C5F90099E}" dt="2026-04-29T14:37:18.277" v="2"/>
+          <ac:cxnSpMkLst>
+            <pc:docMk/>
+            <pc:sldMk cId="3302856774" sldId="317"/>
+            <ac:cxnSpMk id="13" creationId="{D7F471AB-B13A-E0F6-8895-3D2EF3A9C1DF}"/>
+          </ac:cxnSpMkLst>
+        </pc:cxnChg>
+        <pc:cxnChg chg="mod">
+          <ac:chgData name="Tiago Janela" userId="ee1a79fe-c79c-4f34-9602-7f6f2f0482b3" providerId="ADAL" clId="{D59BA079-2D81-42B2-9E2D-198C5F90099E}" dt="2026-04-29T14:37:18.277" v="2"/>
+          <ac:cxnSpMkLst>
+            <pc:docMk/>
+            <pc:sldMk cId="3302856774" sldId="317"/>
+            <ac:cxnSpMk id="16" creationId="{E191783D-2D08-3AAC-2FF0-E2EC291F5384}"/>
+          </ac:cxnSpMkLst>
+        </pc:cxnChg>
+        <pc:cxnChg chg="mod">
+          <ac:chgData name="Tiago Janela" userId="ee1a79fe-c79c-4f34-9602-7f6f2f0482b3" providerId="ADAL" clId="{D59BA079-2D81-42B2-9E2D-198C5F90099E}" dt="2026-04-29T14:42:14.331" v="134"/>
+          <ac:cxnSpMkLst>
+            <pc:docMk/>
+            <pc:sldMk cId="3302856774" sldId="317"/>
+            <ac:cxnSpMk id="30" creationId="{65D80343-978C-867C-3E50-EB8FF1F7E265}"/>
+          </ac:cxnSpMkLst>
+        </pc:cxnChg>
+        <pc:cxnChg chg="mod">
+          <ac:chgData name="Tiago Janela" userId="ee1a79fe-c79c-4f34-9602-7f6f2f0482b3" providerId="ADAL" clId="{D59BA079-2D81-42B2-9E2D-198C5F90099E}" dt="2026-04-29T14:42:14.331" v="134"/>
+          <ac:cxnSpMkLst>
+            <pc:docMk/>
+            <pc:sldMk cId="3302856774" sldId="317"/>
+            <ac:cxnSpMk id="32" creationId="{F6765A01-FE27-3553-571D-FB9EE495DE11}"/>
+          </ac:cxnSpMkLst>
+        </pc:cxnChg>
+        <pc:cxnChg chg="mod">
+          <ac:chgData name="Tiago Janela" userId="ee1a79fe-c79c-4f34-9602-7f6f2f0482b3" providerId="ADAL" clId="{D59BA079-2D81-42B2-9E2D-198C5F90099E}" dt="2026-04-29T14:42:57.418" v="138"/>
+          <ac:cxnSpMkLst>
+            <pc:docMk/>
+            <pc:sldMk cId="3302856774" sldId="317"/>
+            <ac:cxnSpMk id="60" creationId="{28C09AA9-08C7-6E67-BCF9-29634E3479EE}"/>
+          </ac:cxnSpMkLst>
+        </pc:cxnChg>
+        <pc:cxnChg chg="mod">
+          <ac:chgData name="Tiago Janela" userId="ee1a79fe-c79c-4f34-9602-7f6f2f0482b3" providerId="ADAL" clId="{D59BA079-2D81-42B2-9E2D-198C5F90099E}" dt="2026-04-29T14:42:57.418" v="138"/>
+          <ac:cxnSpMkLst>
+            <pc:docMk/>
+            <pc:sldMk cId="3302856774" sldId="317"/>
+            <ac:cxnSpMk id="62" creationId="{82F0C898-A210-87B4-4E25-01F327E73B76}"/>
+          </ac:cxnSpMkLst>
+        </pc:cxnChg>
+      </pc:sldChg>
+      <pc:sldChg chg="addSp delSp modSp add mod ord">
+        <pc:chgData name="Tiago Janela" userId="ee1a79fe-c79c-4f34-9602-7f6f2f0482b3" providerId="ADAL" clId="{D59BA079-2D81-42B2-9E2D-198C5F90099E}" dt="2026-04-29T14:47:30.153" v="160"/>
+        <pc:sldMkLst>
+          <pc:docMk/>
+          <pc:sldMk cId="3463339464" sldId="318"/>
+        </pc:sldMkLst>
+        <pc:spChg chg="add mod">
+          <ac:chgData name="Tiago Janela" userId="ee1a79fe-c79c-4f34-9602-7f6f2f0482b3" providerId="ADAL" clId="{D59BA079-2D81-42B2-9E2D-198C5F90099E}" dt="2026-04-29T14:40:20.758" v="35" actId="404"/>
+          <ac:spMkLst>
+            <pc:docMk/>
+            <pc:sldMk cId="3463339464" sldId="318"/>
+            <ac:spMk id="12" creationId="{84F2BFB3-8FF2-554F-E79D-F8FED4C6DB14}"/>
+          </ac:spMkLst>
+        </pc:spChg>
+        <pc:spChg chg="mod">
+          <ac:chgData name="Tiago Janela" userId="ee1a79fe-c79c-4f34-9602-7f6f2f0482b3" providerId="ADAL" clId="{D59BA079-2D81-42B2-9E2D-198C5F90099E}" dt="2026-04-29T14:39:06.477" v="20"/>
+          <ac:spMkLst>
+            <pc:docMk/>
+            <pc:sldMk cId="3463339464" sldId="318"/>
+            <ac:spMk id="22" creationId="{6A221BB0-FFBC-E869-34CB-BC594E5B0490}"/>
+          </ac:spMkLst>
+        </pc:spChg>
+        <pc:spChg chg="add mod">
+          <ac:chgData name="Tiago Janela" userId="ee1a79fe-c79c-4f34-9602-7f6f2f0482b3" providerId="ADAL" clId="{D59BA079-2D81-42B2-9E2D-198C5F90099E}" dt="2026-04-29T14:39:08.519" v="21" actId="164"/>
+          <ac:spMkLst>
+            <pc:docMk/>
+            <pc:sldMk cId="3463339464" sldId="318"/>
+            <ac:spMk id="25" creationId="{8E792690-D447-952D-A5E7-853CC5FB33BB}"/>
+          </ac:spMkLst>
+        </pc:spChg>
+        <pc:spChg chg="mod">
+          <ac:chgData name="Tiago Janela" userId="ee1a79fe-c79c-4f34-9602-7f6f2f0482b3" providerId="ADAL" clId="{D59BA079-2D81-42B2-9E2D-198C5F90099E}" dt="2026-04-29T14:40:23.702" v="36" actId="404"/>
+          <ac:spMkLst>
+            <pc:docMk/>
+            <pc:sldMk cId="3463339464" sldId="318"/>
+            <ac:spMk id="29" creationId="{50EF08DE-650D-84D8-23E2-83CD379C9565}"/>
+          </ac:spMkLst>
+        </pc:spChg>
+        <pc:spChg chg="mod">
+          <ac:chgData name="Tiago Janela" userId="ee1a79fe-c79c-4f34-9602-7f6f2f0482b3" providerId="ADAL" clId="{D59BA079-2D81-42B2-9E2D-198C5F90099E}" dt="2026-04-29T14:40:26.534" v="37" actId="404"/>
+          <ac:spMkLst>
+            <pc:docMk/>
+            <pc:sldMk cId="3463339464" sldId="318"/>
+            <ac:spMk id="37" creationId="{A9B538AC-1716-FEE9-9303-C64FEB3A2571}"/>
+          </ac:spMkLst>
+        </pc:spChg>
+        <pc:spChg chg="add mod">
+          <ac:chgData name="Tiago Janela" userId="ee1a79fe-c79c-4f34-9602-7f6f2f0482b3" providerId="ADAL" clId="{D59BA079-2D81-42B2-9E2D-198C5F90099E}" dt="2026-04-29T14:39:08.519" v="21" actId="164"/>
+          <ac:spMkLst>
+            <pc:docMk/>
+            <pc:sldMk cId="3463339464" sldId="318"/>
+            <ac:spMk id="42" creationId="{666A450C-D0FA-4FC2-D779-9D8A47EBECE0}"/>
+          </ac:spMkLst>
+        </pc:spChg>
+        <pc:spChg chg="mod">
+          <ac:chgData name="Tiago Janela" userId="ee1a79fe-c79c-4f34-9602-7f6f2f0482b3" providerId="ADAL" clId="{D59BA079-2D81-42B2-9E2D-198C5F90099E}" dt="2026-04-29T14:40:39.373" v="41" actId="404"/>
+          <ac:spMkLst>
+            <pc:docMk/>
+            <pc:sldMk cId="3463339464" sldId="318"/>
+            <ac:spMk id="45" creationId="{092CB276-0083-7B65-2724-8B06427E812A}"/>
+          </ac:spMkLst>
+        </pc:spChg>
+        <pc:spChg chg="mod">
+          <ac:chgData name="Tiago Janela" userId="ee1a79fe-c79c-4f34-9602-7f6f2f0482b3" providerId="ADAL" clId="{D59BA079-2D81-42B2-9E2D-198C5F90099E}" dt="2026-04-29T14:40:43.670" v="43" actId="404"/>
+          <ac:spMkLst>
+            <pc:docMk/>
+            <pc:sldMk cId="3463339464" sldId="318"/>
+            <ac:spMk id="48" creationId="{89DB2597-89D3-3163-87C9-9AC4C1B4C236}"/>
+          </ac:spMkLst>
+        </pc:spChg>
+        <pc:spChg chg="mod">
+          <ac:chgData name="Tiago Janela" userId="ee1a79fe-c79c-4f34-9602-7f6f2f0482b3" providerId="ADAL" clId="{D59BA079-2D81-42B2-9E2D-198C5F90099E}" dt="2026-04-29T14:41:05.450" v="44"/>
+          <ac:spMkLst>
+            <pc:docMk/>
+            <pc:sldMk cId="3463339464" sldId="318"/>
+            <ac:spMk id="51" creationId="{28DD0ECA-8E37-B8B9-0418-38420611096E}"/>
+          </ac:spMkLst>
+        </pc:spChg>
+        <pc:spChg chg="mod">
+          <ac:chgData name="Tiago Janela" userId="ee1a79fe-c79c-4f34-9602-7f6f2f0482b3" providerId="ADAL" clId="{D59BA079-2D81-42B2-9E2D-198C5F90099E}" dt="2026-04-29T14:41:05.450" v="44"/>
+          <ac:spMkLst>
+            <pc:docMk/>
+            <pc:sldMk cId="3463339464" sldId="318"/>
+            <ac:spMk id="53" creationId="{68B48C07-97A0-A5E0-0196-8F9A0D2196A0}"/>
+          </ac:spMkLst>
+        </pc:spChg>
+        <pc:spChg chg="mod">
+          <ac:chgData name="Tiago Janela" userId="ee1a79fe-c79c-4f34-9602-7f6f2f0482b3" providerId="ADAL" clId="{D59BA079-2D81-42B2-9E2D-198C5F90099E}" dt="2026-04-29T14:41:05.450" v="44"/>
+          <ac:spMkLst>
+            <pc:docMk/>
+            <pc:sldMk cId="3463339464" sldId="318"/>
+            <ac:spMk id="54" creationId="{208860F7-EFE8-FE26-053D-F361E5EC7D7E}"/>
+          </ac:spMkLst>
+        </pc:spChg>
+        <pc:spChg chg="mod">
+          <ac:chgData name="Tiago Janela" userId="ee1a79fe-c79c-4f34-9602-7f6f2f0482b3" providerId="ADAL" clId="{D59BA079-2D81-42B2-9E2D-198C5F90099E}" dt="2026-04-29T14:41:05.450" v="44"/>
+          <ac:spMkLst>
+            <pc:docMk/>
+            <pc:sldMk cId="3463339464" sldId="318"/>
+            <ac:spMk id="55" creationId="{2103C611-4C9C-5D35-F98A-38EA5A46DAEE}"/>
+          </ac:spMkLst>
+        </pc:spChg>
+        <pc:spChg chg="mod">
+          <ac:chgData name="Tiago Janela" userId="ee1a79fe-c79c-4f34-9602-7f6f2f0482b3" providerId="ADAL" clId="{D59BA079-2D81-42B2-9E2D-198C5F90099E}" dt="2026-04-29T14:41:05.450" v="44"/>
+          <ac:spMkLst>
+            <pc:docMk/>
+            <pc:sldMk cId="3463339464" sldId="318"/>
+            <ac:spMk id="56" creationId="{90D266F1-FB12-E36F-173D-2B140D4BDCB1}"/>
+          </ac:spMkLst>
+        </pc:spChg>
+        <pc:spChg chg="mod">
+          <ac:chgData name="Tiago Janela" userId="ee1a79fe-c79c-4f34-9602-7f6f2f0482b3" providerId="ADAL" clId="{D59BA079-2D81-42B2-9E2D-198C5F90099E}" dt="2026-04-29T14:41:05.450" v="44"/>
+          <ac:spMkLst>
+            <pc:docMk/>
+            <pc:sldMk cId="3463339464" sldId="318"/>
+            <ac:spMk id="62" creationId="{9B20C80F-F64A-D047-2D22-BDE06D682B1D}"/>
+          </ac:spMkLst>
+        </pc:spChg>
+        <pc:spChg chg="mod">
+          <ac:chgData name="Tiago Janela" userId="ee1a79fe-c79c-4f34-9602-7f6f2f0482b3" providerId="ADAL" clId="{D59BA079-2D81-42B2-9E2D-198C5F90099E}" dt="2026-04-29T14:41:05.450" v="44"/>
+          <ac:spMkLst>
+            <pc:docMk/>
+            <pc:sldMk cId="3463339464" sldId="318"/>
+            <ac:spMk id="128" creationId="{06F0AD43-E1A7-F265-A6E7-B1C848095C75}"/>
+          </ac:spMkLst>
+        </pc:spChg>
+        <pc:spChg chg="mod">
+          <ac:chgData name="Tiago Janela" userId="ee1a79fe-c79c-4f34-9602-7f6f2f0482b3" providerId="ADAL" clId="{D59BA079-2D81-42B2-9E2D-198C5F90099E}" dt="2026-04-29T14:41:05.450" v="44"/>
+          <ac:spMkLst>
+            <pc:docMk/>
+            <pc:sldMk cId="3463339464" sldId="318"/>
+            <ac:spMk id="129" creationId="{34B7B117-4F98-E52D-CB56-DB4F6D143C5C}"/>
+          </ac:spMkLst>
+        </pc:spChg>
+        <pc:spChg chg="mod">
+          <ac:chgData name="Tiago Janela" userId="ee1a79fe-c79c-4f34-9602-7f6f2f0482b3" providerId="ADAL" clId="{D59BA079-2D81-42B2-9E2D-198C5F90099E}" dt="2026-04-29T14:41:35.971" v="129"/>
+          <ac:spMkLst>
+            <pc:docMk/>
+            <pc:sldMk cId="3463339464" sldId="318"/>
+            <ac:spMk id="133" creationId="{89106357-4BD4-E213-5F88-E69A238FD305}"/>
+          </ac:spMkLst>
+        </pc:spChg>
+        <pc:spChg chg="mod">
+          <ac:chgData name="Tiago Janela" userId="ee1a79fe-c79c-4f34-9602-7f6f2f0482b3" providerId="ADAL" clId="{D59BA079-2D81-42B2-9E2D-198C5F90099E}" dt="2026-04-29T14:41:35.971" v="129"/>
+          <ac:spMkLst>
+            <pc:docMk/>
+            <pc:sldMk cId="3463339464" sldId="318"/>
+            <ac:spMk id="135" creationId="{B829107F-5E5C-3E2A-9E4F-520B53D3BEDC}"/>
+          </ac:spMkLst>
+        </pc:spChg>
+        <pc:spChg chg="mod">
+          <ac:chgData name="Tiago Janela" userId="ee1a79fe-c79c-4f34-9602-7f6f2f0482b3" providerId="ADAL" clId="{D59BA079-2D81-42B2-9E2D-198C5F90099E}" dt="2026-04-29T14:41:35.971" v="129"/>
+          <ac:spMkLst>
+            <pc:docMk/>
+            <pc:sldMk cId="3463339464" sldId="318"/>
+            <ac:spMk id="136" creationId="{A4F65601-106E-8065-3458-BB8532110E46}"/>
+          </ac:spMkLst>
+        </pc:spChg>
+        <pc:spChg chg="mod">
+          <ac:chgData name="Tiago Janela" userId="ee1a79fe-c79c-4f34-9602-7f6f2f0482b3" providerId="ADAL" clId="{D59BA079-2D81-42B2-9E2D-198C5F90099E}" dt="2026-04-29T14:41:35.971" v="129"/>
+          <ac:spMkLst>
+            <pc:docMk/>
+            <pc:sldMk cId="3463339464" sldId="318"/>
+            <ac:spMk id="137" creationId="{77093375-B44E-C5DC-ACAB-C7C9B1A2DB3F}"/>
+          </ac:spMkLst>
+        </pc:spChg>
+        <pc:spChg chg="mod">
+          <ac:chgData name="Tiago Janela" userId="ee1a79fe-c79c-4f34-9602-7f6f2f0482b3" providerId="ADAL" clId="{D59BA079-2D81-42B2-9E2D-198C5F90099E}" dt="2026-04-29T14:41:35.971" v="129"/>
+          <ac:spMkLst>
+            <pc:docMk/>
+            <pc:sldMk cId="3463339464" sldId="318"/>
+            <ac:spMk id="138" creationId="{57B8DB79-D5DA-C9F8-4D80-37707F255543}"/>
+          </ac:spMkLst>
+        </pc:spChg>
+        <pc:spChg chg="mod">
+          <ac:chgData name="Tiago Janela" userId="ee1a79fe-c79c-4f34-9602-7f6f2f0482b3" providerId="ADAL" clId="{D59BA079-2D81-42B2-9E2D-198C5F90099E}" dt="2026-04-29T14:41:35.971" v="129"/>
+          <ac:spMkLst>
+            <pc:docMk/>
+            <pc:sldMk cId="3463339464" sldId="318"/>
+            <ac:spMk id="144" creationId="{BBFE61C1-30F9-7A9B-A5ED-945AB26263C7}"/>
+          </ac:spMkLst>
+        </pc:spChg>
+        <pc:spChg chg="mod">
+          <ac:chgData name="Tiago Janela" userId="ee1a79fe-c79c-4f34-9602-7f6f2f0482b3" providerId="ADAL" clId="{D59BA079-2D81-42B2-9E2D-198C5F90099E}" dt="2026-04-29T14:41:35.971" v="129"/>
+          <ac:spMkLst>
+            <pc:docMk/>
+            <pc:sldMk cId="3463339464" sldId="318"/>
+            <ac:spMk id="146" creationId="{8B4C8C75-2AC9-CCA5-FFEA-E8FFE77233AB}"/>
+          </ac:spMkLst>
+        </pc:spChg>
+        <pc:spChg chg="mod">
+          <ac:chgData name="Tiago Janela" userId="ee1a79fe-c79c-4f34-9602-7f6f2f0482b3" providerId="ADAL" clId="{D59BA079-2D81-42B2-9E2D-198C5F90099E}" dt="2026-04-29T14:41:35.971" v="129"/>
+          <ac:spMkLst>
+            <pc:docMk/>
+            <pc:sldMk cId="3463339464" sldId="318"/>
+            <ac:spMk id="147" creationId="{4F3F7314-C4FE-D90A-40CE-8AB2AF92E07D}"/>
+          </ac:spMkLst>
+        </pc:spChg>
+        <pc:spChg chg="mod">
+          <ac:chgData name="Tiago Janela" userId="ee1a79fe-c79c-4f34-9602-7f6f2f0482b3" providerId="ADAL" clId="{D59BA079-2D81-42B2-9E2D-198C5F90099E}" dt="2026-04-29T14:43:18.457" v="144"/>
+          <ac:spMkLst>
+            <pc:docMk/>
+            <pc:sldMk cId="3463339464" sldId="318"/>
+            <ac:spMk id="151" creationId="{642F2191-AE11-A105-A28D-1F95B6A96892}"/>
+          </ac:spMkLst>
+        </pc:spChg>
+        <pc:spChg chg="mod">
+          <ac:chgData name="Tiago Janela" userId="ee1a79fe-c79c-4f34-9602-7f6f2f0482b3" providerId="ADAL" clId="{D59BA079-2D81-42B2-9E2D-198C5F90099E}" dt="2026-04-29T14:43:18.457" v="144"/>
+          <ac:spMkLst>
+            <pc:docMk/>
+            <pc:sldMk cId="3463339464" sldId="318"/>
+            <ac:spMk id="153" creationId="{9FC20A8D-A898-3943-9340-FFE9261F04B4}"/>
+          </ac:spMkLst>
+        </pc:spChg>
+        <pc:spChg chg="mod">
+          <ac:chgData name="Tiago Janela" userId="ee1a79fe-c79c-4f34-9602-7f6f2f0482b3" providerId="ADAL" clId="{D59BA079-2D81-42B2-9E2D-198C5F90099E}" dt="2026-04-29T14:43:46.109" v="154" actId="1076"/>
+          <ac:spMkLst>
+            <pc:docMk/>
+            <pc:sldMk cId="3463339464" sldId="318"/>
+            <ac:spMk id="154" creationId="{B75BF1D5-19E8-2D4C-DD40-5E4F9B0D92FF}"/>
+          </ac:spMkLst>
+        </pc:spChg>
+        <pc:spChg chg="mod">
+          <ac:chgData name="Tiago Janela" userId="ee1a79fe-c79c-4f34-9602-7f6f2f0482b3" providerId="ADAL" clId="{D59BA079-2D81-42B2-9E2D-198C5F90099E}" dt="2026-04-29T14:43:18.457" v="144"/>
+          <ac:spMkLst>
+            <pc:docMk/>
+            <pc:sldMk cId="3463339464" sldId="318"/>
+            <ac:spMk id="155" creationId="{BD1FFE74-07FF-C306-4452-F1A48A611999}"/>
+          </ac:spMkLst>
+        </pc:spChg>
+        <pc:spChg chg="mod">
+          <ac:chgData name="Tiago Janela" userId="ee1a79fe-c79c-4f34-9602-7f6f2f0482b3" providerId="ADAL" clId="{D59BA079-2D81-42B2-9E2D-198C5F90099E}" dt="2026-04-29T14:43:18.457" v="144"/>
+          <ac:spMkLst>
+            <pc:docMk/>
+            <pc:sldMk cId="3463339464" sldId="318"/>
+            <ac:spMk id="156" creationId="{6F238688-2311-35BF-4F94-971FEF816E39}"/>
+          </ac:spMkLst>
+        </pc:spChg>
+        <pc:spChg chg="mod">
+          <ac:chgData name="Tiago Janela" userId="ee1a79fe-c79c-4f34-9602-7f6f2f0482b3" providerId="ADAL" clId="{D59BA079-2D81-42B2-9E2D-198C5F90099E}" dt="2026-04-29T14:43:18.457" v="144"/>
+          <ac:spMkLst>
+            <pc:docMk/>
+            <pc:sldMk cId="3463339464" sldId="318"/>
+            <ac:spMk id="162" creationId="{F5558767-FDAA-D45E-3AC5-CF6A5C3268C9}"/>
+          </ac:spMkLst>
+        </pc:spChg>
+        <pc:spChg chg="mod">
+          <ac:chgData name="Tiago Janela" userId="ee1a79fe-c79c-4f34-9602-7f6f2f0482b3" providerId="ADAL" clId="{D59BA079-2D81-42B2-9E2D-198C5F90099E}" dt="2026-04-29T14:43:18.457" v="144"/>
+          <ac:spMkLst>
+            <pc:docMk/>
+            <pc:sldMk cId="3463339464" sldId="318"/>
+            <ac:spMk id="165" creationId="{CD5729C5-8B36-552A-F410-B2D2ACFF52DB}"/>
+          </ac:spMkLst>
+        </pc:spChg>
+        <pc:spChg chg="mod">
+          <ac:chgData name="Tiago Janela" userId="ee1a79fe-c79c-4f34-9602-7f6f2f0482b3" providerId="ADAL" clId="{D59BA079-2D81-42B2-9E2D-198C5F90099E}" dt="2026-04-29T14:43:18.457" v="144"/>
+          <ac:spMkLst>
+            <pc:docMk/>
+            <pc:sldMk cId="3463339464" sldId="318"/>
+            <ac:spMk id="166" creationId="{6A57B814-ADB9-965C-78F4-9CFF2C476CA1}"/>
+          </ac:spMkLst>
+        </pc:spChg>
+        <pc:grpChg chg="del">
+          <ac:chgData name="Tiago Janela" userId="ee1a79fe-c79c-4f34-9602-7f6f2f0482b3" providerId="ADAL" clId="{D59BA079-2D81-42B2-9E2D-198C5F90099E}" dt="2026-04-29T14:38:45.095" v="19" actId="478"/>
+          <ac:grpSpMkLst>
+            <pc:docMk/>
+            <pc:sldMk cId="3463339464" sldId="318"/>
+            <ac:grpSpMk id="20" creationId="{81A65B80-1110-F1AF-A893-8B82ECA10662}"/>
+          </ac:grpSpMkLst>
+        </pc:grpChg>
+        <pc:grpChg chg="add mod">
+          <ac:chgData name="Tiago Janela" userId="ee1a79fe-c79c-4f34-9602-7f6f2f0482b3" providerId="ADAL" clId="{D59BA079-2D81-42B2-9E2D-198C5F90099E}" dt="2026-04-29T14:39:08.519" v="21" actId="164"/>
+          <ac:grpSpMkLst>
+            <pc:docMk/>
+            <pc:sldMk cId="3463339464" sldId="318"/>
+            <ac:grpSpMk id="21" creationId="{851E801A-07D0-EC46-EC69-B1E3BDC4A0EE}"/>
+          </ac:grpSpMkLst>
+        </pc:grpChg>
+        <pc:grpChg chg="add mod">
+          <ac:chgData name="Tiago Janela" userId="ee1a79fe-c79c-4f34-9602-7f6f2f0482b3" providerId="ADAL" clId="{D59BA079-2D81-42B2-9E2D-198C5F90099E}" dt="2026-04-29T14:39:08.519" v="21" actId="164"/>
+          <ac:grpSpMkLst>
+            <pc:docMk/>
+            <pc:sldMk cId="3463339464" sldId="318"/>
+            <ac:grpSpMk id="26" creationId="{9472E490-A369-C15A-DECA-AE1255870DC8}"/>
+          </ac:grpSpMkLst>
+        </pc:grpChg>
+        <pc:grpChg chg="mod">
+          <ac:chgData name="Tiago Janela" userId="ee1a79fe-c79c-4f34-9602-7f6f2f0482b3" providerId="ADAL" clId="{D59BA079-2D81-42B2-9E2D-198C5F90099E}" dt="2026-04-29T14:39:06.477" v="20"/>
+          <ac:grpSpMkLst>
+            <pc:docMk/>
+            <pc:sldMk cId="3463339464" sldId="318"/>
+            <ac:grpSpMk id="27" creationId="{C867F122-D459-E4D8-E91E-39D4FB20E8FB}"/>
+          </ac:grpSpMkLst>
+        </pc:grpChg>
+        <pc:grpChg chg="mod">
+          <ac:chgData name="Tiago Janela" userId="ee1a79fe-c79c-4f34-9602-7f6f2f0482b3" providerId="ADAL" clId="{D59BA079-2D81-42B2-9E2D-198C5F90099E}" dt="2026-04-29T14:39:06.477" v="20"/>
+          <ac:grpSpMkLst>
+            <pc:docMk/>
+            <pc:sldMk cId="3463339464" sldId="318"/>
+            <ac:grpSpMk id="28" creationId="{31D67220-A5A3-C982-ABAA-76BF27D3A610}"/>
+          </ac:grpSpMkLst>
+        </pc:grpChg>
+        <pc:grpChg chg="add mod">
+          <ac:chgData name="Tiago Janela" userId="ee1a79fe-c79c-4f34-9602-7f6f2f0482b3" providerId="ADAL" clId="{D59BA079-2D81-42B2-9E2D-198C5F90099E}" dt="2026-04-29T14:39:08.519" v="21" actId="164"/>
+          <ac:grpSpMkLst>
+            <pc:docMk/>
+            <pc:sldMk cId="3463339464" sldId="318"/>
+            <ac:grpSpMk id="34" creationId="{0D4F3181-F484-3C7A-63BE-FADB4F9C8C2E}"/>
+          </ac:grpSpMkLst>
+        </pc:grpChg>
+        <pc:grpChg chg="mod">
+          <ac:chgData name="Tiago Janela" userId="ee1a79fe-c79c-4f34-9602-7f6f2f0482b3" providerId="ADAL" clId="{D59BA079-2D81-42B2-9E2D-198C5F90099E}" dt="2026-04-29T14:39:06.477" v="20"/>
+          <ac:grpSpMkLst>
+            <pc:docMk/>
+            <pc:sldMk cId="3463339464" sldId="318"/>
+            <ac:grpSpMk id="35" creationId="{315A4BFF-0CA9-D528-2306-83671A721F96}"/>
+          </ac:grpSpMkLst>
+        </pc:grpChg>
+        <pc:grpChg chg="mod">
+          <ac:chgData name="Tiago Janela" userId="ee1a79fe-c79c-4f34-9602-7f6f2f0482b3" providerId="ADAL" clId="{D59BA079-2D81-42B2-9E2D-198C5F90099E}" dt="2026-04-29T14:39:06.477" v="20"/>
+          <ac:grpSpMkLst>
+            <pc:docMk/>
+            <pc:sldMk cId="3463339464" sldId="318"/>
+            <ac:grpSpMk id="36" creationId="{40F329E8-016F-7B2E-D6E4-F9F4E0BE7A34}"/>
+          </ac:grpSpMkLst>
+        </pc:grpChg>
+        <pc:grpChg chg="add mod">
+          <ac:chgData name="Tiago Janela" userId="ee1a79fe-c79c-4f34-9602-7f6f2f0482b3" providerId="ADAL" clId="{D59BA079-2D81-42B2-9E2D-198C5F90099E}" dt="2026-04-29T14:39:08.519" v="21" actId="164"/>
+          <ac:grpSpMkLst>
+            <pc:docMk/>
+            <pc:sldMk cId="3463339464" sldId="318"/>
+            <ac:grpSpMk id="43" creationId="{F82C89B3-047B-9A9D-4CE0-2F5ECB7C024A}"/>
+          </ac:grpSpMkLst>
+        </pc:grpChg>
+        <pc:grpChg chg="add mod">
+          <ac:chgData name="Tiago Janela" userId="ee1a79fe-c79c-4f34-9602-7f6f2f0482b3" providerId="ADAL" clId="{D59BA079-2D81-42B2-9E2D-198C5F90099E}" dt="2026-04-29T14:39:08.519" v="21" actId="164"/>
+          <ac:grpSpMkLst>
+            <pc:docMk/>
+            <pc:sldMk cId="3463339464" sldId="318"/>
+            <ac:grpSpMk id="46" creationId="{CD48E29D-F3CB-93DF-7120-8F34C9F5EB3C}"/>
+          </ac:grpSpMkLst>
+        </pc:grpChg>
+        <pc:grpChg chg="add mod ord">
+          <ac:chgData name="Tiago Janela" userId="ee1a79fe-c79c-4f34-9602-7f6f2f0482b3" providerId="ADAL" clId="{D59BA079-2D81-42B2-9E2D-198C5F90099E}" dt="2026-04-29T14:43:42.133" v="152" actId="167"/>
+          <ac:grpSpMkLst>
+            <pc:docMk/>
+            <pc:sldMk cId="3463339464" sldId="318"/>
+            <ac:grpSpMk id="49" creationId="{C31E6F76-4E7C-1639-9021-CCC76ADA5882}"/>
+          </ac:grpSpMkLst>
+        </pc:grpChg>
+        <pc:grpChg chg="add mod">
+          <ac:chgData name="Tiago Janela" userId="ee1a79fe-c79c-4f34-9602-7f6f2f0482b3" providerId="ADAL" clId="{D59BA079-2D81-42B2-9E2D-198C5F90099E}" dt="2026-04-29T14:41:05.450" v="44"/>
+          <ac:grpSpMkLst>
+            <pc:docMk/>
+            <pc:sldMk cId="3463339464" sldId="318"/>
+            <ac:grpSpMk id="50" creationId="{D57CAE1F-4C69-E55E-DD88-2C06EA9E4CC5}"/>
+          </ac:grpSpMkLst>
+        </pc:grpChg>
+        <pc:grpChg chg="mod">
+          <ac:chgData name="Tiago Janela" userId="ee1a79fe-c79c-4f34-9602-7f6f2f0482b3" providerId="ADAL" clId="{D59BA079-2D81-42B2-9E2D-198C5F90099E}" dt="2026-04-29T14:41:05.450" v="44"/>
+          <ac:grpSpMkLst>
+            <pc:docMk/>
+            <pc:sldMk cId="3463339464" sldId="318"/>
+            <ac:grpSpMk id="52" creationId="{64D5765C-B2EC-B5F9-4D64-418DF9E0721F}"/>
+          </ac:grpSpMkLst>
+        </pc:grpChg>
+        <pc:grpChg chg="mod">
+          <ac:chgData name="Tiago Janela" userId="ee1a79fe-c79c-4f34-9602-7f6f2f0482b3" providerId="ADAL" clId="{D59BA079-2D81-42B2-9E2D-198C5F90099E}" dt="2026-04-29T14:41:05.450" v="44"/>
+          <ac:grpSpMkLst>
+            <pc:docMk/>
+            <pc:sldMk cId="3463339464" sldId="318"/>
+            <ac:grpSpMk id="57" creationId="{91F3A9FD-192C-B5F3-BAD0-3527115F76D0}"/>
+          </ac:grpSpMkLst>
+        </pc:grpChg>
+        <pc:grpChg chg="mod">
+          <ac:chgData name="Tiago Janela" userId="ee1a79fe-c79c-4f34-9602-7f6f2f0482b3" providerId="ADAL" clId="{D59BA079-2D81-42B2-9E2D-198C5F90099E}" dt="2026-04-29T14:41:05.450" v="44"/>
+          <ac:grpSpMkLst>
+            <pc:docMk/>
+            <pc:sldMk cId="3463339464" sldId="318"/>
+            <ac:grpSpMk id="58" creationId="{FAFFF705-7A29-74F1-4F40-839BF442E1CA}"/>
+          </ac:grpSpMkLst>
+        </pc:grpChg>
+        <pc:grpChg chg="add del mod">
+          <ac:chgData name="Tiago Janela" userId="ee1a79fe-c79c-4f34-9602-7f6f2f0482b3" providerId="ADAL" clId="{D59BA079-2D81-42B2-9E2D-198C5F90099E}" dt="2026-04-29T14:42:06.188" v="132" actId="478"/>
+          <ac:grpSpMkLst>
+            <pc:docMk/>
+            <pc:sldMk cId="3463339464" sldId="318"/>
+            <ac:grpSpMk id="132" creationId="{7D679A1A-9811-6F80-6988-A652D18905E3}"/>
+          </ac:grpSpMkLst>
+        </pc:grpChg>
+        <pc:grpChg chg="mod">
+          <ac:chgData name="Tiago Janela" userId="ee1a79fe-c79c-4f34-9602-7f6f2f0482b3" providerId="ADAL" clId="{D59BA079-2D81-42B2-9E2D-198C5F90099E}" dt="2026-04-29T14:41:35.971" v="129"/>
+          <ac:grpSpMkLst>
+            <pc:docMk/>
+            <pc:sldMk cId="3463339464" sldId="318"/>
+            <ac:grpSpMk id="134" creationId="{51B65499-5373-FCE8-2856-3910277BE174}"/>
+          </ac:grpSpMkLst>
+        </pc:grpChg>
+        <pc:grpChg chg="mod">
+          <ac:chgData name="Tiago Janela" userId="ee1a79fe-c79c-4f34-9602-7f6f2f0482b3" providerId="ADAL" clId="{D59BA079-2D81-42B2-9E2D-198C5F90099E}" dt="2026-04-29T14:41:35.971" v="129"/>
+          <ac:grpSpMkLst>
+            <pc:docMk/>
+            <pc:sldMk cId="3463339464" sldId="318"/>
+            <ac:grpSpMk id="139" creationId="{191878A7-B36A-37F2-B0BF-A4620279843D}"/>
+          </ac:grpSpMkLst>
+        </pc:grpChg>
+        <pc:grpChg chg="mod">
+          <ac:chgData name="Tiago Janela" userId="ee1a79fe-c79c-4f34-9602-7f6f2f0482b3" providerId="ADAL" clId="{D59BA079-2D81-42B2-9E2D-198C5F90099E}" dt="2026-04-29T14:41:35.971" v="129"/>
+          <ac:grpSpMkLst>
+            <pc:docMk/>
+            <pc:sldMk cId="3463339464" sldId="318"/>
+            <ac:grpSpMk id="140" creationId="{D9AD3D22-66A3-A6A1-5BAB-BDEA94034AFD}"/>
+          </ac:grpSpMkLst>
+        </pc:grpChg>
+        <pc:grpChg chg="add del mod ord">
+          <ac:chgData name="Tiago Janela" userId="ee1a79fe-c79c-4f34-9602-7f6f2f0482b3" providerId="ADAL" clId="{D59BA079-2D81-42B2-9E2D-198C5F90099E}" dt="2026-04-29T14:43:51.811" v="155" actId="478"/>
+          <ac:grpSpMkLst>
+            <pc:docMk/>
+            <pc:sldMk cId="3463339464" sldId="318"/>
+            <ac:grpSpMk id="150" creationId="{0E889340-EEAD-529D-0667-5EC3D102D360}"/>
+          </ac:grpSpMkLst>
+        </pc:grpChg>
+        <pc:grpChg chg="mod">
+          <ac:chgData name="Tiago Janela" userId="ee1a79fe-c79c-4f34-9602-7f6f2f0482b3" providerId="ADAL" clId="{D59BA079-2D81-42B2-9E2D-198C5F90099E}" dt="2026-04-29T14:43:18.457" v="144"/>
+          <ac:grpSpMkLst>
+            <pc:docMk/>
+            <pc:sldMk cId="3463339464" sldId="318"/>
+            <ac:grpSpMk id="152" creationId="{0C8C51CC-EB9B-D489-F562-F672BF7EA67F}"/>
+          </ac:grpSpMkLst>
+        </pc:grpChg>
+        <pc:grpChg chg="mod">
+          <ac:chgData name="Tiago Janela" userId="ee1a79fe-c79c-4f34-9602-7f6f2f0482b3" providerId="ADAL" clId="{D59BA079-2D81-42B2-9E2D-198C5F90099E}" dt="2026-04-29T14:43:18.457" v="144"/>
+          <ac:grpSpMkLst>
+            <pc:docMk/>
+            <pc:sldMk cId="3463339464" sldId="318"/>
+            <ac:grpSpMk id="157" creationId="{6AD1BC14-680D-9A2F-3A7A-A5A523B365A3}"/>
+          </ac:grpSpMkLst>
+        </pc:grpChg>
+        <pc:grpChg chg="mod">
+          <ac:chgData name="Tiago Janela" userId="ee1a79fe-c79c-4f34-9602-7f6f2f0482b3" providerId="ADAL" clId="{D59BA079-2D81-42B2-9E2D-198C5F90099E}" dt="2026-04-29T14:43:18.457" v="144"/>
+          <ac:grpSpMkLst>
+            <pc:docMk/>
+            <pc:sldMk cId="3463339464" sldId="318"/>
+            <ac:grpSpMk id="158" creationId="{9FB94B2B-B250-2B0F-D8EA-4B7606C3EDD4}"/>
+          </ac:grpSpMkLst>
+        </pc:grpChg>
+        <pc:picChg chg="mod">
+          <ac:chgData name="Tiago Janela" userId="ee1a79fe-c79c-4f34-9602-7f6f2f0482b3" providerId="ADAL" clId="{D59BA079-2D81-42B2-9E2D-198C5F90099E}" dt="2026-04-29T14:39:06.477" v="20"/>
+          <ac:picMkLst>
+            <pc:docMk/>
+            <pc:sldMk cId="3463339464" sldId="318"/>
+            <ac:picMk id="23" creationId="{0FAB87FB-66B8-682E-AC05-EA6B56D8F4FB}"/>
+          </ac:picMkLst>
+        </pc:picChg>
+        <pc:picChg chg="mod">
+          <ac:chgData name="Tiago Janela" userId="ee1a79fe-c79c-4f34-9602-7f6f2f0482b3" providerId="ADAL" clId="{D59BA079-2D81-42B2-9E2D-198C5F90099E}" dt="2026-04-29T14:39:06.477" v="20"/>
+          <ac:picMkLst>
+            <pc:docMk/>
+            <pc:sldMk cId="3463339464" sldId="318"/>
+            <ac:picMk id="24" creationId="{5AFB6878-0F86-C45A-E83E-50BAC05BCEF5}"/>
+          </ac:picMkLst>
+        </pc:picChg>
+        <pc:picChg chg="mod">
+          <ac:chgData name="Tiago Janela" userId="ee1a79fe-c79c-4f34-9602-7f6f2f0482b3" providerId="ADAL" clId="{D59BA079-2D81-42B2-9E2D-198C5F90099E}" dt="2026-04-29T14:39:06.477" v="20"/>
+          <ac:picMkLst>
+            <pc:docMk/>
+            <pc:sldMk cId="3463339464" sldId="318"/>
+            <ac:picMk id="30" creationId="{31CDC5D0-80F4-CF34-180C-1E2C5181119A}"/>
+          </ac:picMkLst>
+        </pc:picChg>
+        <pc:picChg chg="mod">
+          <ac:chgData name="Tiago Janela" userId="ee1a79fe-c79c-4f34-9602-7f6f2f0482b3" providerId="ADAL" clId="{D59BA079-2D81-42B2-9E2D-198C5F90099E}" dt="2026-04-29T14:39:06.477" v="20"/>
+          <ac:picMkLst>
+            <pc:docMk/>
+            <pc:sldMk cId="3463339464" sldId="318"/>
+            <ac:picMk id="31" creationId="{CA091874-25E2-30DF-B764-40BAC98019C4}"/>
+          </ac:picMkLst>
+        </pc:picChg>
+        <pc:picChg chg="mod">
+          <ac:chgData name="Tiago Janela" userId="ee1a79fe-c79c-4f34-9602-7f6f2f0482b3" providerId="ADAL" clId="{D59BA079-2D81-42B2-9E2D-198C5F90099E}" dt="2026-04-29T14:39:06.477" v="20"/>
+          <ac:picMkLst>
+            <pc:docMk/>
+            <pc:sldMk cId="3463339464" sldId="318"/>
+            <ac:picMk id="32" creationId="{5A34DEF1-BD9B-CD6A-A8D2-7AFC0C5C49C9}"/>
+          </ac:picMkLst>
+        </pc:picChg>
+        <pc:picChg chg="mod">
+          <ac:chgData name="Tiago Janela" userId="ee1a79fe-c79c-4f34-9602-7f6f2f0482b3" providerId="ADAL" clId="{D59BA079-2D81-42B2-9E2D-198C5F90099E}" dt="2026-04-29T14:39:06.477" v="20"/>
+          <ac:picMkLst>
+            <pc:docMk/>
+            <pc:sldMk cId="3463339464" sldId="318"/>
+            <ac:picMk id="33" creationId="{C3C561D4-D6EB-0889-183B-97DE0B45487D}"/>
+          </ac:picMkLst>
+        </pc:picChg>
+        <pc:picChg chg="mod">
+          <ac:chgData name="Tiago Janela" userId="ee1a79fe-c79c-4f34-9602-7f6f2f0482b3" providerId="ADAL" clId="{D59BA079-2D81-42B2-9E2D-198C5F90099E}" dt="2026-04-29T14:39:06.477" v="20"/>
+          <ac:picMkLst>
+            <pc:docMk/>
+            <pc:sldMk cId="3463339464" sldId="318"/>
+            <ac:picMk id="38" creationId="{48ACB3B0-1845-ABC3-5228-376A5949FA79}"/>
+          </ac:picMkLst>
+        </pc:picChg>
+        <pc:picChg chg="mod">
+          <ac:chgData name="Tiago Janela" userId="ee1a79fe-c79c-4f34-9602-7f6f2f0482b3" providerId="ADAL" clId="{D59BA079-2D81-42B2-9E2D-198C5F90099E}" dt="2026-04-29T14:39:06.477" v="20"/>
+          <ac:picMkLst>
+            <pc:docMk/>
+            <pc:sldMk cId="3463339464" sldId="318"/>
+            <ac:picMk id="39" creationId="{5D7062A3-FA42-FF24-FF7D-4729F61DD8A5}"/>
+          </ac:picMkLst>
+        </pc:picChg>
+        <pc:picChg chg="mod">
+          <ac:chgData name="Tiago Janela" userId="ee1a79fe-c79c-4f34-9602-7f6f2f0482b3" providerId="ADAL" clId="{D59BA079-2D81-42B2-9E2D-198C5F90099E}" dt="2026-04-29T14:39:06.477" v="20"/>
+          <ac:picMkLst>
+            <pc:docMk/>
+            <pc:sldMk cId="3463339464" sldId="318"/>
+            <ac:picMk id="40" creationId="{13934202-8C49-5877-EAF5-D53028B5669E}"/>
+          </ac:picMkLst>
+        </pc:picChg>
+        <pc:picChg chg="mod">
+          <ac:chgData name="Tiago Janela" userId="ee1a79fe-c79c-4f34-9602-7f6f2f0482b3" providerId="ADAL" clId="{D59BA079-2D81-42B2-9E2D-198C5F90099E}" dt="2026-04-29T14:39:06.477" v="20"/>
+          <ac:picMkLst>
+            <pc:docMk/>
+            <pc:sldMk cId="3463339464" sldId="318"/>
+            <ac:picMk id="41" creationId="{14AFA39F-495B-AE1F-EE0F-FC1A7BA10F05}"/>
+          </ac:picMkLst>
+        </pc:picChg>
+        <pc:picChg chg="mod">
+          <ac:chgData name="Tiago Janela" userId="ee1a79fe-c79c-4f34-9602-7f6f2f0482b3" providerId="ADAL" clId="{D59BA079-2D81-42B2-9E2D-198C5F90099E}" dt="2026-04-29T14:41:05.450" v="44"/>
+          <ac:picMkLst>
+            <pc:docMk/>
+            <pc:sldMk cId="3463339464" sldId="318"/>
+            <ac:picMk id="59" creationId="{A7C8E1B6-A4B3-0BCF-4C26-6186EF9F59FC}"/>
+          </ac:picMkLst>
+        </pc:picChg>
+        <pc:picChg chg="mod">
+          <ac:chgData name="Tiago Janela" userId="ee1a79fe-c79c-4f34-9602-7f6f2f0482b3" providerId="ADAL" clId="{D59BA079-2D81-42B2-9E2D-198C5F90099E}" dt="2026-04-29T14:41:05.450" v="44"/>
+          <ac:picMkLst>
+            <pc:docMk/>
+            <pc:sldMk cId="3463339464" sldId="318"/>
+            <ac:picMk id="60" creationId="{9F70AD18-D8E1-8976-31FE-EA304180A270}"/>
+          </ac:picMkLst>
+        </pc:picChg>
+        <pc:picChg chg="mod">
+          <ac:chgData name="Tiago Janela" userId="ee1a79fe-c79c-4f34-9602-7f6f2f0482b3" providerId="ADAL" clId="{D59BA079-2D81-42B2-9E2D-198C5F90099E}" dt="2026-04-29T14:41:05.450" v="44"/>
+          <ac:picMkLst>
+            <pc:docMk/>
+            <pc:sldMk cId="3463339464" sldId="318"/>
+            <ac:picMk id="130" creationId="{8EC36DA4-D2FA-908D-744E-6BE08EC2741F}"/>
+          </ac:picMkLst>
+        </pc:picChg>
+        <pc:picChg chg="mod">
+          <ac:chgData name="Tiago Janela" userId="ee1a79fe-c79c-4f34-9602-7f6f2f0482b3" providerId="ADAL" clId="{D59BA079-2D81-42B2-9E2D-198C5F90099E}" dt="2026-04-29T14:41:05.450" v="44"/>
+          <ac:picMkLst>
+            <pc:docMk/>
+            <pc:sldMk cId="3463339464" sldId="318"/>
+            <ac:picMk id="131" creationId="{47FB0CB4-CD0C-2991-DB50-A8C57D1E8B0C}"/>
+          </ac:picMkLst>
+        </pc:picChg>
+        <pc:picChg chg="mod">
+          <ac:chgData name="Tiago Janela" userId="ee1a79fe-c79c-4f34-9602-7f6f2f0482b3" providerId="ADAL" clId="{D59BA079-2D81-42B2-9E2D-198C5F90099E}" dt="2026-04-29T14:41:35.971" v="129"/>
+          <ac:picMkLst>
+            <pc:docMk/>
+            <pc:sldMk cId="3463339464" sldId="318"/>
+            <ac:picMk id="141" creationId="{F4EFBF1D-95ED-A3F4-12D0-3C0D2F64959A}"/>
+          </ac:picMkLst>
+        </pc:picChg>
+        <pc:picChg chg="mod">
+          <ac:chgData name="Tiago Janela" userId="ee1a79fe-c79c-4f34-9602-7f6f2f0482b3" providerId="ADAL" clId="{D59BA079-2D81-42B2-9E2D-198C5F90099E}" dt="2026-04-29T14:41:35.971" v="129"/>
+          <ac:picMkLst>
+            <pc:docMk/>
+            <pc:sldMk cId="3463339464" sldId="318"/>
+            <ac:picMk id="142" creationId="{6B9ADBB7-EC72-A5FB-3287-F4C504614D51}"/>
+          </ac:picMkLst>
+        </pc:picChg>
+        <pc:picChg chg="mod">
+          <ac:chgData name="Tiago Janela" userId="ee1a79fe-c79c-4f34-9602-7f6f2f0482b3" providerId="ADAL" clId="{D59BA079-2D81-42B2-9E2D-198C5F90099E}" dt="2026-04-29T14:41:35.971" v="129"/>
+          <ac:picMkLst>
+            <pc:docMk/>
+            <pc:sldMk cId="3463339464" sldId="318"/>
+            <ac:picMk id="148" creationId="{8D6D62EA-8483-E0E7-6627-BBF48FE888C3}"/>
+          </ac:picMkLst>
+        </pc:picChg>
+        <pc:picChg chg="mod">
+          <ac:chgData name="Tiago Janela" userId="ee1a79fe-c79c-4f34-9602-7f6f2f0482b3" providerId="ADAL" clId="{D59BA079-2D81-42B2-9E2D-198C5F90099E}" dt="2026-04-29T14:41:35.971" v="129"/>
+          <ac:picMkLst>
+            <pc:docMk/>
+            <pc:sldMk cId="3463339464" sldId="318"/>
+            <ac:picMk id="149" creationId="{A4CD2FF9-44D8-CCD7-5C68-26A6C6065822}"/>
+          </ac:picMkLst>
+        </pc:picChg>
+        <pc:picChg chg="mod">
+          <ac:chgData name="Tiago Janela" userId="ee1a79fe-c79c-4f34-9602-7f6f2f0482b3" providerId="ADAL" clId="{D59BA079-2D81-42B2-9E2D-198C5F90099E}" dt="2026-04-29T14:43:18.457" v="144"/>
+          <ac:picMkLst>
+            <pc:docMk/>
+            <pc:sldMk cId="3463339464" sldId="318"/>
+            <ac:picMk id="159" creationId="{CD4358F0-D05E-D3C3-BA5B-D932178076D9}"/>
+          </ac:picMkLst>
+        </pc:picChg>
+        <pc:picChg chg="mod">
+          <ac:chgData name="Tiago Janela" userId="ee1a79fe-c79c-4f34-9602-7f6f2f0482b3" providerId="ADAL" clId="{D59BA079-2D81-42B2-9E2D-198C5F90099E}" dt="2026-04-29T14:43:18.457" v="144"/>
+          <ac:picMkLst>
+            <pc:docMk/>
+            <pc:sldMk cId="3463339464" sldId="318"/>
+            <ac:picMk id="160" creationId="{73C8AF2B-2691-7122-1A4E-6C9D94961867}"/>
+          </ac:picMkLst>
+        </pc:picChg>
+        <pc:picChg chg="mod">
+          <ac:chgData name="Tiago Janela" userId="ee1a79fe-c79c-4f34-9602-7f6f2f0482b3" providerId="ADAL" clId="{D59BA079-2D81-42B2-9E2D-198C5F90099E}" dt="2026-04-29T14:43:18.457" v="144"/>
+          <ac:picMkLst>
+            <pc:docMk/>
+            <pc:sldMk cId="3463339464" sldId="318"/>
+            <ac:picMk id="167" creationId="{B02D8D15-3F25-55BC-1A08-36302AD97557}"/>
+          </ac:picMkLst>
+        </pc:picChg>
+        <pc:picChg chg="mod">
+          <ac:chgData name="Tiago Janela" userId="ee1a79fe-c79c-4f34-9602-7f6f2f0482b3" providerId="ADAL" clId="{D59BA079-2D81-42B2-9E2D-198C5F90099E}" dt="2026-04-29T14:43:18.457" v="144"/>
+          <ac:picMkLst>
+            <pc:docMk/>
+            <pc:sldMk cId="3463339464" sldId="318"/>
+            <ac:picMk id="168" creationId="{04CEB11B-B6F1-FDD0-37A8-2EE7ABE5730D}"/>
+          </ac:picMkLst>
+        </pc:picChg>
+        <pc:cxnChg chg="mod">
+          <ac:chgData name="Tiago Janela" userId="ee1a79fe-c79c-4f34-9602-7f6f2f0482b3" providerId="ADAL" clId="{D59BA079-2D81-42B2-9E2D-198C5F90099E}" dt="2026-04-29T14:39:06.477" v="20"/>
+          <ac:cxnSpMkLst>
+            <pc:docMk/>
+            <pc:sldMk cId="3463339464" sldId="318"/>
+            <ac:cxnSpMk id="44" creationId="{7CA5671C-1E1D-11B4-C48F-3C328C72BA42}"/>
+          </ac:cxnSpMkLst>
+        </pc:cxnChg>
+        <pc:cxnChg chg="mod">
+          <ac:chgData name="Tiago Janela" userId="ee1a79fe-c79c-4f34-9602-7f6f2f0482b3" providerId="ADAL" clId="{D59BA079-2D81-42B2-9E2D-198C5F90099E}" dt="2026-04-29T14:39:06.477" v="20"/>
+          <ac:cxnSpMkLst>
+            <pc:docMk/>
+            <pc:sldMk cId="3463339464" sldId="318"/>
+            <ac:cxnSpMk id="47" creationId="{FB8D1494-CCA9-D25B-F957-26E4BF3049A5}"/>
+          </ac:cxnSpMkLst>
+        </pc:cxnChg>
+        <pc:cxnChg chg="mod">
+          <ac:chgData name="Tiago Janela" userId="ee1a79fe-c79c-4f34-9602-7f6f2f0482b3" providerId="ADAL" clId="{D59BA079-2D81-42B2-9E2D-198C5F90099E}" dt="2026-04-29T14:41:05.450" v="44"/>
+          <ac:cxnSpMkLst>
+            <pc:docMk/>
+            <pc:sldMk cId="3463339464" sldId="318"/>
+            <ac:cxnSpMk id="61" creationId="{08938A15-2979-EEF5-6991-05431F61F7F4}"/>
+          </ac:cxnSpMkLst>
+        </pc:cxnChg>
+        <pc:cxnChg chg="mod">
+          <ac:chgData name="Tiago Janela" userId="ee1a79fe-c79c-4f34-9602-7f6f2f0482b3" providerId="ADAL" clId="{D59BA079-2D81-42B2-9E2D-198C5F90099E}" dt="2026-04-29T14:41:05.450" v="44"/>
+          <ac:cxnSpMkLst>
+            <pc:docMk/>
+            <pc:sldMk cId="3463339464" sldId="318"/>
+            <ac:cxnSpMk id="63" creationId="{023AB4D1-06EE-3BE9-021F-711AEB51150A}"/>
+          </ac:cxnSpMkLst>
+        </pc:cxnChg>
+        <pc:cxnChg chg="mod">
+          <ac:chgData name="Tiago Janela" userId="ee1a79fe-c79c-4f34-9602-7f6f2f0482b3" providerId="ADAL" clId="{D59BA079-2D81-42B2-9E2D-198C5F90099E}" dt="2026-04-29T14:41:35.971" v="129"/>
+          <ac:cxnSpMkLst>
+            <pc:docMk/>
+            <pc:sldMk cId="3463339464" sldId="318"/>
+            <ac:cxnSpMk id="143" creationId="{654790C0-C0D3-2DDF-798E-09EA80122BAE}"/>
+          </ac:cxnSpMkLst>
+        </pc:cxnChg>
+        <pc:cxnChg chg="mod">
+          <ac:chgData name="Tiago Janela" userId="ee1a79fe-c79c-4f34-9602-7f6f2f0482b3" providerId="ADAL" clId="{D59BA079-2D81-42B2-9E2D-198C5F90099E}" dt="2026-04-29T14:41:35.971" v="129"/>
+          <ac:cxnSpMkLst>
+            <pc:docMk/>
+            <pc:sldMk cId="3463339464" sldId="318"/>
+            <ac:cxnSpMk id="145" creationId="{05D2589C-68B7-FD26-BF17-001ABF5A487D}"/>
+          </ac:cxnSpMkLst>
+        </pc:cxnChg>
+        <pc:cxnChg chg="mod">
+          <ac:chgData name="Tiago Janela" userId="ee1a79fe-c79c-4f34-9602-7f6f2f0482b3" providerId="ADAL" clId="{D59BA079-2D81-42B2-9E2D-198C5F90099E}" dt="2026-04-29T14:43:18.457" v="144"/>
+          <ac:cxnSpMkLst>
+            <pc:docMk/>
+            <pc:sldMk cId="3463339464" sldId="318"/>
+            <ac:cxnSpMk id="161" creationId="{718FF3FF-38E3-8534-3375-DE97E2E87C02}"/>
+          </ac:cxnSpMkLst>
+        </pc:cxnChg>
+        <pc:cxnChg chg="mod">
+          <ac:chgData name="Tiago Janela" userId="ee1a79fe-c79c-4f34-9602-7f6f2f0482b3" providerId="ADAL" clId="{D59BA079-2D81-42B2-9E2D-198C5F90099E}" dt="2026-04-29T14:43:18.457" v="144"/>
+          <ac:cxnSpMkLst>
+            <pc:docMk/>
+            <pc:sldMk cId="3463339464" sldId="318"/>
+            <ac:cxnSpMk id="164" creationId="{55BB8492-C6E7-A17E-F1E3-D4F852B87E2E}"/>
+          </ac:cxnSpMkLst>
+        </pc:cxnChg>
+      </pc:sldChg>
+    </pc:docChg>
+  </pc:docChgLst>
+  <pc:docChgLst>
     <pc:chgData name="Tiago Janela" userId="ee1a79fe-c79c-4f34-9602-7f6f2f0482b3" providerId="ADAL" clId="{A1A622BE-A8AD-47B7-8802-BAC61BCE5126}"/>
     <pc:docChg chg="undo custSel modSld">
       <pc:chgData name="Tiago Janela" userId="ee1a79fe-c79c-4f34-9602-7f6f2f0482b3" providerId="ADAL" clId="{A1A622BE-A8AD-47B7-8802-BAC61BCE5126}" dt="2026-04-02T12:40:40.607" v="50" actId="478"/>
@@ -299,6 +1642,45 @@
             <ac:graphicFrameMk id="4" creationId="{689F2044-8E26-DCF5-DE2D-9AD979C8C1EE}"/>
           </ac:graphicFrameMkLst>
         </pc:graphicFrameChg>
+      </pc:sldChg>
+    </pc:docChg>
+  </pc:docChgLst>
+  <pc:docChgLst>
+    <pc:chgData name="Tiago Janela" userId="ee1a79fe-c79c-4f34-9602-7f6f2f0482b3" providerId="ADAL" clId="{67D2C233-DF3C-4C6D-9040-D7553E3BCB8A}"/>
+    <pc:docChg chg="delSld modSld">
+      <pc:chgData name="Tiago Janela" userId="ee1a79fe-c79c-4f34-9602-7f6f2f0482b3" providerId="ADAL" clId="{67D2C233-DF3C-4C6D-9040-D7553E3BCB8A}" dt="2026-03-16T14:03:02.466" v="54" actId="20577"/>
+      <pc:docMkLst>
+        <pc:docMk/>
+      </pc:docMkLst>
+      <pc:sldChg chg="modSp mod">
+        <pc:chgData name="Tiago Janela" userId="ee1a79fe-c79c-4f34-9602-7f6f2f0482b3" providerId="ADAL" clId="{67D2C233-DF3C-4C6D-9040-D7553E3BCB8A}" dt="2026-03-16T14:03:02.466" v="54" actId="20577"/>
+        <pc:sldMkLst>
+          <pc:docMk/>
+          <pc:sldMk cId="829672710" sldId="297"/>
+        </pc:sldMkLst>
+        <pc:spChg chg="mod">
+          <ac:chgData name="Tiago Janela" userId="ee1a79fe-c79c-4f34-9602-7f6f2f0482b3" providerId="ADAL" clId="{67D2C233-DF3C-4C6D-9040-D7553E3BCB8A}" dt="2026-03-16T14:03:02.466" v="54" actId="20577"/>
+          <ac:spMkLst>
+            <pc:docMk/>
+            <pc:sldMk cId="829672710" sldId="297"/>
+            <ac:spMk id="156" creationId="{00000000-0000-0000-0000-000000000000}"/>
+          </ac:spMkLst>
+        </pc:spChg>
+      </pc:sldChg>
+      <pc:sldChg chg="modSp mod">
+        <pc:chgData name="Tiago Janela" userId="ee1a79fe-c79c-4f34-9602-7f6f2f0482b3" providerId="ADAL" clId="{67D2C233-DF3C-4C6D-9040-D7553E3BCB8A}" dt="2026-03-16T14:02:34.148" v="0" actId="20577"/>
+        <pc:sldMkLst>
+          <pc:docMk/>
+          <pc:sldMk cId="721732568" sldId="298"/>
+        </pc:sldMkLst>
+        <pc:spChg chg="mod">
+          <ac:chgData name="Tiago Janela" userId="ee1a79fe-c79c-4f34-9602-7f6f2f0482b3" providerId="ADAL" clId="{67D2C233-DF3C-4C6D-9040-D7553E3BCB8A}" dt="2026-03-16T14:02:34.148" v="0" actId="20577"/>
+          <ac:spMkLst>
+            <pc:docMk/>
+            <pc:sldMk cId="721732568" sldId="298"/>
+            <ac:spMk id="2" creationId="{870990D0-7AC5-46BA-6FC4-274F8E0A3ABE}"/>
+          </ac:spMkLst>
+        </pc:spChg>
       </pc:sldChg>
     </pc:docChg>
   </pc:docChgLst>
@@ -836,7 +2218,7 @@
     </p:spTree>
     <p:extLst>
       <p:ext uri="{BB962C8B-B14F-4D97-AF65-F5344CB8AC3E}">
-        <p14:creationId xmlns:p14="http://schemas.microsoft.com/office/powerpoint/2010/main" val="2203819319"/>
+        <p14:creationId xmlns:p14="http://schemas.microsoft.com/office/powerpoint/2010/main" val="1621614894"/>
       </p:ext>
     </p:extLst>
   </p:cSld>
@@ -912,6 +2294,174 @@
             <a:fld id="{90EBC085-3709-4EED-9401-54C6FC7AFFB6}" type="slidenum">
               <a:rPr lang="en-US" smtClean="0"/>
               <a:t>9</a:t>
+            </a:fld>
+            <a:endParaRPr lang="en-US"/>
+          </a:p>
+        </p:txBody>
+      </p:sp>
+    </p:spTree>
+    <p:extLst>
+      <p:ext uri="{BB962C8B-B14F-4D97-AF65-F5344CB8AC3E}">
+        <p14:creationId xmlns:p14="http://schemas.microsoft.com/office/powerpoint/2010/main" val="1896034854"/>
+      </p:ext>
+    </p:extLst>
+  </p:cSld>
+  <p:clrMapOvr>
+    <a:masterClrMapping/>
+  </p:clrMapOvr>
+</p:notes>
+</file>
+
+<file path=ppt/notesSlides/notesSlide4.xml><?xml version="1.0" encoding="utf-8"?>
+<p:notes xmlns:a="http://schemas.openxmlformats.org/drawingml/2006/main" xmlns:r="http://schemas.openxmlformats.org/officeDocument/2006/relationships" xmlns:p="http://schemas.openxmlformats.org/presentationml/2006/main">
+  <p:cSld>
+    <p:spTree>
+      <p:nvGrpSpPr>
+        <p:cNvPr id="1" name=""/>
+        <p:cNvGrpSpPr/>
+        <p:nvPr/>
+      </p:nvGrpSpPr>
+      <p:grpSpPr>
+        <a:xfrm>
+          <a:off x="0" y="0"/>
+          <a:ext cx="0" cy="0"/>
+          <a:chOff x="0" y="0"/>
+          <a:chExt cx="0" cy="0"/>
+        </a:xfrm>
+      </p:grpSpPr>
+      <p:sp>
+        <p:nvSpPr>
+          <p:cNvPr id="2" name="Slide Image Placeholder 1"/>
+          <p:cNvSpPr>
+            <a:spLocks noGrp="1" noRot="1" noChangeAspect="1"/>
+          </p:cNvSpPr>
+          <p:nvPr>
+            <p:ph type="sldImg"/>
+          </p:nvPr>
+        </p:nvSpPr>
+        <p:spPr/>
+      </p:sp>
+      <p:sp>
+        <p:nvSpPr>
+          <p:cNvPr id="3" name="Notes Placeholder 2"/>
+          <p:cNvSpPr>
+            <a:spLocks noGrp="1"/>
+          </p:cNvSpPr>
+          <p:nvPr>
+            <p:ph type="body" idx="1"/>
+          </p:nvPr>
+        </p:nvSpPr>
+        <p:spPr/>
+        <p:txBody>
+          <a:bodyPr/>
+          <a:lstStyle/>
+          <a:p>
+            <a:endParaRPr lang="en-US" dirty="0"/>
+          </a:p>
+        </p:txBody>
+      </p:sp>
+      <p:sp>
+        <p:nvSpPr>
+          <p:cNvPr id="4" name="Slide Number Placeholder 3"/>
+          <p:cNvSpPr>
+            <a:spLocks noGrp="1"/>
+          </p:cNvSpPr>
+          <p:nvPr>
+            <p:ph type="sldNum" sz="quarter" idx="5"/>
+          </p:nvPr>
+        </p:nvSpPr>
+        <p:spPr/>
+        <p:txBody>
+          <a:bodyPr/>
+          <a:lstStyle/>
+          <a:p>
+            <a:fld id="{90EBC085-3709-4EED-9401-54C6FC7AFFB6}" type="slidenum">
+              <a:rPr lang="en-US" smtClean="0"/>
+              <a:t>10</a:t>
+            </a:fld>
+            <a:endParaRPr lang="en-US"/>
+          </a:p>
+        </p:txBody>
+      </p:sp>
+    </p:spTree>
+    <p:extLst>
+      <p:ext uri="{BB962C8B-B14F-4D97-AF65-F5344CB8AC3E}">
+        <p14:creationId xmlns:p14="http://schemas.microsoft.com/office/powerpoint/2010/main" val="2203819319"/>
+      </p:ext>
+    </p:extLst>
+  </p:cSld>
+  <p:clrMapOvr>
+    <a:masterClrMapping/>
+  </p:clrMapOvr>
+</p:notes>
+</file>
+
+<file path=ppt/notesSlides/notesSlide5.xml><?xml version="1.0" encoding="utf-8"?>
+<p:notes xmlns:a="http://schemas.openxmlformats.org/drawingml/2006/main" xmlns:r="http://schemas.openxmlformats.org/officeDocument/2006/relationships" xmlns:p="http://schemas.openxmlformats.org/presentationml/2006/main">
+  <p:cSld>
+    <p:spTree>
+      <p:nvGrpSpPr>
+        <p:cNvPr id="1" name=""/>
+        <p:cNvGrpSpPr/>
+        <p:nvPr/>
+      </p:nvGrpSpPr>
+      <p:grpSpPr>
+        <a:xfrm>
+          <a:off x="0" y="0"/>
+          <a:ext cx="0" cy="0"/>
+          <a:chOff x="0" y="0"/>
+          <a:chExt cx="0" cy="0"/>
+        </a:xfrm>
+      </p:grpSpPr>
+      <p:sp>
+        <p:nvSpPr>
+          <p:cNvPr id="2" name="Slide Image Placeholder 1"/>
+          <p:cNvSpPr>
+            <a:spLocks noGrp="1" noRot="1" noChangeAspect="1"/>
+          </p:cNvSpPr>
+          <p:nvPr>
+            <p:ph type="sldImg"/>
+          </p:nvPr>
+        </p:nvSpPr>
+        <p:spPr/>
+      </p:sp>
+      <p:sp>
+        <p:nvSpPr>
+          <p:cNvPr id="3" name="Notes Placeholder 2"/>
+          <p:cNvSpPr>
+            <a:spLocks noGrp="1"/>
+          </p:cNvSpPr>
+          <p:nvPr>
+            <p:ph type="body" idx="1"/>
+          </p:nvPr>
+        </p:nvSpPr>
+        <p:spPr/>
+        <p:txBody>
+          <a:bodyPr/>
+          <a:lstStyle/>
+          <a:p>
+            <a:endParaRPr lang="en-US" dirty="0"/>
+          </a:p>
+        </p:txBody>
+      </p:sp>
+      <p:sp>
+        <p:nvSpPr>
+          <p:cNvPr id="4" name="Slide Number Placeholder 3"/>
+          <p:cNvSpPr>
+            <a:spLocks noGrp="1"/>
+          </p:cNvSpPr>
+          <p:nvPr>
+            <p:ph type="sldNum" sz="quarter" idx="5"/>
+          </p:nvPr>
+        </p:nvSpPr>
+        <p:spPr/>
+        <p:txBody>
+          <a:bodyPr/>
+          <a:lstStyle/>
+          <a:p>
+            <a:fld id="{90EBC085-3709-4EED-9401-54C6FC7AFFB6}" type="slidenum">
+              <a:rPr lang="en-US" smtClean="0"/>
+              <a:t>11</a:t>
             </a:fld>
             <a:endParaRPr lang="en-US"/>
           </a:p>
@@ -9957,6 +11507,256 @@
 </file>
 
 <file path=ppt/slides/slide10.xml><?xml version="1.0" encoding="utf-8"?>
+<p:sld xmlns:a="http://schemas.openxmlformats.org/drawingml/2006/main" xmlns:r="http://schemas.openxmlformats.org/officeDocument/2006/relationships" xmlns:p="http://schemas.openxmlformats.org/presentationml/2006/main" show="0">
+  <p:cSld>
+    <p:spTree>
+      <p:nvGrpSpPr>
+        <p:cNvPr id="1" name="">
+          <a:extLst>
+            <a:ext uri="{FF2B5EF4-FFF2-40B4-BE49-F238E27FC236}">
+              <a16:creationId xmlns:a16="http://schemas.microsoft.com/office/drawing/2014/main" id="{A6515F23-0912-A838-23CE-B8F00573A2DA}"/>
+            </a:ext>
+          </a:extLst>
+        </p:cNvPr>
+        <p:cNvGrpSpPr/>
+        <p:nvPr/>
+      </p:nvGrpSpPr>
+      <p:grpSpPr>
+        <a:xfrm>
+          <a:off x="0" y="0"/>
+          <a:ext cx="0" cy="0"/>
+          <a:chOff x="0" y="0"/>
+          <a:chExt cx="0" cy="0"/>
+        </a:xfrm>
+      </p:grpSpPr>
+      <p:sp>
+        <p:nvSpPr>
+          <p:cNvPr id="163" name="PlaceHolder 1">
+            <a:extLst>
+              <a:ext uri="{FF2B5EF4-FFF2-40B4-BE49-F238E27FC236}">
+                <a16:creationId xmlns:a16="http://schemas.microsoft.com/office/drawing/2014/main" id="{57944F4B-F502-E7CC-8790-8737702BC6AC}"/>
+              </a:ext>
+            </a:extLst>
+          </p:cNvPr>
+          <p:cNvSpPr>
+            <a:spLocks noGrp="1"/>
+          </p:cNvSpPr>
+          <p:nvPr>
+            <p:ph type="title"/>
+          </p:nvPr>
+        </p:nvSpPr>
+        <p:spPr>
+          <a:xfrm>
+            <a:off x="380880" y="228600"/>
+            <a:ext cx="8380080" cy="837720"/>
+          </a:xfrm>
+          <a:prstGeom prst="rect">
+            <a:avLst/>
+          </a:prstGeom>
+          <a:noFill/>
+          <a:ln w="0">
+            <a:noFill/>
+          </a:ln>
+        </p:spPr>
+        <p:txBody>
+          <a:bodyPr numCol="1" spcCol="0" anchor="ctr">
+            <a:noAutofit/>
+          </a:bodyPr>
+          <a:lstStyle/>
+          <a:p>
+            <a:pPr>
+              <a:lnSpc>
+                <a:spcPct val="100000"/>
+              </a:lnSpc>
+              <a:buNone/>
+            </a:pPr>
+            <a:r>
+              <a:rPr lang="en-US" sz="3200" b="0" strike="noStrike" spc="-1" dirty="0">
+                <a:solidFill>
+                  <a:srgbClr val="0064C8"/>
+                </a:solidFill>
+                <a:latin typeface="Century Gothic"/>
+              </a:rPr>
+              <a:t>Prompt 2</a:t>
+            </a:r>
+            <a:endParaRPr lang="en-US" sz="3200" b="0" strike="noStrike" spc="-1" dirty="0">
+              <a:solidFill>
+                <a:srgbClr val="000000"/>
+              </a:solidFill>
+              <a:latin typeface="Century Gothic"/>
+            </a:endParaRPr>
+          </a:p>
+        </p:txBody>
+      </p:sp>
+      <p:pic>
+        <p:nvPicPr>
+          <p:cNvPr id="12" name="Picture 11">
+            <a:extLst>
+              <a:ext uri="{FF2B5EF4-FFF2-40B4-BE49-F238E27FC236}">
+                <a16:creationId xmlns:a16="http://schemas.microsoft.com/office/drawing/2014/main" id="{E40230FB-91FB-0DC9-7BD8-1BE8E2E79A66}"/>
+              </a:ext>
+            </a:extLst>
+          </p:cNvPr>
+          <p:cNvPicPr>
+            <a:picLocks noChangeAspect="1"/>
+          </p:cNvPicPr>
+          <p:nvPr/>
+        </p:nvPicPr>
+        <p:blipFill>
+          <a:blip r:embed="rId3"/>
+          <a:stretch>
+            <a:fillRect/>
+          </a:stretch>
+        </p:blipFill>
+        <p:spPr>
+          <a:xfrm>
+            <a:off x="380880" y="1192696"/>
+            <a:ext cx="8177259" cy="4495156"/>
+          </a:xfrm>
+          <a:prstGeom prst="rect">
+            <a:avLst/>
+          </a:prstGeom>
+        </p:spPr>
+      </p:pic>
+    </p:spTree>
+    <p:extLst>
+      <p:ext uri="{BB962C8B-B14F-4D97-AF65-F5344CB8AC3E}">
+        <p14:creationId xmlns:p14="http://schemas.microsoft.com/office/powerpoint/2010/main" val="497639913"/>
+      </p:ext>
+    </p:extLst>
+  </p:cSld>
+  <p:clrMapOvr>
+    <a:masterClrMapping/>
+  </p:clrMapOvr>
+</p:sld>
+</file>
+
+<file path=ppt/slides/slide11.xml><?xml version="1.0" encoding="utf-8"?>
+<p:sld xmlns:a="http://schemas.openxmlformats.org/drawingml/2006/main" xmlns:r="http://schemas.openxmlformats.org/officeDocument/2006/relationships" xmlns:p="http://schemas.openxmlformats.org/presentationml/2006/main">
+  <p:cSld>
+    <p:spTree>
+      <p:nvGrpSpPr>
+        <p:cNvPr id="1" name="">
+          <a:extLst>
+            <a:ext uri="{FF2B5EF4-FFF2-40B4-BE49-F238E27FC236}">
+              <a16:creationId xmlns:a16="http://schemas.microsoft.com/office/drawing/2014/main" id="{A6515F23-0912-A838-23CE-B8F00573A2DA}"/>
+            </a:ext>
+          </a:extLst>
+        </p:cNvPr>
+        <p:cNvGrpSpPr/>
+        <p:nvPr/>
+      </p:nvGrpSpPr>
+      <p:grpSpPr>
+        <a:xfrm>
+          <a:off x="0" y="0"/>
+          <a:ext cx="0" cy="0"/>
+          <a:chOff x="0" y="0"/>
+          <a:chExt cx="0" cy="0"/>
+        </a:xfrm>
+      </p:grpSpPr>
+      <p:sp>
+        <p:nvSpPr>
+          <p:cNvPr id="163" name="PlaceHolder 1">
+            <a:extLst>
+              <a:ext uri="{FF2B5EF4-FFF2-40B4-BE49-F238E27FC236}">
+                <a16:creationId xmlns:a16="http://schemas.microsoft.com/office/drawing/2014/main" id="{57944F4B-F502-E7CC-8790-8737702BC6AC}"/>
+              </a:ext>
+            </a:extLst>
+          </p:cNvPr>
+          <p:cNvSpPr>
+            <a:spLocks noGrp="1"/>
+          </p:cNvSpPr>
+          <p:nvPr>
+            <p:ph type="title"/>
+          </p:nvPr>
+        </p:nvSpPr>
+        <p:spPr>
+          <a:xfrm>
+            <a:off x="380880" y="228600"/>
+            <a:ext cx="8380080" cy="837720"/>
+          </a:xfrm>
+          <a:prstGeom prst="rect">
+            <a:avLst/>
+          </a:prstGeom>
+          <a:noFill/>
+          <a:ln w="0">
+            <a:noFill/>
+          </a:ln>
+        </p:spPr>
+        <p:txBody>
+          <a:bodyPr numCol="1" spcCol="0" anchor="ctr">
+            <a:noAutofit/>
+          </a:bodyPr>
+          <a:lstStyle/>
+          <a:p>
+            <a:pPr>
+              <a:lnSpc>
+                <a:spcPct val="100000"/>
+              </a:lnSpc>
+              <a:buNone/>
+            </a:pPr>
+            <a:r>
+              <a:rPr lang="en-US" sz="3200" b="0" strike="noStrike" spc="-1" dirty="0">
+                <a:solidFill>
+                  <a:srgbClr val="0064C8"/>
+                </a:solidFill>
+                <a:latin typeface="Century Gothic"/>
+              </a:rPr>
+              <a:t>Prompt 2</a:t>
+            </a:r>
+            <a:endParaRPr lang="en-US" sz="3200" b="0" strike="noStrike" spc="-1" dirty="0">
+              <a:solidFill>
+                <a:srgbClr val="000000"/>
+              </a:solidFill>
+              <a:latin typeface="Century Gothic"/>
+            </a:endParaRPr>
+          </a:p>
+        </p:txBody>
+      </p:sp>
+      <p:pic>
+        <p:nvPicPr>
+          <p:cNvPr id="18" name="Picture 17">
+            <a:extLst>
+              <a:ext uri="{FF2B5EF4-FFF2-40B4-BE49-F238E27FC236}">
+                <a16:creationId xmlns:a16="http://schemas.microsoft.com/office/drawing/2014/main" id="{96A81ED6-143C-EB03-E019-D2947E0A8F2E}"/>
+              </a:ext>
+            </a:extLst>
+          </p:cNvPr>
+          <p:cNvPicPr>
+            <a:picLocks noChangeAspect="1"/>
+          </p:cNvPicPr>
+          <p:nvPr/>
+        </p:nvPicPr>
+        <p:blipFill>
+          <a:blip r:embed="rId3"/>
+          <a:stretch>
+            <a:fillRect/>
+          </a:stretch>
+        </p:blipFill>
+        <p:spPr>
+          <a:xfrm>
+            <a:off x="380880" y="1192696"/>
+            <a:ext cx="8169237" cy="4825788"/>
+          </a:xfrm>
+          <a:prstGeom prst="rect">
+            <a:avLst/>
+          </a:prstGeom>
+        </p:spPr>
+      </p:pic>
+    </p:spTree>
+    <p:extLst>
+      <p:ext uri="{BB962C8B-B14F-4D97-AF65-F5344CB8AC3E}">
+        <p14:creationId xmlns:p14="http://schemas.microsoft.com/office/powerpoint/2010/main" val="1027898386"/>
+      </p:ext>
+    </p:extLst>
+  </p:cSld>
+  <p:clrMapOvr>
+    <a:masterClrMapping/>
+  </p:clrMapOvr>
+</p:sld>
+</file>
+
+<file path=ppt/slides/slide12.xml><?xml version="1.0" encoding="utf-8"?>
 <p:sld xmlns:a="http://schemas.openxmlformats.org/drawingml/2006/main" xmlns:r="http://schemas.openxmlformats.org/officeDocument/2006/relationships" xmlns:p="http://schemas.openxmlformats.org/presentationml/2006/main">
   <p:cSld>
     <p:spTree>
@@ -10283,7 +12083,7 @@
 </p:sld>
 </file>
 
-<file path=ppt/slides/slide11.xml><?xml version="1.0" encoding="utf-8"?>
+<file path=ppt/slides/slide13.xml><?xml version="1.0" encoding="utf-8"?>
 <p:sld xmlns:a="http://schemas.openxmlformats.org/drawingml/2006/main" xmlns:r="http://schemas.openxmlformats.org/officeDocument/2006/relationships" xmlns:p="http://schemas.openxmlformats.org/presentationml/2006/main">
   <p:cSld>
     <p:spTree>
@@ -10413,7 +12213,7 @@
                 </a:solidFill>
                 <a:latin typeface="Century Gothic"/>
               </a:rPr>
-              <a:t>11</a:t>
+              <a:t>13</a:t>
             </a:fld>
             <a:endParaRPr lang="en-GB" sz="1200" b="0" strike="noStrike" spc="-1" dirty="0">
               <a:latin typeface="Times New Roman"/>
@@ -10843,7 +12643,7 @@
 </p:sld>
 </file>
 
-<file path=ppt/slides/slide12.xml><?xml version="1.0" encoding="utf-8"?>
+<file path=ppt/slides/slide14.xml><?xml version="1.0" encoding="utf-8"?>
 <p:sld xmlns:a="http://schemas.openxmlformats.org/drawingml/2006/main" xmlns:r="http://schemas.openxmlformats.org/officeDocument/2006/relationships" xmlns:p="http://schemas.openxmlformats.org/presentationml/2006/main">
   <p:cSld>
     <p:spTree>
@@ -10973,7 +12773,7 @@
                 </a:solidFill>
                 <a:latin typeface="Century Gothic"/>
               </a:rPr>
-              <a:t>12</a:t>
+              <a:t>14</a:t>
             </a:fld>
             <a:endParaRPr lang="en-GB" sz="1200" b="0" strike="noStrike" spc="-1" dirty="0">
               <a:latin typeface="Times New Roman"/>
@@ -11351,7 +13151,7 @@
 </p:sld>
 </file>
 
-<file path=ppt/slides/slide13.xml><?xml version="1.0" encoding="utf-8"?>
+<file path=ppt/slides/slide15.xml><?xml version="1.0" encoding="utf-8"?>
 <p:sld xmlns:a="http://schemas.openxmlformats.org/drawingml/2006/main" xmlns:r="http://schemas.openxmlformats.org/officeDocument/2006/relationships" xmlns:p="http://schemas.openxmlformats.org/presentationml/2006/main">
   <p:cSld>
     <p:spTree>
@@ -11481,7 +13281,7 @@
                 </a:solidFill>
                 <a:latin typeface="Century Gothic"/>
               </a:rPr>
-              <a:t>13</a:t>
+              <a:t>15</a:t>
             </a:fld>
             <a:endParaRPr lang="en-GB" sz="1200" b="0" strike="noStrike" spc="-1" dirty="0">
               <a:latin typeface="Times New Roman"/>
@@ -12276,10 +14076,10 @@
       </p:sp>
       <p:pic>
         <p:nvPicPr>
-          <p:cNvPr id="4" name="Picture 3">
+          <p:cNvPr id="3" name="Picture 2">
             <a:extLst>
               <a:ext uri="{FF2B5EF4-FFF2-40B4-BE49-F238E27FC236}">
-                <a16:creationId xmlns:a16="http://schemas.microsoft.com/office/drawing/2014/main" id="{A9172708-06AB-AE7A-4BC0-05B1328EE700}"/>
+                <a16:creationId xmlns:a16="http://schemas.microsoft.com/office/drawing/2014/main" id="{C525295A-47E6-DB8C-78FD-5ACC25A8B445}"/>
               </a:ext>
             </a:extLst>
           </p:cNvPr>
@@ -12301,8 +14101,8 @@
         </p:blipFill>
         <p:spPr>
           <a:xfrm>
-            <a:off x="666509" y="2127309"/>
-            <a:ext cx="7810981" cy="3354962"/>
+            <a:off x="992106" y="2982097"/>
+            <a:ext cx="7159787" cy="3075263"/>
           </a:xfrm>
           <a:prstGeom prst="rect">
             <a:avLst/>
@@ -12687,7 +14487,7 @@
                 </a:solidFill>
                 <a:latin typeface="Century Gothic"/>
               </a:rPr>
-              <a:t>Showcase the utility of Agentic AI combined with XAI:</a:t>
+              <a:t>Showcase the utility of Agentic AI combined with XAI</a:t>
             </a:r>
           </a:p>
           <a:p>
@@ -12704,9 +14504,11 @@
               <a:buClr>
                 <a:srgbClr val="0064C8"/>
               </a:buClr>
+              <a:buFont typeface="Wingdings" panose="05000000000000000000" pitchFamily="2" charset="2"/>
+              <a:buChar char="§"/>
             </a:pPr>
             <a:r>
-              <a:rPr lang="en-US" sz="2000" spc="-1" dirty="0">
+              <a:rPr lang="en-US" sz="1800" spc="-1" dirty="0">
                 <a:solidFill>
                   <a:srgbClr val="000000"/>
                 </a:solidFill>
@@ -12729,15 +14531,17 @@
               <a:buClr>
                 <a:srgbClr val="0064C8"/>
               </a:buClr>
+              <a:buFont typeface="Wingdings" panose="05000000000000000000" pitchFamily="2" charset="2"/>
+              <a:buChar char="§"/>
             </a:pPr>
             <a:r>
-              <a:rPr lang="en-US" sz="2000" spc="-1" dirty="0">
+              <a:rPr lang="en-US" sz="1800" spc="-1" dirty="0">
                 <a:solidFill>
                   <a:srgbClr val="000000"/>
                 </a:solidFill>
                 <a:latin typeface="Century Gothic"/>
               </a:rPr>
-              <a:t>Highlight where using agentic AI can be a advantage over running analysis manually</a:t>
+              <a:t>Highlight where using agentic AI can be an advantage over running analysis manually</a:t>
             </a:r>
           </a:p>
           <a:p>
@@ -15222,40 +17026,797 @@
           </a:p>
         </p:txBody>
       </p:sp>
-      <p:pic>
-        <p:nvPicPr>
-          <p:cNvPr id="12" name="Picture 11">
+      <p:grpSp>
+        <p:nvGrpSpPr>
+          <p:cNvPr id="20" name="Group 19">
             <a:extLst>
               <a:ext uri="{FF2B5EF4-FFF2-40B4-BE49-F238E27FC236}">
-                <a16:creationId xmlns:a16="http://schemas.microsoft.com/office/drawing/2014/main" id="{E40230FB-91FB-0DC9-7BD8-1BE8E2E79A66}"/>
+                <a16:creationId xmlns:a16="http://schemas.microsoft.com/office/drawing/2014/main" id="{81A65B80-1110-F1AF-A893-8B82ECA10662}"/>
               </a:ext>
             </a:extLst>
           </p:cNvPr>
-          <p:cNvPicPr>
-            <a:picLocks noChangeAspect="1"/>
-          </p:cNvPicPr>
+          <p:cNvGrpSpPr>
+            <a:grpSpLocks noChangeAspect="1"/>
+          </p:cNvGrpSpPr>
           <p:nvPr/>
-        </p:nvPicPr>
-        <p:blipFill>
-          <a:blip r:embed="rId3"/>
-          <a:stretch>
-            <a:fillRect/>
-          </a:stretch>
-        </p:blipFill>
-        <p:spPr>
+        </p:nvGrpSpPr>
+        <p:grpSpPr>
           <a:xfrm>
-            <a:off x="380880" y="1192696"/>
-            <a:ext cx="8177259" cy="4495156"/>
+            <a:off x="380879" y="1186718"/>
+            <a:ext cx="8171609" cy="4610073"/>
+            <a:chOff x="232995" y="406630"/>
+            <a:chExt cx="10956807" cy="6181362"/>
           </a:xfrm>
-          <a:prstGeom prst="rect">
-            <a:avLst/>
-          </a:prstGeom>
-        </p:spPr>
-      </p:pic>
+        </p:grpSpPr>
+        <p:sp>
+          <p:nvSpPr>
+            <p:cNvPr id="2" name="TextBox 1">
+              <a:extLst>
+                <a:ext uri="{FF2B5EF4-FFF2-40B4-BE49-F238E27FC236}">
+                  <a16:creationId xmlns:a16="http://schemas.microsoft.com/office/drawing/2014/main" id="{9803C720-5E38-494F-5EED-73C1A8624CA2}"/>
+                </a:ext>
+              </a:extLst>
+            </p:cNvPr>
+            <p:cNvSpPr txBox="1"/>
+            <p:nvPr/>
+          </p:nvSpPr>
+          <p:spPr>
+            <a:xfrm>
+              <a:off x="232995" y="4144987"/>
+              <a:ext cx="4168792" cy="2443005"/>
+            </a:xfrm>
+            <a:prstGeom prst="rect">
+              <a:avLst/>
+            </a:prstGeom>
+            <a:noFill/>
+          </p:spPr>
+          <p:txBody>
+            <a:bodyPr wrap="square">
+              <a:spAutoFit/>
+            </a:bodyPr>
+            <a:lstStyle/>
+            <a:p>
+              <a:pPr algn="just"/>
+              <a:r>
+                <a:rPr lang="en-US" sz="1400" b="1" dirty="0"/>
+                <a:t>Comparing XAI methods</a:t>
+              </a:r>
+            </a:p>
+            <a:p>
+              <a:pPr marL="171450" indent="-171450" algn="just">
+                <a:buFont typeface="Arial" panose="020B0604020202020204" pitchFamily="34" charset="0"/>
+                <a:buChar char="•"/>
+              </a:pPr>
+              <a:endParaRPr lang="en-US" sz="1200" b="1" dirty="0"/>
+            </a:p>
+            <a:p>
+              <a:pPr marL="171450" indent="-171450" algn="just">
+                <a:buFont typeface="Arial" panose="020B0604020202020204" pitchFamily="34" charset="0"/>
+                <a:buChar char="•"/>
+              </a:pPr>
+              <a:r>
+                <a:rPr lang="en-US" sz="800" b="1" dirty="0"/>
+                <a:t>Agreement: </a:t>
+              </a:r>
+              <a:r>
+                <a:rPr lang="en-US" sz="800" dirty="0"/>
+                <a:t>Both methods converge on the morpholine-like ring as the critical pharmacophore. </a:t>
+              </a:r>
+              <a:r>
+                <a:rPr lang="en-US" sz="800" dirty="0" err="1"/>
+                <a:t>MolAnchor</a:t>
+              </a:r>
+              <a:r>
+                <a:rPr lang="en-US" sz="800" dirty="0"/>
+                <a:t> identifies the ring as a cohesive unit, while SHAP confirms that the atoms comprising this ring are indeed the most influential.</a:t>
+              </a:r>
+            </a:p>
+            <a:p>
+              <a:pPr algn="just"/>
+              <a:endParaRPr lang="en-US" sz="800" dirty="0"/>
+            </a:p>
+            <a:p>
+              <a:pPr marL="171450" indent="-171450" algn="just">
+                <a:buFont typeface="Arial" panose="020B0604020202020204" pitchFamily="34" charset="0"/>
+                <a:buChar char="•"/>
+              </a:pPr>
+              <a:r>
+                <a:rPr lang="en-US" sz="800" b="1" dirty="0"/>
+                <a:t>Disagreement: </a:t>
+              </a:r>
+              <a:r>
+                <a:rPr lang="en-US" sz="800" dirty="0" err="1"/>
+                <a:t>MolAnchor</a:t>
+              </a:r>
+              <a:r>
+                <a:rPr lang="en-US" sz="800" dirty="0"/>
+                <a:t> focuses strictly on the highest-precision fragment, potentially downplaying the contribution of the aromatic substituents (benzyl/thiophene) that SHAP would assign non-zero values to. </a:t>
+              </a:r>
+              <a:r>
+                <a:rPr lang="en-US" sz="800" dirty="0" err="1"/>
+                <a:t>MolAnchor</a:t>
+              </a:r>
+              <a:r>
+                <a:rPr lang="en-US" sz="800" dirty="0"/>
+                <a:t> is more "binary" (is this fragment present?), while SHAP is more "continuous" (how much does each atom contribute?).</a:t>
+              </a:r>
+            </a:p>
+          </p:txBody>
+        </p:sp>
+        <p:grpSp>
+          <p:nvGrpSpPr>
+            <p:cNvPr id="3" name="Group 2">
+              <a:extLst>
+                <a:ext uri="{FF2B5EF4-FFF2-40B4-BE49-F238E27FC236}">
+                  <a16:creationId xmlns:a16="http://schemas.microsoft.com/office/drawing/2014/main" id="{98A01790-818B-0A8F-30E5-1112281C9B36}"/>
+                </a:ext>
+              </a:extLst>
+            </p:cNvPr>
+            <p:cNvGrpSpPr/>
+            <p:nvPr/>
+          </p:nvGrpSpPr>
+          <p:grpSpPr>
+            <a:xfrm>
+              <a:off x="232995" y="835775"/>
+              <a:ext cx="1774658" cy="2310063"/>
+              <a:chOff x="990492" y="2511372"/>
+              <a:chExt cx="1774658" cy="2310063"/>
+            </a:xfrm>
+          </p:grpSpPr>
+          <p:sp>
+            <p:nvSpPr>
+              <p:cNvPr id="4" name="Rectangle 3">
+                <a:extLst>
+                  <a:ext uri="{FF2B5EF4-FFF2-40B4-BE49-F238E27FC236}">
+                    <a16:creationId xmlns:a16="http://schemas.microsoft.com/office/drawing/2014/main" id="{29C55CA4-9FFE-F8C7-14D1-7771639D14E4}"/>
+                  </a:ext>
+                </a:extLst>
+              </p:cNvPr>
+              <p:cNvSpPr/>
+              <p:nvPr/>
+            </p:nvSpPr>
+            <p:spPr>
+              <a:xfrm>
+                <a:off x="990492" y="2511372"/>
+                <a:ext cx="1774658" cy="2310063"/>
+              </a:xfrm>
+              <a:prstGeom prst="rect">
+                <a:avLst/>
+              </a:prstGeom>
+              <a:solidFill>
+                <a:schemeClr val="accent1">
+                  <a:lumMod val="20000"/>
+                  <a:lumOff val="80000"/>
+                </a:schemeClr>
+              </a:solidFill>
+              <a:ln>
+                <a:solidFill>
+                  <a:schemeClr val="tx2">
+                    <a:lumMod val="25000"/>
+                    <a:lumOff val="75000"/>
+                  </a:schemeClr>
+                </a:solidFill>
+              </a:ln>
+            </p:spPr>
+            <p:style>
+              <a:lnRef idx="2">
+                <a:schemeClr val="accent1">
+                  <a:shade val="15000"/>
+                </a:schemeClr>
+              </a:lnRef>
+              <a:fillRef idx="1">
+                <a:schemeClr val="accent1"/>
+              </a:fillRef>
+              <a:effectRef idx="0">
+                <a:schemeClr val="accent1"/>
+              </a:effectRef>
+              <a:fontRef idx="minor">
+                <a:schemeClr val="lt1"/>
+              </a:fontRef>
+            </p:style>
+            <p:txBody>
+              <a:bodyPr rtlCol="0" anchor="ctr"/>
+              <a:lstStyle/>
+              <a:p>
+                <a:pPr algn="ctr"/>
+                <a:endParaRPr lang="en-US" dirty="0"/>
+              </a:p>
+            </p:txBody>
+          </p:sp>
+          <p:pic>
+            <p:nvPicPr>
+              <p:cNvPr id="5" name="Graphic 4" descr="Customer review with solid fill">
+                <a:extLst>
+                  <a:ext uri="{FF2B5EF4-FFF2-40B4-BE49-F238E27FC236}">
+                    <a16:creationId xmlns:a16="http://schemas.microsoft.com/office/drawing/2014/main" id="{BC3098E3-543E-39F7-8A4E-3EA3BD9DACFE}"/>
+                  </a:ext>
+                </a:extLst>
+              </p:cNvPr>
+              <p:cNvPicPr>
+                <a:picLocks noChangeAspect="1"/>
+              </p:cNvPicPr>
+              <p:nvPr/>
+            </p:nvPicPr>
+            <p:blipFill>
+              <a:blip r:embed="rId3">
+                <a:extLst>
+                  <a:ext uri="{96DAC541-7B7A-43D3-8B79-37D633B846F1}">
+                    <asvg:svgBlip xmlns:asvg="http://schemas.microsoft.com/office/drawing/2016/SVG/main" r:embed="rId4"/>
+                  </a:ext>
+                </a:extLst>
+              </a:blip>
+              <a:stretch>
+                <a:fillRect/>
+              </a:stretch>
+            </p:blipFill>
+            <p:spPr>
+              <a:xfrm>
+                <a:off x="1400027" y="3700649"/>
+                <a:ext cx="965534" cy="965534"/>
+              </a:xfrm>
+              <a:prstGeom prst="rect">
+                <a:avLst/>
+              </a:prstGeom>
+            </p:spPr>
+          </p:pic>
+          <p:pic>
+            <p:nvPicPr>
+              <p:cNvPr id="6" name="Picture 5">
+                <a:extLst>
+                  <a:ext uri="{FF2B5EF4-FFF2-40B4-BE49-F238E27FC236}">
+                    <a16:creationId xmlns:a16="http://schemas.microsoft.com/office/drawing/2014/main" id="{A6C08A7B-D7B2-8D7E-7551-DA70599DDC7E}"/>
+                  </a:ext>
+                </a:extLst>
+              </p:cNvPr>
+              <p:cNvPicPr>
+                <a:picLocks noChangeAspect="1"/>
+              </p:cNvPicPr>
+              <p:nvPr/>
+            </p:nvPicPr>
+            <p:blipFill>
+              <a:blip r:embed="rId5"/>
+              <a:stretch>
+                <a:fillRect/>
+              </a:stretch>
+            </p:blipFill>
+            <p:spPr>
+              <a:xfrm>
+                <a:off x="1126882" y="2607575"/>
+                <a:ext cx="1525117" cy="996871"/>
+              </a:xfrm>
+              <a:prstGeom prst="rect">
+                <a:avLst/>
+              </a:prstGeom>
+            </p:spPr>
+          </p:pic>
+        </p:grpSp>
+        <p:sp>
+          <p:nvSpPr>
+            <p:cNvPr id="7" name="Arrow: Right 6">
+              <a:extLst>
+                <a:ext uri="{FF2B5EF4-FFF2-40B4-BE49-F238E27FC236}">
+                  <a16:creationId xmlns:a16="http://schemas.microsoft.com/office/drawing/2014/main" id="{97128B13-4612-273D-93A3-BB4FE0ECD72E}"/>
+                </a:ext>
+              </a:extLst>
+            </p:cNvPr>
+            <p:cNvSpPr/>
+            <p:nvPr/>
+          </p:nvSpPr>
+          <p:spPr>
+            <a:xfrm>
+              <a:off x="2327498" y="1803354"/>
+              <a:ext cx="666746" cy="374904"/>
+            </a:xfrm>
+            <a:prstGeom prst="rightArrow">
+              <a:avLst/>
+            </a:prstGeom>
+          </p:spPr>
+          <p:style>
+            <a:lnRef idx="2">
+              <a:schemeClr val="accent1">
+                <a:shade val="15000"/>
+              </a:schemeClr>
+            </a:lnRef>
+            <a:fillRef idx="1">
+              <a:schemeClr val="accent1"/>
+            </a:fillRef>
+            <a:effectRef idx="0">
+              <a:schemeClr val="accent1"/>
+            </a:effectRef>
+            <a:fontRef idx="minor">
+              <a:schemeClr val="lt1"/>
+            </a:fontRef>
+          </p:style>
+          <p:txBody>
+            <a:bodyPr rtlCol="0" anchor="ctr"/>
+            <a:lstStyle/>
+            <a:p>
+              <a:pPr algn="ctr"/>
+              <a:endParaRPr lang="en-US"/>
+            </a:p>
+          </p:txBody>
+        </p:sp>
+        <p:sp>
+          <p:nvSpPr>
+            <p:cNvPr id="8" name="TextBox 7">
+              <a:extLst>
+                <a:ext uri="{FF2B5EF4-FFF2-40B4-BE49-F238E27FC236}">
+                  <a16:creationId xmlns:a16="http://schemas.microsoft.com/office/drawing/2014/main" id="{BFA4F87D-A515-0617-5B19-E065DFAAA219}"/>
+                </a:ext>
+              </a:extLst>
+            </p:cNvPr>
+            <p:cNvSpPr txBox="1"/>
+            <p:nvPr/>
+          </p:nvSpPr>
+          <p:spPr>
+            <a:xfrm>
+              <a:off x="4038832" y="406630"/>
+              <a:ext cx="2444839" cy="438472"/>
+            </a:xfrm>
+            <a:prstGeom prst="rect">
+              <a:avLst/>
+            </a:prstGeom>
+            <a:noFill/>
+          </p:spPr>
+          <p:txBody>
+            <a:bodyPr wrap="square" rtlCol="0">
+              <a:spAutoFit/>
+            </a:bodyPr>
+            <a:lstStyle/>
+            <a:p>
+              <a:pPr algn="ctr"/>
+              <a:r>
+                <a:rPr lang="en-US" sz="1600" b="1" dirty="0" err="1"/>
+                <a:t>MolAnchor</a:t>
+              </a:r>
+              <a:endParaRPr lang="de-DE" sz="1600" b="1" dirty="0"/>
+            </a:p>
+          </p:txBody>
+        </p:sp>
+        <p:sp>
+          <p:nvSpPr>
+            <p:cNvPr id="9" name="TextBox 8">
+              <a:extLst>
+                <a:ext uri="{FF2B5EF4-FFF2-40B4-BE49-F238E27FC236}">
+                  <a16:creationId xmlns:a16="http://schemas.microsoft.com/office/drawing/2014/main" id="{5B5E5C40-61E5-79E5-C05A-CA9180634650}"/>
+                </a:ext>
+              </a:extLst>
+            </p:cNvPr>
+            <p:cNvSpPr txBox="1"/>
+            <p:nvPr/>
+          </p:nvSpPr>
+          <p:spPr>
+            <a:xfrm>
+              <a:off x="8311383" y="406630"/>
+              <a:ext cx="2444839" cy="438472"/>
+            </a:xfrm>
+            <a:prstGeom prst="rect">
+              <a:avLst/>
+            </a:prstGeom>
+            <a:noFill/>
+          </p:spPr>
+          <p:txBody>
+            <a:bodyPr wrap="square" rtlCol="0">
+              <a:spAutoFit/>
+            </a:bodyPr>
+            <a:lstStyle/>
+            <a:p>
+              <a:pPr algn="ctr"/>
+              <a:r>
+                <a:rPr lang="en-US" sz="1600" b="1" dirty="0"/>
+                <a:t>SHAP</a:t>
+              </a:r>
+              <a:endParaRPr lang="de-DE" sz="1600" b="1" dirty="0"/>
+            </a:p>
+          </p:txBody>
+        </p:sp>
+        <p:sp>
+          <p:nvSpPr>
+            <p:cNvPr id="10" name="Arrow: Right 9">
+              <a:extLst>
+                <a:ext uri="{FF2B5EF4-FFF2-40B4-BE49-F238E27FC236}">
+                  <a16:creationId xmlns:a16="http://schemas.microsoft.com/office/drawing/2014/main" id="{A3301E51-4E33-A5C6-58D1-99F3B3249BC8}"/>
+                </a:ext>
+              </a:extLst>
+            </p:cNvPr>
+            <p:cNvSpPr/>
+            <p:nvPr/>
+          </p:nvSpPr>
+          <p:spPr>
+            <a:xfrm rot="5400000">
+              <a:off x="786951" y="3558887"/>
+              <a:ext cx="666746" cy="374904"/>
+            </a:xfrm>
+            <a:prstGeom prst="rightArrow">
+              <a:avLst/>
+            </a:prstGeom>
+          </p:spPr>
+          <p:style>
+            <a:lnRef idx="2">
+              <a:schemeClr val="accent1">
+                <a:shade val="15000"/>
+              </a:schemeClr>
+            </a:lnRef>
+            <a:fillRef idx="1">
+              <a:schemeClr val="accent1"/>
+            </a:fillRef>
+            <a:effectRef idx="0">
+              <a:schemeClr val="accent1"/>
+            </a:effectRef>
+            <a:fontRef idx="minor">
+              <a:schemeClr val="lt1"/>
+            </a:fontRef>
+          </p:style>
+          <p:txBody>
+            <a:bodyPr rtlCol="0" anchor="ctr"/>
+            <a:lstStyle/>
+            <a:p>
+              <a:pPr algn="ctr"/>
+              <a:endParaRPr lang="en-US"/>
+            </a:p>
+          </p:txBody>
+        </p:sp>
+        <p:grpSp>
+          <p:nvGrpSpPr>
+            <p:cNvPr id="11" name="Group 10">
+              <a:extLst>
+                <a:ext uri="{FF2B5EF4-FFF2-40B4-BE49-F238E27FC236}">
+                  <a16:creationId xmlns:a16="http://schemas.microsoft.com/office/drawing/2014/main" id="{40F85673-9AEE-ADD3-DCC6-1FAEC5F6565D}"/>
+                </a:ext>
+              </a:extLst>
+            </p:cNvPr>
+            <p:cNvGrpSpPr/>
+            <p:nvPr/>
+          </p:nvGrpSpPr>
+          <p:grpSpPr>
+            <a:xfrm>
+              <a:off x="4841173" y="4522527"/>
+              <a:ext cx="6165816" cy="573974"/>
+              <a:chOff x="4841173" y="4193969"/>
+              <a:chExt cx="6165816" cy="573974"/>
+            </a:xfrm>
+          </p:grpSpPr>
+          <p:cxnSp>
+            <p:nvCxnSpPr>
+              <p:cNvPr id="13" name="Straight Arrow Connector 12">
+                <a:extLst>
+                  <a:ext uri="{FF2B5EF4-FFF2-40B4-BE49-F238E27FC236}">
+                    <a16:creationId xmlns:a16="http://schemas.microsoft.com/office/drawing/2014/main" id="{D7F471AB-B13A-E0F6-8895-3D2EF3A9C1DF}"/>
+                  </a:ext>
+                </a:extLst>
+              </p:cNvPr>
+              <p:cNvCxnSpPr>
+                <a:cxnSpLocks/>
+              </p:cNvCxnSpPr>
+              <p:nvPr/>
+            </p:nvCxnSpPr>
+            <p:spPr>
+              <a:xfrm>
+                <a:off x="4841173" y="4480956"/>
+                <a:ext cx="1800000" cy="0"/>
+              </a:xfrm>
+              <a:prstGeom prst="straightConnector1">
+                <a:avLst/>
+              </a:prstGeom>
+              <a:ln>
+                <a:tailEnd type="triangle"/>
+              </a:ln>
+            </p:spPr>
+            <p:style>
+              <a:lnRef idx="2">
+                <a:schemeClr val="accent1"/>
+              </a:lnRef>
+              <a:fillRef idx="0">
+                <a:schemeClr val="accent1"/>
+              </a:fillRef>
+              <a:effectRef idx="1">
+                <a:schemeClr val="accent1"/>
+              </a:effectRef>
+              <a:fontRef idx="minor">
+                <a:schemeClr val="tx1"/>
+              </a:fontRef>
+            </p:style>
+          </p:cxnSp>
+          <p:sp>
+            <p:nvSpPr>
+              <p:cNvPr id="14" name="Rectangle: Rounded Corners 13">
+                <a:extLst>
+                  <a:ext uri="{FF2B5EF4-FFF2-40B4-BE49-F238E27FC236}">
+                    <a16:creationId xmlns:a16="http://schemas.microsoft.com/office/drawing/2014/main" id="{52C02012-CF9D-7AF4-DB5E-4F719C94B012}"/>
+                  </a:ext>
+                </a:extLst>
+              </p:cNvPr>
+              <p:cNvSpPr/>
+              <p:nvPr/>
+            </p:nvSpPr>
+            <p:spPr>
+              <a:xfrm>
+                <a:off x="7278137" y="4193969"/>
+                <a:ext cx="3728852" cy="573974"/>
+              </a:xfrm>
+              <a:prstGeom prst="roundRect">
+                <a:avLst/>
+              </a:prstGeom>
+              <a:solidFill>
+                <a:schemeClr val="bg1"/>
+              </a:solidFill>
+            </p:spPr>
+            <p:style>
+              <a:lnRef idx="2">
+                <a:schemeClr val="accent4">
+                  <a:shade val="15000"/>
+                </a:schemeClr>
+              </a:lnRef>
+              <a:fillRef idx="1">
+                <a:schemeClr val="accent4"/>
+              </a:fillRef>
+              <a:effectRef idx="0">
+                <a:schemeClr val="accent4"/>
+              </a:effectRef>
+              <a:fontRef idx="minor">
+                <a:schemeClr val="lt1"/>
+              </a:fontRef>
+            </p:style>
+            <p:txBody>
+              <a:bodyPr rtlCol="0" anchor="ctr"/>
+              <a:lstStyle/>
+              <a:p>
+                <a:pPr algn="ctr"/>
+                <a:r>
+                  <a:rPr lang="en-US" sz="1100" dirty="0">
+                    <a:solidFill>
+                      <a:schemeClr val="tx1"/>
+                    </a:solidFill>
+                  </a:rPr>
+                  <a:t>Morpholine-like ring as the critical pharmacophore </a:t>
+                </a:r>
+                <a:endParaRPr lang="de-DE" sz="1100" dirty="0">
+                  <a:solidFill>
+                    <a:schemeClr val="tx1"/>
+                  </a:solidFill>
+                </a:endParaRPr>
+              </a:p>
+            </p:txBody>
+          </p:sp>
+        </p:grpSp>
+        <p:grpSp>
+          <p:nvGrpSpPr>
+            <p:cNvPr id="15" name="Group 14">
+              <a:extLst>
+                <a:ext uri="{FF2B5EF4-FFF2-40B4-BE49-F238E27FC236}">
+                  <a16:creationId xmlns:a16="http://schemas.microsoft.com/office/drawing/2014/main" id="{2413F157-B8CA-D703-62EE-D4B833AB7125}"/>
+                </a:ext>
+              </a:extLst>
+            </p:cNvPr>
+            <p:cNvGrpSpPr/>
+            <p:nvPr/>
+          </p:nvGrpSpPr>
+          <p:grpSpPr>
+            <a:xfrm>
+              <a:off x="4841173" y="5396256"/>
+              <a:ext cx="6165816" cy="1111401"/>
+              <a:chOff x="4841173" y="5067698"/>
+              <a:chExt cx="6165816" cy="1111401"/>
+            </a:xfrm>
+          </p:grpSpPr>
+          <p:cxnSp>
+            <p:nvCxnSpPr>
+              <p:cNvPr id="16" name="Straight Arrow Connector 15">
+                <a:extLst>
+                  <a:ext uri="{FF2B5EF4-FFF2-40B4-BE49-F238E27FC236}">
+                    <a16:creationId xmlns:a16="http://schemas.microsoft.com/office/drawing/2014/main" id="{E191783D-2D08-3AAC-2FF0-E2EC291F5384}"/>
+                  </a:ext>
+                </a:extLst>
+              </p:cNvPr>
+              <p:cNvCxnSpPr>
+                <a:cxnSpLocks/>
+              </p:cNvCxnSpPr>
+              <p:nvPr/>
+            </p:nvCxnSpPr>
+            <p:spPr>
+              <a:xfrm>
+                <a:off x="4841173" y="5623398"/>
+                <a:ext cx="1800000" cy="0"/>
+              </a:xfrm>
+              <a:prstGeom prst="straightConnector1">
+                <a:avLst/>
+              </a:prstGeom>
+              <a:ln>
+                <a:tailEnd type="triangle"/>
+              </a:ln>
+            </p:spPr>
+            <p:style>
+              <a:lnRef idx="2">
+                <a:schemeClr val="accent1"/>
+              </a:lnRef>
+              <a:fillRef idx="0">
+                <a:schemeClr val="accent1"/>
+              </a:fillRef>
+              <a:effectRef idx="1">
+                <a:schemeClr val="accent1"/>
+              </a:effectRef>
+              <a:fontRef idx="minor">
+                <a:schemeClr val="tx1"/>
+              </a:fontRef>
+            </p:style>
+          </p:cxnSp>
+          <p:sp>
+            <p:nvSpPr>
+              <p:cNvPr id="17" name="Rectangle: Rounded Corners 16">
+                <a:extLst>
+                  <a:ext uri="{FF2B5EF4-FFF2-40B4-BE49-F238E27FC236}">
+                    <a16:creationId xmlns:a16="http://schemas.microsoft.com/office/drawing/2014/main" id="{392DA2FC-B611-0481-11FA-589AFCCD6635}"/>
+                  </a:ext>
+                </a:extLst>
+              </p:cNvPr>
+              <p:cNvSpPr/>
+              <p:nvPr/>
+            </p:nvSpPr>
+            <p:spPr>
+              <a:xfrm>
+                <a:off x="7278137" y="5067698"/>
+                <a:ext cx="3728852" cy="1111401"/>
+              </a:xfrm>
+              <a:prstGeom prst="roundRect">
+                <a:avLst/>
+              </a:prstGeom>
+              <a:solidFill>
+                <a:schemeClr val="bg1"/>
+              </a:solidFill>
+            </p:spPr>
+            <p:style>
+              <a:lnRef idx="2">
+                <a:schemeClr val="accent4">
+                  <a:shade val="15000"/>
+                </a:schemeClr>
+              </a:lnRef>
+              <a:fillRef idx="1">
+                <a:schemeClr val="accent4"/>
+              </a:fillRef>
+              <a:effectRef idx="0">
+                <a:schemeClr val="accent4"/>
+              </a:effectRef>
+              <a:fontRef idx="minor">
+                <a:schemeClr val="lt1"/>
+              </a:fontRef>
+            </p:style>
+            <p:txBody>
+              <a:bodyPr rtlCol="0" anchor="ctr"/>
+              <a:lstStyle/>
+              <a:p>
+                <a:r>
+                  <a:rPr lang="en-US" sz="1100" b="1" dirty="0" err="1">
+                    <a:solidFill>
+                      <a:schemeClr val="tx1"/>
+                    </a:solidFill>
+                  </a:rPr>
+                  <a:t>MolAnchor</a:t>
+                </a:r>
+                <a:r>
+                  <a:rPr lang="en-US" sz="1100" b="1" dirty="0">
+                    <a:solidFill>
+                      <a:schemeClr val="tx1"/>
+                    </a:solidFill>
+                  </a:rPr>
+                  <a:t> </a:t>
+                </a:r>
+                <a:r>
+                  <a:rPr lang="en-US" sz="1100" dirty="0">
+                    <a:solidFill>
+                      <a:schemeClr val="tx1"/>
+                    </a:solidFill>
+                  </a:rPr>
+                  <a:t>- focus on the highest-precision fragment</a:t>
+                </a:r>
+              </a:p>
+              <a:p>
+                <a:endParaRPr lang="en-US" sz="1100" dirty="0">
+                  <a:solidFill>
+                    <a:schemeClr val="tx1"/>
+                  </a:solidFill>
+                </a:endParaRPr>
+              </a:p>
+              <a:p>
+                <a:r>
+                  <a:rPr lang="en-US" sz="1100" b="1" dirty="0">
+                    <a:solidFill>
+                      <a:schemeClr val="tx1"/>
+                    </a:solidFill>
+                  </a:rPr>
+                  <a:t>SHAP</a:t>
+                </a:r>
+                <a:r>
+                  <a:rPr lang="en-US" sz="1100" dirty="0">
+                    <a:solidFill>
+                      <a:schemeClr val="tx1"/>
+                    </a:solidFill>
+                  </a:rPr>
+                  <a:t> – focus on atom contribution</a:t>
+                </a:r>
+                <a:endParaRPr lang="de-DE" sz="1100" dirty="0">
+                  <a:solidFill>
+                    <a:schemeClr val="tx1"/>
+                  </a:solidFill>
+                </a:endParaRPr>
+              </a:p>
+            </p:txBody>
+          </p:sp>
+        </p:grpSp>
+        <p:pic>
+          <p:nvPicPr>
+            <p:cNvPr id="18" name="Picture 17" descr="A molecule of a chemical structure&#10;&#10;AI-generated content may be incorrect.">
+              <a:extLst>
+                <a:ext uri="{FF2B5EF4-FFF2-40B4-BE49-F238E27FC236}">
+                  <a16:creationId xmlns:a16="http://schemas.microsoft.com/office/drawing/2014/main" id="{B00FBE90-B9A0-71D7-78B9-0470979D39BB}"/>
+                </a:ext>
+              </a:extLst>
+            </p:cNvPr>
+            <p:cNvPicPr>
+              <a:picLocks noChangeAspect="1"/>
+            </p:cNvPicPr>
+            <p:nvPr/>
+          </p:nvPicPr>
+          <p:blipFill>
+            <a:blip r:embed="rId6">
+              <a:extLst>
+                <a:ext uri="{28A0092B-C50C-407E-A947-70E740481C1C}">
+                  <a14:useLocalDpi xmlns:a14="http://schemas.microsoft.com/office/drawing/2010/main" val="0"/>
+                </a:ext>
+              </a:extLst>
+            </a:blip>
+            <a:srcRect l="4101" t="21936" r="4499" b="21811"/>
+            <a:stretch/>
+          </p:blipFill>
+          <p:spPr>
+            <a:xfrm>
+              <a:off x="3605250" y="1065529"/>
+              <a:ext cx="3312000" cy="2038388"/>
+            </a:xfrm>
+            <a:prstGeom prst="rect">
+              <a:avLst/>
+            </a:prstGeom>
+          </p:spPr>
+        </p:pic>
+        <p:pic>
+          <p:nvPicPr>
+            <p:cNvPr id="19" name="Picture 18" descr="A structure of a chemical formula&#10;&#10;AI-generated content may be incorrect.">
+              <a:extLst>
+                <a:ext uri="{FF2B5EF4-FFF2-40B4-BE49-F238E27FC236}">
+                  <a16:creationId xmlns:a16="http://schemas.microsoft.com/office/drawing/2014/main" id="{8503AC68-78EB-31F3-DB36-6A64117ACE03}"/>
+                </a:ext>
+              </a:extLst>
+            </p:cNvPr>
+            <p:cNvPicPr>
+              <a:picLocks noChangeAspect="1"/>
+            </p:cNvPicPr>
+            <p:nvPr/>
+          </p:nvPicPr>
+          <p:blipFill>
+            <a:blip r:embed="rId7">
+              <a:extLst>
+                <a:ext uri="{28A0092B-C50C-407E-A947-70E740481C1C}">
+                  <a14:useLocalDpi xmlns:a14="http://schemas.microsoft.com/office/drawing/2010/main" val="0"/>
+                </a:ext>
+              </a:extLst>
+            </a:blip>
+            <a:srcRect l="11528" t="25207" r="11064" b="25192"/>
+            <a:stretch/>
+          </p:blipFill>
+          <p:spPr>
+            <a:xfrm>
+              <a:off x="7877802" y="1023609"/>
+              <a:ext cx="3312000" cy="2122229"/>
+            </a:xfrm>
+            <a:prstGeom prst="rect">
+              <a:avLst/>
+            </a:prstGeom>
+          </p:spPr>
+        </p:pic>
+      </p:grpSp>
     </p:spTree>
     <p:extLst>
       <p:ext uri="{BB962C8B-B14F-4D97-AF65-F5344CB8AC3E}">
-        <p14:creationId xmlns:p14="http://schemas.microsoft.com/office/powerpoint/2010/main" val="497639913"/>
+        <p14:creationId xmlns:p14="http://schemas.microsoft.com/office/powerpoint/2010/main" val="3302856774"/>
       </p:ext>
     </p:extLst>
   </p:cSld>
@@ -15288,6 +17849,1138 @@
           <a:chExt cx="0" cy="0"/>
         </a:xfrm>
       </p:grpSpPr>
+      <p:grpSp>
+        <p:nvGrpSpPr>
+          <p:cNvPr id="49" name="Group 48">
+            <a:extLst>
+              <a:ext uri="{FF2B5EF4-FFF2-40B4-BE49-F238E27FC236}">
+                <a16:creationId xmlns:a16="http://schemas.microsoft.com/office/drawing/2014/main" id="{C31E6F76-4E7C-1639-9021-CCC76ADA5882}"/>
+              </a:ext>
+            </a:extLst>
+          </p:cNvPr>
+          <p:cNvGrpSpPr>
+            <a:grpSpLocks noChangeAspect="1"/>
+          </p:cNvGrpSpPr>
+          <p:nvPr/>
+        </p:nvGrpSpPr>
+        <p:grpSpPr>
+          <a:xfrm>
+            <a:off x="380879" y="1191667"/>
+            <a:ext cx="8601794" cy="4693209"/>
+            <a:chOff x="232995" y="406630"/>
+            <a:chExt cx="11549227" cy="6301353"/>
+          </a:xfrm>
+        </p:grpSpPr>
+        <p:sp>
+          <p:nvSpPr>
+            <p:cNvPr id="12" name="TextBox 11">
+              <a:extLst>
+                <a:ext uri="{FF2B5EF4-FFF2-40B4-BE49-F238E27FC236}">
+                  <a16:creationId xmlns:a16="http://schemas.microsoft.com/office/drawing/2014/main" id="{84F2BFB3-8FF2-554F-E79D-F8FED4C6DB14}"/>
+                </a:ext>
+              </a:extLst>
+            </p:cNvPr>
+            <p:cNvSpPr txBox="1"/>
+            <p:nvPr/>
+          </p:nvSpPr>
+          <p:spPr>
+            <a:xfrm>
+              <a:off x="232995" y="4144987"/>
+              <a:ext cx="4168792" cy="2562996"/>
+            </a:xfrm>
+            <a:prstGeom prst="rect">
+              <a:avLst/>
+            </a:prstGeom>
+            <a:noFill/>
+          </p:spPr>
+          <p:txBody>
+            <a:bodyPr wrap="square">
+              <a:spAutoFit/>
+            </a:bodyPr>
+            <a:lstStyle/>
+            <a:p>
+              <a:pPr algn="just"/>
+              <a:r>
+                <a:rPr lang="en-US" sz="1400" b="1" dirty="0"/>
+                <a:t>Comparing XAI methods</a:t>
+              </a:r>
+            </a:p>
+            <a:p>
+              <a:pPr marL="171450" indent="-171450" algn="just">
+                <a:buFont typeface="Arial" panose="020B0604020202020204" pitchFamily="34" charset="0"/>
+                <a:buChar char="•"/>
+              </a:pPr>
+              <a:endParaRPr lang="en-US" sz="1200" b="1" dirty="0"/>
+            </a:p>
+            <a:p>
+              <a:pPr marL="171450" indent="-171450" algn="just">
+                <a:buFont typeface="Arial" panose="020B0604020202020204" pitchFamily="34" charset="0"/>
+                <a:buChar char="•"/>
+              </a:pPr>
+              <a:r>
+                <a:rPr lang="en-US" sz="800" b="1" dirty="0"/>
+                <a:t>Agreement: </a:t>
+              </a:r>
+              <a:r>
+                <a:rPr lang="en-US" sz="800" dirty="0"/>
+                <a:t>Both methods highlight that modifications to the R-groups attached to the morpholine ring are the most sensitive levers for changing bioactivity.</a:t>
+              </a:r>
+            </a:p>
+            <a:p>
+              <a:pPr algn="just"/>
+              <a:endParaRPr lang="en-US" sz="800" b="1" dirty="0"/>
+            </a:p>
+            <a:p>
+              <a:pPr marL="171450" indent="-171450" algn="just">
+                <a:buFont typeface="Arial" panose="020B0604020202020204" pitchFamily="34" charset="0"/>
+                <a:buChar char="•"/>
+              </a:pPr>
+              <a:r>
+                <a:rPr lang="en-US" sz="800" b="1" dirty="0"/>
+                <a:t>Disagreement: </a:t>
+              </a:r>
+              <a:r>
+                <a:rPr lang="en-US" sz="800" dirty="0" err="1"/>
+                <a:t>MolCE</a:t>
+              </a:r>
+              <a:r>
+                <a:rPr lang="en-US" sz="800" dirty="0"/>
+                <a:t> provides a theoretical contrastive feature (a specific R-group that is "anti-activating"). Counterfactuals provides concrete examples of inactive molecules. </a:t>
+              </a:r>
+              <a:r>
+                <a:rPr lang="en-US" sz="800" dirty="0" err="1"/>
+                <a:t>MolCE</a:t>
+              </a:r>
+              <a:r>
+                <a:rPr lang="en-US" sz="800" dirty="0"/>
+                <a:t> might suggest an R-group not present in the immediate neighborhood of the query, whereas Counterfactuals are constrained by the available library of R-groups for substitution.</a:t>
+              </a:r>
+            </a:p>
+          </p:txBody>
+        </p:sp>
+        <p:grpSp>
+          <p:nvGrpSpPr>
+            <p:cNvPr id="21" name="Group 20">
+              <a:extLst>
+                <a:ext uri="{FF2B5EF4-FFF2-40B4-BE49-F238E27FC236}">
+                  <a16:creationId xmlns:a16="http://schemas.microsoft.com/office/drawing/2014/main" id="{851E801A-07D0-EC46-EC69-B1E3BDC4A0EE}"/>
+                </a:ext>
+              </a:extLst>
+            </p:cNvPr>
+            <p:cNvGrpSpPr/>
+            <p:nvPr/>
+          </p:nvGrpSpPr>
+          <p:grpSpPr>
+            <a:xfrm>
+              <a:off x="232995" y="835775"/>
+              <a:ext cx="1774658" cy="2310063"/>
+              <a:chOff x="990492" y="2511372"/>
+              <a:chExt cx="1774658" cy="2310063"/>
+            </a:xfrm>
+          </p:grpSpPr>
+          <p:sp>
+            <p:nvSpPr>
+              <p:cNvPr id="22" name="Rectangle 21">
+                <a:extLst>
+                  <a:ext uri="{FF2B5EF4-FFF2-40B4-BE49-F238E27FC236}">
+                    <a16:creationId xmlns:a16="http://schemas.microsoft.com/office/drawing/2014/main" id="{6A221BB0-FFBC-E869-34CB-BC594E5B0490}"/>
+                  </a:ext>
+                </a:extLst>
+              </p:cNvPr>
+              <p:cNvSpPr/>
+              <p:nvPr/>
+            </p:nvSpPr>
+            <p:spPr>
+              <a:xfrm>
+                <a:off x="990492" y="2511372"/>
+                <a:ext cx="1774658" cy="2310063"/>
+              </a:xfrm>
+              <a:prstGeom prst="rect">
+                <a:avLst/>
+              </a:prstGeom>
+              <a:solidFill>
+                <a:schemeClr val="accent1">
+                  <a:lumMod val="20000"/>
+                  <a:lumOff val="80000"/>
+                </a:schemeClr>
+              </a:solidFill>
+              <a:ln>
+                <a:solidFill>
+                  <a:schemeClr val="tx2">
+                    <a:lumMod val="25000"/>
+                    <a:lumOff val="75000"/>
+                  </a:schemeClr>
+                </a:solidFill>
+              </a:ln>
+            </p:spPr>
+            <p:style>
+              <a:lnRef idx="2">
+                <a:schemeClr val="accent1">
+                  <a:shade val="15000"/>
+                </a:schemeClr>
+              </a:lnRef>
+              <a:fillRef idx="1">
+                <a:schemeClr val="accent1"/>
+              </a:fillRef>
+              <a:effectRef idx="0">
+                <a:schemeClr val="accent1"/>
+              </a:effectRef>
+              <a:fontRef idx="minor">
+                <a:schemeClr val="lt1"/>
+              </a:fontRef>
+            </p:style>
+            <p:txBody>
+              <a:bodyPr rtlCol="0" anchor="ctr"/>
+              <a:lstStyle/>
+              <a:p>
+                <a:pPr algn="ctr"/>
+                <a:endParaRPr lang="en-US" dirty="0"/>
+              </a:p>
+            </p:txBody>
+          </p:sp>
+          <p:pic>
+            <p:nvPicPr>
+              <p:cNvPr id="23" name="Graphic 22" descr="Customer review with solid fill">
+                <a:extLst>
+                  <a:ext uri="{FF2B5EF4-FFF2-40B4-BE49-F238E27FC236}">
+                    <a16:creationId xmlns:a16="http://schemas.microsoft.com/office/drawing/2014/main" id="{0FAB87FB-66B8-682E-AC05-EA6B56D8F4FB}"/>
+                  </a:ext>
+                </a:extLst>
+              </p:cNvPr>
+              <p:cNvPicPr>
+                <a:picLocks noChangeAspect="1"/>
+              </p:cNvPicPr>
+              <p:nvPr/>
+            </p:nvPicPr>
+            <p:blipFill>
+              <a:blip r:embed="rId3">
+                <a:extLst>
+                  <a:ext uri="{96DAC541-7B7A-43D3-8B79-37D633B846F1}">
+                    <asvg:svgBlip xmlns:asvg="http://schemas.microsoft.com/office/drawing/2016/SVG/main" r:embed="rId4"/>
+                  </a:ext>
+                </a:extLst>
+              </a:blip>
+              <a:stretch>
+                <a:fillRect/>
+              </a:stretch>
+            </p:blipFill>
+            <p:spPr>
+              <a:xfrm>
+                <a:off x="1400027" y="3700649"/>
+                <a:ext cx="965534" cy="965534"/>
+              </a:xfrm>
+              <a:prstGeom prst="rect">
+                <a:avLst/>
+              </a:prstGeom>
+            </p:spPr>
+          </p:pic>
+          <p:pic>
+            <p:nvPicPr>
+              <p:cNvPr id="24" name="Picture 23">
+                <a:extLst>
+                  <a:ext uri="{FF2B5EF4-FFF2-40B4-BE49-F238E27FC236}">
+                    <a16:creationId xmlns:a16="http://schemas.microsoft.com/office/drawing/2014/main" id="{5AFB6878-0F86-C45A-E83E-50BAC05BCEF5}"/>
+                  </a:ext>
+                </a:extLst>
+              </p:cNvPr>
+              <p:cNvPicPr>
+                <a:picLocks noChangeAspect="1"/>
+              </p:cNvPicPr>
+              <p:nvPr/>
+            </p:nvPicPr>
+            <p:blipFill>
+              <a:blip r:embed="rId5"/>
+              <a:stretch>
+                <a:fillRect/>
+              </a:stretch>
+            </p:blipFill>
+            <p:spPr>
+              <a:xfrm>
+                <a:off x="1126882" y="2607575"/>
+                <a:ext cx="1525117" cy="996871"/>
+              </a:xfrm>
+              <a:prstGeom prst="rect">
+                <a:avLst/>
+              </a:prstGeom>
+            </p:spPr>
+          </p:pic>
+        </p:grpSp>
+        <p:sp>
+          <p:nvSpPr>
+            <p:cNvPr id="25" name="Arrow: Right 24">
+              <a:extLst>
+                <a:ext uri="{FF2B5EF4-FFF2-40B4-BE49-F238E27FC236}">
+                  <a16:creationId xmlns:a16="http://schemas.microsoft.com/office/drawing/2014/main" id="{8E792690-D447-952D-A5E7-853CC5FB33BB}"/>
+                </a:ext>
+              </a:extLst>
+            </p:cNvPr>
+            <p:cNvSpPr/>
+            <p:nvPr/>
+          </p:nvSpPr>
+          <p:spPr>
+            <a:xfrm>
+              <a:off x="2327498" y="1803354"/>
+              <a:ext cx="666746" cy="374904"/>
+            </a:xfrm>
+            <a:prstGeom prst="rightArrow">
+              <a:avLst/>
+            </a:prstGeom>
+          </p:spPr>
+          <p:style>
+            <a:lnRef idx="2">
+              <a:schemeClr val="accent1">
+                <a:shade val="15000"/>
+              </a:schemeClr>
+            </a:lnRef>
+            <a:fillRef idx="1">
+              <a:schemeClr val="accent1"/>
+            </a:fillRef>
+            <a:effectRef idx="0">
+              <a:schemeClr val="accent1"/>
+            </a:effectRef>
+            <a:fontRef idx="minor">
+              <a:schemeClr val="lt1"/>
+            </a:fontRef>
+          </p:style>
+          <p:txBody>
+            <a:bodyPr rtlCol="0" anchor="ctr"/>
+            <a:lstStyle/>
+            <a:p>
+              <a:pPr algn="ctr"/>
+              <a:endParaRPr lang="en-US"/>
+            </a:p>
+          </p:txBody>
+        </p:sp>
+        <p:grpSp>
+          <p:nvGrpSpPr>
+            <p:cNvPr id="26" name="Group 25">
+              <a:extLst>
+                <a:ext uri="{FF2B5EF4-FFF2-40B4-BE49-F238E27FC236}">
+                  <a16:creationId xmlns:a16="http://schemas.microsoft.com/office/drawing/2014/main" id="{9472E490-A369-C15A-DECA-AE1255870DC8}"/>
+                </a:ext>
+              </a:extLst>
+            </p:cNvPr>
+            <p:cNvGrpSpPr/>
+            <p:nvPr/>
+          </p:nvGrpSpPr>
+          <p:grpSpPr>
+            <a:xfrm>
+              <a:off x="3100852" y="406630"/>
+              <a:ext cx="4177285" cy="3044438"/>
+              <a:chOff x="2837001" y="180836"/>
+              <a:chExt cx="4177285" cy="3044438"/>
+            </a:xfrm>
+          </p:grpSpPr>
+          <p:grpSp>
+            <p:nvGrpSpPr>
+              <p:cNvPr id="27" name="Group 26">
+                <a:extLst>
+                  <a:ext uri="{FF2B5EF4-FFF2-40B4-BE49-F238E27FC236}">
+                    <a16:creationId xmlns:a16="http://schemas.microsoft.com/office/drawing/2014/main" id="{C867F122-D459-E4D8-E91E-39D4FB20E8FB}"/>
+                  </a:ext>
+                </a:extLst>
+              </p:cNvPr>
+              <p:cNvGrpSpPr>
+                <a:grpSpLocks noChangeAspect="1"/>
+              </p:cNvGrpSpPr>
+              <p:nvPr/>
+            </p:nvGrpSpPr>
+            <p:grpSpPr>
+              <a:xfrm>
+                <a:off x="2837001" y="756337"/>
+                <a:ext cx="2160399" cy="2468937"/>
+                <a:chOff x="3436044" y="2054607"/>
+                <a:chExt cx="2487556" cy="2842817"/>
+              </a:xfrm>
+            </p:grpSpPr>
+            <p:pic>
+              <p:nvPicPr>
+                <p:cNvPr id="32" name="Picture 31" descr="A screenshot of a graph&#10;&#10;AI-generated content may be incorrect.">
+                  <a:extLst>
+                    <a:ext uri="{FF2B5EF4-FFF2-40B4-BE49-F238E27FC236}">
+                      <a16:creationId xmlns:a16="http://schemas.microsoft.com/office/drawing/2014/main" id="{5A34DEF1-BD9B-CD6A-A8D2-7AFC0C5C49C9}"/>
+                    </a:ext>
+                  </a:extLst>
+                </p:cNvPr>
+                <p:cNvPicPr>
+                  <a:picLocks noChangeAspect="1"/>
+                </p:cNvPicPr>
+                <p:nvPr/>
+              </p:nvPicPr>
+              <p:blipFill>
+                <a:blip r:embed="rId6">
+                  <a:extLst>
+                    <a:ext uri="{28A0092B-C50C-407E-A947-70E740481C1C}">
+                      <a14:useLocalDpi xmlns:a14="http://schemas.microsoft.com/office/drawing/2010/main" val="0"/>
+                    </a:ext>
+                  </a:extLst>
+                </a:blip>
+                <a:srcRect l="31035" t="24006" r="53731" b="44988"/>
+                <a:stretch/>
+              </p:blipFill>
+              <p:spPr>
+                <a:xfrm>
+                  <a:off x="3436044" y="2054607"/>
+                  <a:ext cx="2222549" cy="2392796"/>
+                </a:xfrm>
+                <a:prstGeom prst="rect">
+                  <a:avLst/>
+                </a:prstGeom>
+              </p:spPr>
+            </p:pic>
+            <p:pic>
+              <p:nvPicPr>
+                <p:cNvPr id="33" name="Picture 32" descr="A screenshot of a graph&#10;&#10;AI-generated content may be incorrect.">
+                  <a:extLst>
+                    <a:ext uri="{FF2B5EF4-FFF2-40B4-BE49-F238E27FC236}">
+                      <a16:creationId xmlns:a16="http://schemas.microsoft.com/office/drawing/2014/main" id="{C3C561D4-D6EB-0889-183B-97DE0B45487D}"/>
+                    </a:ext>
+                  </a:extLst>
+                </p:cNvPr>
+                <p:cNvPicPr>
+                  <a:picLocks noChangeAspect="1"/>
+                </p:cNvPicPr>
+                <p:nvPr/>
+              </p:nvPicPr>
+              <p:blipFill>
+                <a:blip r:embed="rId6">
+                  <a:extLst>
+                    <a:ext uri="{28A0092B-C50C-407E-A947-70E740481C1C}">
+                      <a14:useLocalDpi xmlns:a14="http://schemas.microsoft.com/office/drawing/2010/main" val="0"/>
+                    </a:ext>
+                  </a:extLst>
+                </a:blip>
+                <a:srcRect l="31170" t="17838" r="53596" b="76213"/>
+                <a:stretch/>
+              </p:blipFill>
+              <p:spPr>
+                <a:xfrm>
+                  <a:off x="3701051" y="4438366"/>
+                  <a:ext cx="2222549" cy="459058"/>
+                </a:xfrm>
+                <a:prstGeom prst="rect">
+                  <a:avLst/>
+                </a:prstGeom>
+              </p:spPr>
+            </p:pic>
+          </p:grpSp>
+          <p:grpSp>
+            <p:nvGrpSpPr>
+              <p:cNvPr id="28" name="Group 27">
+                <a:extLst>
+                  <a:ext uri="{FF2B5EF4-FFF2-40B4-BE49-F238E27FC236}">
+                    <a16:creationId xmlns:a16="http://schemas.microsoft.com/office/drawing/2014/main" id="{31D67220-A5A3-C982-ABAA-76BF27D3A610}"/>
+                  </a:ext>
+                </a:extLst>
+              </p:cNvPr>
+              <p:cNvGrpSpPr>
+                <a:grpSpLocks noChangeAspect="1"/>
+              </p:cNvGrpSpPr>
+              <p:nvPr/>
+            </p:nvGrpSpPr>
+            <p:grpSpPr>
+              <a:xfrm>
+                <a:off x="5025516" y="794440"/>
+                <a:ext cx="1988770" cy="2392732"/>
+                <a:chOff x="5620740" y="1990807"/>
+                <a:chExt cx="2369090" cy="2850303"/>
+              </a:xfrm>
+            </p:grpSpPr>
+            <p:pic>
+              <p:nvPicPr>
+                <p:cNvPr id="30" name="Picture 29" descr="A screenshot of a graph&#10;&#10;AI-generated content may be incorrect.">
+                  <a:extLst>
+                    <a:ext uri="{FF2B5EF4-FFF2-40B4-BE49-F238E27FC236}">
+                      <a16:creationId xmlns:a16="http://schemas.microsoft.com/office/drawing/2014/main" id="{31CDC5D0-80F4-CF34-180C-1E2C5181119A}"/>
+                    </a:ext>
+                  </a:extLst>
+                </p:cNvPr>
+                <p:cNvPicPr>
+                  <a:picLocks noChangeAspect="1"/>
+                </p:cNvPicPr>
+                <p:nvPr/>
+              </p:nvPicPr>
+              <p:blipFill>
+                <a:blip r:embed="rId6">
+                  <a:extLst>
+                    <a:ext uri="{28A0092B-C50C-407E-A947-70E740481C1C}">
+                      <a14:useLocalDpi xmlns:a14="http://schemas.microsoft.com/office/drawing/2010/main" val="0"/>
+                    </a:ext>
+                  </a:extLst>
+                </a:blip>
+                <a:srcRect l="56362" t="23416" r="29209" b="43925"/>
+                <a:stretch/>
+              </p:blipFill>
+              <p:spPr>
+                <a:xfrm>
+                  <a:off x="5620740" y="1990807"/>
+                  <a:ext cx="2105025" cy="2520397"/>
+                </a:xfrm>
+                <a:prstGeom prst="rect">
+                  <a:avLst/>
+                </a:prstGeom>
+              </p:spPr>
+            </p:pic>
+            <p:pic>
+              <p:nvPicPr>
+                <p:cNvPr id="31" name="Picture 30" descr="A screenshot of a graph&#10;&#10;AI-generated content may be incorrect.">
+                  <a:extLst>
+                    <a:ext uri="{FF2B5EF4-FFF2-40B4-BE49-F238E27FC236}">
+                      <a16:creationId xmlns:a16="http://schemas.microsoft.com/office/drawing/2014/main" id="{CA091874-25E2-30DF-B764-40BAC98019C4}"/>
+                    </a:ext>
+                  </a:extLst>
+                </p:cNvPr>
+                <p:cNvPicPr>
+                  <a:picLocks noChangeAspect="1"/>
+                </p:cNvPicPr>
+                <p:nvPr/>
+              </p:nvPicPr>
+              <p:blipFill>
+                <a:blip r:embed="rId6">
+                  <a:extLst>
+                    <a:ext uri="{28A0092B-C50C-407E-A947-70E740481C1C}">
+                      <a14:useLocalDpi xmlns:a14="http://schemas.microsoft.com/office/drawing/2010/main" val="0"/>
+                    </a:ext>
+                  </a:extLst>
+                </a:blip>
+                <a:srcRect l="56362" t="18606" r="29209" b="76905"/>
+                <a:stretch/>
+              </p:blipFill>
+              <p:spPr>
+                <a:xfrm>
+                  <a:off x="5884805" y="4494680"/>
+                  <a:ext cx="2105025" cy="346430"/>
+                </a:xfrm>
+                <a:prstGeom prst="rect">
+                  <a:avLst/>
+                </a:prstGeom>
+              </p:spPr>
+            </p:pic>
+          </p:grpSp>
+          <p:sp>
+            <p:nvSpPr>
+              <p:cNvPr id="29" name="TextBox 28">
+                <a:extLst>
+                  <a:ext uri="{FF2B5EF4-FFF2-40B4-BE49-F238E27FC236}">
+                    <a16:creationId xmlns:a16="http://schemas.microsoft.com/office/drawing/2014/main" id="{50EF08DE-650D-84D8-23E2-83CD379C9565}"/>
+                  </a:ext>
+                </a:extLst>
+              </p:cNvPr>
+              <p:cNvSpPr txBox="1"/>
+              <p:nvPr/>
+            </p:nvSpPr>
+            <p:spPr>
+              <a:xfrm>
+                <a:off x="3774980" y="180836"/>
+                <a:ext cx="2444839" cy="462179"/>
+              </a:xfrm>
+              <a:prstGeom prst="rect">
+                <a:avLst/>
+              </a:prstGeom>
+              <a:noFill/>
+            </p:spPr>
+            <p:txBody>
+              <a:bodyPr wrap="square" rtlCol="0">
+                <a:spAutoFit/>
+              </a:bodyPr>
+              <a:lstStyle/>
+              <a:p>
+                <a:pPr algn="ctr"/>
+                <a:r>
+                  <a:rPr lang="en-US" sz="1600" b="1" dirty="0"/>
+                  <a:t>Counterfactuals</a:t>
+                </a:r>
+                <a:endParaRPr lang="de-DE" sz="1600" b="1" dirty="0"/>
+              </a:p>
+            </p:txBody>
+          </p:sp>
+        </p:grpSp>
+        <p:grpSp>
+          <p:nvGrpSpPr>
+            <p:cNvPr id="34" name="Group 33">
+              <a:extLst>
+                <a:ext uri="{FF2B5EF4-FFF2-40B4-BE49-F238E27FC236}">
+                  <a16:creationId xmlns:a16="http://schemas.microsoft.com/office/drawing/2014/main" id="{0D4F3181-F484-3C7A-63BE-FADB4F9C8C2E}"/>
+                </a:ext>
+              </a:extLst>
+            </p:cNvPr>
+            <p:cNvGrpSpPr/>
+            <p:nvPr/>
+          </p:nvGrpSpPr>
+          <p:grpSpPr>
+            <a:xfrm>
+              <a:off x="7476422" y="406630"/>
+              <a:ext cx="4305800" cy="2445525"/>
+              <a:chOff x="7484339" y="181744"/>
+              <a:chExt cx="4305800" cy="2445525"/>
+            </a:xfrm>
+          </p:grpSpPr>
+          <p:grpSp>
+            <p:nvGrpSpPr>
+              <p:cNvPr id="35" name="Group 34">
+                <a:extLst>
+                  <a:ext uri="{FF2B5EF4-FFF2-40B4-BE49-F238E27FC236}">
+                    <a16:creationId xmlns:a16="http://schemas.microsoft.com/office/drawing/2014/main" id="{315A4BFF-0CA9-D528-2306-83671A721F96}"/>
+                  </a:ext>
+                </a:extLst>
+              </p:cNvPr>
+              <p:cNvGrpSpPr>
+                <a:grpSpLocks noChangeAspect="1"/>
+              </p:cNvGrpSpPr>
+              <p:nvPr/>
+            </p:nvGrpSpPr>
+            <p:grpSpPr>
+              <a:xfrm>
+                <a:off x="7484339" y="1329135"/>
+                <a:ext cx="2052000" cy="1269160"/>
+                <a:chOff x="7955797" y="1713756"/>
+                <a:chExt cx="2885092" cy="1784427"/>
+              </a:xfrm>
+            </p:grpSpPr>
+            <p:pic>
+              <p:nvPicPr>
+                <p:cNvPr id="40" name="Picture 39" descr="A black and red chemical structure&#10;&#10;AI-generated content may be incorrect.">
+                  <a:extLst>
+                    <a:ext uri="{FF2B5EF4-FFF2-40B4-BE49-F238E27FC236}">
+                      <a16:creationId xmlns:a16="http://schemas.microsoft.com/office/drawing/2014/main" id="{13934202-8C49-5877-EAF5-D53028B5669E}"/>
+                    </a:ext>
+                  </a:extLst>
+                </p:cNvPr>
+                <p:cNvPicPr>
+                  <a:picLocks noChangeAspect="1"/>
+                </p:cNvPicPr>
+                <p:nvPr/>
+              </p:nvPicPr>
+              <p:blipFill>
+                <a:blip r:embed="rId7">
+                  <a:extLst>
+                    <a:ext uri="{28A0092B-C50C-407E-A947-70E740481C1C}">
+                      <a14:useLocalDpi xmlns:a14="http://schemas.microsoft.com/office/drawing/2010/main" val="0"/>
+                    </a:ext>
+                  </a:extLst>
+                </a:blip>
+                <a:srcRect l="26131" t="13384" r="50592" b="35527"/>
+                <a:stretch/>
+              </p:blipFill>
+              <p:spPr>
+                <a:xfrm>
+                  <a:off x="7955797" y="1713756"/>
+                  <a:ext cx="2885092" cy="1385205"/>
+                </a:xfrm>
+                <a:prstGeom prst="rect">
+                  <a:avLst/>
+                </a:prstGeom>
+              </p:spPr>
+            </p:pic>
+            <p:pic>
+              <p:nvPicPr>
+                <p:cNvPr id="41" name="Picture 40" descr="A black and red chemical structure&#10;&#10;AI-generated content may be incorrect.">
+                  <a:extLst>
+                    <a:ext uri="{FF2B5EF4-FFF2-40B4-BE49-F238E27FC236}">
+                      <a16:creationId xmlns:a16="http://schemas.microsoft.com/office/drawing/2014/main" id="{14AFA39F-495B-AE1F-EE0F-FC1A7BA10F05}"/>
+                    </a:ext>
+                  </a:extLst>
+                </p:cNvPr>
+                <p:cNvPicPr>
+                  <a:picLocks noChangeAspect="1"/>
+                </p:cNvPicPr>
+                <p:nvPr/>
+              </p:nvPicPr>
+              <p:blipFill>
+                <a:blip r:embed="rId7">
+                  <a:extLst>
+                    <a:ext uri="{28A0092B-C50C-407E-A947-70E740481C1C}">
+                      <a14:useLocalDpi xmlns:a14="http://schemas.microsoft.com/office/drawing/2010/main" val="0"/>
+                    </a:ext>
+                  </a:extLst>
+                </a:blip>
+                <a:srcRect l="34138" t="87643" r="59329" b="4628"/>
+                <a:stretch/>
+              </p:blipFill>
+              <p:spPr>
+                <a:xfrm>
+                  <a:off x="8883993" y="3231955"/>
+                  <a:ext cx="1028700" cy="266228"/>
+                </a:xfrm>
+                <a:prstGeom prst="rect">
+                  <a:avLst/>
+                </a:prstGeom>
+              </p:spPr>
+            </p:pic>
+          </p:grpSp>
+          <p:grpSp>
+            <p:nvGrpSpPr>
+              <p:cNvPr id="36" name="Group 35">
+                <a:extLst>
+                  <a:ext uri="{FF2B5EF4-FFF2-40B4-BE49-F238E27FC236}">
+                    <a16:creationId xmlns:a16="http://schemas.microsoft.com/office/drawing/2014/main" id="{40F329E8-016F-7B2E-D6E4-F9F4E0BE7A34}"/>
+                  </a:ext>
+                </a:extLst>
+              </p:cNvPr>
+              <p:cNvGrpSpPr>
+                <a:grpSpLocks noChangeAspect="1"/>
+              </p:cNvGrpSpPr>
+              <p:nvPr/>
+            </p:nvGrpSpPr>
+            <p:grpSpPr>
+              <a:xfrm>
+                <a:off x="9738139" y="1397550"/>
+                <a:ext cx="2052000" cy="1229719"/>
+                <a:chOff x="7951035" y="3350221"/>
+                <a:chExt cx="2894617" cy="1734681"/>
+              </a:xfrm>
+            </p:grpSpPr>
+            <p:pic>
+              <p:nvPicPr>
+                <p:cNvPr id="38" name="Picture 37" descr="A black and red chemical structure&#10;&#10;AI-generated content may be incorrect.">
+                  <a:extLst>
+                    <a:ext uri="{FF2B5EF4-FFF2-40B4-BE49-F238E27FC236}">
+                      <a16:creationId xmlns:a16="http://schemas.microsoft.com/office/drawing/2014/main" id="{48ACB3B0-1845-ABC3-5228-376A5949FA79}"/>
+                    </a:ext>
+                  </a:extLst>
+                </p:cNvPr>
+                <p:cNvPicPr>
+                  <a:picLocks noChangeAspect="1"/>
+                </p:cNvPicPr>
+                <p:nvPr/>
+              </p:nvPicPr>
+              <p:blipFill>
+                <a:blip r:embed="rId7">
+                  <a:extLst>
+                    <a:ext uri="{28A0092B-C50C-407E-A947-70E740481C1C}">
+                      <a14:useLocalDpi xmlns:a14="http://schemas.microsoft.com/office/drawing/2010/main" val="0"/>
+                    </a:ext>
+                  </a:extLst>
+                </a:blip>
+                <a:srcRect l="51184" t="14586" r="25463" b="34325"/>
+                <a:stretch/>
+              </p:blipFill>
+              <p:spPr>
+                <a:xfrm>
+                  <a:off x="7951035" y="3350221"/>
+                  <a:ext cx="2894617" cy="1385206"/>
+                </a:xfrm>
+                <a:prstGeom prst="rect">
+                  <a:avLst/>
+                </a:prstGeom>
+              </p:spPr>
+            </p:pic>
+            <p:pic>
+              <p:nvPicPr>
+                <p:cNvPr id="39" name="Picture 38" descr="A black and red chemical structure&#10;&#10;AI-generated content may be incorrect.">
+                  <a:extLst>
+                    <a:ext uri="{FF2B5EF4-FFF2-40B4-BE49-F238E27FC236}">
+                      <a16:creationId xmlns:a16="http://schemas.microsoft.com/office/drawing/2014/main" id="{5D7062A3-FA42-FF24-FF7D-4729F61DD8A5}"/>
+                    </a:ext>
+                  </a:extLst>
+                </p:cNvPr>
+                <p:cNvPicPr>
+                  <a:picLocks noChangeAspect="1"/>
+                </p:cNvPicPr>
+                <p:nvPr/>
+              </p:nvPicPr>
+              <p:blipFill>
+                <a:blip r:embed="rId7">
+                  <a:extLst>
+                    <a:ext uri="{28A0092B-C50C-407E-A947-70E740481C1C}">
+                      <a14:useLocalDpi xmlns:a14="http://schemas.microsoft.com/office/drawing/2010/main" val="0"/>
+                    </a:ext>
+                  </a:extLst>
+                </a:blip>
+                <a:srcRect l="59497" t="85098" r="34125" b="3309"/>
+                <a:stretch/>
+              </p:blipFill>
+              <p:spPr>
+                <a:xfrm>
+                  <a:off x="8926807" y="4709945"/>
+                  <a:ext cx="943073" cy="374957"/>
+                </a:xfrm>
+                <a:prstGeom prst="rect">
+                  <a:avLst/>
+                </a:prstGeom>
+              </p:spPr>
+            </p:pic>
+          </p:grpSp>
+          <p:sp>
+            <p:nvSpPr>
+              <p:cNvPr id="37" name="TextBox 36">
+                <a:extLst>
+                  <a:ext uri="{FF2B5EF4-FFF2-40B4-BE49-F238E27FC236}">
+                    <a16:creationId xmlns:a16="http://schemas.microsoft.com/office/drawing/2014/main" id="{A9B538AC-1716-FEE9-9303-C64FEB3A2571}"/>
+                  </a:ext>
+                </a:extLst>
+              </p:cNvPr>
+              <p:cNvSpPr txBox="1"/>
+              <p:nvPr/>
+            </p:nvSpPr>
+            <p:spPr>
+              <a:xfrm>
+                <a:off x="8319300" y="181744"/>
+                <a:ext cx="2444839" cy="462179"/>
+              </a:xfrm>
+              <a:prstGeom prst="rect">
+                <a:avLst/>
+              </a:prstGeom>
+              <a:noFill/>
+            </p:spPr>
+            <p:txBody>
+              <a:bodyPr wrap="square" rtlCol="0">
+                <a:spAutoFit/>
+              </a:bodyPr>
+              <a:lstStyle/>
+              <a:p>
+                <a:pPr algn="ctr"/>
+                <a:r>
+                  <a:rPr lang="en-US" sz="1600" b="1" dirty="0" err="1"/>
+                  <a:t>MolCE</a:t>
+                </a:r>
+                <a:endParaRPr lang="de-DE" sz="1600" b="1" dirty="0"/>
+              </a:p>
+            </p:txBody>
+          </p:sp>
+        </p:grpSp>
+        <p:sp>
+          <p:nvSpPr>
+            <p:cNvPr id="42" name="Arrow: Right 41">
+              <a:extLst>
+                <a:ext uri="{FF2B5EF4-FFF2-40B4-BE49-F238E27FC236}">
+                  <a16:creationId xmlns:a16="http://schemas.microsoft.com/office/drawing/2014/main" id="{666A450C-D0FA-4FC2-D779-9D8A47EBECE0}"/>
+                </a:ext>
+              </a:extLst>
+            </p:cNvPr>
+            <p:cNvSpPr/>
+            <p:nvPr/>
+          </p:nvSpPr>
+          <p:spPr>
+            <a:xfrm rot="5400000">
+              <a:off x="786951" y="3558887"/>
+              <a:ext cx="666746" cy="374904"/>
+            </a:xfrm>
+            <a:prstGeom prst="rightArrow">
+              <a:avLst/>
+            </a:prstGeom>
+          </p:spPr>
+          <p:style>
+            <a:lnRef idx="2">
+              <a:schemeClr val="accent1">
+                <a:shade val="15000"/>
+              </a:schemeClr>
+            </a:lnRef>
+            <a:fillRef idx="1">
+              <a:schemeClr val="accent1"/>
+            </a:fillRef>
+            <a:effectRef idx="0">
+              <a:schemeClr val="accent1"/>
+            </a:effectRef>
+            <a:fontRef idx="minor">
+              <a:schemeClr val="lt1"/>
+            </a:fontRef>
+          </p:style>
+          <p:txBody>
+            <a:bodyPr rtlCol="0" anchor="ctr"/>
+            <a:lstStyle/>
+            <a:p>
+              <a:pPr algn="ctr"/>
+              <a:endParaRPr lang="en-US"/>
+            </a:p>
+          </p:txBody>
+        </p:sp>
+        <p:grpSp>
+          <p:nvGrpSpPr>
+            <p:cNvPr id="43" name="Group 42">
+              <a:extLst>
+                <a:ext uri="{FF2B5EF4-FFF2-40B4-BE49-F238E27FC236}">
+                  <a16:creationId xmlns:a16="http://schemas.microsoft.com/office/drawing/2014/main" id="{F82C89B3-047B-9A9D-4CE0-2F5ECB7C024A}"/>
+                </a:ext>
+              </a:extLst>
+            </p:cNvPr>
+            <p:cNvGrpSpPr/>
+            <p:nvPr/>
+          </p:nvGrpSpPr>
+          <p:grpSpPr>
+            <a:xfrm>
+              <a:off x="4841173" y="4522527"/>
+              <a:ext cx="6165816" cy="573974"/>
+              <a:chOff x="4841173" y="4193969"/>
+              <a:chExt cx="6165816" cy="573974"/>
+            </a:xfrm>
+          </p:grpSpPr>
+          <p:cxnSp>
+            <p:nvCxnSpPr>
+              <p:cNvPr id="44" name="Straight Arrow Connector 43">
+                <a:extLst>
+                  <a:ext uri="{FF2B5EF4-FFF2-40B4-BE49-F238E27FC236}">
+                    <a16:creationId xmlns:a16="http://schemas.microsoft.com/office/drawing/2014/main" id="{7CA5671C-1E1D-11B4-C48F-3C328C72BA42}"/>
+                  </a:ext>
+                </a:extLst>
+              </p:cNvPr>
+              <p:cNvCxnSpPr>
+                <a:cxnSpLocks/>
+              </p:cNvCxnSpPr>
+              <p:nvPr/>
+            </p:nvCxnSpPr>
+            <p:spPr>
+              <a:xfrm>
+                <a:off x="4841173" y="4480956"/>
+                <a:ext cx="1800000" cy="0"/>
+              </a:xfrm>
+              <a:prstGeom prst="straightConnector1">
+                <a:avLst/>
+              </a:prstGeom>
+              <a:ln>
+                <a:tailEnd type="triangle"/>
+              </a:ln>
+            </p:spPr>
+            <p:style>
+              <a:lnRef idx="2">
+                <a:schemeClr val="accent1"/>
+              </a:lnRef>
+              <a:fillRef idx="0">
+                <a:schemeClr val="accent1"/>
+              </a:fillRef>
+              <a:effectRef idx="1">
+                <a:schemeClr val="accent1"/>
+              </a:effectRef>
+              <a:fontRef idx="minor">
+                <a:schemeClr val="tx1"/>
+              </a:fontRef>
+            </p:style>
+          </p:cxnSp>
+          <p:sp>
+            <p:nvSpPr>
+              <p:cNvPr id="45" name="Rectangle: Rounded Corners 44">
+                <a:extLst>
+                  <a:ext uri="{FF2B5EF4-FFF2-40B4-BE49-F238E27FC236}">
+                    <a16:creationId xmlns:a16="http://schemas.microsoft.com/office/drawing/2014/main" id="{092CB276-0083-7B65-2724-8B06427E812A}"/>
+                  </a:ext>
+                </a:extLst>
+              </p:cNvPr>
+              <p:cNvSpPr/>
+              <p:nvPr/>
+            </p:nvSpPr>
+            <p:spPr>
+              <a:xfrm>
+                <a:off x="7278137" y="4193969"/>
+                <a:ext cx="3728852" cy="573974"/>
+              </a:xfrm>
+              <a:prstGeom prst="roundRect">
+                <a:avLst/>
+              </a:prstGeom>
+              <a:solidFill>
+                <a:schemeClr val="bg1"/>
+              </a:solidFill>
+            </p:spPr>
+            <p:style>
+              <a:lnRef idx="2">
+                <a:schemeClr val="accent4">
+                  <a:shade val="15000"/>
+                </a:schemeClr>
+              </a:lnRef>
+              <a:fillRef idx="1">
+                <a:schemeClr val="accent4"/>
+              </a:fillRef>
+              <a:effectRef idx="0">
+                <a:schemeClr val="accent4"/>
+              </a:effectRef>
+              <a:fontRef idx="minor">
+                <a:schemeClr val="lt1"/>
+              </a:fontRef>
+            </p:style>
+            <p:txBody>
+              <a:bodyPr rtlCol="0" anchor="ctr"/>
+              <a:lstStyle/>
+              <a:p>
+                <a:pPr algn="ctr"/>
+                <a:r>
+                  <a:rPr lang="en-US" sz="1100" dirty="0">
+                    <a:solidFill>
+                      <a:schemeClr val="tx1"/>
+                    </a:solidFill>
+                  </a:rPr>
+                  <a:t>R-groups attached to the morpholine ring </a:t>
+                </a:r>
+                <a:endParaRPr lang="de-DE" sz="1100" dirty="0">
+                  <a:solidFill>
+                    <a:schemeClr val="tx1"/>
+                  </a:solidFill>
+                </a:endParaRPr>
+              </a:p>
+            </p:txBody>
+          </p:sp>
+        </p:grpSp>
+        <p:grpSp>
+          <p:nvGrpSpPr>
+            <p:cNvPr id="46" name="Group 45">
+              <a:extLst>
+                <a:ext uri="{FF2B5EF4-FFF2-40B4-BE49-F238E27FC236}">
+                  <a16:creationId xmlns:a16="http://schemas.microsoft.com/office/drawing/2014/main" id="{CD48E29D-F3CB-93DF-7120-8F34C9F5EB3C}"/>
+                </a:ext>
+              </a:extLst>
+            </p:cNvPr>
+            <p:cNvGrpSpPr/>
+            <p:nvPr/>
+          </p:nvGrpSpPr>
+          <p:grpSpPr>
+            <a:xfrm>
+              <a:off x="4841173" y="5396256"/>
+              <a:ext cx="6165816" cy="1111401"/>
+              <a:chOff x="4841173" y="5067698"/>
+              <a:chExt cx="6165816" cy="1111401"/>
+            </a:xfrm>
+          </p:grpSpPr>
+          <p:cxnSp>
+            <p:nvCxnSpPr>
+              <p:cNvPr id="47" name="Straight Arrow Connector 46">
+                <a:extLst>
+                  <a:ext uri="{FF2B5EF4-FFF2-40B4-BE49-F238E27FC236}">
+                    <a16:creationId xmlns:a16="http://schemas.microsoft.com/office/drawing/2014/main" id="{FB8D1494-CCA9-D25B-F957-26E4BF3049A5}"/>
+                  </a:ext>
+                </a:extLst>
+              </p:cNvPr>
+              <p:cNvCxnSpPr>
+                <a:cxnSpLocks/>
+              </p:cNvCxnSpPr>
+              <p:nvPr/>
+            </p:nvCxnSpPr>
+            <p:spPr>
+              <a:xfrm>
+                <a:off x="4841173" y="5623398"/>
+                <a:ext cx="1800000" cy="0"/>
+              </a:xfrm>
+              <a:prstGeom prst="straightConnector1">
+                <a:avLst/>
+              </a:prstGeom>
+              <a:ln>
+                <a:tailEnd type="triangle"/>
+              </a:ln>
+            </p:spPr>
+            <p:style>
+              <a:lnRef idx="2">
+                <a:schemeClr val="accent1"/>
+              </a:lnRef>
+              <a:fillRef idx="0">
+                <a:schemeClr val="accent1"/>
+              </a:fillRef>
+              <a:effectRef idx="1">
+                <a:schemeClr val="accent1"/>
+              </a:effectRef>
+              <a:fontRef idx="minor">
+                <a:schemeClr val="tx1"/>
+              </a:fontRef>
+            </p:style>
+          </p:cxnSp>
+          <p:sp>
+            <p:nvSpPr>
+              <p:cNvPr id="48" name="Rectangle: Rounded Corners 47">
+                <a:extLst>
+                  <a:ext uri="{FF2B5EF4-FFF2-40B4-BE49-F238E27FC236}">
+                    <a16:creationId xmlns:a16="http://schemas.microsoft.com/office/drawing/2014/main" id="{89DB2597-89D3-3163-87C9-9AC4C1B4C236}"/>
+                  </a:ext>
+                </a:extLst>
+              </p:cNvPr>
+              <p:cNvSpPr/>
+              <p:nvPr/>
+            </p:nvSpPr>
+            <p:spPr>
+              <a:xfrm>
+                <a:off x="7278137" y="5067698"/>
+                <a:ext cx="3728852" cy="1111401"/>
+              </a:xfrm>
+              <a:prstGeom prst="roundRect">
+                <a:avLst/>
+              </a:prstGeom>
+              <a:solidFill>
+                <a:schemeClr val="bg1"/>
+              </a:solidFill>
+            </p:spPr>
+            <p:style>
+              <a:lnRef idx="2">
+                <a:schemeClr val="accent4">
+                  <a:shade val="15000"/>
+                </a:schemeClr>
+              </a:lnRef>
+              <a:fillRef idx="1">
+                <a:schemeClr val="accent4"/>
+              </a:fillRef>
+              <a:effectRef idx="0">
+                <a:schemeClr val="accent4"/>
+              </a:effectRef>
+              <a:fontRef idx="minor">
+                <a:schemeClr val="lt1"/>
+              </a:fontRef>
+            </p:style>
+            <p:txBody>
+              <a:bodyPr rtlCol="0" anchor="ctr"/>
+              <a:lstStyle/>
+              <a:p>
+                <a:endParaRPr lang="en-US" sz="1400" dirty="0">
+                  <a:solidFill>
+                    <a:schemeClr val="tx1"/>
+                  </a:solidFill>
+                </a:endParaRPr>
+              </a:p>
+              <a:p>
+                <a:r>
+                  <a:rPr lang="en-US" sz="1100" b="1" dirty="0" err="1">
+                    <a:solidFill>
+                      <a:schemeClr val="tx1"/>
+                    </a:solidFill>
+                  </a:rPr>
+                  <a:t>MolCE</a:t>
+                </a:r>
+                <a:r>
+                  <a:rPr lang="en-US" sz="1100" dirty="0">
+                    <a:solidFill>
+                      <a:schemeClr val="tx1"/>
+                    </a:solidFill>
+                  </a:rPr>
+                  <a:t> - R-group that is “anti-activating”</a:t>
+                </a:r>
+              </a:p>
+              <a:p>
+                <a:endParaRPr lang="en-US" sz="1100" dirty="0">
+                  <a:solidFill>
+                    <a:schemeClr val="tx1"/>
+                  </a:solidFill>
+                </a:endParaRPr>
+              </a:p>
+              <a:p>
+                <a:r>
+                  <a:rPr lang="en-US" sz="1100" b="1" dirty="0">
+                    <a:solidFill>
+                      <a:schemeClr val="tx1"/>
+                    </a:solidFill>
+                  </a:rPr>
+                  <a:t>Counterfactuals</a:t>
+                </a:r>
+                <a:r>
+                  <a:rPr lang="en-US" sz="1100" dirty="0">
+                    <a:solidFill>
+                      <a:schemeClr val="tx1"/>
+                    </a:solidFill>
+                  </a:rPr>
+                  <a:t> - concrete examples of inactive molecules</a:t>
+                </a:r>
+              </a:p>
+              <a:p>
+                <a:r>
+                  <a:rPr lang="en-US" sz="1400" dirty="0">
+                    <a:solidFill>
+                      <a:schemeClr val="tx1"/>
+                    </a:solidFill>
+                  </a:rPr>
+                  <a:t>   </a:t>
+                </a:r>
+                <a:endParaRPr lang="de-DE" sz="1400" dirty="0">
+                  <a:solidFill>
+                    <a:schemeClr val="tx1"/>
+                  </a:solidFill>
+                </a:endParaRPr>
+              </a:p>
+            </p:txBody>
+          </p:sp>
+        </p:grpSp>
+      </p:grpSp>
       <p:sp>
         <p:nvSpPr>
           <p:cNvPr id="163" name="PlaceHolder 1">
@@ -15347,40 +19040,10 @@
           </a:p>
         </p:txBody>
       </p:sp>
-      <p:pic>
-        <p:nvPicPr>
-          <p:cNvPr id="18" name="Picture 17">
-            <a:extLst>
-              <a:ext uri="{FF2B5EF4-FFF2-40B4-BE49-F238E27FC236}">
-                <a16:creationId xmlns:a16="http://schemas.microsoft.com/office/drawing/2014/main" id="{96A81ED6-143C-EB03-E019-D2947E0A8F2E}"/>
-              </a:ext>
-            </a:extLst>
-          </p:cNvPr>
-          <p:cNvPicPr>
-            <a:picLocks noChangeAspect="1"/>
-          </p:cNvPicPr>
-          <p:nvPr/>
-        </p:nvPicPr>
-        <p:blipFill>
-          <a:blip r:embed="rId3"/>
-          <a:stretch>
-            <a:fillRect/>
-          </a:stretch>
-        </p:blipFill>
-        <p:spPr>
-          <a:xfrm>
-            <a:off x="380880" y="1192696"/>
-            <a:ext cx="8169237" cy="4825788"/>
-          </a:xfrm>
-          <a:prstGeom prst="rect">
-            <a:avLst/>
-          </a:prstGeom>
-        </p:spPr>
-      </p:pic>
     </p:spTree>
     <p:extLst>
       <p:ext uri="{BB962C8B-B14F-4D97-AF65-F5344CB8AC3E}">
-        <p14:creationId xmlns:p14="http://schemas.microsoft.com/office/powerpoint/2010/main" val="1027898386"/>
+        <p14:creationId xmlns:p14="http://schemas.microsoft.com/office/powerpoint/2010/main" val="3463339464"/>
       </p:ext>
     </p:extLst>
   </p:cSld>

</xml_diff>

<commit_message>
Bump XAI image quality to ~300 dpi across MolAnchor, MolCE, and counterfactuals
- MolAnchor main image: subImgSize 500 -> 1200 px
- MolCE / MolAnchor recurrent rules (_show_mol_as_pil): default 400x350 -> 1200x1100,
  bondLineWidth=3, legendFontSize 14 -> 28
- Counterfactuals (_mol_to_pil): default 350x300 -> 1200x1100, bondLineWidth=3
- get_most_confident_counterfactual / visualize_counterfactuals mol_size defaults
  bumped (1200x1100 and 1500x1400 respectively); savefig dpi 150 -> 300
- Slides: refresh AI_Agent_Explainability and figures_AI_agent decks
</commit_message>
<xml_diff>
--- a/slides/AI_Agent_Explainability.pptx
+++ b/slides/AI_Agent_Explainability.pptx
@@ -145,6 +145,45 @@
 <file path=ppt/changesInfos/changesInfo1.xml><?xml version="1.0" encoding="utf-8"?>
 <pc:chgInfo xmlns:a="http://schemas.openxmlformats.org/drawingml/2006/main" xmlns:r="http://schemas.openxmlformats.org/officeDocument/2006/relationships" xmlns:ac="http://schemas.microsoft.com/office/drawing/2013/main/command" xmlns:pc="http://schemas.microsoft.com/office/powerpoint/2013/main/command">
   <pc:docChgLst>
+    <pc:chgData name="Tiago Janela" userId="ee1a79fe-c79c-4f34-9602-7f6f2f0482b3" providerId="ADAL" clId="{67D2C233-DF3C-4C6D-9040-D7553E3BCB8A}"/>
+    <pc:docChg chg="delSld modSld">
+      <pc:chgData name="Tiago Janela" userId="ee1a79fe-c79c-4f34-9602-7f6f2f0482b3" providerId="ADAL" clId="{67D2C233-DF3C-4C6D-9040-D7553E3BCB8A}" dt="2026-03-16T14:03:02.466" v="54" actId="20577"/>
+      <pc:docMkLst>
+        <pc:docMk/>
+      </pc:docMkLst>
+      <pc:sldChg chg="modSp mod">
+        <pc:chgData name="Tiago Janela" userId="ee1a79fe-c79c-4f34-9602-7f6f2f0482b3" providerId="ADAL" clId="{67D2C233-DF3C-4C6D-9040-D7553E3BCB8A}" dt="2026-03-16T14:03:02.466" v="54" actId="20577"/>
+        <pc:sldMkLst>
+          <pc:docMk/>
+          <pc:sldMk cId="829672710" sldId="297"/>
+        </pc:sldMkLst>
+        <pc:spChg chg="mod">
+          <ac:chgData name="Tiago Janela" userId="ee1a79fe-c79c-4f34-9602-7f6f2f0482b3" providerId="ADAL" clId="{67D2C233-DF3C-4C6D-9040-D7553E3BCB8A}" dt="2026-03-16T14:03:02.466" v="54" actId="20577"/>
+          <ac:spMkLst>
+            <pc:docMk/>
+            <pc:sldMk cId="829672710" sldId="297"/>
+            <ac:spMk id="156" creationId="{00000000-0000-0000-0000-000000000000}"/>
+          </ac:spMkLst>
+        </pc:spChg>
+      </pc:sldChg>
+      <pc:sldChg chg="modSp mod">
+        <pc:chgData name="Tiago Janela" userId="ee1a79fe-c79c-4f34-9602-7f6f2f0482b3" providerId="ADAL" clId="{67D2C233-DF3C-4C6D-9040-D7553E3BCB8A}" dt="2026-03-16T14:02:34.148" v="0" actId="20577"/>
+        <pc:sldMkLst>
+          <pc:docMk/>
+          <pc:sldMk cId="721732568" sldId="298"/>
+        </pc:sldMkLst>
+        <pc:spChg chg="mod">
+          <ac:chgData name="Tiago Janela" userId="ee1a79fe-c79c-4f34-9602-7f6f2f0482b3" providerId="ADAL" clId="{67D2C233-DF3C-4C6D-9040-D7553E3BCB8A}" dt="2026-03-16T14:02:34.148" v="0" actId="20577"/>
+          <ac:spMkLst>
+            <pc:docMk/>
+            <pc:sldMk cId="721732568" sldId="298"/>
+            <ac:spMk id="2" creationId="{870990D0-7AC5-46BA-6FC4-274F8E0A3ABE}"/>
+          </ac:spMkLst>
+        </pc:spChg>
+      </pc:sldChg>
+    </pc:docChg>
+  </pc:docChgLst>
+  <pc:docChgLst>
     <pc:chgData name="Tiago Janela" userId="ee1a79fe-c79c-4f34-9602-7f6f2f0482b3" providerId="ADAL" clId="{6BE67FA1-4A27-48B9-BA6A-E25A9786A9CC}"/>
     <pc:docChg chg="undo custSel addSld modSld sldOrd">
       <pc:chgData name="Tiago Janela" userId="ee1a79fe-c79c-4f34-9602-7f6f2f0482b3" providerId="ADAL" clId="{6BE67FA1-4A27-48B9-BA6A-E25A9786A9CC}" dt="2026-03-20T13:52:23.099" v="1063" actId="20577"/>
@@ -250,6 +289,30 @@
             <ac:picMk id="6" creationId="{D3BA145D-265C-C0B1-7C0E-2EE32552E491}"/>
           </ac:picMkLst>
         </pc:picChg>
+      </pc:sldChg>
+    </pc:docChg>
+  </pc:docChgLst>
+  <pc:docChgLst>
+    <pc:chgData name="Tiago Janela" userId="ee1a79fe-c79c-4f34-9602-7f6f2f0482b3" providerId="ADAL" clId="{A1A622BE-A8AD-47B7-8802-BAC61BCE5126}"/>
+    <pc:docChg chg="undo custSel modSld">
+      <pc:chgData name="Tiago Janela" userId="ee1a79fe-c79c-4f34-9602-7f6f2f0482b3" providerId="ADAL" clId="{A1A622BE-A8AD-47B7-8802-BAC61BCE5126}" dt="2026-04-02T12:40:40.607" v="50" actId="478"/>
+      <pc:docMkLst>
+        <pc:docMk/>
+      </pc:docMkLst>
+      <pc:sldChg chg="addSp delSp modSp mod">
+        <pc:chgData name="Tiago Janela" userId="ee1a79fe-c79c-4f34-9602-7f6f2f0482b3" providerId="ADAL" clId="{A1A622BE-A8AD-47B7-8802-BAC61BCE5126}" dt="2026-04-02T12:40:40.607" v="50" actId="478"/>
+        <pc:sldMkLst>
+          <pc:docMk/>
+          <pc:sldMk cId="1707478755" sldId="299"/>
+        </pc:sldMkLst>
+        <pc:graphicFrameChg chg="add del modGraphic">
+          <ac:chgData name="Tiago Janela" userId="ee1a79fe-c79c-4f34-9602-7f6f2f0482b3" providerId="ADAL" clId="{A1A622BE-A8AD-47B7-8802-BAC61BCE5126}" dt="2026-04-02T12:40:40.607" v="50" actId="478"/>
+          <ac:graphicFrameMkLst>
+            <pc:docMk/>
+            <pc:sldMk cId="1707478755" sldId="299"/>
+            <ac:graphicFrameMk id="4" creationId="{689F2044-8E26-DCF5-DE2D-9AD979C8C1EE}"/>
+          </ac:graphicFrameMkLst>
+        </pc:graphicFrameChg>
       </pc:sldChg>
     </pc:docChg>
   </pc:docChgLst>
@@ -1835,69 +1898,6 @@
             <ac:cxnSpMk id="11" creationId="{800D65FB-8069-2F90-2859-B2A57A9BB2C4}"/>
           </ac:cxnSpMkLst>
         </pc:cxnChg>
-      </pc:sldChg>
-    </pc:docChg>
-  </pc:docChgLst>
-  <pc:docChgLst>
-    <pc:chgData name="Tiago Janela" userId="ee1a79fe-c79c-4f34-9602-7f6f2f0482b3" providerId="ADAL" clId="{A1A622BE-A8AD-47B7-8802-BAC61BCE5126}"/>
-    <pc:docChg chg="undo custSel modSld">
-      <pc:chgData name="Tiago Janela" userId="ee1a79fe-c79c-4f34-9602-7f6f2f0482b3" providerId="ADAL" clId="{A1A622BE-A8AD-47B7-8802-BAC61BCE5126}" dt="2026-04-02T12:40:40.607" v="50" actId="478"/>
-      <pc:docMkLst>
-        <pc:docMk/>
-      </pc:docMkLst>
-      <pc:sldChg chg="addSp delSp modSp mod">
-        <pc:chgData name="Tiago Janela" userId="ee1a79fe-c79c-4f34-9602-7f6f2f0482b3" providerId="ADAL" clId="{A1A622BE-A8AD-47B7-8802-BAC61BCE5126}" dt="2026-04-02T12:40:40.607" v="50" actId="478"/>
-        <pc:sldMkLst>
-          <pc:docMk/>
-          <pc:sldMk cId="1707478755" sldId="299"/>
-        </pc:sldMkLst>
-        <pc:graphicFrameChg chg="add del modGraphic">
-          <ac:chgData name="Tiago Janela" userId="ee1a79fe-c79c-4f34-9602-7f6f2f0482b3" providerId="ADAL" clId="{A1A622BE-A8AD-47B7-8802-BAC61BCE5126}" dt="2026-04-02T12:40:40.607" v="50" actId="478"/>
-          <ac:graphicFrameMkLst>
-            <pc:docMk/>
-            <pc:sldMk cId="1707478755" sldId="299"/>
-            <ac:graphicFrameMk id="4" creationId="{689F2044-8E26-DCF5-DE2D-9AD979C8C1EE}"/>
-          </ac:graphicFrameMkLst>
-        </pc:graphicFrameChg>
-      </pc:sldChg>
-    </pc:docChg>
-  </pc:docChgLst>
-  <pc:docChgLst>
-    <pc:chgData name="Tiago Janela" userId="ee1a79fe-c79c-4f34-9602-7f6f2f0482b3" providerId="ADAL" clId="{67D2C233-DF3C-4C6D-9040-D7553E3BCB8A}"/>
-    <pc:docChg chg="delSld modSld">
-      <pc:chgData name="Tiago Janela" userId="ee1a79fe-c79c-4f34-9602-7f6f2f0482b3" providerId="ADAL" clId="{67D2C233-DF3C-4C6D-9040-D7553E3BCB8A}" dt="2026-03-16T14:03:02.466" v="54" actId="20577"/>
-      <pc:docMkLst>
-        <pc:docMk/>
-      </pc:docMkLst>
-      <pc:sldChg chg="modSp mod">
-        <pc:chgData name="Tiago Janela" userId="ee1a79fe-c79c-4f34-9602-7f6f2f0482b3" providerId="ADAL" clId="{67D2C233-DF3C-4C6D-9040-D7553E3BCB8A}" dt="2026-03-16T14:03:02.466" v="54" actId="20577"/>
-        <pc:sldMkLst>
-          <pc:docMk/>
-          <pc:sldMk cId="829672710" sldId="297"/>
-        </pc:sldMkLst>
-        <pc:spChg chg="mod">
-          <ac:chgData name="Tiago Janela" userId="ee1a79fe-c79c-4f34-9602-7f6f2f0482b3" providerId="ADAL" clId="{67D2C233-DF3C-4C6D-9040-D7553E3BCB8A}" dt="2026-03-16T14:03:02.466" v="54" actId="20577"/>
-          <ac:spMkLst>
-            <pc:docMk/>
-            <pc:sldMk cId="829672710" sldId="297"/>
-            <ac:spMk id="156" creationId="{00000000-0000-0000-0000-000000000000}"/>
-          </ac:spMkLst>
-        </pc:spChg>
-      </pc:sldChg>
-      <pc:sldChg chg="modSp mod">
-        <pc:chgData name="Tiago Janela" userId="ee1a79fe-c79c-4f34-9602-7f6f2f0482b3" providerId="ADAL" clId="{67D2C233-DF3C-4C6D-9040-D7553E3BCB8A}" dt="2026-03-16T14:02:34.148" v="0" actId="20577"/>
-        <pc:sldMkLst>
-          <pc:docMk/>
-          <pc:sldMk cId="721732568" sldId="298"/>
-        </pc:sldMkLst>
-        <pc:spChg chg="mod">
-          <ac:chgData name="Tiago Janela" userId="ee1a79fe-c79c-4f34-9602-7f6f2f0482b3" providerId="ADAL" clId="{67D2C233-DF3C-4C6D-9040-D7553E3BCB8A}" dt="2026-03-16T14:02:34.148" v="0" actId="20577"/>
-          <ac:spMkLst>
-            <pc:docMk/>
-            <pc:sldMk cId="721732568" sldId="298"/>
-            <ac:spMk id="2" creationId="{870990D0-7AC5-46BA-6FC4-274F8E0A3ABE}"/>
-          </ac:spMkLst>
-        </pc:spChg>
       </pc:sldChg>
     </pc:docChg>
   </pc:docChgLst>
@@ -13146,9 +13146,9 @@
         <p:grpSpPr>
           <a:xfrm>
             <a:off x="380879" y="1191667"/>
-            <a:ext cx="8601794" cy="4349000"/>
+            <a:ext cx="8767517" cy="4349000"/>
             <a:chOff x="232995" y="406630"/>
-            <a:chExt cx="11549227" cy="5839199"/>
+            <a:chExt cx="11771735" cy="5839199"/>
           </a:xfrm>
         </p:grpSpPr>
         <p:sp>
@@ -13203,7 +13203,31 @@
               </a:r>
               <a:r>
                 <a:rPr lang="en-US" sz="1000" dirty="0"/>
-                <a:t>Both methods highlight that modifications to the R-groups attached to the morpholine ring are the most sensitive levers for changing bioactivity.</a:t>
+                <a:t>Both methods highlight that modifications to the </a:t>
+              </a:r>
+              <a:r>
+                <a:rPr lang="en-US" sz="1000" b="1" dirty="0"/>
+                <a:t>R-groups attached to the morpholine ring </a:t>
+              </a:r>
+              <a:r>
+                <a:rPr lang="en-US" sz="1000" dirty="0"/>
+                <a:t>are the </a:t>
+              </a:r>
+              <a:r>
+                <a:rPr lang="en-US" sz="1000" b="1" dirty="0"/>
+                <a:t>most sensitive </a:t>
+              </a:r>
+              <a:r>
+                <a:rPr lang="en-US" sz="1000" dirty="0"/>
+                <a:t>levers for changing </a:t>
+              </a:r>
+              <a:r>
+                <a:rPr lang="en-US" sz="1000" b="1" dirty="0"/>
+                <a:t>bioactivity</a:t>
+              </a:r>
+              <a:r>
+                <a:rPr lang="en-US" sz="1000" dirty="0"/>
+                <a:t>.</a:t>
               </a:r>
             </a:p>
             <a:p>
@@ -13228,7 +13252,23 @@
               </a:r>
               <a:r>
                 <a:rPr lang="en-US" sz="1000" dirty="0"/>
-                <a:t> provides a theoretical contrastive feature (a specific R-group that is "anti-activating"). Counterfactuals provides concrete examples of inactive molecules. </a:t>
+                <a:t> provides a </a:t>
+              </a:r>
+              <a:r>
+                <a:rPr lang="en-US" sz="1000" b="1" dirty="0"/>
+                <a:t>theoretical contrastive feature </a:t>
+              </a:r>
+              <a:r>
+                <a:rPr lang="en-US" sz="1000" dirty="0"/>
+                <a:t>(a specific R-group that is "anti-activating"). Counterfactuals provides </a:t>
+              </a:r>
+              <a:r>
+                <a:rPr lang="en-US" sz="1000" b="1" dirty="0"/>
+                <a:t>concrete examples of inactive molecules</a:t>
+              </a:r>
+              <a:r>
+                <a:rPr lang="en-US" sz="1000" dirty="0"/>
+                <a:t>. </a:t>
               </a:r>
               <a:r>
                 <a:rPr lang="en-US" sz="1000" dirty="0" err="1"/>
@@ -13449,197 +13489,81 @@
           <p:grpSpPr>
             <a:xfrm>
               <a:off x="3100852" y="406630"/>
-              <a:ext cx="4177285" cy="3044438"/>
+              <a:ext cx="4147226" cy="2958817"/>
               <a:chOff x="2837001" y="180836"/>
-              <a:chExt cx="4177285" cy="3044438"/>
+              <a:chExt cx="4147226" cy="2958817"/>
             </a:xfrm>
           </p:grpSpPr>
-          <p:grpSp>
-            <p:nvGrpSpPr>
-              <p:cNvPr id="27" name="Group 26">
+          <p:pic>
+            <p:nvPicPr>
+              <p:cNvPr id="32" name="Picture 31" descr="A screenshot of a graph&#10;&#10;AI-generated content may be incorrect.">
                 <a:extLst>
                   <a:ext uri="{FF2B5EF4-FFF2-40B4-BE49-F238E27FC236}">
-                    <a16:creationId xmlns:a16="http://schemas.microsoft.com/office/drawing/2014/main" id="{C867F122-D459-E4D8-E91E-39D4FB20E8FB}"/>
+                    <a16:creationId xmlns:a16="http://schemas.microsoft.com/office/drawing/2014/main" id="{5A34DEF1-BD9B-CD6A-A8D2-7AFC0C5C49C9}"/>
                   </a:ext>
                 </a:extLst>
               </p:cNvPr>
-              <p:cNvGrpSpPr>
-                <a:grpSpLocks noChangeAspect="1"/>
-              </p:cNvGrpSpPr>
+              <p:cNvPicPr>
+                <a:picLocks noChangeAspect="1"/>
+              </p:cNvPicPr>
               <p:nvPr/>
-            </p:nvGrpSpPr>
-            <p:grpSpPr>
+            </p:nvPicPr>
+            <p:blipFill>
+              <a:blip r:embed="rId6">
+                <a:extLst>
+                  <a:ext uri="{28A0092B-C50C-407E-A947-70E740481C1C}">
+                    <a14:useLocalDpi xmlns:a14="http://schemas.microsoft.com/office/drawing/2010/main" val="0"/>
+                  </a:ext>
+                </a:extLst>
+              </a:blip>
+              <a:srcRect l="31035" t="24006" r="53731" b="44988"/>
+              <a:stretch/>
+            </p:blipFill>
+            <p:spPr>
               <a:xfrm>
                 <a:off x="2837001" y="756337"/>
-                <a:ext cx="2160399" cy="2468937"/>
-                <a:chOff x="3436044" y="2054607"/>
-                <a:chExt cx="2487556" cy="2842817"/>
+                <a:ext cx="2139552" cy="2303440"/>
               </a:xfrm>
-            </p:grpSpPr>
-            <p:pic>
-              <p:nvPicPr>
-                <p:cNvPr id="32" name="Picture 31" descr="A screenshot of a graph&#10;&#10;AI-generated content may be incorrect.">
-                  <a:extLst>
-                    <a:ext uri="{FF2B5EF4-FFF2-40B4-BE49-F238E27FC236}">
-                      <a16:creationId xmlns:a16="http://schemas.microsoft.com/office/drawing/2014/main" id="{5A34DEF1-BD9B-CD6A-A8D2-7AFC0C5C49C9}"/>
-                    </a:ext>
-                  </a:extLst>
-                </p:cNvPr>
-                <p:cNvPicPr>
-                  <a:picLocks noChangeAspect="1"/>
-                </p:cNvPicPr>
-                <p:nvPr/>
-              </p:nvPicPr>
-              <p:blipFill>
-                <a:blip r:embed="rId6">
-                  <a:extLst>
-                    <a:ext uri="{28A0092B-C50C-407E-A947-70E740481C1C}">
-                      <a14:useLocalDpi xmlns:a14="http://schemas.microsoft.com/office/drawing/2010/main" val="0"/>
-                    </a:ext>
-                  </a:extLst>
-                </a:blip>
-                <a:srcRect l="31035" t="24006" r="53731" b="44988"/>
-                <a:stretch/>
-              </p:blipFill>
-              <p:spPr>
-                <a:xfrm>
-                  <a:off x="3436044" y="2054607"/>
-                  <a:ext cx="2222549" cy="2392796"/>
-                </a:xfrm>
-                <a:prstGeom prst="rect">
-                  <a:avLst/>
-                </a:prstGeom>
-              </p:spPr>
-            </p:pic>
-            <p:pic>
-              <p:nvPicPr>
-                <p:cNvPr id="33" name="Picture 32" descr="A screenshot of a graph&#10;&#10;AI-generated content may be incorrect.">
-                  <a:extLst>
-                    <a:ext uri="{FF2B5EF4-FFF2-40B4-BE49-F238E27FC236}">
-                      <a16:creationId xmlns:a16="http://schemas.microsoft.com/office/drawing/2014/main" id="{C3C561D4-D6EB-0889-183B-97DE0B45487D}"/>
-                    </a:ext>
-                  </a:extLst>
-                </p:cNvPr>
-                <p:cNvPicPr>
-                  <a:picLocks noChangeAspect="1"/>
-                </p:cNvPicPr>
-                <p:nvPr/>
-              </p:nvPicPr>
-              <p:blipFill>
-                <a:blip r:embed="rId6">
-                  <a:extLst>
-                    <a:ext uri="{28A0092B-C50C-407E-A947-70E740481C1C}">
-                      <a14:useLocalDpi xmlns:a14="http://schemas.microsoft.com/office/drawing/2010/main" val="0"/>
-                    </a:ext>
-                  </a:extLst>
-                </a:blip>
-                <a:srcRect l="31170" t="17838" r="53596" b="76213"/>
-                <a:stretch/>
-              </p:blipFill>
-              <p:spPr>
-                <a:xfrm>
-                  <a:off x="3701051" y="4438366"/>
-                  <a:ext cx="2222549" cy="459058"/>
-                </a:xfrm>
-                <a:prstGeom prst="rect">
-                  <a:avLst/>
-                </a:prstGeom>
-              </p:spPr>
-            </p:pic>
-          </p:grpSp>
-          <p:grpSp>
-            <p:nvGrpSpPr>
-              <p:cNvPr id="28" name="Group 27">
+              <a:prstGeom prst="rect">
+                <a:avLst/>
+              </a:prstGeom>
+            </p:spPr>
+          </p:pic>
+          <p:pic>
+            <p:nvPicPr>
+              <p:cNvPr id="30" name="Picture 29" descr="A screenshot of a graph&#10;&#10;AI-generated content may be incorrect.">
                 <a:extLst>
                   <a:ext uri="{FF2B5EF4-FFF2-40B4-BE49-F238E27FC236}">
-                    <a16:creationId xmlns:a16="http://schemas.microsoft.com/office/drawing/2014/main" id="{31D67220-A5A3-C982-ABAA-76BF27D3A610}"/>
+                    <a16:creationId xmlns:a16="http://schemas.microsoft.com/office/drawing/2014/main" id="{31CDC5D0-80F4-CF34-180C-1E2C5181119A}"/>
                   </a:ext>
                 </a:extLst>
               </p:cNvPr>
-              <p:cNvGrpSpPr>
-                <a:grpSpLocks noChangeAspect="1"/>
-              </p:cNvGrpSpPr>
+              <p:cNvPicPr>
+                <a:picLocks noChangeAspect="1"/>
+              </p:cNvPicPr>
               <p:nvPr/>
-            </p:nvGrpSpPr>
-            <p:grpSpPr>
+            </p:nvPicPr>
+            <p:blipFill>
+              <a:blip r:embed="rId6">
+                <a:extLst>
+                  <a:ext uri="{28A0092B-C50C-407E-A947-70E740481C1C}">
+                    <a14:useLocalDpi xmlns:a14="http://schemas.microsoft.com/office/drawing/2010/main" val="0"/>
+                  </a:ext>
+                </a:extLst>
+              </a:blip>
+              <a:srcRect l="56362" t="23416" r="29209" b="43925"/>
+              <a:stretch/>
+            </p:blipFill>
+            <p:spPr>
               <a:xfrm>
-                <a:off x="5025516" y="794440"/>
-                <a:ext cx="1988770" cy="2392732"/>
-                <a:chOff x="5620740" y="1990807"/>
-                <a:chExt cx="2369090" cy="2850303"/>
+                <a:off x="5025515" y="794441"/>
+                <a:ext cx="1958712" cy="2345212"/>
               </a:xfrm>
-            </p:grpSpPr>
-            <p:pic>
-              <p:nvPicPr>
-                <p:cNvPr id="30" name="Picture 29" descr="A screenshot of a graph&#10;&#10;AI-generated content may be incorrect.">
-                  <a:extLst>
-                    <a:ext uri="{FF2B5EF4-FFF2-40B4-BE49-F238E27FC236}">
-                      <a16:creationId xmlns:a16="http://schemas.microsoft.com/office/drawing/2014/main" id="{31CDC5D0-80F4-CF34-180C-1E2C5181119A}"/>
-                    </a:ext>
-                  </a:extLst>
-                </p:cNvPr>
-                <p:cNvPicPr>
-                  <a:picLocks noChangeAspect="1"/>
-                </p:cNvPicPr>
-                <p:nvPr/>
-              </p:nvPicPr>
-              <p:blipFill>
-                <a:blip r:embed="rId6">
-                  <a:extLst>
-                    <a:ext uri="{28A0092B-C50C-407E-A947-70E740481C1C}">
-                      <a14:useLocalDpi xmlns:a14="http://schemas.microsoft.com/office/drawing/2010/main" val="0"/>
-                    </a:ext>
-                  </a:extLst>
-                </a:blip>
-                <a:srcRect l="56362" t="23416" r="29209" b="43925"/>
-                <a:stretch/>
-              </p:blipFill>
-              <p:spPr>
-                <a:xfrm>
-                  <a:off x="5620740" y="1990807"/>
-                  <a:ext cx="2105025" cy="2520397"/>
-                </a:xfrm>
-                <a:prstGeom prst="rect">
-                  <a:avLst/>
-                </a:prstGeom>
-              </p:spPr>
-            </p:pic>
-            <p:pic>
-              <p:nvPicPr>
-                <p:cNvPr id="31" name="Picture 30" descr="A screenshot of a graph&#10;&#10;AI-generated content may be incorrect.">
-                  <a:extLst>
-                    <a:ext uri="{FF2B5EF4-FFF2-40B4-BE49-F238E27FC236}">
-                      <a16:creationId xmlns:a16="http://schemas.microsoft.com/office/drawing/2014/main" id="{CA091874-25E2-30DF-B764-40BAC98019C4}"/>
-                    </a:ext>
-                  </a:extLst>
-                </p:cNvPr>
-                <p:cNvPicPr>
-                  <a:picLocks noChangeAspect="1"/>
-                </p:cNvPicPr>
-                <p:nvPr/>
-              </p:nvPicPr>
-              <p:blipFill>
-                <a:blip r:embed="rId6">
-                  <a:extLst>
-                    <a:ext uri="{28A0092B-C50C-407E-A947-70E740481C1C}">
-                      <a14:useLocalDpi xmlns:a14="http://schemas.microsoft.com/office/drawing/2010/main" val="0"/>
-                    </a:ext>
-                  </a:extLst>
-                </a:blip>
-                <a:srcRect l="56362" t="18606" r="29209" b="76905"/>
-                <a:stretch/>
-              </p:blipFill>
-              <p:spPr>
-                <a:xfrm>
-                  <a:off x="5884805" y="4494680"/>
-                  <a:ext cx="2105025" cy="346430"/>
-                </a:xfrm>
-                <a:prstGeom prst="rect">
-                  <a:avLst/>
-                </a:prstGeom>
-              </p:spPr>
-            </p:pic>
-          </p:grpSp>
+              <a:prstGeom prst="rect">
+                <a:avLst/>
+              </a:prstGeom>
+            </p:spPr>
+          </p:pic>
           <p:sp>
             <p:nvSpPr>
               <p:cNvPr id="29" name="TextBox 28">
@@ -13692,198 +13616,82 @@
           </p:nvGrpSpPr>
           <p:grpSpPr>
             <a:xfrm>
-              <a:off x="7476422" y="406630"/>
-              <a:ext cx="4305800" cy="2445525"/>
-              <a:chOff x="7484339" y="181744"/>
-              <a:chExt cx="4305800" cy="2445525"/>
+              <a:off x="7444397" y="406630"/>
+              <a:ext cx="4560333" cy="2304261"/>
+              <a:chOff x="7452314" y="181744"/>
+              <a:chExt cx="4560333" cy="2304261"/>
             </a:xfrm>
           </p:grpSpPr>
-          <p:grpSp>
-            <p:nvGrpSpPr>
-              <p:cNvPr id="35" name="Group 34">
+          <p:pic>
+            <p:nvPicPr>
+              <p:cNvPr id="40" name="Picture 39" descr="A black and red chemical structure&#10;&#10;AI-generated content may be incorrect.">
                 <a:extLst>
                   <a:ext uri="{FF2B5EF4-FFF2-40B4-BE49-F238E27FC236}">
-                    <a16:creationId xmlns:a16="http://schemas.microsoft.com/office/drawing/2014/main" id="{315A4BFF-0CA9-D528-2306-83671A721F96}"/>
+                    <a16:creationId xmlns:a16="http://schemas.microsoft.com/office/drawing/2014/main" id="{13934202-8C49-5877-EAF5-D53028B5669E}"/>
                   </a:ext>
                 </a:extLst>
               </p:cNvPr>
-              <p:cNvGrpSpPr>
-                <a:grpSpLocks noChangeAspect="1"/>
-              </p:cNvGrpSpPr>
+              <p:cNvPicPr>
+                <a:picLocks noChangeAspect="1"/>
+              </p:cNvPicPr>
               <p:nvPr/>
-            </p:nvGrpSpPr>
-            <p:grpSpPr>
+            </p:nvPicPr>
+            <p:blipFill>
+              <a:blip r:embed="rId7" cstate="print">
+                <a:extLst>
+                  <a:ext uri="{28A0092B-C50C-407E-A947-70E740481C1C}">
+                    <a14:useLocalDpi xmlns:a14="http://schemas.microsoft.com/office/drawing/2010/main" val="0"/>
+                  </a:ext>
+                </a:extLst>
+              </a:blip>
+              <a:srcRect l="26131" t="13384" r="50592" b="35527"/>
+              <a:stretch/>
+            </p:blipFill>
+            <p:spPr>
               <a:xfrm>
-                <a:off x="7484339" y="1329135"/>
-                <a:ext cx="2052000" cy="1269160"/>
-                <a:chOff x="7955797" y="1713756"/>
-                <a:chExt cx="2885092" cy="1784427"/>
+                <a:off x="7452314" y="1329135"/>
+                <a:ext cx="2274509" cy="1092048"/>
               </a:xfrm>
-            </p:grpSpPr>
-            <p:pic>
-              <p:nvPicPr>
-                <p:cNvPr id="40" name="Picture 39" descr="A black and red chemical structure&#10;&#10;AI-generated content may be incorrect.">
-                  <a:extLst>
-                    <a:ext uri="{FF2B5EF4-FFF2-40B4-BE49-F238E27FC236}">
-                      <a16:creationId xmlns:a16="http://schemas.microsoft.com/office/drawing/2014/main" id="{13934202-8C49-5877-EAF5-D53028B5669E}"/>
-                    </a:ext>
-                  </a:extLst>
-                </p:cNvPr>
-                <p:cNvPicPr>
-                  <a:picLocks noChangeAspect="1"/>
-                </p:cNvPicPr>
-                <p:nvPr/>
-              </p:nvPicPr>
-              <p:blipFill>
-                <a:blip r:embed="rId7" cstate="print">
-                  <a:extLst>
-                    <a:ext uri="{28A0092B-C50C-407E-A947-70E740481C1C}">
-                      <a14:useLocalDpi xmlns:a14="http://schemas.microsoft.com/office/drawing/2010/main" val="0"/>
-                    </a:ext>
-                  </a:extLst>
-                </a:blip>
-                <a:srcRect l="26131" t="13384" r="50592" b="35527"/>
-                <a:stretch/>
-              </p:blipFill>
-              <p:spPr>
-                <a:xfrm>
-                  <a:off x="7955797" y="1713756"/>
-                  <a:ext cx="2885092" cy="1385205"/>
-                </a:xfrm>
-                <a:prstGeom prst="rect">
-                  <a:avLst/>
-                </a:prstGeom>
-              </p:spPr>
-            </p:pic>
-            <p:pic>
-              <p:nvPicPr>
-                <p:cNvPr id="41" name="Picture 40" descr="A black and red chemical structure&#10;&#10;AI-generated content may be incorrect.">
-                  <a:extLst>
-                    <a:ext uri="{FF2B5EF4-FFF2-40B4-BE49-F238E27FC236}">
-                      <a16:creationId xmlns:a16="http://schemas.microsoft.com/office/drawing/2014/main" id="{14AFA39F-495B-AE1F-EE0F-FC1A7BA10F05}"/>
-                    </a:ext>
-                  </a:extLst>
-                </p:cNvPr>
-                <p:cNvPicPr>
-                  <a:picLocks noChangeAspect="1"/>
-                </p:cNvPicPr>
-                <p:nvPr/>
-              </p:nvPicPr>
-              <p:blipFill>
-                <a:blip r:embed="rId7">
-                  <a:extLst>
-                    <a:ext uri="{28A0092B-C50C-407E-A947-70E740481C1C}">
-                      <a14:useLocalDpi xmlns:a14="http://schemas.microsoft.com/office/drawing/2010/main" val="0"/>
-                    </a:ext>
-                  </a:extLst>
-                </a:blip>
-                <a:srcRect l="34138" t="87643" r="59329" b="4628"/>
-                <a:stretch/>
-              </p:blipFill>
-              <p:spPr>
-                <a:xfrm>
-                  <a:off x="8883993" y="3231955"/>
-                  <a:ext cx="1028700" cy="266228"/>
-                </a:xfrm>
-                <a:prstGeom prst="rect">
-                  <a:avLst/>
-                </a:prstGeom>
-              </p:spPr>
-            </p:pic>
-          </p:grpSp>
-          <p:grpSp>
-            <p:nvGrpSpPr>
-              <p:cNvPr id="36" name="Group 35">
+              <a:prstGeom prst="rect">
+                <a:avLst/>
+              </a:prstGeom>
+            </p:spPr>
+          </p:pic>
+          <p:pic>
+            <p:nvPicPr>
+              <p:cNvPr id="38" name="Picture 37" descr="A black and red chemical structure&#10;&#10;AI-generated content may be incorrect.">
                 <a:extLst>
                   <a:ext uri="{FF2B5EF4-FFF2-40B4-BE49-F238E27FC236}">
-                    <a16:creationId xmlns:a16="http://schemas.microsoft.com/office/drawing/2014/main" id="{40F329E8-016F-7B2E-D6E4-F9F4E0BE7A34}"/>
+                    <a16:creationId xmlns:a16="http://schemas.microsoft.com/office/drawing/2014/main" id="{48ACB3B0-1845-ABC3-5228-376A5949FA79}"/>
                   </a:ext>
                 </a:extLst>
               </p:cNvPr>
-              <p:cNvGrpSpPr>
-                <a:grpSpLocks noChangeAspect="1"/>
-              </p:cNvGrpSpPr>
+              <p:cNvPicPr>
+                <a:picLocks noChangeAspect="1"/>
+              </p:cNvPicPr>
               <p:nvPr/>
-            </p:nvGrpSpPr>
-            <p:grpSpPr>
+            </p:nvPicPr>
+            <p:blipFill>
+              <a:blip r:embed="rId7" cstate="print">
+                <a:extLst>
+                  <a:ext uri="{28A0092B-C50C-407E-A947-70E740481C1C}">
+                    <a14:useLocalDpi xmlns:a14="http://schemas.microsoft.com/office/drawing/2010/main" val="0"/>
+                  </a:ext>
+                </a:extLst>
+              </a:blip>
+              <a:srcRect l="51184" t="14586" r="25463" b="34325"/>
+              <a:stretch/>
+            </p:blipFill>
+            <p:spPr>
               <a:xfrm>
                 <a:off x="9738139" y="1397550"/>
-                <a:ext cx="2052000" cy="1229719"/>
-                <a:chOff x="7951035" y="3350221"/>
-                <a:chExt cx="2894617" cy="1734681"/>
+                <a:ext cx="2274508" cy="1088455"/>
               </a:xfrm>
-            </p:grpSpPr>
-            <p:pic>
-              <p:nvPicPr>
-                <p:cNvPr id="38" name="Picture 37" descr="A black and red chemical structure&#10;&#10;AI-generated content may be incorrect.">
-                  <a:extLst>
-                    <a:ext uri="{FF2B5EF4-FFF2-40B4-BE49-F238E27FC236}">
-                      <a16:creationId xmlns:a16="http://schemas.microsoft.com/office/drawing/2014/main" id="{48ACB3B0-1845-ABC3-5228-376A5949FA79}"/>
-                    </a:ext>
-                  </a:extLst>
-                </p:cNvPr>
-                <p:cNvPicPr>
-                  <a:picLocks noChangeAspect="1"/>
-                </p:cNvPicPr>
-                <p:nvPr/>
-              </p:nvPicPr>
-              <p:blipFill>
-                <a:blip r:embed="rId7" cstate="print">
-                  <a:extLst>
-                    <a:ext uri="{28A0092B-C50C-407E-A947-70E740481C1C}">
-                      <a14:useLocalDpi xmlns:a14="http://schemas.microsoft.com/office/drawing/2010/main" val="0"/>
-                    </a:ext>
-                  </a:extLst>
-                </a:blip>
-                <a:srcRect l="51184" t="14586" r="25463" b="34325"/>
-                <a:stretch/>
-              </p:blipFill>
-              <p:spPr>
-                <a:xfrm>
-                  <a:off x="7951035" y="3350221"/>
-                  <a:ext cx="2894617" cy="1385206"/>
-                </a:xfrm>
-                <a:prstGeom prst="rect">
-                  <a:avLst/>
-                </a:prstGeom>
-              </p:spPr>
-            </p:pic>
-            <p:pic>
-              <p:nvPicPr>
-                <p:cNvPr id="39" name="Picture 38" descr="A black and red chemical structure&#10;&#10;AI-generated content may be incorrect.">
-                  <a:extLst>
-                    <a:ext uri="{FF2B5EF4-FFF2-40B4-BE49-F238E27FC236}">
-                      <a16:creationId xmlns:a16="http://schemas.microsoft.com/office/drawing/2014/main" id="{5D7062A3-FA42-FF24-FF7D-4729F61DD8A5}"/>
-                    </a:ext>
-                  </a:extLst>
-                </p:cNvPr>
-                <p:cNvPicPr>
-                  <a:picLocks noChangeAspect="1"/>
-                </p:cNvPicPr>
-                <p:nvPr/>
-              </p:nvPicPr>
-              <p:blipFill>
-                <a:blip r:embed="rId7">
-                  <a:extLst>
-                    <a:ext uri="{28A0092B-C50C-407E-A947-70E740481C1C}">
-                      <a14:useLocalDpi xmlns:a14="http://schemas.microsoft.com/office/drawing/2010/main" val="0"/>
-                    </a:ext>
-                  </a:extLst>
-                </a:blip>
-                <a:srcRect l="59497" t="85098" r="34125" b="3309"/>
-                <a:stretch/>
-              </p:blipFill>
-              <p:spPr>
-                <a:xfrm>
-                  <a:off x="8926807" y="4709945"/>
-                  <a:ext cx="943073" cy="374957"/>
-                </a:xfrm>
-                <a:prstGeom prst="rect">
-                  <a:avLst/>
-                </a:prstGeom>
-              </p:spPr>
-            </p:pic>
-          </p:grpSp>
+              <a:prstGeom prst="rect">
+                <a:avLst/>
+              </a:prstGeom>
+            </p:spPr>
+          </p:pic>
           <p:sp>
             <p:nvSpPr>
               <p:cNvPr id="37" name="TextBox 36">
@@ -14025,6 +13833,320 @@
               </a:solidFill>
               <a:latin typeface="Century Gothic"/>
             </a:endParaRPr>
+          </a:p>
+        </p:txBody>
+      </p:sp>
+      <p:sp>
+        <p:nvSpPr>
+          <p:cNvPr id="6" name="TextBox 5">
+            <a:extLst>
+              <a:ext uri="{FF2B5EF4-FFF2-40B4-BE49-F238E27FC236}">
+                <a16:creationId xmlns:a16="http://schemas.microsoft.com/office/drawing/2014/main" id="{15287AC3-7F0E-0B38-9378-106BACD22702}"/>
+              </a:ext>
+            </a:extLst>
+          </p:cNvPr>
+          <p:cNvSpPr txBox="1"/>
+          <p:nvPr/>
+        </p:nvSpPr>
+        <p:spPr>
+          <a:xfrm>
+            <a:off x="2197518" y="3355198"/>
+            <a:ext cx="2232171" cy="369332"/>
+          </a:xfrm>
+          <a:prstGeom prst="rect">
+            <a:avLst/>
+          </a:prstGeom>
+          <a:noFill/>
+        </p:spPr>
+        <p:txBody>
+          <a:bodyPr wrap="square" rtlCol="0">
+            <a:spAutoFit/>
+          </a:bodyPr>
+          <a:lstStyle/>
+          <a:p>
+            <a:pPr algn="ctr"/>
+            <a:r>
+              <a:rPr lang="en-US" sz="900" b="1" i="0" dirty="0">
+                <a:solidFill>
+                  <a:srgbClr val="0F0F0F"/>
+                </a:solidFill>
+                <a:effectLst/>
+                <a:latin typeface="ui-sans-serif"/>
+              </a:rPr>
+              <a:t>CF #1 (substituent)</a:t>
+            </a:r>
+          </a:p>
+          <a:p>
+            <a:pPr algn="ctr"/>
+            <a:r>
+              <a:rPr lang="en-US" sz="900" b="1" i="0" dirty="0">
+                <a:solidFill>
+                  <a:srgbClr val="0F0F0F"/>
+                </a:solidFill>
+                <a:effectLst/>
+                <a:latin typeface="ui-sans-serif"/>
+              </a:rPr>
+              <a:t>Predicted class: 0 | Similarity: 0.68</a:t>
+            </a:r>
+          </a:p>
+        </p:txBody>
+      </p:sp>
+      <p:sp>
+        <p:nvSpPr>
+          <p:cNvPr id="7" name="TextBox 6">
+            <a:extLst>
+              <a:ext uri="{FF2B5EF4-FFF2-40B4-BE49-F238E27FC236}">
+                <a16:creationId xmlns:a16="http://schemas.microsoft.com/office/drawing/2014/main" id="{841EB23C-A43D-DDA5-6AC6-03E6D94EA00D}"/>
+              </a:ext>
+            </a:extLst>
+          </p:cNvPr>
+          <p:cNvSpPr txBox="1"/>
+          <p:nvPr/>
+        </p:nvSpPr>
+        <p:spPr>
+          <a:xfrm>
+            <a:off x="5482822" y="3000598"/>
+            <a:ext cx="2232171" cy="369332"/>
+          </a:xfrm>
+          <a:prstGeom prst="rect">
+            <a:avLst/>
+          </a:prstGeom>
+          <a:noFill/>
+        </p:spPr>
+        <p:txBody>
+          <a:bodyPr wrap="square" rtlCol="0">
+            <a:spAutoFit/>
+          </a:bodyPr>
+          <a:lstStyle/>
+          <a:p>
+            <a:pPr algn="ctr"/>
+            <a:r>
+              <a:rPr lang="en-US" sz="900" b="1" i="0" dirty="0">
+                <a:solidFill>
+                  <a:srgbClr val="0F0F0F"/>
+                </a:solidFill>
+                <a:effectLst/>
+                <a:latin typeface="ui-sans-serif"/>
+              </a:rPr>
+              <a:t>Rank 1 |</a:t>
+            </a:r>
+            <a:r>
+              <a:rPr lang="en-US" sz="900" i="0" dirty="0">
+                <a:solidFill>
+                  <a:srgbClr val="0F0F0F"/>
+                </a:solidFill>
+                <a:effectLst/>
+                <a:latin typeface="ui-sans-serif"/>
+              </a:rPr>
+              <a:t> </a:t>
+            </a:r>
+            <a:r>
+              <a:rPr lang="en-US" sz="900" b="1" dirty="0">
+                <a:solidFill>
+                  <a:srgbClr val="0F0F0F"/>
+                </a:solidFill>
+                <a:latin typeface="ui-sans-serif"/>
+              </a:rPr>
+              <a:t>S</a:t>
+            </a:r>
+            <a:r>
+              <a:rPr lang="en-US" sz="900" b="1" i="0" dirty="0">
+                <a:solidFill>
+                  <a:srgbClr val="0F0F0F"/>
+                </a:solidFill>
+                <a:effectLst/>
+                <a:latin typeface="ui-sans-serif"/>
+              </a:rPr>
+              <a:t>ite 1</a:t>
+            </a:r>
+          </a:p>
+          <a:p>
+            <a:pPr algn="ctr"/>
+            <a:r>
+              <a:rPr lang="en-US" sz="900" b="1" dirty="0">
+                <a:solidFill>
+                  <a:srgbClr val="0F0F0F"/>
+                </a:solidFill>
+                <a:latin typeface="ui-sans-serif"/>
+              </a:rPr>
+              <a:t>Contrast=1.000</a:t>
+            </a:r>
+          </a:p>
+        </p:txBody>
+      </p:sp>
+      <p:sp>
+        <p:nvSpPr>
+          <p:cNvPr id="8" name="TextBox 7">
+            <a:extLst>
+              <a:ext uri="{FF2B5EF4-FFF2-40B4-BE49-F238E27FC236}">
+                <a16:creationId xmlns:a16="http://schemas.microsoft.com/office/drawing/2014/main" id="{150DA1B1-02DE-4F73-AF01-3E3EDD2F27A3}"/>
+              </a:ext>
+            </a:extLst>
+          </p:cNvPr>
+          <p:cNvSpPr txBox="1"/>
+          <p:nvPr/>
+        </p:nvSpPr>
+        <p:spPr>
+          <a:xfrm>
+            <a:off x="3917852" y="3353775"/>
+            <a:ext cx="2232171" cy="369332"/>
+          </a:xfrm>
+          <a:prstGeom prst="rect">
+            <a:avLst/>
+          </a:prstGeom>
+          <a:noFill/>
+        </p:spPr>
+        <p:txBody>
+          <a:bodyPr wrap="square" rtlCol="0">
+            <a:spAutoFit/>
+          </a:bodyPr>
+          <a:lstStyle/>
+          <a:p>
+            <a:pPr algn="ctr"/>
+            <a:r>
+              <a:rPr lang="en-US" sz="900" b="1" i="0" dirty="0">
+                <a:solidFill>
+                  <a:srgbClr val="0F0F0F"/>
+                </a:solidFill>
+                <a:effectLst/>
+                <a:latin typeface="ui-sans-serif"/>
+              </a:rPr>
+              <a:t>CF #</a:t>
+            </a:r>
+            <a:r>
+              <a:rPr lang="en-US" sz="900" b="1" dirty="0">
+                <a:solidFill>
+                  <a:srgbClr val="0F0F0F"/>
+                </a:solidFill>
+                <a:latin typeface="ui-sans-serif"/>
+              </a:rPr>
+              <a:t>2</a:t>
+            </a:r>
+            <a:r>
+              <a:rPr lang="en-US" sz="900" b="1" i="0" dirty="0">
+                <a:solidFill>
+                  <a:srgbClr val="0F0F0F"/>
+                </a:solidFill>
+                <a:effectLst/>
+                <a:latin typeface="ui-sans-serif"/>
+              </a:rPr>
+              <a:t> (substituent)</a:t>
+            </a:r>
+          </a:p>
+          <a:p>
+            <a:pPr algn="ctr"/>
+            <a:r>
+              <a:rPr lang="en-US" sz="900" b="1" i="0" dirty="0">
+                <a:solidFill>
+                  <a:srgbClr val="0F0F0F"/>
+                </a:solidFill>
+                <a:effectLst/>
+                <a:latin typeface="ui-sans-serif"/>
+              </a:rPr>
+              <a:t>Predicted class: 0 | Similarity: 0.68</a:t>
+            </a:r>
+          </a:p>
+        </p:txBody>
+      </p:sp>
+      <p:sp>
+        <p:nvSpPr>
+          <p:cNvPr id="9" name="TextBox 8">
+            <a:extLst>
+              <a:ext uri="{FF2B5EF4-FFF2-40B4-BE49-F238E27FC236}">
+                <a16:creationId xmlns:a16="http://schemas.microsoft.com/office/drawing/2014/main" id="{0F0130AB-996C-A630-430B-39DF8AF93E0F}"/>
+              </a:ext>
+            </a:extLst>
+          </p:cNvPr>
+          <p:cNvSpPr txBox="1"/>
+          <p:nvPr/>
+        </p:nvSpPr>
+        <p:spPr>
+          <a:xfrm>
+            <a:off x="7185290" y="3000598"/>
+            <a:ext cx="2232171" cy="369332"/>
+          </a:xfrm>
+          <a:prstGeom prst="rect">
+            <a:avLst/>
+          </a:prstGeom>
+          <a:noFill/>
+        </p:spPr>
+        <p:txBody>
+          <a:bodyPr wrap="square" rtlCol="0">
+            <a:spAutoFit/>
+          </a:bodyPr>
+          <a:lstStyle/>
+          <a:p>
+            <a:pPr algn="ctr"/>
+            <a:r>
+              <a:rPr lang="en-US" sz="900" b="1" i="0" dirty="0">
+                <a:solidFill>
+                  <a:srgbClr val="0F0F0F"/>
+                </a:solidFill>
+                <a:effectLst/>
+                <a:latin typeface="ui-sans-serif"/>
+              </a:rPr>
+              <a:t>Rank </a:t>
+            </a:r>
+            <a:r>
+              <a:rPr lang="en-US" sz="900" b="1" dirty="0">
+                <a:solidFill>
+                  <a:srgbClr val="0F0F0F"/>
+                </a:solidFill>
+                <a:latin typeface="ui-sans-serif"/>
+              </a:rPr>
+              <a:t>2</a:t>
+            </a:r>
+            <a:r>
+              <a:rPr lang="en-US" sz="900" b="1" i="0" dirty="0">
+                <a:solidFill>
+                  <a:srgbClr val="0F0F0F"/>
+                </a:solidFill>
+                <a:effectLst/>
+                <a:latin typeface="ui-sans-serif"/>
+              </a:rPr>
+              <a:t> |</a:t>
+            </a:r>
+            <a:r>
+              <a:rPr lang="en-US" sz="900" i="0" dirty="0">
+                <a:solidFill>
+                  <a:srgbClr val="0F0F0F"/>
+                </a:solidFill>
+                <a:effectLst/>
+                <a:latin typeface="ui-sans-serif"/>
+              </a:rPr>
+              <a:t> </a:t>
+            </a:r>
+            <a:r>
+              <a:rPr lang="en-US" sz="900" b="1" dirty="0">
+                <a:solidFill>
+                  <a:srgbClr val="0F0F0F"/>
+                </a:solidFill>
+                <a:latin typeface="ui-sans-serif"/>
+              </a:rPr>
+              <a:t>S</a:t>
+            </a:r>
+            <a:r>
+              <a:rPr lang="en-US" sz="900" b="1" i="0" dirty="0">
+                <a:solidFill>
+                  <a:srgbClr val="0F0F0F"/>
+                </a:solidFill>
+                <a:effectLst/>
+                <a:latin typeface="ui-sans-serif"/>
+              </a:rPr>
+              <a:t>ite 1</a:t>
+            </a:r>
+          </a:p>
+          <a:p>
+            <a:pPr algn="ctr"/>
+            <a:r>
+              <a:rPr lang="en-US" sz="900" b="1" dirty="0">
+                <a:solidFill>
+                  <a:srgbClr val="0F0F0F"/>
+                </a:solidFill>
+                <a:latin typeface="ui-sans-serif"/>
+              </a:rPr>
+              <a:t>Contrast=1.000</a:t>
+            </a:r>
           </a:p>
         </p:txBody>
       </p:sp>
@@ -14350,7 +14472,7 @@
                 </a:solidFill>
                 <a:latin typeface="Century Gothic"/>
               </a:rPr>
-              <a:t>Demonstrate the ability of the agent to investigate learning characteristics of distinct ML methods </a:t>
+              <a:t>Display the capacity of the agent to compare and interpret explanations for different predictions</a:t>
             </a:r>
           </a:p>
           <a:p>
@@ -15132,7 +15254,7 @@
         <p:spPr>
           <a:xfrm>
             <a:off x="380879" y="3927356"/>
-            <a:ext cx="4304372" cy="2031325"/>
+            <a:ext cx="4350147" cy="2154436"/>
           </a:xfrm>
           <a:prstGeom prst="rect">
             <a:avLst/>
@@ -15180,7 +15302,7 @@
             </a:r>
           </a:p>
           <a:p>
-            <a:pPr marL="742950" lvl="1" indent="-285750" algn="l">
+            <a:pPr marL="628650" lvl="1" indent="-171450">
               <a:buFont typeface="Arial" panose="020B0604020202020204" pitchFamily="34" charset="0"/>
               <a:buChar char="•"/>
             </a:pPr>
@@ -15278,7 +15400,19 @@
               <a:rPr lang="en-US" sz="800" b="0" i="0" dirty="0">
                 <a:effectLst/>
               </a:rPr>
-              <a:t>The presence of two chlorine atoms on the phenyl ring contributes positively</a:t>
+              <a:t>The presence of </a:t>
+            </a:r>
+            <a:r>
+              <a:rPr lang="en-US" sz="800" b="1" i="0" dirty="0">
+                <a:effectLst/>
+              </a:rPr>
+              <a:t>two chlorine</a:t>
+            </a:r>
+            <a:r>
+              <a:rPr lang="en-US" sz="800" b="0" i="0" dirty="0">
+                <a:effectLst/>
+              </a:rPr>
+              <a:t> atoms on the phenyl ring contributes positively</a:t>
             </a:r>
           </a:p>
           <a:p>
@@ -15320,10 +15454,16 @@
               <a:buChar char="•"/>
             </a:pPr>
             <a:r>
+              <a:rPr lang="en-US" sz="800" b="1" i="0" dirty="0">
+                <a:effectLst/>
+              </a:rPr>
+              <a:t>The C-C bonds in the alkene linker </a:t>
+            </a:r>
+            <a:r>
               <a:rPr lang="en-US" sz="800" b="0" i="0" dirty="0">
                 <a:effectLst/>
               </a:rPr>
-              <a:t>The C-C bonds in the alkene linker (φ = 0.089, 0.070) contribute positively</a:t>
+              <a:t>(φ = 0.089, 0.070) contribute positively</a:t>
             </a:r>
           </a:p>
           <a:p>
@@ -15335,7 +15475,25 @@
               <a:rPr lang="en-US" sz="800" b="0" i="0" dirty="0">
                 <a:effectLst/>
               </a:rPr>
-              <a:t>This flexible linker allows optimal positioning of pharmacophores</a:t>
+              <a:t>This flexible </a:t>
+            </a:r>
+            <a:r>
+              <a:rPr lang="en-US" sz="800" b="1" i="0" dirty="0">
+                <a:effectLst/>
+              </a:rPr>
+              <a:t>linker</a:t>
+            </a:r>
+            <a:r>
+              <a:rPr lang="en-US" sz="800" b="0" i="0" dirty="0">
+                <a:effectLst/>
+              </a:rPr>
+              <a:t> allows optimal positioning of </a:t>
+            </a:r>
+            <a:r>
+              <a:rPr lang="en-US" sz="800" b="1" i="0" dirty="0">
+                <a:effectLst/>
+              </a:rPr>
+              <a:t>pharmacophores</a:t>
             </a:r>
           </a:p>
         </p:txBody>
@@ -15411,7 +15569,31 @@
               <a:rPr lang="en-US" sz="800" i="0" dirty="0">
                 <a:effectLst/>
               </a:rPr>
-              <a:t>The C-C bond between methyl and phenyl has an extremely high SHAP value</a:t>
+              <a:t>The</a:t>
+            </a:r>
+            <a:r>
+              <a:rPr lang="en-US" sz="800" b="1" i="0" dirty="0">
+                <a:effectLst/>
+              </a:rPr>
+              <a:t> C-C bond between methyl and phenyl </a:t>
+            </a:r>
+            <a:r>
+              <a:rPr lang="en-US" sz="800" i="0" dirty="0">
+                <a:effectLst/>
+              </a:rPr>
+              <a:t>has an extremely </a:t>
+            </a:r>
+            <a:r>
+              <a:rPr lang="en-US" sz="800" b="1" i="0" dirty="0">
+                <a:effectLst/>
+              </a:rPr>
+              <a:t>high</a:t>
+            </a:r>
+            <a:r>
+              <a:rPr lang="en-US" sz="800" i="0" dirty="0">
+                <a:effectLst/>
+              </a:rPr>
+              <a:t> SHAP value</a:t>
             </a:r>
           </a:p>
           <a:p>
@@ -15423,7 +15605,19 @@
               <a:rPr lang="en-US" sz="800" i="0" dirty="0">
                 <a:effectLst/>
               </a:rPr>
-              <a:t>This suggests the model associates simple alkyl-phenyl systems with inactivity</a:t>
+              <a:t>This suggests the model associates </a:t>
+            </a:r>
+            <a:r>
+              <a:rPr lang="en-US" sz="800" b="1" i="0" dirty="0">
+                <a:effectLst/>
+              </a:rPr>
+              <a:t>simple alkyl-phenyl systems </a:t>
+            </a:r>
+            <a:r>
+              <a:rPr lang="en-US" sz="800" i="0" dirty="0">
+                <a:effectLst/>
+              </a:rPr>
+              <a:t>with inactivity</a:t>
             </a:r>
           </a:p>
           <a:p>
@@ -15432,10 +15626,28 @@
               <a:buChar char="•"/>
             </a:pPr>
             <a:r>
+              <a:rPr lang="en-US" sz="800" b="1" i="0" dirty="0">
+                <a:effectLst/>
+              </a:rPr>
+              <a:t>Lack</a:t>
+            </a:r>
+            <a:r>
               <a:rPr lang="en-US" sz="800" i="0" dirty="0">
                 <a:effectLst/>
               </a:rPr>
-              <a:t>Lack of complex pharmacophore reduces activity likelihood</a:t>
+              <a:t> of </a:t>
+            </a:r>
+            <a:r>
+              <a:rPr lang="en-US" sz="800" b="1" i="0" dirty="0">
+                <a:effectLst/>
+              </a:rPr>
+              <a:t>complex pharmacophore </a:t>
+            </a:r>
+            <a:r>
+              <a:rPr lang="en-US" sz="800" i="0" dirty="0">
+                <a:effectLst/>
+              </a:rPr>
+              <a:t>reduces activity likelihood</a:t>
             </a:r>
           </a:p>
           <a:p>
@@ -15459,7 +15671,31 @@
               <a:rPr lang="en-US" sz="800" i="0" dirty="0">
                 <a:effectLst/>
               </a:rPr>
-              <a:t>The S-N bond (φ = 0.013) and S=O bonds (φ = 0.003) have low positive contributions</a:t>
+              <a:t>The </a:t>
+            </a:r>
+            <a:r>
+              <a:rPr lang="en-US" sz="800" b="1" i="0" dirty="0">
+                <a:effectLst/>
+              </a:rPr>
+              <a:t>S-N bond </a:t>
+            </a:r>
+            <a:r>
+              <a:rPr lang="en-US" sz="800" i="0" dirty="0">
+                <a:effectLst/>
+              </a:rPr>
+              <a:t>(φ = 0.013) </a:t>
+            </a:r>
+            <a:r>
+              <a:rPr lang="en-US" sz="800" b="1" i="0" dirty="0">
+                <a:effectLst/>
+              </a:rPr>
+              <a:t>and S=O </a:t>
+            </a:r>
+            <a:r>
+              <a:rPr lang="en-US" sz="800" i="0" dirty="0">
+                <a:effectLst/>
+              </a:rPr>
+              <a:t>bonds (φ = 0.003) have low positive contributions</a:t>
             </a:r>
           </a:p>
           <a:p>
@@ -15468,10 +15704,40 @@
               <a:buChar char="•"/>
             </a:pPr>
             <a:r>
+              <a:rPr lang="en-US" sz="800" b="1" i="0" dirty="0">
+                <a:effectLst/>
+              </a:rPr>
+              <a:t>Sulfonamides</a:t>
+            </a:r>
+            <a:r>
               <a:rPr lang="en-US" sz="800" i="0" dirty="0">
                 <a:effectLst/>
               </a:rPr>
-              <a:t>Sulfonamides in this context may not contribute to the target activity</a:t>
+              <a:t> in this context may </a:t>
+            </a:r>
+            <a:r>
+              <a:rPr lang="en-US" sz="800" b="1" i="0" dirty="0">
+                <a:effectLst/>
+              </a:rPr>
+              <a:t>not</a:t>
+            </a:r>
+            <a:r>
+              <a:rPr lang="en-US" sz="800" i="0" dirty="0">
+                <a:effectLst/>
+              </a:rPr>
+              <a:t> </a:t>
+            </a:r>
+            <a:r>
+              <a:rPr lang="en-US" sz="800" b="1" i="0" dirty="0">
+                <a:effectLst/>
+              </a:rPr>
+              <a:t>contribute</a:t>
+            </a:r>
+            <a:r>
+              <a:rPr lang="en-US" sz="800" i="0" dirty="0">
+                <a:effectLst/>
+              </a:rPr>
+              <a:t> to the target activity</a:t>
             </a:r>
           </a:p>
           <a:p>
@@ -15495,7 +15761,19 @@
               <a:rPr lang="en-US" sz="800" i="0" dirty="0">
                 <a:effectLst/>
               </a:rPr>
-              <a:t>The bicyclic terpenoid structure with hydroxyl group shows minimal SHAP contribution</a:t>
+              <a:t>The </a:t>
+            </a:r>
+            <a:r>
+              <a:rPr lang="en-US" sz="800" b="1" i="0" dirty="0">
+                <a:effectLst/>
+              </a:rPr>
+              <a:t>bicyclic terpenoid structure </a:t>
+            </a:r>
+            <a:r>
+              <a:rPr lang="en-US" sz="800" i="0" dirty="0">
+                <a:effectLst/>
+              </a:rPr>
+              <a:t>with hydroxyl group shows minimal SHAP contribution</a:t>
             </a:r>
           </a:p>
           <a:p>
@@ -15504,10 +15782,28 @@
               <a:buChar char="•"/>
             </a:pPr>
             <a:r>
+              <a:rPr lang="en-US" sz="800" b="1" i="0" dirty="0">
+                <a:effectLst/>
+              </a:rPr>
+              <a:t>Complex 3D </a:t>
+            </a:r>
+            <a:r>
               <a:rPr lang="en-US" sz="800" i="0" dirty="0">
                 <a:effectLst/>
               </a:rPr>
-              <a:t>Complex 3D structure may not align with target binding site</a:t>
+              <a:t>structure may </a:t>
+            </a:r>
+            <a:r>
+              <a:rPr lang="en-US" sz="800" b="1" i="0" dirty="0">
+                <a:effectLst/>
+              </a:rPr>
+              <a:t>not align </a:t>
+            </a:r>
+            <a:r>
+              <a:rPr lang="en-US" sz="800" i="0" dirty="0">
+                <a:effectLst/>
+              </a:rPr>
+              <a:t>with target binding site</a:t>
             </a:r>
           </a:p>
         </p:txBody>
@@ -18852,7 +19148,7 @@
                 </a:solidFill>
                 <a:latin typeface="Century Gothic"/>
               </a:rPr>
-              <a:t>Demonstrate the ability of the agent to analyze and compare the different learning characteristics of graph-based  models</a:t>
+              <a:t>Determine whether agent is capable of analyzing and comparing the learning characteristics of distinct ML-models</a:t>
             </a:r>
           </a:p>
           <a:p>
@@ -23686,7 +23982,7 @@
         </p:nvSpPr>
         <p:spPr>
           <a:xfrm>
-            <a:off x="380880" y="1375729"/>
+            <a:off x="380880" y="1328023"/>
             <a:ext cx="8380080" cy="4468480"/>
           </a:xfrm>
           <a:prstGeom prst="rect">
@@ -23906,14 +24202,16 @@
                 <a:spcPct val="100000"/>
               </a:lnSpc>
               <a:spcBef>
-                <a:spcPts val="400"/>
+                <a:spcPts val="200"/>
               </a:spcBef>
               <a:buClr>
                 <a:srgbClr val="0064C8"/>
               </a:buClr>
+              <a:buFont typeface="Wingdings" panose="05000000000000000000" pitchFamily="2" charset="2"/>
+              <a:buChar char="§"/>
             </a:pPr>
             <a:r>
-              <a:rPr lang="en-US" sz="2000" spc="-1" dirty="0">
+              <a:rPr lang="en-US" sz="1800" spc="-1" dirty="0">
                 <a:solidFill>
                   <a:srgbClr val="000000"/>
                 </a:solidFill>
@@ -23923,19 +24221,41 @@
             </a:r>
           </a:p>
           <a:p>
+            <a:pPr marL="0" indent="0">
+              <a:lnSpc>
+                <a:spcPct val="100000"/>
+              </a:lnSpc>
+              <a:spcBef>
+                <a:spcPts val="200"/>
+              </a:spcBef>
+              <a:buClr>
+                <a:srgbClr val="0064C8"/>
+              </a:buClr>
+              <a:buNone/>
+            </a:pPr>
+            <a:endParaRPr lang="en-US" sz="1800" spc="-1" dirty="0">
+              <a:solidFill>
+                <a:srgbClr val="000000"/>
+              </a:solidFill>
+              <a:latin typeface="Century Gothic"/>
+            </a:endParaRPr>
+          </a:p>
+          <a:p>
             <a:pPr>
               <a:lnSpc>
                 <a:spcPct val="100000"/>
               </a:lnSpc>
               <a:spcBef>
-                <a:spcPts val="400"/>
+                <a:spcPts val="200"/>
               </a:spcBef>
               <a:buClr>
                 <a:srgbClr val="0064C8"/>
               </a:buClr>
+              <a:buFont typeface="Wingdings" panose="05000000000000000000" pitchFamily="2" charset="2"/>
+              <a:buChar char="§"/>
             </a:pPr>
             <a:r>
-              <a:rPr lang="en-US" sz="2000" spc="-1" dirty="0" err="1">
+              <a:rPr lang="en-US" sz="1800" spc="-1" dirty="0" err="1">
                 <a:solidFill>
                   <a:srgbClr val="000000"/>
                 </a:solidFill>
@@ -23944,7 +24264,7 @@
               <a:t>ChemicHAL</a:t>
             </a:r>
             <a:r>
-              <a:rPr lang="en-US" sz="2000" spc="-1" dirty="0">
+              <a:rPr lang="en-US" sz="1800" spc="-1" dirty="0">
                 <a:solidFill>
                   <a:srgbClr val="000000"/>
                 </a:solidFill>
@@ -23954,19 +24274,41 @@
             </a:r>
           </a:p>
           <a:p>
+            <a:pPr marL="0" indent="0">
+              <a:lnSpc>
+                <a:spcPct val="100000"/>
+              </a:lnSpc>
+              <a:spcBef>
+                <a:spcPts val="200"/>
+              </a:spcBef>
+              <a:buClr>
+                <a:srgbClr val="0064C8"/>
+              </a:buClr>
+              <a:buNone/>
+            </a:pPr>
+            <a:endParaRPr lang="en-US" sz="1800" spc="-1" dirty="0">
+              <a:solidFill>
+                <a:srgbClr val="000000"/>
+              </a:solidFill>
+              <a:latin typeface="Century Gothic"/>
+            </a:endParaRPr>
+          </a:p>
+          <a:p>
             <a:pPr>
               <a:lnSpc>
                 <a:spcPct val="100000"/>
               </a:lnSpc>
               <a:spcBef>
-                <a:spcPts val="400"/>
+                <a:spcPts val="200"/>
               </a:spcBef>
               <a:buClr>
                 <a:srgbClr val="0064C8"/>
               </a:buClr>
+              <a:buFont typeface="Wingdings" panose="05000000000000000000" pitchFamily="2" charset="2"/>
+              <a:buChar char="§"/>
             </a:pPr>
             <a:r>
-              <a:rPr lang="en-US" sz="2000" spc="-1" dirty="0">
+              <a:rPr lang="en-US" sz="1800" spc="-1" dirty="0">
                 <a:solidFill>
                   <a:srgbClr val="000000"/>
                 </a:solidFill>
@@ -23981,14 +24323,37 @@
                 <a:spcPct val="100000"/>
               </a:lnSpc>
               <a:spcBef>
-                <a:spcPts val="400"/>
+                <a:spcPts val="200"/>
               </a:spcBef>
               <a:buClr>
                 <a:srgbClr val="0064C8"/>
               </a:buClr>
+              <a:buFont typeface="Wingdings" panose="05000000000000000000" pitchFamily="2" charset="2"/>
+              <a:buChar char="§"/>
+            </a:pPr>
+            <a:endParaRPr lang="en-US" sz="1800" spc="-1" dirty="0">
+              <a:solidFill>
+                <a:srgbClr val="000000"/>
+              </a:solidFill>
+              <a:latin typeface="Century Gothic"/>
+            </a:endParaRPr>
+          </a:p>
+          <a:p>
+            <a:pPr>
+              <a:lnSpc>
+                <a:spcPct val="100000"/>
+              </a:lnSpc>
+              <a:spcBef>
+                <a:spcPts val="200"/>
+              </a:spcBef>
+              <a:buClr>
+                <a:srgbClr val="0064C8"/>
+              </a:buClr>
+              <a:buFont typeface="Wingdings" panose="05000000000000000000" pitchFamily="2" charset="2"/>
+              <a:buChar char="§"/>
             </a:pPr>
             <a:r>
-              <a:rPr lang="en-US" sz="2000" spc="-1" dirty="0">
+              <a:rPr lang="en-US" sz="1800" spc="-1" dirty="0">
                 <a:solidFill>
                   <a:srgbClr val="000000"/>
                 </a:solidFill>
@@ -24003,14 +24368,37 @@
                 <a:spcPct val="100000"/>
               </a:lnSpc>
               <a:spcBef>
-                <a:spcPts val="400"/>
+                <a:spcPts val="200"/>
               </a:spcBef>
               <a:buClr>
                 <a:srgbClr val="0064C8"/>
               </a:buClr>
+              <a:buFont typeface="Wingdings" panose="05000000000000000000" pitchFamily="2" charset="2"/>
+              <a:buChar char="§"/>
+            </a:pPr>
+            <a:endParaRPr lang="en-US" sz="1800" spc="-1" dirty="0">
+              <a:solidFill>
+                <a:srgbClr val="000000"/>
+              </a:solidFill>
+              <a:latin typeface="Century Gothic"/>
+            </a:endParaRPr>
+          </a:p>
+          <a:p>
+            <a:pPr>
+              <a:lnSpc>
+                <a:spcPct val="100000"/>
+              </a:lnSpc>
+              <a:spcBef>
+                <a:spcPts val="200"/>
+              </a:spcBef>
+              <a:buClr>
+                <a:srgbClr val="0064C8"/>
+              </a:buClr>
+              <a:buFont typeface="Wingdings" panose="05000000000000000000" pitchFamily="2" charset="2"/>
+              <a:buChar char="§"/>
             </a:pPr>
             <a:r>
-              <a:rPr lang="en-US" sz="2000" spc="-1" dirty="0">
+              <a:rPr lang="en-US" sz="1800" spc="-1" dirty="0">
                 <a:solidFill>
                   <a:srgbClr val="000000"/>
                 </a:solidFill>
@@ -24766,8 +25154,8 @@
         </p:nvSpPr>
         <p:spPr>
           <a:xfrm>
-            <a:off x="380880" y="1371598"/>
-            <a:ext cx="8109070" cy="4559301"/>
+            <a:off x="380879" y="1371598"/>
+            <a:ext cx="8246285" cy="4559301"/>
           </a:xfrm>
           <a:prstGeom prst="rect">
             <a:avLst/>
@@ -25015,6 +25403,51 @@
             </a:r>
           </a:p>
           <a:p>
+            <a:pPr>
+              <a:lnSpc>
+                <a:spcPct val="100000"/>
+              </a:lnSpc>
+              <a:spcBef>
+                <a:spcPts val="400"/>
+              </a:spcBef>
+              <a:buClr>
+                <a:srgbClr val="0064C8"/>
+              </a:buClr>
+              <a:buFont typeface="Wingdings" panose="05000000000000000000" pitchFamily="2" charset="2"/>
+              <a:buChar char="§"/>
+            </a:pPr>
+            <a:endParaRPr lang="en-US" sz="2000" spc="-1" dirty="0">
+              <a:solidFill>
+                <a:srgbClr val="000000"/>
+              </a:solidFill>
+              <a:latin typeface="Century Gothic"/>
+            </a:endParaRPr>
+          </a:p>
+          <a:p>
+            <a:pPr>
+              <a:lnSpc>
+                <a:spcPct val="100000"/>
+              </a:lnSpc>
+              <a:spcBef>
+                <a:spcPts val="400"/>
+              </a:spcBef>
+              <a:buClr>
+                <a:srgbClr val="0064C8"/>
+              </a:buClr>
+              <a:buFont typeface="Wingdings" panose="05000000000000000000" pitchFamily="2" charset="2"/>
+              <a:buChar char="§"/>
+            </a:pPr>
+            <a:r>
+              <a:rPr lang="en-US" sz="2000" spc="-1" dirty="0">
+                <a:solidFill>
+                  <a:srgbClr val="000000"/>
+                </a:solidFill>
+                <a:latin typeface="Century Gothic"/>
+              </a:rPr>
+              <a:t>Use the system prompt to nudge the LLM to desirable responses</a:t>
+            </a:r>
+          </a:p>
+          <a:p>
             <a:pPr marL="0" indent="0">
               <a:lnSpc>
                 <a:spcPct val="100000"/>
@@ -25057,6 +25490,129 @@
               </a:rPr>
               <a:t>Proper design of docstrings and documentation is essential</a:t>
             </a:r>
+          </a:p>
+          <a:p>
+            <a:pPr>
+              <a:lnSpc>
+                <a:spcPct val="100000"/>
+              </a:lnSpc>
+              <a:spcBef>
+                <a:spcPts val="400"/>
+              </a:spcBef>
+              <a:buClr>
+                <a:srgbClr val="0064C8"/>
+              </a:buClr>
+              <a:buFont typeface="Wingdings" panose="05000000000000000000" pitchFamily="2" charset="2"/>
+              <a:buChar char="§"/>
+            </a:pPr>
+            <a:endParaRPr lang="en-US" sz="2000" spc="-1" dirty="0">
+              <a:solidFill>
+                <a:srgbClr val="000000"/>
+              </a:solidFill>
+              <a:latin typeface="Century Gothic"/>
+            </a:endParaRPr>
+          </a:p>
+          <a:p>
+            <a:pPr>
+              <a:lnSpc>
+                <a:spcPct val="100000"/>
+              </a:lnSpc>
+              <a:spcBef>
+                <a:spcPts val="400"/>
+              </a:spcBef>
+              <a:buClr>
+                <a:srgbClr val="0064C8"/>
+              </a:buClr>
+              <a:buFont typeface="Wingdings" panose="05000000000000000000" pitchFamily="2" charset="2"/>
+              <a:buChar char="§"/>
+            </a:pPr>
+            <a:r>
+              <a:rPr lang="en-US" sz="2000" spc="-1" dirty="0">
+                <a:solidFill>
+                  <a:srgbClr val="000000"/>
+                </a:solidFill>
+                <a:latin typeface="Century Gothic"/>
+              </a:rPr>
+              <a:t>Using code assistants (</a:t>
+            </a:r>
+            <a:r>
+              <a:rPr lang="en-US" sz="2000" spc="-1" dirty="0" err="1">
+                <a:solidFill>
+                  <a:srgbClr val="000000"/>
+                </a:solidFill>
+                <a:latin typeface="Century Gothic"/>
+              </a:rPr>
+              <a:t>eg.</a:t>
+            </a:r>
+            <a:r>
+              <a:rPr lang="en-US" sz="2000" spc="-1" dirty="0">
+                <a:solidFill>
+                  <a:srgbClr val="000000"/>
+                </a:solidFill>
+                <a:latin typeface="Century Gothic"/>
+              </a:rPr>
+              <a:t> Claude code, </a:t>
+            </a:r>
+            <a:r>
+              <a:rPr lang="en-US" sz="2000" spc="-1" dirty="0" err="1">
+                <a:solidFill>
+                  <a:srgbClr val="000000"/>
+                </a:solidFill>
+                <a:latin typeface="Century Gothic"/>
+              </a:rPr>
+              <a:t>Github</a:t>
+            </a:r>
+            <a:r>
+              <a:rPr lang="en-US" sz="2000" spc="-1" dirty="0">
+                <a:solidFill>
+                  <a:srgbClr val="000000"/>
+                </a:solidFill>
+                <a:latin typeface="Century Gothic"/>
+              </a:rPr>
+              <a:t> CoPilot) makes the large repositories manageable</a:t>
+            </a:r>
+          </a:p>
+          <a:p>
+            <a:pPr>
+              <a:lnSpc>
+                <a:spcPct val="100000"/>
+              </a:lnSpc>
+              <a:spcBef>
+                <a:spcPts val="400"/>
+              </a:spcBef>
+              <a:buClr>
+                <a:srgbClr val="0064C8"/>
+              </a:buClr>
+              <a:buFont typeface="Wingdings" panose="05000000000000000000" pitchFamily="2" charset="2"/>
+              <a:buChar char="§"/>
+            </a:pPr>
+            <a:endParaRPr lang="en-US" sz="2000" spc="-1" dirty="0">
+              <a:solidFill>
+                <a:srgbClr val="000000"/>
+              </a:solidFill>
+              <a:latin typeface="Century Gothic"/>
+            </a:endParaRPr>
+          </a:p>
+          <a:p>
+            <a:pPr>
+              <a:lnSpc>
+                <a:spcPct val="100000"/>
+              </a:lnSpc>
+              <a:spcBef>
+                <a:spcPts val="400"/>
+              </a:spcBef>
+              <a:buClr>
+                <a:srgbClr val="0064C8"/>
+              </a:buClr>
+              <a:buFont typeface="Wingdings" panose="05000000000000000000" pitchFamily="2" charset="2"/>
+              <a:buChar char="§"/>
+            </a:pPr>
+            <a:endParaRPr lang="en-US" sz="2000" spc="-1" dirty="0">
+              <a:solidFill>
+                <a:srgbClr val="000000"/>
+              </a:solidFill>
+              <a:latin typeface="Century Gothic"/>
+            </a:endParaRPr>
           </a:p>
           <a:p>
             <a:pPr>
@@ -30044,9 +30600,9 @@
               <a:buNone/>
             </a:pPr>
             <a:r>
-              <a:rPr lang="en-US" sz="1800" b="1" spc="-1" dirty="0">
+              <a:rPr lang="en-US" sz="1800" spc="-1" dirty="0">
                 <a:solidFill>
-                  <a:srgbClr val="000000"/>
+                  <a:srgbClr val="0064C8"/>
                 </a:solidFill>
                 <a:latin typeface="Century Gothic"/>
               </a:rPr>
@@ -30064,6 +30620,8 @@
               <a:buClr>
                 <a:srgbClr val="0064C8"/>
               </a:buClr>
+              <a:buFont typeface="Wingdings" panose="05000000000000000000" pitchFamily="2" charset="2"/>
+              <a:buChar char="§"/>
             </a:pPr>
             <a:r>
               <a:rPr lang="en-US" sz="1400" spc="-1" dirty="0">
@@ -30075,18 +30633,18 @@
               <a:t>LM Studio + Open Source LLM  (</a:t>
             </a:r>
             <a:r>
-              <a:rPr lang="en-US" sz="1400" b="1" spc="-1" dirty="0" err="1">
+              <a:rPr lang="en-US" sz="1400" spc="-1" dirty="0" err="1">
                 <a:solidFill>
-                  <a:srgbClr val="000000"/>
+                  <a:srgbClr val="0064C8"/>
                 </a:solidFill>
                 <a:latin typeface="Century Gothic"/>
               </a:rPr>
               <a:t>Qwen</a:t>
             </a:r>
             <a:r>
-              <a:rPr lang="en-US" sz="1400" b="1" spc="-1" dirty="0">
+              <a:rPr lang="en-US" sz="1400" spc="-1" dirty="0">
                 <a:solidFill>
-                  <a:srgbClr val="000000"/>
+                  <a:srgbClr val="0064C8"/>
                 </a:solidFill>
                 <a:latin typeface="Century Gothic"/>
               </a:rPr>
@@ -30116,9 +30674,9 @@
               <a:buNone/>
             </a:pPr>
             <a:r>
-              <a:rPr lang="en-US" sz="1800" b="1" spc="-1" dirty="0">
+              <a:rPr lang="en-US" sz="1800" spc="-1" dirty="0">
                 <a:solidFill>
-                  <a:srgbClr val="000000"/>
+                  <a:srgbClr val="0064C8"/>
                 </a:solidFill>
                 <a:latin typeface="Century Gothic"/>
               </a:rPr>
@@ -30136,6 +30694,8 @@
               <a:buClr>
                 <a:srgbClr val="0064C8"/>
               </a:buClr>
+              <a:buFont typeface="Wingdings" panose="05000000000000000000" pitchFamily="2" charset="2"/>
+              <a:buChar char="§"/>
             </a:pPr>
             <a:r>
               <a:rPr lang="en-US" sz="1400" spc="-1" dirty="0">
@@ -30158,6 +30718,8 @@
               <a:buClr>
                 <a:srgbClr val="0064C8"/>
               </a:buClr>
+              <a:buFont typeface="Wingdings" panose="05000000000000000000" pitchFamily="2" charset="2"/>
+              <a:buChar char="§"/>
             </a:pPr>
             <a:r>
               <a:rPr lang="en-US" sz="1400" spc="-1" dirty="0">
@@ -30183,9 +30745,9 @@
               <a:buNone/>
             </a:pPr>
             <a:r>
-              <a:rPr lang="en-US" sz="1800" b="1" spc="-1" dirty="0">
+              <a:rPr lang="en-US" sz="1800" spc="-1" dirty="0">
                 <a:solidFill>
-                  <a:srgbClr val="000000"/>
+                  <a:srgbClr val="0064C8"/>
                 </a:solidFill>
                 <a:latin typeface="Century Gothic"/>
               </a:rPr>
@@ -30203,6 +30765,8 @@
               <a:buClr>
                 <a:srgbClr val="0064C8"/>
               </a:buClr>
+              <a:buFont typeface="Wingdings" panose="05000000000000000000" pitchFamily="2" charset="2"/>
+              <a:buChar char="§"/>
             </a:pPr>
             <a:r>
               <a:rPr lang="en-US" sz="1400" spc="-1" dirty="0">
@@ -30225,6 +30789,8 @@
               <a:buClr>
                 <a:srgbClr val="0064C8"/>
               </a:buClr>
+              <a:buFont typeface="Wingdings" panose="05000000000000000000" pitchFamily="2" charset="2"/>
+              <a:buChar char="§"/>
             </a:pPr>
             <a:r>
               <a:rPr lang="en-US" sz="1400" spc="-1" dirty="0">
@@ -30250,9 +30816,9 @@
               <a:buNone/>
             </a:pPr>
             <a:r>
-              <a:rPr lang="en-US" sz="1800" b="1" spc="-1" dirty="0">
+              <a:rPr lang="en-US" sz="1800" spc="-1" dirty="0">
                 <a:solidFill>
-                  <a:srgbClr val="000000"/>
+                  <a:srgbClr val="0064C8"/>
                 </a:solidFill>
                 <a:latin typeface="Century Gothic"/>
               </a:rPr>
@@ -30270,6 +30836,8 @@
               <a:buClr>
                 <a:srgbClr val="0064C8"/>
               </a:buClr>
+              <a:buFont typeface="Wingdings" panose="05000000000000000000" pitchFamily="2" charset="2"/>
+              <a:buChar char="§"/>
             </a:pPr>
             <a:r>
               <a:rPr lang="en-US" sz="1400" spc="-1" dirty="0">
@@ -30292,6 +30860,8 @@
               <a:buClr>
                 <a:srgbClr val="0064C8"/>
               </a:buClr>
+              <a:buFont typeface="Wingdings" panose="05000000000000000000" pitchFamily="2" charset="2"/>
+              <a:buChar char="§"/>
             </a:pPr>
             <a:r>
               <a:rPr lang="en-US" sz="1400" spc="-1" dirty="0">
@@ -30317,18 +30887,18 @@
               <a:buNone/>
             </a:pPr>
             <a:r>
-              <a:rPr lang="en-US" sz="1800" b="1" spc="-1" dirty="0" err="1">
+              <a:rPr lang="en-US" sz="1800" spc="-1" dirty="0" err="1">
                 <a:solidFill>
-                  <a:srgbClr val="000000"/>
+                  <a:srgbClr val="0064C8"/>
                 </a:solidFill>
                 <a:latin typeface="Century Gothic"/>
               </a:rPr>
               <a:t>Explainability</a:t>
             </a:r>
             <a:r>
-              <a:rPr lang="en-US" sz="1800" b="1" spc="-1" dirty="0">
+              <a:rPr lang="en-US" sz="1800" spc="-1" dirty="0">
                 <a:solidFill>
-                  <a:srgbClr val="000000"/>
+                  <a:srgbClr val="0064C8"/>
                 </a:solidFill>
                 <a:latin typeface="Century Gothic"/>
               </a:rPr>
@@ -30346,6 +30916,8 @@
               <a:buClr>
                 <a:srgbClr val="0064C8"/>
               </a:buClr>
+              <a:buFont typeface="Wingdings" panose="05000000000000000000" pitchFamily="2" charset="2"/>
+              <a:buChar char="§"/>
             </a:pPr>
             <a:r>
               <a:rPr lang="en-US" sz="1400" spc="-1" dirty="0">
@@ -30386,6 +30958,8 @@
               <a:buClr>
                 <a:srgbClr val="0064C8"/>
               </a:buClr>
+              <a:buFont typeface="Wingdings" panose="05000000000000000000" pitchFamily="2" charset="2"/>
+              <a:buChar char="§"/>
             </a:pPr>
             <a:r>
               <a:rPr lang="en-US" sz="1400" spc="-1" dirty="0" err="1">
@@ -30414,6 +30988,8 @@
               <a:buClr>
                 <a:srgbClr val="0064C8"/>
               </a:buClr>
+              <a:buFont typeface="Wingdings" panose="05000000000000000000" pitchFamily="2" charset="2"/>
+              <a:buChar char="§"/>
             </a:pPr>
             <a:r>
               <a:rPr lang="en-US" sz="1400" spc="-1" dirty="0">
@@ -30868,8 +31444,8 @@
         </p:nvSpPr>
         <p:spPr>
           <a:xfrm>
-            <a:off x="380879" y="1355697"/>
-            <a:ext cx="5248644" cy="4643307"/>
+            <a:off x="380878" y="1355697"/>
+            <a:ext cx="7920283" cy="4643307"/>
           </a:xfrm>
           <a:prstGeom prst="rect">
             <a:avLst/>
@@ -31062,20 +31638,32 @@
               <a:buChar char="§"/>
             </a:pPr>
             <a:r>
+              <a:rPr lang="en-US" sz="1800" spc="-1" dirty="0">
+                <a:solidFill>
+                  <a:srgbClr val="0064C8"/>
+                </a:solidFill>
+                <a:latin typeface="Century Gothic"/>
+              </a:rPr>
+              <a:t>Prompt 1</a:t>
+            </a:r>
+            <a:r>
               <a:rPr lang="en-US" sz="1800" b="1" spc="-1" dirty="0">
+                <a:solidFill>
+                  <a:srgbClr val="0064C8"/>
+                </a:solidFill>
+                <a:latin typeface="Century Gothic"/>
+              </a:rPr>
+              <a:t>: </a:t>
+            </a:r>
+            <a:r>
+              <a:rPr lang="en-US" sz="1800" spc="-1" dirty="0">
                 <a:solidFill>
                   <a:srgbClr val="000000"/>
                 </a:solidFill>
                 <a:latin typeface="Century Gothic"/>
               </a:rPr>
-              <a:t>Prompt 1 </a:t>
+              <a:t>Showcase that the AI agent is able to use tools to reproduce known results and correctly put them into the chemical context</a:t>
             </a:r>
-            <a:endParaRPr lang="en-US" sz="1400" b="1" spc="-1" dirty="0">
-              <a:solidFill>
-                <a:srgbClr val="000000"/>
-              </a:solidFill>
-              <a:latin typeface="Century Gothic"/>
-            </a:endParaRPr>
           </a:p>
           <a:p>
             <a:pPr lvl="1">
@@ -31113,14 +31701,29 @@
               <a:buChar char="§"/>
             </a:pPr>
             <a:r>
-              <a:rPr lang="en-US" sz="1800" b="1" spc="-1" dirty="0">
+              <a:rPr lang="en-US" sz="1800" spc="-1" dirty="0">
+                <a:solidFill>
+                  <a:srgbClr val="0064C8"/>
+                </a:solidFill>
+                <a:latin typeface="Century Gothic"/>
+              </a:rPr>
+              <a:t>Prompt 2: </a:t>
+            </a:r>
+            <a:r>
+              <a:rPr lang="en-US" sz="1800" spc="-1" dirty="0">
                 <a:solidFill>
                   <a:srgbClr val="000000"/>
                 </a:solidFill>
                 <a:latin typeface="Century Gothic"/>
               </a:rPr>
-              <a:t>Prompt 2 </a:t>
+              <a:t>Demonstrate the ability of the agent to provide and compare explanations derived from different XAI methods</a:t>
             </a:r>
+            <a:endParaRPr lang="en-US" sz="1800" b="1" spc="-1" dirty="0">
+              <a:solidFill>
+                <a:srgbClr val="000000"/>
+              </a:solidFill>
+              <a:latin typeface="Century Gothic"/>
+            </a:endParaRPr>
           </a:p>
           <a:p>
             <a:pPr>
@@ -31158,14 +31761,134 @@
               <a:buChar char="§"/>
             </a:pPr>
             <a:r>
-              <a:rPr lang="en-US" sz="1800" b="1" spc="-1" dirty="0">
+              <a:rPr lang="en-US" sz="1800" spc="-1" dirty="0">
+                <a:solidFill>
+                  <a:srgbClr val="0064C8"/>
+                </a:solidFill>
+                <a:latin typeface="Century Gothic"/>
+              </a:rPr>
+              <a:t>Prompt 3: </a:t>
+            </a:r>
+            <a:r>
+              <a:rPr lang="en-US" sz="1800" spc="-1" dirty="0">
                 <a:solidFill>
                   <a:srgbClr val="000000"/>
                 </a:solidFill>
                 <a:latin typeface="Century Gothic"/>
               </a:rPr>
-              <a:t>Prompt 3</a:t>
+              <a:t>Display the capacity of the agent to compare and interpret explanations for different predictions</a:t>
             </a:r>
+          </a:p>
+          <a:p>
+            <a:pPr>
+              <a:lnSpc>
+                <a:spcPct val="100000"/>
+              </a:lnSpc>
+              <a:spcBef>
+                <a:spcPts val="400"/>
+              </a:spcBef>
+              <a:buClr>
+                <a:srgbClr val="0064C8"/>
+              </a:buClr>
+              <a:buFont typeface="Wingdings" panose="05000000000000000000" pitchFamily="2" charset="2"/>
+              <a:buChar char="§"/>
+            </a:pPr>
+            <a:endParaRPr lang="en-US" sz="1800" spc="-1" dirty="0">
+              <a:solidFill>
+                <a:srgbClr val="000000"/>
+              </a:solidFill>
+              <a:latin typeface="Century Gothic"/>
+            </a:endParaRPr>
+          </a:p>
+          <a:p>
+            <a:pPr>
+              <a:lnSpc>
+                <a:spcPct val="100000"/>
+              </a:lnSpc>
+              <a:spcBef>
+                <a:spcPts val="400"/>
+              </a:spcBef>
+              <a:buClr>
+                <a:srgbClr val="0064C8"/>
+              </a:buClr>
+              <a:buFont typeface="Wingdings" panose="05000000000000000000" pitchFamily="2" charset="2"/>
+              <a:buChar char="§"/>
+            </a:pPr>
+            <a:r>
+              <a:rPr lang="en-US" sz="1800" spc="-1" dirty="0">
+                <a:solidFill>
+                  <a:srgbClr val="0064C8"/>
+                </a:solidFill>
+                <a:latin typeface="Century Gothic"/>
+              </a:rPr>
+              <a:t>Prompt 4: </a:t>
+            </a:r>
+            <a:r>
+              <a:rPr lang="en-US" sz="1800" spc="-1" dirty="0">
+                <a:solidFill>
+                  <a:srgbClr val="000000"/>
+                </a:solidFill>
+                <a:latin typeface="Century Gothic"/>
+              </a:rPr>
+              <a:t>Determine whether agent is capable of analyzing and comparing the learning characteristics of distinct ML-models</a:t>
+            </a:r>
+          </a:p>
+          <a:p>
+            <a:pPr>
+              <a:lnSpc>
+                <a:spcPct val="100000"/>
+              </a:lnSpc>
+              <a:spcBef>
+                <a:spcPts val="400"/>
+              </a:spcBef>
+              <a:buClr>
+                <a:srgbClr val="0064C8"/>
+              </a:buClr>
+              <a:buFont typeface="Wingdings" panose="05000000000000000000" pitchFamily="2" charset="2"/>
+              <a:buChar char="§"/>
+            </a:pPr>
+            <a:endParaRPr lang="en-US" sz="1800" spc="-1" dirty="0">
+              <a:solidFill>
+                <a:srgbClr val="000000"/>
+              </a:solidFill>
+              <a:latin typeface="Century Gothic"/>
+            </a:endParaRPr>
+          </a:p>
+          <a:p>
+            <a:pPr>
+              <a:lnSpc>
+                <a:spcPct val="100000"/>
+              </a:lnSpc>
+              <a:spcBef>
+                <a:spcPts val="400"/>
+              </a:spcBef>
+              <a:buClr>
+                <a:srgbClr val="0064C8"/>
+              </a:buClr>
+              <a:buFont typeface="Wingdings" panose="05000000000000000000" pitchFamily="2" charset="2"/>
+              <a:buChar char="§"/>
+            </a:pPr>
+            <a:endParaRPr lang="en-US" sz="1800" spc="-1" dirty="0">
+              <a:solidFill>
+                <a:srgbClr val="000000"/>
+              </a:solidFill>
+              <a:latin typeface="Century Gothic"/>
+            </a:endParaRPr>
+          </a:p>
+          <a:p>
+            <a:pPr>
+              <a:lnSpc>
+                <a:spcPct val="100000"/>
+              </a:lnSpc>
+              <a:spcBef>
+                <a:spcPts val="400"/>
+              </a:spcBef>
+              <a:buClr>
+                <a:srgbClr val="0064C8"/>
+              </a:buClr>
+              <a:buFont typeface="Wingdings" panose="05000000000000000000" pitchFamily="2" charset="2"/>
+              <a:buChar char="§"/>
+            </a:pPr>
             <a:endParaRPr lang="en-US" sz="1400" spc="-1" dirty="0">
               <a:solidFill>
                 <a:srgbClr val="000000"/>
@@ -31582,7 +32305,7 @@
                 </a:solidFill>
                 <a:latin typeface="Century Gothic"/>
               </a:rPr>
-              <a:t>Showcase that the AI agent is able to use tools correctly to reproduce known results</a:t>
+              <a:t>Showcase that the AI agent is able to use tools to reproduce known results and correctly put them into the chemical context</a:t>
             </a:r>
           </a:p>
           <a:p>
@@ -31607,7 +32330,7 @@
                 </a:solidFill>
                 <a:latin typeface="Century Gothic"/>
               </a:rPr>
-              <a:t>Can the agent derive verifiable, correct chemical insight from model explanations?</a:t>
+              <a:t>Can the reproduce the Anchor PI3K-study and provide correct chemical insight from model explanations?</a:t>
             </a:r>
           </a:p>
           <a:p>
@@ -32964,7 +33687,7 @@
                 </a:solidFill>
                 <a:latin typeface="Century Gothic"/>
               </a:rPr>
-              <a:t>Demonstrate the ability of the agent to provide chemically intuitive explanations for model predictions </a:t>
+              <a:t>Demonstrate the ability of the agent to provide and compare explanations derived from different XAI methods</a:t>
             </a:r>
           </a:p>
           <a:p>
@@ -32989,7 +33712,75 @@
                 </a:solidFill>
                 <a:latin typeface="Century Gothic"/>
               </a:rPr>
-              <a:t>Can the agent correctly interpret and compare explanations derived from different XAI methods?</a:t>
+              <a:t>Can the agent correctly interpret and compare explanations:</a:t>
+            </a:r>
+          </a:p>
+          <a:p>
+            <a:pPr lvl="1">
+              <a:lnSpc>
+                <a:spcPct val="100000"/>
+              </a:lnSpc>
+              <a:spcBef>
+                <a:spcPts val="400"/>
+              </a:spcBef>
+              <a:spcAft>
+                <a:spcPts val="601"/>
+              </a:spcAft>
+              <a:buClr>
+                <a:srgbClr val="0064C8"/>
+              </a:buClr>
+            </a:pPr>
+            <a:r>
+              <a:rPr lang="en-US" sz="1600" spc="-1" dirty="0" err="1">
+                <a:solidFill>
+                  <a:srgbClr val="000000"/>
+                </a:solidFill>
+                <a:latin typeface="Century Gothic"/>
+              </a:rPr>
+              <a:t>MolAnchor</a:t>
+            </a:r>
+            <a:r>
+              <a:rPr lang="en-US" sz="1600" spc="-1" dirty="0">
+                <a:solidFill>
+                  <a:srgbClr val="000000"/>
+                </a:solidFill>
+                <a:latin typeface="Century Gothic"/>
+              </a:rPr>
+              <a:t> vs SHAP </a:t>
+            </a:r>
+          </a:p>
+          <a:p>
+            <a:pPr lvl="1">
+              <a:lnSpc>
+                <a:spcPct val="100000"/>
+              </a:lnSpc>
+              <a:spcBef>
+                <a:spcPts val="400"/>
+              </a:spcBef>
+              <a:spcAft>
+                <a:spcPts val="601"/>
+              </a:spcAft>
+              <a:buClr>
+                <a:srgbClr val="0064C8"/>
+              </a:buClr>
+            </a:pPr>
+            <a:r>
+              <a:rPr lang="en-US" sz="1600" spc="-1" dirty="0" err="1">
+                <a:solidFill>
+                  <a:srgbClr val="000000"/>
+                </a:solidFill>
+                <a:latin typeface="Century Gothic"/>
+              </a:rPr>
+              <a:t>MolCE</a:t>
+            </a:r>
+            <a:r>
+              <a:rPr lang="en-US" sz="1600" spc="-1" dirty="0">
+                <a:solidFill>
+                  <a:srgbClr val="000000"/>
+                </a:solidFill>
+                <a:latin typeface="Century Gothic"/>
+              </a:rPr>
+              <a:t> vs Counterfactuals?</a:t>
             </a:r>
           </a:p>
           <a:p>

</xml_diff>